<commit_message>
Clarify presentation labels and measurements and use singular voice
</commit_message>
<xml_diff>
--- a/presentation/unos_kidney_biopsy.pptx
+++ b/presentation/unos_kidney_biopsy.pptx
@@ -2,36 +2,36 @@
 <file path=ppt/presentation.xml><?xml version="1.0" encoding="utf-8"?>
 <p:presentation xmlns:p="http://schemas.openxmlformats.org/presentationml/2006/main" xmlns:r="http://schemas.openxmlformats.org/officeDocument/2006/relationships">
   <p:sldMasterIdLst>
-    <p:sldMasterId id="2147483648" r:id="Re8093aee81b845f4"/>
+    <p:sldMasterId id="2147483648" r:id="R795e38e1b45941d0"/>
   </p:sldMasterIdLst>
   <p:sldIdLst>
-    <p:sldId id="256" r:id="R27d35d42350f48c3"/>
-    <p:sldId id="257" r:id="R2de282704664476a"/>
-    <p:sldId id="258" r:id="Ra96ac9243e624c0b"/>
-    <p:sldId id="259" r:id="Rf3a7574bda14452f"/>
-    <p:sldId id="260" r:id="R92f47e12211840ca"/>
-    <p:sldId id="261" r:id="R32c273e320db4766"/>
-    <p:sldId id="262" r:id="R069005ad54374942"/>
-    <p:sldId id="263" r:id="Ra268efc20fb14988"/>
-    <p:sldId id="264" r:id="Rf59c5735bcbb49d9"/>
-    <p:sldId id="265" r:id="R7a5a45dcd2ec47aa"/>
-    <p:sldId id="266" r:id="Ra8889290ba704ee9"/>
-    <p:sldId id="267" r:id="R07fa47ae0df64bc9"/>
-    <p:sldId id="268" r:id="Ra9cde02a0670471e"/>
-    <p:sldId id="269" r:id="Rb00b82dcfd234374"/>
-    <p:sldId id="270" r:id="R7c2ba2f5b7ed4b1d"/>
-    <p:sldId id="271" r:id="Rad0c0d45aaf246b2"/>
-    <p:sldId id="272" r:id="R688c01e1cf5b48a4"/>
-    <p:sldId id="273" r:id="R2f31db7a163c46fe"/>
-    <p:sldId id="274" r:id="R28c7c51c2d804ec8"/>
-    <p:sldId id="275" r:id="R59bd98ad52034f2a"/>
-    <p:sldId id="276" r:id="R8ac4cb8efcad4d24"/>
-    <p:sldId id="277" r:id="Rc85a80ad9f43459f"/>
-    <p:sldId id="278" r:id="Rdad09b1d9d5f42fe"/>
-    <p:sldId id="279" r:id="R18e0f5381708400b"/>
-    <p:sldId id="280" r:id="R4a67bf5d7c794828"/>
-    <p:sldId id="281" r:id="Rd8b73157cad945d0"/>
-    <p:sldId id="282" r:id="Re7ad539fc20b4105"/>
+    <p:sldId id="256" r:id="Ra2e5987f5cd9402e"/>
+    <p:sldId id="257" r:id="R88b6c35a67094843"/>
+    <p:sldId id="258" r:id="Rb9e02b2a47b14552"/>
+    <p:sldId id="259" r:id="Raea07e2bc2fd400b"/>
+    <p:sldId id="260" r:id="R4a883e58a0de4092"/>
+    <p:sldId id="261" r:id="R9ee8407c6daa432c"/>
+    <p:sldId id="262" r:id="R487697ab6da547aa"/>
+    <p:sldId id="263" r:id="R625dc816186a4cae"/>
+    <p:sldId id="264" r:id="R163ab851ca464962"/>
+    <p:sldId id="265" r:id="R339b914838de4544"/>
+    <p:sldId id="266" r:id="R387b2356c53e44d5"/>
+    <p:sldId id="267" r:id="R0264449f1a3f47a4"/>
+    <p:sldId id="268" r:id="R81ede3964fca4630"/>
+    <p:sldId id="269" r:id="Rb5b1f94fd2cb453c"/>
+    <p:sldId id="270" r:id="Rb143e5b251fe4859"/>
+    <p:sldId id="271" r:id="R3cf35e120d1e45f1"/>
+    <p:sldId id="272" r:id="R1b7f5e37f6da46eb"/>
+    <p:sldId id="273" r:id="R5151ade6c1f84748"/>
+    <p:sldId id="274" r:id="R09e2f201fc3a4595"/>
+    <p:sldId id="275" r:id="R04b1157f1c8e45de"/>
+    <p:sldId id="276" r:id="Rd4bc542a68d34b1c"/>
+    <p:sldId id="277" r:id="R8d933dfdd60a4a5c"/>
+    <p:sldId id="278" r:id="R3c91bf60e299437a"/>
+    <p:sldId id="279" r:id="R80db1586d1c0439e"/>
+    <p:sldId id="280" r:id="R398152affa034801"/>
+    <p:sldId id="281" r:id="R42b2a288cc9f436b"/>
+    <p:sldId id="282" r:id="R68442a5439ed4b4e"/>
   </p:sldIdLst>
   <p:sldSz cx="12192000" cy="6858000"/>
   <p:notesSz cx="6858000" cy="9144000"/>
@@ -76,7 +76,7 @@
   </p:cSld>
   <p:clrMap bg1="lt1" tx1="dk1" bg2="lt2" tx2="dk2" accent1="accent1" accent2="accent2" accent3="accent3" accent4="accent4" accent5="accent5" accent6="accent6" hlink="hlink" folHlink="folHlink"/>
   <p:sldLayoutIdLst>
-    <p:sldLayoutId xmlns:r="http://schemas.openxmlformats.org/officeDocument/2006/relationships" id="2147483649" r:id="Rb3ef00f2e711481f"/>
+    <p:sldLayoutId xmlns:r="http://schemas.openxmlformats.org/officeDocument/2006/relationships" id="2147483649" r:id="Rf78abd7c10c74a21"/>
   </p:sldLayoutIdLst>
   <p:txStyles>
     <p:titleStyle>
@@ -1245,7 +1245,7 @@
           <p:cNvPr id="2" name="">
             <a:extLst xmlns:a="http://schemas.openxmlformats.org/drawingml/2006/main">
               <a:ext uri="{FF2B5EF4-FFF2-40B4-BE49-F238E27FC236}">
-                <a16:creationId xmlns:a16="http://schemas.microsoft.com/office/drawing/2014/main" id="{3A5879B5-DFDE-4CFF-85D9-0B0344FA0A4B}"/>
+                <a16:creationId xmlns:a16="http://schemas.microsoft.com/office/drawing/2014/main" id="{64D65980-7A9D-421C-B0C9-11C08E5E01FE}"/>
               </a:ext>
             </a:extLst>
           </p:cNvPr>
@@ -1346,7 +1346,7 @@
     </p:spTree>
     <p:extLst>
       <p:ext uri="{BB962C8B-B14F-4D97-AF65-F5344CB8AC3E}">
-        <p14:creationId xmlns:p14="http://schemas.microsoft.com/office/powerpoint/2010/main" val="1483870282"/>
+        <p14:creationId xmlns:p14="http://schemas.microsoft.com/office/powerpoint/2010/main" val="109289756"/>
       </p:ext>
     </p:extLst>
   </p:cSld>
@@ -1377,7 +1377,7 @@
           <p:cNvPr id="6" name="">
             <a:extLst xmlns:a="http://schemas.openxmlformats.org/drawingml/2006/main">
               <a:ext uri="{FF2B5EF4-FFF2-40B4-BE49-F238E27FC236}">
-                <a16:creationId xmlns:a16="http://schemas.microsoft.com/office/drawing/2014/main" id="{F83514BF-8CED-42AA-B464-ABA2F95BD415}"/>
+                <a16:creationId xmlns:a16="http://schemas.microsoft.com/office/drawing/2014/main" id="{F57956E2-EFA5-4C0A-A91C-1A92A7D9EB3D}"/>
               </a:ext>
             </a:extLst>
           </p:cNvPr>
@@ -1434,7 +1434,7 @@
           <p:cNvPr id="2" name="">
             <a:extLst xmlns:a="http://schemas.openxmlformats.org/drawingml/2006/main">
               <a:ext uri="{FF2B5EF4-FFF2-40B4-BE49-F238E27FC236}">
-                <a16:creationId xmlns:a16="http://schemas.microsoft.com/office/drawing/2014/main" id="{C15AEAEC-82DF-4888-AA7A-DDBEB62F7FDD}"/>
+                <a16:creationId xmlns:a16="http://schemas.microsoft.com/office/drawing/2014/main" id="{6EF5938C-3D3B-4319-8680-8B34B396D1E0}"/>
               </a:ext>
             </a:extLst>
           </p:cNvPr>
@@ -1491,7 +1491,7 @@
           <p:cNvPr id="3" name="">
             <a:extLst xmlns:a="http://schemas.openxmlformats.org/drawingml/2006/main">
               <a:ext uri="{FF2B5EF4-FFF2-40B4-BE49-F238E27FC236}">
-                <a16:creationId xmlns:a16="http://schemas.microsoft.com/office/drawing/2014/main" id="{B35FC85A-16CE-4FC1-A9D0-D71F873DB94A}"/>
+                <a16:creationId xmlns:a16="http://schemas.microsoft.com/office/drawing/2014/main" id="{766B4837-61E8-4605-AE74-3CDDD94E8AEF}"/>
               </a:ext>
             </a:extLst>
           </p:cNvPr>
@@ -1548,7 +1548,7 @@
           <p:cNvPr id="4" name="">
             <a:extLst xmlns:a="http://schemas.openxmlformats.org/drawingml/2006/main">
               <a:ext uri="{FF2B5EF4-FFF2-40B4-BE49-F238E27FC236}">
-                <a16:creationId xmlns:a16="http://schemas.microsoft.com/office/drawing/2014/main" id="{2A705363-765D-42DF-8B66-9FCC0B341131}"/>
+                <a16:creationId xmlns:a16="http://schemas.microsoft.com/office/drawing/2014/main" id="{66EA16B6-D15B-4C00-9021-41753FF2085C}"/>
               </a:ext>
             </a:extLst>
           </p:cNvPr>
@@ -1921,7 +1921,7 @@
     </p:spTree>
     <p:extLst>
       <p:ext uri="{BB962C8B-B14F-4D97-AF65-F5344CB8AC3E}">
-        <p14:creationId xmlns:p14="http://schemas.microsoft.com/office/powerpoint/2010/main" val="1307118146"/>
+        <p14:creationId xmlns:p14="http://schemas.microsoft.com/office/powerpoint/2010/main" val="618380760"/>
       </p:ext>
     </p:extLst>
   </p:cSld>
@@ -1952,7 +1952,7 @@
           <p:cNvPr id="13" name="">
             <a:extLst xmlns:a="http://schemas.openxmlformats.org/drawingml/2006/main">
               <a:ext uri="{FF2B5EF4-FFF2-40B4-BE49-F238E27FC236}">
-                <a16:creationId xmlns:a16="http://schemas.microsoft.com/office/drawing/2014/main" id="{1FFDFD1D-1824-46C4-9A0C-999AF100F256}"/>
+                <a16:creationId xmlns:a16="http://schemas.microsoft.com/office/drawing/2014/main" id="{0A1A2DC9-C058-4E1D-BCE8-FB6395FA62DC}"/>
               </a:ext>
             </a:extLst>
           </p:cNvPr>
@@ -2009,7 +2009,7 @@
           <p:cNvPr id="2" name="">
             <a:extLst xmlns:a="http://schemas.openxmlformats.org/drawingml/2006/main">
               <a:ext uri="{FF2B5EF4-FFF2-40B4-BE49-F238E27FC236}">
-                <a16:creationId xmlns:a16="http://schemas.microsoft.com/office/drawing/2014/main" id="{A563B68C-D214-46EF-BA80-A18845BE3E5C}"/>
+                <a16:creationId xmlns:a16="http://schemas.microsoft.com/office/drawing/2014/main" id="{38C4CC90-CA74-4B9A-9EAF-4116E561F242}"/>
               </a:ext>
             </a:extLst>
           </p:cNvPr>
@@ -2066,7 +2066,7 @@
           <p:cNvPr id="3" name="">
             <a:extLst xmlns:a="http://schemas.openxmlformats.org/drawingml/2006/main">
               <a:ext uri="{FF2B5EF4-FFF2-40B4-BE49-F238E27FC236}">
-                <a16:creationId xmlns:a16="http://schemas.microsoft.com/office/drawing/2014/main" id="{82D27729-CEFE-4350-B248-8E6CD5DD6E32}"/>
+                <a16:creationId xmlns:a16="http://schemas.microsoft.com/office/drawing/2014/main" id="{677D08DA-F28D-460F-9E91-39617B951FA3}"/>
               </a:ext>
             </a:extLst>
           </p:cNvPr>
@@ -2123,7 +2123,7 @@
           <p:cNvPr id="4" name="">
             <a:extLst xmlns:a="http://schemas.openxmlformats.org/drawingml/2006/main">
               <a:ext uri="{FF2B5EF4-FFF2-40B4-BE49-F238E27FC236}">
-                <a16:creationId xmlns:a16="http://schemas.microsoft.com/office/drawing/2014/main" id="{6804646C-4E26-4D69-ACD3-B95CB9C7D3C6}"/>
+                <a16:creationId xmlns:a16="http://schemas.microsoft.com/office/drawing/2014/main" id="{E974C0FA-2590-41EF-B83F-2A7C06C1145F}"/>
               </a:ext>
             </a:extLst>
           </p:cNvPr>
@@ -2180,7 +2180,7 @@
           <p:cNvPr id="5" name="">
             <a:extLst xmlns:a="http://schemas.openxmlformats.org/drawingml/2006/main">
               <a:ext uri="{FF2B5EF4-FFF2-40B4-BE49-F238E27FC236}">
-                <a16:creationId xmlns:a16="http://schemas.microsoft.com/office/drawing/2014/main" id="{3573E241-79F3-48F1-8AD0-A4F0DC464C0B}"/>
+                <a16:creationId xmlns:a16="http://schemas.microsoft.com/office/drawing/2014/main" id="{C4EB4253-E172-4AF9-A6BC-0DB23D068B99}"/>
               </a:ext>
             </a:extLst>
           </p:cNvPr>
@@ -2260,7 +2260,7 @@
           <p:cNvPr id="6" name="">
             <a:extLst xmlns:a="http://schemas.openxmlformats.org/drawingml/2006/main">
               <a:ext uri="{FF2B5EF4-FFF2-40B4-BE49-F238E27FC236}">
-                <a16:creationId xmlns:a16="http://schemas.microsoft.com/office/drawing/2014/main" id="{27EACDCA-5CF6-4966-AAE6-A2EB74AE09D4}"/>
+                <a16:creationId xmlns:a16="http://schemas.microsoft.com/office/drawing/2014/main" id="{E5784D09-1BD4-42ED-9525-9B8CA0D1A7BC}"/>
               </a:ext>
             </a:extLst>
           </p:cNvPr>
@@ -2317,7 +2317,7 @@
           <p:cNvPr id="7" name="">
             <a:extLst xmlns:a="http://schemas.openxmlformats.org/drawingml/2006/main">
               <a:ext uri="{FF2B5EF4-FFF2-40B4-BE49-F238E27FC236}">
-                <a16:creationId xmlns:a16="http://schemas.microsoft.com/office/drawing/2014/main" id="{76F589DE-0BD3-44AF-AA94-FC7BFC2CDD90}"/>
+                <a16:creationId xmlns:a16="http://schemas.microsoft.com/office/drawing/2014/main" id="{A818FB0C-1187-4B4A-80D6-2B53DD3E136F}"/>
               </a:ext>
             </a:extLst>
           </p:cNvPr>
@@ -2374,7 +2374,7 @@
           <p:cNvPr id="8" name="">
             <a:extLst xmlns:a="http://schemas.openxmlformats.org/drawingml/2006/main">
               <a:ext uri="{FF2B5EF4-FFF2-40B4-BE49-F238E27FC236}">
-                <a16:creationId xmlns:a16="http://schemas.microsoft.com/office/drawing/2014/main" id="{F6B02BA4-8815-4F54-A416-4B489DFA2FA4}"/>
+                <a16:creationId xmlns:a16="http://schemas.microsoft.com/office/drawing/2014/main" id="{A61EFD17-43D2-4CA2-99C8-4E0C8E9546EB}"/>
               </a:ext>
             </a:extLst>
           </p:cNvPr>
@@ -2454,7 +2454,7 @@
           <p:cNvPr id="9" name="">
             <a:extLst xmlns:a="http://schemas.openxmlformats.org/drawingml/2006/main">
               <a:ext uri="{FF2B5EF4-FFF2-40B4-BE49-F238E27FC236}">
-                <a16:creationId xmlns:a16="http://schemas.microsoft.com/office/drawing/2014/main" id="{D05234F9-5D10-4852-94F4-435C2E732FBC}"/>
+                <a16:creationId xmlns:a16="http://schemas.microsoft.com/office/drawing/2014/main" id="{8037A119-058D-415B-A99E-21385755E95F}"/>
               </a:ext>
             </a:extLst>
           </p:cNvPr>
@@ -2511,7 +2511,7 @@
           <p:cNvPr id="10" name="">
             <a:extLst xmlns:a="http://schemas.openxmlformats.org/drawingml/2006/main">
               <a:ext uri="{FF2B5EF4-FFF2-40B4-BE49-F238E27FC236}">
-                <a16:creationId xmlns:a16="http://schemas.microsoft.com/office/drawing/2014/main" id="{2F7EF0F1-CF8F-411F-980E-F9E035478A75}"/>
+                <a16:creationId xmlns:a16="http://schemas.microsoft.com/office/drawing/2014/main" id="{71BCBAE4-13FA-4210-8CD5-5322D53D3DE6}"/>
               </a:ext>
             </a:extLst>
           </p:cNvPr>
@@ -2806,7 +2806,7 @@
           <p:cNvPr id="12" name="">
             <a:extLst xmlns:a="http://schemas.openxmlformats.org/drawingml/2006/main">
               <a:ext uri="{FF2B5EF4-FFF2-40B4-BE49-F238E27FC236}">
-                <a16:creationId xmlns:a16="http://schemas.microsoft.com/office/drawing/2014/main" id="{54056865-C62F-4496-BD9D-4F4AE5BC9925}"/>
+                <a16:creationId xmlns:a16="http://schemas.microsoft.com/office/drawing/2014/main" id="{E143CE4F-0344-4935-A343-2199181EDD72}"/>
               </a:ext>
             </a:extLst>
           </p:cNvPr>
@@ -2861,7 +2861,7 @@
     </p:spTree>
     <p:extLst>
       <p:ext uri="{BB962C8B-B14F-4D97-AF65-F5344CB8AC3E}">
-        <p14:creationId xmlns:p14="http://schemas.microsoft.com/office/powerpoint/2010/main" val="1192199758"/>
+        <p14:creationId xmlns:p14="http://schemas.microsoft.com/office/powerpoint/2010/main" val="130087960"/>
       </p:ext>
     </p:extLst>
   </p:cSld>
@@ -2892,7 +2892,7 @@
           <p:cNvPr id="7" name="">
             <a:extLst xmlns:a="http://schemas.openxmlformats.org/drawingml/2006/main">
               <a:ext uri="{FF2B5EF4-FFF2-40B4-BE49-F238E27FC236}">
-                <a16:creationId xmlns:a16="http://schemas.microsoft.com/office/drawing/2014/main" id="{AED9C52D-EA13-463C-9E44-845CBF58B82E}"/>
+                <a16:creationId xmlns:a16="http://schemas.microsoft.com/office/drawing/2014/main" id="{93D9871B-70F3-4BCC-9FE0-3C347B9E45AB}"/>
               </a:ext>
             </a:extLst>
           </p:cNvPr>
@@ -2949,7 +2949,7 @@
           <p:cNvPr id="2" name="">
             <a:extLst xmlns:a="http://schemas.openxmlformats.org/drawingml/2006/main">
               <a:ext uri="{FF2B5EF4-FFF2-40B4-BE49-F238E27FC236}">
-                <a16:creationId xmlns:a16="http://schemas.microsoft.com/office/drawing/2014/main" id="{53BC208F-7020-41DB-BFC7-693C0918BDC5}"/>
+                <a16:creationId xmlns:a16="http://schemas.microsoft.com/office/drawing/2014/main" id="{B645D562-9303-469B-8507-BF5AE3956390}"/>
               </a:ext>
             </a:extLst>
           </p:cNvPr>
@@ -3006,7 +3006,7 @@
           <p:cNvPr id="3" name="">
             <a:extLst xmlns:a="http://schemas.openxmlformats.org/drawingml/2006/main">
               <a:ext uri="{FF2B5EF4-FFF2-40B4-BE49-F238E27FC236}">
-                <a16:creationId xmlns:a16="http://schemas.microsoft.com/office/drawing/2014/main" id="{F067271E-FAE5-445A-BE84-3DD40092EED5}"/>
+                <a16:creationId xmlns:a16="http://schemas.microsoft.com/office/drawing/2014/main" id="{C8683C4C-4A13-45E3-8A34-71BABBE4F97E}"/>
               </a:ext>
             </a:extLst>
           </p:cNvPr>
@@ -3063,7 +3063,7 @@
           <p:cNvPr id="4" name="">
             <a:extLst xmlns:a="http://schemas.openxmlformats.org/drawingml/2006/main">
               <a:ext uri="{FF2B5EF4-FFF2-40B4-BE49-F238E27FC236}">
-                <a16:creationId xmlns:a16="http://schemas.microsoft.com/office/drawing/2014/main" id="{07561ECF-D5DC-4ECD-929B-361241B4A0C8}"/>
+                <a16:creationId xmlns:a16="http://schemas.microsoft.com/office/drawing/2014/main" id="{DC07CE36-2BC0-4EF2-B058-271B3BAC6600}"/>
               </a:ext>
             </a:extLst>
           </p:cNvPr>
@@ -3127,7 +3127,7 @@
         </p:xfrm>
         <a:graphic xmlns:a="http://schemas.openxmlformats.org/drawingml/2006/main">
           <a:graphicData uri="http://schemas.openxmlformats.org/drawingml/2006/chart">
-            <c:chart xmlns:r="http://schemas.openxmlformats.org/officeDocument/2006/relationships" xmlns:c="http://schemas.openxmlformats.org/drawingml/2006/chart" r:id="Rca6263f60e7744e2"/>
+            <c:chart xmlns:r="http://schemas.openxmlformats.org/officeDocument/2006/relationships" xmlns:c="http://schemas.openxmlformats.org/drawingml/2006/chart" r:id="R7d94b5ba6c7b44c0"/>
           </a:graphicData>
         </a:graphic>
       </p:graphicFrame>
@@ -3136,7 +3136,7 @@
           <p:cNvPr id="6" name="">
             <a:extLst xmlns:a="http://schemas.openxmlformats.org/drawingml/2006/main">
               <a:ext uri="{FF2B5EF4-FFF2-40B4-BE49-F238E27FC236}">
-                <a16:creationId xmlns:a16="http://schemas.microsoft.com/office/drawing/2014/main" id="{2FF33D3F-FBA1-4ACC-9535-64F158972E7B}"/>
+                <a16:creationId xmlns:a16="http://schemas.microsoft.com/office/drawing/2014/main" id="{D0D8533A-D554-48DE-A334-0BBC0C369357}"/>
               </a:ext>
             </a:extLst>
           </p:cNvPr>
@@ -3222,7 +3222,7 @@
     </p:spTree>
     <p:extLst>
       <p:ext uri="{BB962C8B-B14F-4D97-AF65-F5344CB8AC3E}">
-        <p14:creationId xmlns:p14="http://schemas.microsoft.com/office/powerpoint/2010/main" val="1834464974"/>
+        <p14:creationId xmlns:p14="http://schemas.microsoft.com/office/powerpoint/2010/main" val="1978114221"/>
       </p:ext>
     </p:extLst>
   </p:cSld>
@@ -3253,7 +3253,7 @@
           <p:cNvPr id="9" name="">
             <a:extLst xmlns:a="http://schemas.openxmlformats.org/drawingml/2006/main">
               <a:ext uri="{FF2B5EF4-FFF2-40B4-BE49-F238E27FC236}">
-                <a16:creationId xmlns:a16="http://schemas.microsoft.com/office/drawing/2014/main" id="{C1475BAA-B406-4F67-9C4F-29980A64DE8F}"/>
+                <a16:creationId xmlns:a16="http://schemas.microsoft.com/office/drawing/2014/main" id="{2E0DA066-B79A-4EA9-B34C-44849A563527}"/>
               </a:ext>
             </a:extLst>
           </p:cNvPr>
@@ -3310,7 +3310,7 @@
           <p:cNvPr id="2" name="">
             <a:extLst xmlns:a="http://schemas.openxmlformats.org/drawingml/2006/main">
               <a:ext uri="{FF2B5EF4-FFF2-40B4-BE49-F238E27FC236}">
-                <a16:creationId xmlns:a16="http://schemas.microsoft.com/office/drawing/2014/main" id="{A6B7AAF4-47F9-4163-A5EA-4B6AE71FBBD6}"/>
+                <a16:creationId xmlns:a16="http://schemas.microsoft.com/office/drawing/2014/main" id="{A660362B-A01E-4804-A667-78A2215FE1D9}"/>
               </a:ext>
             </a:extLst>
           </p:cNvPr>
@@ -3367,7 +3367,7 @@
           <p:cNvPr id="3" name="">
             <a:extLst xmlns:a="http://schemas.openxmlformats.org/drawingml/2006/main">
               <a:ext uri="{FF2B5EF4-FFF2-40B4-BE49-F238E27FC236}">
-                <a16:creationId xmlns:a16="http://schemas.microsoft.com/office/drawing/2014/main" id="{10C84328-DA36-41F5-86F4-7DC3B052949A}"/>
+                <a16:creationId xmlns:a16="http://schemas.microsoft.com/office/drawing/2014/main" id="{FB1A113E-35A8-4BAC-97E3-4B502D59278B}"/>
               </a:ext>
             </a:extLst>
           </p:cNvPr>
@@ -3424,7 +3424,7 @@
           <p:cNvPr id="4" name="">
             <a:extLst xmlns:a="http://schemas.openxmlformats.org/drawingml/2006/main">
               <a:ext uri="{FF2B5EF4-FFF2-40B4-BE49-F238E27FC236}">
-                <a16:creationId xmlns:a16="http://schemas.microsoft.com/office/drawing/2014/main" id="{03385D87-40FA-4E1D-8235-8FF0E1691F5B}"/>
+                <a16:creationId xmlns:a16="http://schemas.microsoft.com/office/drawing/2014/main" id="{F5C14B07-C47D-45C2-B62A-811028C7F59A}"/>
               </a:ext>
             </a:extLst>
           </p:cNvPr>
@@ -3481,7 +3481,7 @@
           <p:cNvPr id="5" name="">
             <a:extLst xmlns:a="http://schemas.openxmlformats.org/drawingml/2006/main">
               <a:ext uri="{FF2B5EF4-FFF2-40B4-BE49-F238E27FC236}">
-                <a16:creationId xmlns:a16="http://schemas.microsoft.com/office/drawing/2014/main" id="{0896648A-A816-4706-9EA0-4B57C8D19C0F}"/>
+                <a16:creationId xmlns:a16="http://schemas.microsoft.com/office/drawing/2014/main" id="{BA5004C3-0B24-4EC1-B00F-F7CAF2F80DAE}"/>
               </a:ext>
             </a:extLst>
           </p:cNvPr>
@@ -3561,7 +3561,7 @@
           <p:cNvPr id="6" name="">
             <a:extLst xmlns:a="http://schemas.openxmlformats.org/drawingml/2006/main">
               <a:ext uri="{FF2B5EF4-FFF2-40B4-BE49-F238E27FC236}">
-                <a16:creationId xmlns:a16="http://schemas.microsoft.com/office/drawing/2014/main" id="{5FF27EBB-12E7-4358-A601-C4A7F12DCBAB}"/>
+                <a16:creationId xmlns:a16="http://schemas.microsoft.com/office/drawing/2014/main" id="{4A3FA261-EAD3-43EF-9DA2-F8A29948126A}"/>
               </a:ext>
             </a:extLst>
           </p:cNvPr>
@@ -3649,7 +3649,7 @@
           <p:cNvPr id="7" name="">
             <a:extLst xmlns:a="http://schemas.openxmlformats.org/drawingml/2006/main">
               <a:ext uri="{FF2B5EF4-FFF2-40B4-BE49-F238E27FC236}">
-                <a16:creationId xmlns:a16="http://schemas.microsoft.com/office/drawing/2014/main" id="{3178A475-6542-4184-96FC-787F857B9585}"/>
+                <a16:creationId xmlns:a16="http://schemas.microsoft.com/office/drawing/2014/main" id="{275CE76F-034D-4CEB-A51E-2B00152F9F48}"/>
               </a:ext>
             </a:extLst>
           </p:cNvPr>
@@ -3942,7 +3942,7 @@
     </p:spTree>
     <p:extLst>
       <p:ext uri="{BB962C8B-B14F-4D97-AF65-F5344CB8AC3E}">
-        <p14:creationId xmlns:p14="http://schemas.microsoft.com/office/powerpoint/2010/main" val="1541840098"/>
+        <p14:creationId xmlns:p14="http://schemas.microsoft.com/office/powerpoint/2010/main" val="1451916616"/>
       </p:ext>
     </p:extLst>
   </p:cSld>
@@ -3973,7 +3973,7 @@
           <p:cNvPr id="9" name="">
             <a:extLst xmlns:a="http://schemas.openxmlformats.org/drawingml/2006/main">
               <a:ext uri="{FF2B5EF4-FFF2-40B4-BE49-F238E27FC236}">
-                <a16:creationId xmlns:a16="http://schemas.microsoft.com/office/drawing/2014/main" id="{2FFFFD05-4775-4642-BEF7-C9EA72AA89A4}"/>
+                <a16:creationId xmlns:a16="http://schemas.microsoft.com/office/drawing/2014/main" id="{E40DD3F2-1F8E-4047-8B69-D0B48B042CA2}"/>
               </a:ext>
             </a:extLst>
           </p:cNvPr>
@@ -4030,7 +4030,7 @@
           <p:cNvPr id="2" name="">
             <a:extLst xmlns:a="http://schemas.openxmlformats.org/drawingml/2006/main">
               <a:ext uri="{FF2B5EF4-FFF2-40B4-BE49-F238E27FC236}">
-                <a16:creationId xmlns:a16="http://schemas.microsoft.com/office/drawing/2014/main" id="{2DF82CA6-F3B4-49FF-9502-ECC37D432B32}"/>
+                <a16:creationId xmlns:a16="http://schemas.microsoft.com/office/drawing/2014/main" id="{282562CD-8197-4E18-AD74-CCEAFC401621}"/>
               </a:ext>
             </a:extLst>
           </p:cNvPr>
@@ -4087,7 +4087,7 @@
           <p:cNvPr id="3" name="">
             <a:extLst xmlns:a="http://schemas.openxmlformats.org/drawingml/2006/main">
               <a:ext uri="{FF2B5EF4-FFF2-40B4-BE49-F238E27FC236}">
-                <a16:creationId xmlns:a16="http://schemas.microsoft.com/office/drawing/2014/main" id="{9617792A-7F38-4A04-A606-129FBCF50840}"/>
+                <a16:creationId xmlns:a16="http://schemas.microsoft.com/office/drawing/2014/main" id="{2809DF0E-CBF2-4D8F-8FAA-907119DCE778}"/>
               </a:ext>
             </a:extLst>
           </p:cNvPr>
@@ -4144,7 +4144,7 @@
           <p:cNvPr id="4" name="">
             <a:extLst xmlns:a="http://schemas.openxmlformats.org/drawingml/2006/main">
               <a:ext uri="{FF2B5EF4-FFF2-40B4-BE49-F238E27FC236}">
-                <a16:creationId xmlns:a16="http://schemas.microsoft.com/office/drawing/2014/main" id="{A512E363-B0AD-403E-BE09-ED8500535511}"/>
+                <a16:creationId xmlns:a16="http://schemas.microsoft.com/office/drawing/2014/main" id="{AC706D7A-CD55-4743-9CB7-5A4FD3EC379C}"/>
               </a:ext>
             </a:extLst>
           </p:cNvPr>
@@ -4201,7 +4201,7 @@
           <p:cNvPr id="5" name="">
             <a:extLst xmlns:a="http://schemas.openxmlformats.org/drawingml/2006/main">
               <a:ext uri="{FF2B5EF4-FFF2-40B4-BE49-F238E27FC236}">
-                <a16:creationId xmlns:a16="http://schemas.microsoft.com/office/drawing/2014/main" id="{BDFFE187-378D-43B9-A686-A7D9993F0A18}"/>
+                <a16:creationId xmlns:a16="http://schemas.microsoft.com/office/drawing/2014/main" id="{0059457B-6ADF-4C8A-90B9-EBF95C04B7DF}"/>
               </a:ext>
             </a:extLst>
           </p:cNvPr>
@@ -4316,7 +4316,7 @@
           <p:cNvPr id="6" name="">
             <a:extLst xmlns:a="http://schemas.openxmlformats.org/drawingml/2006/main">
               <a:ext uri="{FF2B5EF4-FFF2-40B4-BE49-F238E27FC236}">
-                <a16:creationId xmlns:a16="http://schemas.microsoft.com/office/drawing/2014/main" id="{37EBD814-053A-4E72-9805-F1606A1324E1}"/>
+                <a16:creationId xmlns:a16="http://schemas.microsoft.com/office/drawing/2014/main" id="{32E1ADC9-27FF-4402-BC6C-AD66D23DC720}"/>
               </a:ext>
             </a:extLst>
           </p:cNvPr>
@@ -4503,7 +4503,7 @@
           <p:cNvPr id="8" name="">
             <a:extLst xmlns:a="http://schemas.openxmlformats.org/drawingml/2006/main">
               <a:ext uri="{FF2B5EF4-FFF2-40B4-BE49-F238E27FC236}">
-                <a16:creationId xmlns:a16="http://schemas.microsoft.com/office/drawing/2014/main" id="{3A419549-9D24-47BB-8874-1336B12883A7}"/>
+                <a16:creationId xmlns:a16="http://schemas.microsoft.com/office/drawing/2014/main" id="{527D5680-E4CD-4D5B-AC9A-E5F341556CD4}"/>
               </a:ext>
             </a:extLst>
           </p:cNvPr>
@@ -4558,7 +4558,7 @@
     </p:spTree>
     <p:extLst>
       <p:ext uri="{BB962C8B-B14F-4D97-AF65-F5344CB8AC3E}">
-        <p14:creationId xmlns:p14="http://schemas.microsoft.com/office/powerpoint/2010/main" val="2088631444"/>
+        <p14:creationId xmlns:p14="http://schemas.microsoft.com/office/powerpoint/2010/main" val="562149893"/>
       </p:ext>
     </p:extLst>
   </p:cSld>
@@ -4589,7 +4589,7 @@
           <p:cNvPr id="13" name="">
             <a:extLst xmlns:a="http://schemas.openxmlformats.org/drawingml/2006/main">
               <a:ext uri="{FF2B5EF4-FFF2-40B4-BE49-F238E27FC236}">
-                <a16:creationId xmlns:a16="http://schemas.microsoft.com/office/drawing/2014/main" id="{05C93409-8EAA-4BF4-A0B0-71B98ECEC7F1}"/>
+                <a16:creationId xmlns:a16="http://schemas.microsoft.com/office/drawing/2014/main" id="{2E0882ED-E60F-42C9-8377-14F27131CB7C}"/>
               </a:ext>
             </a:extLst>
           </p:cNvPr>
@@ -4646,7 +4646,7 @@
           <p:cNvPr id="2" name="">
             <a:extLst xmlns:a="http://schemas.openxmlformats.org/drawingml/2006/main">
               <a:ext uri="{FF2B5EF4-FFF2-40B4-BE49-F238E27FC236}">
-                <a16:creationId xmlns:a16="http://schemas.microsoft.com/office/drawing/2014/main" id="{A5A8C4EA-C2D6-49A4-8B56-D162D2BA4AB4}"/>
+                <a16:creationId xmlns:a16="http://schemas.microsoft.com/office/drawing/2014/main" id="{4FA511B9-A0B6-49F9-841B-4978E9390C2B}"/>
               </a:ext>
             </a:extLst>
           </p:cNvPr>
@@ -4703,7 +4703,7 @@
           <p:cNvPr id="3" name="">
             <a:extLst xmlns:a="http://schemas.openxmlformats.org/drawingml/2006/main">
               <a:ext uri="{FF2B5EF4-FFF2-40B4-BE49-F238E27FC236}">
-                <a16:creationId xmlns:a16="http://schemas.microsoft.com/office/drawing/2014/main" id="{3FE8931E-A3BB-45C7-B2AF-138442094B7C}"/>
+                <a16:creationId xmlns:a16="http://schemas.microsoft.com/office/drawing/2014/main" id="{69890894-B54B-4093-B2C0-FF9D2A57BDB6}"/>
               </a:ext>
             </a:extLst>
           </p:cNvPr>
@@ -4760,7 +4760,7 @@
           <p:cNvPr id="4" name="">
             <a:extLst xmlns:a="http://schemas.openxmlformats.org/drawingml/2006/main">
               <a:ext uri="{FF2B5EF4-FFF2-40B4-BE49-F238E27FC236}">
-                <a16:creationId xmlns:a16="http://schemas.microsoft.com/office/drawing/2014/main" id="{A5649BD6-3E4E-43F9-90C0-5622B8CD622D}"/>
+                <a16:creationId xmlns:a16="http://schemas.microsoft.com/office/drawing/2014/main" id="{F71AD415-61F3-4BD6-B3EA-A9D7ACACA976}"/>
               </a:ext>
             </a:extLst>
           </p:cNvPr>
@@ -4821,7 +4821,7 @@
           <p:cNvPr id="5" name="">
             <a:extLst xmlns:a="http://schemas.openxmlformats.org/drawingml/2006/main">
               <a:ext uri="{FF2B5EF4-FFF2-40B4-BE49-F238E27FC236}">
-                <a16:creationId xmlns:a16="http://schemas.microsoft.com/office/drawing/2014/main" id="{58470725-96A1-4866-8C8C-9A4D691C59FA}"/>
+                <a16:creationId xmlns:a16="http://schemas.microsoft.com/office/drawing/2014/main" id="{966BCBA2-C6E6-462C-BEFC-D5DBECC92E1C}"/>
               </a:ext>
             </a:extLst>
           </p:cNvPr>
@@ -4882,7 +4882,7 @@
           <p:cNvPr id="6" name="">
             <a:extLst xmlns:a="http://schemas.openxmlformats.org/drawingml/2006/main">
               <a:ext uri="{FF2B5EF4-FFF2-40B4-BE49-F238E27FC236}">
-                <a16:creationId xmlns:a16="http://schemas.microsoft.com/office/drawing/2014/main" id="{F981A68A-00B4-49AC-A169-239180FFD0CA}"/>
+                <a16:creationId xmlns:a16="http://schemas.microsoft.com/office/drawing/2014/main" id="{0E45DF08-E0E9-49B0-8354-538CA5BCE163}"/>
               </a:ext>
             </a:extLst>
           </p:cNvPr>
@@ -4991,7 +4991,7 @@
           <p:cNvPr id="8" name="">
             <a:extLst xmlns:a="http://schemas.openxmlformats.org/drawingml/2006/main">
               <a:ext uri="{FF2B5EF4-FFF2-40B4-BE49-F238E27FC236}">
-                <a16:creationId xmlns:a16="http://schemas.microsoft.com/office/drawing/2014/main" id="{72EED323-F945-4F61-B513-81E64BC3842E}"/>
+                <a16:creationId xmlns:a16="http://schemas.microsoft.com/office/drawing/2014/main" id="{944C38F2-084A-4DE9-9B6A-E090758B77AE}"/>
               </a:ext>
             </a:extLst>
           </p:cNvPr>
@@ -5100,7 +5100,7 @@
           <p:cNvPr id="10" name="">
             <a:extLst xmlns:a="http://schemas.openxmlformats.org/drawingml/2006/main">
               <a:ext uri="{FF2B5EF4-FFF2-40B4-BE49-F238E27FC236}">
-                <a16:creationId xmlns:a16="http://schemas.microsoft.com/office/drawing/2014/main" id="{2706F8E5-3BA3-447A-9395-D4B74378C972}"/>
+                <a16:creationId xmlns:a16="http://schemas.microsoft.com/office/drawing/2014/main" id="{E89AFDD9-B5B1-4609-9903-692DD64EE528}"/>
               </a:ext>
             </a:extLst>
           </p:cNvPr>
@@ -5209,7 +5209,7 @@
           <p:cNvPr id="12" name="">
             <a:extLst xmlns:a="http://schemas.openxmlformats.org/drawingml/2006/main">
               <a:ext uri="{FF2B5EF4-FFF2-40B4-BE49-F238E27FC236}">
-                <a16:creationId xmlns:a16="http://schemas.microsoft.com/office/drawing/2014/main" id="{60FEF61A-0090-4561-BD4C-212E9F037144}"/>
+                <a16:creationId xmlns:a16="http://schemas.microsoft.com/office/drawing/2014/main" id="{A9DFF5A5-A5D4-46D9-86AC-5C0466FD4733}"/>
               </a:ext>
             </a:extLst>
           </p:cNvPr>
@@ -5295,7 +5295,7 @@
     </p:spTree>
     <p:extLst>
       <p:ext uri="{BB962C8B-B14F-4D97-AF65-F5344CB8AC3E}">
-        <p14:creationId xmlns:p14="http://schemas.microsoft.com/office/powerpoint/2010/main" val="1700704644"/>
+        <p14:creationId xmlns:p14="http://schemas.microsoft.com/office/powerpoint/2010/main" val="1277179253"/>
       </p:ext>
     </p:extLst>
   </p:cSld>
@@ -5326,7 +5326,7 @@
           <p:cNvPr id="9" name="">
             <a:extLst xmlns:a="http://schemas.openxmlformats.org/drawingml/2006/main">
               <a:ext uri="{FF2B5EF4-FFF2-40B4-BE49-F238E27FC236}">
-                <a16:creationId xmlns:a16="http://schemas.microsoft.com/office/drawing/2014/main" id="{020D3ECF-9DC2-45CE-A07F-6D75EC1F4BA2}"/>
+                <a16:creationId xmlns:a16="http://schemas.microsoft.com/office/drawing/2014/main" id="{4B01B305-F2E8-41BE-802A-29998389A753}"/>
               </a:ext>
             </a:extLst>
           </p:cNvPr>
@@ -5383,7 +5383,7 @@
           <p:cNvPr id="2" name="">
             <a:extLst xmlns:a="http://schemas.openxmlformats.org/drawingml/2006/main">
               <a:ext uri="{FF2B5EF4-FFF2-40B4-BE49-F238E27FC236}">
-                <a16:creationId xmlns:a16="http://schemas.microsoft.com/office/drawing/2014/main" id="{7E688A78-84F5-43B9-8B64-C1BE036D8D29}"/>
+                <a16:creationId xmlns:a16="http://schemas.microsoft.com/office/drawing/2014/main" id="{1B486D4F-38F2-4246-BCB9-53B88E3CBC1D}"/>
               </a:ext>
             </a:extLst>
           </p:cNvPr>
@@ -5440,7 +5440,7 @@
           <p:cNvPr id="3" name="">
             <a:extLst xmlns:a="http://schemas.openxmlformats.org/drawingml/2006/main">
               <a:ext uri="{FF2B5EF4-FFF2-40B4-BE49-F238E27FC236}">
-                <a16:creationId xmlns:a16="http://schemas.microsoft.com/office/drawing/2014/main" id="{FBA9DD6B-26FF-4B17-9F3B-523A56E09568}"/>
+                <a16:creationId xmlns:a16="http://schemas.microsoft.com/office/drawing/2014/main" id="{9B70EE77-3414-4B8A-B95B-51B19F400493}"/>
               </a:ext>
             </a:extLst>
           </p:cNvPr>
@@ -5497,7 +5497,7 @@
           <p:cNvPr id="4" name="">
             <a:extLst xmlns:a="http://schemas.openxmlformats.org/drawingml/2006/main">
               <a:ext uri="{FF2B5EF4-FFF2-40B4-BE49-F238E27FC236}">
-                <a16:creationId xmlns:a16="http://schemas.microsoft.com/office/drawing/2014/main" id="{1D2B267B-1A43-41FA-AC1A-BC6668370D84}"/>
+                <a16:creationId xmlns:a16="http://schemas.microsoft.com/office/drawing/2014/main" id="{CE94F1DE-FFAE-4D8D-AD86-705912AD30B9}"/>
               </a:ext>
             </a:extLst>
           </p:cNvPr>
@@ -5741,7 +5741,7 @@
           <p:cNvPr id="6" name="">
             <a:extLst xmlns:a="http://schemas.openxmlformats.org/drawingml/2006/main">
               <a:ext uri="{FF2B5EF4-FFF2-40B4-BE49-F238E27FC236}">
-                <a16:creationId xmlns:a16="http://schemas.microsoft.com/office/drawing/2014/main" id="{531BEECD-BE3A-4D73-9DD5-82040DE08525}"/>
+                <a16:creationId xmlns:a16="http://schemas.microsoft.com/office/drawing/2014/main" id="{8D5BA349-FFE1-4465-A59D-43BCFEC24A2E}"/>
               </a:ext>
             </a:extLst>
           </p:cNvPr>
@@ -5798,7 +5798,7 @@
           <p:cNvPr id="7" name="">
             <a:extLst xmlns:a="http://schemas.openxmlformats.org/drawingml/2006/main">
               <a:ext uri="{FF2B5EF4-FFF2-40B4-BE49-F238E27FC236}">
-                <a16:creationId xmlns:a16="http://schemas.microsoft.com/office/drawing/2014/main" id="{42E2DAA0-BF1E-4788-BADD-A2F3F086C64C}"/>
+                <a16:creationId xmlns:a16="http://schemas.microsoft.com/office/drawing/2014/main" id="{EC4E6BF0-26E9-49F0-84DC-FA494DCE33B9}"/>
               </a:ext>
             </a:extLst>
           </p:cNvPr>
@@ -5886,7 +5886,7 @@
           <p:cNvPr id="8" name="">
             <a:extLst xmlns:a="http://schemas.openxmlformats.org/drawingml/2006/main">
               <a:ext uri="{FF2B5EF4-FFF2-40B4-BE49-F238E27FC236}">
-                <a16:creationId xmlns:a16="http://schemas.microsoft.com/office/drawing/2014/main" id="{644C0C34-0738-4848-81FD-98B3516D9CD5}"/>
+                <a16:creationId xmlns:a16="http://schemas.microsoft.com/office/drawing/2014/main" id="{5EE7B87D-B935-4237-BEE1-EC5F3572BF8E}"/>
               </a:ext>
             </a:extLst>
           </p:cNvPr>
@@ -5941,7 +5941,7 @@
     </p:spTree>
     <p:extLst>
       <p:ext uri="{BB962C8B-B14F-4D97-AF65-F5344CB8AC3E}">
-        <p14:creationId xmlns:p14="http://schemas.microsoft.com/office/powerpoint/2010/main" val="483760217"/>
+        <p14:creationId xmlns:p14="http://schemas.microsoft.com/office/powerpoint/2010/main" val="933223053"/>
       </p:ext>
     </p:extLst>
   </p:cSld>
@@ -5972,7 +5972,7 @@
           <p:cNvPr id="7" name="">
             <a:extLst xmlns:a="http://schemas.openxmlformats.org/drawingml/2006/main">
               <a:ext uri="{FF2B5EF4-FFF2-40B4-BE49-F238E27FC236}">
-                <a16:creationId xmlns:a16="http://schemas.microsoft.com/office/drawing/2014/main" id="{D9234208-591F-4995-BB5B-5D748D42D50A}"/>
+                <a16:creationId xmlns:a16="http://schemas.microsoft.com/office/drawing/2014/main" id="{5E5257DB-6D79-44B8-ADB0-C0CE130707DF}"/>
               </a:ext>
             </a:extLst>
           </p:cNvPr>
@@ -6029,7 +6029,7 @@
           <p:cNvPr id="2" name="">
             <a:extLst xmlns:a="http://schemas.openxmlformats.org/drawingml/2006/main">
               <a:ext uri="{FF2B5EF4-FFF2-40B4-BE49-F238E27FC236}">
-                <a16:creationId xmlns:a16="http://schemas.microsoft.com/office/drawing/2014/main" id="{1657E6DD-0EB4-4514-8B9D-248019075A43}"/>
+                <a16:creationId xmlns:a16="http://schemas.microsoft.com/office/drawing/2014/main" id="{CE9A73B0-679C-4EE3-A7A5-71A47D6015DB}"/>
               </a:ext>
             </a:extLst>
           </p:cNvPr>
@@ -6086,7 +6086,7 @@
           <p:cNvPr id="3" name="">
             <a:extLst xmlns:a="http://schemas.openxmlformats.org/drawingml/2006/main">
               <a:ext uri="{FF2B5EF4-FFF2-40B4-BE49-F238E27FC236}">
-                <a16:creationId xmlns:a16="http://schemas.microsoft.com/office/drawing/2014/main" id="{CB4915E4-5DCD-4081-9991-DE87EEB2B75C}"/>
+                <a16:creationId xmlns:a16="http://schemas.microsoft.com/office/drawing/2014/main" id="{EA353D05-52B1-4C24-BA8E-8F3E33D3BB76}"/>
               </a:ext>
             </a:extLst>
           </p:cNvPr>
@@ -6143,7 +6143,7 @@
           <p:cNvPr id="4" name="">
             <a:extLst xmlns:a="http://schemas.openxmlformats.org/drawingml/2006/main">
               <a:ext uri="{FF2B5EF4-FFF2-40B4-BE49-F238E27FC236}">
-                <a16:creationId xmlns:a16="http://schemas.microsoft.com/office/drawing/2014/main" id="{27EEE8B8-D184-43AB-A3D6-607355E61BA1}"/>
+                <a16:creationId xmlns:a16="http://schemas.microsoft.com/office/drawing/2014/main" id="{8CD3BC87-D132-4A57-B566-A263EA402437}"/>
               </a:ext>
             </a:extLst>
           </p:cNvPr>
@@ -6442,7 +6442,7 @@
           <p:cNvPr id="6" name="">
             <a:extLst xmlns:a="http://schemas.openxmlformats.org/drawingml/2006/main">
               <a:ext uri="{FF2B5EF4-FFF2-40B4-BE49-F238E27FC236}">
-                <a16:creationId xmlns:a16="http://schemas.microsoft.com/office/drawing/2014/main" id="{5548554C-055F-4382-A9E2-186244869378}"/>
+                <a16:creationId xmlns:a16="http://schemas.microsoft.com/office/drawing/2014/main" id="{E20F8D19-D00F-48DF-8409-46897678A98C}"/>
               </a:ext>
             </a:extLst>
           </p:cNvPr>
@@ -6528,7 +6528,7 @@
     </p:spTree>
     <p:extLst>
       <p:ext uri="{BB962C8B-B14F-4D97-AF65-F5344CB8AC3E}">
-        <p14:creationId xmlns:p14="http://schemas.microsoft.com/office/powerpoint/2010/main" val="284900560"/>
+        <p14:creationId xmlns:p14="http://schemas.microsoft.com/office/powerpoint/2010/main" val="844225268"/>
       </p:ext>
     </p:extLst>
   </p:cSld>
@@ -6559,7 +6559,7 @@
           <p:cNvPr id="6" name="">
             <a:extLst xmlns:a="http://schemas.openxmlformats.org/drawingml/2006/main">
               <a:ext uri="{FF2B5EF4-FFF2-40B4-BE49-F238E27FC236}">
-                <a16:creationId xmlns:a16="http://schemas.microsoft.com/office/drawing/2014/main" id="{35FBD081-7428-4286-BBF5-339D3BFBB9A0}"/>
+                <a16:creationId xmlns:a16="http://schemas.microsoft.com/office/drawing/2014/main" id="{2475668C-DB65-4692-A0D0-41C02CDE662D}"/>
               </a:ext>
             </a:extLst>
           </p:cNvPr>
@@ -6616,7 +6616,7 @@
           <p:cNvPr id="2" name="">
             <a:extLst xmlns:a="http://schemas.openxmlformats.org/drawingml/2006/main">
               <a:ext uri="{FF2B5EF4-FFF2-40B4-BE49-F238E27FC236}">
-                <a16:creationId xmlns:a16="http://schemas.microsoft.com/office/drawing/2014/main" id="{A398AA83-33B9-4089-9FF5-D3BD50B0D47F}"/>
+                <a16:creationId xmlns:a16="http://schemas.microsoft.com/office/drawing/2014/main" id="{B36BA0C0-7E3B-4034-9B51-8D5015735D32}"/>
               </a:ext>
             </a:extLst>
           </p:cNvPr>
@@ -6673,7 +6673,7 @@
           <p:cNvPr id="3" name="">
             <a:extLst xmlns:a="http://schemas.openxmlformats.org/drawingml/2006/main">
               <a:ext uri="{FF2B5EF4-FFF2-40B4-BE49-F238E27FC236}">
-                <a16:creationId xmlns:a16="http://schemas.microsoft.com/office/drawing/2014/main" id="{EF44B4BB-8BCE-4B11-90E3-F8F11D578240}"/>
+                <a16:creationId xmlns:a16="http://schemas.microsoft.com/office/drawing/2014/main" id="{838AC7F4-3E36-4E59-9709-5DDD91AE5E22}"/>
               </a:ext>
             </a:extLst>
           </p:cNvPr>
@@ -6730,7 +6730,7 @@
           <p:cNvPr id="4" name="">
             <a:extLst xmlns:a="http://schemas.openxmlformats.org/drawingml/2006/main">
               <a:ext uri="{FF2B5EF4-FFF2-40B4-BE49-F238E27FC236}">
-                <a16:creationId xmlns:a16="http://schemas.microsoft.com/office/drawing/2014/main" id="{EDFCA2B5-6144-4C70-94A2-244AF2DE3652}"/>
+                <a16:creationId xmlns:a16="http://schemas.microsoft.com/office/drawing/2014/main" id="{67233FF5-93C0-4DB6-9253-5CB39A8BE121}"/>
               </a:ext>
             </a:extLst>
           </p:cNvPr>
@@ -6999,7 +6999,7 @@
     </p:spTree>
     <p:extLst>
       <p:ext uri="{BB962C8B-B14F-4D97-AF65-F5344CB8AC3E}">
-        <p14:creationId xmlns:p14="http://schemas.microsoft.com/office/powerpoint/2010/main" val="107517716"/>
+        <p14:creationId xmlns:p14="http://schemas.microsoft.com/office/powerpoint/2010/main" val="2116705782"/>
       </p:ext>
     </p:extLst>
   </p:cSld>
@@ -7030,7 +7030,7 @@
           <p:cNvPr id="7" name="">
             <a:extLst xmlns:a="http://schemas.openxmlformats.org/drawingml/2006/main">
               <a:ext uri="{FF2B5EF4-FFF2-40B4-BE49-F238E27FC236}">
-                <a16:creationId xmlns:a16="http://schemas.microsoft.com/office/drawing/2014/main" id="{6EDA867F-CC00-438A-8CFC-A49EBCACB966}"/>
+                <a16:creationId xmlns:a16="http://schemas.microsoft.com/office/drawing/2014/main" id="{FEE2714F-C655-4940-9BFB-75345AB5C814}"/>
               </a:ext>
             </a:extLst>
           </p:cNvPr>
@@ -7087,7 +7087,7 @@
           <p:cNvPr id="2" name="">
             <a:extLst xmlns:a="http://schemas.openxmlformats.org/drawingml/2006/main">
               <a:ext uri="{FF2B5EF4-FFF2-40B4-BE49-F238E27FC236}">
-                <a16:creationId xmlns:a16="http://schemas.microsoft.com/office/drawing/2014/main" id="{3E682C42-4D56-49E1-9D96-DF2CB1343334}"/>
+                <a16:creationId xmlns:a16="http://schemas.microsoft.com/office/drawing/2014/main" id="{4F3D158F-3C06-434E-BB3A-521F6341E23B}"/>
               </a:ext>
             </a:extLst>
           </p:cNvPr>
@@ -7144,7 +7144,7 @@
           <p:cNvPr id="3" name="">
             <a:extLst xmlns:a="http://schemas.openxmlformats.org/drawingml/2006/main">
               <a:ext uri="{FF2B5EF4-FFF2-40B4-BE49-F238E27FC236}">
-                <a16:creationId xmlns:a16="http://schemas.microsoft.com/office/drawing/2014/main" id="{6F7A68CA-796A-4E7A-BA7D-67B5E257A143}"/>
+                <a16:creationId xmlns:a16="http://schemas.microsoft.com/office/drawing/2014/main" id="{E98FB051-C36F-48E2-959C-1D3B2B17668A}"/>
               </a:ext>
             </a:extLst>
           </p:cNvPr>
@@ -7201,7 +7201,7 @@
           <p:cNvPr id="4" name="">
             <a:extLst xmlns:a="http://schemas.openxmlformats.org/drawingml/2006/main">
               <a:ext uri="{FF2B5EF4-FFF2-40B4-BE49-F238E27FC236}">
-                <a16:creationId xmlns:a16="http://schemas.microsoft.com/office/drawing/2014/main" id="{2B431625-E31B-43EA-BD4A-697064FBC3A4}"/>
+                <a16:creationId xmlns:a16="http://schemas.microsoft.com/office/drawing/2014/main" id="{DA8B6391-D3E1-4A78-95B0-14E6A65864A3}"/>
               </a:ext>
             </a:extLst>
           </p:cNvPr>
@@ -7258,7 +7258,7 @@
           <p:cNvPr id="5" name="">
             <a:extLst xmlns:a="http://schemas.openxmlformats.org/drawingml/2006/main">
               <a:ext uri="{FF2B5EF4-FFF2-40B4-BE49-F238E27FC236}">
-                <a16:creationId xmlns:a16="http://schemas.microsoft.com/office/drawing/2014/main" id="{B6C4FADB-E72E-458C-A9B7-1B746DB13A0B}"/>
+                <a16:creationId xmlns:a16="http://schemas.microsoft.com/office/drawing/2014/main" id="{DA3A90B5-EBA9-464B-B7F7-E552A905F3CE}"/>
               </a:ext>
             </a:extLst>
           </p:cNvPr>
@@ -7315,7 +7315,7 @@
           <p:cNvPr id="6" name="">
             <a:extLst xmlns:a="http://schemas.openxmlformats.org/drawingml/2006/main">
               <a:ext uri="{FF2B5EF4-FFF2-40B4-BE49-F238E27FC236}">
-                <a16:creationId xmlns:a16="http://schemas.microsoft.com/office/drawing/2014/main" id="{01A27923-9CCB-4158-8B30-CEBE5E4A677B}"/>
+                <a16:creationId xmlns:a16="http://schemas.microsoft.com/office/drawing/2014/main" id="{AB0CB923-9247-45C2-ADC7-AFC0737D3EC8}"/>
               </a:ext>
             </a:extLst>
           </p:cNvPr>
@@ -7428,7 +7428,7 @@
     </p:spTree>
     <p:extLst>
       <p:ext uri="{BB962C8B-B14F-4D97-AF65-F5344CB8AC3E}">
-        <p14:creationId xmlns:p14="http://schemas.microsoft.com/office/powerpoint/2010/main" val="1642001901"/>
+        <p14:creationId xmlns:p14="http://schemas.microsoft.com/office/powerpoint/2010/main" val="454130606"/>
       </p:ext>
     </p:extLst>
   </p:cSld>
@@ -7459,7 +7459,7 @@
           <p:cNvPr id="8" name="">
             <a:extLst xmlns:a="http://schemas.openxmlformats.org/drawingml/2006/main">
               <a:ext uri="{FF2B5EF4-FFF2-40B4-BE49-F238E27FC236}">
-                <a16:creationId xmlns:a16="http://schemas.microsoft.com/office/drawing/2014/main" id="{3F55A85A-BC71-4C35-B4C2-A5A947AB818E}"/>
+                <a16:creationId xmlns:a16="http://schemas.microsoft.com/office/drawing/2014/main" id="{CEF9ABC7-FFB1-4472-A6DB-28B9FC794285}"/>
               </a:ext>
             </a:extLst>
           </p:cNvPr>
@@ -7516,7 +7516,7 @@
           <p:cNvPr id="2" name="">
             <a:extLst xmlns:a="http://schemas.openxmlformats.org/drawingml/2006/main">
               <a:ext uri="{FF2B5EF4-FFF2-40B4-BE49-F238E27FC236}">
-                <a16:creationId xmlns:a16="http://schemas.microsoft.com/office/drawing/2014/main" id="{7AD97EA4-DFE8-4982-8271-4E0701819D8F}"/>
+                <a16:creationId xmlns:a16="http://schemas.microsoft.com/office/drawing/2014/main" id="{3671BE4E-D284-49C3-87B3-AC4DA2D8504D}"/>
               </a:ext>
             </a:extLst>
           </p:cNvPr>
@@ -7573,7 +7573,7 @@
           <p:cNvPr id="3" name="">
             <a:extLst xmlns:a="http://schemas.openxmlformats.org/drawingml/2006/main">
               <a:ext uri="{FF2B5EF4-FFF2-40B4-BE49-F238E27FC236}">
-                <a16:creationId xmlns:a16="http://schemas.microsoft.com/office/drawing/2014/main" id="{8FD0FA6E-57CD-4981-A2F1-C5DC07584576}"/>
+                <a16:creationId xmlns:a16="http://schemas.microsoft.com/office/drawing/2014/main" id="{E38B796D-BD2F-4DEC-A8FC-637296B5EAFB}"/>
               </a:ext>
             </a:extLst>
           </p:cNvPr>
@@ -7630,7 +7630,7 @@
           <p:cNvPr id="4" name="">
             <a:extLst xmlns:a="http://schemas.openxmlformats.org/drawingml/2006/main">
               <a:ext uri="{FF2B5EF4-FFF2-40B4-BE49-F238E27FC236}">
-                <a16:creationId xmlns:a16="http://schemas.microsoft.com/office/drawing/2014/main" id="{93254147-C718-49A0-B7F2-835CBE803671}"/>
+                <a16:creationId xmlns:a16="http://schemas.microsoft.com/office/drawing/2014/main" id="{4B48F20C-40E9-4D07-958B-4ABF110971AA}"/>
               </a:ext>
             </a:extLst>
           </p:cNvPr>
@@ -7687,7 +7687,7 @@
           <p:cNvPr id="5" name="">
             <a:extLst xmlns:a="http://schemas.openxmlformats.org/drawingml/2006/main">
               <a:ext uri="{FF2B5EF4-FFF2-40B4-BE49-F238E27FC236}">
-                <a16:creationId xmlns:a16="http://schemas.microsoft.com/office/drawing/2014/main" id="{277B3972-BEF4-48AF-A48F-0228FC5D15A8}"/>
+                <a16:creationId xmlns:a16="http://schemas.microsoft.com/office/drawing/2014/main" id="{CF9E59C5-AA62-4CA0-BFE6-E1DFA57FFD89}"/>
               </a:ext>
             </a:extLst>
           </p:cNvPr>
@@ -7744,7 +7744,7 @@
           <p:cNvPr id="6" name="">
             <a:extLst xmlns:a="http://schemas.openxmlformats.org/drawingml/2006/main">
               <a:ext uri="{FF2B5EF4-FFF2-40B4-BE49-F238E27FC236}">
-                <a16:creationId xmlns:a16="http://schemas.microsoft.com/office/drawing/2014/main" id="{D760CA93-9B15-43E7-8CE0-6EE21A6E17BC}"/>
+                <a16:creationId xmlns:a16="http://schemas.microsoft.com/office/drawing/2014/main" id="{19A24AED-FF2E-4A0B-B850-16F795FBD124}"/>
               </a:ext>
             </a:extLst>
           </p:cNvPr>
@@ -7801,7 +7801,7 @@
           <p:cNvPr id="7" name="">
             <a:extLst xmlns:a="http://schemas.openxmlformats.org/drawingml/2006/main">
               <a:ext uri="{FF2B5EF4-FFF2-40B4-BE49-F238E27FC236}">
-                <a16:creationId xmlns:a16="http://schemas.microsoft.com/office/drawing/2014/main" id="{4CFE326B-EB13-4F3E-9EA1-50F7621DC0D6}"/>
+                <a16:creationId xmlns:a16="http://schemas.microsoft.com/office/drawing/2014/main" id="{32A628D0-EE51-4521-8189-3A89782D2934}"/>
               </a:ext>
             </a:extLst>
           </p:cNvPr>
@@ -7856,7 +7856,7 @@
     </p:spTree>
     <p:extLst>
       <p:ext uri="{BB962C8B-B14F-4D97-AF65-F5344CB8AC3E}">
-        <p14:creationId xmlns:p14="http://schemas.microsoft.com/office/powerpoint/2010/main" val="1226093040"/>
+        <p14:creationId xmlns:p14="http://schemas.microsoft.com/office/powerpoint/2010/main" val="1480923889"/>
       </p:ext>
     </p:extLst>
   </p:cSld>
@@ -7887,7 +7887,7 @@
           <p:cNvPr id="6" name="">
             <a:extLst xmlns:a="http://schemas.openxmlformats.org/drawingml/2006/main">
               <a:ext uri="{FF2B5EF4-FFF2-40B4-BE49-F238E27FC236}">
-                <a16:creationId xmlns:a16="http://schemas.microsoft.com/office/drawing/2014/main" id="{9740FAD8-288E-425C-87F7-B6992D6ADF2B}"/>
+                <a16:creationId xmlns:a16="http://schemas.microsoft.com/office/drawing/2014/main" id="{9663A43C-F171-4D9C-BDBE-4A19675229F7}"/>
               </a:ext>
             </a:extLst>
           </p:cNvPr>
@@ -7944,7 +7944,7 @@
           <p:cNvPr id="2" name="">
             <a:extLst xmlns:a="http://schemas.openxmlformats.org/drawingml/2006/main">
               <a:ext uri="{FF2B5EF4-FFF2-40B4-BE49-F238E27FC236}">
-                <a16:creationId xmlns:a16="http://schemas.microsoft.com/office/drawing/2014/main" id="{4F815F25-AD11-44DF-B4D0-375A6FA4E6DE}"/>
+                <a16:creationId xmlns:a16="http://schemas.microsoft.com/office/drawing/2014/main" id="{DF195A7F-71B3-4E85-81A9-5E9E65624194}"/>
               </a:ext>
             </a:extLst>
           </p:cNvPr>
@@ -8001,7 +8001,7 @@
           <p:cNvPr id="3" name="">
             <a:extLst xmlns:a="http://schemas.openxmlformats.org/drawingml/2006/main">
               <a:ext uri="{FF2B5EF4-FFF2-40B4-BE49-F238E27FC236}">
-                <a16:creationId xmlns:a16="http://schemas.microsoft.com/office/drawing/2014/main" id="{84E2B0FD-7298-49AD-8919-26FB8C109C7C}"/>
+                <a16:creationId xmlns:a16="http://schemas.microsoft.com/office/drawing/2014/main" id="{372CC687-8C91-424D-857B-737D5BEC4A82}"/>
               </a:ext>
             </a:extLst>
           </p:cNvPr>
@@ -8058,7 +8058,7 @@
           <p:cNvPr id="4" name="">
             <a:extLst xmlns:a="http://schemas.openxmlformats.org/drawingml/2006/main">
               <a:ext uri="{FF2B5EF4-FFF2-40B4-BE49-F238E27FC236}">
-                <a16:creationId xmlns:a16="http://schemas.microsoft.com/office/drawing/2014/main" id="{4E225F91-8C8A-4FA9-8B50-E3E6C91C9732}"/>
+                <a16:creationId xmlns:a16="http://schemas.microsoft.com/office/drawing/2014/main" id="{61D01FF6-47A7-47B3-84E7-75732BEEEE9E}"/>
               </a:ext>
             </a:extLst>
           </p:cNvPr>
@@ -8173,7 +8173,7 @@
           <p:cNvPr id="5" name="">
             <a:extLst xmlns:a="http://schemas.openxmlformats.org/drawingml/2006/main">
               <a:ext uri="{FF2B5EF4-FFF2-40B4-BE49-F238E27FC236}">
-                <a16:creationId xmlns:a16="http://schemas.microsoft.com/office/drawing/2014/main" id="{EBE7B64B-8B68-4486-8646-E27E60B9DC90}"/>
+                <a16:creationId xmlns:a16="http://schemas.microsoft.com/office/drawing/2014/main" id="{FA0347ED-5B9D-4C4B-AAA1-F32BCC7677AC}"/>
               </a:ext>
             </a:extLst>
           </p:cNvPr>
@@ -8228,7 +8228,7 @@
     </p:spTree>
     <p:extLst>
       <p:ext uri="{BB962C8B-B14F-4D97-AF65-F5344CB8AC3E}">
-        <p14:creationId xmlns:p14="http://schemas.microsoft.com/office/powerpoint/2010/main" val="2059133241"/>
+        <p14:creationId xmlns:p14="http://schemas.microsoft.com/office/powerpoint/2010/main" val="30707401"/>
       </p:ext>
     </p:extLst>
   </p:cSld>
@@ -8259,7 +8259,7 @@
           <p:cNvPr id="6" name="">
             <a:extLst xmlns:a="http://schemas.openxmlformats.org/drawingml/2006/main">
               <a:ext uri="{FF2B5EF4-FFF2-40B4-BE49-F238E27FC236}">
-                <a16:creationId xmlns:a16="http://schemas.microsoft.com/office/drawing/2014/main" id="{11F0612B-DE94-4175-8248-8D5C0515E1FE}"/>
+                <a16:creationId xmlns:a16="http://schemas.microsoft.com/office/drawing/2014/main" id="{2B785153-A0A4-421A-94C0-B2CAD1D3EC4A}"/>
               </a:ext>
             </a:extLst>
           </p:cNvPr>
@@ -8316,7 +8316,7 @@
           <p:cNvPr id="2" name="">
             <a:extLst xmlns:a="http://schemas.openxmlformats.org/drawingml/2006/main">
               <a:ext uri="{FF2B5EF4-FFF2-40B4-BE49-F238E27FC236}">
-                <a16:creationId xmlns:a16="http://schemas.microsoft.com/office/drawing/2014/main" id="{84C6F991-59F3-4F41-BFA5-3B372796073C}"/>
+                <a16:creationId xmlns:a16="http://schemas.microsoft.com/office/drawing/2014/main" id="{6E46A1AA-E30E-4604-A09F-40B49ACC05EF}"/>
               </a:ext>
             </a:extLst>
           </p:cNvPr>
@@ -8373,7 +8373,7 @@
           <p:cNvPr id="3" name="">
             <a:extLst xmlns:a="http://schemas.openxmlformats.org/drawingml/2006/main">
               <a:ext uri="{FF2B5EF4-FFF2-40B4-BE49-F238E27FC236}">
-                <a16:creationId xmlns:a16="http://schemas.microsoft.com/office/drawing/2014/main" id="{9AC5B9AC-1114-41D5-AB02-7A37C801D4CB}"/>
+                <a16:creationId xmlns:a16="http://schemas.microsoft.com/office/drawing/2014/main" id="{876FED1E-3EFF-4292-8FE4-C357DBA14042}"/>
               </a:ext>
             </a:extLst>
           </p:cNvPr>
@@ -9246,7 +9246,7 @@
           <p:cNvPr id="5" name="">
             <a:extLst xmlns:a="http://schemas.openxmlformats.org/drawingml/2006/main">
               <a:ext uri="{FF2B5EF4-FFF2-40B4-BE49-F238E27FC236}">
-                <a16:creationId xmlns:a16="http://schemas.microsoft.com/office/drawing/2014/main" id="{60AB3F5E-451E-4047-A88C-E75205E6AF28}"/>
+                <a16:creationId xmlns:a16="http://schemas.microsoft.com/office/drawing/2014/main" id="{E98523FA-3791-444F-9067-9350886F8743}"/>
               </a:ext>
             </a:extLst>
           </p:cNvPr>
@@ -9301,7 +9301,7 @@
     </p:spTree>
     <p:extLst>
       <p:ext uri="{BB962C8B-B14F-4D97-AF65-F5344CB8AC3E}">
-        <p14:creationId xmlns:p14="http://schemas.microsoft.com/office/powerpoint/2010/main" val="269508118"/>
+        <p14:creationId xmlns:p14="http://schemas.microsoft.com/office/powerpoint/2010/main" val="100845625"/>
       </p:ext>
     </p:extLst>
   </p:cSld>
@@ -9332,7 +9332,7 @@
           <p:cNvPr id="6" name="">
             <a:extLst xmlns:a="http://schemas.openxmlformats.org/drawingml/2006/main">
               <a:ext uri="{FF2B5EF4-FFF2-40B4-BE49-F238E27FC236}">
-                <a16:creationId xmlns:a16="http://schemas.microsoft.com/office/drawing/2014/main" id="{6F822553-DB4E-4042-8465-8EC28B419922}"/>
+                <a16:creationId xmlns:a16="http://schemas.microsoft.com/office/drawing/2014/main" id="{D962F0E7-BFF3-4807-8F84-BC62BB818099}"/>
               </a:ext>
             </a:extLst>
           </p:cNvPr>
@@ -9389,7 +9389,7 @@
           <p:cNvPr id="2" name="">
             <a:extLst xmlns:a="http://schemas.openxmlformats.org/drawingml/2006/main">
               <a:ext uri="{FF2B5EF4-FFF2-40B4-BE49-F238E27FC236}">
-                <a16:creationId xmlns:a16="http://schemas.microsoft.com/office/drawing/2014/main" id="{20756BC0-961A-46FB-A73A-4A063BE0EC8D}"/>
+                <a16:creationId xmlns:a16="http://schemas.microsoft.com/office/drawing/2014/main" id="{227B18B6-4FBF-4E4C-95EC-E74B51990F31}"/>
               </a:ext>
             </a:extLst>
           </p:cNvPr>
@@ -9446,7 +9446,7 @@
           <p:cNvPr id="3" name="">
             <a:extLst xmlns:a="http://schemas.openxmlformats.org/drawingml/2006/main">
               <a:ext uri="{FF2B5EF4-FFF2-40B4-BE49-F238E27FC236}">
-                <a16:creationId xmlns:a16="http://schemas.microsoft.com/office/drawing/2014/main" id="{E3F90766-B3C1-4F16-B73C-BB1E8AAA928C}"/>
+                <a16:creationId xmlns:a16="http://schemas.microsoft.com/office/drawing/2014/main" id="{F31D94FA-3DF0-4BF9-962D-67AB11B69422}"/>
               </a:ext>
             </a:extLst>
           </p:cNvPr>
@@ -9503,7 +9503,7 @@
           <p:cNvPr id="4" name="">
             <a:extLst xmlns:a="http://schemas.openxmlformats.org/drawingml/2006/main">
               <a:ext uri="{FF2B5EF4-FFF2-40B4-BE49-F238E27FC236}">
-                <a16:creationId xmlns:a16="http://schemas.microsoft.com/office/drawing/2014/main" id="{AC36A180-ED22-4A9E-855B-CBE8D77B1C2E}"/>
+                <a16:creationId xmlns:a16="http://schemas.microsoft.com/office/drawing/2014/main" id="{24BE6FB2-728D-4A28-AABA-AB387CA0EDB2}"/>
               </a:ext>
             </a:extLst>
           </p:cNvPr>
@@ -9791,7 +9791,7 @@
     </p:spTree>
     <p:extLst>
       <p:ext uri="{BB962C8B-B14F-4D97-AF65-F5344CB8AC3E}">
-        <p14:creationId xmlns:p14="http://schemas.microsoft.com/office/powerpoint/2010/main" val="633891230"/>
+        <p14:creationId xmlns:p14="http://schemas.microsoft.com/office/powerpoint/2010/main" val="1285197974"/>
       </p:ext>
     </p:extLst>
   </p:cSld>
@@ -9822,7 +9822,7 @@
           <p:cNvPr id="9" name="">
             <a:extLst xmlns:a="http://schemas.openxmlformats.org/drawingml/2006/main">
               <a:ext uri="{FF2B5EF4-FFF2-40B4-BE49-F238E27FC236}">
-                <a16:creationId xmlns:a16="http://schemas.microsoft.com/office/drawing/2014/main" id="{93AFD798-0153-4975-867F-16487933A241}"/>
+                <a16:creationId xmlns:a16="http://schemas.microsoft.com/office/drawing/2014/main" id="{26292D99-8FE5-460E-8493-B209E87F92F6}"/>
               </a:ext>
             </a:extLst>
           </p:cNvPr>
@@ -9879,7 +9879,7 @@
           <p:cNvPr id="2" name="">
             <a:extLst xmlns:a="http://schemas.openxmlformats.org/drawingml/2006/main">
               <a:ext uri="{FF2B5EF4-FFF2-40B4-BE49-F238E27FC236}">
-                <a16:creationId xmlns:a16="http://schemas.microsoft.com/office/drawing/2014/main" id="{8599A73F-364A-4695-939E-3BA4D3F958D1}"/>
+                <a16:creationId xmlns:a16="http://schemas.microsoft.com/office/drawing/2014/main" id="{CC58B0E6-594B-4124-8F45-A4B7D3ED632A}"/>
               </a:ext>
             </a:extLst>
           </p:cNvPr>
@@ -9936,7 +9936,7 @@
           <p:cNvPr id="3" name="">
             <a:extLst xmlns:a="http://schemas.openxmlformats.org/drawingml/2006/main">
               <a:ext uri="{FF2B5EF4-FFF2-40B4-BE49-F238E27FC236}">
-                <a16:creationId xmlns:a16="http://schemas.microsoft.com/office/drawing/2014/main" id="{82FF0FF8-6A4B-4CDD-AE8A-F37DEE096D99}"/>
+                <a16:creationId xmlns:a16="http://schemas.microsoft.com/office/drawing/2014/main" id="{13D562C7-7D82-4701-B97E-89AAAF828419}"/>
               </a:ext>
             </a:extLst>
           </p:cNvPr>
@@ -9993,7 +9993,7 @@
           <p:cNvPr id="4" name="">
             <a:extLst xmlns:a="http://schemas.openxmlformats.org/drawingml/2006/main">
               <a:ext uri="{FF2B5EF4-FFF2-40B4-BE49-F238E27FC236}">
-                <a16:creationId xmlns:a16="http://schemas.microsoft.com/office/drawing/2014/main" id="{C48A9997-2A2C-49C8-9612-B10CB7A96856}"/>
+                <a16:creationId xmlns:a16="http://schemas.microsoft.com/office/drawing/2014/main" id="{9E13A2A6-9413-428E-A142-165DA9BBB3CC}"/>
               </a:ext>
             </a:extLst>
           </p:cNvPr>
@@ -10057,7 +10057,7 @@
         </p:xfrm>
         <a:graphic xmlns:a="http://schemas.openxmlformats.org/drawingml/2006/main">
           <a:graphicData uri="http://schemas.openxmlformats.org/drawingml/2006/chart">
-            <c:chart xmlns:r="http://schemas.openxmlformats.org/officeDocument/2006/relationships" xmlns:c="http://schemas.openxmlformats.org/drawingml/2006/chart" r:id="Re3d7429ce7244d72"/>
+            <c:chart xmlns:r="http://schemas.openxmlformats.org/officeDocument/2006/relationships" xmlns:c="http://schemas.openxmlformats.org/drawingml/2006/chart" r:id="Receb76cc05064b59"/>
           </a:graphicData>
         </a:graphic>
       </p:graphicFrame>
@@ -10066,7 +10066,7 @@
           <p:cNvPr id="6" name="">
             <a:extLst xmlns:a="http://schemas.openxmlformats.org/drawingml/2006/main">
               <a:ext uri="{FF2B5EF4-FFF2-40B4-BE49-F238E27FC236}">
-                <a16:creationId xmlns:a16="http://schemas.microsoft.com/office/drawing/2014/main" id="{0B5EB011-701D-4322-9468-A877ACD65CE5}"/>
+                <a16:creationId xmlns:a16="http://schemas.microsoft.com/office/drawing/2014/main" id="{D401E909-04D8-43C3-A2C6-6F090D11D0B8}"/>
               </a:ext>
             </a:extLst>
           </p:cNvPr>
@@ -10123,7 +10123,7 @@
           <p:cNvPr id="7" name="">
             <a:extLst xmlns:a="http://schemas.openxmlformats.org/drawingml/2006/main">
               <a:ext uri="{FF2B5EF4-FFF2-40B4-BE49-F238E27FC236}">
-                <a16:creationId xmlns:a16="http://schemas.microsoft.com/office/drawing/2014/main" id="{C3F0FE2A-6EB5-46A9-A3C2-3254BED91C30}"/>
+                <a16:creationId xmlns:a16="http://schemas.microsoft.com/office/drawing/2014/main" id="{04B29800-147B-4472-B636-43DE9737A1ED}"/>
               </a:ext>
             </a:extLst>
           </p:cNvPr>
@@ -10239,7 +10239,7 @@
           <p:cNvPr id="8" name="">
             <a:extLst xmlns:a="http://schemas.openxmlformats.org/drawingml/2006/main">
               <a:ext uri="{FF2B5EF4-FFF2-40B4-BE49-F238E27FC236}">
-                <a16:creationId xmlns:a16="http://schemas.microsoft.com/office/drawing/2014/main" id="{E0887F57-0B57-4515-9AA7-39536489790B}"/>
+                <a16:creationId xmlns:a16="http://schemas.microsoft.com/office/drawing/2014/main" id="{75106335-6FC0-40EE-A900-65A7DC67D376}"/>
               </a:ext>
             </a:extLst>
           </p:cNvPr>
@@ -10294,7 +10294,7 @@
     </p:spTree>
     <p:extLst>
       <p:ext uri="{BB962C8B-B14F-4D97-AF65-F5344CB8AC3E}">
-        <p14:creationId xmlns:p14="http://schemas.microsoft.com/office/powerpoint/2010/main" val="1970478976"/>
+        <p14:creationId xmlns:p14="http://schemas.microsoft.com/office/powerpoint/2010/main" val="1647793744"/>
       </p:ext>
     </p:extLst>
   </p:cSld>
@@ -10325,7 +10325,7 @@
           <p:cNvPr id="6" name="">
             <a:extLst xmlns:a="http://schemas.openxmlformats.org/drawingml/2006/main">
               <a:ext uri="{FF2B5EF4-FFF2-40B4-BE49-F238E27FC236}">
-                <a16:creationId xmlns:a16="http://schemas.microsoft.com/office/drawing/2014/main" id="{4CA99560-ADE6-4240-B05B-5AD2BCE3679A}"/>
+                <a16:creationId xmlns:a16="http://schemas.microsoft.com/office/drawing/2014/main" id="{A15B28EB-E52B-41C9-8A37-B3E0DE3DBFC0}"/>
               </a:ext>
             </a:extLst>
           </p:cNvPr>
@@ -10382,7 +10382,7 @@
           <p:cNvPr id="2" name="">
             <a:extLst xmlns:a="http://schemas.openxmlformats.org/drawingml/2006/main">
               <a:ext uri="{FF2B5EF4-FFF2-40B4-BE49-F238E27FC236}">
-                <a16:creationId xmlns:a16="http://schemas.microsoft.com/office/drawing/2014/main" id="{CFFCC6D7-19D8-4F1D-B348-D9F82B6BEC4D}"/>
+                <a16:creationId xmlns:a16="http://schemas.microsoft.com/office/drawing/2014/main" id="{E8A74F08-A8B7-40C1-8A6B-CC425D4BE47F}"/>
               </a:ext>
             </a:extLst>
           </p:cNvPr>
@@ -10439,7 +10439,7 @@
           <p:cNvPr id="3" name="">
             <a:extLst xmlns:a="http://schemas.openxmlformats.org/drawingml/2006/main">
               <a:ext uri="{FF2B5EF4-FFF2-40B4-BE49-F238E27FC236}">
-                <a16:creationId xmlns:a16="http://schemas.microsoft.com/office/drawing/2014/main" id="{3FC0D422-6248-43A6-8A1D-083DCED163AE}"/>
+                <a16:creationId xmlns:a16="http://schemas.microsoft.com/office/drawing/2014/main" id="{FF27EE0C-79F9-4B1F-B31F-F3C4840D087A}"/>
               </a:ext>
             </a:extLst>
           </p:cNvPr>
@@ -10919,7 +10919,7 @@
           <p:cNvPr id="5" name="">
             <a:extLst xmlns:a="http://schemas.openxmlformats.org/drawingml/2006/main">
               <a:ext uri="{FF2B5EF4-FFF2-40B4-BE49-F238E27FC236}">
-                <a16:creationId xmlns:a16="http://schemas.microsoft.com/office/drawing/2014/main" id="{141C94F4-963B-4554-878D-1B29012FE32C}"/>
+                <a16:creationId xmlns:a16="http://schemas.microsoft.com/office/drawing/2014/main" id="{4E502C7A-ED13-4207-9B75-5B58C92A30BF}"/>
               </a:ext>
             </a:extLst>
           </p:cNvPr>
@@ -10978,7 +10978,7 @@
     </p:spTree>
     <p:extLst>
       <p:ext uri="{BB962C8B-B14F-4D97-AF65-F5344CB8AC3E}">
-        <p14:creationId xmlns:p14="http://schemas.microsoft.com/office/powerpoint/2010/main" val="1822563191"/>
+        <p14:creationId xmlns:p14="http://schemas.microsoft.com/office/powerpoint/2010/main" val="766076677"/>
       </p:ext>
     </p:extLst>
   </p:cSld>
@@ -11009,7 +11009,7 @@
           <p:cNvPr id="5" name="">
             <a:extLst xmlns:a="http://schemas.openxmlformats.org/drawingml/2006/main">
               <a:ext uri="{FF2B5EF4-FFF2-40B4-BE49-F238E27FC236}">
-                <a16:creationId xmlns:a16="http://schemas.microsoft.com/office/drawing/2014/main" id="{0FE9903F-8142-4CF3-AAB2-89099711FC11}"/>
+                <a16:creationId xmlns:a16="http://schemas.microsoft.com/office/drawing/2014/main" id="{FBEB2474-CB25-4E6D-A224-4DB523C8F5B5}"/>
               </a:ext>
             </a:extLst>
           </p:cNvPr>
@@ -11066,7 +11066,7 @@
           <p:cNvPr id="2" name="">
             <a:extLst xmlns:a="http://schemas.openxmlformats.org/drawingml/2006/main">
               <a:ext uri="{FF2B5EF4-FFF2-40B4-BE49-F238E27FC236}">
-                <a16:creationId xmlns:a16="http://schemas.microsoft.com/office/drawing/2014/main" id="{D2D2BAAD-1FAC-451D-9F5F-AC9B5AEE7D7B}"/>
+                <a16:creationId xmlns:a16="http://schemas.microsoft.com/office/drawing/2014/main" id="{21CD345E-E9C5-4792-8F29-EFD1DF1992D5}"/>
               </a:ext>
             </a:extLst>
           </p:cNvPr>
@@ -11123,7 +11123,7 @@
           <p:cNvPr id="3" name="">
             <a:extLst xmlns:a="http://schemas.openxmlformats.org/drawingml/2006/main">
               <a:ext uri="{FF2B5EF4-FFF2-40B4-BE49-F238E27FC236}">
-                <a16:creationId xmlns:a16="http://schemas.microsoft.com/office/drawing/2014/main" id="{7F9CB7BD-C082-4E98-8C0B-8D28CCE9DE7B}"/>
+                <a16:creationId xmlns:a16="http://schemas.microsoft.com/office/drawing/2014/main" id="{0F3B4FFD-2B8E-4615-8F70-0377EC15D209}"/>
               </a:ext>
             </a:extLst>
           </p:cNvPr>
@@ -11537,7 +11537,7 @@
     </p:spTree>
     <p:extLst>
       <p:ext uri="{BB962C8B-B14F-4D97-AF65-F5344CB8AC3E}">
-        <p14:creationId xmlns:p14="http://schemas.microsoft.com/office/powerpoint/2010/main" val="396115484"/>
+        <p14:creationId xmlns:p14="http://schemas.microsoft.com/office/powerpoint/2010/main" val="131982224"/>
       </p:ext>
     </p:extLst>
   </p:cSld>
@@ -11568,7 +11568,7 @@
           <p:cNvPr id="9" name="">
             <a:extLst xmlns:a="http://schemas.openxmlformats.org/drawingml/2006/main">
               <a:ext uri="{FF2B5EF4-FFF2-40B4-BE49-F238E27FC236}">
-                <a16:creationId xmlns:a16="http://schemas.microsoft.com/office/drawing/2014/main" id="{555A06C4-A759-4C53-A4D8-2396DA180951}"/>
+                <a16:creationId xmlns:a16="http://schemas.microsoft.com/office/drawing/2014/main" id="{A5B48973-B157-415C-B8A6-A4DEC5A09EE9}"/>
               </a:ext>
             </a:extLst>
           </p:cNvPr>
@@ -11625,7 +11625,7 @@
           <p:cNvPr id="2" name="">
             <a:extLst xmlns:a="http://schemas.openxmlformats.org/drawingml/2006/main">
               <a:ext uri="{FF2B5EF4-FFF2-40B4-BE49-F238E27FC236}">
-                <a16:creationId xmlns:a16="http://schemas.microsoft.com/office/drawing/2014/main" id="{8983AB44-ADA5-408A-98B7-DBB50B0DFD6A}"/>
+                <a16:creationId xmlns:a16="http://schemas.microsoft.com/office/drawing/2014/main" id="{CF600A0B-0AF4-48C9-BE6C-39C399537559}"/>
               </a:ext>
             </a:extLst>
           </p:cNvPr>
@@ -11682,7 +11682,7 @@
           <p:cNvPr id="3" name="">
             <a:extLst xmlns:a="http://schemas.openxmlformats.org/drawingml/2006/main">
               <a:ext uri="{FF2B5EF4-FFF2-40B4-BE49-F238E27FC236}">
-                <a16:creationId xmlns:a16="http://schemas.microsoft.com/office/drawing/2014/main" id="{C27CC38B-F026-43C7-AED0-28D1D234FC0A}"/>
+                <a16:creationId xmlns:a16="http://schemas.microsoft.com/office/drawing/2014/main" id="{68F46AFB-4D47-4E4C-BCFC-655424D85ECE}"/>
               </a:ext>
             </a:extLst>
           </p:cNvPr>
@@ -11739,7 +11739,7 @@
           <p:cNvPr id="4" name="">
             <a:extLst xmlns:a="http://schemas.openxmlformats.org/drawingml/2006/main">
               <a:ext uri="{FF2B5EF4-FFF2-40B4-BE49-F238E27FC236}">
-                <a16:creationId xmlns:a16="http://schemas.microsoft.com/office/drawing/2014/main" id="{0BC2B90B-BEE1-44D6-8305-34FD873A8F19}"/>
+                <a16:creationId xmlns:a16="http://schemas.microsoft.com/office/drawing/2014/main" id="{338DAA53-B552-4CA0-BA0D-AA8E089F881D}"/>
               </a:ext>
             </a:extLst>
           </p:cNvPr>
@@ -11800,7 +11800,7 @@
           <p:cNvPr id="5" name="">
             <a:extLst xmlns:a="http://schemas.openxmlformats.org/drawingml/2006/main">
               <a:ext uri="{FF2B5EF4-FFF2-40B4-BE49-F238E27FC236}">
-                <a16:creationId xmlns:a16="http://schemas.microsoft.com/office/drawing/2014/main" id="{1922CBA6-76D2-4D87-9232-EC2102F1EFBF}"/>
+                <a16:creationId xmlns:a16="http://schemas.microsoft.com/office/drawing/2014/main" id="{3B62C125-83C0-479A-904E-A87F0232A7CE}"/>
               </a:ext>
             </a:extLst>
           </p:cNvPr>
@@ -11857,7 +11857,7 @@
           <p:cNvPr id="6" name="">
             <a:extLst xmlns:a="http://schemas.openxmlformats.org/drawingml/2006/main">
               <a:ext uri="{FF2B5EF4-FFF2-40B4-BE49-F238E27FC236}">
-                <a16:creationId xmlns:a16="http://schemas.microsoft.com/office/drawing/2014/main" id="{338871A0-9897-4C83-844F-5BC8047481D0}"/>
+                <a16:creationId xmlns:a16="http://schemas.microsoft.com/office/drawing/2014/main" id="{9790C229-0674-41CC-9775-7BBAE8DDC590}"/>
               </a:ext>
             </a:extLst>
           </p:cNvPr>
@@ -11918,7 +11918,7 @@
           <p:cNvPr id="7" name="">
             <a:extLst xmlns:a="http://schemas.openxmlformats.org/drawingml/2006/main">
               <a:ext uri="{FF2B5EF4-FFF2-40B4-BE49-F238E27FC236}">
-                <a16:creationId xmlns:a16="http://schemas.microsoft.com/office/drawing/2014/main" id="{FD9D3D75-0BD3-48B2-B463-E8B55DF3BCA3}"/>
+                <a16:creationId xmlns:a16="http://schemas.microsoft.com/office/drawing/2014/main" id="{E8AB72F2-3F7A-41F1-A105-3C365DBB16F2}"/>
               </a:ext>
             </a:extLst>
           </p:cNvPr>
@@ -11975,7 +11975,7 @@
           <p:cNvPr id="8" name="">
             <a:extLst xmlns:a="http://schemas.openxmlformats.org/drawingml/2006/main">
               <a:ext uri="{FF2B5EF4-FFF2-40B4-BE49-F238E27FC236}">
-                <a16:creationId xmlns:a16="http://schemas.microsoft.com/office/drawing/2014/main" id="{48DDD0FD-43BB-44C2-AE50-A490304E19D4}"/>
+                <a16:creationId xmlns:a16="http://schemas.microsoft.com/office/drawing/2014/main" id="{307E7E95-C9FC-4774-B544-25CAC2D79F09}"/>
               </a:ext>
             </a:extLst>
           </p:cNvPr>
@@ -12030,7 +12030,7 @@
     </p:spTree>
     <p:extLst>
       <p:ext uri="{BB962C8B-B14F-4D97-AF65-F5344CB8AC3E}">
-        <p14:creationId xmlns:p14="http://schemas.microsoft.com/office/powerpoint/2010/main" val="891671451"/>
+        <p14:creationId xmlns:p14="http://schemas.microsoft.com/office/powerpoint/2010/main" val="634152223"/>
       </p:ext>
     </p:extLst>
   </p:cSld>
@@ -12061,7 +12061,7 @@
           <p:cNvPr id="6" name="">
             <a:extLst xmlns:a="http://schemas.openxmlformats.org/drawingml/2006/main">
               <a:ext uri="{FF2B5EF4-FFF2-40B4-BE49-F238E27FC236}">
-                <a16:creationId xmlns:a16="http://schemas.microsoft.com/office/drawing/2014/main" id="{761135E1-4B78-4069-AA27-36AB8B0C62B8}"/>
+                <a16:creationId xmlns:a16="http://schemas.microsoft.com/office/drawing/2014/main" id="{9C222FF8-19FB-464A-B272-D99AB8A85564}"/>
               </a:ext>
             </a:extLst>
           </p:cNvPr>
@@ -12118,7 +12118,7 @@
           <p:cNvPr id="2" name="">
             <a:extLst xmlns:a="http://schemas.openxmlformats.org/drawingml/2006/main">
               <a:ext uri="{FF2B5EF4-FFF2-40B4-BE49-F238E27FC236}">
-                <a16:creationId xmlns:a16="http://schemas.microsoft.com/office/drawing/2014/main" id="{1DD64403-055D-42C0-AE4A-0C8E9D36ED60}"/>
+                <a16:creationId xmlns:a16="http://schemas.microsoft.com/office/drawing/2014/main" id="{92ED05CB-DB08-46A5-9D50-295FFE2E4353}"/>
               </a:ext>
             </a:extLst>
           </p:cNvPr>
@@ -12175,7 +12175,7 @@
           <p:cNvPr id="3" name="">
             <a:extLst xmlns:a="http://schemas.openxmlformats.org/drawingml/2006/main">
               <a:ext uri="{FF2B5EF4-FFF2-40B4-BE49-F238E27FC236}">
-                <a16:creationId xmlns:a16="http://schemas.microsoft.com/office/drawing/2014/main" id="{60040726-BD82-40D5-8317-393F6478265C}"/>
+                <a16:creationId xmlns:a16="http://schemas.microsoft.com/office/drawing/2014/main" id="{F5321CF7-2D48-41C8-A9F8-E62ED21E216D}"/>
               </a:ext>
             </a:extLst>
           </p:cNvPr>
@@ -12232,7 +12232,7 @@
           <p:cNvPr id="4" name="">
             <a:extLst xmlns:a="http://schemas.openxmlformats.org/drawingml/2006/main">
               <a:ext uri="{FF2B5EF4-FFF2-40B4-BE49-F238E27FC236}">
-                <a16:creationId xmlns:a16="http://schemas.microsoft.com/office/drawing/2014/main" id="{5D9E527B-1CE1-4AA7-B584-406694F7952F}"/>
+                <a16:creationId xmlns:a16="http://schemas.microsoft.com/office/drawing/2014/main" id="{E799F4FE-5C18-4E70-8DDD-434C1D6C5FAD}"/>
               </a:ext>
             </a:extLst>
           </p:cNvPr>
@@ -12374,7 +12374,7 @@
           <p:cNvPr id="5" name="">
             <a:extLst xmlns:a="http://schemas.openxmlformats.org/drawingml/2006/main">
               <a:ext uri="{FF2B5EF4-FFF2-40B4-BE49-F238E27FC236}">
-                <a16:creationId xmlns:a16="http://schemas.microsoft.com/office/drawing/2014/main" id="{450BD5B4-2990-4FA7-A13A-538A247C9B01}"/>
+                <a16:creationId xmlns:a16="http://schemas.microsoft.com/office/drawing/2014/main" id="{21C7E465-4BEF-4BAD-876A-E308AB067DA1}"/>
               </a:ext>
             </a:extLst>
           </p:cNvPr>
@@ -12421,7 +12421,7 @@
                 <a:ea typeface="Arial"/>
                 <a:cs typeface="Arial"/>
               </a:rPr>
-              <a:t>This is a different clinical task and does not validate our classifier.</a:t>
+              <a:t>This is a different clinical task and does not validate my classifier.</a:t>
             </a:r>
           </a:p>
         </p:txBody>
@@ -12429,7 +12429,7 @@
     </p:spTree>
     <p:extLst>
       <p:ext uri="{BB962C8B-B14F-4D97-AF65-F5344CB8AC3E}">
-        <p14:creationId xmlns:p14="http://schemas.microsoft.com/office/powerpoint/2010/main" val="1790455695"/>
+        <p14:creationId xmlns:p14="http://schemas.microsoft.com/office/powerpoint/2010/main" val="635623695"/>
       </p:ext>
     </p:extLst>
   </p:cSld>
@@ -12460,7 +12460,7 @@
           <p:cNvPr id="12" name="">
             <a:extLst xmlns:a="http://schemas.openxmlformats.org/drawingml/2006/main">
               <a:ext uri="{FF2B5EF4-FFF2-40B4-BE49-F238E27FC236}">
-                <a16:creationId xmlns:a16="http://schemas.microsoft.com/office/drawing/2014/main" id="{F34D02E7-368C-4F9E-A9AE-12804AD60F79}"/>
+                <a16:creationId xmlns:a16="http://schemas.microsoft.com/office/drawing/2014/main" id="{B8848057-D04E-4A00-933F-8B0CD66855B8}"/>
               </a:ext>
             </a:extLst>
           </p:cNvPr>
@@ -12517,7 +12517,7 @@
           <p:cNvPr id="2" name="">
             <a:extLst xmlns:a="http://schemas.openxmlformats.org/drawingml/2006/main">
               <a:ext uri="{FF2B5EF4-FFF2-40B4-BE49-F238E27FC236}">
-                <a16:creationId xmlns:a16="http://schemas.microsoft.com/office/drawing/2014/main" id="{DEEBF120-E533-44AC-9727-50F7466A8D83}"/>
+                <a16:creationId xmlns:a16="http://schemas.microsoft.com/office/drawing/2014/main" id="{A5691752-DED8-4E75-AECF-DFB253D7EF94}"/>
               </a:ext>
             </a:extLst>
           </p:cNvPr>
@@ -12574,7 +12574,7 @@
           <p:cNvPr id="3" name="">
             <a:extLst xmlns:a="http://schemas.openxmlformats.org/drawingml/2006/main">
               <a:ext uri="{FF2B5EF4-FFF2-40B4-BE49-F238E27FC236}">
-                <a16:creationId xmlns:a16="http://schemas.microsoft.com/office/drawing/2014/main" id="{2C8C908B-10CC-4D5B-B204-AAEFC984DFB2}"/>
+                <a16:creationId xmlns:a16="http://schemas.microsoft.com/office/drawing/2014/main" id="{B94740A6-D0D0-4E8B-A32F-64D8E7CC9488}"/>
               </a:ext>
             </a:extLst>
           </p:cNvPr>
@@ -12631,7 +12631,7 @@
           <p:cNvPr id="4" name="">
             <a:extLst xmlns:a="http://schemas.openxmlformats.org/drawingml/2006/main">
               <a:ext uri="{FF2B5EF4-FFF2-40B4-BE49-F238E27FC236}">
-                <a16:creationId xmlns:a16="http://schemas.microsoft.com/office/drawing/2014/main" id="{FD2E1ABB-1389-47EA-BD1B-10CDAD5F1CDD}"/>
+                <a16:creationId xmlns:a16="http://schemas.microsoft.com/office/drawing/2014/main" id="{A354281E-11B9-4E7A-B9C5-1106462AC3DA}"/>
               </a:ext>
             </a:extLst>
           </p:cNvPr>
@@ -12692,7 +12692,7 @@
           <p:cNvPr id="5" name="">
             <a:extLst xmlns:a="http://schemas.openxmlformats.org/drawingml/2006/main">
               <a:ext uri="{FF2B5EF4-FFF2-40B4-BE49-F238E27FC236}">
-                <a16:creationId xmlns:a16="http://schemas.microsoft.com/office/drawing/2014/main" id="{878BEEED-04C4-47DC-BB69-6ED26955EDE9}"/>
+                <a16:creationId xmlns:a16="http://schemas.microsoft.com/office/drawing/2014/main" id="{3F3EA7AA-98C8-4422-84EA-3434D5A711D3}"/>
               </a:ext>
             </a:extLst>
           </p:cNvPr>
@@ -12724,7 +12724,7 @@
           <p:cNvPr id="6" name="">
             <a:extLst xmlns:a="http://schemas.openxmlformats.org/drawingml/2006/main">
               <a:ext uri="{FF2B5EF4-FFF2-40B4-BE49-F238E27FC236}">
-                <a16:creationId xmlns:a16="http://schemas.microsoft.com/office/drawing/2014/main" id="{78BD6CEC-A411-4B62-A7E2-55344AEDBDA0}"/>
+                <a16:creationId xmlns:a16="http://schemas.microsoft.com/office/drawing/2014/main" id="{6B77326A-C287-47EC-9B60-B5FD018E63AD}"/>
               </a:ext>
             </a:extLst>
           </p:cNvPr>
@@ -12781,7 +12781,7 @@
           <p:cNvPr id="7" name="">
             <a:extLst xmlns:a="http://schemas.openxmlformats.org/drawingml/2006/main">
               <a:ext uri="{FF2B5EF4-FFF2-40B4-BE49-F238E27FC236}">
-                <a16:creationId xmlns:a16="http://schemas.microsoft.com/office/drawing/2014/main" id="{5AA5AB2C-D59B-4929-888A-4DD31D45AED9}"/>
+                <a16:creationId xmlns:a16="http://schemas.microsoft.com/office/drawing/2014/main" id="{DFA30412-C06A-4880-814A-63FD80F9C82D}"/>
               </a:ext>
             </a:extLst>
           </p:cNvPr>
@@ -12838,7 +12838,7 @@
           <p:cNvPr id="8" name="">
             <a:extLst xmlns:a="http://schemas.openxmlformats.org/drawingml/2006/main">
               <a:ext uri="{FF2B5EF4-FFF2-40B4-BE49-F238E27FC236}">
-                <a16:creationId xmlns:a16="http://schemas.microsoft.com/office/drawing/2014/main" id="{7EDEB9B7-582E-4458-A310-C582D85E564E}"/>
+                <a16:creationId xmlns:a16="http://schemas.microsoft.com/office/drawing/2014/main" id="{66061FE2-2218-42BA-91AE-A42D4B2C7992}"/>
               </a:ext>
             </a:extLst>
           </p:cNvPr>
@@ -12899,7 +12899,7 @@
           <p:cNvPr id="9" name="">
             <a:extLst xmlns:a="http://schemas.openxmlformats.org/drawingml/2006/main">
               <a:ext uri="{FF2B5EF4-FFF2-40B4-BE49-F238E27FC236}">
-                <a16:creationId xmlns:a16="http://schemas.microsoft.com/office/drawing/2014/main" id="{56BF50A0-F60E-48E6-AEFD-128A919F1C1B}"/>
+                <a16:creationId xmlns:a16="http://schemas.microsoft.com/office/drawing/2014/main" id="{265686C7-CA2C-4EF0-8609-A89D6C9095CF}"/>
               </a:ext>
             </a:extLst>
           </p:cNvPr>
@@ -12931,7 +12931,7 @@
           <p:cNvPr id="10" name="">
             <a:extLst xmlns:a="http://schemas.openxmlformats.org/drawingml/2006/main">
               <a:ext uri="{FF2B5EF4-FFF2-40B4-BE49-F238E27FC236}">
-                <a16:creationId xmlns:a16="http://schemas.microsoft.com/office/drawing/2014/main" id="{E91DF608-D7CE-4035-9452-11B163A1C62E}"/>
+                <a16:creationId xmlns:a16="http://schemas.microsoft.com/office/drawing/2014/main" id="{EFB58F6F-084F-4582-9FDD-0489C0C394F7}"/>
               </a:ext>
             </a:extLst>
           </p:cNvPr>
@@ -12988,7 +12988,7 @@
           <p:cNvPr id="11" name="">
             <a:extLst xmlns:a="http://schemas.openxmlformats.org/drawingml/2006/main">
               <a:ext uri="{FF2B5EF4-FFF2-40B4-BE49-F238E27FC236}">
-                <a16:creationId xmlns:a16="http://schemas.microsoft.com/office/drawing/2014/main" id="{5F41BED3-5E98-414C-AE95-5E99BDA14454}"/>
+                <a16:creationId xmlns:a16="http://schemas.microsoft.com/office/drawing/2014/main" id="{75F4AB5A-DC10-465D-B821-AF61BCC2B500}"/>
               </a:ext>
             </a:extLst>
           </p:cNvPr>
@@ -13043,7 +13043,7 @@
     </p:spTree>
     <p:extLst>
       <p:ext uri="{BB962C8B-B14F-4D97-AF65-F5344CB8AC3E}">
-        <p14:creationId xmlns:p14="http://schemas.microsoft.com/office/powerpoint/2010/main" val="1673337828"/>
+        <p14:creationId xmlns:p14="http://schemas.microsoft.com/office/powerpoint/2010/main" val="232443302"/>
       </p:ext>
     </p:extLst>
   </p:cSld>
@@ -13074,7 +13074,7 @@
           <p:cNvPr id="10" name="">
             <a:extLst xmlns:a="http://schemas.openxmlformats.org/drawingml/2006/main">
               <a:ext uri="{FF2B5EF4-FFF2-40B4-BE49-F238E27FC236}">
-                <a16:creationId xmlns:a16="http://schemas.microsoft.com/office/drawing/2014/main" id="{66C4118D-8416-4A7F-B645-B1F2DD6E8A2A}"/>
+                <a16:creationId xmlns:a16="http://schemas.microsoft.com/office/drawing/2014/main" id="{C51F835E-DF58-4A14-A492-85AEF575AE2E}"/>
               </a:ext>
             </a:extLst>
           </p:cNvPr>
@@ -13131,7 +13131,7 @@
           <p:cNvPr id="2" name="">
             <a:extLst xmlns:a="http://schemas.openxmlformats.org/drawingml/2006/main">
               <a:ext uri="{FF2B5EF4-FFF2-40B4-BE49-F238E27FC236}">
-                <a16:creationId xmlns:a16="http://schemas.microsoft.com/office/drawing/2014/main" id="{035A3072-0C5E-4A81-805E-90104609B279}"/>
+                <a16:creationId xmlns:a16="http://schemas.microsoft.com/office/drawing/2014/main" id="{5D82511D-527E-4AF8-83C3-31005CF22055}"/>
               </a:ext>
             </a:extLst>
           </p:cNvPr>
@@ -13188,7 +13188,7 @@
           <p:cNvPr id="3" name="">
             <a:extLst xmlns:a="http://schemas.openxmlformats.org/drawingml/2006/main">
               <a:ext uri="{FF2B5EF4-FFF2-40B4-BE49-F238E27FC236}">
-                <a16:creationId xmlns:a16="http://schemas.microsoft.com/office/drawing/2014/main" id="{66F0516F-0625-4D04-AAF4-4BAEACDA42E4}"/>
+                <a16:creationId xmlns:a16="http://schemas.microsoft.com/office/drawing/2014/main" id="{6CBFF378-5077-408D-9A69-C643423DB53E}"/>
               </a:ext>
             </a:extLst>
           </p:cNvPr>
@@ -13268,7 +13268,7 @@
           <p:cNvPr id="4" name="">
             <a:extLst xmlns:a="http://schemas.openxmlformats.org/drawingml/2006/main">
               <a:ext uri="{FF2B5EF4-FFF2-40B4-BE49-F238E27FC236}">
-                <a16:creationId xmlns:a16="http://schemas.microsoft.com/office/drawing/2014/main" id="{B117401F-EFC6-45B5-8840-BC9FBA48BEFD}"/>
+                <a16:creationId xmlns:a16="http://schemas.microsoft.com/office/drawing/2014/main" id="{1D257D2F-4DA4-463C-A9C9-3B45C7FDF9F6}"/>
               </a:ext>
             </a:extLst>
           </p:cNvPr>
@@ -13348,7 +13348,7 @@
           <p:cNvPr id="5" name="">
             <a:extLst xmlns:a="http://schemas.openxmlformats.org/drawingml/2006/main">
               <a:ext uri="{FF2B5EF4-FFF2-40B4-BE49-F238E27FC236}">
-                <a16:creationId xmlns:a16="http://schemas.microsoft.com/office/drawing/2014/main" id="{34DEB7BD-CEFB-4698-BC57-A7FC9D0C64A8}"/>
+                <a16:creationId xmlns:a16="http://schemas.microsoft.com/office/drawing/2014/main" id="{C5E466E1-0F6A-456A-97BF-24C9374B9A38}"/>
               </a:ext>
             </a:extLst>
           </p:cNvPr>
@@ -13377,7 +13377,7 @@
           <p:cNvPr id="6" name="">
             <a:extLst xmlns:a="http://schemas.openxmlformats.org/drawingml/2006/main">
               <a:ext uri="{FF2B5EF4-FFF2-40B4-BE49-F238E27FC236}">
-                <a16:creationId xmlns:a16="http://schemas.microsoft.com/office/drawing/2014/main" id="{44AEB4EA-ED14-4665-87CD-6C88A993770B}"/>
+                <a16:creationId xmlns:a16="http://schemas.microsoft.com/office/drawing/2014/main" id="{4F5D591D-CB0D-4A3D-AD20-58CCF9E1CE36}"/>
               </a:ext>
             </a:extLst>
           </p:cNvPr>
@@ -13457,7 +13457,7 @@
           <p:cNvPr id="7" name="">
             <a:extLst xmlns:a="http://schemas.openxmlformats.org/drawingml/2006/main">
               <a:ext uri="{FF2B5EF4-FFF2-40B4-BE49-F238E27FC236}">
-                <a16:creationId xmlns:a16="http://schemas.microsoft.com/office/drawing/2014/main" id="{B833412D-67EA-43CC-A02D-BB903C3CEB00}"/>
+                <a16:creationId xmlns:a16="http://schemas.microsoft.com/office/drawing/2014/main" id="{587D9924-844B-42DC-AF11-92198606D6D1}"/>
               </a:ext>
             </a:extLst>
           </p:cNvPr>
@@ -13560,7 +13560,7 @@
           <p:cNvPr id="8" name="">
             <a:extLst xmlns:a="http://schemas.openxmlformats.org/drawingml/2006/main">
               <a:ext uri="{FF2B5EF4-FFF2-40B4-BE49-F238E27FC236}">
-                <a16:creationId xmlns:a16="http://schemas.microsoft.com/office/drawing/2014/main" id="{299538CD-B4F8-4AEB-AE97-45A6EFE7C10C}"/>
+                <a16:creationId xmlns:a16="http://schemas.microsoft.com/office/drawing/2014/main" id="{AEAE6C24-EA5A-4EB5-8A5C-6C92CFBE30DC}"/>
               </a:ext>
             </a:extLst>
           </p:cNvPr>
@@ -13589,7 +13589,7 @@
           <p:cNvPr id="9" name="">
             <a:extLst xmlns:a="http://schemas.openxmlformats.org/drawingml/2006/main">
               <a:ext uri="{FF2B5EF4-FFF2-40B4-BE49-F238E27FC236}">
-                <a16:creationId xmlns:a16="http://schemas.microsoft.com/office/drawing/2014/main" id="{CA59AA53-A6A8-4203-844B-B7697A3431BC}"/>
+                <a16:creationId xmlns:a16="http://schemas.microsoft.com/office/drawing/2014/main" id="{4BD538A9-F641-42C7-B989-E2BD32502DCF}"/>
               </a:ext>
             </a:extLst>
           </p:cNvPr>
@@ -13667,7 +13667,7 @@
     </p:spTree>
     <p:extLst>
       <p:ext uri="{BB962C8B-B14F-4D97-AF65-F5344CB8AC3E}">
-        <p14:creationId xmlns:p14="http://schemas.microsoft.com/office/powerpoint/2010/main" val="2095467691"/>
+        <p14:creationId xmlns:p14="http://schemas.microsoft.com/office/powerpoint/2010/main" val="678934267"/>
       </p:ext>
     </p:extLst>
   </p:cSld>
@@ -13698,7 +13698,7 @@
           <p:cNvPr id="13" name="">
             <a:extLst xmlns:a="http://schemas.openxmlformats.org/drawingml/2006/main">
               <a:ext uri="{FF2B5EF4-FFF2-40B4-BE49-F238E27FC236}">
-                <a16:creationId xmlns:a16="http://schemas.microsoft.com/office/drawing/2014/main" id="{C4F29D6F-3370-43F3-B3C0-A60CDA463CCD}"/>
+                <a16:creationId xmlns:a16="http://schemas.microsoft.com/office/drawing/2014/main" id="{D1C3AF68-6122-4AC9-B4F7-8A37EB18C64F}"/>
               </a:ext>
             </a:extLst>
           </p:cNvPr>
@@ -13755,7 +13755,7 @@
           <p:cNvPr id="2" name="">
             <a:extLst xmlns:a="http://schemas.openxmlformats.org/drawingml/2006/main">
               <a:ext uri="{FF2B5EF4-FFF2-40B4-BE49-F238E27FC236}">
-                <a16:creationId xmlns:a16="http://schemas.microsoft.com/office/drawing/2014/main" id="{F6FAF9AC-AC8D-4A14-B093-5EAD89F89643}"/>
+                <a16:creationId xmlns:a16="http://schemas.microsoft.com/office/drawing/2014/main" id="{B6695A7E-DA75-47BA-A221-0FDC6C04E2C1}"/>
               </a:ext>
             </a:extLst>
           </p:cNvPr>
@@ -13812,7 +13812,7 @@
           <p:cNvPr id="3" name="">
             <a:extLst xmlns:a="http://schemas.openxmlformats.org/drawingml/2006/main">
               <a:ext uri="{FF2B5EF4-FFF2-40B4-BE49-F238E27FC236}">
-                <a16:creationId xmlns:a16="http://schemas.microsoft.com/office/drawing/2014/main" id="{367527E3-35AD-4762-8A0E-1948F4E7998C}"/>
+                <a16:creationId xmlns:a16="http://schemas.microsoft.com/office/drawing/2014/main" id="{2D17BDD4-B208-4689-AC28-93B3359B1426}"/>
               </a:ext>
             </a:extLst>
           </p:cNvPr>
@@ -13869,7 +13869,7 @@
           <p:cNvPr id="4" name="">
             <a:extLst xmlns:a="http://schemas.openxmlformats.org/drawingml/2006/main">
               <a:ext uri="{FF2B5EF4-FFF2-40B4-BE49-F238E27FC236}">
-                <a16:creationId xmlns:a16="http://schemas.microsoft.com/office/drawing/2014/main" id="{CFF7D202-B323-4C97-B2F9-6CE897F50D29}"/>
+                <a16:creationId xmlns:a16="http://schemas.microsoft.com/office/drawing/2014/main" id="{966E6ED7-54A8-449B-9EBE-673551EB4E1A}"/>
               </a:ext>
             </a:extLst>
           </p:cNvPr>
@@ -13926,7 +13926,7 @@
           <p:cNvPr id="5" name="">
             <a:extLst xmlns:a="http://schemas.openxmlformats.org/drawingml/2006/main">
               <a:ext uri="{FF2B5EF4-FFF2-40B4-BE49-F238E27FC236}">
-                <a16:creationId xmlns:a16="http://schemas.microsoft.com/office/drawing/2014/main" id="{D7FF3ACE-CC94-4E45-96E1-2EB9D066F0FC}"/>
+                <a16:creationId xmlns:a16="http://schemas.microsoft.com/office/drawing/2014/main" id="{44CF3F60-C1DD-4B6C-A1BF-C50F49AEFEDE}"/>
               </a:ext>
             </a:extLst>
           </p:cNvPr>
@@ -13983,7 +13983,7 @@
           <p:cNvPr id="6" name="">
             <a:extLst xmlns:a="http://schemas.openxmlformats.org/drawingml/2006/main">
               <a:ext uri="{FF2B5EF4-FFF2-40B4-BE49-F238E27FC236}">
-                <a16:creationId xmlns:a16="http://schemas.microsoft.com/office/drawing/2014/main" id="{A437C660-FF60-43D0-A4E3-6B46E024BF61}"/>
+                <a16:creationId xmlns:a16="http://schemas.microsoft.com/office/drawing/2014/main" id="{B944F978-1822-47C3-BD62-F90CF7883715}"/>
               </a:ext>
             </a:extLst>
           </p:cNvPr>
@@ -14624,7 +14624,7 @@
           <p:cNvPr id="9" name="">
             <a:extLst xmlns:a="http://schemas.openxmlformats.org/drawingml/2006/main">
               <a:ext uri="{FF2B5EF4-FFF2-40B4-BE49-F238E27FC236}">
-                <a16:creationId xmlns:a16="http://schemas.microsoft.com/office/drawing/2014/main" id="{35851B03-D414-4117-B1E2-ADFEB806F30D}"/>
+                <a16:creationId xmlns:a16="http://schemas.microsoft.com/office/drawing/2014/main" id="{A99CF02A-1925-4033-9E34-A7EE6232B789}"/>
               </a:ext>
             </a:extLst>
           </p:cNvPr>
@@ -14653,7 +14653,7 @@
           <p:cNvPr id="10" name="">
             <a:extLst xmlns:a="http://schemas.openxmlformats.org/drawingml/2006/main">
               <a:ext uri="{FF2B5EF4-FFF2-40B4-BE49-F238E27FC236}">
-                <a16:creationId xmlns:a16="http://schemas.microsoft.com/office/drawing/2014/main" id="{AF05D230-526F-4FBC-A7C6-FF641D6EA9AE}"/>
+                <a16:creationId xmlns:a16="http://schemas.microsoft.com/office/drawing/2014/main" id="{88578FD9-F10A-4FF8-BACB-C87439FCD78A}"/>
               </a:ext>
             </a:extLst>
           </p:cNvPr>
@@ -14710,7 +14710,7 @@
           <p:cNvPr id="11" name="">
             <a:extLst xmlns:a="http://schemas.openxmlformats.org/drawingml/2006/main">
               <a:ext uri="{FF2B5EF4-FFF2-40B4-BE49-F238E27FC236}">
-                <a16:creationId xmlns:a16="http://schemas.microsoft.com/office/drawing/2014/main" id="{DA8473DF-7560-4C85-BD8B-15C926F17A66}"/>
+                <a16:creationId xmlns:a16="http://schemas.microsoft.com/office/drawing/2014/main" id="{58D65CD6-CA8C-4DAA-91C1-D6DA5796227E}"/>
               </a:ext>
             </a:extLst>
           </p:cNvPr>
@@ -14767,7 +14767,7 @@
           <p:cNvPr id="12" name="">
             <a:extLst xmlns:a="http://schemas.openxmlformats.org/drawingml/2006/main">
               <a:ext uri="{FF2B5EF4-FFF2-40B4-BE49-F238E27FC236}">
-                <a16:creationId xmlns:a16="http://schemas.microsoft.com/office/drawing/2014/main" id="{3F23F906-F252-4FC2-A4B3-3E2B8B8929D6}"/>
+                <a16:creationId xmlns:a16="http://schemas.microsoft.com/office/drawing/2014/main" id="{B5800147-36EF-4BCE-A64E-277CABDEE080}"/>
               </a:ext>
             </a:extLst>
           </p:cNvPr>
@@ -14822,7 +14822,7 @@
     </p:spTree>
     <p:extLst>
       <p:ext uri="{BB962C8B-B14F-4D97-AF65-F5344CB8AC3E}">
-        <p14:creationId xmlns:p14="http://schemas.microsoft.com/office/powerpoint/2010/main" val="1516088969"/>
+        <p14:creationId xmlns:p14="http://schemas.microsoft.com/office/powerpoint/2010/main" val="226790736"/>
       </p:ext>
     </p:extLst>
   </p:cSld>
@@ -14850,10 +14850,10 @@
       </p:grpSpPr>
       <p:sp>
         <p:nvSpPr>
-          <p:cNvPr id="6" name="">
+          <p:cNvPr id="7" name="">
             <a:extLst xmlns:a="http://schemas.openxmlformats.org/drawingml/2006/main">
               <a:ext uri="{FF2B5EF4-FFF2-40B4-BE49-F238E27FC236}">
-                <a16:creationId xmlns:a16="http://schemas.microsoft.com/office/drawing/2014/main" id="{97082387-50A6-4230-A076-A3DD53BC49E1}"/>
+                <a16:creationId xmlns:a16="http://schemas.microsoft.com/office/drawing/2014/main" id="{9F181F1B-25CF-4DC5-9E56-862CA3703E96}"/>
               </a:ext>
             </a:extLst>
           </p:cNvPr>
@@ -14910,7 +14910,7 @@
           <p:cNvPr id="2" name="">
             <a:extLst xmlns:a="http://schemas.openxmlformats.org/drawingml/2006/main">
               <a:ext uri="{FF2B5EF4-FFF2-40B4-BE49-F238E27FC236}">
-                <a16:creationId xmlns:a16="http://schemas.microsoft.com/office/drawing/2014/main" id="{EC00C321-F4C4-47D7-B8F0-7F0378F6548C}"/>
+                <a16:creationId xmlns:a16="http://schemas.microsoft.com/office/drawing/2014/main" id="{EEF9FD1E-4A1C-48A0-AA04-EA7CDF03E9DB}"/>
               </a:ext>
             </a:extLst>
           </p:cNvPr>
@@ -14957,7 +14957,7 @@
                 <a:ea typeface="Arial"/>
                 <a:cs typeface="Arial"/>
               </a:rPr>
-              <a:t>Source: Zhang et al. (2024), GSE212160; project diagnosis mapping</a:t>
+              <a:t>Sources: Zhang et al. (2024), Tables 5–6 and Discussion, p. 11; project diagnosis mapping</a:t>
             </a:r>
           </a:p>
         </p:txBody>
@@ -14967,7 +14967,7 @@
           <p:cNvPr id="3" name="">
             <a:extLst xmlns:a="http://schemas.openxmlformats.org/drawingml/2006/main">
               <a:ext uri="{FF2B5EF4-FFF2-40B4-BE49-F238E27FC236}">
-                <a16:creationId xmlns:a16="http://schemas.microsoft.com/office/drawing/2014/main" id="{8E840CB6-9A7E-4C51-86F1-ED20DC3D797A}"/>
+                <a16:creationId xmlns:a16="http://schemas.microsoft.com/office/drawing/2014/main" id="{42EF78D0-302D-41D1-A494-3D8C0FF3FECA}"/>
               </a:ext>
             </a:extLst>
           </p:cNvPr>
@@ -15019,15 +15019,72 @@
           </a:p>
         </p:txBody>
       </p:sp>
+      <p:sp>
+        <p:nvSpPr>
+          <p:cNvPr id="4" name="">
+            <a:extLst xmlns:a="http://schemas.openxmlformats.org/drawingml/2006/main">
+              <a:ext uri="{FF2B5EF4-FFF2-40B4-BE49-F238E27FC236}">
+                <a16:creationId xmlns:a16="http://schemas.microsoft.com/office/drawing/2014/main" id="{95539E92-7929-4E7A-81FE-FB039DDDDD6D}"/>
+              </a:ext>
+            </a:extLst>
+          </p:cNvPr>
+          <p:cNvSpPr>
+            <a:spLocks xmlns:a="http://schemas.openxmlformats.org/drawingml/2006/main" noGrp="1"/>
+          </p:cNvSpPr>
+          <p:nvPr/>
+        </p:nvSpPr>
+        <p:spPr>
+          <a:xfrm xmlns:a="http://schemas.openxmlformats.org/drawingml/2006/main">
+            <a:off x="609600" y="1581150"/>
+            <a:ext cx="10972800" cy="666750"/>
+          </a:xfrm>
+          <a:prstGeom xmlns:a="http://schemas.openxmlformats.org/drawingml/2006/main" prst="rect">
+            <a:avLst/>
+          </a:prstGeom>
+          <a:noFill xmlns:a="http://schemas.openxmlformats.org/drawingml/2006/main"/>
+          <a:ln xmlns:a="http://schemas.openxmlformats.org/drawingml/2006/main" w="0">
+            <a:noFill/>
+          </a:ln>
+        </p:spPr>
+        <p:txBody>
+          <a:bodyPr xmlns:a="http://schemas.openxmlformats.org/drawingml/2006/main" anchor="ctr">
+            <a:noAutofit/>
+          </a:bodyPr>
+          <a:lstStyle xmlns:a="http://schemas.openxmlformats.org/drawingml/2006/main"/>
+          <a:p xmlns:a="http://schemas.openxmlformats.org/drawingml/2006/main">
+            <a:pPr algn="l">
+              <a:defRPr sz="2400" b="0">
+                <a:solidFill>
+                  <a:srgbClr val="007C78"/>
+                </a:solidFill>
+                <a:latin typeface="Arial"/>
+                <a:ea typeface="Arial"/>
+                <a:cs typeface="Arial"/>
+              </a:defRPr>
+            </a:pPr>
+            <a:r>
+              <a:rPr sz="2400" b="0">
+                <a:solidFill>
+                  <a:srgbClr val="007C78"/>
+                </a:solidFill>
+                <a:latin typeface="Arial"/>
+                <a:ea typeface="Arial"/>
+                <a:cs typeface="Arial"/>
+              </a:rPr>
+              <a:t>The model combines the three rejection categories included in this study.</a:t>
+            </a:r>
+          </a:p>
+        </p:txBody>
+      </p:sp>
       <p:graphicFrame>
         <p:nvGraphicFramePr>
-          <p:cNvPr id="9" name=""/>
+          <p:cNvPr id="11" name=""/>
           <p:cNvGraphicFramePr/>
           <p:nvPr/>
         </p:nvGraphicFramePr>
         <p:xfrm>
-          <a:off xmlns:a="http://schemas.openxmlformats.org/drawingml/2006/main" x="609600" y="1724025"/>
-          <a:ext xmlns:a="http://schemas.openxmlformats.org/drawingml/2006/main" cx="10972800" cy="3495675"/>
+          <a:off xmlns:a="http://schemas.openxmlformats.org/drawingml/2006/main" x="609600" y="2428875"/>
+          <a:ext xmlns:a="http://schemas.openxmlformats.org/drawingml/2006/main" cx="10972800" cy="3095625"/>
         </p:xfrm>
         <a:graphic xmlns:a="http://schemas.openxmlformats.org/drawingml/2006/main">
           <a:graphicData uri="http://schemas.openxmlformats.org/drawingml/2006/table">
@@ -15038,7 +15095,7 @@
                 <a:gridCol w="3876675"/>
                 <a:gridCol w="2476500"/>
               </a:tblGrid>
-              <a:tr h="699135">
+              <a:tr h="619125">
                 <a:tc>
                   <a:txBody>
                     <a:bodyPr>
@@ -15118,7 +15175,7 @@
                   </a:tcPr>
                 </a:tc>
               </a:tr>
-              <a:tr h="699135">
+              <a:tr h="619125">
                 <a:tc>
                   <a:txBody>
                     <a:bodyPr>
@@ -15198,7 +15255,7 @@
                   </a:tcPr>
                 </a:tc>
               </a:tr>
-              <a:tr h="699135">
+              <a:tr h="619125">
                 <a:tc>
                   <a:txBody>
                     <a:bodyPr>
@@ -15278,7 +15335,7 @@
                   </a:tcPr>
                 </a:tc>
               </a:tr>
-              <a:tr h="699135">
+              <a:tr h="619125">
                 <a:tc>
                   <a:txBody>
                     <a:bodyPr>
@@ -15358,7 +15415,7 @@
                   </a:tcPr>
                 </a:tc>
               </a:tr>
-              <a:tr h="699135">
+              <a:tr h="619125">
                 <a:tc>
                   <a:txBody>
                     <a:bodyPr>
@@ -15444,10 +15501,10 @@
       </p:graphicFrame>
       <p:sp>
         <p:nvSpPr>
-          <p:cNvPr id="5" name="">
+          <p:cNvPr id="6" name="">
             <a:extLst xmlns:a="http://schemas.openxmlformats.org/drawingml/2006/main">
               <a:ext uri="{FF2B5EF4-FFF2-40B4-BE49-F238E27FC236}">
-                <a16:creationId xmlns:a16="http://schemas.microsoft.com/office/drawing/2014/main" id="{986BE59F-1201-4272-8E70-2AA7B5D92065}"/>
+                <a16:creationId xmlns:a16="http://schemas.microsoft.com/office/drawing/2014/main" id="{DDFE2DC3-454F-40B8-A91B-E0ACF30FA75E}"/>
               </a:ext>
             </a:extLst>
           </p:cNvPr>
@@ -15458,8 +15515,8 @@
         </p:nvSpPr>
         <p:spPr>
           <a:xfrm xmlns:a="http://schemas.openxmlformats.org/drawingml/2006/main">
-            <a:off x="609600" y="5572125"/>
-            <a:ext cx="10972800" cy="571500"/>
+            <a:off x="609600" y="5695950"/>
+            <a:ext cx="10972800" cy="419100"/>
           </a:xfrm>
           <a:prstGeom xmlns:a="http://schemas.openxmlformats.org/drawingml/2006/main" prst="rect">
             <a:avLst/>
@@ -15476,25 +15533,25 @@
           <a:lstStyle xmlns:a="http://schemas.openxmlformats.org/drawingml/2006/main"/>
           <a:p xmlns:a="http://schemas.openxmlformats.org/drawingml/2006/main">
             <a:pPr algn="l">
-              <a:defRPr sz="2400" b="0">
-                <a:solidFill>
-                  <a:srgbClr val="007C78"/>
-                </a:solidFill>
-                <a:latin typeface="Arial"/>
-                <a:ea typeface="Arial"/>
-                <a:cs typeface="Arial"/>
-              </a:defRPr>
-            </a:pPr>
-            <a:r>
-              <a:rPr sz="2400" b="0">
-                <a:solidFill>
-                  <a:srgbClr val="007C78"/>
-                </a:solidFill>
-                <a:latin typeface="Arial"/>
-                <a:ea typeface="Arial"/>
-                <a:cs typeface="Arial"/>
-              </a:rPr>
-              <a:t>The main question combines all three forms of rejection.</a:t>
+              <a:defRPr sz="1950" b="0">
+                <a:solidFill>
+                  <a:srgbClr val="52656B"/>
+                </a:solidFill>
+                <a:latin typeface="Arial"/>
+                <a:ea typeface="Arial"/>
+                <a:cs typeface="Arial"/>
+              </a:defRPr>
+            </a:pPr>
+            <a:r>
+              <a:rPr sz="1950" b="0">
+                <a:solidFill>
+                  <a:srgbClr val="52656B"/>
+                </a:solidFill>
+                <a:latin typeface="Arial"/>
+                <a:ea typeface="Arial"/>
+                <a:cs typeface="Arial"/>
+              </a:rPr>
+              <a:t>Some diagnostic categories were excluded from the study.</a:t>
             </a:r>
           </a:p>
         </p:txBody>
@@ -15502,7 +15559,7 @@
     </p:spTree>
     <p:extLst>
       <p:ext uri="{BB962C8B-B14F-4D97-AF65-F5344CB8AC3E}">
-        <p14:creationId xmlns:p14="http://schemas.microsoft.com/office/powerpoint/2010/main" val="96008773"/>
+        <p14:creationId xmlns:p14="http://schemas.microsoft.com/office/powerpoint/2010/main" val="799425300"/>
       </p:ext>
     </p:extLst>
   </p:cSld>
@@ -15533,7 +15590,7 @@
           <p:cNvPr id="11" name="">
             <a:extLst xmlns:a="http://schemas.openxmlformats.org/drawingml/2006/main">
               <a:ext uri="{FF2B5EF4-FFF2-40B4-BE49-F238E27FC236}">
-                <a16:creationId xmlns:a16="http://schemas.microsoft.com/office/drawing/2014/main" id="{8DC0A12B-5F48-44B4-9F1F-3A4B07721167}"/>
+                <a16:creationId xmlns:a16="http://schemas.microsoft.com/office/drawing/2014/main" id="{01019537-945F-459A-89CF-90B826F55CB6}"/>
               </a:ext>
             </a:extLst>
           </p:cNvPr>
@@ -15590,7 +15647,7 @@
           <p:cNvPr id="2" name="">
             <a:extLst xmlns:a="http://schemas.openxmlformats.org/drawingml/2006/main">
               <a:ext uri="{FF2B5EF4-FFF2-40B4-BE49-F238E27FC236}">
-                <a16:creationId xmlns:a16="http://schemas.microsoft.com/office/drawing/2014/main" id="{88A8A3BC-D7A5-4761-8556-641DE8DC053D}"/>
+                <a16:creationId xmlns:a16="http://schemas.microsoft.com/office/drawing/2014/main" id="{C346A449-D8C1-4911-9E10-743D18204D41}"/>
               </a:ext>
             </a:extLst>
           </p:cNvPr>
@@ -15647,7 +15704,7 @@
           <p:cNvPr id="3" name="">
             <a:extLst xmlns:a="http://schemas.openxmlformats.org/drawingml/2006/main">
               <a:ext uri="{FF2B5EF4-FFF2-40B4-BE49-F238E27FC236}">
-                <a16:creationId xmlns:a16="http://schemas.microsoft.com/office/drawing/2014/main" id="{FF273E55-F155-4871-A35B-56CBCB10C84B}"/>
+                <a16:creationId xmlns:a16="http://schemas.microsoft.com/office/drawing/2014/main" id="{8D675409-E84C-4F09-849C-E73A5AA2BD6B}"/>
               </a:ext>
             </a:extLst>
           </p:cNvPr>
@@ -15704,7 +15761,7 @@
           <p:cNvPr id="4" name="">
             <a:extLst xmlns:a="http://schemas.openxmlformats.org/drawingml/2006/main">
               <a:ext uri="{FF2B5EF4-FFF2-40B4-BE49-F238E27FC236}">
-                <a16:creationId xmlns:a16="http://schemas.microsoft.com/office/drawing/2014/main" id="{A522D254-CABD-40A8-81DC-9C1A0BE5DECD}"/>
+                <a16:creationId xmlns:a16="http://schemas.microsoft.com/office/drawing/2014/main" id="{B70F0D56-4DFE-4846-9295-8A006A4433BD}"/>
               </a:ext>
             </a:extLst>
           </p:cNvPr>
@@ -15761,7 +15818,7 @@
           <p:cNvPr id="5" name="">
             <a:extLst xmlns:a="http://schemas.openxmlformats.org/drawingml/2006/main">
               <a:ext uri="{FF2B5EF4-FFF2-40B4-BE49-F238E27FC236}">
-                <a16:creationId xmlns:a16="http://schemas.microsoft.com/office/drawing/2014/main" id="{280204C1-CDCD-43C3-BEE7-4D89F4A5E24E}"/>
+                <a16:creationId xmlns:a16="http://schemas.microsoft.com/office/drawing/2014/main" id="{ED51939A-7B5C-4759-B6F1-ACA5B2A3A50C}"/>
               </a:ext>
             </a:extLst>
           </p:cNvPr>
@@ -15818,7 +15875,7 @@
           <p:cNvPr id="6" name="">
             <a:extLst xmlns:a="http://schemas.openxmlformats.org/drawingml/2006/main">
               <a:ext uri="{FF2B5EF4-FFF2-40B4-BE49-F238E27FC236}">
-                <a16:creationId xmlns:a16="http://schemas.microsoft.com/office/drawing/2014/main" id="{59ABFDFC-E96A-45A5-86F8-6BCE749A4EB7}"/>
+                <a16:creationId xmlns:a16="http://schemas.microsoft.com/office/drawing/2014/main" id="{2AEE672E-3E67-4831-8512-CF8B4C745ED7}"/>
               </a:ext>
             </a:extLst>
           </p:cNvPr>
@@ -15875,7 +15932,7 @@
           <p:cNvPr id="7" name="">
             <a:extLst xmlns:a="http://schemas.openxmlformats.org/drawingml/2006/main">
               <a:ext uri="{FF2B5EF4-FFF2-40B4-BE49-F238E27FC236}">
-                <a16:creationId xmlns:a16="http://schemas.microsoft.com/office/drawing/2014/main" id="{BC81C9D8-65B6-4E03-AEF0-6B7EDFDD4808}"/>
+                <a16:creationId xmlns:a16="http://schemas.microsoft.com/office/drawing/2014/main" id="{8096422C-C33F-4148-990F-C180AC26D2E3}"/>
               </a:ext>
             </a:extLst>
           </p:cNvPr>
@@ -15926,33 +15983,6 @@
                 <a:ea typeface="Arial"/>
                 <a:cs typeface="Arial"/>
               </a:rPr>
-              <a:t>Normalized counts are the model inputs.</a:t>
-            </a:r>
-          </a:p>
-          <a:p xmlns:a="http://schemas.openxmlformats.org/drawingml/2006/main">
-            <a:pPr marL="279400" indent="-152400" algn="l">
-              <a:spcAft>
-                <a:spcPts val="1200"/>
-              </a:spcAft>
-              <a:buChar char="•"/>
-              <a:defRPr sz="2175" b="0">
-                <a:solidFill>
-                  <a:srgbClr val="16343E"/>
-                </a:solidFill>
-                <a:latin typeface="Arial"/>
-                <a:ea typeface="Arial"/>
-                <a:cs typeface="Arial"/>
-              </a:defRPr>
-            </a:pPr>
-            <a:r>
-              <a:rPr sz="2175" b="0">
-                <a:solidFill>
-                  <a:srgbClr val="16343E"/>
-                </a:solidFill>
-                <a:latin typeface="Arial"/>
-                <a:ea typeface="Arial"/>
-                <a:cs typeface="Arial"/>
-              </a:rPr>
               <a:t>Include human and viral RNA.</a:t>
             </a:r>
           </a:p>
@@ -15990,7 +16020,7 @@
           <p:cNvPr id="8" name="">
             <a:extLst xmlns:a="http://schemas.openxmlformats.org/drawingml/2006/main">
               <a:ext uri="{FF2B5EF4-FFF2-40B4-BE49-F238E27FC236}">
-                <a16:creationId xmlns:a16="http://schemas.microsoft.com/office/drawing/2014/main" id="{FEB6434E-DA54-40D9-9A85-BD9A1BDD4E25}"/>
+                <a16:creationId xmlns:a16="http://schemas.microsoft.com/office/drawing/2014/main" id="{B72D3CFD-8E2E-4015-A4B1-D8EB0591A2F8}"/>
               </a:ext>
             </a:extLst>
           </p:cNvPr>
@@ -16047,7 +16077,7 @@
           <p:cNvPr id="9" name="">
             <a:extLst xmlns:a="http://schemas.openxmlformats.org/drawingml/2006/main">
               <a:ext uri="{FF2B5EF4-FFF2-40B4-BE49-F238E27FC236}">
-                <a16:creationId xmlns:a16="http://schemas.microsoft.com/office/drawing/2014/main" id="{68F57799-48A6-4EEF-8650-DABF7F842678}"/>
+                <a16:creationId xmlns:a16="http://schemas.microsoft.com/office/drawing/2014/main" id="{D2574B07-F256-49EC-9289-551127636050}"/>
               </a:ext>
             </a:extLst>
           </p:cNvPr>
@@ -16104,7 +16134,7 @@
           <p:cNvPr id="10" name="">
             <a:extLst xmlns:a="http://schemas.openxmlformats.org/drawingml/2006/main">
               <a:ext uri="{FF2B5EF4-FFF2-40B4-BE49-F238E27FC236}">
-                <a16:creationId xmlns:a16="http://schemas.microsoft.com/office/drawing/2014/main" id="{A0422DDF-D895-4E26-B630-1A434A59A9A5}"/>
+                <a16:creationId xmlns:a16="http://schemas.microsoft.com/office/drawing/2014/main" id="{6170D545-2508-4343-8ACA-E2D772387C95}"/>
               </a:ext>
             </a:extLst>
           </p:cNvPr>
@@ -16182,34 +16212,7 @@
                 <a:ea typeface="Arial"/>
                 <a:cs typeface="Arial"/>
               </a:rPr>
-              <a:t>Used to normalize the other counts.</a:t>
-            </a:r>
-          </a:p>
-          <a:p xmlns:a="http://schemas.openxmlformats.org/drawingml/2006/main">
-            <a:pPr marL="279400" indent="-152400" algn="l">
-              <a:spcAft>
-                <a:spcPts val="1200"/>
-              </a:spcAft>
-              <a:buChar char="•"/>
-              <a:defRPr sz="2175" b="0">
-                <a:solidFill>
-                  <a:srgbClr val="16343E"/>
-                </a:solidFill>
-                <a:latin typeface="Arial"/>
-                <a:ea typeface="Arial"/>
-                <a:cs typeface="Arial"/>
-              </a:defRPr>
-            </a:pPr>
-            <a:r>
-              <a:rPr sz="2175" b="0">
-                <a:solidFill>
-                  <a:srgbClr val="16343E"/>
-                </a:solidFill>
-                <a:latin typeface="Arial"/>
-                <a:ea typeface="Arial"/>
-                <a:cs typeface="Arial"/>
-              </a:rPr>
-              <a:t>Excluded as separate model inputs.</a:t>
+              <a:t>Used to adjust for differences in how much RNA each specimen supplies.</a:t>
             </a:r>
           </a:p>
         </p:txBody>
@@ -16217,7 +16220,7 @@
     </p:spTree>
     <p:extLst>
       <p:ext uri="{BB962C8B-B14F-4D97-AF65-F5344CB8AC3E}">
-        <p14:creationId xmlns:p14="http://schemas.microsoft.com/office/powerpoint/2010/main" val="843577050"/>
+        <p14:creationId xmlns:p14="http://schemas.microsoft.com/office/powerpoint/2010/main" val="970247735"/>
       </p:ext>
     </p:extLst>
   </p:cSld>
@@ -16245,10 +16248,10 @@
       </p:grpSpPr>
       <p:sp>
         <p:nvSpPr>
-          <p:cNvPr id="6" name="">
+          <p:cNvPr id="5" name="">
             <a:extLst xmlns:a="http://schemas.openxmlformats.org/drawingml/2006/main">
               <a:ext uri="{FF2B5EF4-FFF2-40B4-BE49-F238E27FC236}">
-                <a16:creationId xmlns:a16="http://schemas.microsoft.com/office/drawing/2014/main" id="{2A6107D7-3E8E-421F-8341-44C1441E8680}"/>
+                <a16:creationId xmlns:a16="http://schemas.microsoft.com/office/drawing/2014/main" id="{7482C293-6724-4227-A01C-F36D0591C4D2}"/>
               </a:ext>
             </a:extLst>
           </p:cNvPr>
@@ -16305,7 +16308,7 @@
           <p:cNvPr id="2" name="">
             <a:extLst xmlns:a="http://schemas.openxmlformats.org/drawingml/2006/main">
               <a:ext uri="{FF2B5EF4-FFF2-40B4-BE49-F238E27FC236}">
-                <a16:creationId xmlns:a16="http://schemas.microsoft.com/office/drawing/2014/main" id="{5D63FB25-6CA0-4638-90E4-834A9D3E99CE}"/>
+                <a16:creationId xmlns:a16="http://schemas.microsoft.com/office/drawing/2014/main" id="{F032DA67-E3B9-4FFA-8254-27CD28363CC4}"/>
               </a:ext>
             </a:extLst>
           </p:cNvPr>
@@ -16362,7 +16365,7 @@
           <p:cNvPr id="3" name="">
             <a:extLst xmlns:a="http://schemas.openxmlformats.org/drawingml/2006/main">
               <a:ext uri="{FF2B5EF4-FFF2-40B4-BE49-F238E27FC236}">
-                <a16:creationId xmlns:a16="http://schemas.microsoft.com/office/drawing/2014/main" id="{8336F471-8AF2-43F8-86DE-75C27B975177}"/>
+                <a16:creationId xmlns:a16="http://schemas.microsoft.com/office/drawing/2014/main" id="{AE19C01C-B110-412E-BF1E-4F801731A45D}"/>
               </a:ext>
             </a:extLst>
           </p:cNvPr>
@@ -16416,7 +16419,7 @@
       </p:sp>
       <p:graphicFrame>
         <p:nvGraphicFramePr>
-          <p:cNvPr id="9" name=""/>
+          <p:cNvPr id="8" name=""/>
           <p:cNvGraphicFramePr/>
           <p:nvPr/>
         </p:nvGraphicFramePr>
@@ -16706,67 +16709,10 @@
           </a:graphicData>
         </a:graphic>
       </p:graphicFrame>
-      <p:sp>
-        <p:nvSpPr>
-          <p:cNvPr id="5" name="">
-            <a:extLst xmlns:a="http://schemas.openxmlformats.org/drawingml/2006/main">
-              <a:ext uri="{FF2B5EF4-FFF2-40B4-BE49-F238E27FC236}">
-                <a16:creationId xmlns:a16="http://schemas.microsoft.com/office/drawing/2014/main" id="{85A1B3A2-5E76-4AE7-8D95-8234D29A8ABE}"/>
-              </a:ext>
-            </a:extLst>
-          </p:cNvPr>
-          <p:cNvSpPr>
-            <a:spLocks xmlns:a="http://schemas.openxmlformats.org/drawingml/2006/main" noGrp="1"/>
-          </p:cNvSpPr>
-          <p:nvPr/>
-        </p:nvSpPr>
-        <p:spPr>
-          <a:xfrm xmlns:a="http://schemas.openxmlformats.org/drawingml/2006/main">
-            <a:off x="609600" y="5305425"/>
-            <a:ext cx="10972800" cy="847725"/>
-          </a:xfrm>
-          <a:prstGeom xmlns:a="http://schemas.openxmlformats.org/drawingml/2006/main" prst="rect">
-            <a:avLst/>
-          </a:prstGeom>
-          <a:noFill xmlns:a="http://schemas.openxmlformats.org/drawingml/2006/main"/>
-          <a:ln xmlns:a="http://schemas.openxmlformats.org/drawingml/2006/main" w="0">
-            <a:noFill/>
-          </a:ln>
-        </p:spPr>
-        <p:txBody>
-          <a:bodyPr xmlns:a="http://schemas.openxmlformats.org/drawingml/2006/main" anchor="ctr">
-            <a:noAutofit/>
-          </a:bodyPr>
-          <a:lstStyle xmlns:a="http://schemas.openxmlformats.org/drawingml/2006/main"/>
-          <a:p xmlns:a="http://schemas.openxmlformats.org/drawingml/2006/main">
-            <a:pPr algn="l">
-              <a:defRPr sz="2250" b="0">
-                <a:solidFill>
-                  <a:srgbClr val="007C78"/>
-                </a:solidFill>
-                <a:latin typeface="Arial"/>
-                <a:ea typeface="Arial"/>
-                <a:cs typeface="Arial"/>
-              </a:defRPr>
-            </a:pPr>
-            <a:r>
-              <a:rPr sz="2250" b="0">
-                <a:solidFill>
-                  <a:srgbClr val="007C78"/>
-                </a:solidFill>
-                <a:latin typeface="Arial"/>
-                <a:ea typeface="Arial"/>
-                <a:cs typeface="Arial"/>
-              </a:rPr>
-              <a:t>Housekeeping RNAs help account for differences in how much RNA a specimen supplies.</a:t>
-            </a:r>
-          </a:p>
-        </p:txBody>
-      </p:sp>
     </p:spTree>
     <p:extLst>
       <p:ext uri="{BB962C8B-B14F-4D97-AF65-F5344CB8AC3E}">
-        <p14:creationId xmlns:p14="http://schemas.microsoft.com/office/powerpoint/2010/main" val="1107055851"/>
+        <p14:creationId xmlns:p14="http://schemas.microsoft.com/office/powerpoint/2010/main" val="1728725474"/>
       </p:ext>
     </p:extLst>
   </p:cSld>
@@ -16797,7 +16743,7 @@
           <p:cNvPr id="12" name="">
             <a:extLst xmlns:a="http://schemas.openxmlformats.org/drawingml/2006/main">
               <a:ext uri="{FF2B5EF4-FFF2-40B4-BE49-F238E27FC236}">
-                <a16:creationId xmlns:a16="http://schemas.microsoft.com/office/drawing/2014/main" id="{3B969A39-076D-488D-B118-7C3A5E8D4EC7}"/>
+                <a16:creationId xmlns:a16="http://schemas.microsoft.com/office/drawing/2014/main" id="{94D4CBF4-831D-43CB-93D5-E9EF4EC494C8}"/>
               </a:ext>
             </a:extLst>
           </p:cNvPr>
@@ -16854,7 +16800,7 @@
           <p:cNvPr id="2" name="">
             <a:extLst xmlns:a="http://schemas.openxmlformats.org/drawingml/2006/main">
               <a:ext uri="{FF2B5EF4-FFF2-40B4-BE49-F238E27FC236}">
-                <a16:creationId xmlns:a16="http://schemas.microsoft.com/office/drawing/2014/main" id="{2CCA8B5D-0363-4CC7-9B82-482D7AFA0987}"/>
+                <a16:creationId xmlns:a16="http://schemas.microsoft.com/office/drawing/2014/main" id="{2371D178-423C-4789-96AB-CFEF0CD862E7}"/>
               </a:ext>
             </a:extLst>
           </p:cNvPr>
@@ -16911,7 +16857,7 @@
           <p:cNvPr id="3" name="">
             <a:extLst xmlns:a="http://schemas.openxmlformats.org/drawingml/2006/main">
               <a:ext uri="{FF2B5EF4-FFF2-40B4-BE49-F238E27FC236}">
-                <a16:creationId xmlns:a16="http://schemas.microsoft.com/office/drawing/2014/main" id="{64812C08-A442-429A-9549-1F260A3BEB4C}"/>
+                <a16:creationId xmlns:a16="http://schemas.microsoft.com/office/drawing/2014/main" id="{95427286-838E-4AAC-A869-AE1A99368BEB}"/>
               </a:ext>
             </a:extLst>
           </p:cNvPr>
@@ -16968,7 +16914,7 @@
           <p:cNvPr id="4" name="">
             <a:extLst xmlns:a="http://schemas.openxmlformats.org/drawingml/2006/main">
               <a:ext uri="{FF2B5EF4-FFF2-40B4-BE49-F238E27FC236}">
-                <a16:creationId xmlns:a16="http://schemas.microsoft.com/office/drawing/2014/main" id="{D3E59FF1-3C1B-4768-88F3-DE9CD3A40B01}"/>
+                <a16:creationId xmlns:a16="http://schemas.microsoft.com/office/drawing/2014/main" id="{171BD683-7896-40EE-B7BC-8D4E2C88C363}"/>
               </a:ext>
             </a:extLst>
           </p:cNvPr>
@@ -17019,7 +16965,7 @@
                 <a:ea typeface="Arial"/>
                 <a:cs typeface="Arial"/>
               </a:rPr>
-              <a:t>We use the authors’ two study groups: discovery and validation cohorts.</a:t>
+              <a:t>I use the authors’ two study groups: discovery and validation cohorts.</a:t>
             </a:r>
           </a:p>
           <a:p xmlns:a="http://schemas.openxmlformats.org/drawingml/2006/main">
@@ -17046,7 +16992,7 @@
                 <a:ea typeface="Arial"/>
                 <a:cs typeface="Arial"/>
               </a:rPr>
-              <a:t>Our training / screening split keeps diagnosis proportions similar.</a:t>
+              <a:t>My training / screening split keeps diagnosis proportions similar.</a:t>
             </a:r>
           </a:p>
         </p:txBody>
@@ -17056,7 +17002,7 @@
           <p:cNvPr id="5" name="">
             <a:extLst xmlns:a="http://schemas.openxmlformats.org/drawingml/2006/main">
               <a:ext uri="{FF2B5EF4-FFF2-40B4-BE49-F238E27FC236}">
-                <a16:creationId xmlns:a16="http://schemas.microsoft.com/office/drawing/2014/main" id="{B59DF90C-EA5A-4BFE-A620-A240E2A73A79}"/>
+                <a16:creationId xmlns:a16="http://schemas.microsoft.com/office/drawing/2014/main" id="{882A0D62-1850-4028-BD5A-4DD7A40667EB}"/>
               </a:ext>
             </a:extLst>
           </p:cNvPr>
@@ -17140,7 +17086,7 @@
           <p:cNvPr id="6" name="">
             <a:extLst xmlns:a="http://schemas.openxmlformats.org/drawingml/2006/main">
               <a:ext uri="{FF2B5EF4-FFF2-40B4-BE49-F238E27FC236}">
-                <a16:creationId xmlns:a16="http://schemas.microsoft.com/office/drawing/2014/main" id="{979946F0-CCB5-4AE0-85E7-0197B38154B4}"/>
+                <a16:creationId xmlns:a16="http://schemas.microsoft.com/office/drawing/2014/main" id="{115DEF77-144C-476B-AA4B-415592A61FC9}"/>
               </a:ext>
             </a:extLst>
           </p:cNvPr>
@@ -17224,7 +17170,7 @@
           <p:cNvPr id="7" name="">
             <a:extLst xmlns:a="http://schemas.openxmlformats.org/drawingml/2006/main">
               <a:ext uri="{FF2B5EF4-FFF2-40B4-BE49-F238E27FC236}">
-                <a16:creationId xmlns:a16="http://schemas.microsoft.com/office/drawing/2014/main" id="{469E9210-BBAC-4300-B717-8A75592659BD}"/>
+                <a16:creationId xmlns:a16="http://schemas.microsoft.com/office/drawing/2014/main" id="{F298BDEC-EAD2-4E50-ABC3-90086D5A9C5B}"/>
               </a:ext>
             </a:extLst>
           </p:cNvPr>
@@ -17364,7 +17310,7 @@
           <p:cNvPr id="10" name="">
             <a:extLst xmlns:a="http://schemas.openxmlformats.org/drawingml/2006/main">
               <a:ext uri="{FF2B5EF4-FFF2-40B4-BE49-F238E27FC236}">
-                <a16:creationId xmlns:a16="http://schemas.microsoft.com/office/drawing/2014/main" id="{EEB3839F-B30D-4B31-95B7-8647F34BD2C3}"/>
+                <a16:creationId xmlns:a16="http://schemas.microsoft.com/office/drawing/2014/main" id="{98619F37-A93D-4676-80D3-F5CE8C520346}"/>
               </a:ext>
             </a:extLst>
           </p:cNvPr>
@@ -17499,7 +17445,7 @@
           <p:cNvPr id="11" name="">
             <a:extLst xmlns:a="http://schemas.openxmlformats.org/drawingml/2006/main">
               <a:ext uri="{FF2B5EF4-FFF2-40B4-BE49-F238E27FC236}">
-                <a16:creationId xmlns:a16="http://schemas.microsoft.com/office/drawing/2014/main" id="{2B73C6C2-59F3-4156-B228-02A6B6A93D84}"/>
+                <a16:creationId xmlns:a16="http://schemas.microsoft.com/office/drawing/2014/main" id="{D0137FC3-7A2F-4997-AC1A-7CAD01E73411}"/>
               </a:ext>
             </a:extLst>
           </p:cNvPr>
@@ -17554,7 +17500,7 @@
     </p:spTree>
     <p:extLst>
       <p:ext uri="{BB962C8B-B14F-4D97-AF65-F5344CB8AC3E}">
-        <p14:creationId xmlns:p14="http://schemas.microsoft.com/office/powerpoint/2010/main" val="759988669"/>
+        <p14:creationId xmlns:p14="http://schemas.microsoft.com/office/powerpoint/2010/main" val="793949922"/>
       </p:ext>
     </p:extLst>
   </p:cSld>

</xml_diff>

<commit_message>
Refine presentation layouts, clinical context, and project conclusions
</commit_message>
<xml_diff>
--- a/presentation/unos_kidney_biopsy.pptx
+++ b/presentation/unos_kidney_biopsy.pptx
@@ -2,36 +2,36 @@
 <file path=ppt/presentation.xml><?xml version="1.0" encoding="utf-8"?>
 <p:presentation xmlns:p="http://schemas.openxmlformats.org/presentationml/2006/main" xmlns:r="http://schemas.openxmlformats.org/officeDocument/2006/relationships">
   <p:sldMasterIdLst>
-    <p:sldMasterId id="2147483648" r:id="R795e38e1b45941d0"/>
+    <p:sldMasterId id="2147483648" r:id="R7c225ff666a24f86"/>
   </p:sldMasterIdLst>
   <p:sldIdLst>
-    <p:sldId id="256" r:id="Ra2e5987f5cd9402e"/>
-    <p:sldId id="257" r:id="R88b6c35a67094843"/>
-    <p:sldId id="258" r:id="Rb9e02b2a47b14552"/>
-    <p:sldId id="259" r:id="Raea07e2bc2fd400b"/>
-    <p:sldId id="260" r:id="R4a883e58a0de4092"/>
-    <p:sldId id="261" r:id="R9ee8407c6daa432c"/>
-    <p:sldId id="262" r:id="R487697ab6da547aa"/>
-    <p:sldId id="263" r:id="R625dc816186a4cae"/>
-    <p:sldId id="264" r:id="R163ab851ca464962"/>
-    <p:sldId id="265" r:id="R339b914838de4544"/>
-    <p:sldId id="266" r:id="R387b2356c53e44d5"/>
-    <p:sldId id="267" r:id="R0264449f1a3f47a4"/>
-    <p:sldId id="268" r:id="R81ede3964fca4630"/>
-    <p:sldId id="269" r:id="Rb5b1f94fd2cb453c"/>
-    <p:sldId id="270" r:id="Rb143e5b251fe4859"/>
-    <p:sldId id="271" r:id="R3cf35e120d1e45f1"/>
-    <p:sldId id="272" r:id="R1b7f5e37f6da46eb"/>
-    <p:sldId id="273" r:id="R5151ade6c1f84748"/>
-    <p:sldId id="274" r:id="R09e2f201fc3a4595"/>
-    <p:sldId id="275" r:id="R04b1157f1c8e45de"/>
-    <p:sldId id="276" r:id="Rd4bc542a68d34b1c"/>
-    <p:sldId id="277" r:id="R8d933dfdd60a4a5c"/>
-    <p:sldId id="278" r:id="R3c91bf60e299437a"/>
-    <p:sldId id="279" r:id="R80db1586d1c0439e"/>
-    <p:sldId id="280" r:id="R398152affa034801"/>
-    <p:sldId id="281" r:id="R42b2a288cc9f436b"/>
-    <p:sldId id="282" r:id="R68442a5439ed4b4e"/>
+    <p:sldId id="256" r:id="R0989a0ca1da64de5"/>
+    <p:sldId id="257" r:id="R5310eeb9830a4618"/>
+    <p:sldId id="258" r:id="Rff08bf3527e441e2"/>
+    <p:sldId id="259" r:id="Rff46253dc12a4256"/>
+    <p:sldId id="260" r:id="Rff63545d8a3545a1"/>
+    <p:sldId id="261" r:id="R09874e4dc9c0486d"/>
+    <p:sldId id="262" r:id="R7c0af833523946e2"/>
+    <p:sldId id="263" r:id="Rc22108eb85894f7b"/>
+    <p:sldId id="264" r:id="R86df1212b1004d79"/>
+    <p:sldId id="265" r:id="Ra7e30180903d4804"/>
+    <p:sldId id="266" r:id="R24adefa6f3434584"/>
+    <p:sldId id="267" r:id="R805c1cd95d204e1a"/>
+    <p:sldId id="268" r:id="Rf890ee60763a4caa"/>
+    <p:sldId id="269" r:id="Rfe95aab059dc4f79"/>
+    <p:sldId id="270" r:id="R2dd9f77b8c31432b"/>
+    <p:sldId id="271" r:id="Rca20f738740c4f48"/>
+    <p:sldId id="272" r:id="R725bc4d31d4d4b6c"/>
+    <p:sldId id="273" r:id="R85291651d66f42a4"/>
+    <p:sldId id="274" r:id="R0daa642d6b2d438b"/>
+    <p:sldId id="275" r:id="Rb274479f1f4e4814"/>
+    <p:sldId id="276" r:id="Rfec517323f8548ef"/>
+    <p:sldId id="277" r:id="R6308870db90d4f3b"/>
+    <p:sldId id="278" r:id="R2d454f2c40cd4238"/>
+    <p:sldId id="279" r:id="R0ca4c9fa79d34962"/>
+    <p:sldId id="280" r:id="R07998d4533c64386"/>
+    <p:sldId id="281" r:id="R09ba7aa6ebce4e57"/>
+    <p:sldId id="282" r:id="Rce23fe55c35643ba"/>
   </p:sldIdLst>
   <p:sldSz cx="12192000" cy="6858000"/>
   <p:notesSz cx="6858000" cy="9144000"/>
@@ -76,7 +76,7 @@
   </p:cSld>
   <p:clrMap bg1="lt1" tx1="dk1" bg2="lt2" tx2="dk2" accent1="accent1" accent2="accent2" accent3="accent3" accent4="accent4" accent5="accent5" accent6="accent6" hlink="hlink" folHlink="folHlink"/>
   <p:sldLayoutIdLst>
-    <p:sldLayoutId xmlns:r="http://schemas.openxmlformats.org/officeDocument/2006/relationships" id="2147483649" r:id="Rf78abd7c10c74a21"/>
+    <p:sldLayoutId xmlns:r="http://schemas.openxmlformats.org/officeDocument/2006/relationships" id="2147483649" r:id="Rf1f3bbf19cf54110"/>
   </p:sldLayoutIdLst>
   <p:txStyles>
     <p:titleStyle>
@@ -1245,7 +1245,7 @@
           <p:cNvPr id="2" name="">
             <a:extLst xmlns:a="http://schemas.openxmlformats.org/drawingml/2006/main">
               <a:ext uri="{FF2B5EF4-FFF2-40B4-BE49-F238E27FC236}">
-                <a16:creationId xmlns:a16="http://schemas.microsoft.com/office/drawing/2014/main" id="{64D65980-7A9D-421C-B0C9-11C08E5E01FE}"/>
+                <a16:creationId xmlns:a16="http://schemas.microsoft.com/office/drawing/2014/main" id="{7F41B514-C8F6-4330-9000-B3C49A6D3374}"/>
               </a:ext>
             </a:extLst>
           </p:cNvPr>
@@ -1346,7 +1346,7 @@
     </p:spTree>
     <p:extLst>
       <p:ext uri="{BB962C8B-B14F-4D97-AF65-F5344CB8AC3E}">
-        <p14:creationId xmlns:p14="http://schemas.microsoft.com/office/powerpoint/2010/main" val="109289756"/>
+        <p14:creationId xmlns:p14="http://schemas.microsoft.com/office/powerpoint/2010/main" val="1294290763"/>
       </p:ext>
     </p:extLst>
   </p:cSld>
@@ -1377,7 +1377,7 @@
           <p:cNvPr id="6" name="">
             <a:extLst xmlns:a="http://schemas.openxmlformats.org/drawingml/2006/main">
               <a:ext uri="{FF2B5EF4-FFF2-40B4-BE49-F238E27FC236}">
-                <a16:creationId xmlns:a16="http://schemas.microsoft.com/office/drawing/2014/main" id="{F57956E2-EFA5-4C0A-A91C-1A92A7D9EB3D}"/>
+                <a16:creationId xmlns:a16="http://schemas.microsoft.com/office/drawing/2014/main" id="{F9A6A437-00AF-4208-9CDA-64688BBE9AB6}"/>
               </a:ext>
             </a:extLst>
           </p:cNvPr>
@@ -1434,7 +1434,7 @@
           <p:cNvPr id="2" name="">
             <a:extLst xmlns:a="http://schemas.openxmlformats.org/drawingml/2006/main">
               <a:ext uri="{FF2B5EF4-FFF2-40B4-BE49-F238E27FC236}">
-                <a16:creationId xmlns:a16="http://schemas.microsoft.com/office/drawing/2014/main" id="{6EF5938C-3D3B-4319-8680-8B34B396D1E0}"/>
+                <a16:creationId xmlns:a16="http://schemas.microsoft.com/office/drawing/2014/main" id="{08AB12C9-386B-42E9-A42F-BF91B19C1C80}"/>
               </a:ext>
             </a:extLst>
           </p:cNvPr>
@@ -1491,7 +1491,7 @@
           <p:cNvPr id="3" name="">
             <a:extLst xmlns:a="http://schemas.openxmlformats.org/drawingml/2006/main">
               <a:ext uri="{FF2B5EF4-FFF2-40B4-BE49-F238E27FC236}">
-                <a16:creationId xmlns:a16="http://schemas.microsoft.com/office/drawing/2014/main" id="{766B4837-61E8-4605-AE74-3CDDD94E8AEF}"/>
+                <a16:creationId xmlns:a16="http://schemas.microsoft.com/office/drawing/2014/main" id="{9770D246-2A6F-4E14-99DC-DEA5E5C619E5}"/>
               </a:ext>
             </a:extLst>
           </p:cNvPr>
@@ -1548,7 +1548,7 @@
           <p:cNvPr id="4" name="">
             <a:extLst xmlns:a="http://schemas.openxmlformats.org/drawingml/2006/main">
               <a:ext uri="{FF2B5EF4-FFF2-40B4-BE49-F238E27FC236}">
-                <a16:creationId xmlns:a16="http://schemas.microsoft.com/office/drawing/2014/main" id="{66EA16B6-D15B-4C00-9021-41753FF2085C}"/>
+                <a16:creationId xmlns:a16="http://schemas.microsoft.com/office/drawing/2014/main" id="{C2636D61-B86C-46BA-B393-D5EEEFAD880E}"/>
               </a:ext>
             </a:extLst>
           </p:cNvPr>
@@ -1921,7 +1921,7 @@
     </p:spTree>
     <p:extLst>
       <p:ext uri="{BB962C8B-B14F-4D97-AF65-F5344CB8AC3E}">
-        <p14:creationId xmlns:p14="http://schemas.microsoft.com/office/powerpoint/2010/main" val="618380760"/>
+        <p14:creationId xmlns:p14="http://schemas.microsoft.com/office/powerpoint/2010/main" val="1966982383"/>
       </p:ext>
     </p:extLst>
   </p:cSld>
@@ -1949,10 +1949,10 @@
       </p:grpSpPr>
       <p:sp>
         <p:nvSpPr>
-          <p:cNvPr id="13" name="">
+          <p:cNvPr id="17" name="">
             <a:extLst xmlns:a="http://schemas.openxmlformats.org/drawingml/2006/main">
               <a:ext uri="{FF2B5EF4-FFF2-40B4-BE49-F238E27FC236}">
-                <a16:creationId xmlns:a16="http://schemas.microsoft.com/office/drawing/2014/main" id="{0A1A2DC9-C058-4E1D-BCE8-FB6395FA62DC}"/>
+                <a16:creationId xmlns:a16="http://schemas.microsoft.com/office/drawing/2014/main" id="{82E554F0-969A-4672-ACC7-ED7AF9A8060D}"/>
               </a:ext>
             </a:extLst>
           </p:cNvPr>
@@ -2009,7 +2009,7 @@
           <p:cNvPr id="2" name="">
             <a:extLst xmlns:a="http://schemas.openxmlformats.org/drawingml/2006/main">
               <a:ext uri="{FF2B5EF4-FFF2-40B4-BE49-F238E27FC236}">
-                <a16:creationId xmlns:a16="http://schemas.microsoft.com/office/drawing/2014/main" id="{38C4CC90-CA74-4B9A-9EAF-4116E561F242}"/>
+                <a16:creationId xmlns:a16="http://schemas.microsoft.com/office/drawing/2014/main" id="{FC1A396B-0A57-46AC-80EF-D8B1F6C9464D}"/>
               </a:ext>
             </a:extLst>
           </p:cNvPr>
@@ -2066,7 +2066,7 @@
           <p:cNvPr id="3" name="">
             <a:extLst xmlns:a="http://schemas.openxmlformats.org/drawingml/2006/main">
               <a:ext uri="{FF2B5EF4-FFF2-40B4-BE49-F238E27FC236}">
-                <a16:creationId xmlns:a16="http://schemas.microsoft.com/office/drawing/2014/main" id="{677D08DA-F28D-460F-9E91-39617B951FA3}"/>
+                <a16:creationId xmlns:a16="http://schemas.microsoft.com/office/drawing/2014/main" id="{8FC80041-1AB7-4DC5-BA56-9302DCE52454}"/>
               </a:ext>
             </a:extLst>
           </p:cNvPr>
@@ -2123,7 +2123,7 @@
           <p:cNvPr id="4" name="">
             <a:extLst xmlns:a="http://schemas.openxmlformats.org/drawingml/2006/main">
               <a:ext uri="{FF2B5EF4-FFF2-40B4-BE49-F238E27FC236}">
-                <a16:creationId xmlns:a16="http://schemas.microsoft.com/office/drawing/2014/main" id="{E974C0FA-2590-41EF-B83F-2A7C06C1145F}"/>
+                <a16:creationId xmlns:a16="http://schemas.microsoft.com/office/drawing/2014/main" id="{695FD238-7FC0-48DF-A2F9-3F50CC0370CD}"/>
               </a:ext>
             </a:extLst>
           </p:cNvPr>
@@ -2180,7 +2180,7 @@
           <p:cNvPr id="5" name="">
             <a:extLst xmlns:a="http://schemas.openxmlformats.org/drawingml/2006/main">
               <a:ext uri="{FF2B5EF4-FFF2-40B4-BE49-F238E27FC236}">
-                <a16:creationId xmlns:a16="http://schemas.microsoft.com/office/drawing/2014/main" id="{C4EB4253-E172-4AF9-A6BC-0DB23D068B99}"/>
+                <a16:creationId xmlns:a16="http://schemas.microsoft.com/office/drawing/2014/main" id="{628F2EC7-A2E5-4E8A-AE19-D372254C6C67}"/>
               </a:ext>
             </a:extLst>
           </p:cNvPr>
@@ -2191,8 +2191,8 @@
         </p:nvSpPr>
         <p:spPr>
           <a:xfrm xmlns:a="http://schemas.openxmlformats.org/drawingml/2006/main">
-            <a:off x="609600" y="2133600"/>
-            <a:ext cx="5181600" cy="771525"/>
+            <a:off x="609600" y="2124075"/>
+            <a:ext cx="5181600" cy="447675"/>
           </a:xfrm>
           <a:prstGeom xmlns:a="http://schemas.openxmlformats.org/drawingml/2006/main" prst="rect">
             <a:avLst/>
@@ -2208,49 +2208,26 @@
           </a:bodyPr>
           <a:lstStyle xmlns:a="http://schemas.openxmlformats.org/drawingml/2006/main"/>
           <a:p xmlns:a="http://schemas.openxmlformats.org/drawingml/2006/main">
-            <a:pPr algn="l">
-              <a:defRPr sz="2250" b="0">
-                <a:solidFill>
-                  <a:srgbClr val="16343E"/>
-                </a:solidFill>
-                <a:latin typeface="Arial"/>
-                <a:ea typeface="Arial"/>
-                <a:cs typeface="Arial"/>
-              </a:defRPr>
-            </a:pPr>
-            <a:r>
-              <a:rPr sz="2250" b="0">
-                <a:solidFill>
-                  <a:srgbClr val="16343E"/>
-                </a:solidFill>
-                <a:latin typeface="Arial"/>
-                <a:ea typeface="Arial"/>
-                <a:cs typeface="Arial"/>
-              </a:rPr>
-              <a:t>Proportion of recorded rejection</a:t>
-            </a:r>
-          </a:p>
-          <a:p xmlns:a="http://schemas.openxmlformats.org/drawingml/2006/main">
-            <a:pPr algn="l">
-              <a:defRPr sz="2250" b="0">
-                <a:solidFill>
-                  <a:srgbClr val="16343E"/>
-                </a:solidFill>
-                <a:latin typeface="Arial"/>
-                <a:ea typeface="Arial"/>
-                <a:cs typeface="Arial"/>
-              </a:defRPr>
-            </a:pPr>
-            <a:r>
-              <a:rPr sz="2250" b="0">
-                <a:solidFill>
-                  <a:srgbClr val="16343E"/>
-                </a:solidFill>
-                <a:latin typeface="Arial"/>
-                <a:ea typeface="Arial"/>
-                <a:cs typeface="Arial"/>
-              </a:rPr>
-              <a:t>cases detected</a:t>
+            <a:pPr algn="ctr">
+              <a:defRPr sz="2100" b="0">
+                <a:solidFill>
+                  <a:srgbClr val="16343E"/>
+                </a:solidFill>
+                <a:latin typeface="Arial"/>
+                <a:ea typeface="Arial"/>
+                <a:cs typeface="Arial"/>
+              </a:defRPr>
+            </a:pPr>
+            <a:r>
+              <a:rPr sz="2100" b="0">
+                <a:solidFill>
+                  <a:srgbClr val="16343E"/>
+                </a:solidFill>
+                <a:latin typeface="Arial"/>
+                <a:ea typeface="Arial"/>
+                <a:cs typeface="Arial"/>
+              </a:rPr>
+              <a:t>Recorded rejection cases detected</a:t>
             </a:r>
           </a:p>
         </p:txBody>
@@ -2260,7 +2237,7 @@
           <p:cNvPr id="6" name="">
             <a:extLst xmlns:a="http://schemas.openxmlformats.org/drawingml/2006/main">
               <a:ext uri="{FF2B5EF4-FFF2-40B4-BE49-F238E27FC236}">
-                <a16:creationId xmlns:a16="http://schemas.microsoft.com/office/drawing/2014/main" id="{E5784D09-1BD4-42ED-9525-9B8CA0D1A7BC}"/>
+                <a16:creationId xmlns:a16="http://schemas.microsoft.com/office/drawing/2014/main" id="{F938E53E-F76B-48F2-87D2-62F76F0F149F}"/>
               </a:ext>
             </a:extLst>
           </p:cNvPr>
@@ -2271,53 +2248,25 @@
         </p:nvSpPr>
         <p:spPr>
           <a:xfrm xmlns:a="http://schemas.openxmlformats.org/drawingml/2006/main">
-            <a:off x="609600" y="3076575"/>
-            <a:ext cx="5181600" cy="638175"/>
-          </a:xfrm>
-          <a:prstGeom xmlns:a="http://schemas.openxmlformats.org/drawingml/2006/main" prst="rect">
-            <a:avLst/>
-          </a:prstGeom>
-          <a:noFill xmlns:a="http://schemas.openxmlformats.org/drawingml/2006/main"/>
-          <a:ln xmlns:a="http://schemas.openxmlformats.org/drawingml/2006/main" w="0">
-            <a:noFill/>
-          </a:ln>
-        </p:spPr>
-        <p:txBody>
-          <a:bodyPr xmlns:a="http://schemas.openxmlformats.org/drawingml/2006/main" anchor="ctr">
-            <a:noAutofit/>
-          </a:bodyPr>
-          <a:lstStyle xmlns:a="http://schemas.openxmlformats.org/drawingml/2006/main"/>
-          <a:p xmlns:a="http://schemas.openxmlformats.org/drawingml/2006/main">
-            <a:pPr algn="l">
-              <a:defRPr sz="2100" b="0">
-                <a:solidFill>
-                  <a:srgbClr val="B55730"/>
-                </a:solidFill>
-                <a:latin typeface="Arial"/>
-                <a:ea typeface="Arial"/>
-                <a:cs typeface="Arial"/>
-              </a:defRPr>
-            </a:pPr>
-            <a:r>
-              <a:rPr sz="2100" b="0">
-                <a:solidFill>
-                  <a:srgbClr val="B55730"/>
-                </a:solidFill>
-                <a:latin typeface="Arial"/>
-                <a:ea typeface="Arial"/>
-                <a:cs typeface="Arial"/>
-              </a:rPr>
-              <a:t>(False negatives are missed cases.)</a:t>
-            </a:r>
-          </a:p>
-        </p:txBody>
+            <a:off x="723900" y="2647950"/>
+            <a:ext cx="4953000" cy="0"/>
+          </a:xfrm>
+          <a:prstGeom xmlns:a="http://schemas.openxmlformats.org/drawingml/2006/main" prst="line">
+            <a:avLst/>
+          </a:prstGeom>
+          <a:ln xmlns:a="http://schemas.openxmlformats.org/drawingml/2006/main" w="11430">
+            <a:solidFill>
+              <a:srgbClr val="16343E"/>
+            </a:solidFill>
+          </a:ln>
+        </p:spPr>
       </p:sp>
       <p:sp>
         <p:nvSpPr>
           <p:cNvPr id="7" name="">
             <a:extLst xmlns:a="http://schemas.openxmlformats.org/drawingml/2006/main">
               <a:ext uri="{FF2B5EF4-FFF2-40B4-BE49-F238E27FC236}">
-                <a16:creationId xmlns:a16="http://schemas.microsoft.com/office/drawing/2014/main" id="{A818FB0C-1187-4B4A-80D6-2B53DD3E136F}"/>
+                <a16:creationId xmlns:a16="http://schemas.microsoft.com/office/drawing/2014/main" id="{452B7F36-C4DE-430D-B848-A89FE8963EE8}"/>
               </a:ext>
             </a:extLst>
           </p:cNvPr>
@@ -2328,8 +2277,8 @@
         </p:nvSpPr>
         <p:spPr>
           <a:xfrm xmlns:a="http://schemas.openxmlformats.org/drawingml/2006/main">
-            <a:off x="6705600" y="1590675"/>
-            <a:ext cx="4876800" cy="428625"/>
+            <a:off x="609600" y="2705100"/>
+            <a:ext cx="5181600" cy="447675"/>
           </a:xfrm>
           <a:prstGeom xmlns:a="http://schemas.openxmlformats.org/drawingml/2006/main" prst="rect">
             <a:avLst/>
@@ -2345,26 +2294,26 @@
           </a:bodyPr>
           <a:lstStyle xmlns:a="http://schemas.openxmlformats.org/drawingml/2006/main"/>
           <a:p xmlns:a="http://schemas.openxmlformats.org/drawingml/2006/main">
-            <a:pPr algn="l">
-              <a:defRPr sz="2625" b="1">
-                <a:solidFill>
-                  <a:srgbClr val="007C78"/>
-                </a:solidFill>
-                <a:latin typeface="Arial"/>
-                <a:ea typeface="Arial"/>
-                <a:cs typeface="Arial"/>
-              </a:defRPr>
-            </a:pPr>
-            <a:r>
-              <a:rPr sz="2625" b="1">
-                <a:solidFill>
-                  <a:srgbClr val="007C78"/>
-                </a:solidFill>
-                <a:latin typeface="Arial"/>
-                <a:ea typeface="Arial"/>
-                <a:cs typeface="Arial"/>
-              </a:rPr>
-              <a:t>Precision</a:t>
+            <a:pPr algn="ctr">
+              <a:defRPr sz="2100" b="0">
+                <a:solidFill>
+                  <a:srgbClr val="16343E"/>
+                </a:solidFill>
+                <a:latin typeface="Arial"/>
+                <a:ea typeface="Arial"/>
+                <a:cs typeface="Arial"/>
+              </a:defRPr>
+            </a:pPr>
+            <a:r>
+              <a:rPr sz="2100" b="0">
+                <a:solidFill>
+                  <a:srgbClr val="16343E"/>
+                </a:solidFill>
+                <a:latin typeface="Arial"/>
+                <a:ea typeface="Arial"/>
+                <a:cs typeface="Arial"/>
+              </a:rPr>
+              <a:t>All recorded rejection cases</a:t>
             </a:r>
           </a:p>
         </p:txBody>
@@ -2374,7 +2323,7 @@
           <p:cNvPr id="8" name="">
             <a:extLst xmlns:a="http://schemas.openxmlformats.org/drawingml/2006/main">
               <a:ext uri="{FF2B5EF4-FFF2-40B4-BE49-F238E27FC236}">
-                <a16:creationId xmlns:a16="http://schemas.microsoft.com/office/drawing/2014/main" id="{A61EFD17-43D2-4CA2-99C8-4E0C8E9546EB}"/>
+                <a16:creationId xmlns:a16="http://schemas.microsoft.com/office/drawing/2014/main" id="{01DAE889-778F-42B9-8F35-B874D529D816}"/>
               </a:ext>
             </a:extLst>
           </p:cNvPr>
@@ -2385,8 +2334,8 @@
         </p:nvSpPr>
         <p:spPr>
           <a:xfrm xmlns:a="http://schemas.openxmlformats.org/drawingml/2006/main">
-            <a:off x="6705600" y="2133600"/>
-            <a:ext cx="4876800" cy="771525"/>
+            <a:off x="609600" y="3257550"/>
+            <a:ext cx="5181600" cy="523875"/>
           </a:xfrm>
           <a:prstGeom xmlns:a="http://schemas.openxmlformats.org/drawingml/2006/main" prst="rect">
             <a:avLst/>
@@ -2403,48 +2352,25 @@
           <a:lstStyle xmlns:a="http://schemas.openxmlformats.org/drawingml/2006/main"/>
           <a:p xmlns:a="http://schemas.openxmlformats.org/drawingml/2006/main">
             <a:pPr algn="l">
-              <a:defRPr sz="2250" b="0">
-                <a:solidFill>
-                  <a:srgbClr val="16343E"/>
-                </a:solidFill>
-                <a:latin typeface="Arial"/>
-                <a:ea typeface="Arial"/>
-                <a:cs typeface="Arial"/>
-              </a:defRPr>
-            </a:pPr>
-            <a:r>
-              <a:rPr sz="2250" b="0">
-                <a:solidFill>
-                  <a:srgbClr val="16343E"/>
-                </a:solidFill>
-                <a:latin typeface="Arial"/>
-                <a:ea typeface="Arial"/>
-                <a:cs typeface="Arial"/>
-              </a:rPr>
-              <a:t>Proportion of positive flags</a:t>
-            </a:r>
-          </a:p>
-          <a:p xmlns:a="http://schemas.openxmlformats.org/drawingml/2006/main">
-            <a:pPr algn="l">
-              <a:defRPr sz="2250" b="0">
-                <a:solidFill>
-                  <a:srgbClr val="16343E"/>
-                </a:solidFill>
-                <a:latin typeface="Arial"/>
-                <a:ea typeface="Arial"/>
-                <a:cs typeface="Arial"/>
-              </a:defRPr>
-            </a:pPr>
-            <a:r>
-              <a:rPr sz="2250" b="0">
-                <a:solidFill>
-                  <a:srgbClr val="16343E"/>
-                </a:solidFill>
-                <a:latin typeface="Arial"/>
-                <a:ea typeface="Arial"/>
-                <a:cs typeface="Arial"/>
-              </a:rPr>
-              <a:t>with recorded rejection</a:t>
+              <a:defRPr sz="2100" b="0">
+                <a:solidFill>
+                  <a:srgbClr val="B55730"/>
+                </a:solidFill>
+                <a:latin typeface="Arial"/>
+                <a:ea typeface="Arial"/>
+                <a:cs typeface="Arial"/>
+              </a:defRPr>
+            </a:pPr>
+            <a:r>
+              <a:rPr sz="2100" b="0">
+                <a:solidFill>
+                  <a:srgbClr val="B55730"/>
+                </a:solidFill>
+                <a:latin typeface="Arial"/>
+                <a:ea typeface="Arial"/>
+                <a:cs typeface="Arial"/>
+              </a:rPr>
+              <a:t>(False negatives are missed cases.)</a:t>
             </a:r>
           </a:p>
         </p:txBody>
@@ -2454,7 +2380,7 @@
           <p:cNvPr id="9" name="">
             <a:extLst xmlns:a="http://schemas.openxmlformats.org/drawingml/2006/main">
               <a:ext uri="{FF2B5EF4-FFF2-40B4-BE49-F238E27FC236}">
-                <a16:creationId xmlns:a16="http://schemas.microsoft.com/office/drawing/2014/main" id="{8037A119-058D-415B-A99E-21385755E95F}"/>
+                <a16:creationId xmlns:a16="http://schemas.microsoft.com/office/drawing/2014/main" id="{CC14D9E0-A1AF-49C4-B32B-8484275CE655}"/>
               </a:ext>
             </a:extLst>
           </p:cNvPr>
@@ -2465,8 +2391,8 @@
         </p:nvSpPr>
         <p:spPr>
           <a:xfrm xmlns:a="http://schemas.openxmlformats.org/drawingml/2006/main">
-            <a:off x="6705600" y="3076575"/>
-            <a:ext cx="4876800" cy="638175"/>
+            <a:off x="6705600" y="1590675"/>
+            <a:ext cx="4876800" cy="428625"/>
           </a:xfrm>
           <a:prstGeom xmlns:a="http://schemas.openxmlformats.org/drawingml/2006/main" prst="rect">
             <a:avLst/>
@@ -2483,7 +2409,7 @@
           <a:lstStyle xmlns:a="http://schemas.openxmlformats.org/drawingml/2006/main"/>
           <a:p xmlns:a="http://schemas.openxmlformats.org/drawingml/2006/main">
             <a:pPr algn="l">
-              <a:defRPr sz="2100" b="0">
+              <a:defRPr sz="2625" b="1">
                 <a:solidFill>
                   <a:srgbClr val="007C78"/>
                 </a:solidFill>
@@ -2493,7 +2419,7 @@
               </a:defRPr>
             </a:pPr>
             <a:r>
-              <a:rPr sz="2100" b="0">
+              <a:rPr sz="2625" b="1">
                 <a:solidFill>
                   <a:srgbClr val="007C78"/>
                 </a:solidFill>
@@ -2501,7 +2427,7 @@
                 <a:ea typeface="Arial"/>
                 <a:cs typeface="Arial"/>
               </a:rPr>
-              <a:t>(False positives are incorrect flags.)</a:t>
+              <a:t>Precision</a:t>
             </a:r>
           </a:p>
         </p:txBody>
@@ -2511,7 +2437,7 @@
           <p:cNvPr id="10" name="">
             <a:extLst xmlns:a="http://schemas.openxmlformats.org/drawingml/2006/main">
               <a:ext uri="{FF2B5EF4-FFF2-40B4-BE49-F238E27FC236}">
-                <a16:creationId xmlns:a16="http://schemas.microsoft.com/office/drawing/2014/main" id="{71BCBAE4-13FA-4210-8CD5-5322D53D3DE6}"/>
+                <a16:creationId xmlns:a16="http://schemas.microsoft.com/office/drawing/2014/main" id="{FA380D3B-F8E0-4812-9CEB-274BD74F7626}"/>
               </a:ext>
             </a:extLst>
           </p:cNvPr>
@@ -2522,8 +2448,8 @@
         </p:nvSpPr>
         <p:spPr>
           <a:xfrm xmlns:a="http://schemas.openxmlformats.org/drawingml/2006/main">
-            <a:off x="609600" y="4000500"/>
-            <a:ext cx="10972800" cy="381000"/>
+            <a:off x="6705600" y="2124075"/>
+            <a:ext cx="4876800" cy="447675"/>
           </a:xfrm>
           <a:prstGeom xmlns:a="http://schemas.openxmlformats.org/drawingml/2006/main" prst="rect">
             <a:avLst/>
@@ -2539,6 +2465,206 @@
           </a:bodyPr>
           <a:lstStyle xmlns:a="http://schemas.openxmlformats.org/drawingml/2006/main"/>
           <a:p xmlns:a="http://schemas.openxmlformats.org/drawingml/2006/main">
+            <a:pPr algn="ctr">
+              <a:defRPr sz="2100" b="0">
+                <a:solidFill>
+                  <a:srgbClr val="16343E"/>
+                </a:solidFill>
+                <a:latin typeface="Arial"/>
+                <a:ea typeface="Arial"/>
+                <a:cs typeface="Arial"/>
+              </a:defRPr>
+            </a:pPr>
+            <a:r>
+              <a:rPr sz="2100" b="0">
+                <a:solidFill>
+                  <a:srgbClr val="16343E"/>
+                </a:solidFill>
+                <a:latin typeface="Arial"/>
+                <a:ea typeface="Arial"/>
+                <a:cs typeface="Arial"/>
+              </a:rPr>
+              <a:t>Flags with recorded rejection</a:t>
+            </a:r>
+          </a:p>
+        </p:txBody>
+      </p:sp>
+      <p:sp>
+        <p:nvSpPr>
+          <p:cNvPr id="11" name="">
+            <a:extLst xmlns:a="http://schemas.openxmlformats.org/drawingml/2006/main">
+              <a:ext uri="{FF2B5EF4-FFF2-40B4-BE49-F238E27FC236}">
+                <a16:creationId xmlns:a16="http://schemas.microsoft.com/office/drawing/2014/main" id="{31F62A75-1633-4745-992E-8326DB939BD5}"/>
+              </a:ext>
+            </a:extLst>
+          </p:cNvPr>
+          <p:cNvSpPr>
+            <a:spLocks xmlns:a="http://schemas.openxmlformats.org/drawingml/2006/main" noGrp="1"/>
+          </p:cNvSpPr>
+          <p:nvPr/>
+        </p:nvSpPr>
+        <p:spPr>
+          <a:xfrm xmlns:a="http://schemas.openxmlformats.org/drawingml/2006/main">
+            <a:off x="6819900" y="2647950"/>
+            <a:ext cx="4648200" cy="0"/>
+          </a:xfrm>
+          <a:prstGeom xmlns:a="http://schemas.openxmlformats.org/drawingml/2006/main" prst="line">
+            <a:avLst/>
+          </a:prstGeom>
+          <a:ln xmlns:a="http://schemas.openxmlformats.org/drawingml/2006/main" w="11430">
+            <a:solidFill>
+              <a:srgbClr val="16343E"/>
+            </a:solidFill>
+          </a:ln>
+        </p:spPr>
+      </p:sp>
+      <p:sp>
+        <p:nvSpPr>
+          <p:cNvPr id="12" name="">
+            <a:extLst xmlns:a="http://schemas.openxmlformats.org/drawingml/2006/main">
+              <a:ext uri="{FF2B5EF4-FFF2-40B4-BE49-F238E27FC236}">
+                <a16:creationId xmlns:a16="http://schemas.microsoft.com/office/drawing/2014/main" id="{1A3F7D60-3ABE-476B-B5D7-46E112A80C11}"/>
+              </a:ext>
+            </a:extLst>
+          </p:cNvPr>
+          <p:cNvSpPr>
+            <a:spLocks xmlns:a="http://schemas.openxmlformats.org/drawingml/2006/main" noGrp="1"/>
+          </p:cNvSpPr>
+          <p:nvPr/>
+        </p:nvSpPr>
+        <p:spPr>
+          <a:xfrm xmlns:a="http://schemas.openxmlformats.org/drawingml/2006/main">
+            <a:off x="6705600" y="2705100"/>
+            <a:ext cx="4876800" cy="447675"/>
+          </a:xfrm>
+          <a:prstGeom xmlns:a="http://schemas.openxmlformats.org/drawingml/2006/main" prst="rect">
+            <a:avLst/>
+          </a:prstGeom>
+          <a:noFill xmlns:a="http://schemas.openxmlformats.org/drawingml/2006/main"/>
+          <a:ln xmlns:a="http://schemas.openxmlformats.org/drawingml/2006/main" w="0">
+            <a:noFill/>
+          </a:ln>
+        </p:spPr>
+        <p:txBody>
+          <a:bodyPr xmlns:a="http://schemas.openxmlformats.org/drawingml/2006/main" anchor="ctr">
+            <a:noAutofit/>
+          </a:bodyPr>
+          <a:lstStyle xmlns:a="http://schemas.openxmlformats.org/drawingml/2006/main"/>
+          <a:p xmlns:a="http://schemas.openxmlformats.org/drawingml/2006/main">
+            <a:pPr algn="ctr">
+              <a:defRPr sz="2100" b="0">
+                <a:solidFill>
+                  <a:srgbClr val="16343E"/>
+                </a:solidFill>
+                <a:latin typeface="Arial"/>
+                <a:ea typeface="Arial"/>
+                <a:cs typeface="Arial"/>
+              </a:defRPr>
+            </a:pPr>
+            <a:r>
+              <a:rPr sz="2100" b="0">
+                <a:solidFill>
+                  <a:srgbClr val="16343E"/>
+                </a:solidFill>
+                <a:latin typeface="Arial"/>
+                <a:ea typeface="Arial"/>
+                <a:cs typeface="Arial"/>
+              </a:rPr>
+              <a:t>All positive flags</a:t>
+            </a:r>
+          </a:p>
+        </p:txBody>
+      </p:sp>
+      <p:sp>
+        <p:nvSpPr>
+          <p:cNvPr id="13" name="">
+            <a:extLst xmlns:a="http://schemas.openxmlformats.org/drawingml/2006/main">
+              <a:ext uri="{FF2B5EF4-FFF2-40B4-BE49-F238E27FC236}">
+                <a16:creationId xmlns:a16="http://schemas.microsoft.com/office/drawing/2014/main" id="{4E7969CB-039F-4945-89C9-D5BC125589A9}"/>
+              </a:ext>
+            </a:extLst>
+          </p:cNvPr>
+          <p:cNvSpPr>
+            <a:spLocks xmlns:a="http://schemas.openxmlformats.org/drawingml/2006/main" noGrp="1"/>
+          </p:cNvSpPr>
+          <p:nvPr/>
+        </p:nvSpPr>
+        <p:spPr>
+          <a:xfrm xmlns:a="http://schemas.openxmlformats.org/drawingml/2006/main">
+            <a:off x="6705600" y="3257550"/>
+            <a:ext cx="4876800" cy="523875"/>
+          </a:xfrm>
+          <a:prstGeom xmlns:a="http://schemas.openxmlformats.org/drawingml/2006/main" prst="rect">
+            <a:avLst/>
+          </a:prstGeom>
+          <a:noFill xmlns:a="http://schemas.openxmlformats.org/drawingml/2006/main"/>
+          <a:ln xmlns:a="http://schemas.openxmlformats.org/drawingml/2006/main" w="0">
+            <a:noFill/>
+          </a:ln>
+        </p:spPr>
+        <p:txBody>
+          <a:bodyPr xmlns:a="http://schemas.openxmlformats.org/drawingml/2006/main" anchor="ctr">
+            <a:noAutofit/>
+          </a:bodyPr>
+          <a:lstStyle xmlns:a="http://schemas.openxmlformats.org/drawingml/2006/main"/>
+          <a:p xmlns:a="http://schemas.openxmlformats.org/drawingml/2006/main">
+            <a:pPr algn="l">
+              <a:defRPr sz="2100" b="0">
+                <a:solidFill>
+                  <a:srgbClr val="007C78"/>
+                </a:solidFill>
+                <a:latin typeface="Arial"/>
+                <a:ea typeface="Arial"/>
+                <a:cs typeface="Arial"/>
+              </a:defRPr>
+            </a:pPr>
+            <a:r>
+              <a:rPr sz="2100" b="0">
+                <a:solidFill>
+                  <a:srgbClr val="007C78"/>
+                </a:solidFill>
+                <a:latin typeface="Arial"/>
+                <a:ea typeface="Arial"/>
+                <a:cs typeface="Arial"/>
+              </a:rPr>
+              <a:t>(False positives are incorrect flags.)</a:t>
+            </a:r>
+          </a:p>
+        </p:txBody>
+      </p:sp>
+      <p:sp>
+        <p:nvSpPr>
+          <p:cNvPr id="14" name="">
+            <a:extLst xmlns:a="http://schemas.openxmlformats.org/drawingml/2006/main">
+              <a:ext uri="{FF2B5EF4-FFF2-40B4-BE49-F238E27FC236}">
+                <a16:creationId xmlns:a16="http://schemas.microsoft.com/office/drawing/2014/main" id="{2F4420A0-6058-4FC8-88FC-3B2BAD156E5F}"/>
+              </a:ext>
+            </a:extLst>
+          </p:cNvPr>
+          <p:cNvSpPr>
+            <a:spLocks xmlns:a="http://schemas.openxmlformats.org/drawingml/2006/main" noGrp="1"/>
+          </p:cNvSpPr>
+          <p:nvPr/>
+        </p:nvSpPr>
+        <p:spPr>
+          <a:xfrm xmlns:a="http://schemas.openxmlformats.org/drawingml/2006/main">
+            <a:off x="609600" y="4000500"/>
+            <a:ext cx="10972800" cy="381000"/>
+          </a:xfrm>
+          <a:prstGeom xmlns:a="http://schemas.openxmlformats.org/drawingml/2006/main" prst="rect">
+            <a:avLst/>
+          </a:prstGeom>
+          <a:noFill xmlns:a="http://schemas.openxmlformats.org/drawingml/2006/main"/>
+          <a:ln xmlns:a="http://schemas.openxmlformats.org/drawingml/2006/main" w="0">
+            <a:noFill/>
+          </a:ln>
+        </p:spPr>
+        <p:txBody>
+          <a:bodyPr xmlns:a="http://schemas.openxmlformats.org/drawingml/2006/main" anchor="ctr">
+            <a:noAutofit/>
+          </a:bodyPr>
+          <a:lstStyle xmlns:a="http://schemas.openxmlformats.org/drawingml/2006/main"/>
+          <a:p xmlns:a="http://schemas.openxmlformats.org/drawingml/2006/main">
             <a:pPr algn="l">
               <a:defRPr sz="2400" b="1">
                 <a:solidFill>
@@ -2565,7 +2691,7 @@
       </p:sp>
       <p:graphicFrame>
         <p:nvGraphicFramePr>
-          <p:cNvPr id="23" name=""/>
+          <p:cNvPr id="31" name=""/>
           <p:cNvGraphicFramePr/>
           <p:nvPr/>
         </p:nvGraphicFramePr>
@@ -2803,10 +2929,10 @@
       </p:graphicFrame>
       <p:sp>
         <p:nvSpPr>
-          <p:cNvPr id="12" name="">
+          <p:cNvPr id="16" name="">
             <a:extLst xmlns:a="http://schemas.openxmlformats.org/drawingml/2006/main">
               <a:ext uri="{FF2B5EF4-FFF2-40B4-BE49-F238E27FC236}">
-                <a16:creationId xmlns:a16="http://schemas.microsoft.com/office/drawing/2014/main" id="{E143CE4F-0344-4935-A343-2199181EDD72}"/>
+                <a16:creationId xmlns:a16="http://schemas.microsoft.com/office/drawing/2014/main" id="{0AEF79EC-0BD2-4CB3-9829-EE39DA58DB2F}"/>
               </a:ext>
             </a:extLst>
           </p:cNvPr>
@@ -2861,7 +2987,7 @@
     </p:spTree>
     <p:extLst>
       <p:ext uri="{BB962C8B-B14F-4D97-AF65-F5344CB8AC3E}">
-        <p14:creationId xmlns:p14="http://schemas.microsoft.com/office/powerpoint/2010/main" val="130087960"/>
+        <p14:creationId xmlns:p14="http://schemas.microsoft.com/office/powerpoint/2010/main" val="1632424565"/>
       </p:ext>
     </p:extLst>
   </p:cSld>
@@ -2892,7 +3018,7 @@
           <p:cNvPr id="7" name="">
             <a:extLst xmlns:a="http://schemas.openxmlformats.org/drawingml/2006/main">
               <a:ext uri="{FF2B5EF4-FFF2-40B4-BE49-F238E27FC236}">
-                <a16:creationId xmlns:a16="http://schemas.microsoft.com/office/drawing/2014/main" id="{93D9871B-70F3-4BCC-9FE0-3C347B9E45AB}"/>
+                <a16:creationId xmlns:a16="http://schemas.microsoft.com/office/drawing/2014/main" id="{E29C166B-21AE-414D-8C5F-DAD7A23B3B01}"/>
               </a:ext>
             </a:extLst>
           </p:cNvPr>
@@ -2949,7 +3075,7 @@
           <p:cNvPr id="2" name="">
             <a:extLst xmlns:a="http://schemas.openxmlformats.org/drawingml/2006/main">
               <a:ext uri="{FF2B5EF4-FFF2-40B4-BE49-F238E27FC236}">
-                <a16:creationId xmlns:a16="http://schemas.microsoft.com/office/drawing/2014/main" id="{B645D562-9303-469B-8507-BF5AE3956390}"/>
+                <a16:creationId xmlns:a16="http://schemas.microsoft.com/office/drawing/2014/main" id="{07587E13-10EF-4227-B11E-14EDA6BF1CE3}"/>
               </a:ext>
             </a:extLst>
           </p:cNvPr>
@@ -3006,7 +3132,7 @@
           <p:cNvPr id="3" name="">
             <a:extLst xmlns:a="http://schemas.openxmlformats.org/drawingml/2006/main">
               <a:ext uri="{FF2B5EF4-FFF2-40B4-BE49-F238E27FC236}">
-                <a16:creationId xmlns:a16="http://schemas.microsoft.com/office/drawing/2014/main" id="{C8683C4C-4A13-45E3-8A34-71BABBE4F97E}"/>
+                <a16:creationId xmlns:a16="http://schemas.microsoft.com/office/drawing/2014/main" id="{0820101C-68D0-4BDC-8031-DA39DD933195}"/>
               </a:ext>
             </a:extLst>
           </p:cNvPr>
@@ -3063,7 +3189,7 @@
           <p:cNvPr id="4" name="">
             <a:extLst xmlns:a="http://schemas.openxmlformats.org/drawingml/2006/main">
               <a:ext uri="{FF2B5EF4-FFF2-40B4-BE49-F238E27FC236}">
-                <a16:creationId xmlns:a16="http://schemas.microsoft.com/office/drawing/2014/main" id="{DC07CE36-2BC0-4EF2-B058-271B3BAC6600}"/>
+                <a16:creationId xmlns:a16="http://schemas.microsoft.com/office/drawing/2014/main" id="{363124D7-118C-40D4-A62C-1DA89D02371B}"/>
               </a:ext>
             </a:extLst>
           </p:cNvPr>
@@ -3127,7 +3253,7 @@
         </p:xfrm>
         <a:graphic xmlns:a="http://schemas.openxmlformats.org/drawingml/2006/main">
           <a:graphicData uri="http://schemas.openxmlformats.org/drawingml/2006/chart">
-            <c:chart xmlns:r="http://schemas.openxmlformats.org/officeDocument/2006/relationships" xmlns:c="http://schemas.openxmlformats.org/drawingml/2006/chart" r:id="R7d94b5ba6c7b44c0"/>
+            <c:chart xmlns:r="http://schemas.openxmlformats.org/officeDocument/2006/relationships" xmlns:c="http://schemas.openxmlformats.org/drawingml/2006/chart" r:id="Rca3b9ed9027f45b4"/>
           </a:graphicData>
         </a:graphic>
       </p:graphicFrame>
@@ -3136,7 +3262,7 @@
           <p:cNvPr id="6" name="">
             <a:extLst xmlns:a="http://schemas.openxmlformats.org/drawingml/2006/main">
               <a:ext uri="{FF2B5EF4-FFF2-40B4-BE49-F238E27FC236}">
-                <a16:creationId xmlns:a16="http://schemas.microsoft.com/office/drawing/2014/main" id="{D0D8533A-D554-48DE-A334-0BBC0C369357}"/>
+                <a16:creationId xmlns:a16="http://schemas.microsoft.com/office/drawing/2014/main" id="{4D3133AB-F27A-444D-BA58-8510313CD4FE}"/>
               </a:ext>
             </a:extLst>
           </p:cNvPr>
@@ -3222,7 +3348,7 @@
     </p:spTree>
     <p:extLst>
       <p:ext uri="{BB962C8B-B14F-4D97-AF65-F5344CB8AC3E}">
-        <p14:creationId xmlns:p14="http://schemas.microsoft.com/office/powerpoint/2010/main" val="1978114221"/>
+        <p14:creationId xmlns:p14="http://schemas.microsoft.com/office/powerpoint/2010/main" val="127773223"/>
       </p:ext>
     </p:extLst>
   </p:cSld>
@@ -3253,7 +3379,7 @@
           <p:cNvPr id="9" name="">
             <a:extLst xmlns:a="http://schemas.openxmlformats.org/drawingml/2006/main">
               <a:ext uri="{FF2B5EF4-FFF2-40B4-BE49-F238E27FC236}">
-                <a16:creationId xmlns:a16="http://schemas.microsoft.com/office/drawing/2014/main" id="{2E0DA066-B79A-4EA9-B34C-44849A563527}"/>
+                <a16:creationId xmlns:a16="http://schemas.microsoft.com/office/drawing/2014/main" id="{66C3FCE4-A5C2-4644-B938-F6D411D28F41}"/>
               </a:ext>
             </a:extLst>
           </p:cNvPr>
@@ -3310,7 +3436,7 @@
           <p:cNvPr id="2" name="">
             <a:extLst xmlns:a="http://schemas.openxmlformats.org/drawingml/2006/main">
               <a:ext uri="{FF2B5EF4-FFF2-40B4-BE49-F238E27FC236}">
-                <a16:creationId xmlns:a16="http://schemas.microsoft.com/office/drawing/2014/main" id="{A660362B-A01E-4804-A667-78A2215FE1D9}"/>
+                <a16:creationId xmlns:a16="http://schemas.microsoft.com/office/drawing/2014/main" id="{B8229517-23CD-4431-BA1B-D9D58D9133C8}"/>
               </a:ext>
             </a:extLst>
           </p:cNvPr>
@@ -3367,7 +3493,7 @@
           <p:cNvPr id="3" name="">
             <a:extLst xmlns:a="http://schemas.openxmlformats.org/drawingml/2006/main">
               <a:ext uri="{FF2B5EF4-FFF2-40B4-BE49-F238E27FC236}">
-                <a16:creationId xmlns:a16="http://schemas.microsoft.com/office/drawing/2014/main" id="{FB1A113E-35A8-4BAC-97E3-4B502D59278B}"/>
+                <a16:creationId xmlns:a16="http://schemas.microsoft.com/office/drawing/2014/main" id="{F5B1AE7B-A413-4063-B17D-3CFBAD98B3E2}"/>
               </a:ext>
             </a:extLst>
           </p:cNvPr>
@@ -3424,7 +3550,7 @@
           <p:cNvPr id="4" name="">
             <a:extLst xmlns:a="http://schemas.openxmlformats.org/drawingml/2006/main">
               <a:ext uri="{FF2B5EF4-FFF2-40B4-BE49-F238E27FC236}">
-                <a16:creationId xmlns:a16="http://schemas.microsoft.com/office/drawing/2014/main" id="{F5C14B07-C47D-45C2-B62A-811028C7F59A}"/>
+                <a16:creationId xmlns:a16="http://schemas.microsoft.com/office/drawing/2014/main" id="{8739D2F5-1B34-452E-B472-AD47631A8FF2}"/>
               </a:ext>
             </a:extLst>
           </p:cNvPr>
@@ -3481,7 +3607,7 @@
           <p:cNvPr id="5" name="">
             <a:extLst xmlns:a="http://schemas.openxmlformats.org/drawingml/2006/main">
               <a:ext uri="{FF2B5EF4-FFF2-40B4-BE49-F238E27FC236}">
-                <a16:creationId xmlns:a16="http://schemas.microsoft.com/office/drawing/2014/main" id="{BA5004C3-0B24-4EC1-B00F-F7CAF2F80DAE}"/>
+                <a16:creationId xmlns:a16="http://schemas.microsoft.com/office/drawing/2014/main" id="{24EEABEC-FBCF-46B1-8A26-14233474A748}"/>
               </a:ext>
             </a:extLst>
           </p:cNvPr>
@@ -3561,7 +3687,7 @@
           <p:cNvPr id="6" name="">
             <a:extLst xmlns:a="http://schemas.openxmlformats.org/drawingml/2006/main">
               <a:ext uri="{FF2B5EF4-FFF2-40B4-BE49-F238E27FC236}">
-                <a16:creationId xmlns:a16="http://schemas.microsoft.com/office/drawing/2014/main" id="{4A3FA261-EAD3-43EF-9DA2-F8A29948126A}"/>
+                <a16:creationId xmlns:a16="http://schemas.microsoft.com/office/drawing/2014/main" id="{1DA375D3-44E1-43F4-9997-EA55F0CED00A}"/>
               </a:ext>
             </a:extLst>
           </p:cNvPr>
@@ -3649,7 +3775,7 @@
           <p:cNvPr id="7" name="">
             <a:extLst xmlns:a="http://schemas.openxmlformats.org/drawingml/2006/main">
               <a:ext uri="{FF2B5EF4-FFF2-40B4-BE49-F238E27FC236}">
-                <a16:creationId xmlns:a16="http://schemas.microsoft.com/office/drawing/2014/main" id="{275CE76F-034D-4CEB-A51E-2B00152F9F48}"/>
+                <a16:creationId xmlns:a16="http://schemas.microsoft.com/office/drawing/2014/main" id="{4FE9D7BA-71ED-4B6A-96FC-94C403EB2C0E}"/>
               </a:ext>
             </a:extLst>
           </p:cNvPr>
@@ -3942,7 +4068,7 @@
     </p:spTree>
     <p:extLst>
       <p:ext uri="{BB962C8B-B14F-4D97-AF65-F5344CB8AC3E}">
-        <p14:creationId xmlns:p14="http://schemas.microsoft.com/office/powerpoint/2010/main" val="1451916616"/>
+        <p14:creationId xmlns:p14="http://schemas.microsoft.com/office/powerpoint/2010/main" val="1169880390"/>
       </p:ext>
     </p:extLst>
   </p:cSld>
@@ -3973,7 +4099,7 @@
           <p:cNvPr id="9" name="">
             <a:extLst xmlns:a="http://schemas.openxmlformats.org/drawingml/2006/main">
               <a:ext uri="{FF2B5EF4-FFF2-40B4-BE49-F238E27FC236}">
-                <a16:creationId xmlns:a16="http://schemas.microsoft.com/office/drawing/2014/main" id="{E40DD3F2-1F8E-4047-8B69-D0B48B042CA2}"/>
+                <a16:creationId xmlns:a16="http://schemas.microsoft.com/office/drawing/2014/main" id="{AB60851F-0479-427C-A7B9-36EE11BF2B56}"/>
               </a:ext>
             </a:extLst>
           </p:cNvPr>
@@ -4030,7 +4156,7 @@
           <p:cNvPr id="2" name="">
             <a:extLst xmlns:a="http://schemas.openxmlformats.org/drawingml/2006/main">
               <a:ext uri="{FF2B5EF4-FFF2-40B4-BE49-F238E27FC236}">
-                <a16:creationId xmlns:a16="http://schemas.microsoft.com/office/drawing/2014/main" id="{282562CD-8197-4E18-AD74-CCEAFC401621}"/>
+                <a16:creationId xmlns:a16="http://schemas.microsoft.com/office/drawing/2014/main" id="{565D2DDF-7B50-4590-A645-158627A5E58F}"/>
               </a:ext>
             </a:extLst>
           </p:cNvPr>
@@ -4087,7 +4213,7 @@
           <p:cNvPr id="3" name="">
             <a:extLst xmlns:a="http://schemas.openxmlformats.org/drawingml/2006/main">
               <a:ext uri="{FF2B5EF4-FFF2-40B4-BE49-F238E27FC236}">
-                <a16:creationId xmlns:a16="http://schemas.microsoft.com/office/drawing/2014/main" id="{2809DF0E-CBF2-4D8F-8FAA-907119DCE778}"/>
+                <a16:creationId xmlns:a16="http://schemas.microsoft.com/office/drawing/2014/main" id="{8D610B85-A8AF-42BF-BDED-27C0FCA34A78}"/>
               </a:ext>
             </a:extLst>
           </p:cNvPr>
@@ -4144,7 +4270,7 @@
           <p:cNvPr id="4" name="">
             <a:extLst xmlns:a="http://schemas.openxmlformats.org/drawingml/2006/main">
               <a:ext uri="{FF2B5EF4-FFF2-40B4-BE49-F238E27FC236}">
-                <a16:creationId xmlns:a16="http://schemas.microsoft.com/office/drawing/2014/main" id="{AC706D7A-CD55-4743-9CB7-5A4FD3EC379C}"/>
+                <a16:creationId xmlns:a16="http://schemas.microsoft.com/office/drawing/2014/main" id="{5ED566BB-48A8-464A-B01B-E06B95162047}"/>
               </a:ext>
             </a:extLst>
           </p:cNvPr>
@@ -4201,7 +4327,7 @@
           <p:cNvPr id="5" name="">
             <a:extLst xmlns:a="http://schemas.openxmlformats.org/drawingml/2006/main">
               <a:ext uri="{FF2B5EF4-FFF2-40B4-BE49-F238E27FC236}">
-                <a16:creationId xmlns:a16="http://schemas.microsoft.com/office/drawing/2014/main" id="{0059457B-6ADF-4C8A-90B9-EBF95C04B7DF}"/>
+                <a16:creationId xmlns:a16="http://schemas.microsoft.com/office/drawing/2014/main" id="{7791DAE0-4627-4BD5-B4E0-B7295939D6F2}"/>
               </a:ext>
             </a:extLst>
           </p:cNvPr>
@@ -4316,7 +4442,7 @@
           <p:cNvPr id="6" name="">
             <a:extLst xmlns:a="http://schemas.openxmlformats.org/drawingml/2006/main">
               <a:ext uri="{FF2B5EF4-FFF2-40B4-BE49-F238E27FC236}">
-                <a16:creationId xmlns:a16="http://schemas.microsoft.com/office/drawing/2014/main" id="{32E1ADC9-27FF-4402-BC6C-AD66D23DC720}"/>
+                <a16:creationId xmlns:a16="http://schemas.microsoft.com/office/drawing/2014/main" id="{506E2892-5F71-402B-ADC5-17B71B5D59DF}"/>
               </a:ext>
             </a:extLst>
           </p:cNvPr>
@@ -4503,7 +4629,7 @@
           <p:cNvPr id="8" name="">
             <a:extLst xmlns:a="http://schemas.openxmlformats.org/drawingml/2006/main">
               <a:ext uri="{FF2B5EF4-FFF2-40B4-BE49-F238E27FC236}">
-                <a16:creationId xmlns:a16="http://schemas.microsoft.com/office/drawing/2014/main" id="{527D5680-E4CD-4D5B-AC9A-E5F341556CD4}"/>
+                <a16:creationId xmlns:a16="http://schemas.microsoft.com/office/drawing/2014/main" id="{F71E7439-1C34-45E0-ADC4-63B9CB307565}"/>
               </a:ext>
             </a:extLst>
           </p:cNvPr>
@@ -4558,7 +4684,7 @@
     </p:spTree>
     <p:extLst>
       <p:ext uri="{BB962C8B-B14F-4D97-AF65-F5344CB8AC3E}">
-        <p14:creationId xmlns:p14="http://schemas.microsoft.com/office/powerpoint/2010/main" val="562149893"/>
+        <p14:creationId xmlns:p14="http://schemas.microsoft.com/office/powerpoint/2010/main" val="598331586"/>
       </p:ext>
     </p:extLst>
   </p:cSld>
@@ -4589,7 +4715,7 @@
           <p:cNvPr id="13" name="">
             <a:extLst xmlns:a="http://schemas.openxmlformats.org/drawingml/2006/main">
               <a:ext uri="{FF2B5EF4-FFF2-40B4-BE49-F238E27FC236}">
-                <a16:creationId xmlns:a16="http://schemas.microsoft.com/office/drawing/2014/main" id="{2E0882ED-E60F-42C9-8377-14F27131CB7C}"/>
+                <a16:creationId xmlns:a16="http://schemas.microsoft.com/office/drawing/2014/main" id="{E54A8FE2-6003-46A6-A716-180B5F3DC258}"/>
               </a:ext>
             </a:extLst>
           </p:cNvPr>
@@ -4636,7 +4762,7 @@
                 <a:ea typeface="Arial"/>
                 <a:cs typeface="Arial"/>
               </a:rPr>
-              <a:t>Training and prediction use the same preparation</a:t>
+              <a:t>Prediction service and demonstration</a:t>
             </a:r>
           </a:p>
         </p:txBody>
@@ -4646,7 +4772,7 @@
           <p:cNvPr id="2" name="">
             <a:extLst xmlns:a="http://schemas.openxmlformats.org/drawingml/2006/main">
               <a:ext uri="{FF2B5EF4-FFF2-40B4-BE49-F238E27FC236}">
-                <a16:creationId xmlns:a16="http://schemas.microsoft.com/office/drawing/2014/main" id="{4FA511B9-A0B6-49F9-841B-4978E9390C2B}"/>
+                <a16:creationId xmlns:a16="http://schemas.microsoft.com/office/drawing/2014/main" id="{4D6B3B66-5D4C-497A-A910-98C5403CF75D}"/>
               </a:ext>
             </a:extLst>
           </p:cNvPr>
@@ -4703,7 +4829,7 @@
           <p:cNvPr id="3" name="">
             <a:extLst xmlns:a="http://schemas.openxmlformats.org/drawingml/2006/main">
               <a:ext uri="{FF2B5EF4-FFF2-40B4-BE49-F238E27FC236}">
-                <a16:creationId xmlns:a16="http://schemas.microsoft.com/office/drawing/2014/main" id="{69890894-B54B-4093-B2C0-FF9D2A57BDB6}"/>
+                <a16:creationId xmlns:a16="http://schemas.microsoft.com/office/drawing/2014/main" id="{21D2080F-1312-4BC8-A0D0-B7079484538F}"/>
               </a:ext>
             </a:extLst>
           </p:cNvPr>
@@ -4760,7 +4886,7 @@
           <p:cNvPr id="4" name="">
             <a:extLst xmlns:a="http://schemas.openxmlformats.org/drawingml/2006/main">
               <a:ext uri="{FF2B5EF4-FFF2-40B4-BE49-F238E27FC236}">
-                <a16:creationId xmlns:a16="http://schemas.microsoft.com/office/drawing/2014/main" id="{F71AD415-61F3-4BD6-B3EA-A9D7ACACA976}"/>
+                <a16:creationId xmlns:a16="http://schemas.microsoft.com/office/drawing/2014/main" id="{A3519A4B-435C-4203-A098-63317865DA2D}"/>
               </a:ext>
             </a:extLst>
           </p:cNvPr>
@@ -4771,8 +4897,8 @@
         </p:nvSpPr>
         <p:spPr>
           <a:xfrm xmlns:a="http://schemas.openxmlformats.org/drawingml/2006/main">
-            <a:off x="609600" y="1571625"/>
-            <a:ext cx="10972800" cy="571500"/>
+            <a:off x="609600" y="1524000"/>
+            <a:ext cx="10972800" cy="790575"/>
           </a:xfrm>
           <a:prstGeom xmlns:a="http://schemas.openxmlformats.org/drawingml/2006/main" prst="rect">
             <a:avLst/>
@@ -4790,20 +4916,20 @@
           <a:p xmlns:a="http://schemas.openxmlformats.org/drawingml/2006/main">
             <a:pPr marL="279400" indent="-152400" algn="l">
               <a:spcAft>
-                <a:spcPts val="1200"/>
+                <a:spcPts val="600"/>
               </a:spcAft>
               <a:buChar char="•"/>
-              <a:defRPr sz="2475" b="0">
-                <a:solidFill>
-                  <a:srgbClr val="16343E"/>
-                </a:solidFill>
-                <a:latin typeface="Arial"/>
-                <a:ea typeface="Arial"/>
-                <a:cs typeface="Arial"/>
-              </a:defRPr>
-            </a:pPr>
-            <a:r>
-              <a:rPr sz="2475" b="0">
+              <a:defRPr sz="2175" b="0">
+                <a:solidFill>
+                  <a:srgbClr val="16343E"/>
+                </a:solidFill>
+                <a:latin typeface="Arial"/>
+                <a:ea typeface="Arial"/>
+                <a:cs typeface="Arial"/>
+              </a:defRPr>
+            </a:pPr>
+            <a:r>
+              <a:rPr sz="2175" b="0">
                 <a:solidFill>
                   <a:srgbClr val="16343E"/>
                 </a:solidFill>
@@ -4812,6 +4938,33 @@
                 <a:cs typeface="Arial"/>
               </a:rPr>
               <a:t>CSV input through the command line or web application.</a:t>
+            </a:r>
+          </a:p>
+          <a:p xmlns:a="http://schemas.openxmlformats.org/drawingml/2006/main">
+            <a:pPr marL="279400" indent="-152400" algn="l">
+              <a:spcAft>
+                <a:spcPts val="600"/>
+              </a:spcAft>
+              <a:buChar char="•"/>
+              <a:defRPr sz="2175" b="0">
+                <a:solidFill>
+                  <a:srgbClr val="16343E"/>
+                </a:solidFill>
+                <a:latin typeface="Arial"/>
+                <a:ea typeface="Arial"/>
+                <a:cs typeface="Arial"/>
+              </a:defRPr>
+            </a:pPr>
+            <a:r>
+              <a:rPr sz="2175" b="0">
+                <a:solidFill>
+                  <a:srgbClr val="16343E"/>
+                </a:solidFill>
+                <a:latin typeface="Arial"/>
+                <a:ea typeface="Arial"/>
+                <a:cs typeface="Arial"/>
+              </a:rPr>
+              <a:t>Training and prediction share the preparation code.</a:t>
             </a:r>
           </a:p>
         </p:txBody>
@@ -4821,7 +4974,7 @@
           <p:cNvPr id="5" name="">
             <a:extLst xmlns:a="http://schemas.openxmlformats.org/drawingml/2006/main">
               <a:ext uri="{FF2B5EF4-FFF2-40B4-BE49-F238E27FC236}">
-                <a16:creationId xmlns:a16="http://schemas.microsoft.com/office/drawing/2014/main" id="{966BCBA2-C6E6-462C-BEFC-D5DBECC92E1C}"/>
+                <a16:creationId xmlns:a16="http://schemas.microsoft.com/office/drawing/2014/main" id="{3CC0AD85-0F67-4B6A-97E2-4EDCA0AABB37}"/>
               </a:ext>
             </a:extLst>
           </p:cNvPr>
@@ -4882,7 +5035,7 @@
           <p:cNvPr id="6" name="">
             <a:extLst xmlns:a="http://schemas.openxmlformats.org/drawingml/2006/main">
               <a:ext uri="{FF2B5EF4-FFF2-40B4-BE49-F238E27FC236}">
-                <a16:creationId xmlns:a16="http://schemas.microsoft.com/office/drawing/2014/main" id="{0E45DF08-E0E9-49B0-8354-538CA5BCE163}"/>
+                <a16:creationId xmlns:a16="http://schemas.microsoft.com/office/drawing/2014/main" id="{884D9139-524E-49E9-9BA4-E06D68CACA01}"/>
               </a:ext>
             </a:extLst>
           </p:cNvPr>
@@ -4991,7 +5144,7 @@
           <p:cNvPr id="8" name="">
             <a:extLst xmlns:a="http://schemas.openxmlformats.org/drawingml/2006/main">
               <a:ext uri="{FF2B5EF4-FFF2-40B4-BE49-F238E27FC236}">
-                <a16:creationId xmlns:a16="http://schemas.microsoft.com/office/drawing/2014/main" id="{944C38F2-084A-4DE9-9B6A-E090758B77AE}"/>
+                <a16:creationId xmlns:a16="http://schemas.microsoft.com/office/drawing/2014/main" id="{64762E3D-26F1-4AFF-A718-0FD0A1BF87B7}"/>
               </a:ext>
             </a:extLst>
           </p:cNvPr>
@@ -5100,7 +5253,7 @@
           <p:cNvPr id="10" name="">
             <a:extLst xmlns:a="http://schemas.openxmlformats.org/drawingml/2006/main">
               <a:ext uri="{FF2B5EF4-FFF2-40B4-BE49-F238E27FC236}">
-                <a16:creationId xmlns:a16="http://schemas.microsoft.com/office/drawing/2014/main" id="{E89AFDD9-B5B1-4609-9903-692DD64EE528}"/>
+                <a16:creationId xmlns:a16="http://schemas.microsoft.com/office/drawing/2014/main" id="{4E2F8D7D-C280-42F8-9599-7394D0F1BF86}"/>
               </a:ext>
             </a:extLst>
           </p:cNvPr>
@@ -5209,7 +5362,7 @@
           <p:cNvPr id="12" name="">
             <a:extLst xmlns:a="http://schemas.openxmlformats.org/drawingml/2006/main">
               <a:ext uri="{FF2B5EF4-FFF2-40B4-BE49-F238E27FC236}">
-                <a16:creationId xmlns:a16="http://schemas.microsoft.com/office/drawing/2014/main" id="{A9DFF5A5-A5D4-46D9-86AC-5C0466FD4733}"/>
+                <a16:creationId xmlns:a16="http://schemas.microsoft.com/office/drawing/2014/main" id="{95EABD82-ECF3-4F7A-9567-36063A3F0AA0}"/>
               </a:ext>
             </a:extLst>
           </p:cNvPr>
@@ -5295,7 +5448,7 @@
     </p:spTree>
     <p:extLst>
       <p:ext uri="{BB962C8B-B14F-4D97-AF65-F5344CB8AC3E}">
-        <p14:creationId xmlns:p14="http://schemas.microsoft.com/office/powerpoint/2010/main" val="1277179253"/>
+        <p14:creationId xmlns:p14="http://schemas.microsoft.com/office/powerpoint/2010/main" val="1404919146"/>
       </p:ext>
     </p:extLst>
   </p:cSld>
@@ -5326,7 +5479,7 @@
           <p:cNvPr id="9" name="">
             <a:extLst xmlns:a="http://schemas.openxmlformats.org/drawingml/2006/main">
               <a:ext uri="{FF2B5EF4-FFF2-40B4-BE49-F238E27FC236}">
-                <a16:creationId xmlns:a16="http://schemas.microsoft.com/office/drawing/2014/main" id="{4B01B305-F2E8-41BE-802A-29998389A753}"/>
+                <a16:creationId xmlns:a16="http://schemas.microsoft.com/office/drawing/2014/main" id="{60B12E10-902A-4D94-B2BB-65ED70346A15}"/>
               </a:ext>
             </a:extLst>
           </p:cNvPr>
@@ -5383,7 +5536,7 @@
           <p:cNvPr id="2" name="">
             <a:extLst xmlns:a="http://schemas.openxmlformats.org/drawingml/2006/main">
               <a:ext uri="{FF2B5EF4-FFF2-40B4-BE49-F238E27FC236}">
-                <a16:creationId xmlns:a16="http://schemas.microsoft.com/office/drawing/2014/main" id="{1B486D4F-38F2-4246-BCB9-53B88E3CBC1D}"/>
+                <a16:creationId xmlns:a16="http://schemas.microsoft.com/office/drawing/2014/main" id="{A40FA92F-E999-4C58-A209-8FBD24C44791}"/>
               </a:ext>
             </a:extLst>
           </p:cNvPr>
@@ -5440,7 +5593,7 @@
           <p:cNvPr id="3" name="">
             <a:extLst xmlns:a="http://schemas.openxmlformats.org/drawingml/2006/main">
               <a:ext uri="{FF2B5EF4-FFF2-40B4-BE49-F238E27FC236}">
-                <a16:creationId xmlns:a16="http://schemas.microsoft.com/office/drawing/2014/main" id="{9B70EE77-3414-4B8A-B95B-51B19F400493}"/>
+                <a16:creationId xmlns:a16="http://schemas.microsoft.com/office/drawing/2014/main" id="{300F3AB6-3108-45FA-950A-23C58CE48E50}"/>
               </a:ext>
             </a:extLst>
           </p:cNvPr>
@@ -5497,7 +5650,7 @@
           <p:cNvPr id="4" name="">
             <a:extLst xmlns:a="http://schemas.openxmlformats.org/drawingml/2006/main">
               <a:ext uri="{FF2B5EF4-FFF2-40B4-BE49-F238E27FC236}">
-                <a16:creationId xmlns:a16="http://schemas.microsoft.com/office/drawing/2014/main" id="{CE94F1DE-FFAE-4D8D-AD86-705912AD30B9}"/>
+                <a16:creationId xmlns:a16="http://schemas.microsoft.com/office/drawing/2014/main" id="{A8F124F3-8051-4078-9915-471577AA7018}"/>
               </a:ext>
             </a:extLst>
           </p:cNvPr>
@@ -5741,7 +5894,7 @@
           <p:cNvPr id="6" name="">
             <a:extLst xmlns:a="http://schemas.openxmlformats.org/drawingml/2006/main">
               <a:ext uri="{FF2B5EF4-FFF2-40B4-BE49-F238E27FC236}">
-                <a16:creationId xmlns:a16="http://schemas.microsoft.com/office/drawing/2014/main" id="{8D5BA349-FFE1-4465-A59D-43BCFEC24A2E}"/>
+                <a16:creationId xmlns:a16="http://schemas.microsoft.com/office/drawing/2014/main" id="{B7054A0A-3161-4CAB-B661-402DE7205CBA}"/>
               </a:ext>
             </a:extLst>
           </p:cNvPr>
@@ -5798,7 +5951,7 @@
           <p:cNvPr id="7" name="">
             <a:extLst xmlns:a="http://schemas.openxmlformats.org/drawingml/2006/main">
               <a:ext uri="{FF2B5EF4-FFF2-40B4-BE49-F238E27FC236}">
-                <a16:creationId xmlns:a16="http://schemas.microsoft.com/office/drawing/2014/main" id="{EC4E6BF0-26E9-49F0-84DC-FA494DCE33B9}"/>
+                <a16:creationId xmlns:a16="http://schemas.microsoft.com/office/drawing/2014/main" id="{15ABC40D-995E-4FC5-BFD9-D9528999ABBF}"/>
               </a:ext>
             </a:extLst>
           </p:cNvPr>
@@ -5886,7 +6039,7 @@
           <p:cNvPr id="8" name="">
             <a:extLst xmlns:a="http://schemas.openxmlformats.org/drawingml/2006/main">
               <a:ext uri="{FF2B5EF4-FFF2-40B4-BE49-F238E27FC236}">
-                <a16:creationId xmlns:a16="http://schemas.microsoft.com/office/drawing/2014/main" id="{5EE7B87D-B935-4237-BEE1-EC5F3572BF8E}"/>
+                <a16:creationId xmlns:a16="http://schemas.microsoft.com/office/drawing/2014/main" id="{FAACC592-0E71-473E-822D-D24BCAE3B592}"/>
               </a:ext>
             </a:extLst>
           </p:cNvPr>
@@ -5941,7 +6094,7 @@
     </p:spTree>
     <p:extLst>
       <p:ext uri="{BB962C8B-B14F-4D97-AF65-F5344CB8AC3E}">
-        <p14:creationId xmlns:p14="http://schemas.microsoft.com/office/powerpoint/2010/main" val="933223053"/>
+        <p14:creationId xmlns:p14="http://schemas.microsoft.com/office/powerpoint/2010/main" val="1755082383"/>
       </p:ext>
     </p:extLst>
   </p:cSld>
@@ -5972,7 +6125,7 @@
           <p:cNvPr id="7" name="">
             <a:extLst xmlns:a="http://schemas.openxmlformats.org/drawingml/2006/main">
               <a:ext uri="{FF2B5EF4-FFF2-40B4-BE49-F238E27FC236}">
-                <a16:creationId xmlns:a16="http://schemas.microsoft.com/office/drawing/2014/main" id="{5E5257DB-6D79-44B8-ADB0-C0CE130707DF}"/>
+                <a16:creationId xmlns:a16="http://schemas.microsoft.com/office/drawing/2014/main" id="{07F5E51B-B22F-44C3-BC86-7BC785A25EA0}"/>
               </a:ext>
             </a:extLst>
           </p:cNvPr>
@@ -6029,7 +6182,7 @@
           <p:cNvPr id="2" name="">
             <a:extLst xmlns:a="http://schemas.openxmlformats.org/drawingml/2006/main">
               <a:ext uri="{FF2B5EF4-FFF2-40B4-BE49-F238E27FC236}">
-                <a16:creationId xmlns:a16="http://schemas.microsoft.com/office/drawing/2014/main" id="{CE9A73B0-679C-4EE3-A7A5-71A47D6015DB}"/>
+                <a16:creationId xmlns:a16="http://schemas.microsoft.com/office/drawing/2014/main" id="{94B8D860-6894-48DD-B17B-CF12F732AB1B}"/>
               </a:ext>
             </a:extLst>
           </p:cNvPr>
@@ -6086,7 +6239,7 @@
           <p:cNvPr id="3" name="">
             <a:extLst xmlns:a="http://schemas.openxmlformats.org/drawingml/2006/main">
               <a:ext uri="{FF2B5EF4-FFF2-40B4-BE49-F238E27FC236}">
-                <a16:creationId xmlns:a16="http://schemas.microsoft.com/office/drawing/2014/main" id="{EA353D05-52B1-4C24-BA8E-8F3E33D3BB76}"/>
+                <a16:creationId xmlns:a16="http://schemas.microsoft.com/office/drawing/2014/main" id="{C7A32D45-DA0E-44FF-8331-5CAEBCC31B48}"/>
               </a:ext>
             </a:extLst>
           </p:cNvPr>
@@ -6143,7 +6296,7 @@
           <p:cNvPr id="4" name="">
             <a:extLst xmlns:a="http://schemas.openxmlformats.org/drawingml/2006/main">
               <a:ext uri="{FF2B5EF4-FFF2-40B4-BE49-F238E27FC236}">
-                <a16:creationId xmlns:a16="http://schemas.microsoft.com/office/drawing/2014/main" id="{8CD3BC87-D132-4A57-B566-A263EA402437}"/>
+                <a16:creationId xmlns:a16="http://schemas.microsoft.com/office/drawing/2014/main" id="{F600F02C-70C9-45DA-B2CB-99A401E30690}"/>
               </a:ext>
             </a:extLst>
           </p:cNvPr>
@@ -6442,7 +6595,7 @@
           <p:cNvPr id="6" name="">
             <a:extLst xmlns:a="http://schemas.openxmlformats.org/drawingml/2006/main">
               <a:ext uri="{FF2B5EF4-FFF2-40B4-BE49-F238E27FC236}">
-                <a16:creationId xmlns:a16="http://schemas.microsoft.com/office/drawing/2014/main" id="{E20F8D19-D00F-48DF-8409-46897678A98C}"/>
+                <a16:creationId xmlns:a16="http://schemas.microsoft.com/office/drawing/2014/main" id="{A15CA0AB-FB60-4A4E-80B5-9394EBBA57A3}"/>
               </a:ext>
             </a:extLst>
           </p:cNvPr>
@@ -6528,7 +6681,7 @@
     </p:spTree>
     <p:extLst>
       <p:ext uri="{BB962C8B-B14F-4D97-AF65-F5344CB8AC3E}">
-        <p14:creationId xmlns:p14="http://schemas.microsoft.com/office/powerpoint/2010/main" val="844225268"/>
+        <p14:creationId xmlns:p14="http://schemas.microsoft.com/office/powerpoint/2010/main" val="2073885485"/>
       </p:ext>
     </p:extLst>
   </p:cSld>
@@ -6559,7 +6712,7 @@
           <p:cNvPr id="6" name="">
             <a:extLst xmlns:a="http://schemas.openxmlformats.org/drawingml/2006/main">
               <a:ext uri="{FF2B5EF4-FFF2-40B4-BE49-F238E27FC236}">
-                <a16:creationId xmlns:a16="http://schemas.microsoft.com/office/drawing/2014/main" id="{2475668C-DB65-4692-A0D0-41C02CDE662D}"/>
+                <a16:creationId xmlns:a16="http://schemas.microsoft.com/office/drawing/2014/main" id="{A4F4E59F-202D-453A-A030-C87C175ED9D0}"/>
               </a:ext>
             </a:extLst>
           </p:cNvPr>
@@ -6606,7 +6759,7 @@
                 <a:ea typeface="Arial"/>
                 <a:cs typeface="Arial"/>
               </a:rPr>
-              <a:t>Testing the proposed use in ambiguous biopsies</a:t>
+              <a:t>Possible next steps</a:t>
             </a:r>
           </a:p>
         </p:txBody>
@@ -6616,7 +6769,7 @@
           <p:cNvPr id="2" name="">
             <a:extLst xmlns:a="http://schemas.openxmlformats.org/drawingml/2006/main">
               <a:ext uri="{FF2B5EF4-FFF2-40B4-BE49-F238E27FC236}">
-                <a16:creationId xmlns:a16="http://schemas.microsoft.com/office/drawing/2014/main" id="{B36BA0C0-7E3B-4034-9B51-8D5015735D32}"/>
+                <a16:creationId xmlns:a16="http://schemas.microsoft.com/office/drawing/2014/main" id="{FDDF993B-8CDC-4ED6-B14C-F738651D3F51}"/>
               </a:ext>
             </a:extLst>
           </p:cNvPr>
@@ -6663,7 +6816,7 @@
                 <a:ea typeface="Arial"/>
                 <a:cs typeface="Arial"/>
               </a:rPr>
-              <a:t>Sources: project research context; primary analysis; Banff work plan (2024). Proposed evaluation.</a:t>
+              <a:t>Sources: project results and research context. Hypothetical extensions.</a:t>
             </a:r>
           </a:p>
         </p:txBody>
@@ -6673,7 +6826,7 @@
           <p:cNvPr id="3" name="">
             <a:extLst xmlns:a="http://schemas.openxmlformats.org/drawingml/2006/main">
               <a:ext uri="{FF2B5EF4-FFF2-40B4-BE49-F238E27FC236}">
-                <a16:creationId xmlns:a16="http://schemas.microsoft.com/office/drawing/2014/main" id="{838AC7F4-3E36-4E59-9709-5DDD91AE5E22}"/>
+                <a16:creationId xmlns:a16="http://schemas.microsoft.com/office/drawing/2014/main" id="{37B6BE33-4A8D-4E3B-9333-E60D6857CC35}"/>
               </a:ext>
             </a:extLst>
           </p:cNvPr>
@@ -6730,7 +6883,7 @@
           <p:cNvPr id="4" name="">
             <a:extLst xmlns:a="http://schemas.openxmlformats.org/drawingml/2006/main">
               <a:ext uri="{FF2B5EF4-FFF2-40B4-BE49-F238E27FC236}">
-                <a16:creationId xmlns:a16="http://schemas.microsoft.com/office/drawing/2014/main" id="{67233FF5-93C0-4DB6-9253-5CB39A8BE121}"/>
+                <a16:creationId xmlns:a16="http://schemas.microsoft.com/office/drawing/2014/main" id="{E35144E4-F508-4F88-9DC8-6523273B8367}"/>
               </a:ext>
             </a:extLst>
           </p:cNvPr>
@@ -6741,8 +6894,8 @@
         </p:nvSpPr>
         <p:spPr>
           <a:xfrm xmlns:a="http://schemas.openxmlformats.org/drawingml/2006/main">
-            <a:off x="609600" y="1590675"/>
-            <a:ext cx="10972800" cy="809625"/>
+            <a:off x="609600" y="1600200"/>
+            <a:ext cx="10972800" cy="647700"/>
           </a:xfrm>
           <a:prstGeom xmlns:a="http://schemas.openxmlformats.org/drawingml/2006/main" prst="rect">
             <a:avLst/>
@@ -6753,19 +6906,15 @@
           </a:ln>
         </p:spPr>
         <p:txBody>
-          <a:bodyPr xmlns:a="http://schemas.openxmlformats.org/drawingml/2006/main" anchor="t">
+          <a:bodyPr xmlns:a="http://schemas.openxmlformats.org/drawingml/2006/main" anchor="ctr">
             <a:noAutofit/>
           </a:bodyPr>
           <a:lstStyle xmlns:a="http://schemas.openxmlformats.org/drawingml/2006/main"/>
           <a:p xmlns:a="http://schemas.openxmlformats.org/drawingml/2006/main">
-            <a:pPr marL="279400" indent="-152400" algn="l">
-              <a:spcAft>
-                <a:spcPts val="1200"/>
-              </a:spcAft>
-              <a:buChar char="•"/>
+            <a:pPr algn="l">
               <a:defRPr sz="2400" b="0">
                 <a:solidFill>
-                  <a:srgbClr val="16343E"/>
+                  <a:srgbClr val="007C78"/>
                 </a:solidFill>
                 <a:latin typeface="Arial"/>
                 <a:ea typeface="Arial"/>
@@ -6775,13 +6924,13 @@
             <a:r>
               <a:rPr sz="2400" b="0">
                 <a:solidFill>
-                  <a:srgbClr val="16343E"/>
-                </a:solidFill>
-                <a:latin typeface="Arial"/>
-                <a:ea typeface="Arial"/>
-                <a:cs typeface="Arial"/>
-              </a:rPr>
-              <a:t>This project establishes classification performance in one deposited study.</a:t>
+                  <a:srgbClr val="007C78"/>
+                </a:solidFill>
+                <a:latin typeface="Arial"/>
+                <a:ea typeface="Arial"/>
+                <a:cs typeface="Arial"/>
+              </a:rPr>
+              <a:t>Ideas for extending this personal project</a:t>
             </a:r>
           </a:p>
         </p:txBody>
@@ -6793,8 +6942,8 @@
           <p:nvPr/>
         </p:nvGraphicFramePr>
         <p:xfrm>
-          <a:off xmlns:a="http://schemas.openxmlformats.org/drawingml/2006/main" x="609600" y="2571750"/>
-          <a:ext xmlns:a="http://schemas.openxmlformats.org/drawingml/2006/main" cx="10972800" cy="3048000"/>
+          <a:off xmlns:a="http://schemas.openxmlformats.org/drawingml/2006/main" x="609600" y="2486025"/>
+          <a:ext xmlns:a="http://schemas.openxmlformats.org/drawingml/2006/main" cx="10972800" cy="3333750"/>
         </p:xfrm>
         <a:graphic xmlns:a="http://schemas.openxmlformats.org/drawingml/2006/main">
           <a:graphicData uri="http://schemas.openxmlformats.org/drawingml/2006/table">
@@ -6847,7 +6996,7 @@
                           <a:ea typeface="Arial"/>
                           <a:cs typeface="Arial"/>
                         </a:rPr>
-                        <a:t>Proposed evaluation</a:t>
+                        <a:t>Possible approach</a:t>
                       </a:r>
                     </a:p>
                   </a:txBody>
@@ -6858,7 +7007,7 @@
                   </a:tcPr>
                 </a:tc>
               </a:tr>
-              <a:tr h="1333500">
+              <a:tr h="1409700">
                 <a:tc>
                   <a:txBody>
                     <a:bodyPr>
@@ -6875,7 +7024,7 @@
                           <a:ea typeface="Arial"/>
                           <a:cs typeface="Arial"/>
                         </a:rPr>
-                        <a:t>Does performance hold in a new study?</a:t>
+                        <a:t>Would the results hold in another dataset?</a:t>
                       </a:r>
                     </a:p>
                   </a:txBody>
@@ -6901,7 +7050,7 @@
                           <a:ea typeface="Arial"/>
                           <a:cs typeface="Arial"/>
                         </a:rPr>
-                        <a:t>New transplant biopsies with patient and center IDs and lab quality records.</a:t>
+                        <a:t>Test the saved models and thresholds on new transplant biopsies.</a:t>
                       </a:r>
                     </a:p>
                     <a:p>
@@ -6914,7 +7063,7 @@
                           <a:ea typeface="Arial"/>
                           <a:cs typeface="Arial"/>
                         </a:rPr>
-                        <a:t>Use the chosen models and thresholds.</a:t>
+                        <a:t>Record patient, center and lab quality information.</a:t>
                       </a:r>
                     </a:p>
                   </a:txBody>
@@ -6925,7 +7074,7 @@
                   </a:tcPr>
                 </a:tc>
               </a:tr>
-              <a:tr h="1200150">
+              <a:tr h="1409700">
                 <a:tc>
                   <a:txBody>
                     <a:bodyPr>
@@ -6942,7 +7091,7 @@
                           <a:ea typeface="Arial"/>
                           <a:cs typeface="Arial"/>
                         </a:rPr>
-                        <a:t>Does the score help with ambiguous biopsies?</a:t>
+                        <a:t>Would RNA help with uncertain biopsies?</a:t>
                       </a:r>
                     </a:p>
                   </a:txBody>
@@ -6968,7 +7117,7 @@
                           <a:ea typeface="Arial"/>
                           <a:cs typeface="Arial"/>
                         </a:rPr>
-                        <a:t>Compare usual assessment with and without the molecular score.</a:t>
+                        <a:t>With clinical collaborators, compare assessment with and without the RNA score.</a:t>
                       </a:r>
                     </a:p>
                     <a:p>
@@ -6981,7 +7130,7 @@
                           <a:ea typeface="Arial"/>
                           <a:cs typeface="Arial"/>
                         </a:rPr>
-                        <a:t>Use independent review and follow-up outcomes.</a:t>
+                        <a:t>Review decisions and follow-up outcomes.</a:t>
                       </a:r>
                     </a:p>
                   </a:txBody>
@@ -6999,7 +7148,7 @@
     </p:spTree>
     <p:extLst>
       <p:ext uri="{BB962C8B-B14F-4D97-AF65-F5344CB8AC3E}">
-        <p14:creationId xmlns:p14="http://schemas.microsoft.com/office/powerpoint/2010/main" val="2116705782"/>
+        <p14:creationId xmlns:p14="http://schemas.microsoft.com/office/powerpoint/2010/main" val="276349190"/>
       </p:ext>
     </p:extLst>
   </p:cSld>
@@ -7027,10 +7176,10 @@
       </p:grpSpPr>
       <p:sp>
         <p:nvSpPr>
-          <p:cNvPr id="7" name="">
+          <p:cNvPr id="14" name="">
             <a:extLst xmlns:a="http://schemas.openxmlformats.org/drawingml/2006/main">
               <a:ext uri="{FF2B5EF4-FFF2-40B4-BE49-F238E27FC236}">
-                <a16:creationId xmlns:a16="http://schemas.microsoft.com/office/drawing/2014/main" id="{FEE2714F-C655-4940-9BFB-75345AB5C814}"/>
+                <a16:creationId xmlns:a16="http://schemas.microsoft.com/office/drawing/2014/main" id="{A827F13D-E296-487E-BC3D-BEC1C5FEF432}"/>
               </a:ext>
             </a:extLst>
           </p:cNvPr>
@@ -7077,7 +7226,7 @@
                 <a:ea typeface="Arial"/>
                 <a:cs typeface="Arial"/>
               </a:rPr>
-              <a:t>Molecular counts can classify recorded rejection</a:t>
+              <a:t>What this project accomplished</a:t>
             </a:r>
           </a:p>
         </p:txBody>
@@ -7087,7 +7236,7 @@
           <p:cNvPr id="2" name="">
             <a:extLst xmlns:a="http://schemas.openxmlformats.org/drawingml/2006/main">
               <a:ext uri="{FF2B5EF4-FFF2-40B4-BE49-F238E27FC236}">
-                <a16:creationId xmlns:a16="http://schemas.microsoft.com/office/drawing/2014/main" id="{4F3D158F-3C06-434E-BB3A-521F6341E23B}"/>
+                <a16:creationId xmlns:a16="http://schemas.microsoft.com/office/drawing/2014/main" id="{1384811A-BC5B-4994-B1FB-840C52CEB48F}"/>
               </a:ext>
             </a:extLst>
           </p:cNvPr>
@@ -7144,7 +7293,7 @@
           <p:cNvPr id="3" name="">
             <a:extLst xmlns:a="http://schemas.openxmlformats.org/drawingml/2006/main">
               <a:ext uri="{FF2B5EF4-FFF2-40B4-BE49-F238E27FC236}">
-                <a16:creationId xmlns:a16="http://schemas.microsoft.com/office/drawing/2014/main" id="{E98FB051-C36F-48E2-959C-1D3B2B17668A}"/>
+                <a16:creationId xmlns:a16="http://schemas.microsoft.com/office/drawing/2014/main" id="{48A84633-E373-4173-B48C-6EDC81AC86E7}"/>
               </a:ext>
             </a:extLst>
           </p:cNvPr>
@@ -7201,7 +7350,7 @@
           <p:cNvPr id="4" name="">
             <a:extLst xmlns:a="http://schemas.openxmlformats.org/drawingml/2006/main">
               <a:ext uri="{FF2B5EF4-FFF2-40B4-BE49-F238E27FC236}">
-                <a16:creationId xmlns:a16="http://schemas.microsoft.com/office/drawing/2014/main" id="{DA8B6391-D3E1-4A78-95B0-14E6A65864A3}"/>
+                <a16:creationId xmlns:a16="http://schemas.microsoft.com/office/drawing/2014/main" id="{3CA30DF5-DED2-491F-9227-8927EF66229C}"/>
               </a:ext>
             </a:extLst>
           </p:cNvPr>
@@ -7212,7 +7361,7 @@
         </p:nvSpPr>
         <p:spPr>
           <a:xfrm xmlns:a="http://schemas.openxmlformats.org/drawingml/2006/main">
-            <a:off x="609600" y="1628775"/>
+            <a:off x="609600" y="1533525"/>
             <a:ext cx="10972800" cy="409575"/>
           </a:xfrm>
           <a:prstGeom xmlns:a="http://schemas.openxmlformats.org/drawingml/2006/main" prst="rect">
@@ -7230,7 +7379,7 @@
           <a:lstStyle xmlns:a="http://schemas.openxmlformats.org/drawingml/2006/main"/>
           <a:p xmlns:a="http://schemas.openxmlformats.org/drawingml/2006/main">
             <a:pPr algn="l">
-              <a:defRPr sz="2325" b="0">
+              <a:defRPr sz="2400" b="1">
                 <a:solidFill>
                   <a:srgbClr val="FFFFFF"/>
                 </a:solidFill>
@@ -7240,7 +7389,7 @@
               </a:defRPr>
             </a:pPr>
             <a:r>
-              <a:rPr sz="2325" b="0">
+              <a:rPr sz="2400" b="1">
                 <a:solidFill>
                   <a:srgbClr val="FFFFFF"/>
                 </a:solidFill>
@@ -7248,7 +7397,7 @@
                 <a:ea typeface="Arial"/>
                 <a:cs typeface="Arial"/>
               </a:rPr>
-              <a:t>CatBoost, 345 evaluation specimens</a:t>
+              <a:t>Model comparison</a:t>
             </a:r>
           </a:p>
         </p:txBody>
@@ -7258,7 +7407,7 @@
           <p:cNvPr id="5" name="">
             <a:extLst xmlns:a="http://schemas.openxmlformats.org/drawingml/2006/main">
               <a:ext uri="{FF2B5EF4-FFF2-40B4-BE49-F238E27FC236}">
-                <a16:creationId xmlns:a16="http://schemas.microsoft.com/office/drawing/2014/main" id="{DA3A90B5-EBA9-464B-B7F7-E552A905F3CE}"/>
+                <a16:creationId xmlns:a16="http://schemas.microsoft.com/office/drawing/2014/main" id="{CCD479A6-5E91-4058-8A49-88481CE0D1F3}"/>
               </a:ext>
             </a:extLst>
           </p:cNvPr>
@@ -7269,8 +7418,8 @@
         </p:nvSpPr>
         <p:spPr>
           <a:xfrm xmlns:a="http://schemas.openxmlformats.org/drawingml/2006/main">
-            <a:off x="609600" y="2085975"/>
-            <a:ext cx="10972800" cy="800100"/>
+            <a:off x="609600" y="1971675"/>
+            <a:ext cx="10972800" cy="381000"/>
           </a:xfrm>
           <a:prstGeom xmlns:a="http://schemas.openxmlformats.org/drawingml/2006/main" prst="rect">
             <a:avLst/>
@@ -7287,7 +7436,7 @@
           <a:lstStyle xmlns:a="http://schemas.openxmlformats.org/drawingml/2006/main"/>
           <a:p xmlns:a="http://schemas.openxmlformats.org/drawingml/2006/main">
             <a:pPr algn="l">
-              <a:defRPr sz="4200" b="1">
+              <a:defRPr sz="2100" b="0">
                 <a:solidFill>
                   <a:srgbClr val="FFFFFF"/>
                 </a:solidFill>
@@ -7297,7 +7446,7 @@
               </a:defRPr>
             </a:pPr>
             <a:r>
-              <a:rPr sz="4200" b="1">
+              <a:rPr sz="2100" b="0">
                 <a:solidFill>
                   <a:srgbClr val="FFFFFF"/>
                 </a:solidFill>
@@ -7305,7 +7454,7 @@
                 <a:ea typeface="Arial"/>
                 <a:cs typeface="Arial"/>
               </a:rPr>
-              <a:t>25 / 169 misses. 8 / 176 false flags.</a:t>
+              <a:t>CatBoost, 345 evaluation specimens</a:t>
             </a:r>
           </a:p>
         </p:txBody>
@@ -7315,7 +7464,7 @@
           <p:cNvPr id="6" name="">
             <a:extLst xmlns:a="http://schemas.openxmlformats.org/drawingml/2006/main">
               <a:ext uri="{FF2B5EF4-FFF2-40B4-BE49-F238E27FC236}">
-                <a16:creationId xmlns:a16="http://schemas.microsoft.com/office/drawing/2014/main" id="{AB0CB923-9247-45C2-ADC7-AFC0737D3EC8}"/>
+                <a16:creationId xmlns:a16="http://schemas.microsoft.com/office/drawing/2014/main" id="{0B4058D1-3828-49FA-916D-A0509C1C2482}"/>
               </a:ext>
             </a:extLst>
           </p:cNvPr>
@@ -7326,8 +7475,402 @@
         </p:nvSpPr>
         <p:spPr>
           <a:xfrm xmlns:a="http://schemas.openxmlformats.org/drawingml/2006/main">
-            <a:off x="609600" y="3381375"/>
-            <a:ext cx="10972800" cy="2428875"/>
+            <a:off x="609600" y="2390775"/>
+            <a:ext cx="5162550" cy="590550"/>
+          </a:xfrm>
+          <a:prstGeom xmlns:a="http://schemas.openxmlformats.org/drawingml/2006/main" prst="rect">
+            <a:avLst/>
+          </a:prstGeom>
+          <a:noFill xmlns:a="http://schemas.openxmlformats.org/drawingml/2006/main"/>
+          <a:ln xmlns:a="http://schemas.openxmlformats.org/drawingml/2006/main" w="0">
+            <a:noFill/>
+          </a:ln>
+        </p:spPr>
+        <p:txBody>
+          <a:bodyPr xmlns:a="http://schemas.openxmlformats.org/drawingml/2006/main" anchor="ctr">
+            <a:noAutofit/>
+          </a:bodyPr>
+          <a:lstStyle xmlns:a="http://schemas.openxmlformats.org/drawingml/2006/main"/>
+          <a:p xmlns:a="http://schemas.openxmlformats.org/drawingml/2006/main">
+            <a:pPr algn="l">
+              <a:defRPr sz="3525" b="1">
+                <a:solidFill>
+                  <a:srgbClr val="FFFFFF"/>
+                </a:solidFill>
+                <a:latin typeface="Arial"/>
+                <a:ea typeface="Arial"/>
+                <a:cs typeface="Arial"/>
+              </a:defRPr>
+            </a:pPr>
+            <a:r>
+              <a:rPr sz="3525" b="1">
+                <a:solidFill>
+                  <a:srgbClr val="FFFFFF"/>
+                </a:solidFill>
+                <a:latin typeface="Arial"/>
+                <a:ea typeface="Arial"/>
+                <a:cs typeface="Arial"/>
+              </a:rPr>
+              <a:t>14.8% missed</a:t>
+            </a:r>
+          </a:p>
+        </p:txBody>
+      </p:sp>
+      <p:sp>
+        <p:nvSpPr>
+          <p:cNvPr id="7" name="">
+            <a:extLst xmlns:a="http://schemas.openxmlformats.org/drawingml/2006/main">
+              <a:ext uri="{FF2B5EF4-FFF2-40B4-BE49-F238E27FC236}">
+                <a16:creationId xmlns:a16="http://schemas.microsoft.com/office/drawing/2014/main" id="{B145E8F5-53D5-4E6F-9760-A59DF66AB278}"/>
+              </a:ext>
+            </a:extLst>
+          </p:cNvPr>
+          <p:cNvSpPr>
+            <a:spLocks xmlns:a="http://schemas.openxmlformats.org/drawingml/2006/main" noGrp="1"/>
+          </p:cNvSpPr>
+          <p:nvPr/>
+        </p:nvSpPr>
+        <p:spPr>
+          <a:xfrm xmlns:a="http://schemas.openxmlformats.org/drawingml/2006/main">
+            <a:off x="6343650" y="2390775"/>
+            <a:ext cx="5238750" cy="590550"/>
+          </a:xfrm>
+          <a:prstGeom xmlns:a="http://schemas.openxmlformats.org/drawingml/2006/main" prst="rect">
+            <a:avLst/>
+          </a:prstGeom>
+          <a:noFill xmlns:a="http://schemas.openxmlformats.org/drawingml/2006/main"/>
+          <a:ln xmlns:a="http://schemas.openxmlformats.org/drawingml/2006/main" w="0">
+            <a:noFill/>
+          </a:ln>
+        </p:spPr>
+        <p:txBody>
+          <a:bodyPr xmlns:a="http://schemas.openxmlformats.org/drawingml/2006/main" anchor="ctr">
+            <a:noAutofit/>
+          </a:bodyPr>
+          <a:lstStyle xmlns:a="http://schemas.openxmlformats.org/drawingml/2006/main"/>
+          <a:p xmlns:a="http://schemas.openxmlformats.org/drawingml/2006/main">
+            <a:pPr algn="l">
+              <a:defRPr sz="3525" b="1">
+                <a:solidFill>
+                  <a:srgbClr val="FFFFFF"/>
+                </a:solidFill>
+                <a:latin typeface="Arial"/>
+                <a:ea typeface="Arial"/>
+                <a:cs typeface="Arial"/>
+              </a:defRPr>
+            </a:pPr>
+            <a:r>
+              <a:rPr sz="3525" b="1">
+                <a:solidFill>
+                  <a:srgbClr val="FFFFFF"/>
+                </a:solidFill>
+                <a:latin typeface="Arial"/>
+                <a:ea typeface="Arial"/>
+                <a:cs typeface="Arial"/>
+              </a:rPr>
+              <a:t>4.5% false flags</a:t>
+            </a:r>
+          </a:p>
+        </p:txBody>
+      </p:sp>
+      <p:sp>
+        <p:nvSpPr>
+          <p:cNvPr id="8" name="">
+            <a:extLst xmlns:a="http://schemas.openxmlformats.org/drawingml/2006/main">
+              <a:ext uri="{FF2B5EF4-FFF2-40B4-BE49-F238E27FC236}">
+                <a16:creationId xmlns:a16="http://schemas.microsoft.com/office/drawing/2014/main" id="{67571658-5BD9-487A-9E6C-8661BE54E4FB}"/>
+              </a:ext>
+            </a:extLst>
+          </p:cNvPr>
+          <p:cNvSpPr>
+            <a:spLocks xmlns:a="http://schemas.openxmlformats.org/drawingml/2006/main" noGrp="1"/>
+          </p:cNvSpPr>
+          <p:nvPr/>
+        </p:nvSpPr>
+        <p:spPr>
+          <a:xfrm xmlns:a="http://schemas.openxmlformats.org/drawingml/2006/main">
+            <a:off x="609600" y="3048000"/>
+            <a:ext cx="5162550" cy="400050"/>
+          </a:xfrm>
+          <a:prstGeom xmlns:a="http://schemas.openxmlformats.org/drawingml/2006/main" prst="rect">
+            <a:avLst/>
+          </a:prstGeom>
+          <a:noFill xmlns:a="http://schemas.openxmlformats.org/drawingml/2006/main"/>
+          <a:ln xmlns:a="http://schemas.openxmlformats.org/drawingml/2006/main" w="0">
+            <a:noFill/>
+          </a:ln>
+        </p:spPr>
+        <p:txBody>
+          <a:bodyPr xmlns:a="http://schemas.openxmlformats.org/drawingml/2006/main" anchor="ctr">
+            <a:noAutofit/>
+          </a:bodyPr>
+          <a:lstStyle xmlns:a="http://schemas.openxmlformats.org/drawingml/2006/main"/>
+          <a:p xmlns:a="http://schemas.openxmlformats.org/drawingml/2006/main">
+            <a:pPr algn="l">
+              <a:defRPr sz="1875" b="0">
+                <a:solidFill>
+                  <a:srgbClr val="FFFFFF"/>
+                </a:solidFill>
+                <a:latin typeface="Arial"/>
+                <a:ea typeface="Arial"/>
+                <a:cs typeface="Arial"/>
+              </a:defRPr>
+            </a:pPr>
+            <a:r>
+              <a:rPr sz="1875" b="0">
+                <a:solidFill>
+                  <a:srgbClr val="FFFFFF"/>
+                </a:solidFill>
+                <a:latin typeface="Arial"/>
+                <a:ea typeface="Arial"/>
+                <a:cs typeface="Arial"/>
+              </a:rPr>
+              <a:t>25 of 169 recorded rejection specimens</a:t>
+            </a:r>
+          </a:p>
+        </p:txBody>
+      </p:sp>
+      <p:sp>
+        <p:nvSpPr>
+          <p:cNvPr id="9" name="">
+            <a:extLst xmlns:a="http://schemas.openxmlformats.org/drawingml/2006/main">
+              <a:ext uri="{FF2B5EF4-FFF2-40B4-BE49-F238E27FC236}">
+                <a16:creationId xmlns:a16="http://schemas.microsoft.com/office/drawing/2014/main" id="{A0E739F1-1484-4F98-BD00-C3599D74D9CE}"/>
+              </a:ext>
+            </a:extLst>
+          </p:cNvPr>
+          <p:cNvSpPr>
+            <a:spLocks xmlns:a="http://schemas.openxmlformats.org/drawingml/2006/main" noGrp="1"/>
+          </p:cNvSpPr>
+          <p:nvPr/>
+        </p:nvSpPr>
+        <p:spPr>
+          <a:xfrm xmlns:a="http://schemas.openxmlformats.org/drawingml/2006/main">
+            <a:off x="6343650" y="3048000"/>
+            <a:ext cx="5238750" cy="400050"/>
+          </a:xfrm>
+          <a:prstGeom xmlns:a="http://schemas.openxmlformats.org/drawingml/2006/main" prst="rect">
+            <a:avLst/>
+          </a:prstGeom>
+          <a:noFill xmlns:a="http://schemas.openxmlformats.org/drawingml/2006/main"/>
+          <a:ln xmlns:a="http://schemas.openxmlformats.org/drawingml/2006/main" w="0">
+            <a:noFill/>
+          </a:ln>
+        </p:spPr>
+        <p:txBody>
+          <a:bodyPr xmlns:a="http://schemas.openxmlformats.org/drawingml/2006/main" anchor="ctr">
+            <a:noAutofit/>
+          </a:bodyPr>
+          <a:lstStyle xmlns:a="http://schemas.openxmlformats.org/drawingml/2006/main"/>
+          <a:p xmlns:a="http://schemas.openxmlformats.org/drawingml/2006/main">
+            <a:pPr algn="l">
+              <a:defRPr sz="1875" b="0">
+                <a:solidFill>
+                  <a:srgbClr val="FFFFFF"/>
+                </a:solidFill>
+                <a:latin typeface="Arial"/>
+                <a:ea typeface="Arial"/>
+                <a:cs typeface="Arial"/>
+              </a:defRPr>
+            </a:pPr>
+            <a:r>
+              <a:rPr sz="1875" b="0">
+                <a:solidFill>
+                  <a:srgbClr val="FFFFFF"/>
+                </a:solidFill>
+                <a:latin typeface="Arial"/>
+                <a:ea typeface="Arial"/>
+                <a:cs typeface="Arial"/>
+              </a:rPr>
+              <a:t>8 of 176 recorded no-rejection specimens</a:t>
+            </a:r>
+          </a:p>
+        </p:txBody>
+      </p:sp>
+      <p:sp>
+        <p:nvSpPr>
+          <p:cNvPr id="10" name="">
+            <a:extLst xmlns:a="http://schemas.openxmlformats.org/drawingml/2006/main">
+              <a:ext uri="{FF2B5EF4-FFF2-40B4-BE49-F238E27FC236}">
+                <a16:creationId xmlns:a16="http://schemas.microsoft.com/office/drawing/2014/main" id="{0A4605B1-D513-47FD-BAEF-BA3D11FDE62E}"/>
+              </a:ext>
+            </a:extLst>
+          </p:cNvPr>
+          <p:cNvSpPr>
+            <a:spLocks xmlns:a="http://schemas.openxmlformats.org/drawingml/2006/main" noGrp="1"/>
+          </p:cNvSpPr>
+          <p:nvPr/>
+        </p:nvSpPr>
+        <p:spPr>
+          <a:xfrm xmlns:a="http://schemas.openxmlformats.org/drawingml/2006/main">
+            <a:off x="609600" y="3552825"/>
+            <a:ext cx="10972800" cy="723900"/>
+          </a:xfrm>
+          <a:prstGeom xmlns:a="http://schemas.openxmlformats.org/drawingml/2006/main" prst="rect">
+            <a:avLst/>
+          </a:prstGeom>
+          <a:noFill xmlns:a="http://schemas.openxmlformats.org/drawingml/2006/main"/>
+          <a:ln xmlns:a="http://schemas.openxmlformats.org/drawingml/2006/main" w="0">
+            <a:noFill/>
+          </a:ln>
+        </p:spPr>
+        <p:txBody>
+          <a:bodyPr xmlns:a="http://schemas.openxmlformats.org/drawingml/2006/main" anchor="ctr">
+            <a:noAutofit/>
+          </a:bodyPr>
+          <a:lstStyle xmlns:a="http://schemas.openxmlformats.org/drawingml/2006/main"/>
+          <a:p xmlns:a="http://schemas.openxmlformats.org/drawingml/2006/main">
+            <a:pPr algn="l">
+              <a:defRPr sz="2175" b="0">
+                <a:solidFill>
+                  <a:srgbClr val="FFFFFF"/>
+                </a:solidFill>
+                <a:latin typeface="Arial"/>
+                <a:ea typeface="Arial"/>
+                <a:cs typeface="Arial"/>
+              </a:defRPr>
+            </a:pPr>
+            <a:r>
+              <a:rPr sz="2175" b="0">
+                <a:solidFill>
+                  <a:srgbClr val="FFFFFF"/>
+                </a:solidFill>
+                <a:latin typeface="Arial"/>
+                <a:ea typeface="Arial"/>
+                <a:cs typeface="Arial"/>
+              </a:rPr>
+              <a:t>Fewer false flags than IFNG, but more misses.</a:t>
+            </a:r>
+          </a:p>
+          <a:p xmlns:a="http://schemas.openxmlformats.org/drawingml/2006/main">
+            <a:pPr algn="l">
+              <a:defRPr sz="2175" b="0">
+                <a:solidFill>
+                  <a:srgbClr val="FFFFFF"/>
+                </a:solidFill>
+                <a:latin typeface="Arial"/>
+                <a:ea typeface="Arial"/>
+                <a:cs typeface="Arial"/>
+              </a:defRPr>
+            </a:pPr>
+            <a:r>
+              <a:rPr sz="2175" b="0">
+                <a:solidFill>
+                  <a:srgbClr val="FFFFFF"/>
+                </a:solidFill>
+                <a:latin typeface="Arial"/>
+                <a:ea typeface="Arial"/>
+                <a:cs typeface="Arial"/>
+              </a:rPr>
+              <a:t>Advantage over logistic regression remains uncertain.</a:t>
+            </a:r>
+          </a:p>
+        </p:txBody>
+      </p:sp>
+      <p:sp>
+        <p:nvSpPr>
+          <p:cNvPr id="11" name="">
+            <a:extLst xmlns:a="http://schemas.openxmlformats.org/drawingml/2006/main">
+              <a:ext uri="{FF2B5EF4-FFF2-40B4-BE49-F238E27FC236}">
+                <a16:creationId xmlns:a16="http://schemas.microsoft.com/office/drawing/2014/main" id="{AD4EFCD4-72FD-4DA6-A388-C9AF351A6CE8}"/>
+              </a:ext>
+            </a:extLst>
+          </p:cNvPr>
+          <p:cNvSpPr>
+            <a:spLocks xmlns:a="http://schemas.openxmlformats.org/drawingml/2006/main" noGrp="1"/>
+          </p:cNvSpPr>
+          <p:nvPr/>
+        </p:nvSpPr>
+        <p:spPr>
+          <a:xfrm xmlns:a="http://schemas.openxmlformats.org/drawingml/2006/main">
+            <a:off x="609600" y="4476750"/>
+            <a:ext cx="10972800" cy="0"/>
+          </a:xfrm>
+          <a:prstGeom xmlns:a="http://schemas.openxmlformats.org/drawingml/2006/main" prst="line">
+            <a:avLst/>
+          </a:prstGeom>
+          <a:ln xmlns:a="http://schemas.openxmlformats.org/drawingml/2006/main" w="11430">
+            <a:solidFill>
+              <a:srgbClr val="78949B"/>
+            </a:solidFill>
+          </a:ln>
+        </p:spPr>
+      </p:sp>
+      <p:sp>
+        <p:nvSpPr>
+          <p:cNvPr id="12" name="">
+            <a:extLst xmlns:a="http://schemas.openxmlformats.org/drawingml/2006/main">
+              <a:ext uri="{FF2B5EF4-FFF2-40B4-BE49-F238E27FC236}">
+                <a16:creationId xmlns:a16="http://schemas.microsoft.com/office/drawing/2014/main" id="{472D92F0-D623-4A0F-807E-C3A912200E61}"/>
+              </a:ext>
+            </a:extLst>
+          </p:cNvPr>
+          <p:cNvSpPr>
+            <a:spLocks xmlns:a="http://schemas.openxmlformats.org/drawingml/2006/main" noGrp="1"/>
+          </p:cNvSpPr>
+          <p:nvPr/>
+        </p:nvSpPr>
+        <p:spPr>
+          <a:xfrm xmlns:a="http://schemas.openxmlformats.org/drawingml/2006/main">
+            <a:off x="609600" y="4629150"/>
+            <a:ext cx="10972800" cy="409575"/>
+          </a:xfrm>
+          <a:prstGeom xmlns:a="http://schemas.openxmlformats.org/drawingml/2006/main" prst="rect">
+            <a:avLst/>
+          </a:prstGeom>
+          <a:noFill xmlns:a="http://schemas.openxmlformats.org/drawingml/2006/main"/>
+          <a:ln xmlns:a="http://schemas.openxmlformats.org/drawingml/2006/main" w="0">
+            <a:noFill/>
+          </a:ln>
+        </p:spPr>
+        <p:txBody>
+          <a:bodyPr xmlns:a="http://schemas.openxmlformats.org/drawingml/2006/main" anchor="ctr">
+            <a:noAutofit/>
+          </a:bodyPr>
+          <a:lstStyle xmlns:a="http://schemas.openxmlformats.org/drawingml/2006/main"/>
+          <a:p xmlns:a="http://schemas.openxmlformats.org/drawingml/2006/main">
+            <a:pPr algn="l">
+              <a:defRPr sz="2400" b="1">
+                <a:solidFill>
+                  <a:srgbClr val="FFFFFF"/>
+                </a:solidFill>
+                <a:latin typeface="Arial"/>
+                <a:ea typeface="Arial"/>
+                <a:cs typeface="Arial"/>
+              </a:defRPr>
+            </a:pPr>
+            <a:r>
+              <a:rPr sz="2400" b="1">
+                <a:solidFill>
+                  <a:srgbClr val="FFFFFF"/>
+                </a:solidFill>
+                <a:latin typeface="Arial"/>
+                <a:ea typeface="Arial"/>
+                <a:cs typeface="Arial"/>
+              </a:rPr>
+              <a:t>Prediction service and demo</a:t>
+            </a:r>
+          </a:p>
+        </p:txBody>
+      </p:sp>
+      <p:sp>
+        <p:nvSpPr>
+          <p:cNvPr id="13" name="">
+            <a:extLst xmlns:a="http://schemas.openxmlformats.org/drawingml/2006/main">
+              <a:ext uri="{FF2B5EF4-FFF2-40B4-BE49-F238E27FC236}">
+                <a16:creationId xmlns:a16="http://schemas.microsoft.com/office/drawing/2014/main" id="{0ABFBC1F-89BC-4FAA-9380-A59ABE375897}"/>
+              </a:ext>
+            </a:extLst>
+          </p:cNvPr>
+          <p:cNvSpPr>
+            <a:spLocks xmlns:a="http://schemas.openxmlformats.org/drawingml/2006/main" noGrp="1"/>
+          </p:cNvSpPr>
+          <p:nvPr/>
+        </p:nvSpPr>
+        <p:spPr>
+          <a:xfrm xmlns:a="http://schemas.openxmlformats.org/drawingml/2006/main">
+            <a:off x="609600" y="5181600"/>
+            <a:ext cx="10972800" cy="838200"/>
           </a:xfrm>
           <a:prstGeom xmlns:a="http://schemas.openxmlformats.org/drawingml/2006/main" prst="rect">
             <a:avLst/>
@@ -7345,10 +7888,10 @@
           <a:p xmlns:a="http://schemas.openxmlformats.org/drawingml/2006/main">
             <a:pPr marL="279400" indent="-152400" algn="l">
               <a:spcAft>
-                <a:spcPts val="2500"/>
+                <a:spcPts val="1000"/>
               </a:spcAft>
               <a:buChar char="•"/>
-              <a:defRPr sz="2550" b="0">
+              <a:defRPr sz="2175" b="0">
                 <a:solidFill>
                   <a:srgbClr val="FFFFFF"/>
                 </a:solidFill>
@@ -7358,7 +7901,7 @@
               </a:defRPr>
             </a:pPr>
             <a:r>
-              <a:rPr sz="2550" b="0">
+              <a:rPr sz="2175" b="0">
                 <a:solidFill>
                   <a:srgbClr val="FFFFFF"/>
                 </a:solidFill>
@@ -7366,16 +7909,16 @@
                 <a:ea typeface="Arial"/>
                 <a:cs typeface="Arial"/>
               </a:rPr>
-              <a:t>Logistic regression remains a credible simpler alternative.</a:t>
+              <a:t>Shared preparation code reproduced all 345 saved scores.</a:t>
             </a:r>
           </a:p>
           <a:p xmlns:a="http://schemas.openxmlformats.org/drawingml/2006/main">
             <a:pPr marL="279400" indent="-152400" algn="l">
               <a:spcAft>
-                <a:spcPts val="2500"/>
+                <a:spcPts val="1000"/>
               </a:spcAft>
               <a:buChar char="•"/>
-              <a:defRPr sz="2550" b="0">
+              <a:defRPr sz="2175" b="0">
                 <a:solidFill>
                   <a:srgbClr val="FFFFFF"/>
                 </a:solidFill>
@@ -7385,7 +7928,7 @@
               </a:defRPr>
             </a:pPr>
             <a:r>
-              <a:rPr sz="2550" b="0">
+              <a:rPr sz="2175" b="0">
                 <a:solidFill>
                   <a:srgbClr val="FFFFFF"/>
                 </a:solidFill>
@@ -7393,34 +7936,7 @@
                 <a:ea typeface="Arial"/>
                 <a:cs typeface="Arial"/>
               </a:rPr>
-              <a:t>The project provides a reproducible classifier and a tested prediction service.</a:t>
-            </a:r>
-          </a:p>
-          <a:p xmlns:a="http://schemas.openxmlformats.org/drawingml/2006/main">
-            <a:pPr marL="279400" indent="-152400" algn="l">
-              <a:spcAft>
-                <a:spcPts val="2500"/>
-              </a:spcAft>
-              <a:buChar char="•"/>
-              <a:defRPr sz="2550" b="0">
-                <a:solidFill>
-                  <a:srgbClr val="FFFFFF"/>
-                </a:solidFill>
-                <a:latin typeface="Arial"/>
-                <a:ea typeface="Arial"/>
-                <a:cs typeface="Arial"/>
-              </a:defRPr>
-            </a:pPr>
-            <a:r>
-              <a:rPr sz="2550" b="0">
-                <a:solidFill>
-                  <a:srgbClr val="FFFFFF"/>
-                </a:solidFill>
-                <a:latin typeface="Arial"/>
-                <a:ea typeface="Arial"/>
-                <a:cs typeface="Arial"/>
-              </a:rPr>
-              <a:t>Next: test added value in ambiguous biopsies in a new study.</a:t>
+              <a:t>Working demo with valid input and clear error messages.</a:t>
             </a:r>
           </a:p>
         </p:txBody>
@@ -7428,7 +7944,7 @@
     </p:spTree>
     <p:extLst>
       <p:ext uri="{BB962C8B-B14F-4D97-AF65-F5344CB8AC3E}">
-        <p14:creationId xmlns:p14="http://schemas.microsoft.com/office/powerpoint/2010/main" val="454130606"/>
+        <p14:creationId xmlns:p14="http://schemas.microsoft.com/office/powerpoint/2010/main" val="675679110"/>
       </p:ext>
     </p:extLst>
   </p:cSld>
@@ -7459,7 +7975,7 @@
           <p:cNvPr id="8" name="">
             <a:extLst xmlns:a="http://schemas.openxmlformats.org/drawingml/2006/main">
               <a:ext uri="{FF2B5EF4-FFF2-40B4-BE49-F238E27FC236}">
-                <a16:creationId xmlns:a16="http://schemas.microsoft.com/office/drawing/2014/main" id="{CEF9ABC7-FFB1-4472-A6DB-28B9FC794285}"/>
+                <a16:creationId xmlns:a16="http://schemas.microsoft.com/office/drawing/2014/main" id="{69BD640E-4046-47B9-A30F-1F7F77ED9C0C}"/>
               </a:ext>
             </a:extLst>
           </p:cNvPr>
@@ -7516,7 +8032,7 @@
           <p:cNvPr id="2" name="">
             <a:extLst xmlns:a="http://schemas.openxmlformats.org/drawingml/2006/main">
               <a:ext uri="{FF2B5EF4-FFF2-40B4-BE49-F238E27FC236}">
-                <a16:creationId xmlns:a16="http://schemas.microsoft.com/office/drawing/2014/main" id="{3671BE4E-D284-49C3-87B3-AC4DA2D8504D}"/>
+                <a16:creationId xmlns:a16="http://schemas.microsoft.com/office/drawing/2014/main" id="{03B5B35D-D0B5-4DA6-B7D3-F4B49472D787}"/>
               </a:ext>
             </a:extLst>
           </p:cNvPr>
@@ -7573,7 +8089,7 @@
           <p:cNvPr id="3" name="">
             <a:extLst xmlns:a="http://schemas.openxmlformats.org/drawingml/2006/main">
               <a:ext uri="{FF2B5EF4-FFF2-40B4-BE49-F238E27FC236}">
-                <a16:creationId xmlns:a16="http://schemas.microsoft.com/office/drawing/2014/main" id="{E38B796D-BD2F-4DEC-A8FC-637296B5EAFB}"/>
+                <a16:creationId xmlns:a16="http://schemas.microsoft.com/office/drawing/2014/main" id="{2D8515F9-FF7F-41D5-8F04-6AF42F14EFDA}"/>
               </a:ext>
             </a:extLst>
           </p:cNvPr>
@@ -7630,7 +8146,7 @@
           <p:cNvPr id="4" name="">
             <a:extLst xmlns:a="http://schemas.openxmlformats.org/drawingml/2006/main">
               <a:ext uri="{FF2B5EF4-FFF2-40B4-BE49-F238E27FC236}">
-                <a16:creationId xmlns:a16="http://schemas.microsoft.com/office/drawing/2014/main" id="{4B48F20C-40E9-4D07-958B-4ABF110971AA}"/>
+                <a16:creationId xmlns:a16="http://schemas.microsoft.com/office/drawing/2014/main" id="{0B7651A8-F593-4D13-8F22-69215C2400E8}"/>
               </a:ext>
             </a:extLst>
           </p:cNvPr>
@@ -7642,7 +8158,7 @@
         <p:spPr>
           <a:xfrm xmlns:a="http://schemas.openxmlformats.org/drawingml/2006/main">
             <a:off x="609600" y="1685925"/>
-            <a:ext cx="10972800" cy="828675"/>
+            <a:ext cx="10972800" cy="571500"/>
           </a:xfrm>
           <a:prstGeom xmlns:a="http://schemas.openxmlformats.org/drawingml/2006/main" prst="rect">
             <a:avLst/>
@@ -7687,7 +8203,7 @@
           <p:cNvPr id="5" name="">
             <a:extLst xmlns:a="http://schemas.openxmlformats.org/drawingml/2006/main">
               <a:ext uri="{FF2B5EF4-FFF2-40B4-BE49-F238E27FC236}">
-                <a16:creationId xmlns:a16="http://schemas.microsoft.com/office/drawing/2014/main" id="{CF9E59C5-AA62-4CA0-BFE6-E1DFA57FFD89}"/>
+                <a16:creationId xmlns:a16="http://schemas.microsoft.com/office/drawing/2014/main" id="{EB6F2983-BE7D-44BE-899E-133A6C7FE6BA}"/>
               </a:ext>
             </a:extLst>
           </p:cNvPr>
@@ -7698,8 +8214,8 @@
         </p:nvSpPr>
         <p:spPr>
           <a:xfrm xmlns:a="http://schemas.openxmlformats.org/drawingml/2006/main">
-            <a:off x="609600" y="2819400"/>
-            <a:ext cx="10972800" cy="838200"/>
+            <a:off x="609600" y="2447925"/>
+            <a:ext cx="10972800" cy="885825"/>
           </a:xfrm>
           <a:prstGeom xmlns:a="http://schemas.openxmlformats.org/drawingml/2006/main" prst="rect">
             <a:avLst/>
@@ -7744,7 +8260,7 @@
           <p:cNvPr id="6" name="">
             <a:extLst xmlns:a="http://schemas.openxmlformats.org/drawingml/2006/main">
               <a:ext uri="{FF2B5EF4-FFF2-40B4-BE49-F238E27FC236}">
-                <a16:creationId xmlns:a16="http://schemas.microsoft.com/office/drawing/2014/main" id="{19A24AED-FF2E-4A0B-B850-16F795FBD124}"/>
+                <a16:creationId xmlns:a16="http://schemas.microsoft.com/office/drawing/2014/main" id="{C5D5123F-C7D6-4E33-BB8E-14AC88BDAC32}"/>
               </a:ext>
             </a:extLst>
           </p:cNvPr>
@@ -7755,7 +8271,7 @@
         </p:nvSpPr>
         <p:spPr>
           <a:xfrm xmlns:a="http://schemas.openxmlformats.org/drawingml/2006/main">
-            <a:off x="1057275" y="3990975"/>
+            <a:off x="1057275" y="3590925"/>
             <a:ext cx="10525125" cy="876300"/>
           </a:xfrm>
           <a:prstGeom xmlns:a="http://schemas.openxmlformats.org/drawingml/2006/main" prst="rect">
@@ -7801,7 +8317,7 @@
           <p:cNvPr id="7" name="">
             <a:extLst xmlns:a="http://schemas.openxmlformats.org/drawingml/2006/main">
               <a:ext uri="{FF2B5EF4-FFF2-40B4-BE49-F238E27FC236}">
-                <a16:creationId xmlns:a16="http://schemas.microsoft.com/office/drawing/2014/main" id="{32A628D0-EE51-4521-8189-3A89782D2934}"/>
+                <a16:creationId xmlns:a16="http://schemas.microsoft.com/office/drawing/2014/main" id="{47713512-A658-4362-8465-29BF3D3277E2}"/>
               </a:ext>
             </a:extLst>
           </p:cNvPr>
@@ -7812,8 +8328,8 @@
         </p:nvSpPr>
         <p:spPr>
           <a:xfrm xmlns:a="http://schemas.openxmlformats.org/drawingml/2006/main">
-            <a:off x="1057275" y="5219700"/>
-            <a:ext cx="10525125" cy="828675"/>
+            <a:off x="1057275" y="4695825"/>
+            <a:ext cx="10525125" cy="876300"/>
           </a:xfrm>
           <a:prstGeom xmlns:a="http://schemas.openxmlformats.org/drawingml/2006/main" prst="rect">
             <a:avLst/>
@@ -7856,7 +8372,7 @@
     </p:spTree>
     <p:extLst>
       <p:ext uri="{BB962C8B-B14F-4D97-AF65-F5344CB8AC3E}">
-        <p14:creationId xmlns:p14="http://schemas.microsoft.com/office/powerpoint/2010/main" val="1480923889"/>
+        <p14:creationId xmlns:p14="http://schemas.microsoft.com/office/powerpoint/2010/main" val="816631428"/>
       </p:ext>
     </p:extLst>
   </p:cSld>
@@ -7887,7 +8403,7 @@
           <p:cNvPr id="6" name="">
             <a:extLst xmlns:a="http://schemas.openxmlformats.org/drawingml/2006/main">
               <a:ext uri="{FF2B5EF4-FFF2-40B4-BE49-F238E27FC236}">
-                <a16:creationId xmlns:a16="http://schemas.microsoft.com/office/drawing/2014/main" id="{9663A43C-F171-4D9C-BDBE-4A19675229F7}"/>
+                <a16:creationId xmlns:a16="http://schemas.microsoft.com/office/drawing/2014/main" id="{68859C7B-C133-43DB-8406-26833AF44958}"/>
               </a:ext>
             </a:extLst>
           </p:cNvPr>
@@ -7944,7 +8460,7 @@
           <p:cNvPr id="2" name="">
             <a:extLst xmlns:a="http://schemas.openxmlformats.org/drawingml/2006/main">
               <a:ext uri="{FF2B5EF4-FFF2-40B4-BE49-F238E27FC236}">
-                <a16:creationId xmlns:a16="http://schemas.microsoft.com/office/drawing/2014/main" id="{DF195A7F-71B3-4E85-81A9-5E9E65624194}"/>
+                <a16:creationId xmlns:a16="http://schemas.microsoft.com/office/drawing/2014/main" id="{F8B927D5-CDED-4880-A59D-52C0B3C432EC}"/>
               </a:ext>
             </a:extLst>
           </p:cNvPr>
@@ -8001,7 +8517,7 @@
           <p:cNvPr id="3" name="">
             <a:extLst xmlns:a="http://schemas.openxmlformats.org/drawingml/2006/main">
               <a:ext uri="{FF2B5EF4-FFF2-40B4-BE49-F238E27FC236}">
-                <a16:creationId xmlns:a16="http://schemas.microsoft.com/office/drawing/2014/main" id="{372CC687-8C91-424D-857B-737D5BEC4A82}"/>
+                <a16:creationId xmlns:a16="http://schemas.microsoft.com/office/drawing/2014/main" id="{DEDD5821-AF82-46C7-B953-30B99ED17FB4}"/>
               </a:ext>
             </a:extLst>
           </p:cNvPr>
@@ -8058,7 +8574,7 @@
           <p:cNvPr id="4" name="">
             <a:extLst xmlns:a="http://schemas.openxmlformats.org/drawingml/2006/main">
               <a:ext uri="{FF2B5EF4-FFF2-40B4-BE49-F238E27FC236}">
-                <a16:creationId xmlns:a16="http://schemas.microsoft.com/office/drawing/2014/main" id="{61D01FF6-47A7-47B3-84E7-75732BEEEE9E}"/>
+                <a16:creationId xmlns:a16="http://schemas.microsoft.com/office/drawing/2014/main" id="{66E948DC-2B29-4761-8428-46F38E13FF4F}"/>
               </a:ext>
             </a:extLst>
           </p:cNvPr>
@@ -8173,7 +8689,7 @@
           <p:cNvPr id="5" name="">
             <a:extLst xmlns:a="http://schemas.openxmlformats.org/drawingml/2006/main">
               <a:ext uri="{FF2B5EF4-FFF2-40B4-BE49-F238E27FC236}">
-                <a16:creationId xmlns:a16="http://schemas.microsoft.com/office/drawing/2014/main" id="{FA0347ED-5B9D-4C4B-AAA1-F32BCC7677AC}"/>
+                <a16:creationId xmlns:a16="http://schemas.microsoft.com/office/drawing/2014/main" id="{9A4EDB1A-646B-4977-9874-003FEFDC02B5}"/>
               </a:ext>
             </a:extLst>
           </p:cNvPr>
@@ -8228,7 +8744,7 @@
     </p:spTree>
     <p:extLst>
       <p:ext uri="{BB962C8B-B14F-4D97-AF65-F5344CB8AC3E}">
-        <p14:creationId xmlns:p14="http://schemas.microsoft.com/office/powerpoint/2010/main" val="30707401"/>
+        <p14:creationId xmlns:p14="http://schemas.microsoft.com/office/powerpoint/2010/main" val="1814137767"/>
       </p:ext>
     </p:extLst>
   </p:cSld>
@@ -8259,7 +8775,7 @@
           <p:cNvPr id="6" name="">
             <a:extLst xmlns:a="http://schemas.openxmlformats.org/drawingml/2006/main">
               <a:ext uri="{FF2B5EF4-FFF2-40B4-BE49-F238E27FC236}">
-                <a16:creationId xmlns:a16="http://schemas.microsoft.com/office/drawing/2014/main" id="{2B785153-A0A4-421A-94C0-B2CAD1D3EC4A}"/>
+                <a16:creationId xmlns:a16="http://schemas.microsoft.com/office/drawing/2014/main" id="{6BF21BDC-B5EA-48C9-ABC5-0329B4E664FE}"/>
               </a:ext>
             </a:extLst>
           </p:cNvPr>
@@ -8316,7 +8832,7 @@
           <p:cNvPr id="2" name="">
             <a:extLst xmlns:a="http://schemas.openxmlformats.org/drawingml/2006/main">
               <a:ext uri="{FF2B5EF4-FFF2-40B4-BE49-F238E27FC236}">
-                <a16:creationId xmlns:a16="http://schemas.microsoft.com/office/drawing/2014/main" id="{6E46A1AA-E30E-4604-A09F-40B49ACC05EF}"/>
+                <a16:creationId xmlns:a16="http://schemas.microsoft.com/office/drawing/2014/main" id="{12632283-4B63-40A1-B3C4-1EF4E7C4CC27}"/>
               </a:ext>
             </a:extLst>
           </p:cNvPr>
@@ -8373,7 +8889,7 @@
           <p:cNvPr id="3" name="">
             <a:extLst xmlns:a="http://schemas.openxmlformats.org/drawingml/2006/main">
               <a:ext uri="{FF2B5EF4-FFF2-40B4-BE49-F238E27FC236}">
-                <a16:creationId xmlns:a16="http://schemas.microsoft.com/office/drawing/2014/main" id="{876FED1E-3EFF-4292-8FE4-C357DBA14042}"/>
+                <a16:creationId xmlns:a16="http://schemas.microsoft.com/office/drawing/2014/main" id="{7D1DCFFB-055C-4FBB-8F8A-F0B0D10F014C}"/>
               </a:ext>
             </a:extLst>
           </p:cNvPr>
@@ -9246,7 +9762,7 @@
           <p:cNvPr id="5" name="">
             <a:extLst xmlns:a="http://schemas.openxmlformats.org/drawingml/2006/main">
               <a:ext uri="{FF2B5EF4-FFF2-40B4-BE49-F238E27FC236}">
-                <a16:creationId xmlns:a16="http://schemas.microsoft.com/office/drawing/2014/main" id="{E98523FA-3791-444F-9067-9350886F8743}"/>
+                <a16:creationId xmlns:a16="http://schemas.microsoft.com/office/drawing/2014/main" id="{78E08BEE-86D8-498D-B03D-5B177B73021F}"/>
               </a:ext>
             </a:extLst>
           </p:cNvPr>
@@ -9301,7 +9817,7 @@
     </p:spTree>
     <p:extLst>
       <p:ext uri="{BB962C8B-B14F-4D97-AF65-F5344CB8AC3E}">
-        <p14:creationId xmlns:p14="http://schemas.microsoft.com/office/powerpoint/2010/main" val="100845625"/>
+        <p14:creationId xmlns:p14="http://schemas.microsoft.com/office/powerpoint/2010/main" val="1002277887"/>
       </p:ext>
     </p:extLst>
   </p:cSld>
@@ -9332,7 +9848,7 @@
           <p:cNvPr id="6" name="">
             <a:extLst xmlns:a="http://schemas.openxmlformats.org/drawingml/2006/main">
               <a:ext uri="{FF2B5EF4-FFF2-40B4-BE49-F238E27FC236}">
-                <a16:creationId xmlns:a16="http://schemas.microsoft.com/office/drawing/2014/main" id="{D962F0E7-BFF3-4807-8F84-BC62BB818099}"/>
+                <a16:creationId xmlns:a16="http://schemas.microsoft.com/office/drawing/2014/main" id="{6CE42A14-EC5A-44A4-9B06-A9F7D555A7BC}"/>
               </a:ext>
             </a:extLst>
           </p:cNvPr>
@@ -9389,7 +9905,7 @@
           <p:cNvPr id="2" name="">
             <a:extLst xmlns:a="http://schemas.openxmlformats.org/drawingml/2006/main">
               <a:ext uri="{FF2B5EF4-FFF2-40B4-BE49-F238E27FC236}">
-                <a16:creationId xmlns:a16="http://schemas.microsoft.com/office/drawing/2014/main" id="{227B18B6-4FBF-4E4C-95EC-E74B51990F31}"/>
+                <a16:creationId xmlns:a16="http://schemas.microsoft.com/office/drawing/2014/main" id="{92A78389-33DD-4083-88A7-B5FD500CFB10}"/>
               </a:ext>
             </a:extLst>
           </p:cNvPr>
@@ -9446,7 +9962,7 @@
           <p:cNvPr id="3" name="">
             <a:extLst xmlns:a="http://schemas.openxmlformats.org/drawingml/2006/main">
               <a:ext uri="{FF2B5EF4-FFF2-40B4-BE49-F238E27FC236}">
-                <a16:creationId xmlns:a16="http://schemas.microsoft.com/office/drawing/2014/main" id="{F31D94FA-3DF0-4BF9-962D-67AB11B69422}"/>
+                <a16:creationId xmlns:a16="http://schemas.microsoft.com/office/drawing/2014/main" id="{440BE242-CAFD-4641-B9A6-68C3697A5380}"/>
               </a:ext>
             </a:extLst>
           </p:cNvPr>
@@ -9503,7 +10019,7 @@
           <p:cNvPr id="4" name="">
             <a:extLst xmlns:a="http://schemas.openxmlformats.org/drawingml/2006/main">
               <a:ext uri="{FF2B5EF4-FFF2-40B4-BE49-F238E27FC236}">
-                <a16:creationId xmlns:a16="http://schemas.microsoft.com/office/drawing/2014/main" id="{24BE6FB2-728D-4A28-AABA-AB387CA0EDB2}"/>
+                <a16:creationId xmlns:a16="http://schemas.microsoft.com/office/drawing/2014/main" id="{2645D3DD-7ED5-454A-87BA-EFE21C3F2550}"/>
               </a:ext>
             </a:extLst>
           </p:cNvPr>
@@ -9791,7 +10307,7 @@
     </p:spTree>
     <p:extLst>
       <p:ext uri="{BB962C8B-B14F-4D97-AF65-F5344CB8AC3E}">
-        <p14:creationId xmlns:p14="http://schemas.microsoft.com/office/powerpoint/2010/main" val="1285197974"/>
+        <p14:creationId xmlns:p14="http://schemas.microsoft.com/office/powerpoint/2010/main" val="799337456"/>
       </p:ext>
     </p:extLst>
   </p:cSld>
@@ -9822,7 +10338,7 @@
           <p:cNvPr id="9" name="">
             <a:extLst xmlns:a="http://schemas.openxmlformats.org/drawingml/2006/main">
               <a:ext uri="{FF2B5EF4-FFF2-40B4-BE49-F238E27FC236}">
-                <a16:creationId xmlns:a16="http://schemas.microsoft.com/office/drawing/2014/main" id="{26292D99-8FE5-460E-8493-B209E87F92F6}"/>
+                <a16:creationId xmlns:a16="http://schemas.microsoft.com/office/drawing/2014/main" id="{BCBFCA71-8016-4738-B724-91A8D2AF7348}"/>
               </a:ext>
             </a:extLst>
           </p:cNvPr>
@@ -9879,7 +10395,7 @@
           <p:cNvPr id="2" name="">
             <a:extLst xmlns:a="http://schemas.openxmlformats.org/drawingml/2006/main">
               <a:ext uri="{FF2B5EF4-FFF2-40B4-BE49-F238E27FC236}">
-                <a16:creationId xmlns:a16="http://schemas.microsoft.com/office/drawing/2014/main" id="{CC58B0E6-594B-4124-8F45-A4B7D3ED632A}"/>
+                <a16:creationId xmlns:a16="http://schemas.microsoft.com/office/drawing/2014/main" id="{E22DD19E-21C9-4C25-A5C2-636E89F3371D}"/>
               </a:ext>
             </a:extLst>
           </p:cNvPr>
@@ -9936,7 +10452,7 @@
           <p:cNvPr id="3" name="">
             <a:extLst xmlns:a="http://schemas.openxmlformats.org/drawingml/2006/main">
               <a:ext uri="{FF2B5EF4-FFF2-40B4-BE49-F238E27FC236}">
-                <a16:creationId xmlns:a16="http://schemas.microsoft.com/office/drawing/2014/main" id="{13D562C7-7D82-4701-B97E-89AAAF828419}"/>
+                <a16:creationId xmlns:a16="http://schemas.microsoft.com/office/drawing/2014/main" id="{098BB7B2-1F1F-4030-8437-13ED6A3C58BF}"/>
               </a:ext>
             </a:extLst>
           </p:cNvPr>
@@ -9993,7 +10509,7 @@
           <p:cNvPr id="4" name="">
             <a:extLst xmlns:a="http://schemas.openxmlformats.org/drawingml/2006/main">
               <a:ext uri="{FF2B5EF4-FFF2-40B4-BE49-F238E27FC236}">
-                <a16:creationId xmlns:a16="http://schemas.microsoft.com/office/drawing/2014/main" id="{9E13A2A6-9413-428E-A142-165DA9BBB3CC}"/>
+                <a16:creationId xmlns:a16="http://schemas.microsoft.com/office/drawing/2014/main" id="{175E1CC5-CD93-4145-95A6-610E28C0CAAA}"/>
               </a:ext>
             </a:extLst>
           </p:cNvPr>
@@ -10057,7 +10573,7 @@
         </p:xfrm>
         <a:graphic xmlns:a="http://schemas.openxmlformats.org/drawingml/2006/main">
           <a:graphicData uri="http://schemas.openxmlformats.org/drawingml/2006/chart">
-            <c:chart xmlns:r="http://schemas.openxmlformats.org/officeDocument/2006/relationships" xmlns:c="http://schemas.openxmlformats.org/drawingml/2006/chart" r:id="Receb76cc05064b59"/>
+            <c:chart xmlns:r="http://schemas.openxmlformats.org/officeDocument/2006/relationships" xmlns:c="http://schemas.openxmlformats.org/drawingml/2006/chart" r:id="R089f47c496794191"/>
           </a:graphicData>
         </a:graphic>
       </p:graphicFrame>
@@ -10066,7 +10582,7 @@
           <p:cNvPr id="6" name="">
             <a:extLst xmlns:a="http://schemas.openxmlformats.org/drawingml/2006/main">
               <a:ext uri="{FF2B5EF4-FFF2-40B4-BE49-F238E27FC236}">
-                <a16:creationId xmlns:a16="http://schemas.microsoft.com/office/drawing/2014/main" id="{D401E909-04D8-43C3-A2C6-6F090D11D0B8}"/>
+                <a16:creationId xmlns:a16="http://schemas.microsoft.com/office/drawing/2014/main" id="{B61CCE58-2154-4204-A3BA-594E6B4BC417}"/>
               </a:ext>
             </a:extLst>
           </p:cNvPr>
@@ -10123,7 +10639,7 @@
           <p:cNvPr id="7" name="">
             <a:extLst xmlns:a="http://schemas.openxmlformats.org/drawingml/2006/main">
               <a:ext uri="{FF2B5EF4-FFF2-40B4-BE49-F238E27FC236}">
-                <a16:creationId xmlns:a16="http://schemas.microsoft.com/office/drawing/2014/main" id="{04B29800-147B-4472-B636-43DE9737A1ED}"/>
+                <a16:creationId xmlns:a16="http://schemas.microsoft.com/office/drawing/2014/main" id="{0B74DB84-DB7A-484D-B67F-F7EB030DE958}"/>
               </a:ext>
             </a:extLst>
           </p:cNvPr>
@@ -10239,7 +10755,7 @@
           <p:cNvPr id="8" name="">
             <a:extLst xmlns:a="http://schemas.openxmlformats.org/drawingml/2006/main">
               <a:ext uri="{FF2B5EF4-FFF2-40B4-BE49-F238E27FC236}">
-                <a16:creationId xmlns:a16="http://schemas.microsoft.com/office/drawing/2014/main" id="{75106335-6FC0-40EE-A900-65A7DC67D376}"/>
+                <a16:creationId xmlns:a16="http://schemas.microsoft.com/office/drawing/2014/main" id="{4914430D-A34F-4828-B049-32E90106BF6C}"/>
               </a:ext>
             </a:extLst>
           </p:cNvPr>
@@ -10294,7 +10810,7 @@
     </p:spTree>
     <p:extLst>
       <p:ext uri="{BB962C8B-B14F-4D97-AF65-F5344CB8AC3E}">
-        <p14:creationId xmlns:p14="http://schemas.microsoft.com/office/powerpoint/2010/main" val="1647793744"/>
+        <p14:creationId xmlns:p14="http://schemas.microsoft.com/office/powerpoint/2010/main" val="1944329423"/>
       </p:ext>
     </p:extLst>
   </p:cSld>
@@ -10325,7 +10841,7 @@
           <p:cNvPr id="6" name="">
             <a:extLst xmlns:a="http://schemas.openxmlformats.org/drawingml/2006/main">
               <a:ext uri="{FF2B5EF4-FFF2-40B4-BE49-F238E27FC236}">
-                <a16:creationId xmlns:a16="http://schemas.microsoft.com/office/drawing/2014/main" id="{A15B28EB-E52B-41C9-8A37-B3E0DE3DBFC0}"/>
+                <a16:creationId xmlns:a16="http://schemas.microsoft.com/office/drawing/2014/main" id="{132B83BB-4939-4147-813F-C4C529BE9DFF}"/>
               </a:ext>
             </a:extLst>
           </p:cNvPr>
@@ -10382,7 +10898,7 @@
           <p:cNvPr id="2" name="">
             <a:extLst xmlns:a="http://schemas.openxmlformats.org/drawingml/2006/main">
               <a:ext uri="{FF2B5EF4-FFF2-40B4-BE49-F238E27FC236}">
-                <a16:creationId xmlns:a16="http://schemas.microsoft.com/office/drawing/2014/main" id="{E8A74F08-A8B7-40C1-8A6B-CC425D4BE47F}"/>
+                <a16:creationId xmlns:a16="http://schemas.microsoft.com/office/drawing/2014/main" id="{F271FB5A-84AA-42BD-93C4-143D4C0908F6}"/>
               </a:ext>
             </a:extLst>
           </p:cNvPr>
@@ -10439,7 +10955,7 @@
           <p:cNvPr id="3" name="">
             <a:extLst xmlns:a="http://schemas.openxmlformats.org/drawingml/2006/main">
               <a:ext uri="{FF2B5EF4-FFF2-40B4-BE49-F238E27FC236}">
-                <a16:creationId xmlns:a16="http://schemas.microsoft.com/office/drawing/2014/main" id="{FF27EE0C-79F9-4B1F-B31F-F3C4840D087A}"/>
+                <a16:creationId xmlns:a16="http://schemas.microsoft.com/office/drawing/2014/main" id="{CA2C940B-83AE-4718-A3A8-98676C63154D}"/>
               </a:ext>
             </a:extLst>
           </p:cNvPr>
@@ -10919,7 +11435,7 @@
           <p:cNvPr id="5" name="">
             <a:extLst xmlns:a="http://schemas.openxmlformats.org/drawingml/2006/main">
               <a:ext uri="{FF2B5EF4-FFF2-40B4-BE49-F238E27FC236}">
-                <a16:creationId xmlns:a16="http://schemas.microsoft.com/office/drawing/2014/main" id="{4E502C7A-ED13-4207-9B75-5B58C92A30BF}"/>
+                <a16:creationId xmlns:a16="http://schemas.microsoft.com/office/drawing/2014/main" id="{61FA32EB-3539-453A-9187-C63639F53E72}"/>
               </a:ext>
             </a:extLst>
           </p:cNvPr>
@@ -10978,7 +11494,7 @@
     </p:spTree>
     <p:extLst>
       <p:ext uri="{BB962C8B-B14F-4D97-AF65-F5344CB8AC3E}">
-        <p14:creationId xmlns:p14="http://schemas.microsoft.com/office/powerpoint/2010/main" val="766076677"/>
+        <p14:creationId xmlns:p14="http://schemas.microsoft.com/office/powerpoint/2010/main" val="584846588"/>
       </p:ext>
     </p:extLst>
   </p:cSld>
@@ -11009,7 +11525,7 @@
           <p:cNvPr id="5" name="">
             <a:extLst xmlns:a="http://schemas.openxmlformats.org/drawingml/2006/main">
               <a:ext uri="{FF2B5EF4-FFF2-40B4-BE49-F238E27FC236}">
-                <a16:creationId xmlns:a16="http://schemas.microsoft.com/office/drawing/2014/main" id="{FBEB2474-CB25-4E6D-A224-4DB523C8F5B5}"/>
+                <a16:creationId xmlns:a16="http://schemas.microsoft.com/office/drawing/2014/main" id="{BB9AD1D0-6B55-4238-B9EF-1F4641CDE395}"/>
               </a:ext>
             </a:extLst>
           </p:cNvPr>
@@ -11066,7 +11582,7 @@
           <p:cNvPr id="2" name="">
             <a:extLst xmlns:a="http://schemas.openxmlformats.org/drawingml/2006/main">
               <a:ext uri="{FF2B5EF4-FFF2-40B4-BE49-F238E27FC236}">
-                <a16:creationId xmlns:a16="http://schemas.microsoft.com/office/drawing/2014/main" id="{21CD345E-E9C5-4792-8F29-EFD1DF1992D5}"/>
+                <a16:creationId xmlns:a16="http://schemas.microsoft.com/office/drawing/2014/main" id="{B2CBFE9D-80A6-4F1B-850C-ADC63C1FAD39}"/>
               </a:ext>
             </a:extLst>
           </p:cNvPr>
@@ -11123,7 +11639,7 @@
           <p:cNvPr id="3" name="">
             <a:extLst xmlns:a="http://schemas.openxmlformats.org/drawingml/2006/main">
               <a:ext uri="{FF2B5EF4-FFF2-40B4-BE49-F238E27FC236}">
-                <a16:creationId xmlns:a16="http://schemas.microsoft.com/office/drawing/2014/main" id="{0F3B4FFD-2B8E-4615-8F70-0377EC15D209}"/>
+                <a16:creationId xmlns:a16="http://schemas.microsoft.com/office/drawing/2014/main" id="{ADE45332-D463-48CD-BC01-59FEE191E0D2}"/>
               </a:ext>
             </a:extLst>
           </p:cNvPr>
@@ -11537,7 +12053,7 @@
     </p:spTree>
     <p:extLst>
       <p:ext uri="{BB962C8B-B14F-4D97-AF65-F5344CB8AC3E}">
-        <p14:creationId xmlns:p14="http://schemas.microsoft.com/office/powerpoint/2010/main" val="131982224"/>
+        <p14:creationId xmlns:p14="http://schemas.microsoft.com/office/powerpoint/2010/main" val="478106522"/>
       </p:ext>
     </p:extLst>
   </p:cSld>
@@ -11568,7 +12084,7 @@
           <p:cNvPr id="9" name="">
             <a:extLst xmlns:a="http://schemas.openxmlformats.org/drawingml/2006/main">
               <a:ext uri="{FF2B5EF4-FFF2-40B4-BE49-F238E27FC236}">
-                <a16:creationId xmlns:a16="http://schemas.microsoft.com/office/drawing/2014/main" id="{A5B48973-B157-415C-B8A6-A4DEC5A09EE9}"/>
+                <a16:creationId xmlns:a16="http://schemas.microsoft.com/office/drawing/2014/main" id="{414A1309-54E9-435D-AF58-CD3E6D407B12}"/>
               </a:ext>
             </a:extLst>
           </p:cNvPr>
@@ -11625,7 +12141,7 @@
           <p:cNvPr id="2" name="">
             <a:extLst xmlns:a="http://schemas.openxmlformats.org/drawingml/2006/main">
               <a:ext uri="{FF2B5EF4-FFF2-40B4-BE49-F238E27FC236}">
-                <a16:creationId xmlns:a16="http://schemas.microsoft.com/office/drawing/2014/main" id="{CF600A0B-0AF4-48C9-BE6C-39C399537559}"/>
+                <a16:creationId xmlns:a16="http://schemas.microsoft.com/office/drawing/2014/main" id="{D0420695-F6D7-4274-9CB2-9AFC56FAACAD}"/>
               </a:ext>
             </a:extLst>
           </p:cNvPr>
@@ -11682,7 +12198,7 @@
           <p:cNvPr id="3" name="">
             <a:extLst xmlns:a="http://schemas.openxmlformats.org/drawingml/2006/main">
               <a:ext uri="{FF2B5EF4-FFF2-40B4-BE49-F238E27FC236}">
-                <a16:creationId xmlns:a16="http://schemas.microsoft.com/office/drawing/2014/main" id="{68F46AFB-4D47-4E4C-BCFC-655424D85ECE}"/>
+                <a16:creationId xmlns:a16="http://schemas.microsoft.com/office/drawing/2014/main" id="{F6CFA779-58D7-40F9-A478-44E449910517}"/>
               </a:ext>
             </a:extLst>
           </p:cNvPr>
@@ -11739,7 +12255,7 @@
           <p:cNvPr id="4" name="">
             <a:extLst xmlns:a="http://schemas.openxmlformats.org/drawingml/2006/main">
               <a:ext uri="{FF2B5EF4-FFF2-40B4-BE49-F238E27FC236}">
-                <a16:creationId xmlns:a16="http://schemas.microsoft.com/office/drawing/2014/main" id="{338DAA53-B552-4CA0-BA0D-AA8E089F881D}"/>
+                <a16:creationId xmlns:a16="http://schemas.microsoft.com/office/drawing/2014/main" id="{43AA88D7-FE97-47CE-930E-A23090F0E43F}"/>
               </a:ext>
             </a:extLst>
           </p:cNvPr>
@@ -11800,7 +12316,7 @@
           <p:cNvPr id="5" name="">
             <a:extLst xmlns:a="http://schemas.openxmlformats.org/drawingml/2006/main">
               <a:ext uri="{FF2B5EF4-FFF2-40B4-BE49-F238E27FC236}">
-                <a16:creationId xmlns:a16="http://schemas.microsoft.com/office/drawing/2014/main" id="{3B62C125-83C0-479A-904E-A87F0232A7CE}"/>
+                <a16:creationId xmlns:a16="http://schemas.microsoft.com/office/drawing/2014/main" id="{9EE1AEBA-5D36-45A6-A0F3-B9AB33C509C2}"/>
               </a:ext>
             </a:extLst>
           </p:cNvPr>
@@ -11857,7 +12373,7 @@
           <p:cNvPr id="6" name="">
             <a:extLst xmlns:a="http://schemas.openxmlformats.org/drawingml/2006/main">
               <a:ext uri="{FF2B5EF4-FFF2-40B4-BE49-F238E27FC236}">
-                <a16:creationId xmlns:a16="http://schemas.microsoft.com/office/drawing/2014/main" id="{9790C229-0674-41CC-9775-7BBAE8DDC590}"/>
+                <a16:creationId xmlns:a16="http://schemas.microsoft.com/office/drawing/2014/main" id="{CA139E2E-04A1-4E92-8247-879072EBA2A9}"/>
               </a:ext>
             </a:extLst>
           </p:cNvPr>
@@ -11918,7 +12434,7 @@
           <p:cNvPr id="7" name="">
             <a:extLst xmlns:a="http://schemas.openxmlformats.org/drawingml/2006/main">
               <a:ext uri="{FF2B5EF4-FFF2-40B4-BE49-F238E27FC236}">
-                <a16:creationId xmlns:a16="http://schemas.microsoft.com/office/drawing/2014/main" id="{E8AB72F2-3F7A-41F1-A105-3C365DBB16F2}"/>
+                <a16:creationId xmlns:a16="http://schemas.microsoft.com/office/drawing/2014/main" id="{247AA429-FCF2-45AF-878C-84AD2FD6295D}"/>
               </a:ext>
             </a:extLst>
           </p:cNvPr>
@@ -11975,7 +12491,7 @@
           <p:cNvPr id="8" name="">
             <a:extLst xmlns:a="http://schemas.openxmlformats.org/drawingml/2006/main">
               <a:ext uri="{FF2B5EF4-FFF2-40B4-BE49-F238E27FC236}">
-                <a16:creationId xmlns:a16="http://schemas.microsoft.com/office/drawing/2014/main" id="{307E7E95-C9FC-4774-B544-25CAC2D79F09}"/>
+                <a16:creationId xmlns:a16="http://schemas.microsoft.com/office/drawing/2014/main" id="{14986899-6338-4165-8EFB-54F0F8D88ABE}"/>
               </a:ext>
             </a:extLst>
           </p:cNvPr>
@@ -12030,7 +12546,7 @@
     </p:spTree>
     <p:extLst>
       <p:ext uri="{BB962C8B-B14F-4D97-AF65-F5344CB8AC3E}">
-        <p14:creationId xmlns:p14="http://schemas.microsoft.com/office/powerpoint/2010/main" val="634152223"/>
+        <p14:creationId xmlns:p14="http://schemas.microsoft.com/office/powerpoint/2010/main" val="1610160321"/>
       </p:ext>
     </p:extLst>
   </p:cSld>
@@ -12061,7 +12577,7 @@
           <p:cNvPr id="6" name="">
             <a:extLst xmlns:a="http://schemas.openxmlformats.org/drawingml/2006/main">
               <a:ext uri="{FF2B5EF4-FFF2-40B4-BE49-F238E27FC236}">
-                <a16:creationId xmlns:a16="http://schemas.microsoft.com/office/drawing/2014/main" id="{9C222FF8-19FB-464A-B272-D99AB8A85564}"/>
+                <a16:creationId xmlns:a16="http://schemas.microsoft.com/office/drawing/2014/main" id="{29F25AD8-8430-4D3E-91A6-D3308F442455}"/>
               </a:ext>
             </a:extLst>
           </p:cNvPr>
@@ -12118,7 +12634,7 @@
           <p:cNvPr id="2" name="">
             <a:extLst xmlns:a="http://schemas.openxmlformats.org/drawingml/2006/main">
               <a:ext uri="{FF2B5EF4-FFF2-40B4-BE49-F238E27FC236}">
-                <a16:creationId xmlns:a16="http://schemas.microsoft.com/office/drawing/2014/main" id="{92ED05CB-DB08-46A5-9D50-295FFE2E4353}"/>
+                <a16:creationId xmlns:a16="http://schemas.microsoft.com/office/drawing/2014/main" id="{862E3D9B-2A42-4FF1-99E2-9605EC4BBB82}"/>
               </a:ext>
             </a:extLst>
           </p:cNvPr>
@@ -12175,7 +12691,7 @@
           <p:cNvPr id="3" name="">
             <a:extLst xmlns:a="http://schemas.openxmlformats.org/drawingml/2006/main">
               <a:ext uri="{FF2B5EF4-FFF2-40B4-BE49-F238E27FC236}">
-                <a16:creationId xmlns:a16="http://schemas.microsoft.com/office/drawing/2014/main" id="{F5321CF7-2D48-41C8-A9F8-E62ED21E216D}"/>
+                <a16:creationId xmlns:a16="http://schemas.microsoft.com/office/drawing/2014/main" id="{5400956E-5E12-4E4C-855C-7ACC2BA7A722}"/>
               </a:ext>
             </a:extLst>
           </p:cNvPr>
@@ -12232,7 +12748,7 @@
           <p:cNvPr id="4" name="">
             <a:extLst xmlns:a="http://schemas.openxmlformats.org/drawingml/2006/main">
               <a:ext uri="{FF2B5EF4-FFF2-40B4-BE49-F238E27FC236}">
-                <a16:creationId xmlns:a16="http://schemas.microsoft.com/office/drawing/2014/main" id="{E799F4FE-5C18-4E70-8DDD-434C1D6C5FAD}"/>
+                <a16:creationId xmlns:a16="http://schemas.microsoft.com/office/drawing/2014/main" id="{29BE0D72-41BA-4D59-8E1C-2EFDC397E930}"/>
               </a:ext>
             </a:extLst>
           </p:cNvPr>
@@ -12374,7 +12890,7 @@
           <p:cNvPr id="5" name="">
             <a:extLst xmlns:a="http://schemas.openxmlformats.org/drawingml/2006/main">
               <a:ext uri="{FF2B5EF4-FFF2-40B4-BE49-F238E27FC236}">
-                <a16:creationId xmlns:a16="http://schemas.microsoft.com/office/drawing/2014/main" id="{21C7E465-4BEF-4BAD-876A-E308AB067DA1}"/>
+                <a16:creationId xmlns:a16="http://schemas.microsoft.com/office/drawing/2014/main" id="{DF76A5BA-B0E2-4735-868B-61323518C00B}"/>
               </a:ext>
             </a:extLst>
           </p:cNvPr>
@@ -12429,7 +12945,7 @@
     </p:spTree>
     <p:extLst>
       <p:ext uri="{BB962C8B-B14F-4D97-AF65-F5344CB8AC3E}">
-        <p14:creationId xmlns:p14="http://schemas.microsoft.com/office/powerpoint/2010/main" val="635623695"/>
+        <p14:creationId xmlns:p14="http://schemas.microsoft.com/office/powerpoint/2010/main" val="1884559718"/>
       </p:ext>
     </p:extLst>
   </p:cSld>
@@ -12460,7 +12976,7 @@
           <p:cNvPr id="12" name="">
             <a:extLst xmlns:a="http://schemas.openxmlformats.org/drawingml/2006/main">
               <a:ext uri="{FF2B5EF4-FFF2-40B4-BE49-F238E27FC236}">
-                <a16:creationId xmlns:a16="http://schemas.microsoft.com/office/drawing/2014/main" id="{B8848057-D04E-4A00-933F-8B0CD66855B8}"/>
+                <a16:creationId xmlns:a16="http://schemas.microsoft.com/office/drawing/2014/main" id="{C2C2B19F-ED62-4F03-A4E9-7C2BF593F45B}"/>
               </a:ext>
             </a:extLst>
           </p:cNvPr>
@@ -12517,7 +13033,7 @@
           <p:cNvPr id="2" name="">
             <a:extLst xmlns:a="http://schemas.openxmlformats.org/drawingml/2006/main">
               <a:ext uri="{FF2B5EF4-FFF2-40B4-BE49-F238E27FC236}">
-                <a16:creationId xmlns:a16="http://schemas.microsoft.com/office/drawing/2014/main" id="{A5691752-DED8-4E75-AECF-DFB253D7EF94}"/>
+                <a16:creationId xmlns:a16="http://schemas.microsoft.com/office/drawing/2014/main" id="{C03AF5C1-9A69-4770-836E-CEFC0FA824F9}"/>
               </a:ext>
             </a:extLst>
           </p:cNvPr>
@@ -12574,7 +13090,7 @@
           <p:cNvPr id="3" name="">
             <a:extLst xmlns:a="http://schemas.openxmlformats.org/drawingml/2006/main">
               <a:ext uri="{FF2B5EF4-FFF2-40B4-BE49-F238E27FC236}">
-                <a16:creationId xmlns:a16="http://schemas.microsoft.com/office/drawing/2014/main" id="{B94740A6-D0D0-4E8B-A32F-64D8E7CC9488}"/>
+                <a16:creationId xmlns:a16="http://schemas.microsoft.com/office/drawing/2014/main" id="{F2FC4AB0-B45B-4992-BA99-7FDAF5DBC4E5}"/>
               </a:ext>
             </a:extLst>
           </p:cNvPr>
@@ -12631,7 +13147,7 @@
           <p:cNvPr id="4" name="">
             <a:extLst xmlns:a="http://schemas.openxmlformats.org/drawingml/2006/main">
               <a:ext uri="{FF2B5EF4-FFF2-40B4-BE49-F238E27FC236}">
-                <a16:creationId xmlns:a16="http://schemas.microsoft.com/office/drawing/2014/main" id="{A354281E-11B9-4E7A-B9C5-1106462AC3DA}"/>
+                <a16:creationId xmlns:a16="http://schemas.microsoft.com/office/drawing/2014/main" id="{D7FAA486-28B4-4122-94D2-15DC600A0804}"/>
               </a:ext>
             </a:extLst>
           </p:cNvPr>
@@ -12692,7 +13208,7 @@
           <p:cNvPr id="5" name="">
             <a:extLst xmlns:a="http://schemas.openxmlformats.org/drawingml/2006/main">
               <a:ext uri="{FF2B5EF4-FFF2-40B4-BE49-F238E27FC236}">
-                <a16:creationId xmlns:a16="http://schemas.microsoft.com/office/drawing/2014/main" id="{3F3EA7AA-98C8-4422-84EA-3434D5A711D3}"/>
+                <a16:creationId xmlns:a16="http://schemas.microsoft.com/office/drawing/2014/main" id="{8050E365-A892-48BC-93F3-9544B8688A1D}"/>
               </a:ext>
             </a:extLst>
           </p:cNvPr>
@@ -12724,7 +13240,7 @@
           <p:cNvPr id="6" name="">
             <a:extLst xmlns:a="http://schemas.openxmlformats.org/drawingml/2006/main">
               <a:ext uri="{FF2B5EF4-FFF2-40B4-BE49-F238E27FC236}">
-                <a16:creationId xmlns:a16="http://schemas.microsoft.com/office/drawing/2014/main" id="{6B77326A-C287-47EC-9B60-B5FD018E63AD}"/>
+                <a16:creationId xmlns:a16="http://schemas.microsoft.com/office/drawing/2014/main" id="{295D5FF2-0A6B-46D9-8E36-6A853A7272DA}"/>
               </a:ext>
             </a:extLst>
           </p:cNvPr>
@@ -12781,7 +13297,7 @@
           <p:cNvPr id="7" name="">
             <a:extLst xmlns:a="http://schemas.openxmlformats.org/drawingml/2006/main">
               <a:ext uri="{FF2B5EF4-FFF2-40B4-BE49-F238E27FC236}">
-                <a16:creationId xmlns:a16="http://schemas.microsoft.com/office/drawing/2014/main" id="{DFA30412-C06A-4880-814A-63FD80F9C82D}"/>
+                <a16:creationId xmlns:a16="http://schemas.microsoft.com/office/drawing/2014/main" id="{8A379BC0-1758-473B-AEAA-CC34C1E16405}"/>
               </a:ext>
             </a:extLst>
           </p:cNvPr>
@@ -12838,7 +13354,7 @@
           <p:cNvPr id="8" name="">
             <a:extLst xmlns:a="http://schemas.openxmlformats.org/drawingml/2006/main">
               <a:ext uri="{FF2B5EF4-FFF2-40B4-BE49-F238E27FC236}">
-                <a16:creationId xmlns:a16="http://schemas.microsoft.com/office/drawing/2014/main" id="{66061FE2-2218-42BA-91AE-A42D4B2C7992}"/>
+                <a16:creationId xmlns:a16="http://schemas.microsoft.com/office/drawing/2014/main" id="{E9495C64-6A4B-4269-8A6A-E862B7242ADA}"/>
               </a:ext>
             </a:extLst>
           </p:cNvPr>
@@ -12899,7 +13415,7 @@
           <p:cNvPr id="9" name="">
             <a:extLst xmlns:a="http://schemas.openxmlformats.org/drawingml/2006/main">
               <a:ext uri="{FF2B5EF4-FFF2-40B4-BE49-F238E27FC236}">
-                <a16:creationId xmlns:a16="http://schemas.microsoft.com/office/drawing/2014/main" id="{265686C7-CA2C-4EF0-8609-A89D6C9095CF}"/>
+                <a16:creationId xmlns:a16="http://schemas.microsoft.com/office/drawing/2014/main" id="{4D8E8992-A284-4830-B5F9-005589A75978}"/>
               </a:ext>
             </a:extLst>
           </p:cNvPr>
@@ -12931,7 +13447,7 @@
           <p:cNvPr id="10" name="">
             <a:extLst xmlns:a="http://schemas.openxmlformats.org/drawingml/2006/main">
               <a:ext uri="{FF2B5EF4-FFF2-40B4-BE49-F238E27FC236}">
-                <a16:creationId xmlns:a16="http://schemas.microsoft.com/office/drawing/2014/main" id="{EFB58F6F-084F-4582-9FDD-0489C0C394F7}"/>
+                <a16:creationId xmlns:a16="http://schemas.microsoft.com/office/drawing/2014/main" id="{2A3E59A0-FEFD-4646-9B17-63CAFBDE3B9E}"/>
               </a:ext>
             </a:extLst>
           </p:cNvPr>
@@ -12988,7 +13504,7 @@
           <p:cNvPr id="11" name="">
             <a:extLst xmlns:a="http://schemas.openxmlformats.org/drawingml/2006/main">
               <a:ext uri="{FF2B5EF4-FFF2-40B4-BE49-F238E27FC236}">
-                <a16:creationId xmlns:a16="http://schemas.microsoft.com/office/drawing/2014/main" id="{75F4AB5A-DC10-465D-B821-AF61BCC2B500}"/>
+                <a16:creationId xmlns:a16="http://schemas.microsoft.com/office/drawing/2014/main" id="{56D68790-3531-4E48-B30C-DB717F840A11}"/>
               </a:ext>
             </a:extLst>
           </p:cNvPr>
@@ -13043,7 +13559,7 @@
     </p:spTree>
     <p:extLst>
       <p:ext uri="{BB962C8B-B14F-4D97-AF65-F5344CB8AC3E}">
-        <p14:creationId xmlns:p14="http://schemas.microsoft.com/office/powerpoint/2010/main" val="232443302"/>
+        <p14:creationId xmlns:p14="http://schemas.microsoft.com/office/powerpoint/2010/main" val="1731437620"/>
       </p:ext>
     </p:extLst>
   </p:cSld>
@@ -13071,10 +13587,10 @@
       </p:grpSpPr>
       <p:sp>
         <p:nvSpPr>
-          <p:cNvPr id="10" name="">
+          <p:cNvPr id="13" name="">
             <a:extLst xmlns:a="http://schemas.openxmlformats.org/drawingml/2006/main">
               <a:ext uri="{FF2B5EF4-FFF2-40B4-BE49-F238E27FC236}">
-                <a16:creationId xmlns:a16="http://schemas.microsoft.com/office/drawing/2014/main" id="{C51F835E-DF58-4A14-A492-85AEF575AE2E}"/>
+                <a16:creationId xmlns:a16="http://schemas.microsoft.com/office/drawing/2014/main" id="{2F79A06A-FAD6-46A5-90B1-3C0D09EB4DE4}"/>
               </a:ext>
             </a:extLst>
           </p:cNvPr>
@@ -13131,7 +13647,7 @@
           <p:cNvPr id="2" name="">
             <a:extLst xmlns:a="http://schemas.openxmlformats.org/drawingml/2006/main">
               <a:ext uri="{FF2B5EF4-FFF2-40B4-BE49-F238E27FC236}">
-                <a16:creationId xmlns:a16="http://schemas.microsoft.com/office/drawing/2014/main" id="{5D82511D-527E-4AF8-83C3-31005CF22055}"/>
+                <a16:creationId xmlns:a16="http://schemas.microsoft.com/office/drawing/2014/main" id="{112A1B6F-5766-432E-AAEA-CFA57988881A}"/>
               </a:ext>
             </a:extLst>
           </p:cNvPr>
@@ -13188,7 +13704,7 @@
           <p:cNvPr id="3" name="">
             <a:extLst xmlns:a="http://schemas.openxmlformats.org/drawingml/2006/main">
               <a:ext uri="{FF2B5EF4-FFF2-40B4-BE49-F238E27FC236}">
-                <a16:creationId xmlns:a16="http://schemas.microsoft.com/office/drawing/2014/main" id="{6CBFF378-5077-408D-9A69-C643423DB53E}"/>
+                <a16:creationId xmlns:a16="http://schemas.microsoft.com/office/drawing/2014/main" id="{F9E35677-C436-4927-AB9D-8E3191DDFD0B}"/>
               </a:ext>
             </a:extLst>
           </p:cNvPr>
@@ -13199,8 +13715,8 @@
         </p:nvSpPr>
         <p:spPr>
           <a:xfrm xmlns:a="http://schemas.openxmlformats.org/drawingml/2006/main">
-            <a:off x="609600" y="1590675"/>
-            <a:ext cx="2609850" cy="914400"/>
+            <a:off x="609600" y="1533525"/>
+            <a:ext cx="2609850" cy="723900"/>
           </a:xfrm>
           <a:prstGeom xmlns:a="http://schemas.openxmlformats.org/drawingml/2006/main" prst="rect">
             <a:avLst/>
@@ -13217,17 +13733,17 @@
           <a:lstStyle xmlns:a="http://schemas.openxmlformats.org/drawingml/2006/main"/>
           <a:p xmlns:a="http://schemas.openxmlformats.org/drawingml/2006/main">
             <a:pPr algn="l">
-              <a:defRPr sz="2400" b="1">
-                <a:solidFill>
-                  <a:srgbClr val="16343E"/>
-                </a:solidFill>
-                <a:latin typeface="Arial"/>
-                <a:ea typeface="Arial"/>
-                <a:cs typeface="Arial"/>
-              </a:defRPr>
-            </a:pPr>
-            <a:r>
-              <a:rPr sz="2400" b="1">
+              <a:defRPr sz="2175" b="1">
+                <a:solidFill>
+                  <a:srgbClr val="16343E"/>
+                </a:solidFill>
+                <a:latin typeface="Arial"/>
+                <a:ea typeface="Arial"/>
+                <a:cs typeface="Arial"/>
+              </a:defRPr>
+            </a:pPr>
+            <a:r>
+              <a:rPr sz="2175" b="1">
                 <a:solidFill>
                   <a:srgbClr val="16343E"/>
                 </a:solidFill>
@@ -13240,17 +13756,17 @@
           </a:p>
           <a:p xmlns:a="http://schemas.openxmlformats.org/drawingml/2006/main">
             <a:pPr algn="l">
-              <a:defRPr sz="2400" b="1">
-                <a:solidFill>
-                  <a:srgbClr val="16343E"/>
-                </a:solidFill>
-                <a:latin typeface="Arial"/>
-                <a:ea typeface="Arial"/>
-                <a:cs typeface="Arial"/>
-              </a:defRPr>
-            </a:pPr>
-            <a:r>
-              <a:rPr sz="2400" b="1">
+              <a:defRPr sz="2175" b="1">
+                <a:solidFill>
+                  <a:srgbClr val="16343E"/>
+                </a:solidFill>
+                <a:latin typeface="Arial"/>
+                <a:ea typeface="Arial"/>
+                <a:cs typeface="Arial"/>
+              </a:defRPr>
+            </a:pPr>
+            <a:r>
+              <a:rPr sz="2175" b="1">
                 <a:solidFill>
                   <a:srgbClr val="16343E"/>
                 </a:solidFill>
@@ -13268,7 +13784,7 @@
           <p:cNvPr id="4" name="">
             <a:extLst xmlns:a="http://schemas.openxmlformats.org/drawingml/2006/main">
               <a:ext uri="{FF2B5EF4-FFF2-40B4-BE49-F238E27FC236}">
-                <a16:creationId xmlns:a16="http://schemas.microsoft.com/office/drawing/2014/main" id="{1D257D2F-4DA4-463C-A9C9-3B45C7FDF9F6}"/>
+                <a16:creationId xmlns:a16="http://schemas.microsoft.com/office/drawing/2014/main" id="{9728830D-33B6-4BF0-9714-6EF9FDBDE3BA}"/>
               </a:ext>
             </a:extLst>
           </p:cNvPr>
@@ -13280,7 +13796,7 @@
         <p:spPr>
           <a:xfrm xmlns:a="http://schemas.openxmlformats.org/drawingml/2006/main">
             <a:off x="3476625" y="1533525"/>
-            <a:ext cx="8105775" cy="990600"/>
+            <a:ext cx="8105775" cy="723900"/>
           </a:xfrm>
           <a:prstGeom xmlns:a="http://schemas.openxmlformats.org/drawingml/2006/main" prst="rect">
             <a:avLst/>
@@ -13297,17 +13813,17 @@
           <a:lstStyle xmlns:a="http://schemas.openxmlformats.org/drawingml/2006/main"/>
           <a:p xmlns:a="http://schemas.openxmlformats.org/drawingml/2006/main">
             <a:pPr algn="l">
-              <a:defRPr sz="2475" b="0">
-                <a:solidFill>
-                  <a:srgbClr val="16343E"/>
-                </a:solidFill>
-                <a:latin typeface="Arial"/>
-                <a:ea typeface="Arial"/>
-                <a:cs typeface="Arial"/>
-              </a:defRPr>
-            </a:pPr>
-            <a:r>
-              <a:rPr sz="2475" b="0">
+              <a:defRPr sz="2250" b="0">
+                <a:solidFill>
+                  <a:srgbClr val="16343E"/>
+                </a:solidFill>
+                <a:latin typeface="Arial"/>
+                <a:ea typeface="Arial"/>
+                <a:cs typeface="Arial"/>
+              </a:defRPr>
+            </a:pPr>
+            <a:r>
+              <a:rPr sz="2250" b="0">
                 <a:solidFill>
                   <a:srgbClr val="16343E"/>
                 </a:solidFill>
@@ -13320,17 +13836,17 @@
           </a:p>
           <a:p xmlns:a="http://schemas.openxmlformats.org/drawingml/2006/main">
             <a:pPr algn="l">
-              <a:defRPr sz="2475" b="0">
-                <a:solidFill>
-                  <a:srgbClr val="16343E"/>
-                </a:solidFill>
-                <a:latin typeface="Arial"/>
-                <a:ea typeface="Arial"/>
-                <a:cs typeface="Arial"/>
-              </a:defRPr>
-            </a:pPr>
-            <a:r>
-              <a:rPr sz="2475" b="0">
+              <a:defRPr sz="2250" b="0">
+                <a:solidFill>
+                  <a:srgbClr val="16343E"/>
+                </a:solidFill>
+                <a:latin typeface="Arial"/>
+                <a:ea typeface="Arial"/>
+                <a:cs typeface="Arial"/>
+              </a:defRPr>
+            </a:pPr>
+            <a:r>
+              <a:rPr sz="2250" b="0">
                 <a:solidFill>
                   <a:srgbClr val="16343E"/>
                 </a:solidFill>
@@ -13348,7 +13864,7 @@
           <p:cNvPr id="5" name="">
             <a:extLst xmlns:a="http://schemas.openxmlformats.org/drawingml/2006/main">
               <a:ext uri="{FF2B5EF4-FFF2-40B4-BE49-F238E27FC236}">
-                <a16:creationId xmlns:a16="http://schemas.microsoft.com/office/drawing/2014/main" id="{C5E466E1-0F6A-456A-97BF-24C9374B9A38}"/>
+                <a16:creationId xmlns:a16="http://schemas.microsoft.com/office/drawing/2014/main" id="{CB430DC7-55E8-4C91-80E0-2C7BA3E14CEA}"/>
               </a:ext>
             </a:extLst>
           </p:cNvPr>
@@ -13359,7 +13875,7 @@
         </p:nvSpPr>
         <p:spPr>
           <a:xfrm xmlns:a="http://schemas.openxmlformats.org/drawingml/2006/main">
-            <a:off x="609600" y="2790825"/>
+            <a:off x="609600" y="2371725"/>
             <a:ext cx="10972800" cy="0"/>
           </a:xfrm>
           <a:prstGeom xmlns:a="http://schemas.openxmlformats.org/drawingml/2006/main" prst="line">
@@ -13377,7 +13893,7 @@
           <p:cNvPr id="6" name="">
             <a:extLst xmlns:a="http://schemas.openxmlformats.org/drawingml/2006/main">
               <a:ext uri="{FF2B5EF4-FFF2-40B4-BE49-F238E27FC236}">
-                <a16:creationId xmlns:a16="http://schemas.microsoft.com/office/drawing/2014/main" id="{4F5D591D-CB0D-4A3D-AD20-58CCF9E1CE36}"/>
+                <a16:creationId xmlns:a16="http://schemas.microsoft.com/office/drawing/2014/main" id="{2A1119C6-95BF-4A1A-AD11-E3AEECF7C0C9}"/>
               </a:ext>
             </a:extLst>
           </p:cNvPr>
@@ -13388,8 +13904,8 @@
         </p:nvSpPr>
         <p:spPr>
           <a:xfrm xmlns:a="http://schemas.openxmlformats.org/drawingml/2006/main">
-            <a:off x="609600" y="3067050"/>
-            <a:ext cx="2609850" cy="857250"/>
+            <a:off x="609600" y="2552700"/>
+            <a:ext cx="2609850" cy="771525"/>
           </a:xfrm>
           <a:prstGeom xmlns:a="http://schemas.openxmlformats.org/drawingml/2006/main" prst="rect">
             <a:avLst/>
@@ -13406,17 +13922,17 @@
           <a:lstStyle xmlns:a="http://schemas.openxmlformats.org/drawingml/2006/main"/>
           <a:p xmlns:a="http://schemas.openxmlformats.org/drawingml/2006/main">
             <a:pPr algn="l">
-              <a:defRPr sz="2325" b="1">
-                <a:solidFill>
-                  <a:srgbClr val="16343E"/>
-                </a:solidFill>
-                <a:latin typeface="Arial"/>
-                <a:ea typeface="Arial"/>
-                <a:cs typeface="Arial"/>
-              </a:defRPr>
-            </a:pPr>
-            <a:r>
-              <a:rPr sz="2325" b="1">
+              <a:defRPr sz="2175" b="1">
+                <a:solidFill>
+                  <a:srgbClr val="16343E"/>
+                </a:solidFill>
+                <a:latin typeface="Arial"/>
+                <a:ea typeface="Arial"/>
+                <a:cs typeface="Arial"/>
+              </a:defRPr>
+            </a:pPr>
+            <a:r>
+              <a:rPr sz="2175" b="1">
                 <a:solidFill>
                   <a:srgbClr val="16343E"/>
                 </a:solidFill>
@@ -13429,17 +13945,17 @@
           </a:p>
           <a:p xmlns:a="http://schemas.openxmlformats.org/drawingml/2006/main">
             <a:pPr algn="l">
-              <a:defRPr sz="2325" b="1">
-                <a:solidFill>
-                  <a:srgbClr val="16343E"/>
-                </a:solidFill>
-                <a:latin typeface="Arial"/>
-                <a:ea typeface="Arial"/>
-                <a:cs typeface="Arial"/>
-              </a:defRPr>
-            </a:pPr>
-            <a:r>
-              <a:rPr sz="2325" b="1">
+              <a:defRPr sz="2175" b="1">
+                <a:solidFill>
+                  <a:srgbClr val="16343E"/>
+                </a:solidFill>
+                <a:latin typeface="Arial"/>
+                <a:ea typeface="Arial"/>
+                <a:cs typeface="Arial"/>
+              </a:defRPr>
+            </a:pPr>
+            <a:r>
+              <a:rPr sz="2175" b="1">
                 <a:solidFill>
                   <a:srgbClr val="16343E"/>
                 </a:solidFill>
@@ -13457,7 +13973,7 @@
           <p:cNvPr id="7" name="">
             <a:extLst xmlns:a="http://schemas.openxmlformats.org/drawingml/2006/main">
               <a:ext uri="{FF2B5EF4-FFF2-40B4-BE49-F238E27FC236}">
-                <a16:creationId xmlns:a16="http://schemas.microsoft.com/office/drawing/2014/main" id="{587D9924-844B-42DC-AF11-92198606D6D1}"/>
+                <a16:creationId xmlns:a16="http://schemas.microsoft.com/office/drawing/2014/main" id="{59DC8E45-8715-4C5A-BE3C-6CEEF3D9E8A1}"/>
               </a:ext>
             </a:extLst>
           </p:cNvPr>
@@ -13468,8 +13984,8 @@
         </p:nvSpPr>
         <p:spPr>
           <a:xfrm xmlns:a="http://schemas.openxmlformats.org/drawingml/2006/main">
-            <a:off x="3476625" y="2962275"/>
-            <a:ext cx="8105775" cy="1333500"/>
+            <a:off x="3476625" y="2466975"/>
+            <a:ext cx="8105775" cy="1028700"/>
           </a:xfrm>
           <a:prstGeom xmlns:a="http://schemas.openxmlformats.org/drawingml/2006/main" prst="rect">
             <a:avLst/>
@@ -13486,71 +14002,71 @@
           <a:lstStyle xmlns:a="http://schemas.openxmlformats.org/drawingml/2006/main"/>
           <a:p xmlns:a="http://schemas.openxmlformats.org/drawingml/2006/main">
             <a:pPr algn="l">
-              <a:defRPr sz="2325" b="0">
-                <a:solidFill>
-                  <a:srgbClr val="16343E"/>
-                </a:solidFill>
-                <a:latin typeface="Arial"/>
-                <a:ea typeface="Arial"/>
-                <a:cs typeface="Arial"/>
-              </a:defRPr>
-            </a:pPr>
-            <a:r>
-              <a:rPr sz="2325" b="0">
-                <a:solidFill>
-                  <a:srgbClr val="16343E"/>
-                </a:solidFill>
-                <a:latin typeface="Arial"/>
-                <a:ea typeface="Arial"/>
-                <a:cs typeface="Arial"/>
-              </a:rPr>
-              <a:t>Higher initial molecular scores in patients who</a:t>
+              <a:defRPr sz="2100" b="0">
+                <a:solidFill>
+                  <a:srgbClr val="16343E"/>
+                </a:solidFill>
+                <a:latin typeface="Arial"/>
+                <a:ea typeface="Arial"/>
+                <a:cs typeface="Arial"/>
+              </a:defRPr>
+            </a:pPr>
+            <a:r>
+              <a:rPr sz="2100" b="0">
+                <a:solidFill>
+                  <a:srgbClr val="16343E"/>
+                </a:solidFill>
+                <a:latin typeface="Arial"/>
+                <a:ea typeface="Arial"/>
+                <a:cs typeface="Arial"/>
+              </a:rPr>
+              <a:t>Higher initial molecular scores in patients who later</a:t>
             </a:r>
           </a:p>
           <a:p xmlns:a="http://schemas.openxmlformats.org/drawingml/2006/main">
             <a:pPr algn="l">
-              <a:defRPr sz="2325" b="0">
-                <a:solidFill>
-                  <a:srgbClr val="16343E"/>
-                </a:solidFill>
-                <a:latin typeface="Arial"/>
-                <a:ea typeface="Arial"/>
-                <a:cs typeface="Arial"/>
-              </a:defRPr>
-            </a:pPr>
-            <a:r>
-              <a:rPr sz="2325" b="0">
-                <a:solidFill>
-                  <a:srgbClr val="16343E"/>
-                </a:solidFill>
-                <a:latin typeface="Arial"/>
-                <a:ea typeface="Arial"/>
-                <a:cs typeface="Arial"/>
-              </a:rPr>
-              <a:t>later developed chronic active antibody-mediated</a:t>
+              <a:defRPr sz="2100" b="0">
+                <a:solidFill>
+                  <a:srgbClr val="16343E"/>
+                </a:solidFill>
+                <a:latin typeface="Arial"/>
+                <a:ea typeface="Arial"/>
+                <a:cs typeface="Arial"/>
+              </a:defRPr>
+            </a:pPr>
+            <a:r>
+              <a:rPr sz="2100" b="0">
+                <a:solidFill>
+                  <a:srgbClr val="16343E"/>
+                </a:solidFill>
+                <a:latin typeface="Arial"/>
+                <a:ea typeface="Arial"/>
+                <a:cs typeface="Arial"/>
+              </a:rPr>
+              <a:t>developed chronic active antibody-mediated rejection,</a:t>
             </a:r>
           </a:p>
           <a:p xmlns:a="http://schemas.openxmlformats.org/drawingml/2006/main">
             <a:pPr algn="l">
-              <a:defRPr sz="2325" b="0">
-                <a:solidFill>
-                  <a:srgbClr val="16343E"/>
-                </a:solidFill>
-                <a:latin typeface="Arial"/>
-                <a:ea typeface="Arial"/>
-                <a:cs typeface="Arial"/>
-              </a:defRPr>
-            </a:pPr>
-            <a:r>
-              <a:rPr sz="2325" b="0">
-                <a:solidFill>
-                  <a:srgbClr val="16343E"/>
-                </a:solidFill>
-                <a:latin typeface="Arial"/>
-                <a:ea typeface="Arial"/>
-                <a:cs typeface="Arial"/>
-              </a:rPr>
-              <a:t>rejection, despite no initial diagnosis of it</a:t>
+              <a:defRPr sz="2100" b="0">
+                <a:solidFill>
+                  <a:srgbClr val="16343E"/>
+                </a:solidFill>
+                <a:latin typeface="Arial"/>
+                <a:ea typeface="Arial"/>
+                <a:cs typeface="Arial"/>
+              </a:defRPr>
+            </a:pPr>
+            <a:r>
+              <a:rPr sz="2100" b="0">
+                <a:solidFill>
+                  <a:srgbClr val="16343E"/>
+                </a:solidFill>
+                <a:latin typeface="Arial"/>
+                <a:ea typeface="Arial"/>
+                <a:cs typeface="Arial"/>
+              </a:rPr>
+              <a:t>despite no initial diagnosis of it</a:t>
             </a:r>
           </a:p>
         </p:txBody>
@@ -13560,7 +14076,7 @@
           <p:cNvPr id="8" name="">
             <a:extLst xmlns:a="http://schemas.openxmlformats.org/drawingml/2006/main">
               <a:ext uri="{FF2B5EF4-FFF2-40B4-BE49-F238E27FC236}">
-                <a16:creationId xmlns:a16="http://schemas.microsoft.com/office/drawing/2014/main" id="{AEAE6C24-EA5A-4EB5-8A5C-6C92CFBE30DC}"/>
+                <a16:creationId xmlns:a16="http://schemas.microsoft.com/office/drawing/2014/main" id="{3F858CA2-683E-48B4-8D22-FD68A1F61C61}"/>
               </a:ext>
             </a:extLst>
           </p:cNvPr>
@@ -13571,7 +14087,7 @@
         </p:nvSpPr>
         <p:spPr>
           <a:xfrm xmlns:a="http://schemas.openxmlformats.org/drawingml/2006/main">
-            <a:off x="609600" y="4572000"/>
+            <a:off x="609600" y="3648075"/>
             <a:ext cx="10972800" cy="0"/>
           </a:xfrm>
           <a:prstGeom xmlns:a="http://schemas.openxmlformats.org/drawingml/2006/main" prst="line">
@@ -13589,7 +14105,7 @@
           <p:cNvPr id="9" name="">
             <a:extLst xmlns:a="http://schemas.openxmlformats.org/drawingml/2006/main">
               <a:ext uri="{FF2B5EF4-FFF2-40B4-BE49-F238E27FC236}">
-                <a16:creationId xmlns:a16="http://schemas.microsoft.com/office/drawing/2014/main" id="{4BD538A9-F641-42C7-B989-E2BD32502DCF}"/>
+                <a16:creationId xmlns:a16="http://schemas.microsoft.com/office/drawing/2014/main" id="{E1ECC72D-AEBC-4041-8F02-491620920AA9}"/>
               </a:ext>
             </a:extLst>
           </p:cNvPr>
@@ -13600,8 +14116,8 @@
         </p:nvSpPr>
         <p:spPr>
           <a:xfrm xmlns:a="http://schemas.openxmlformats.org/drawingml/2006/main">
-            <a:off x="609600" y="4895850"/>
-            <a:ext cx="10972800" cy="1085850"/>
+            <a:off x="609600" y="3829050"/>
+            <a:ext cx="2609850" cy="981075"/>
           </a:xfrm>
           <a:prstGeom xmlns:a="http://schemas.openxmlformats.org/drawingml/2006/main" prst="rect">
             <a:avLst/>
@@ -13618,7 +14134,224 @@
           <a:lstStyle xmlns:a="http://schemas.openxmlformats.org/drawingml/2006/main"/>
           <a:p xmlns:a="http://schemas.openxmlformats.org/drawingml/2006/main">
             <a:pPr algn="l">
-              <a:defRPr sz="2475" b="1">
+              <a:defRPr sz="2100" b="1">
+                <a:solidFill>
+                  <a:srgbClr val="16343E"/>
+                </a:solidFill>
+                <a:latin typeface="Arial"/>
+                <a:ea typeface="Arial"/>
+                <a:cs typeface="Arial"/>
+              </a:defRPr>
+            </a:pPr>
+            <a:r>
+              <a:rPr sz="2100" b="1">
+                <a:solidFill>
+                  <a:srgbClr val="16343E"/>
+                </a:solidFill>
+                <a:latin typeface="Arial"/>
+                <a:ea typeface="Arial"/>
+                <a:cs typeface="Arial"/>
+              </a:rPr>
+              <a:t>Why incorrect</a:t>
+            </a:r>
+          </a:p>
+          <a:p xmlns:a="http://schemas.openxmlformats.org/drawingml/2006/main">
+            <a:pPr algn="l">
+              <a:defRPr sz="2100" b="1">
+                <a:solidFill>
+                  <a:srgbClr val="16343E"/>
+                </a:solidFill>
+                <a:latin typeface="Arial"/>
+                <a:ea typeface="Arial"/>
+                <a:cs typeface="Arial"/>
+              </a:defRPr>
+            </a:pPr>
+            <a:r>
+              <a:rPr sz="2100" b="1">
+                <a:solidFill>
+                  <a:srgbClr val="16343E"/>
+                </a:solidFill>
+                <a:latin typeface="Arial"/>
+                <a:ea typeface="Arial"/>
+                <a:cs typeface="Arial"/>
+              </a:rPr>
+              <a:t>rejection calls matter</a:t>
+            </a:r>
+          </a:p>
+        </p:txBody>
+      </p:sp>
+      <p:sp>
+        <p:nvSpPr>
+          <p:cNvPr id="10" name="">
+            <a:extLst xmlns:a="http://schemas.openxmlformats.org/drawingml/2006/main">
+              <a:ext uri="{FF2B5EF4-FFF2-40B4-BE49-F238E27FC236}">
+                <a16:creationId xmlns:a16="http://schemas.microsoft.com/office/drawing/2014/main" id="{F032FB58-BBDE-475A-AF7C-07746FF4FB97}"/>
+              </a:ext>
+            </a:extLst>
+          </p:cNvPr>
+          <p:cNvSpPr>
+            <a:spLocks xmlns:a="http://schemas.openxmlformats.org/drawingml/2006/main" noGrp="1"/>
+          </p:cNvSpPr>
+          <p:nvPr/>
+        </p:nvSpPr>
+        <p:spPr>
+          <a:xfrm xmlns:a="http://schemas.openxmlformats.org/drawingml/2006/main">
+            <a:off x="3476625" y="3781425"/>
+            <a:ext cx="8105775" cy="1019175"/>
+          </a:xfrm>
+          <a:prstGeom xmlns:a="http://schemas.openxmlformats.org/drawingml/2006/main" prst="rect">
+            <a:avLst/>
+          </a:prstGeom>
+          <a:noFill xmlns:a="http://schemas.openxmlformats.org/drawingml/2006/main"/>
+          <a:ln xmlns:a="http://schemas.openxmlformats.org/drawingml/2006/main" w="0">
+            <a:noFill/>
+          </a:ln>
+        </p:spPr>
+        <p:txBody>
+          <a:bodyPr xmlns:a="http://schemas.openxmlformats.org/drawingml/2006/main" anchor="ctr">
+            <a:noAutofit/>
+          </a:bodyPr>
+          <a:lstStyle xmlns:a="http://schemas.openxmlformats.org/drawingml/2006/main"/>
+          <a:p xmlns:a="http://schemas.openxmlformats.org/drawingml/2006/main">
+            <a:pPr algn="l">
+              <a:defRPr sz="2175" b="0">
+                <a:solidFill>
+                  <a:srgbClr val="16343E"/>
+                </a:solidFill>
+                <a:latin typeface="Arial"/>
+                <a:ea typeface="Arial"/>
+                <a:cs typeface="Arial"/>
+              </a:defRPr>
+            </a:pPr>
+            <a:r>
+              <a:rPr sz="2175" b="0">
+                <a:solidFill>
+                  <a:srgbClr val="16343E"/>
+                </a:solidFill>
+                <a:latin typeface="Arial"/>
+                <a:ea typeface="Arial"/>
+                <a:cs typeface="Arial"/>
+              </a:rPr>
+              <a:t>Unnecessary rejection treatment can weaken the body’s</a:t>
+            </a:r>
+          </a:p>
+          <a:p xmlns:a="http://schemas.openxmlformats.org/drawingml/2006/main">
+            <a:pPr algn="l">
+              <a:defRPr sz="2175" b="0">
+                <a:solidFill>
+                  <a:srgbClr val="16343E"/>
+                </a:solidFill>
+                <a:latin typeface="Arial"/>
+                <a:ea typeface="Arial"/>
+                <a:cs typeface="Arial"/>
+              </a:defRPr>
+            </a:pPr>
+            <a:r>
+              <a:rPr sz="2175" b="0">
+                <a:solidFill>
+                  <a:srgbClr val="16343E"/>
+                </a:solidFill>
+                <a:latin typeface="Arial"/>
+                <a:ea typeface="Arial"/>
+                <a:cs typeface="Arial"/>
+              </a:rPr>
+              <a:t>defenses and worsen an infection.</a:t>
+            </a:r>
+          </a:p>
+        </p:txBody>
+      </p:sp>
+      <p:sp>
+        <p:nvSpPr>
+          <p:cNvPr id="11" name="">
+            <a:extLst xmlns:a="http://schemas.openxmlformats.org/drawingml/2006/main">
+              <a:ext uri="{FF2B5EF4-FFF2-40B4-BE49-F238E27FC236}">
+                <a16:creationId xmlns:a16="http://schemas.microsoft.com/office/drawing/2014/main" id="{17107F7D-5FED-40E1-A405-F51AF263E978}"/>
+              </a:ext>
+            </a:extLst>
+          </p:cNvPr>
+          <p:cNvSpPr>
+            <a:spLocks xmlns:a="http://schemas.openxmlformats.org/drawingml/2006/main" noGrp="1"/>
+          </p:cNvSpPr>
+          <p:nvPr/>
+        </p:nvSpPr>
+        <p:spPr>
+          <a:xfrm xmlns:a="http://schemas.openxmlformats.org/drawingml/2006/main">
+            <a:off x="3476625" y="4829175"/>
+            <a:ext cx="8105775" cy="257175"/>
+          </a:xfrm>
+          <a:prstGeom xmlns:a="http://schemas.openxmlformats.org/drawingml/2006/main" prst="rect">
+            <a:avLst/>
+          </a:prstGeom>
+          <a:noFill xmlns:a="http://schemas.openxmlformats.org/drawingml/2006/main"/>
+          <a:ln xmlns:a="http://schemas.openxmlformats.org/drawingml/2006/main" w="0">
+            <a:noFill/>
+          </a:ln>
+        </p:spPr>
+        <p:txBody>
+          <a:bodyPr xmlns:a="http://schemas.openxmlformats.org/drawingml/2006/main" anchor="ctr">
+            <a:noAutofit/>
+          </a:bodyPr>
+          <a:lstStyle xmlns:a="http://schemas.openxmlformats.org/drawingml/2006/main"/>
+          <a:p xmlns:a="http://schemas.openxmlformats.org/drawingml/2006/main">
+            <a:pPr algn="l">
+              <a:defRPr sz="1350" b="0">
+                <a:solidFill>
+                  <a:srgbClr val="52656B"/>
+                </a:solidFill>
+                <a:latin typeface="Arial"/>
+                <a:ea typeface="Arial"/>
+                <a:cs typeface="Arial"/>
+              </a:defRPr>
+            </a:pPr>
+            <a:r>
+              <a:rPr sz="1350" b="0">
+                <a:solidFill>
+                  <a:srgbClr val="52656B"/>
+                </a:solidFill>
+                <a:latin typeface="Arial"/>
+                <a:ea typeface="Arial"/>
+                <a:cs typeface="Arial"/>
+              </a:rPr>
+              <a:t>KDIGO (2009); BK polyomavirus consensus (2024)</a:t>
+            </a:r>
+          </a:p>
+        </p:txBody>
+      </p:sp>
+      <p:sp>
+        <p:nvSpPr>
+          <p:cNvPr id="12" name="">
+            <a:extLst xmlns:a="http://schemas.openxmlformats.org/drawingml/2006/main">
+              <a:ext uri="{FF2B5EF4-FFF2-40B4-BE49-F238E27FC236}">
+                <a16:creationId xmlns:a16="http://schemas.microsoft.com/office/drawing/2014/main" id="{663C5AA1-6A21-4297-A81D-F39FD1C371FC}"/>
+              </a:ext>
+            </a:extLst>
+          </p:cNvPr>
+          <p:cNvSpPr>
+            <a:spLocks xmlns:a="http://schemas.openxmlformats.org/drawingml/2006/main" noGrp="1"/>
+          </p:cNvSpPr>
+          <p:nvPr/>
+        </p:nvSpPr>
+        <p:spPr>
+          <a:xfrm xmlns:a="http://schemas.openxmlformats.org/drawingml/2006/main">
+            <a:off x="609600" y="5286375"/>
+            <a:ext cx="10972800" cy="809625"/>
+          </a:xfrm>
+          <a:prstGeom xmlns:a="http://schemas.openxmlformats.org/drawingml/2006/main" prst="rect">
+            <a:avLst/>
+          </a:prstGeom>
+          <a:noFill xmlns:a="http://schemas.openxmlformats.org/drawingml/2006/main"/>
+          <a:ln xmlns:a="http://schemas.openxmlformats.org/drawingml/2006/main" w="0">
+            <a:noFill/>
+          </a:ln>
+        </p:spPr>
+        <p:txBody>
+          <a:bodyPr xmlns:a="http://schemas.openxmlformats.org/drawingml/2006/main" anchor="ctr">
+            <a:noAutofit/>
+          </a:bodyPr>
+          <a:lstStyle xmlns:a="http://schemas.openxmlformats.org/drawingml/2006/main"/>
+          <a:p xmlns:a="http://schemas.openxmlformats.org/drawingml/2006/main">
+            <a:pPr algn="l">
+              <a:defRPr sz="2250" b="1">
                 <a:solidFill>
                   <a:srgbClr val="007C78"/>
                 </a:solidFill>
@@ -13628,7 +14361,7 @@
               </a:defRPr>
             </a:pPr>
             <a:r>
-              <a:rPr sz="2475" b="1">
+              <a:rPr sz="2250" b="1">
                 <a:solidFill>
                   <a:srgbClr val="007C78"/>
                 </a:solidFill>
@@ -13641,7 +14374,7 @@
           </a:p>
           <a:p xmlns:a="http://schemas.openxmlformats.org/drawingml/2006/main">
             <a:pPr algn="l">
-              <a:defRPr sz="2475" b="1">
+              <a:defRPr sz="2250" b="1">
                 <a:solidFill>
                   <a:srgbClr val="007C78"/>
                 </a:solidFill>
@@ -13651,7 +14384,7 @@
               </a:defRPr>
             </a:pPr>
             <a:r>
-              <a:rPr sz="2475" b="1">
+              <a:rPr sz="2250" b="1">
                 <a:solidFill>
                   <a:srgbClr val="007C78"/>
                 </a:solidFill>
@@ -13667,7 +14400,7 @@
     </p:spTree>
     <p:extLst>
       <p:ext uri="{BB962C8B-B14F-4D97-AF65-F5344CB8AC3E}">
-        <p14:creationId xmlns:p14="http://schemas.microsoft.com/office/powerpoint/2010/main" val="678934267"/>
+        <p14:creationId xmlns:p14="http://schemas.microsoft.com/office/powerpoint/2010/main" val="1374412812"/>
       </p:ext>
     </p:extLst>
   </p:cSld>
@@ -13698,7 +14431,7 @@
           <p:cNvPr id="13" name="">
             <a:extLst xmlns:a="http://schemas.openxmlformats.org/drawingml/2006/main">
               <a:ext uri="{FF2B5EF4-FFF2-40B4-BE49-F238E27FC236}">
-                <a16:creationId xmlns:a16="http://schemas.microsoft.com/office/drawing/2014/main" id="{D1C3AF68-6122-4AC9-B4F7-8A37EB18C64F}"/>
+                <a16:creationId xmlns:a16="http://schemas.microsoft.com/office/drawing/2014/main" id="{517497A1-0C23-4806-AC7B-AAF575DBB633}"/>
               </a:ext>
             </a:extLst>
           </p:cNvPr>
@@ -13755,7 +14488,7 @@
           <p:cNvPr id="2" name="">
             <a:extLst xmlns:a="http://schemas.openxmlformats.org/drawingml/2006/main">
               <a:ext uri="{FF2B5EF4-FFF2-40B4-BE49-F238E27FC236}">
-                <a16:creationId xmlns:a16="http://schemas.microsoft.com/office/drawing/2014/main" id="{B6695A7E-DA75-47BA-A221-0FDC6C04E2C1}"/>
+                <a16:creationId xmlns:a16="http://schemas.microsoft.com/office/drawing/2014/main" id="{04EC1BB6-D4D2-467B-8E4D-1EE08DA65541}"/>
               </a:ext>
             </a:extLst>
           </p:cNvPr>
@@ -13802,7 +14535,7 @@
                 <a:ea typeface="Arial"/>
                 <a:cs typeface="Arial"/>
               </a:rPr>
-              <a:t>Sources: GSE212160; Zhang et al. (2024), Tables 5–6; project data reader</a:t>
+              <a:t>Sources: GSE212160; Zhang et al. (2024), Methods and Tables 5–6; project data reader</a:t>
             </a:r>
           </a:p>
         </p:txBody>
@@ -13812,7 +14545,7 @@
           <p:cNvPr id="3" name="">
             <a:extLst xmlns:a="http://schemas.openxmlformats.org/drawingml/2006/main">
               <a:ext uri="{FF2B5EF4-FFF2-40B4-BE49-F238E27FC236}">
-                <a16:creationId xmlns:a16="http://schemas.microsoft.com/office/drawing/2014/main" id="{2D17BDD4-B208-4689-AC28-93B3359B1426}"/>
+                <a16:creationId xmlns:a16="http://schemas.microsoft.com/office/drawing/2014/main" id="{4245295C-B14B-4CFE-BF8A-0909F342A510}"/>
               </a:ext>
             </a:extLst>
           </p:cNvPr>
@@ -13869,7 +14602,7 @@
           <p:cNvPr id="4" name="">
             <a:extLst xmlns:a="http://schemas.openxmlformats.org/drawingml/2006/main">
               <a:ext uri="{FF2B5EF4-FFF2-40B4-BE49-F238E27FC236}">
-                <a16:creationId xmlns:a16="http://schemas.microsoft.com/office/drawing/2014/main" id="{966E6ED7-54A8-449B-9EBE-673551EB4E1A}"/>
+                <a16:creationId xmlns:a16="http://schemas.microsoft.com/office/drawing/2014/main" id="{1BF2AB9C-AD2E-41C6-8B9A-F79927A20DA8}"/>
               </a:ext>
             </a:extLst>
           </p:cNvPr>
@@ -13926,7 +14659,7 @@
           <p:cNvPr id="5" name="">
             <a:extLst xmlns:a="http://schemas.openxmlformats.org/drawingml/2006/main">
               <a:ext uri="{FF2B5EF4-FFF2-40B4-BE49-F238E27FC236}">
-                <a16:creationId xmlns:a16="http://schemas.microsoft.com/office/drawing/2014/main" id="{44CF3F60-C1DD-4B6C-A1BF-C50F49AEFEDE}"/>
+                <a16:creationId xmlns:a16="http://schemas.microsoft.com/office/drawing/2014/main" id="{EF1D6A05-DCF3-4F01-9DE7-722B805433A9}"/>
               </a:ext>
             </a:extLst>
           </p:cNvPr>
@@ -13937,7 +14670,7 @@
         </p:nvSpPr>
         <p:spPr>
           <a:xfrm xmlns:a="http://schemas.openxmlformats.org/drawingml/2006/main">
-            <a:off x="609600" y="2628900"/>
+            <a:off x="609600" y="2343150"/>
             <a:ext cx="4781550" cy="447675"/>
           </a:xfrm>
           <a:prstGeom xmlns:a="http://schemas.openxmlformats.org/drawingml/2006/main" prst="rect">
@@ -13983,7 +14716,7 @@
           <p:cNvPr id="6" name="">
             <a:extLst xmlns:a="http://schemas.openxmlformats.org/drawingml/2006/main">
               <a:ext uri="{FF2B5EF4-FFF2-40B4-BE49-F238E27FC236}">
-                <a16:creationId xmlns:a16="http://schemas.microsoft.com/office/drawing/2014/main" id="{B944F978-1822-47C3-BD62-F90CF7883715}"/>
+                <a16:creationId xmlns:a16="http://schemas.microsoft.com/office/drawing/2014/main" id="{6F4DEA1B-4018-45BA-B3C1-48CB8218DAEF}"/>
               </a:ext>
             </a:extLst>
           </p:cNvPr>
@@ -13994,7 +14727,7 @@
         </p:nvSpPr>
         <p:spPr>
           <a:xfrm xmlns:a="http://schemas.openxmlformats.org/drawingml/2006/main">
-            <a:off x="6819900" y="2628900"/>
+            <a:off x="6819900" y="2343150"/>
             <a:ext cx="4762500" cy="447675"/>
           </a:xfrm>
           <a:prstGeom xmlns:a="http://schemas.openxmlformats.org/drawingml/2006/main" prst="rect">
@@ -14042,7 +14775,7 @@
           <p:nvPr/>
         </p:nvGraphicFramePr>
         <p:xfrm>
-          <a:off xmlns:a="http://schemas.openxmlformats.org/drawingml/2006/main" x="609600" y="3333750"/>
+          <a:off xmlns:a="http://schemas.openxmlformats.org/drawingml/2006/main" x="609600" y="2990850"/>
           <a:ext xmlns:a="http://schemas.openxmlformats.org/drawingml/2006/main" cx="4781550" cy="2276475"/>
         </p:xfrm>
         <a:graphic xmlns:a="http://schemas.openxmlformats.org/drawingml/2006/main">
@@ -14334,7 +15067,7 @@
           <p:nvPr/>
         </p:nvGraphicFramePr>
         <p:xfrm>
-          <a:off xmlns:a="http://schemas.openxmlformats.org/drawingml/2006/main" x="6819900" y="3333750"/>
+          <a:off xmlns:a="http://schemas.openxmlformats.org/drawingml/2006/main" x="6819900" y="2990850"/>
           <a:ext xmlns:a="http://schemas.openxmlformats.org/drawingml/2006/main" cx="4762500" cy="2276475"/>
         </p:xfrm>
         <a:graphic xmlns:a="http://schemas.openxmlformats.org/drawingml/2006/main">
@@ -14624,7 +15357,7 @@
           <p:cNvPr id="9" name="">
             <a:extLst xmlns:a="http://schemas.openxmlformats.org/drawingml/2006/main">
               <a:ext uri="{FF2B5EF4-FFF2-40B4-BE49-F238E27FC236}">
-                <a16:creationId xmlns:a16="http://schemas.microsoft.com/office/drawing/2014/main" id="{A99CF02A-1925-4033-9E34-A7EE6232B789}"/>
+                <a16:creationId xmlns:a16="http://schemas.microsoft.com/office/drawing/2014/main" id="{D9E367C0-0516-42F2-85D1-9042DE15EAD7}"/>
               </a:ext>
             </a:extLst>
           </p:cNvPr>
@@ -14635,7 +15368,7 @@
         </p:nvSpPr>
         <p:spPr>
           <a:xfrm xmlns:a="http://schemas.openxmlformats.org/drawingml/2006/main">
-            <a:off x="5391150" y="4019550"/>
+            <a:off x="5391150" y="3676650"/>
             <a:ext cx="1428750" cy="0"/>
           </a:xfrm>
           <a:prstGeom xmlns:a="http://schemas.openxmlformats.org/drawingml/2006/main" prst="line">
@@ -14653,7 +15386,7 @@
           <p:cNvPr id="10" name="">
             <a:extLst xmlns:a="http://schemas.openxmlformats.org/drawingml/2006/main">
               <a:ext uri="{FF2B5EF4-FFF2-40B4-BE49-F238E27FC236}">
-                <a16:creationId xmlns:a16="http://schemas.microsoft.com/office/drawing/2014/main" id="{88578FD9-F10A-4FF8-BACB-C87439FCD78A}"/>
+                <a16:creationId xmlns:a16="http://schemas.microsoft.com/office/drawing/2014/main" id="{8190575A-F8D9-4C93-B3D2-B23863226946}"/>
               </a:ext>
             </a:extLst>
           </p:cNvPr>
@@ -14664,7 +15397,7 @@
         </p:nvSpPr>
         <p:spPr>
           <a:xfrm xmlns:a="http://schemas.openxmlformats.org/drawingml/2006/main">
-            <a:off x="5467350" y="3619500"/>
+            <a:off x="5467350" y="3276600"/>
             <a:ext cx="1276350" cy="323850"/>
           </a:xfrm>
           <a:prstGeom xmlns:a="http://schemas.openxmlformats.org/drawingml/2006/main" prst="rect">
@@ -14710,7 +15443,7 @@
           <p:cNvPr id="11" name="">
             <a:extLst xmlns:a="http://schemas.openxmlformats.org/drawingml/2006/main">
               <a:ext uri="{FF2B5EF4-FFF2-40B4-BE49-F238E27FC236}">
-                <a16:creationId xmlns:a16="http://schemas.microsoft.com/office/drawing/2014/main" id="{58D65CD6-CA8C-4DAA-91C1-D6DA5796227E}"/>
+                <a16:creationId xmlns:a16="http://schemas.microsoft.com/office/drawing/2014/main" id="{6FC5A186-1A1A-42D1-8A13-D3BA6D88870A}"/>
               </a:ext>
             </a:extLst>
           </p:cNvPr>
@@ -14721,7 +15454,7 @@
         </p:nvSpPr>
         <p:spPr>
           <a:xfrm xmlns:a="http://schemas.openxmlformats.org/drawingml/2006/main">
-            <a:off x="5467350" y="4095750"/>
+            <a:off x="5467350" y="3752850"/>
             <a:ext cx="1276350" cy="333375"/>
           </a:xfrm>
           <a:prstGeom xmlns:a="http://schemas.openxmlformats.org/drawingml/2006/main" prst="rect">
@@ -14767,7 +15500,7 @@
           <p:cNvPr id="12" name="">
             <a:extLst xmlns:a="http://schemas.openxmlformats.org/drawingml/2006/main">
               <a:ext uri="{FF2B5EF4-FFF2-40B4-BE49-F238E27FC236}">
-                <a16:creationId xmlns:a16="http://schemas.microsoft.com/office/drawing/2014/main" id="{B5800147-36EF-4BCE-A64E-277CABDEE080}"/>
+                <a16:creationId xmlns:a16="http://schemas.microsoft.com/office/drawing/2014/main" id="{0BC0FA2D-1820-4D9A-BF5D-FEAB20B7DD22}"/>
               </a:ext>
             </a:extLst>
           </p:cNvPr>
@@ -14778,8 +15511,8 @@
         </p:nvSpPr>
         <p:spPr>
           <a:xfrm xmlns:a="http://schemas.openxmlformats.org/drawingml/2006/main">
-            <a:off x="609600" y="5810250"/>
-            <a:ext cx="10972800" cy="371475"/>
+            <a:off x="609600" y="5467350"/>
+            <a:ext cx="10972800" cy="723900"/>
           </a:xfrm>
           <a:prstGeom xmlns:a="http://schemas.openxmlformats.org/drawingml/2006/main" prst="rect">
             <a:avLst/>
@@ -14790,23 +15523,27 @@
           </a:ln>
         </p:spPr>
         <p:txBody>
-          <a:bodyPr xmlns:a="http://schemas.openxmlformats.org/drawingml/2006/main" anchor="ctr">
+          <a:bodyPr xmlns:a="http://schemas.openxmlformats.org/drawingml/2006/main" anchor="t">
             <a:noAutofit/>
           </a:bodyPr>
           <a:lstStyle xmlns:a="http://schemas.openxmlformats.org/drawingml/2006/main"/>
           <a:p xmlns:a="http://schemas.openxmlformats.org/drawingml/2006/main">
-            <a:pPr algn="l">
-              <a:defRPr sz="2025" b="0">
-                <a:solidFill>
-                  <a:srgbClr val="16343E"/>
-                </a:solidFill>
-                <a:latin typeface="Arial"/>
-                <a:ea typeface="Arial"/>
-                <a:cs typeface="Arial"/>
-              </a:defRPr>
-            </a:pPr>
-            <a:r>
-              <a:rPr sz="2025" b="0">
+            <a:pPr marL="279400" indent="-152400" algn="l">
+              <a:spcAft>
+                <a:spcPts val="800"/>
+              </a:spcAft>
+              <a:buChar char="•"/>
+              <a:defRPr sz="1875" b="0">
+                <a:solidFill>
+                  <a:srgbClr val="16343E"/>
+                </a:solidFill>
+                <a:latin typeface="Arial"/>
+                <a:ea typeface="Arial"/>
+                <a:cs typeface="Arial"/>
+              </a:defRPr>
+            </a:pPr>
+            <a:r>
+              <a:rPr sz="1875" b="0">
                 <a:solidFill>
                   <a:srgbClr val="16343E"/>
                 </a:solidFill>
@@ -14815,6 +15552,33 @@
                 <a:cs typeface="Arial"/>
               </a:rPr>
               <a:t>Includes 1,193 transplant biopsies and 202 native-kidney controls.</a:t>
+            </a:r>
+          </a:p>
+          <a:p xmlns:a="http://schemas.openxmlformats.org/drawingml/2006/main">
+            <a:pPr marL="279400" indent="-152400" algn="l">
+              <a:spcAft>
+                <a:spcPts val="800"/>
+              </a:spcAft>
+              <a:buChar char="•"/>
+              <a:defRPr sz="1875" b="0">
+                <a:solidFill>
+                  <a:srgbClr val="16343E"/>
+                </a:solidFill>
+                <a:latin typeface="Arial"/>
+                <a:ea typeface="Arial"/>
+                <a:cs typeface="Arial"/>
+              </a:defRPr>
+            </a:pPr>
+            <a:r>
+              <a:rPr sz="1875" b="0">
+                <a:solidFill>
+                  <a:srgbClr val="16343E"/>
+                </a:solidFill>
+                <a:latin typeface="Arial"/>
+                <a:ea typeface="Arial"/>
+                <a:cs typeface="Arial"/>
+              </a:rPr>
+              <a:t>The study does not document separation by patient or referring center between study groups.</a:t>
             </a:r>
           </a:p>
         </p:txBody>
@@ -14822,7 +15586,7 @@
     </p:spTree>
     <p:extLst>
       <p:ext uri="{BB962C8B-B14F-4D97-AF65-F5344CB8AC3E}">
-        <p14:creationId xmlns:p14="http://schemas.microsoft.com/office/powerpoint/2010/main" val="226790736"/>
+        <p14:creationId xmlns:p14="http://schemas.microsoft.com/office/powerpoint/2010/main" val="53266795"/>
       </p:ext>
     </p:extLst>
   </p:cSld>
@@ -14853,7 +15617,7 @@
           <p:cNvPr id="7" name="">
             <a:extLst xmlns:a="http://schemas.openxmlformats.org/drawingml/2006/main">
               <a:ext uri="{FF2B5EF4-FFF2-40B4-BE49-F238E27FC236}">
-                <a16:creationId xmlns:a16="http://schemas.microsoft.com/office/drawing/2014/main" id="{9F181F1B-25CF-4DC5-9E56-862CA3703E96}"/>
+                <a16:creationId xmlns:a16="http://schemas.microsoft.com/office/drawing/2014/main" id="{3B13B808-2BB4-4937-B684-33B4F348E3D8}"/>
               </a:ext>
             </a:extLst>
           </p:cNvPr>
@@ -14910,7 +15674,7 @@
           <p:cNvPr id="2" name="">
             <a:extLst xmlns:a="http://schemas.openxmlformats.org/drawingml/2006/main">
               <a:ext uri="{FF2B5EF4-FFF2-40B4-BE49-F238E27FC236}">
-                <a16:creationId xmlns:a16="http://schemas.microsoft.com/office/drawing/2014/main" id="{EEF9FD1E-4A1C-48A0-AA04-EA7CDF03E9DB}"/>
+                <a16:creationId xmlns:a16="http://schemas.microsoft.com/office/drawing/2014/main" id="{8B0563C3-7CC1-4BA1-BC4E-C3896C419745}"/>
               </a:ext>
             </a:extLst>
           </p:cNvPr>
@@ -14967,7 +15731,7 @@
           <p:cNvPr id="3" name="">
             <a:extLst xmlns:a="http://schemas.openxmlformats.org/drawingml/2006/main">
               <a:ext uri="{FF2B5EF4-FFF2-40B4-BE49-F238E27FC236}">
-                <a16:creationId xmlns:a16="http://schemas.microsoft.com/office/drawing/2014/main" id="{42EF78D0-302D-41D1-A494-3D8C0FF3FECA}"/>
+                <a16:creationId xmlns:a16="http://schemas.microsoft.com/office/drawing/2014/main" id="{F934B2D8-1DCD-4FAC-BC37-99F02BD24DA9}"/>
               </a:ext>
             </a:extLst>
           </p:cNvPr>
@@ -15024,7 +15788,7 @@
           <p:cNvPr id="4" name="">
             <a:extLst xmlns:a="http://schemas.openxmlformats.org/drawingml/2006/main">
               <a:ext uri="{FF2B5EF4-FFF2-40B4-BE49-F238E27FC236}">
-                <a16:creationId xmlns:a16="http://schemas.microsoft.com/office/drawing/2014/main" id="{95539E92-7929-4E7A-81FE-FB039DDDDD6D}"/>
+                <a16:creationId xmlns:a16="http://schemas.microsoft.com/office/drawing/2014/main" id="{2362F86C-0BF9-4658-BBD7-AE3E9F846C23}"/>
               </a:ext>
             </a:extLst>
           </p:cNvPr>
@@ -15504,7 +16268,7 @@
           <p:cNvPr id="6" name="">
             <a:extLst xmlns:a="http://schemas.openxmlformats.org/drawingml/2006/main">
               <a:ext uri="{FF2B5EF4-FFF2-40B4-BE49-F238E27FC236}">
-                <a16:creationId xmlns:a16="http://schemas.microsoft.com/office/drawing/2014/main" id="{DDFE2DC3-454F-40B8-A91B-E0ACF30FA75E}"/>
+                <a16:creationId xmlns:a16="http://schemas.microsoft.com/office/drawing/2014/main" id="{9F559C41-DB40-4107-9C0B-8EBA86D27B45}"/>
               </a:ext>
             </a:extLst>
           </p:cNvPr>
@@ -15559,7 +16323,7 @@
     </p:spTree>
     <p:extLst>
       <p:ext uri="{BB962C8B-B14F-4D97-AF65-F5344CB8AC3E}">
-        <p14:creationId xmlns:p14="http://schemas.microsoft.com/office/powerpoint/2010/main" val="799425300"/>
+        <p14:creationId xmlns:p14="http://schemas.microsoft.com/office/powerpoint/2010/main" val="1867624314"/>
       </p:ext>
     </p:extLst>
   </p:cSld>
@@ -15590,7 +16354,7 @@
           <p:cNvPr id="11" name="">
             <a:extLst xmlns:a="http://schemas.openxmlformats.org/drawingml/2006/main">
               <a:ext uri="{FF2B5EF4-FFF2-40B4-BE49-F238E27FC236}">
-                <a16:creationId xmlns:a16="http://schemas.microsoft.com/office/drawing/2014/main" id="{01019537-945F-459A-89CF-90B826F55CB6}"/>
+                <a16:creationId xmlns:a16="http://schemas.microsoft.com/office/drawing/2014/main" id="{8FA6ABA4-7136-4747-9567-66C3F23819FB}"/>
               </a:ext>
             </a:extLst>
           </p:cNvPr>
@@ -15647,7 +16411,7 @@
           <p:cNvPr id="2" name="">
             <a:extLst xmlns:a="http://schemas.openxmlformats.org/drawingml/2006/main">
               <a:ext uri="{FF2B5EF4-FFF2-40B4-BE49-F238E27FC236}">
-                <a16:creationId xmlns:a16="http://schemas.microsoft.com/office/drawing/2014/main" id="{C346A449-D8C1-4911-9E10-743D18204D41}"/>
+                <a16:creationId xmlns:a16="http://schemas.microsoft.com/office/drawing/2014/main" id="{B8679DE8-5A33-4F4C-A307-361D66662BAA}"/>
               </a:ext>
             </a:extLst>
           </p:cNvPr>
@@ -15704,7 +16468,7 @@
           <p:cNvPr id="3" name="">
             <a:extLst xmlns:a="http://schemas.openxmlformats.org/drawingml/2006/main">
               <a:ext uri="{FF2B5EF4-FFF2-40B4-BE49-F238E27FC236}">
-                <a16:creationId xmlns:a16="http://schemas.microsoft.com/office/drawing/2014/main" id="{8D675409-E84C-4F09-849C-E73A5AA2BD6B}"/>
+                <a16:creationId xmlns:a16="http://schemas.microsoft.com/office/drawing/2014/main" id="{A945066F-904A-4C5C-BE02-6857700C5B2F}"/>
               </a:ext>
             </a:extLst>
           </p:cNvPr>
@@ -15761,7 +16525,7 @@
           <p:cNvPr id="4" name="">
             <a:extLst xmlns:a="http://schemas.openxmlformats.org/drawingml/2006/main">
               <a:ext uri="{FF2B5EF4-FFF2-40B4-BE49-F238E27FC236}">
-                <a16:creationId xmlns:a16="http://schemas.microsoft.com/office/drawing/2014/main" id="{B70F0D56-4DFE-4846-9295-8A006A4433BD}"/>
+                <a16:creationId xmlns:a16="http://schemas.microsoft.com/office/drawing/2014/main" id="{D4435EB7-FDB9-4AC4-968B-DCB4DAD16862}"/>
               </a:ext>
             </a:extLst>
           </p:cNvPr>
@@ -15818,7 +16582,7 @@
           <p:cNvPr id="5" name="">
             <a:extLst xmlns:a="http://schemas.openxmlformats.org/drawingml/2006/main">
               <a:ext uri="{FF2B5EF4-FFF2-40B4-BE49-F238E27FC236}">
-                <a16:creationId xmlns:a16="http://schemas.microsoft.com/office/drawing/2014/main" id="{ED51939A-7B5C-4759-B6F1-ACA5B2A3A50C}"/>
+                <a16:creationId xmlns:a16="http://schemas.microsoft.com/office/drawing/2014/main" id="{289C47E9-43DD-4001-A86F-CBA8B1228B37}"/>
               </a:ext>
             </a:extLst>
           </p:cNvPr>
@@ -15875,7 +16639,7 @@
           <p:cNvPr id="6" name="">
             <a:extLst xmlns:a="http://schemas.openxmlformats.org/drawingml/2006/main">
               <a:ext uri="{FF2B5EF4-FFF2-40B4-BE49-F238E27FC236}">
-                <a16:creationId xmlns:a16="http://schemas.microsoft.com/office/drawing/2014/main" id="{2AEE672E-3E67-4831-8512-CF8B4C745ED7}"/>
+                <a16:creationId xmlns:a16="http://schemas.microsoft.com/office/drawing/2014/main" id="{1DD675FC-F32B-42AB-B917-48D75F7163BE}"/>
               </a:ext>
             </a:extLst>
           </p:cNvPr>
@@ -15932,7 +16696,7 @@
           <p:cNvPr id="7" name="">
             <a:extLst xmlns:a="http://schemas.openxmlformats.org/drawingml/2006/main">
               <a:ext uri="{FF2B5EF4-FFF2-40B4-BE49-F238E27FC236}">
-                <a16:creationId xmlns:a16="http://schemas.microsoft.com/office/drawing/2014/main" id="{8096422C-C33F-4148-990F-C180AC26D2E3}"/>
+                <a16:creationId xmlns:a16="http://schemas.microsoft.com/office/drawing/2014/main" id="{70DC698D-BDEA-4A70-8C68-3ADC74FC6EC3}"/>
               </a:ext>
             </a:extLst>
           </p:cNvPr>
@@ -16020,7 +16784,7 @@
           <p:cNvPr id="8" name="">
             <a:extLst xmlns:a="http://schemas.openxmlformats.org/drawingml/2006/main">
               <a:ext uri="{FF2B5EF4-FFF2-40B4-BE49-F238E27FC236}">
-                <a16:creationId xmlns:a16="http://schemas.microsoft.com/office/drawing/2014/main" id="{B72D3CFD-8E2E-4015-A4B1-D8EB0591A2F8}"/>
+                <a16:creationId xmlns:a16="http://schemas.microsoft.com/office/drawing/2014/main" id="{F33373E1-ADE9-476C-B000-E4341011AC2B}"/>
               </a:ext>
             </a:extLst>
           </p:cNvPr>
@@ -16077,7 +16841,7 @@
           <p:cNvPr id="9" name="">
             <a:extLst xmlns:a="http://schemas.openxmlformats.org/drawingml/2006/main">
               <a:ext uri="{FF2B5EF4-FFF2-40B4-BE49-F238E27FC236}">
-                <a16:creationId xmlns:a16="http://schemas.microsoft.com/office/drawing/2014/main" id="{D2574B07-F256-49EC-9289-551127636050}"/>
+                <a16:creationId xmlns:a16="http://schemas.microsoft.com/office/drawing/2014/main" id="{655B14D4-CDA2-44BA-A0E2-CF066D25AAFC}"/>
               </a:ext>
             </a:extLst>
           </p:cNvPr>
@@ -16134,7 +16898,7 @@
           <p:cNvPr id="10" name="">
             <a:extLst xmlns:a="http://schemas.openxmlformats.org/drawingml/2006/main">
               <a:ext uri="{FF2B5EF4-FFF2-40B4-BE49-F238E27FC236}">
-                <a16:creationId xmlns:a16="http://schemas.microsoft.com/office/drawing/2014/main" id="{6170D545-2508-4343-8ACA-E2D772387C95}"/>
+                <a16:creationId xmlns:a16="http://schemas.microsoft.com/office/drawing/2014/main" id="{A2BC13FD-3F68-46D9-8392-9EAEEB02B34F}"/>
               </a:ext>
             </a:extLst>
           </p:cNvPr>
@@ -16220,7 +16984,7 @@
     </p:spTree>
     <p:extLst>
       <p:ext uri="{BB962C8B-B14F-4D97-AF65-F5344CB8AC3E}">
-        <p14:creationId xmlns:p14="http://schemas.microsoft.com/office/powerpoint/2010/main" val="970247735"/>
+        <p14:creationId xmlns:p14="http://schemas.microsoft.com/office/powerpoint/2010/main" val="481325537"/>
       </p:ext>
     </p:extLst>
   </p:cSld>
@@ -16251,7 +17015,7 @@
           <p:cNvPr id="5" name="">
             <a:extLst xmlns:a="http://schemas.openxmlformats.org/drawingml/2006/main">
               <a:ext uri="{FF2B5EF4-FFF2-40B4-BE49-F238E27FC236}">
-                <a16:creationId xmlns:a16="http://schemas.microsoft.com/office/drawing/2014/main" id="{7482C293-6724-4227-A01C-F36D0591C4D2}"/>
+                <a16:creationId xmlns:a16="http://schemas.microsoft.com/office/drawing/2014/main" id="{998BC72A-C5D1-4659-80EB-65CA7696DF34}"/>
               </a:ext>
             </a:extLst>
           </p:cNvPr>
@@ -16308,7 +17072,7 @@
           <p:cNvPr id="2" name="">
             <a:extLst xmlns:a="http://schemas.openxmlformats.org/drawingml/2006/main">
               <a:ext uri="{FF2B5EF4-FFF2-40B4-BE49-F238E27FC236}">
-                <a16:creationId xmlns:a16="http://schemas.microsoft.com/office/drawing/2014/main" id="{F032DA67-E3B9-4FFA-8254-27CD28363CC4}"/>
+                <a16:creationId xmlns:a16="http://schemas.microsoft.com/office/drawing/2014/main" id="{44AEECC4-F095-4F81-8CA4-452EE1AD821A}"/>
               </a:ext>
             </a:extLst>
           </p:cNvPr>
@@ -16365,7 +17129,7 @@
           <p:cNvPr id="3" name="">
             <a:extLst xmlns:a="http://schemas.openxmlformats.org/drawingml/2006/main">
               <a:ext uri="{FF2B5EF4-FFF2-40B4-BE49-F238E27FC236}">
-                <a16:creationId xmlns:a16="http://schemas.microsoft.com/office/drawing/2014/main" id="{AE19C01C-B110-412E-BF1E-4F801731A45D}"/>
+                <a16:creationId xmlns:a16="http://schemas.microsoft.com/office/drawing/2014/main" id="{D1F921DB-AA27-4F56-9EDE-8F4EAC388976}"/>
               </a:ext>
             </a:extLst>
           </p:cNvPr>
@@ -16712,7 +17476,7 @@
     </p:spTree>
     <p:extLst>
       <p:ext uri="{BB962C8B-B14F-4D97-AF65-F5344CB8AC3E}">
-        <p14:creationId xmlns:p14="http://schemas.microsoft.com/office/powerpoint/2010/main" val="1728725474"/>
+        <p14:creationId xmlns:p14="http://schemas.microsoft.com/office/powerpoint/2010/main" val="603511967"/>
       </p:ext>
     </p:extLst>
   </p:cSld>
@@ -16740,10 +17504,10 @@
       </p:grpSpPr>
       <p:sp>
         <p:nvSpPr>
-          <p:cNvPr id="12" name="">
+          <p:cNvPr id="11" name="">
             <a:extLst xmlns:a="http://schemas.openxmlformats.org/drawingml/2006/main">
               <a:ext uri="{FF2B5EF4-FFF2-40B4-BE49-F238E27FC236}">
-                <a16:creationId xmlns:a16="http://schemas.microsoft.com/office/drawing/2014/main" id="{94D4CBF4-831D-43CB-93D5-E9EF4EC494C8}"/>
+                <a16:creationId xmlns:a16="http://schemas.microsoft.com/office/drawing/2014/main" id="{A32EED76-5B79-45EA-B79E-62E593160FBF}"/>
               </a:ext>
             </a:extLst>
           </p:cNvPr>
@@ -16800,7 +17564,7 @@
           <p:cNvPr id="2" name="">
             <a:extLst xmlns:a="http://schemas.openxmlformats.org/drawingml/2006/main">
               <a:ext uri="{FF2B5EF4-FFF2-40B4-BE49-F238E27FC236}">
-                <a16:creationId xmlns:a16="http://schemas.microsoft.com/office/drawing/2014/main" id="{2371D178-423C-4789-96AB-CFEF0CD862E7}"/>
+                <a16:creationId xmlns:a16="http://schemas.microsoft.com/office/drawing/2014/main" id="{303DDE87-11A4-43E5-8369-63F91B8AE660}"/>
               </a:ext>
             </a:extLst>
           </p:cNvPr>
@@ -16857,7 +17621,7 @@
           <p:cNvPr id="3" name="">
             <a:extLst xmlns:a="http://schemas.openxmlformats.org/drawingml/2006/main">
               <a:ext uri="{FF2B5EF4-FFF2-40B4-BE49-F238E27FC236}">
-                <a16:creationId xmlns:a16="http://schemas.microsoft.com/office/drawing/2014/main" id="{95427286-838E-4AAC-A869-AE1A99368BEB}"/>
+                <a16:creationId xmlns:a16="http://schemas.microsoft.com/office/drawing/2014/main" id="{5FFDEF61-9CDB-4A07-877F-75CD426FC67C}"/>
               </a:ext>
             </a:extLst>
           </p:cNvPr>
@@ -16914,7 +17678,7 @@
           <p:cNvPr id="4" name="">
             <a:extLst xmlns:a="http://schemas.openxmlformats.org/drawingml/2006/main">
               <a:ext uri="{FF2B5EF4-FFF2-40B4-BE49-F238E27FC236}">
-                <a16:creationId xmlns:a16="http://schemas.microsoft.com/office/drawing/2014/main" id="{171BD683-7896-40EE-B7BC-8D4E2C88C363}"/>
+                <a16:creationId xmlns:a16="http://schemas.microsoft.com/office/drawing/2014/main" id="{19CB5857-2414-41EF-BD6A-E7E5F588F03B}"/>
               </a:ext>
             </a:extLst>
           </p:cNvPr>
@@ -17002,7 +17766,7 @@
           <p:cNvPr id="5" name="">
             <a:extLst xmlns:a="http://schemas.openxmlformats.org/drawingml/2006/main">
               <a:ext uri="{FF2B5EF4-FFF2-40B4-BE49-F238E27FC236}">
-                <a16:creationId xmlns:a16="http://schemas.microsoft.com/office/drawing/2014/main" id="{882A0D62-1850-4028-BD5A-4DD7A40667EB}"/>
+                <a16:creationId xmlns:a16="http://schemas.microsoft.com/office/drawing/2014/main" id="{3D3CEF92-A00E-4EA1-B540-EE2232A9D827}"/>
               </a:ext>
             </a:extLst>
           </p:cNvPr>
@@ -17086,7 +17850,7 @@
           <p:cNvPr id="6" name="">
             <a:extLst xmlns:a="http://schemas.openxmlformats.org/drawingml/2006/main">
               <a:ext uri="{FF2B5EF4-FFF2-40B4-BE49-F238E27FC236}">
-                <a16:creationId xmlns:a16="http://schemas.microsoft.com/office/drawing/2014/main" id="{115DEF77-144C-476B-AA4B-415592A61FC9}"/>
+                <a16:creationId xmlns:a16="http://schemas.microsoft.com/office/drawing/2014/main" id="{A38DCAF6-EA70-4EF7-B719-FDF680382F68}"/>
               </a:ext>
             </a:extLst>
           </p:cNvPr>
@@ -17170,7 +17934,7 @@
           <p:cNvPr id="7" name="">
             <a:extLst xmlns:a="http://schemas.openxmlformats.org/drawingml/2006/main">
               <a:ext uri="{FF2B5EF4-FFF2-40B4-BE49-F238E27FC236}">
-                <a16:creationId xmlns:a16="http://schemas.microsoft.com/office/drawing/2014/main" id="{F298BDEC-EAD2-4E50-ABC3-90086D5A9C5B}"/>
+                <a16:creationId xmlns:a16="http://schemas.microsoft.com/office/drawing/2014/main" id="{2C1B96DD-6EF8-42EB-ADEE-3251F0BB2613}"/>
               </a:ext>
             </a:extLst>
           </p:cNvPr>
@@ -17251,7 +18015,7 @@
       </p:sp>
       <p:cxnSp>
         <p:nvCxnSpPr>
-          <p:cNvPr id="19" name=""/>
+          <p:cNvPr id="18" name=""/>
           <p:cNvCxnSpPr>
             <a:stCxn xmlns:a="http://schemas.openxmlformats.org/drawingml/2006/main" id="5" idx="2"/>
             <a:endCxn xmlns:a="http://schemas.openxmlformats.org/drawingml/2006/main" id="6" idx="0"/>
@@ -17279,7 +18043,7 @@
       </p:cxnSp>
       <p:cxnSp>
         <p:nvCxnSpPr>
-          <p:cNvPr id="20" name=""/>
+          <p:cNvPr id="19" name=""/>
           <p:cNvCxnSpPr>
             <a:stCxn xmlns:a="http://schemas.openxmlformats.org/drawingml/2006/main" id="5" idx="2"/>
             <a:endCxn xmlns:a="http://schemas.openxmlformats.org/drawingml/2006/main" id="7" idx="0"/>
@@ -17310,7 +18074,7 @@
           <p:cNvPr id="10" name="">
             <a:extLst xmlns:a="http://schemas.openxmlformats.org/drawingml/2006/main">
               <a:ext uri="{FF2B5EF4-FFF2-40B4-BE49-F238E27FC236}">
-                <a16:creationId xmlns:a16="http://schemas.microsoft.com/office/drawing/2014/main" id="{98619F37-A93D-4676-80D3-F5CE8C520346}"/>
+                <a16:creationId xmlns:a16="http://schemas.microsoft.com/office/drawing/2014/main" id="{D47066D6-D86B-40BF-92F1-032E797BE925}"/>
               </a:ext>
             </a:extLst>
           </p:cNvPr>
@@ -17440,67 +18204,10 @@
           </a:p>
         </p:txBody>
       </p:sp>
-      <p:sp>
-        <p:nvSpPr>
-          <p:cNvPr id="11" name="">
-            <a:extLst xmlns:a="http://schemas.openxmlformats.org/drawingml/2006/main">
-              <a:ext uri="{FF2B5EF4-FFF2-40B4-BE49-F238E27FC236}">
-                <a16:creationId xmlns:a16="http://schemas.microsoft.com/office/drawing/2014/main" id="{D0137FC3-7A2F-4997-AC1A-7CAD01E73411}"/>
-              </a:ext>
-            </a:extLst>
-          </p:cNvPr>
-          <p:cNvSpPr>
-            <a:spLocks xmlns:a="http://schemas.openxmlformats.org/drawingml/2006/main" noGrp="1"/>
-          </p:cNvSpPr>
-          <p:nvPr/>
-        </p:nvSpPr>
-        <p:spPr>
-          <a:xfrm xmlns:a="http://schemas.openxmlformats.org/drawingml/2006/main">
-            <a:off x="609600" y="5848350"/>
-            <a:ext cx="10972800" cy="342900"/>
-          </a:xfrm>
-          <a:prstGeom xmlns:a="http://schemas.openxmlformats.org/drawingml/2006/main" prst="rect">
-            <a:avLst/>
-          </a:prstGeom>
-          <a:noFill xmlns:a="http://schemas.openxmlformats.org/drawingml/2006/main"/>
-          <a:ln xmlns:a="http://schemas.openxmlformats.org/drawingml/2006/main" w="0">
-            <a:noFill/>
-          </a:ln>
-        </p:spPr>
-        <p:txBody>
-          <a:bodyPr xmlns:a="http://schemas.openxmlformats.org/drawingml/2006/main" anchor="ctr">
-            <a:noAutofit/>
-          </a:bodyPr>
-          <a:lstStyle xmlns:a="http://schemas.openxmlformats.org/drawingml/2006/main"/>
-          <a:p xmlns:a="http://schemas.openxmlformats.org/drawingml/2006/main">
-            <a:pPr algn="l">
-              <a:defRPr sz="1950" b="0">
-                <a:solidFill>
-                  <a:srgbClr val="16343E"/>
-                </a:solidFill>
-                <a:latin typeface="Arial"/>
-                <a:ea typeface="Arial"/>
-                <a:cs typeface="Arial"/>
-              </a:defRPr>
-            </a:pPr>
-            <a:r>
-              <a:rPr sz="1950" b="0">
-                <a:solidFill>
-                  <a:srgbClr val="16343E"/>
-                </a:solidFill>
-                <a:latin typeface="Arial"/>
-                <a:ea typeface="Arial"/>
-                <a:cs typeface="Arial"/>
-              </a:rPr>
-              <a:t>*Patient and referring-center separation are not documented in the study.</a:t>
-            </a:r>
-          </a:p>
-        </p:txBody>
-      </p:sp>
     </p:spTree>
     <p:extLst>
       <p:ext uri="{BB962C8B-B14F-4D97-AF65-F5344CB8AC3E}">
-        <p14:creationId xmlns:p14="http://schemas.microsoft.com/office/powerpoint/2010/main" val="793949922"/>
+        <p14:creationId xmlns:p14="http://schemas.microsoft.com/office/powerpoint/2010/main" val="782157859"/>
       </p:ext>
     </p:extLst>
   </p:cSld>

</xml_diff>

<commit_message>
Reconcile source-study findings and document methodology
</commit_message>
<xml_diff>
--- a/presentation/unos_kidney_biopsy.pptx
+++ b/presentation/unos_kidney_biopsy.pptx
@@ -2,37 +2,37 @@
 <file path=ppt/presentation.xml><?xml version="1.0" encoding="utf-8"?>
 <p:presentation xmlns:p="http://schemas.openxmlformats.org/presentationml/2006/main" xmlns:r="http://schemas.openxmlformats.org/officeDocument/2006/relationships">
   <p:sldMasterIdLst>
-    <p:sldMasterId id="2147483648" r:id="R6aa170a24b4340e0"/>
+    <p:sldMasterId id="2147483648" r:id="R7774073c01bb411c"/>
   </p:sldMasterIdLst>
   <p:sldIdLst>
-    <p:sldId id="256" r:id="Rb8a9d4ff5c114b4d"/>
-    <p:sldId id="257" r:id="Rd1cfa362c39a4d0f"/>
-    <p:sldId id="258" r:id="R669a1701949b43ab"/>
-    <p:sldId id="259" r:id="R114cb4a482b94705"/>
-    <p:sldId id="260" r:id="R02264290dfaf4008"/>
-    <p:sldId id="261" r:id="Rab168b01868a44fc"/>
-    <p:sldId id="262" r:id="R2a4b077876e94aef"/>
-    <p:sldId id="263" r:id="R377b62088b7d4a89"/>
-    <p:sldId id="264" r:id="Rb3e8736392ac4b5d"/>
-    <p:sldId id="265" r:id="R49d4573d94844bd8"/>
-    <p:sldId id="266" r:id="Re4f2fdd002a449fb"/>
-    <p:sldId id="267" r:id="R40b860add8c0490d"/>
-    <p:sldId id="268" r:id="Ra4cca81810b24d3a"/>
-    <p:sldId id="269" r:id="R46a20048d58a4a19"/>
-    <p:sldId id="270" r:id="Rd22a3041bc5d4a22"/>
-    <p:sldId id="271" r:id="R747708837d23423a"/>
-    <p:sldId id="272" r:id="R0d3e2cc92efd428f"/>
-    <p:sldId id="273" r:id="R694ad4f27212493b"/>
-    <p:sldId id="274" r:id="Rec6cf7b1574e4a8d"/>
-    <p:sldId id="275" r:id="R4227d634ef9b4500"/>
-    <p:sldId id="276" r:id="R3d4454a4d0564758"/>
-    <p:sldId id="277" r:id="R30410cdb453144eb"/>
-    <p:sldId id="278" r:id="Rddc5eb51e4324ef8"/>
-    <p:sldId id="279" r:id="Rec7c7b38083e4cd0"/>
-    <p:sldId id="280" r:id="R6944550b5df94736"/>
-    <p:sldId id="281" r:id="R2f319dd0935548f9"/>
-    <p:sldId id="282" r:id="Ra867be7762d84d2c"/>
-    <p:sldId id="283" r:id="R7c1174a5d7c848d2"/>
+    <p:sldId id="256" r:id="Rfd8531a0aec54c3f"/>
+    <p:sldId id="257" r:id="R74bb408217b5440d"/>
+    <p:sldId id="258" r:id="R1cf8721bd4194095"/>
+    <p:sldId id="259" r:id="R35cda89b91ba4f51"/>
+    <p:sldId id="260" r:id="R1fbdc952ff884d3a"/>
+    <p:sldId id="261" r:id="R7fe7089d49234dda"/>
+    <p:sldId id="262" r:id="R52f7fed439054593"/>
+    <p:sldId id="263" r:id="R2c8067f3d5b34a05"/>
+    <p:sldId id="264" r:id="Rb3b5e4264c254af8"/>
+    <p:sldId id="265" r:id="R887e41daa2754bc7"/>
+    <p:sldId id="266" r:id="Rc7c6314caafa4ae5"/>
+    <p:sldId id="267" r:id="R9207c263edb14e95"/>
+    <p:sldId id="268" r:id="R768de5ec83f5410d"/>
+    <p:sldId id="269" r:id="R91f7a4618cd84434"/>
+    <p:sldId id="270" r:id="R94ff88df8e614afa"/>
+    <p:sldId id="271" r:id="Rcfeb2795a64b4df7"/>
+    <p:sldId id="272" r:id="Rfaf8ae27affc4a77"/>
+    <p:sldId id="273" r:id="R0fc17d1099794fd3"/>
+    <p:sldId id="274" r:id="R1b07c50167c94d32"/>
+    <p:sldId id="275" r:id="Rcbb6821efe0d4a65"/>
+    <p:sldId id="276" r:id="R30e803465e1b4d4a"/>
+    <p:sldId id="277" r:id="R534315b83c4c490d"/>
+    <p:sldId id="278" r:id="R881ed418b3804c6b"/>
+    <p:sldId id="279" r:id="Rd512c2c93ab64101"/>
+    <p:sldId id="280" r:id="R97bcf03cee7e473c"/>
+    <p:sldId id="281" r:id="R67135188b8204a6c"/>
+    <p:sldId id="282" r:id="Rdc5326e1ba9d4c41"/>
+    <p:sldId id="283" r:id="R82c812a3451e4bee"/>
   </p:sldIdLst>
   <p:sldSz cx="12192000" cy="6858000"/>
   <p:notesSz cx="6858000" cy="9144000"/>
@@ -77,7 +77,7 @@
   </p:cSld>
   <p:clrMap bg1="lt1" tx1="dk1" bg2="lt2" tx2="dk2" accent1="accent1" accent2="accent2" accent3="accent3" accent4="accent4" accent5="accent5" accent6="accent6" hlink="hlink" folHlink="folHlink"/>
   <p:sldLayoutIdLst>
-    <p:sldLayoutId xmlns:r="http://schemas.openxmlformats.org/officeDocument/2006/relationships" id="2147483649" r:id="R0f1890886f2f4f66"/>
+    <p:sldLayoutId xmlns:r="http://schemas.openxmlformats.org/officeDocument/2006/relationships" id="2147483649" r:id="R779a5abcae41489b"/>
   </p:sldLayoutIdLst>
   <p:txStyles>
     <p:titleStyle>
@@ -1250,7 +1250,7 @@
           <p:cNvPr id="2" name="">
             <a:extLst xmlns:a="http://schemas.openxmlformats.org/drawingml/2006/main">
               <a:ext uri="{FF2B5EF4-FFF2-40B4-BE49-F238E27FC236}">
-                <a16:creationId xmlns:a16="http://schemas.microsoft.com/office/drawing/2014/main" id="{053830A3-EEC7-4B0E-81E9-471F45253A22}"/>
+                <a16:creationId xmlns:a16="http://schemas.microsoft.com/office/drawing/2014/main" id="{C847B5AB-E997-4182-8808-DC8405BE635E}"/>
               </a:ext>
             </a:extLst>
           </p:cNvPr>
@@ -1351,7 +1351,7 @@
     </p:spTree>
     <p:extLst>
       <p:ext uri="{BB962C8B-B14F-4D97-AF65-F5344CB8AC3E}">
-        <p14:creationId xmlns:p14="http://schemas.microsoft.com/office/powerpoint/2010/main" val="1672114085"/>
+        <p14:creationId xmlns:p14="http://schemas.microsoft.com/office/powerpoint/2010/main" val="1680737355"/>
       </p:ext>
     </p:extLst>
   </p:cSld>
@@ -1382,7 +1382,7 @@
           <p:cNvPr id="6" name="">
             <a:extLst xmlns:a="http://schemas.openxmlformats.org/drawingml/2006/main">
               <a:ext uri="{FF2B5EF4-FFF2-40B4-BE49-F238E27FC236}">
-                <a16:creationId xmlns:a16="http://schemas.microsoft.com/office/drawing/2014/main" id="{78192CDD-B1C2-42E2-8D2D-729A3E0435E9}"/>
+                <a16:creationId xmlns:a16="http://schemas.microsoft.com/office/drawing/2014/main" id="{68F695A3-119B-4C4A-AB88-617B9E9CCABF}"/>
               </a:ext>
             </a:extLst>
           </p:cNvPr>
@@ -1439,7 +1439,7 @@
           <p:cNvPr id="2" name="">
             <a:extLst xmlns:a="http://schemas.openxmlformats.org/drawingml/2006/main">
               <a:ext uri="{FF2B5EF4-FFF2-40B4-BE49-F238E27FC236}">
-                <a16:creationId xmlns:a16="http://schemas.microsoft.com/office/drawing/2014/main" id="{63517380-117D-4BC6-84F3-D0ABE4648B86}"/>
+                <a16:creationId xmlns:a16="http://schemas.microsoft.com/office/drawing/2014/main" id="{048D4573-32F9-425A-AB2E-798DC8CD86B7}"/>
               </a:ext>
             </a:extLst>
           </p:cNvPr>
@@ -1496,7 +1496,7 @@
           <p:cNvPr id="3" name="">
             <a:extLst xmlns:a="http://schemas.openxmlformats.org/drawingml/2006/main">
               <a:ext uri="{FF2B5EF4-FFF2-40B4-BE49-F238E27FC236}">
-                <a16:creationId xmlns:a16="http://schemas.microsoft.com/office/drawing/2014/main" id="{D1AAB18C-E75F-48B0-878C-895804BF773C}"/>
+                <a16:creationId xmlns:a16="http://schemas.microsoft.com/office/drawing/2014/main" id="{32FE306D-2D8F-4340-A7BF-3DC53B4E744E}"/>
               </a:ext>
             </a:extLst>
           </p:cNvPr>
@@ -1553,7 +1553,7 @@
           <p:cNvPr id="4" name="">
             <a:extLst xmlns:a="http://schemas.openxmlformats.org/drawingml/2006/main">
               <a:ext uri="{FF2B5EF4-FFF2-40B4-BE49-F238E27FC236}">
-                <a16:creationId xmlns:a16="http://schemas.microsoft.com/office/drawing/2014/main" id="{757C03AB-72D9-45B5-B02C-5C0F85DB55D0}"/>
+                <a16:creationId xmlns:a16="http://schemas.microsoft.com/office/drawing/2014/main" id="{017407CE-690B-4408-BC39-065275C665E5}"/>
               </a:ext>
             </a:extLst>
           </p:cNvPr>
@@ -1952,7 +1952,7 @@
     </p:spTree>
     <p:extLst>
       <p:ext uri="{BB962C8B-B14F-4D97-AF65-F5344CB8AC3E}">
-        <p14:creationId xmlns:p14="http://schemas.microsoft.com/office/powerpoint/2010/main" val="1776389490"/>
+        <p14:creationId xmlns:p14="http://schemas.microsoft.com/office/powerpoint/2010/main" val="1135119898"/>
       </p:ext>
     </p:extLst>
   </p:cSld>
@@ -1983,7 +1983,7 @@
           <p:cNvPr id="17" name="">
             <a:extLst xmlns:a="http://schemas.openxmlformats.org/drawingml/2006/main">
               <a:ext uri="{FF2B5EF4-FFF2-40B4-BE49-F238E27FC236}">
-                <a16:creationId xmlns:a16="http://schemas.microsoft.com/office/drawing/2014/main" id="{5C647A27-521D-4B78-8FC2-5DB69725297E}"/>
+                <a16:creationId xmlns:a16="http://schemas.microsoft.com/office/drawing/2014/main" id="{AD559558-3735-4E4C-9CF2-7CC11AF12CAC}"/>
               </a:ext>
             </a:extLst>
           </p:cNvPr>
@@ -2040,7 +2040,7 @@
           <p:cNvPr id="2" name="">
             <a:extLst xmlns:a="http://schemas.openxmlformats.org/drawingml/2006/main">
               <a:ext uri="{FF2B5EF4-FFF2-40B4-BE49-F238E27FC236}">
-                <a16:creationId xmlns:a16="http://schemas.microsoft.com/office/drawing/2014/main" id="{8A971F09-B754-4F30-A2F0-1874F535B141}"/>
+                <a16:creationId xmlns:a16="http://schemas.microsoft.com/office/drawing/2014/main" id="{97FE6F22-14A2-4EBA-91D1-A16752AC0177}"/>
               </a:ext>
             </a:extLst>
           </p:cNvPr>
@@ -2097,7 +2097,7 @@
           <p:cNvPr id="3" name="">
             <a:extLst xmlns:a="http://schemas.openxmlformats.org/drawingml/2006/main">
               <a:ext uri="{FF2B5EF4-FFF2-40B4-BE49-F238E27FC236}">
-                <a16:creationId xmlns:a16="http://schemas.microsoft.com/office/drawing/2014/main" id="{723AF733-B116-436E-8183-79B26D249D6E}"/>
+                <a16:creationId xmlns:a16="http://schemas.microsoft.com/office/drawing/2014/main" id="{FCCC86D0-3906-45EA-82D5-1E29C5E19856}"/>
               </a:ext>
             </a:extLst>
           </p:cNvPr>
@@ -2154,7 +2154,7 @@
           <p:cNvPr id="4" name="">
             <a:extLst xmlns:a="http://schemas.openxmlformats.org/drawingml/2006/main">
               <a:ext uri="{FF2B5EF4-FFF2-40B4-BE49-F238E27FC236}">
-                <a16:creationId xmlns:a16="http://schemas.microsoft.com/office/drawing/2014/main" id="{DF276B88-3497-4DB9-A1A4-4DB1E0B1B80A}"/>
+                <a16:creationId xmlns:a16="http://schemas.microsoft.com/office/drawing/2014/main" id="{7414763F-C5D2-4CD4-AC0B-2C10C8541D63}"/>
               </a:ext>
             </a:extLst>
           </p:cNvPr>
@@ -2211,7 +2211,7 @@
           <p:cNvPr id="5" name="">
             <a:extLst xmlns:a="http://schemas.openxmlformats.org/drawingml/2006/main">
               <a:ext uri="{FF2B5EF4-FFF2-40B4-BE49-F238E27FC236}">
-                <a16:creationId xmlns:a16="http://schemas.microsoft.com/office/drawing/2014/main" id="{76611A0B-3A24-467B-9617-1CBFBCD6CC6B}"/>
+                <a16:creationId xmlns:a16="http://schemas.microsoft.com/office/drawing/2014/main" id="{E82BF9D3-3AAC-400B-92A5-DB88559C883B}"/>
               </a:ext>
             </a:extLst>
           </p:cNvPr>
@@ -2268,7 +2268,7 @@
           <p:cNvPr id="6" name="">
             <a:extLst xmlns:a="http://schemas.openxmlformats.org/drawingml/2006/main">
               <a:ext uri="{FF2B5EF4-FFF2-40B4-BE49-F238E27FC236}">
-                <a16:creationId xmlns:a16="http://schemas.microsoft.com/office/drawing/2014/main" id="{AEE8327A-1CF4-4312-88F6-2844F3B38CD1}"/>
+                <a16:creationId xmlns:a16="http://schemas.microsoft.com/office/drawing/2014/main" id="{90545AC7-1434-4985-B17A-ED880AEF03A1}"/>
               </a:ext>
             </a:extLst>
           </p:cNvPr>
@@ -2297,7 +2297,7 @@
           <p:cNvPr id="7" name="">
             <a:extLst xmlns:a="http://schemas.openxmlformats.org/drawingml/2006/main">
               <a:ext uri="{FF2B5EF4-FFF2-40B4-BE49-F238E27FC236}">
-                <a16:creationId xmlns:a16="http://schemas.microsoft.com/office/drawing/2014/main" id="{CA97ED30-2F9C-4923-9233-935D615DE9D8}"/>
+                <a16:creationId xmlns:a16="http://schemas.microsoft.com/office/drawing/2014/main" id="{5F427BF2-A5D0-49D6-8A1A-5C950E3A9D53}"/>
               </a:ext>
             </a:extLst>
           </p:cNvPr>
@@ -2354,7 +2354,7 @@
           <p:cNvPr id="8" name="">
             <a:extLst xmlns:a="http://schemas.openxmlformats.org/drawingml/2006/main">
               <a:ext uri="{FF2B5EF4-FFF2-40B4-BE49-F238E27FC236}">
-                <a16:creationId xmlns:a16="http://schemas.microsoft.com/office/drawing/2014/main" id="{720E2A1F-3BB6-4A2F-91B0-9AFF8DF92B03}"/>
+                <a16:creationId xmlns:a16="http://schemas.microsoft.com/office/drawing/2014/main" id="{5D0C0FA8-24CC-48E7-9D39-E860CB4D262E}"/>
               </a:ext>
             </a:extLst>
           </p:cNvPr>
@@ -2411,7 +2411,7 @@
           <p:cNvPr id="9" name="">
             <a:extLst xmlns:a="http://schemas.openxmlformats.org/drawingml/2006/main">
               <a:ext uri="{FF2B5EF4-FFF2-40B4-BE49-F238E27FC236}">
-                <a16:creationId xmlns:a16="http://schemas.microsoft.com/office/drawing/2014/main" id="{77E9857B-17F0-4303-990C-5DEB49A8DE9E}"/>
+                <a16:creationId xmlns:a16="http://schemas.microsoft.com/office/drawing/2014/main" id="{85D1C4A9-FBE7-4DED-AB05-FCEEA9FB9111}"/>
               </a:ext>
             </a:extLst>
           </p:cNvPr>
@@ -2468,7 +2468,7 @@
           <p:cNvPr id="10" name="">
             <a:extLst xmlns:a="http://schemas.openxmlformats.org/drawingml/2006/main">
               <a:ext uri="{FF2B5EF4-FFF2-40B4-BE49-F238E27FC236}">
-                <a16:creationId xmlns:a16="http://schemas.microsoft.com/office/drawing/2014/main" id="{FB18350F-6227-4593-AE11-F819BCBBF3E5}"/>
+                <a16:creationId xmlns:a16="http://schemas.microsoft.com/office/drawing/2014/main" id="{F9BC31CA-676F-4EDC-A78B-3B1BBDDBAFD3}"/>
               </a:ext>
             </a:extLst>
           </p:cNvPr>
@@ -2525,7 +2525,7 @@
           <p:cNvPr id="11" name="">
             <a:extLst xmlns:a="http://schemas.openxmlformats.org/drawingml/2006/main">
               <a:ext uri="{FF2B5EF4-FFF2-40B4-BE49-F238E27FC236}">
-                <a16:creationId xmlns:a16="http://schemas.microsoft.com/office/drawing/2014/main" id="{A3BEEAB5-477C-428B-B725-0F6EDDCFA586}"/>
+                <a16:creationId xmlns:a16="http://schemas.microsoft.com/office/drawing/2014/main" id="{E109645C-9DEA-4EA6-AB36-DEF8AAA9544B}"/>
               </a:ext>
             </a:extLst>
           </p:cNvPr>
@@ -2554,7 +2554,7 @@
           <p:cNvPr id="12" name="">
             <a:extLst xmlns:a="http://schemas.openxmlformats.org/drawingml/2006/main">
               <a:ext uri="{FF2B5EF4-FFF2-40B4-BE49-F238E27FC236}">
-                <a16:creationId xmlns:a16="http://schemas.microsoft.com/office/drawing/2014/main" id="{C5B6BBEA-BA7B-47A3-884E-FBD443571EFF}"/>
+                <a16:creationId xmlns:a16="http://schemas.microsoft.com/office/drawing/2014/main" id="{9E10687A-C4D7-473B-936F-7DB6BAA01DCE}"/>
               </a:ext>
             </a:extLst>
           </p:cNvPr>
@@ -2611,7 +2611,7 @@
           <p:cNvPr id="13" name="">
             <a:extLst xmlns:a="http://schemas.openxmlformats.org/drawingml/2006/main">
               <a:ext uri="{FF2B5EF4-FFF2-40B4-BE49-F238E27FC236}">
-                <a16:creationId xmlns:a16="http://schemas.microsoft.com/office/drawing/2014/main" id="{FFE4EFDD-090B-4BAB-B508-17BF1A4A520A}"/>
+                <a16:creationId xmlns:a16="http://schemas.microsoft.com/office/drawing/2014/main" id="{DD91675A-35A7-43C7-AF9D-73D9F7F42CB3}"/>
               </a:ext>
             </a:extLst>
           </p:cNvPr>
@@ -2668,7 +2668,7 @@
           <p:cNvPr id="14" name="">
             <a:extLst xmlns:a="http://schemas.openxmlformats.org/drawingml/2006/main">
               <a:ext uri="{FF2B5EF4-FFF2-40B4-BE49-F238E27FC236}">
-                <a16:creationId xmlns:a16="http://schemas.microsoft.com/office/drawing/2014/main" id="{41A684D0-AAA4-499C-A989-9F0CA5DC1753}"/>
+                <a16:creationId xmlns:a16="http://schemas.microsoft.com/office/drawing/2014/main" id="{F8DC9333-CF2F-4963-B1C0-3B9A17DCF050}"/>
               </a:ext>
             </a:extLst>
           </p:cNvPr>
@@ -2963,7 +2963,7 @@
           <p:cNvPr id="16" name="">
             <a:extLst xmlns:a="http://schemas.openxmlformats.org/drawingml/2006/main">
               <a:ext uri="{FF2B5EF4-FFF2-40B4-BE49-F238E27FC236}">
-                <a16:creationId xmlns:a16="http://schemas.microsoft.com/office/drawing/2014/main" id="{5E2A9AA0-6C13-4E79-B75B-F59A98537C08}"/>
+                <a16:creationId xmlns:a16="http://schemas.microsoft.com/office/drawing/2014/main" id="{50A8C3C3-A62A-46DC-920A-5914995B504B}"/>
               </a:ext>
             </a:extLst>
           </p:cNvPr>
@@ -3018,7 +3018,7 @@
     </p:spTree>
     <p:extLst>
       <p:ext uri="{BB962C8B-B14F-4D97-AF65-F5344CB8AC3E}">
-        <p14:creationId xmlns:p14="http://schemas.microsoft.com/office/powerpoint/2010/main" val="857207569"/>
+        <p14:creationId xmlns:p14="http://schemas.microsoft.com/office/powerpoint/2010/main" val="2032064345"/>
       </p:ext>
     </p:extLst>
   </p:cSld>
@@ -3049,7 +3049,7 @@
           <p:cNvPr id="7" name="">
             <a:extLst xmlns:a="http://schemas.openxmlformats.org/drawingml/2006/main">
               <a:ext uri="{FF2B5EF4-FFF2-40B4-BE49-F238E27FC236}">
-                <a16:creationId xmlns:a16="http://schemas.microsoft.com/office/drawing/2014/main" id="{5C940AE1-DE54-4835-BA29-F594E62C8A2A}"/>
+                <a16:creationId xmlns:a16="http://schemas.microsoft.com/office/drawing/2014/main" id="{4487ADB7-EA64-4629-B855-31E299FCC41C}"/>
               </a:ext>
             </a:extLst>
           </p:cNvPr>
@@ -3106,7 +3106,7 @@
           <p:cNvPr id="2" name="">
             <a:extLst xmlns:a="http://schemas.openxmlformats.org/drawingml/2006/main">
               <a:ext uri="{FF2B5EF4-FFF2-40B4-BE49-F238E27FC236}">
-                <a16:creationId xmlns:a16="http://schemas.microsoft.com/office/drawing/2014/main" id="{11C12C9E-2FBD-4120-8065-FD1C86AE1479}"/>
+                <a16:creationId xmlns:a16="http://schemas.microsoft.com/office/drawing/2014/main" id="{72465C40-548B-430A-848F-17C7B4BAB7F4}"/>
               </a:ext>
             </a:extLst>
           </p:cNvPr>
@@ -3163,7 +3163,7 @@
           <p:cNvPr id="3" name="">
             <a:extLst xmlns:a="http://schemas.openxmlformats.org/drawingml/2006/main">
               <a:ext uri="{FF2B5EF4-FFF2-40B4-BE49-F238E27FC236}">
-                <a16:creationId xmlns:a16="http://schemas.microsoft.com/office/drawing/2014/main" id="{81631855-5B35-4B6C-B76C-7D42F809444E}"/>
+                <a16:creationId xmlns:a16="http://schemas.microsoft.com/office/drawing/2014/main" id="{BF815E61-FC08-4301-8593-B56A8AD00C8A}"/>
               </a:ext>
             </a:extLst>
           </p:cNvPr>
@@ -3220,7 +3220,7 @@
           <p:cNvPr id="4" name="">
             <a:extLst xmlns:a="http://schemas.openxmlformats.org/drawingml/2006/main">
               <a:ext uri="{FF2B5EF4-FFF2-40B4-BE49-F238E27FC236}">
-                <a16:creationId xmlns:a16="http://schemas.microsoft.com/office/drawing/2014/main" id="{3A839108-C94E-494C-827F-1A6206C8987C}"/>
+                <a16:creationId xmlns:a16="http://schemas.microsoft.com/office/drawing/2014/main" id="{C93517B1-9B5C-495F-8843-E18CF27028AE}"/>
               </a:ext>
             </a:extLst>
           </p:cNvPr>
@@ -3284,7 +3284,7 @@
         </p:xfrm>
         <a:graphic xmlns:a="http://schemas.openxmlformats.org/drawingml/2006/main">
           <a:graphicData uri="http://schemas.openxmlformats.org/drawingml/2006/chart">
-            <c:chart xmlns:r="http://schemas.openxmlformats.org/officeDocument/2006/relationships" xmlns:c="http://schemas.openxmlformats.org/drawingml/2006/chart" r:id="Rf0701bf17ef54bbf"/>
+            <c:chart xmlns:r="http://schemas.openxmlformats.org/officeDocument/2006/relationships" xmlns:c="http://schemas.openxmlformats.org/drawingml/2006/chart" r:id="Rf33c028e63ef4b5b"/>
           </a:graphicData>
         </a:graphic>
       </p:graphicFrame>
@@ -3293,7 +3293,7 @@
           <p:cNvPr id="6" name="">
             <a:extLst xmlns:a="http://schemas.openxmlformats.org/drawingml/2006/main">
               <a:ext uri="{FF2B5EF4-FFF2-40B4-BE49-F238E27FC236}">
-                <a16:creationId xmlns:a16="http://schemas.microsoft.com/office/drawing/2014/main" id="{758C8D1F-C68C-46C0-9DC8-7B36346A6975}"/>
+                <a16:creationId xmlns:a16="http://schemas.microsoft.com/office/drawing/2014/main" id="{79E7EEC6-575E-4773-82FB-46FCF4FDA23F}"/>
               </a:ext>
             </a:extLst>
           </p:cNvPr>
@@ -3379,7 +3379,7 @@
     </p:spTree>
     <p:extLst>
       <p:ext uri="{BB962C8B-B14F-4D97-AF65-F5344CB8AC3E}">
-        <p14:creationId xmlns:p14="http://schemas.microsoft.com/office/powerpoint/2010/main" val="591472627"/>
+        <p14:creationId xmlns:p14="http://schemas.microsoft.com/office/powerpoint/2010/main" val="1034749709"/>
       </p:ext>
     </p:extLst>
   </p:cSld>
@@ -3410,7 +3410,7 @@
           <p:cNvPr id="9" name="">
             <a:extLst xmlns:a="http://schemas.openxmlformats.org/drawingml/2006/main">
               <a:ext uri="{FF2B5EF4-FFF2-40B4-BE49-F238E27FC236}">
-                <a16:creationId xmlns:a16="http://schemas.microsoft.com/office/drawing/2014/main" id="{C80AAE4C-886B-45B5-B2E7-DCE15F7F0E29}"/>
+                <a16:creationId xmlns:a16="http://schemas.microsoft.com/office/drawing/2014/main" id="{A5B17974-0F56-4F3E-9D4B-904C715C3261}"/>
               </a:ext>
             </a:extLst>
           </p:cNvPr>
@@ -3467,7 +3467,7 @@
           <p:cNvPr id="2" name="">
             <a:extLst xmlns:a="http://schemas.openxmlformats.org/drawingml/2006/main">
               <a:ext uri="{FF2B5EF4-FFF2-40B4-BE49-F238E27FC236}">
-                <a16:creationId xmlns:a16="http://schemas.microsoft.com/office/drawing/2014/main" id="{7D955AE2-4864-4421-8D05-43695D13BF61}"/>
+                <a16:creationId xmlns:a16="http://schemas.microsoft.com/office/drawing/2014/main" id="{CCBAF3D8-E96D-4C69-9FB0-4D083957EE88}"/>
               </a:ext>
             </a:extLst>
           </p:cNvPr>
@@ -3524,7 +3524,7 @@
           <p:cNvPr id="3" name="">
             <a:extLst xmlns:a="http://schemas.openxmlformats.org/drawingml/2006/main">
               <a:ext uri="{FF2B5EF4-FFF2-40B4-BE49-F238E27FC236}">
-                <a16:creationId xmlns:a16="http://schemas.microsoft.com/office/drawing/2014/main" id="{FCD32ADD-A1A9-4F9D-951C-D8534A56110B}"/>
+                <a16:creationId xmlns:a16="http://schemas.microsoft.com/office/drawing/2014/main" id="{03FACB15-D590-409E-9185-2A239A326E60}"/>
               </a:ext>
             </a:extLst>
           </p:cNvPr>
@@ -3581,7 +3581,7 @@
           <p:cNvPr id="4" name="">
             <a:extLst xmlns:a="http://schemas.openxmlformats.org/drawingml/2006/main">
               <a:ext uri="{FF2B5EF4-FFF2-40B4-BE49-F238E27FC236}">
-                <a16:creationId xmlns:a16="http://schemas.microsoft.com/office/drawing/2014/main" id="{E021A7CC-4E01-45D4-8E4E-61D356BC4EE6}"/>
+                <a16:creationId xmlns:a16="http://schemas.microsoft.com/office/drawing/2014/main" id="{7F700A8E-5AC8-4BED-B542-86E8FE6D47B0}"/>
               </a:ext>
             </a:extLst>
           </p:cNvPr>
@@ -3638,7 +3638,7 @@
           <p:cNvPr id="5" name="">
             <a:extLst xmlns:a="http://schemas.openxmlformats.org/drawingml/2006/main">
               <a:ext uri="{FF2B5EF4-FFF2-40B4-BE49-F238E27FC236}">
-                <a16:creationId xmlns:a16="http://schemas.microsoft.com/office/drawing/2014/main" id="{A4D7FF17-72DD-46AB-A181-1D224E92DA8E}"/>
+                <a16:creationId xmlns:a16="http://schemas.microsoft.com/office/drawing/2014/main" id="{50DDDDB7-DF63-4199-9BB3-9AE2A85BD323}"/>
               </a:ext>
             </a:extLst>
           </p:cNvPr>
@@ -3718,7 +3718,7 @@
           <p:cNvPr id="6" name="">
             <a:extLst xmlns:a="http://schemas.openxmlformats.org/drawingml/2006/main">
               <a:ext uri="{FF2B5EF4-FFF2-40B4-BE49-F238E27FC236}">
-                <a16:creationId xmlns:a16="http://schemas.microsoft.com/office/drawing/2014/main" id="{34A779BF-972D-4A71-AA95-7FB7A52BE8A3}"/>
+                <a16:creationId xmlns:a16="http://schemas.microsoft.com/office/drawing/2014/main" id="{DB4B5FEC-80B6-4668-B1FF-7CAB43F9381E}"/>
               </a:ext>
             </a:extLst>
           </p:cNvPr>
@@ -3806,7 +3806,7 @@
           <p:cNvPr id="7" name="">
             <a:extLst xmlns:a="http://schemas.openxmlformats.org/drawingml/2006/main">
               <a:ext uri="{FF2B5EF4-FFF2-40B4-BE49-F238E27FC236}">
-                <a16:creationId xmlns:a16="http://schemas.microsoft.com/office/drawing/2014/main" id="{6E62E209-0072-47FF-BFF8-0426E02FD628}"/>
+                <a16:creationId xmlns:a16="http://schemas.microsoft.com/office/drawing/2014/main" id="{A1670AFB-99D7-4942-8B4A-DA82EEBD7096}"/>
               </a:ext>
             </a:extLst>
           </p:cNvPr>
@@ -4099,7 +4099,7 @@
     </p:spTree>
     <p:extLst>
       <p:ext uri="{BB962C8B-B14F-4D97-AF65-F5344CB8AC3E}">
-        <p14:creationId xmlns:p14="http://schemas.microsoft.com/office/powerpoint/2010/main" val="1992736716"/>
+        <p14:creationId xmlns:p14="http://schemas.microsoft.com/office/powerpoint/2010/main" val="133267846"/>
       </p:ext>
     </p:extLst>
   </p:cSld>
@@ -4130,7 +4130,7 @@
           <p:cNvPr id="12" name="">
             <a:extLst xmlns:a="http://schemas.openxmlformats.org/drawingml/2006/main">
               <a:ext uri="{FF2B5EF4-FFF2-40B4-BE49-F238E27FC236}">
-                <a16:creationId xmlns:a16="http://schemas.microsoft.com/office/drawing/2014/main" id="{2D2D6C23-0A98-48FF-9285-76E573259D25}"/>
+                <a16:creationId xmlns:a16="http://schemas.microsoft.com/office/drawing/2014/main" id="{A76C0583-17D9-4DAB-BA79-BD16DA8D53C8}"/>
               </a:ext>
             </a:extLst>
           </p:cNvPr>
@@ -4187,7 +4187,7 @@
           <p:cNvPr id="2" name="">
             <a:extLst xmlns:a="http://schemas.openxmlformats.org/drawingml/2006/main">
               <a:ext uri="{FF2B5EF4-FFF2-40B4-BE49-F238E27FC236}">
-                <a16:creationId xmlns:a16="http://schemas.microsoft.com/office/drawing/2014/main" id="{7462FE3B-D308-4693-A8C5-E74228D3DAF1}"/>
+                <a16:creationId xmlns:a16="http://schemas.microsoft.com/office/drawing/2014/main" id="{74122BAD-8038-439E-B13F-81D5A459F264}"/>
               </a:ext>
             </a:extLst>
           </p:cNvPr>
@@ -4244,7 +4244,7 @@
           <p:cNvPr id="3" name="">
             <a:extLst xmlns:a="http://schemas.openxmlformats.org/drawingml/2006/main">
               <a:ext uri="{FF2B5EF4-FFF2-40B4-BE49-F238E27FC236}">
-                <a16:creationId xmlns:a16="http://schemas.microsoft.com/office/drawing/2014/main" id="{4C906FD0-E5D5-4CA4-B826-4FB0CA4EDB9F}"/>
+                <a16:creationId xmlns:a16="http://schemas.microsoft.com/office/drawing/2014/main" id="{C6441EC8-B0E5-4D7E-BC81-C7F41DB2E4D3}"/>
               </a:ext>
             </a:extLst>
           </p:cNvPr>
@@ -4301,7 +4301,7 @@
           <p:cNvPr id="4" name="">
             <a:extLst xmlns:a="http://schemas.openxmlformats.org/drawingml/2006/main">
               <a:ext uri="{FF2B5EF4-FFF2-40B4-BE49-F238E27FC236}">
-                <a16:creationId xmlns:a16="http://schemas.microsoft.com/office/drawing/2014/main" id="{F2ED0915-1FB8-4A26-AC5A-897C53250384}"/>
+                <a16:creationId xmlns:a16="http://schemas.microsoft.com/office/drawing/2014/main" id="{3A4A7751-98E4-43AC-9B2C-845039DBB552}"/>
               </a:ext>
             </a:extLst>
           </p:cNvPr>
@@ -4358,7 +4358,7 @@
           <p:cNvPr id="5" name="">
             <a:extLst xmlns:a="http://schemas.openxmlformats.org/drawingml/2006/main">
               <a:ext uri="{FF2B5EF4-FFF2-40B4-BE49-F238E27FC236}">
-                <a16:creationId xmlns:a16="http://schemas.microsoft.com/office/drawing/2014/main" id="{2AA5978B-3413-4654-AC74-94384431F552}"/>
+                <a16:creationId xmlns:a16="http://schemas.microsoft.com/office/drawing/2014/main" id="{4B72CE75-4962-403F-BEE9-232337F7F45F}"/>
               </a:ext>
             </a:extLst>
           </p:cNvPr>
@@ -4415,7 +4415,7 @@
           <p:cNvPr id="6" name="">
             <a:extLst xmlns:a="http://schemas.openxmlformats.org/drawingml/2006/main">
               <a:ext uri="{FF2B5EF4-FFF2-40B4-BE49-F238E27FC236}">
-                <a16:creationId xmlns:a16="http://schemas.microsoft.com/office/drawing/2014/main" id="{1BD05947-A7EF-4D70-B214-7EC2377CD1B3}"/>
+                <a16:creationId xmlns:a16="http://schemas.microsoft.com/office/drawing/2014/main" id="{6B7EAB8F-47F5-4B4D-A58C-47262D406686}"/>
               </a:ext>
             </a:extLst>
           </p:cNvPr>
@@ -4472,7 +4472,7 @@
           <p:cNvPr id="7" name="">
             <a:extLst xmlns:a="http://schemas.openxmlformats.org/drawingml/2006/main">
               <a:ext uri="{FF2B5EF4-FFF2-40B4-BE49-F238E27FC236}">
-                <a16:creationId xmlns:a16="http://schemas.microsoft.com/office/drawing/2014/main" id="{6471CF54-1415-4BAB-AB84-FB23602D0D1D}"/>
+                <a16:creationId xmlns:a16="http://schemas.microsoft.com/office/drawing/2014/main" id="{B1B81B74-E217-4D90-B481-876DA972D128}"/>
               </a:ext>
             </a:extLst>
           </p:cNvPr>
@@ -4529,7 +4529,7 @@
           <p:cNvPr id="8" name="">
             <a:extLst xmlns:a="http://schemas.openxmlformats.org/drawingml/2006/main">
               <a:ext uri="{FF2B5EF4-FFF2-40B4-BE49-F238E27FC236}">
-                <a16:creationId xmlns:a16="http://schemas.microsoft.com/office/drawing/2014/main" id="{72F264EF-6FA0-4F41-B23D-4F0C1341D36F}"/>
+                <a16:creationId xmlns:a16="http://schemas.microsoft.com/office/drawing/2014/main" id="{0C9C9990-E373-41C9-B861-807FC8E1878A}"/>
               </a:ext>
             </a:extLst>
           </p:cNvPr>
@@ -4586,7 +4586,7 @@
           <p:cNvPr id="9" name="">
             <a:extLst xmlns:a="http://schemas.openxmlformats.org/drawingml/2006/main">
               <a:ext uri="{FF2B5EF4-FFF2-40B4-BE49-F238E27FC236}">
-                <a16:creationId xmlns:a16="http://schemas.microsoft.com/office/drawing/2014/main" id="{E6EB486E-27AD-4958-8F41-92FC66308158}"/>
+                <a16:creationId xmlns:a16="http://schemas.microsoft.com/office/drawing/2014/main" id="{47D59F4F-9C21-415D-8CFE-FDC99EE43D39}"/>
               </a:ext>
             </a:extLst>
           </p:cNvPr>
@@ -4643,7 +4643,7 @@
           <p:cNvPr id="10" name="">
             <a:extLst xmlns:a="http://schemas.openxmlformats.org/drawingml/2006/main">
               <a:ext uri="{FF2B5EF4-FFF2-40B4-BE49-F238E27FC236}">
-                <a16:creationId xmlns:a16="http://schemas.microsoft.com/office/drawing/2014/main" id="{1102C108-A99F-46B4-9E1E-FB0A944A3661}"/>
+                <a16:creationId xmlns:a16="http://schemas.microsoft.com/office/drawing/2014/main" id="{01EEF60B-9892-4F52-A509-8F6580E0DDA1}"/>
               </a:ext>
             </a:extLst>
           </p:cNvPr>
@@ -4700,7 +4700,7 @@
           <p:cNvPr id="11" name="">
             <a:extLst xmlns:a="http://schemas.openxmlformats.org/drawingml/2006/main">
               <a:ext uri="{FF2B5EF4-FFF2-40B4-BE49-F238E27FC236}">
-                <a16:creationId xmlns:a16="http://schemas.microsoft.com/office/drawing/2014/main" id="{D65B065E-FB84-4B02-BF40-2F4B95F9530B}"/>
+                <a16:creationId xmlns:a16="http://schemas.microsoft.com/office/drawing/2014/main" id="{28CDFAB3-2CD7-448E-AC96-667D69E65E5D}"/>
               </a:ext>
             </a:extLst>
           </p:cNvPr>
@@ -4778,7 +4778,7 @@
     </p:spTree>
     <p:extLst>
       <p:ext uri="{BB962C8B-B14F-4D97-AF65-F5344CB8AC3E}">
-        <p14:creationId xmlns:p14="http://schemas.microsoft.com/office/powerpoint/2010/main" val="676686587"/>
+        <p14:creationId xmlns:p14="http://schemas.microsoft.com/office/powerpoint/2010/main" val="1445958360"/>
       </p:ext>
     </p:extLst>
   </p:cSld>
@@ -4809,7 +4809,7 @@
           <p:cNvPr id="12" name="">
             <a:extLst xmlns:a="http://schemas.openxmlformats.org/drawingml/2006/main">
               <a:ext uri="{FF2B5EF4-FFF2-40B4-BE49-F238E27FC236}">
-                <a16:creationId xmlns:a16="http://schemas.microsoft.com/office/drawing/2014/main" id="{76FAE3E8-437F-4D9B-BE80-9ABEC2579FA0}"/>
+                <a16:creationId xmlns:a16="http://schemas.microsoft.com/office/drawing/2014/main" id="{0C300CBF-9C93-467E-8039-A0305FD5BBA3}"/>
               </a:ext>
             </a:extLst>
           </p:cNvPr>
@@ -4866,7 +4866,7 @@
           <p:cNvPr id="2" name="">
             <a:extLst xmlns:a="http://schemas.openxmlformats.org/drawingml/2006/main">
               <a:ext uri="{FF2B5EF4-FFF2-40B4-BE49-F238E27FC236}">
-                <a16:creationId xmlns:a16="http://schemas.microsoft.com/office/drawing/2014/main" id="{CFE3A630-B308-4CAA-8349-1C8718F82766}"/>
+                <a16:creationId xmlns:a16="http://schemas.microsoft.com/office/drawing/2014/main" id="{7F0A18DA-E78F-4B5D-828D-18D0631915E4}"/>
               </a:ext>
             </a:extLst>
           </p:cNvPr>
@@ -4923,7 +4923,7 @@
           <p:cNvPr id="3" name="">
             <a:extLst xmlns:a="http://schemas.openxmlformats.org/drawingml/2006/main">
               <a:ext uri="{FF2B5EF4-FFF2-40B4-BE49-F238E27FC236}">
-                <a16:creationId xmlns:a16="http://schemas.microsoft.com/office/drawing/2014/main" id="{FF2D7058-245A-4B6F-B38A-6CCE08621001}"/>
+                <a16:creationId xmlns:a16="http://schemas.microsoft.com/office/drawing/2014/main" id="{4B63846E-65C0-45DB-9908-B68EFAE4B5A3}"/>
               </a:ext>
             </a:extLst>
           </p:cNvPr>
@@ -4980,7 +4980,7 @@
           <p:cNvPr id="4" name="">
             <a:extLst xmlns:a="http://schemas.openxmlformats.org/drawingml/2006/main">
               <a:ext uri="{FF2B5EF4-FFF2-40B4-BE49-F238E27FC236}">
-                <a16:creationId xmlns:a16="http://schemas.microsoft.com/office/drawing/2014/main" id="{2FDFD909-6B8F-459F-8A90-02028EB2A4F2}"/>
+                <a16:creationId xmlns:a16="http://schemas.microsoft.com/office/drawing/2014/main" id="{39893A83-EEE6-4C35-B0ED-CBFF3EBC186A}"/>
               </a:ext>
             </a:extLst>
           </p:cNvPr>
@@ -5037,7 +5037,7 @@
           <p:cNvPr id="5" name="">
             <a:extLst xmlns:a="http://schemas.openxmlformats.org/drawingml/2006/main">
               <a:ext uri="{FF2B5EF4-FFF2-40B4-BE49-F238E27FC236}">
-                <a16:creationId xmlns:a16="http://schemas.microsoft.com/office/drawing/2014/main" id="{1F52B2F2-E6B3-4C88-9158-3D2776DB842E}"/>
+                <a16:creationId xmlns:a16="http://schemas.microsoft.com/office/drawing/2014/main" id="{E90D1B00-E797-4293-BF10-FA3438FDD992}"/>
               </a:ext>
             </a:extLst>
           </p:cNvPr>
@@ -5117,7 +5117,7 @@
           <p:cNvPr id="6" name="">
             <a:extLst xmlns:a="http://schemas.openxmlformats.org/drawingml/2006/main">
               <a:ext uri="{FF2B5EF4-FFF2-40B4-BE49-F238E27FC236}">
-                <a16:creationId xmlns:a16="http://schemas.microsoft.com/office/drawing/2014/main" id="{B8B892BA-8FA4-4079-80DE-F1A2F0AF2F59}"/>
+                <a16:creationId xmlns:a16="http://schemas.microsoft.com/office/drawing/2014/main" id="{5B661367-C0D1-4606-BBC5-26100304157A}"/>
               </a:ext>
             </a:extLst>
           </p:cNvPr>
@@ -5201,7 +5201,7 @@
           <p:cNvPr id="7" name="">
             <a:extLst xmlns:a="http://schemas.openxmlformats.org/drawingml/2006/main">
               <a:ext uri="{FF2B5EF4-FFF2-40B4-BE49-F238E27FC236}">
-                <a16:creationId xmlns:a16="http://schemas.microsoft.com/office/drawing/2014/main" id="{B5EB2564-BFFB-4EF7-B3BC-940AADD99FCE}"/>
+                <a16:creationId xmlns:a16="http://schemas.microsoft.com/office/drawing/2014/main" id="{BC5F9EFE-F0EA-42C6-8358-D0F69D155C02}"/>
               </a:ext>
             </a:extLst>
           </p:cNvPr>
@@ -5285,7 +5285,7 @@
           <p:cNvPr id="8" name="">
             <a:extLst xmlns:a="http://schemas.openxmlformats.org/drawingml/2006/main">
               <a:ext uri="{FF2B5EF4-FFF2-40B4-BE49-F238E27FC236}">
-                <a16:creationId xmlns:a16="http://schemas.microsoft.com/office/drawing/2014/main" id="{2EAC8B61-AA71-4305-9159-D482824265B6}"/>
+                <a16:creationId xmlns:a16="http://schemas.microsoft.com/office/drawing/2014/main" id="{57374A53-08FD-4F25-8C75-7F0000D91AA3}"/>
               </a:ext>
             </a:extLst>
           </p:cNvPr>
@@ -5369,7 +5369,7 @@
           <p:cNvPr id="9" name="">
             <a:extLst xmlns:a="http://schemas.openxmlformats.org/drawingml/2006/main">
               <a:ext uri="{FF2B5EF4-FFF2-40B4-BE49-F238E27FC236}">
-                <a16:creationId xmlns:a16="http://schemas.microsoft.com/office/drawing/2014/main" id="{A8E21444-79CC-4FCF-8046-026E6A42A63F}"/>
+                <a16:creationId xmlns:a16="http://schemas.microsoft.com/office/drawing/2014/main" id="{67026311-537A-4EAE-964D-7EED1467B797}"/>
               </a:ext>
             </a:extLst>
           </p:cNvPr>
@@ -5579,7 +5579,7 @@
           <p:cNvPr id="11" name="">
             <a:extLst xmlns:a="http://schemas.openxmlformats.org/drawingml/2006/main">
               <a:ext uri="{FF2B5EF4-FFF2-40B4-BE49-F238E27FC236}">
-                <a16:creationId xmlns:a16="http://schemas.microsoft.com/office/drawing/2014/main" id="{54F148CA-0417-4B89-92F8-1602D958F0F2}"/>
+                <a16:creationId xmlns:a16="http://schemas.microsoft.com/office/drawing/2014/main" id="{E01C12E7-963B-42C3-92A2-D6B5F7AE0267}"/>
               </a:ext>
             </a:extLst>
           </p:cNvPr>
@@ -5634,7 +5634,7 @@
     </p:spTree>
     <p:extLst>
       <p:ext uri="{BB962C8B-B14F-4D97-AF65-F5344CB8AC3E}">
-        <p14:creationId xmlns:p14="http://schemas.microsoft.com/office/powerpoint/2010/main" val="1814131044"/>
+        <p14:creationId xmlns:p14="http://schemas.microsoft.com/office/powerpoint/2010/main" val="1286257210"/>
       </p:ext>
     </p:extLst>
   </p:cSld>
@@ -5665,7 +5665,7 @@
           <p:cNvPr id="13" name="">
             <a:extLst xmlns:a="http://schemas.openxmlformats.org/drawingml/2006/main">
               <a:ext uri="{FF2B5EF4-FFF2-40B4-BE49-F238E27FC236}">
-                <a16:creationId xmlns:a16="http://schemas.microsoft.com/office/drawing/2014/main" id="{A5F92D5E-7AA5-45F5-A5CA-5AE5AAEB37B5}"/>
+                <a16:creationId xmlns:a16="http://schemas.microsoft.com/office/drawing/2014/main" id="{86C08364-F238-47F7-A63A-50EE5745A86A}"/>
               </a:ext>
             </a:extLst>
           </p:cNvPr>
@@ -5722,7 +5722,7 @@
           <p:cNvPr id="2" name="">
             <a:extLst xmlns:a="http://schemas.openxmlformats.org/drawingml/2006/main">
               <a:ext uri="{FF2B5EF4-FFF2-40B4-BE49-F238E27FC236}">
-                <a16:creationId xmlns:a16="http://schemas.microsoft.com/office/drawing/2014/main" id="{3D8BA2EE-6300-4B92-8F27-D1AEFE767041}"/>
+                <a16:creationId xmlns:a16="http://schemas.microsoft.com/office/drawing/2014/main" id="{F73C4790-0A83-4E7E-A91A-20932EE32D51}"/>
               </a:ext>
             </a:extLst>
           </p:cNvPr>
@@ -5779,7 +5779,7 @@
           <p:cNvPr id="3" name="">
             <a:extLst xmlns:a="http://schemas.openxmlformats.org/drawingml/2006/main">
               <a:ext uri="{FF2B5EF4-FFF2-40B4-BE49-F238E27FC236}">
-                <a16:creationId xmlns:a16="http://schemas.microsoft.com/office/drawing/2014/main" id="{7419EC9F-53B6-4C63-A61E-3715B16CF623}"/>
+                <a16:creationId xmlns:a16="http://schemas.microsoft.com/office/drawing/2014/main" id="{1E635A88-8BC4-4190-A989-0132FAF59B1E}"/>
               </a:ext>
             </a:extLst>
           </p:cNvPr>
@@ -5836,7 +5836,7 @@
           <p:cNvPr id="4" name="">
             <a:extLst xmlns:a="http://schemas.openxmlformats.org/drawingml/2006/main">
               <a:ext uri="{FF2B5EF4-FFF2-40B4-BE49-F238E27FC236}">
-                <a16:creationId xmlns:a16="http://schemas.microsoft.com/office/drawing/2014/main" id="{AE677B5D-6E8C-42AF-8D35-27F15C485583}"/>
+                <a16:creationId xmlns:a16="http://schemas.microsoft.com/office/drawing/2014/main" id="{76168E4C-223A-453F-98BB-55DE1695234D}"/>
               </a:ext>
             </a:extLst>
           </p:cNvPr>
@@ -5924,7 +5924,7 @@
           <p:cNvPr id="5" name="">
             <a:extLst xmlns:a="http://schemas.openxmlformats.org/drawingml/2006/main">
               <a:ext uri="{FF2B5EF4-FFF2-40B4-BE49-F238E27FC236}">
-                <a16:creationId xmlns:a16="http://schemas.microsoft.com/office/drawing/2014/main" id="{14E9555C-D18F-4F96-80B0-0C8E3A81451B}"/>
+                <a16:creationId xmlns:a16="http://schemas.microsoft.com/office/drawing/2014/main" id="{00E6EC05-94C6-44C0-985A-F388816898E1}"/>
               </a:ext>
             </a:extLst>
           </p:cNvPr>
@@ -5985,7 +5985,7 @@
           <p:cNvPr id="6" name="">
             <a:extLst xmlns:a="http://schemas.openxmlformats.org/drawingml/2006/main">
               <a:ext uri="{FF2B5EF4-FFF2-40B4-BE49-F238E27FC236}">
-                <a16:creationId xmlns:a16="http://schemas.microsoft.com/office/drawing/2014/main" id="{D1BF87C8-A90D-4150-9F0C-0983F8BA5D05}"/>
+                <a16:creationId xmlns:a16="http://schemas.microsoft.com/office/drawing/2014/main" id="{6547A84F-059B-42C9-A461-2A342EC1F237}"/>
               </a:ext>
             </a:extLst>
           </p:cNvPr>
@@ -6094,7 +6094,7 @@
           <p:cNvPr id="8" name="">
             <a:extLst xmlns:a="http://schemas.openxmlformats.org/drawingml/2006/main">
               <a:ext uri="{FF2B5EF4-FFF2-40B4-BE49-F238E27FC236}">
-                <a16:creationId xmlns:a16="http://schemas.microsoft.com/office/drawing/2014/main" id="{30D3BCC8-1C38-45BC-8918-C392945E7E3C}"/>
+                <a16:creationId xmlns:a16="http://schemas.microsoft.com/office/drawing/2014/main" id="{EF62F07F-3264-4524-9048-FF56DC066D0B}"/>
               </a:ext>
             </a:extLst>
           </p:cNvPr>
@@ -6203,7 +6203,7 @@
           <p:cNvPr id="10" name="">
             <a:extLst xmlns:a="http://schemas.openxmlformats.org/drawingml/2006/main">
               <a:ext uri="{FF2B5EF4-FFF2-40B4-BE49-F238E27FC236}">
-                <a16:creationId xmlns:a16="http://schemas.microsoft.com/office/drawing/2014/main" id="{0311F743-97D6-4CF7-A206-63AD5B98BCA5}"/>
+                <a16:creationId xmlns:a16="http://schemas.microsoft.com/office/drawing/2014/main" id="{25BA0861-73E2-4AEF-9664-C79BDD8B9E87}"/>
               </a:ext>
             </a:extLst>
           </p:cNvPr>
@@ -6312,7 +6312,7 @@
           <p:cNvPr id="12" name="">
             <a:extLst xmlns:a="http://schemas.openxmlformats.org/drawingml/2006/main">
               <a:ext uri="{FF2B5EF4-FFF2-40B4-BE49-F238E27FC236}">
-                <a16:creationId xmlns:a16="http://schemas.microsoft.com/office/drawing/2014/main" id="{FACE142C-28AE-44A3-8CDD-550231EB68FF}"/>
+                <a16:creationId xmlns:a16="http://schemas.microsoft.com/office/drawing/2014/main" id="{236AC334-BC79-4E65-BB95-FC5F3F62DC25}"/>
               </a:ext>
             </a:extLst>
           </p:cNvPr>
@@ -6398,7 +6398,7 @@
     </p:spTree>
     <p:extLst>
       <p:ext uri="{BB962C8B-B14F-4D97-AF65-F5344CB8AC3E}">
-        <p14:creationId xmlns:p14="http://schemas.microsoft.com/office/powerpoint/2010/main" val="1702856441"/>
+        <p14:creationId xmlns:p14="http://schemas.microsoft.com/office/powerpoint/2010/main" val="1300901033"/>
       </p:ext>
     </p:extLst>
   </p:cSld>
@@ -6429,7 +6429,7 @@
           <p:cNvPr id="9" name="">
             <a:extLst xmlns:a="http://schemas.openxmlformats.org/drawingml/2006/main">
               <a:ext uri="{FF2B5EF4-FFF2-40B4-BE49-F238E27FC236}">
-                <a16:creationId xmlns:a16="http://schemas.microsoft.com/office/drawing/2014/main" id="{512AB1B2-D2F9-406C-B3ED-0C1BF0C51050}"/>
+                <a16:creationId xmlns:a16="http://schemas.microsoft.com/office/drawing/2014/main" id="{4BA15E8D-8808-4AE6-AF8C-27C5E8733BAA}"/>
               </a:ext>
             </a:extLst>
           </p:cNvPr>
@@ -6486,7 +6486,7 @@
           <p:cNvPr id="2" name="">
             <a:extLst xmlns:a="http://schemas.openxmlformats.org/drawingml/2006/main">
               <a:ext uri="{FF2B5EF4-FFF2-40B4-BE49-F238E27FC236}">
-                <a16:creationId xmlns:a16="http://schemas.microsoft.com/office/drawing/2014/main" id="{04F3292F-9668-4270-B136-DACC03BC8AF0}"/>
+                <a16:creationId xmlns:a16="http://schemas.microsoft.com/office/drawing/2014/main" id="{C220C7DD-143D-41C1-B29F-095147E03B41}"/>
               </a:ext>
             </a:extLst>
           </p:cNvPr>
@@ -6543,7 +6543,7 @@
           <p:cNvPr id="3" name="">
             <a:extLst xmlns:a="http://schemas.openxmlformats.org/drawingml/2006/main">
               <a:ext uri="{FF2B5EF4-FFF2-40B4-BE49-F238E27FC236}">
-                <a16:creationId xmlns:a16="http://schemas.microsoft.com/office/drawing/2014/main" id="{5D68E0C8-325F-40DE-82F3-39D40D3824BC}"/>
+                <a16:creationId xmlns:a16="http://schemas.microsoft.com/office/drawing/2014/main" id="{7B5B5326-CA99-4824-9557-98B49634BF06}"/>
               </a:ext>
             </a:extLst>
           </p:cNvPr>
@@ -6600,7 +6600,7 @@
           <p:cNvPr id="4" name="">
             <a:extLst xmlns:a="http://schemas.openxmlformats.org/drawingml/2006/main">
               <a:ext uri="{FF2B5EF4-FFF2-40B4-BE49-F238E27FC236}">
-                <a16:creationId xmlns:a16="http://schemas.microsoft.com/office/drawing/2014/main" id="{81C82799-C50F-4A6F-9C8C-53BCD74E2AAF}"/>
+                <a16:creationId xmlns:a16="http://schemas.microsoft.com/office/drawing/2014/main" id="{F2CF8ECB-F20A-4EEB-9A1A-198999CA2B79}"/>
               </a:ext>
             </a:extLst>
           </p:cNvPr>
@@ -6844,7 +6844,7 @@
           <p:cNvPr id="6" name="">
             <a:extLst xmlns:a="http://schemas.openxmlformats.org/drawingml/2006/main">
               <a:ext uri="{FF2B5EF4-FFF2-40B4-BE49-F238E27FC236}">
-                <a16:creationId xmlns:a16="http://schemas.microsoft.com/office/drawing/2014/main" id="{B1E504DE-FDF3-4B5E-AAF5-FEDF54EF0DD3}"/>
+                <a16:creationId xmlns:a16="http://schemas.microsoft.com/office/drawing/2014/main" id="{549A60AB-0597-410A-AE64-807464AE1F7C}"/>
               </a:ext>
             </a:extLst>
           </p:cNvPr>
@@ -6901,7 +6901,7 @@
           <p:cNvPr id="7" name="">
             <a:extLst xmlns:a="http://schemas.openxmlformats.org/drawingml/2006/main">
               <a:ext uri="{FF2B5EF4-FFF2-40B4-BE49-F238E27FC236}">
-                <a16:creationId xmlns:a16="http://schemas.microsoft.com/office/drawing/2014/main" id="{37C1509C-A401-4C9C-ADD1-BC18C90EAB6E}"/>
+                <a16:creationId xmlns:a16="http://schemas.microsoft.com/office/drawing/2014/main" id="{B4061017-FA0E-4E7A-AA75-46350E45F6EF}"/>
               </a:ext>
             </a:extLst>
           </p:cNvPr>
@@ -6989,7 +6989,7 @@
           <p:cNvPr id="8" name="">
             <a:extLst xmlns:a="http://schemas.openxmlformats.org/drawingml/2006/main">
               <a:ext uri="{FF2B5EF4-FFF2-40B4-BE49-F238E27FC236}">
-                <a16:creationId xmlns:a16="http://schemas.microsoft.com/office/drawing/2014/main" id="{EA09217C-350B-4766-AC16-2692BAAB9069}"/>
+                <a16:creationId xmlns:a16="http://schemas.microsoft.com/office/drawing/2014/main" id="{2BA52406-7684-428F-99B1-848F1E20912A}"/>
               </a:ext>
             </a:extLst>
           </p:cNvPr>
@@ -7044,7 +7044,7 @@
     </p:spTree>
     <p:extLst>
       <p:ext uri="{BB962C8B-B14F-4D97-AF65-F5344CB8AC3E}">
-        <p14:creationId xmlns:p14="http://schemas.microsoft.com/office/powerpoint/2010/main" val="314869899"/>
+        <p14:creationId xmlns:p14="http://schemas.microsoft.com/office/powerpoint/2010/main" val="1427917535"/>
       </p:ext>
     </p:extLst>
   </p:cSld>
@@ -7075,7 +7075,7 @@
           <p:cNvPr id="7" name="">
             <a:extLst xmlns:a="http://schemas.openxmlformats.org/drawingml/2006/main">
               <a:ext uri="{FF2B5EF4-FFF2-40B4-BE49-F238E27FC236}">
-                <a16:creationId xmlns:a16="http://schemas.microsoft.com/office/drawing/2014/main" id="{F9791DE8-A369-4EEA-ACB9-6056FB9A364D}"/>
+                <a16:creationId xmlns:a16="http://schemas.microsoft.com/office/drawing/2014/main" id="{E2DD152C-D34C-4382-938D-B1228406D7B2}"/>
               </a:ext>
             </a:extLst>
           </p:cNvPr>
@@ -7132,7 +7132,7 @@
           <p:cNvPr id="2" name="">
             <a:extLst xmlns:a="http://schemas.openxmlformats.org/drawingml/2006/main">
               <a:ext uri="{FF2B5EF4-FFF2-40B4-BE49-F238E27FC236}">
-                <a16:creationId xmlns:a16="http://schemas.microsoft.com/office/drawing/2014/main" id="{DE702F9E-6FD3-42F9-81C9-45792AA79E75}"/>
+                <a16:creationId xmlns:a16="http://schemas.microsoft.com/office/drawing/2014/main" id="{749F084D-26B3-40D5-A787-9FC4DE2CBEC5}"/>
               </a:ext>
             </a:extLst>
           </p:cNvPr>
@@ -7189,7 +7189,7 @@
           <p:cNvPr id="3" name="">
             <a:extLst xmlns:a="http://schemas.openxmlformats.org/drawingml/2006/main">
               <a:ext uri="{FF2B5EF4-FFF2-40B4-BE49-F238E27FC236}">
-                <a16:creationId xmlns:a16="http://schemas.microsoft.com/office/drawing/2014/main" id="{174C9C47-2163-4BF2-8970-163DE9D2CCEC}"/>
+                <a16:creationId xmlns:a16="http://schemas.microsoft.com/office/drawing/2014/main" id="{07EB0D2B-AAEE-4AFA-A5E1-2A8D7A8AD3E1}"/>
               </a:ext>
             </a:extLst>
           </p:cNvPr>
@@ -7246,7 +7246,7 @@
           <p:cNvPr id="4" name="">
             <a:extLst xmlns:a="http://schemas.openxmlformats.org/drawingml/2006/main">
               <a:ext uri="{FF2B5EF4-FFF2-40B4-BE49-F238E27FC236}">
-                <a16:creationId xmlns:a16="http://schemas.microsoft.com/office/drawing/2014/main" id="{E3E01AA3-2579-44D2-A5C7-8F6CF2D14E0E}"/>
+                <a16:creationId xmlns:a16="http://schemas.microsoft.com/office/drawing/2014/main" id="{5E9AFF45-49C1-4C6F-BA57-74C9DCE046B5}"/>
               </a:ext>
             </a:extLst>
           </p:cNvPr>
@@ -7545,7 +7545,7 @@
           <p:cNvPr id="6" name="">
             <a:extLst xmlns:a="http://schemas.openxmlformats.org/drawingml/2006/main">
               <a:ext uri="{FF2B5EF4-FFF2-40B4-BE49-F238E27FC236}">
-                <a16:creationId xmlns:a16="http://schemas.microsoft.com/office/drawing/2014/main" id="{D089A4B5-599E-4CE2-BC07-4ABD16DA19C3}"/>
+                <a16:creationId xmlns:a16="http://schemas.microsoft.com/office/drawing/2014/main" id="{7891FF3F-8747-4424-AF92-BED79FAB3181}"/>
               </a:ext>
             </a:extLst>
           </p:cNvPr>
@@ -7631,7 +7631,7 @@
     </p:spTree>
     <p:extLst>
       <p:ext uri="{BB962C8B-B14F-4D97-AF65-F5344CB8AC3E}">
-        <p14:creationId xmlns:p14="http://schemas.microsoft.com/office/powerpoint/2010/main" val="560650925"/>
+        <p14:creationId xmlns:p14="http://schemas.microsoft.com/office/powerpoint/2010/main" val="930436447"/>
       </p:ext>
     </p:extLst>
   </p:cSld>
@@ -7662,7 +7662,7 @@
           <p:cNvPr id="6" name="">
             <a:extLst xmlns:a="http://schemas.openxmlformats.org/drawingml/2006/main">
               <a:ext uri="{FF2B5EF4-FFF2-40B4-BE49-F238E27FC236}">
-                <a16:creationId xmlns:a16="http://schemas.microsoft.com/office/drawing/2014/main" id="{C47680F7-9713-4E13-8A9D-16D5A9D690E9}"/>
+                <a16:creationId xmlns:a16="http://schemas.microsoft.com/office/drawing/2014/main" id="{34BB26CF-9DC5-4B83-836E-DE228C26B6FE}"/>
               </a:ext>
             </a:extLst>
           </p:cNvPr>
@@ -7719,7 +7719,7 @@
           <p:cNvPr id="2" name="">
             <a:extLst xmlns:a="http://schemas.openxmlformats.org/drawingml/2006/main">
               <a:ext uri="{FF2B5EF4-FFF2-40B4-BE49-F238E27FC236}">
-                <a16:creationId xmlns:a16="http://schemas.microsoft.com/office/drawing/2014/main" id="{8EF958C0-4594-442D-82D9-F50D420AA723}"/>
+                <a16:creationId xmlns:a16="http://schemas.microsoft.com/office/drawing/2014/main" id="{07AF5AB7-DA6A-4FB8-85FA-C9EDF8B881C3}"/>
               </a:ext>
             </a:extLst>
           </p:cNvPr>
@@ -7776,7 +7776,7 @@
           <p:cNvPr id="3" name="">
             <a:extLst xmlns:a="http://schemas.openxmlformats.org/drawingml/2006/main">
               <a:ext uri="{FF2B5EF4-FFF2-40B4-BE49-F238E27FC236}">
-                <a16:creationId xmlns:a16="http://schemas.microsoft.com/office/drawing/2014/main" id="{5F1C8A97-3922-49D9-8062-63D2955DF567}"/>
+                <a16:creationId xmlns:a16="http://schemas.microsoft.com/office/drawing/2014/main" id="{4BD11FC6-CE83-410D-816C-956FB6B0FF10}"/>
               </a:ext>
             </a:extLst>
           </p:cNvPr>
@@ -7833,7 +7833,7 @@
           <p:cNvPr id="4" name="">
             <a:extLst xmlns:a="http://schemas.openxmlformats.org/drawingml/2006/main">
               <a:ext uri="{FF2B5EF4-FFF2-40B4-BE49-F238E27FC236}">
-                <a16:creationId xmlns:a16="http://schemas.microsoft.com/office/drawing/2014/main" id="{7239DF67-969A-4C7F-A79C-830876A285EC}"/>
+                <a16:creationId xmlns:a16="http://schemas.microsoft.com/office/drawing/2014/main" id="{98F6FA2A-5C70-47FE-86AA-5734516015F4}"/>
               </a:ext>
             </a:extLst>
           </p:cNvPr>
@@ -8098,7 +8098,7 @@
     </p:spTree>
     <p:extLst>
       <p:ext uri="{BB962C8B-B14F-4D97-AF65-F5344CB8AC3E}">
-        <p14:creationId xmlns:p14="http://schemas.microsoft.com/office/powerpoint/2010/main" val="1404689855"/>
+        <p14:creationId xmlns:p14="http://schemas.microsoft.com/office/powerpoint/2010/main" val="222135518"/>
       </p:ext>
     </p:extLst>
   </p:cSld>
@@ -8129,7 +8129,7 @@
           <p:cNvPr id="8" name="">
             <a:extLst xmlns:a="http://schemas.openxmlformats.org/drawingml/2006/main">
               <a:ext uri="{FF2B5EF4-FFF2-40B4-BE49-F238E27FC236}">
-                <a16:creationId xmlns:a16="http://schemas.microsoft.com/office/drawing/2014/main" id="{9B789894-4C24-4FD9-BB48-5299E26DBD80}"/>
+                <a16:creationId xmlns:a16="http://schemas.microsoft.com/office/drawing/2014/main" id="{D0509877-C2F3-47F0-B001-ABABDE00DD35}"/>
               </a:ext>
             </a:extLst>
           </p:cNvPr>
@@ -8186,7 +8186,7 @@
           <p:cNvPr id="2" name="">
             <a:extLst xmlns:a="http://schemas.openxmlformats.org/drawingml/2006/main">
               <a:ext uri="{FF2B5EF4-FFF2-40B4-BE49-F238E27FC236}">
-                <a16:creationId xmlns:a16="http://schemas.microsoft.com/office/drawing/2014/main" id="{DFAC3BD8-CF10-4A07-87FF-68F3C9CCE7B9}"/>
+                <a16:creationId xmlns:a16="http://schemas.microsoft.com/office/drawing/2014/main" id="{449DE7A4-6A0A-4B1D-825D-FC3AC8B41C2A}"/>
               </a:ext>
             </a:extLst>
           </p:cNvPr>
@@ -8243,7 +8243,7 @@
           <p:cNvPr id="3" name="">
             <a:extLst xmlns:a="http://schemas.openxmlformats.org/drawingml/2006/main">
               <a:ext uri="{FF2B5EF4-FFF2-40B4-BE49-F238E27FC236}">
-                <a16:creationId xmlns:a16="http://schemas.microsoft.com/office/drawing/2014/main" id="{0CE1269E-94EF-468A-BDE3-6B6F85C58C02}"/>
+                <a16:creationId xmlns:a16="http://schemas.microsoft.com/office/drawing/2014/main" id="{8759A6E2-A894-4712-B2F2-F6D01D2897E9}"/>
               </a:ext>
             </a:extLst>
           </p:cNvPr>
@@ -8300,7 +8300,7 @@
           <p:cNvPr id="4" name="">
             <a:extLst xmlns:a="http://schemas.openxmlformats.org/drawingml/2006/main">
               <a:ext uri="{FF2B5EF4-FFF2-40B4-BE49-F238E27FC236}">
-                <a16:creationId xmlns:a16="http://schemas.microsoft.com/office/drawing/2014/main" id="{ACA7BAB9-6742-4446-B4A0-9E8CD294F7E6}"/>
+                <a16:creationId xmlns:a16="http://schemas.microsoft.com/office/drawing/2014/main" id="{EE1514B2-FE6C-446F-9028-9578D9594793}"/>
               </a:ext>
             </a:extLst>
           </p:cNvPr>
@@ -8357,7 +8357,7 @@
           <p:cNvPr id="5" name="">
             <a:extLst xmlns:a="http://schemas.openxmlformats.org/drawingml/2006/main">
               <a:ext uri="{FF2B5EF4-FFF2-40B4-BE49-F238E27FC236}">
-                <a16:creationId xmlns:a16="http://schemas.microsoft.com/office/drawing/2014/main" id="{3A0AA65C-2BCA-43F8-B27C-87CA40A3AC02}"/>
+                <a16:creationId xmlns:a16="http://schemas.microsoft.com/office/drawing/2014/main" id="{127152C6-5915-4C5A-AB18-E823F55190F9}"/>
               </a:ext>
             </a:extLst>
           </p:cNvPr>
@@ -8414,7 +8414,7 @@
           <p:cNvPr id="6" name="">
             <a:extLst xmlns:a="http://schemas.openxmlformats.org/drawingml/2006/main">
               <a:ext uri="{FF2B5EF4-FFF2-40B4-BE49-F238E27FC236}">
-                <a16:creationId xmlns:a16="http://schemas.microsoft.com/office/drawing/2014/main" id="{10752F35-5091-474A-9E55-E50579C9607C}"/>
+                <a16:creationId xmlns:a16="http://schemas.microsoft.com/office/drawing/2014/main" id="{2FA05D8E-E9F4-44CF-A983-31186E977ADE}"/>
               </a:ext>
             </a:extLst>
           </p:cNvPr>
@@ -8471,7 +8471,7 @@
           <p:cNvPr id="7" name="">
             <a:extLst xmlns:a="http://schemas.openxmlformats.org/drawingml/2006/main">
               <a:ext uri="{FF2B5EF4-FFF2-40B4-BE49-F238E27FC236}">
-                <a16:creationId xmlns:a16="http://schemas.microsoft.com/office/drawing/2014/main" id="{90DA3038-C760-4BD1-B92C-34FD98ECFC25}"/>
+                <a16:creationId xmlns:a16="http://schemas.microsoft.com/office/drawing/2014/main" id="{D72F19BE-FFEF-4029-9A6C-BC7955BCBE47}"/>
               </a:ext>
             </a:extLst>
           </p:cNvPr>
@@ -8526,7 +8526,7 @@
     </p:spTree>
     <p:extLst>
       <p:ext uri="{BB962C8B-B14F-4D97-AF65-F5344CB8AC3E}">
-        <p14:creationId xmlns:p14="http://schemas.microsoft.com/office/powerpoint/2010/main" val="1745022577"/>
+        <p14:creationId xmlns:p14="http://schemas.microsoft.com/office/powerpoint/2010/main" val="1412634186"/>
       </p:ext>
     </p:extLst>
   </p:cSld>
@@ -8557,7 +8557,7 @@
           <p:cNvPr id="14" name="">
             <a:extLst xmlns:a="http://schemas.openxmlformats.org/drawingml/2006/main">
               <a:ext uri="{FF2B5EF4-FFF2-40B4-BE49-F238E27FC236}">
-                <a16:creationId xmlns:a16="http://schemas.microsoft.com/office/drawing/2014/main" id="{0EB9D23E-F3CB-4D74-8288-CEB3D998ECDD}"/>
+                <a16:creationId xmlns:a16="http://schemas.microsoft.com/office/drawing/2014/main" id="{7746058B-331B-4A9B-8DE8-4AE8198516EA}"/>
               </a:ext>
             </a:extLst>
           </p:cNvPr>
@@ -8614,7 +8614,7 @@
           <p:cNvPr id="2" name="">
             <a:extLst xmlns:a="http://schemas.openxmlformats.org/drawingml/2006/main">
               <a:ext uri="{FF2B5EF4-FFF2-40B4-BE49-F238E27FC236}">
-                <a16:creationId xmlns:a16="http://schemas.microsoft.com/office/drawing/2014/main" id="{D9FB61FB-2B88-4E97-9013-3274CD82477C}"/>
+                <a16:creationId xmlns:a16="http://schemas.microsoft.com/office/drawing/2014/main" id="{D5956F79-6A35-4649-B7DF-F65DF40AF5B5}"/>
               </a:ext>
             </a:extLst>
           </p:cNvPr>
@@ -8671,7 +8671,7 @@
           <p:cNvPr id="3" name="">
             <a:extLst xmlns:a="http://schemas.openxmlformats.org/drawingml/2006/main">
               <a:ext uri="{FF2B5EF4-FFF2-40B4-BE49-F238E27FC236}">
-                <a16:creationId xmlns:a16="http://schemas.microsoft.com/office/drawing/2014/main" id="{630D4BC9-4379-43C0-9E3E-A8709C8D2ED0}"/>
+                <a16:creationId xmlns:a16="http://schemas.microsoft.com/office/drawing/2014/main" id="{EE084E5F-528E-478A-96DF-A6ABF262D4AF}"/>
               </a:ext>
             </a:extLst>
           </p:cNvPr>
@@ -8728,7 +8728,7 @@
           <p:cNvPr id="4" name="">
             <a:extLst xmlns:a="http://schemas.openxmlformats.org/drawingml/2006/main">
               <a:ext uri="{FF2B5EF4-FFF2-40B4-BE49-F238E27FC236}">
-                <a16:creationId xmlns:a16="http://schemas.microsoft.com/office/drawing/2014/main" id="{931B0BB0-F3C7-45D3-90F8-BC66A60F3926}"/>
+                <a16:creationId xmlns:a16="http://schemas.microsoft.com/office/drawing/2014/main" id="{72A7C96B-61B6-471A-B46E-8695B7B720A9}"/>
               </a:ext>
             </a:extLst>
           </p:cNvPr>
@@ -8785,7 +8785,7 @@
           <p:cNvPr id="5" name="">
             <a:extLst xmlns:a="http://schemas.openxmlformats.org/drawingml/2006/main">
               <a:ext uri="{FF2B5EF4-FFF2-40B4-BE49-F238E27FC236}">
-                <a16:creationId xmlns:a16="http://schemas.microsoft.com/office/drawing/2014/main" id="{EC4FBF3C-8411-4336-91F1-620DAC2AB4CF}"/>
+                <a16:creationId xmlns:a16="http://schemas.microsoft.com/office/drawing/2014/main" id="{586490A8-EB35-4927-BC35-A866A0378D5F}"/>
               </a:ext>
             </a:extLst>
           </p:cNvPr>
@@ -8842,7 +8842,7 @@
           <p:cNvPr id="6" name="">
             <a:extLst xmlns:a="http://schemas.openxmlformats.org/drawingml/2006/main">
               <a:ext uri="{FF2B5EF4-FFF2-40B4-BE49-F238E27FC236}">
-                <a16:creationId xmlns:a16="http://schemas.microsoft.com/office/drawing/2014/main" id="{66792A48-028C-42F7-AD59-D4B7821A1016}"/>
+                <a16:creationId xmlns:a16="http://schemas.microsoft.com/office/drawing/2014/main" id="{5DF08409-35FB-4A37-BA95-D0BB5D575764}"/>
               </a:ext>
             </a:extLst>
           </p:cNvPr>
@@ -8899,7 +8899,7 @@
           <p:cNvPr id="7" name="">
             <a:extLst xmlns:a="http://schemas.openxmlformats.org/drawingml/2006/main">
               <a:ext uri="{FF2B5EF4-FFF2-40B4-BE49-F238E27FC236}">
-                <a16:creationId xmlns:a16="http://schemas.microsoft.com/office/drawing/2014/main" id="{7358D622-67F7-4992-BF5A-2C0A776FF4B4}"/>
+                <a16:creationId xmlns:a16="http://schemas.microsoft.com/office/drawing/2014/main" id="{CDDD1E70-E201-436E-B46E-F07CB08E77EA}"/>
               </a:ext>
             </a:extLst>
           </p:cNvPr>
@@ -8956,7 +8956,7 @@
           <p:cNvPr id="8" name="">
             <a:extLst xmlns:a="http://schemas.openxmlformats.org/drawingml/2006/main">
               <a:ext uri="{FF2B5EF4-FFF2-40B4-BE49-F238E27FC236}">
-                <a16:creationId xmlns:a16="http://schemas.microsoft.com/office/drawing/2014/main" id="{5E486D8A-4D82-41B2-8E30-A9ECF8F23416}"/>
+                <a16:creationId xmlns:a16="http://schemas.microsoft.com/office/drawing/2014/main" id="{34D5847D-9EC4-4929-84AE-428D00A685CB}"/>
               </a:ext>
             </a:extLst>
           </p:cNvPr>
@@ -9013,7 +9013,7 @@
           <p:cNvPr id="9" name="">
             <a:extLst xmlns:a="http://schemas.openxmlformats.org/drawingml/2006/main">
               <a:ext uri="{FF2B5EF4-FFF2-40B4-BE49-F238E27FC236}">
-                <a16:creationId xmlns:a16="http://schemas.microsoft.com/office/drawing/2014/main" id="{9F96EC2A-DD3F-4404-A4F8-F0293E51DBDD}"/>
+                <a16:creationId xmlns:a16="http://schemas.microsoft.com/office/drawing/2014/main" id="{2CEF4E99-A094-4512-B6D4-F3858A8DA736}"/>
               </a:ext>
             </a:extLst>
           </p:cNvPr>
@@ -9070,7 +9070,7 @@
           <p:cNvPr id="10" name="">
             <a:extLst xmlns:a="http://schemas.openxmlformats.org/drawingml/2006/main">
               <a:ext uri="{FF2B5EF4-FFF2-40B4-BE49-F238E27FC236}">
-                <a16:creationId xmlns:a16="http://schemas.microsoft.com/office/drawing/2014/main" id="{10CD939B-7CFE-420C-9AD9-532AC7A46B04}"/>
+                <a16:creationId xmlns:a16="http://schemas.microsoft.com/office/drawing/2014/main" id="{FC9750C4-E106-4DB3-A111-30EFCED86194}"/>
               </a:ext>
             </a:extLst>
           </p:cNvPr>
@@ -9150,7 +9150,7 @@
           <p:cNvPr id="11" name="">
             <a:extLst xmlns:a="http://schemas.openxmlformats.org/drawingml/2006/main">
               <a:ext uri="{FF2B5EF4-FFF2-40B4-BE49-F238E27FC236}">
-                <a16:creationId xmlns:a16="http://schemas.microsoft.com/office/drawing/2014/main" id="{A31C8520-16FA-460E-AD7A-F0DD36A6E945}"/>
+                <a16:creationId xmlns:a16="http://schemas.microsoft.com/office/drawing/2014/main" id="{40D9EF88-31DE-4A12-9E57-F545DAA12BC8}"/>
               </a:ext>
             </a:extLst>
           </p:cNvPr>
@@ -9179,7 +9179,7 @@
           <p:cNvPr id="12" name="">
             <a:extLst xmlns:a="http://schemas.openxmlformats.org/drawingml/2006/main">
               <a:ext uri="{FF2B5EF4-FFF2-40B4-BE49-F238E27FC236}">
-                <a16:creationId xmlns:a16="http://schemas.microsoft.com/office/drawing/2014/main" id="{C95AE0D7-0797-47C9-9F8E-8C23B64B65AC}"/>
+                <a16:creationId xmlns:a16="http://schemas.microsoft.com/office/drawing/2014/main" id="{6960D0A6-F588-4F2A-8E13-9998CCA16362}"/>
               </a:ext>
             </a:extLst>
           </p:cNvPr>
@@ -9236,7 +9236,7 @@
           <p:cNvPr id="13" name="">
             <a:extLst xmlns:a="http://schemas.openxmlformats.org/drawingml/2006/main">
               <a:ext uri="{FF2B5EF4-FFF2-40B4-BE49-F238E27FC236}">
-                <a16:creationId xmlns:a16="http://schemas.microsoft.com/office/drawing/2014/main" id="{0B54C290-35D1-4AC8-A4FF-9CEA02452853}"/>
+                <a16:creationId xmlns:a16="http://schemas.microsoft.com/office/drawing/2014/main" id="{BDF19639-9A27-4F2E-A551-AC654E243312}"/>
               </a:ext>
             </a:extLst>
           </p:cNvPr>
@@ -9322,7 +9322,7 @@
     </p:spTree>
     <p:extLst>
       <p:ext uri="{BB962C8B-B14F-4D97-AF65-F5344CB8AC3E}">
-        <p14:creationId xmlns:p14="http://schemas.microsoft.com/office/powerpoint/2010/main" val="655841451"/>
+        <p14:creationId xmlns:p14="http://schemas.microsoft.com/office/powerpoint/2010/main" val="1683374267"/>
       </p:ext>
     </p:extLst>
   </p:cSld>
@@ -9353,7 +9353,7 @@
           <p:cNvPr id="6" name="">
             <a:extLst xmlns:a="http://schemas.openxmlformats.org/drawingml/2006/main">
               <a:ext uri="{FF2B5EF4-FFF2-40B4-BE49-F238E27FC236}">
-                <a16:creationId xmlns:a16="http://schemas.microsoft.com/office/drawing/2014/main" id="{379C9F2C-355D-41B4-A4DB-4F034399CFEA}"/>
+                <a16:creationId xmlns:a16="http://schemas.microsoft.com/office/drawing/2014/main" id="{33E9DC4B-4EFD-4587-891E-D088592DC576}"/>
               </a:ext>
             </a:extLst>
           </p:cNvPr>
@@ -9410,7 +9410,7 @@
           <p:cNvPr id="2" name="">
             <a:extLst xmlns:a="http://schemas.openxmlformats.org/drawingml/2006/main">
               <a:ext uri="{FF2B5EF4-FFF2-40B4-BE49-F238E27FC236}">
-                <a16:creationId xmlns:a16="http://schemas.microsoft.com/office/drawing/2014/main" id="{6A01092B-9DB2-4124-87CD-E1FE142F042B}"/>
+                <a16:creationId xmlns:a16="http://schemas.microsoft.com/office/drawing/2014/main" id="{54E5521F-A98F-4C38-B28A-BE1EFD2B10D9}"/>
               </a:ext>
             </a:extLst>
           </p:cNvPr>
@@ -9467,7 +9467,7 @@
           <p:cNvPr id="3" name="">
             <a:extLst xmlns:a="http://schemas.openxmlformats.org/drawingml/2006/main">
               <a:ext uri="{FF2B5EF4-FFF2-40B4-BE49-F238E27FC236}">
-                <a16:creationId xmlns:a16="http://schemas.microsoft.com/office/drawing/2014/main" id="{011CD939-E608-4287-B439-8C3FEDEEA9AD}"/>
+                <a16:creationId xmlns:a16="http://schemas.microsoft.com/office/drawing/2014/main" id="{5B4C3BEE-D9C6-4505-8C5F-7B317C9F60C7}"/>
               </a:ext>
             </a:extLst>
           </p:cNvPr>
@@ -9524,7 +9524,7 @@
           <p:cNvPr id="4" name="">
             <a:extLst xmlns:a="http://schemas.openxmlformats.org/drawingml/2006/main">
               <a:ext uri="{FF2B5EF4-FFF2-40B4-BE49-F238E27FC236}">
-                <a16:creationId xmlns:a16="http://schemas.microsoft.com/office/drawing/2014/main" id="{A7C29AE9-F394-45E9-8837-AF904B09BB7D}"/>
+                <a16:creationId xmlns:a16="http://schemas.microsoft.com/office/drawing/2014/main" id="{71A24727-BC96-4095-AADE-B10875EE04F8}"/>
               </a:ext>
             </a:extLst>
           </p:cNvPr>
@@ -9639,7 +9639,7 @@
           <p:cNvPr id="5" name="">
             <a:extLst xmlns:a="http://schemas.openxmlformats.org/drawingml/2006/main">
               <a:ext uri="{FF2B5EF4-FFF2-40B4-BE49-F238E27FC236}">
-                <a16:creationId xmlns:a16="http://schemas.microsoft.com/office/drawing/2014/main" id="{4817C926-D581-4717-9CAD-59658267CB3F}"/>
+                <a16:creationId xmlns:a16="http://schemas.microsoft.com/office/drawing/2014/main" id="{A66F0C37-B1B6-4BA4-B7E9-4E6B95567A3D}"/>
               </a:ext>
             </a:extLst>
           </p:cNvPr>
@@ -9694,7 +9694,7 @@
     </p:spTree>
     <p:extLst>
       <p:ext uri="{BB962C8B-B14F-4D97-AF65-F5344CB8AC3E}">
-        <p14:creationId xmlns:p14="http://schemas.microsoft.com/office/powerpoint/2010/main" val="32729578"/>
+        <p14:creationId xmlns:p14="http://schemas.microsoft.com/office/powerpoint/2010/main" val="1951878457"/>
       </p:ext>
     </p:extLst>
   </p:cSld>
@@ -9725,7 +9725,7 @@
           <p:cNvPr id="6" name="">
             <a:extLst xmlns:a="http://schemas.openxmlformats.org/drawingml/2006/main">
               <a:ext uri="{FF2B5EF4-FFF2-40B4-BE49-F238E27FC236}">
-                <a16:creationId xmlns:a16="http://schemas.microsoft.com/office/drawing/2014/main" id="{55949734-689B-48E3-89AA-022DFF037B25}"/>
+                <a16:creationId xmlns:a16="http://schemas.microsoft.com/office/drawing/2014/main" id="{46659465-7F9F-4D7B-B8FF-4AEAF9E029B8}"/>
               </a:ext>
             </a:extLst>
           </p:cNvPr>
@@ -9782,7 +9782,7 @@
           <p:cNvPr id="2" name="">
             <a:extLst xmlns:a="http://schemas.openxmlformats.org/drawingml/2006/main">
               <a:ext uri="{FF2B5EF4-FFF2-40B4-BE49-F238E27FC236}">
-                <a16:creationId xmlns:a16="http://schemas.microsoft.com/office/drawing/2014/main" id="{34AEB1E3-5A98-4D21-BF17-7414DC691BFB}"/>
+                <a16:creationId xmlns:a16="http://schemas.microsoft.com/office/drawing/2014/main" id="{D867557F-66A9-4BB2-A26C-C821505DE292}"/>
               </a:ext>
             </a:extLst>
           </p:cNvPr>
@@ -9839,7 +9839,7 @@
           <p:cNvPr id="3" name="">
             <a:extLst xmlns:a="http://schemas.openxmlformats.org/drawingml/2006/main">
               <a:ext uri="{FF2B5EF4-FFF2-40B4-BE49-F238E27FC236}">
-                <a16:creationId xmlns:a16="http://schemas.microsoft.com/office/drawing/2014/main" id="{AC7BBF0E-B263-47C5-916C-31E5D4F6ABEB}"/>
+                <a16:creationId xmlns:a16="http://schemas.microsoft.com/office/drawing/2014/main" id="{A6345670-FD3C-4661-9339-E6A278D7C61B}"/>
               </a:ext>
             </a:extLst>
           </p:cNvPr>
@@ -10738,7 +10738,7 @@
           <p:cNvPr id="5" name="">
             <a:extLst xmlns:a="http://schemas.openxmlformats.org/drawingml/2006/main">
               <a:ext uri="{FF2B5EF4-FFF2-40B4-BE49-F238E27FC236}">
-                <a16:creationId xmlns:a16="http://schemas.microsoft.com/office/drawing/2014/main" id="{DC7E0400-2B1B-4BA7-8933-B4ECC74F4D0A}"/>
+                <a16:creationId xmlns:a16="http://schemas.microsoft.com/office/drawing/2014/main" id="{AC929227-29A6-4967-BB18-16F160E107EA}"/>
               </a:ext>
             </a:extLst>
           </p:cNvPr>
@@ -10793,7 +10793,7 @@
     </p:spTree>
     <p:extLst>
       <p:ext uri="{BB962C8B-B14F-4D97-AF65-F5344CB8AC3E}">
-        <p14:creationId xmlns:p14="http://schemas.microsoft.com/office/powerpoint/2010/main" val="2018317244"/>
+        <p14:creationId xmlns:p14="http://schemas.microsoft.com/office/powerpoint/2010/main" val="52263718"/>
       </p:ext>
     </p:extLst>
   </p:cSld>
@@ -10824,7 +10824,7 @@
           <p:cNvPr id="6" name="">
             <a:extLst xmlns:a="http://schemas.openxmlformats.org/drawingml/2006/main">
               <a:ext uri="{FF2B5EF4-FFF2-40B4-BE49-F238E27FC236}">
-                <a16:creationId xmlns:a16="http://schemas.microsoft.com/office/drawing/2014/main" id="{94CA99D4-B806-4884-8E2F-4AEB56133331}"/>
+                <a16:creationId xmlns:a16="http://schemas.microsoft.com/office/drawing/2014/main" id="{D689ADE2-4D0B-412F-89C9-737F2ADC7BDA}"/>
               </a:ext>
             </a:extLst>
           </p:cNvPr>
@@ -10881,7 +10881,7 @@
           <p:cNvPr id="2" name="">
             <a:extLst xmlns:a="http://schemas.openxmlformats.org/drawingml/2006/main">
               <a:ext uri="{FF2B5EF4-FFF2-40B4-BE49-F238E27FC236}">
-                <a16:creationId xmlns:a16="http://schemas.microsoft.com/office/drawing/2014/main" id="{E04FDE31-204C-4CB9-98F1-495FB4F491B1}"/>
+                <a16:creationId xmlns:a16="http://schemas.microsoft.com/office/drawing/2014/main" id="{F4B2D2DB-5685-48C3-B467-BA737B4E018E}"/>
               </a:ext>
             </a:extLst>
           </p:cNvPr>
@@ -10938,7 +10938,7 @@
           <p:cNvPr id="3" name="">
             <a:extLst xmlns:a="http://schemas.openxmlformats.org/drawingml/2006/main">
               <a:ext uri="{FF2B5EF4-FFF2-40B4-BE49-F238E27FC236}">
-                <a16:creationId xmlns:a16="http://schemas.microsoft.com/office/drawing/2014/main" id="{A0F575E8-28AC-47FA-805A-2FD9469231DF}"/>
+                <a16:creationId xmlns:a16="http://schemas.microsoft.com/office/drawing/2014/main" id="{3BF790DE-C94B-4CE6-AE7F-5A2CC33D2FD6}"/>
               </a:ext>
             </a:extLst>
           </p:cNvPr>
@@ -10995,7 +10995,7 @@
           <p:cNvPr id="4" name="">
             <a:extLst xmlns:a="http://schemas.openxmlformats.org/drawingml/2006/main">
               <a:ext uri="{FF2B5EF4-FFF2-40B4-BE49-F238E27FC236}">
-                <a16:creationId xmlns:a16="http://schemas.microsoft.com/office/drawing/2014/main" id="{46888CD7-0CA2-4AB4-AB92-8212291DD8B7}"/>
+                <a16:creationId xmlns:a16="http://schemas.microsoft.com/office/drawing/2014/main" id="{56F414A4-092F-4C18-9D73-741E3D54774D}"/>
               </a:ext>
             </a:extLst>
           </p:cNvPr>
@@ -11159,7 +11159,20 @@
                           <a:ea typeface="Arial"/>
                           <a:cs typeface="Arial"/>
                         </a:rPr>
-                        <a:t>Logistic regression</a:t>
+                        <a:t>All RNA</a:t>
+                      </a:r>
+                    </a:p>
+                    <a:p>
+                      <a:r>
+                        <a:rPr sz="2100" b="0">
+                          <a:solidFill>
+                            <a:srgbClr val="16343E"/>
+                          </a:solidFill>
+                          <a:latin typeface="Arial"/>
+                          <a:ea typeface="Arial"/>
+                          <a:cs typeface="Arial"/>
+                        </a:rPr>
+                        <a:t>(Logistic Regression)</a:t>
                       </a:r>
                     </a:p>
                   </a:txBody>
@@ -11283,7 +11296,7 @@
     </p:spTree>
     <p:extLst>
       <p:ext uri="{BB962C8B-B14F-4D97-AF65-F5344CB8AC3E}">
-        <p14:creationId xmlns:p14="http://schemas.microsoft.com/office/powerpoint/2010/main" val="2063255045"/>
+        <p14:creationId xmlns:p14="http://schemas.microsoft.com/office/powerpoint/2010/main" val="219983860"/>
       </p:ext>
     </p:extLst>
   </p:cSld>
@@ -11314,7 +11327,7 @@
           <p:cNvPr id="9" name="">
             <a:extLst xmlns:a="http://schemas.openxmlformats.org/drawingml/2006/main">
               <a:ext uri="{FF2B5EF4-FFF2-40B4-BE49-F238E27FC236}">
-                <a16:creationId xmlns:a16="http://schemas.microsoft.com/office/drawing/2014/main" id="{8A32D8E0-FF44-4BE2-9CFB-986A8B0D238F}"/>
+                <a16:creationId xmlns:a16="http://schemas.microsoft.com/office/drawing/2014/main" id="{747543AD-C6F5-40BE-9DE2-619718B36445}"/>
               </a:ext>
             </a:extLst>
           </p:cNvPr>
@@ -11371,7 +11384,7 @@
           <p:cNvPr id="2" name="">
             <a:extLst xmlns:a="http://schemas.openxmlformats.org/drawingml/2006/main">
               <a:ext uri="{FF2B5EF4-FFF2-40B4-BE49-F238E27FC236}">
-                <a16:creationId xmlns:a16="http://schemas.microsoft.com/office/drawing/2014/main" id="{4EB33213-B83B-4721-96ED-76442E42DD98}"/>
+                <a16:creationId xmlns:a16="http://schemas.microsoft.com/office/drawing/2014/main" id="{0895CCC0-1271-425F-A124-15C07C70327F}"/>
               </a:ext>
             </a:extLst>
           </p:cNvPr>
@@ -11428,7 +11441,7 @@
           <p:cNvPr id="3" name="">
             <a:extLst xmlns:a="http://schemas.openxmlformats.org/drawingml/2006/main">
               <a:ext uri="{FF2B5EF4-FFF2-40B4-BE49-F238E27FC236}">
-                <a16:creationId xmlns:a16="http://schemas.microsoft.com/office/drawing/2014/main" id="{9C0ACBFF-05B7-4B3D-940E-B6FD3159A4E4}"/>
+                <a16:creationId xmlns:a16="http://schemas.microsoft.com/office/drawing/2014/main" id="{3AA42124-549C-4D7F-9C48-202E0DF4D28D}"/>
               </a:ext>
             </a:extLst>
           </p:cNvPr>
@@ -11485,7 +11498,7 @@
           <p:cNvPr id="4" name="">
             <a:extLst xmlns:a="http://schemas.openxmlformats.org/drawingml/2006/main">
               <a:ext uri="{FF2B5EF4-FFF2-40B4-BE49-F238E27FC236}">
-                <a16:creationId xmlns:a16="http://schemas.microsoft.com/office/drawing/2014/main" id="{121AF52B-247E-4943-8B8E-540AADEA40D2}"/>
+                <a16:creationId xmlns:a16="http://schemas.microsoft.com/office/drawing/2014/main" id="{84D4E816-D788-4751-AFE5-0AF7FFA67E4A}"/>
               </a:ext>
             </a:extLst>
           </p:cNvPr>
@@ -11549,7 +11562,7 @@
         </p:xfrm>
         <a:graphic xmlns:a="http://schemas.openxmlformats.org/drawingml/2006/main">
           <a:graphicData uri="http://schemas.openxmlformats.org/drawingml/2006/chart">
-            <c:chart xmlns:r="http://schemas.openxmlformats.org/officeDocument/2006/relationships" xmlns:c="http://schemas.openxmlformats.org/drawingml/2006/chart" r:id="Rdb5be6f53d784fec"/>
+            <c:chart xmlns:r="http://schemas.openxmlformats.org/officeDocument/2006/relationships" xmlns:c="http://schemas.openxmlformats.org/drawingml/2006/chart" r:id="R619cde001f45431e"/>
           </a:graphicData>
         </a:graphic>
       </p:graphicFrame>
@@ -11558,7 +11571,7 @@
           <p:cNvPr id="6" name="">
             <a:extLst xmlns:a="http://schemas.openxmlformats.org/drawingml/2006/main">
               <a:ext uri="{FF2B5EF4-FFF2-40B4-BE49-F238E27FC236}">
-                <a16:creationId xmlns:a16="http://schemas.microsoft.com/office/drawing/2014/main" id="{2622B0D4-E884-4620-B1B0-921155D8EF9D}"/>
+                <a16:creationId xmlns:a16="http://schemas.microsoft.com/office/drawing/2014/main" id="{05CCD67C-E81B-4374-BA9B-79912B8A1572}"/>
               </a:ext>
             </a:extLst>
           </p:cNvPr>
@@ -11615,7 +11628,7 @@
           <p:cNvPr id="7" name="">
             <a:extLst xmlns:a="http://schemas.openxmlformats.org/drawingml/2006/main">
               <a:ext uri="{FF2B5EF4-FFF2-40B4-BE49-F238E27FC236}">
-                <a16:creationId xmlns:a16="http://schemas.microsoft.com/office/drawing/2014/main" id="{CC790DE9-2EAD-454D-ABE5-2D1A29391439}"/>
+                <a16:creationId xmlns:a16="http://schemas.microsoft.com/office/drawing/2014/main" id="{B4B380D1-84D2-43EC-BBFD-C6B6CA8610C0}"/>
               </a:ext>
             </a:extLst>
           </p:cNvPr>
@@ -11731,7 +11744,7 @@
           <p:cNvPr id="8" name="">
             <a:extLst xmlns:a="http://schemas.openxmlformats.org/drawingml/2006/main">
               <a:ext uri="{FF2B5EF4-FFF2-40B4-BE49-F238E27FC236}">
-                <a16:creationId xmlns:a16="http://schemas.microsoft.com/office/drawing/2014/main" id="{42E79CB4-9A24-4FE6-A128-BEC205DE1A99}"/>
+                <a16:creationId xmlns:a16="http://schemas.microsoft.com/office/drawing/2014/main" id="{A4877D99-A50E-4936-B1B4-C85CDB2AB788}"/>
               </a:ext>
             </a:extLst>
           </p:cNvPr>
@@ -11786,7 +11799,7 @@
     </p:spTree>
     <p:extLst>
       <p:ext uri="{BB962C8B-B14F-4D97-AF65-F5344CB8AC3E}">
-        <p14:creationId xmlns:p14="http://schemas.microsoft.com/office/powerpoint/2010/main" val="1128465027"/>
+        <p14:creationId xmlns:p14="http://schemas.microsoft.com/office/powerpoint/2010/main" val="1188728465"/>
       </p:ext>
     </p:extLst>
   </p:cSld>
@@ -11817,7 +11830,7 @@
           <p:cNvPr id="6" name="">
             <a:extLst xmlns:a="http://schemas.openxmlformats.org/drawingml/2006/main">
               <a:ext uri="{FF2B5EF4-FFF2-40B4-BE49-F238E27FC236}">
-                <a16:creationId xmlns:a16="http://schemas.microsoft.com/office/drawing/2014/main" id="{F97148CA-A3EC-4BF9-8EAE-08483ABB644F}"/>
+                <a16:creationId xmlns:a16="http://schemas.microsoft.com/office/drawing/2014/main" id="{1232AB50-136A-46CC-BBF0-C02403D4EA0A}"/>
               </a:ext>
             </a:extLst>
           </p:cNvPr>
@@ -11874,7 +11887,7 @@
           <p:cNvPr id="2" name="">
             <a:extLst xmlns:a="http://schemas.openxmlformats.org/drawingml/2006/main">
               <a:ext uri="{FF2B5EF4-FFF2-40B4-BE49-F238E27FC236}">
-                <a16:creationId xmlns:a16="http://schemas.microsoft.com/office/drawing/2014/main" id="{80A451FE-5834-485B-B4AE-ED3A7364D28D}"/>
+                <a16:creationId xmlns:a16="http://schemas.microsoft.com/office/drawing/2014/main" id="{DAF49CAA-5FC2-40E9-87A7-2B13D2512877}"/>
               </a:ext>
             </a:extLst>
           </p:cNvPr>
@@ -11931,7 +11944,7 @@
           <p:cNvPr id="3" name="">
             <a:extLst xmlns:a="http://schemas.openxmlformats.org/drawingml/2006/main">
               <a:ext uri="{FF2B5EF4-FFF2-40B4-BE49-F238E27FC236}">
-                <a16:creationId xmlns:a16="http://schemas.microsoft.com/office/drawing/2014/main" id="{8DACE6B3-499E-4A3E-B00C-0F2C60CAB1B9}"/>
+                <a16:creationId xmlns:a16="http://schemas.microsoft.com/office/drawing/2014/main" id="{7F91929E-A4B3-459C-8C05-6FB92E57CAD5}"/>
               </a:ext>
             </a:extLst>
           </p:cNvPr>
@@ -12411,7 +12424,7 @@
           <p:cNvPr id="5" name="">
             <a:extLst xmlns:a="http://schemas.openxmlformats.org/drawingml/2006/main">
               <a:ext uri="{FF2B5EF4-FFF2-40B4-BE49-F238E27FC236}">
-                <a16:creationId xmlns:a16="http://schemas.microsoft.com/office/drawing/2014/main" id="{79F5D0DE-361B-4A61-AF76-638BE0EFF6CF}"/>
+                <a16:creationId xmlns:a16="http://schemas.microsoft.com/office/drawing/2014/main" id="{9FC79E3C-79F9-4E29-A9D5-8628D0D24354}"/>
               </a:ext>
             </a:extLst>
           </p:cNvPr>
@@ -12470,7 +12483,7 @@
     </p:spTree>
     <p:extLst>
       <p:ext uri="{BB962C8B-B14F-4D97-AF65-F5344CB8AC3E}">
-        <p14:creationId xmlns:p14="http://schemas.microsoft.com/office/powerpoint/2010/main" val="1748712610"/>
+        <p14:creationId xmlns:p14="http://schemas.microsoft.com/office/powerpoint/2010/main" val="439906211"/>
       </p:ext>
     </p:extLst>
   </p:cSld>
@@ -12501,7 +12514,7 @@
           <p:cNvPr id="5" name="">
             <a:extLst xmlns:a="http://schemas.openxmlformats.org/drawingml/2006/main">
               <a:ext uri="{FF2B5EF4-FFF2-40B4-BE49-F238E27FC236}">
-                <a16:creationId xmlns:a16="http://schemas.microsoft.com/office/drawing/2014/main" id="{E70CABA4-0B91-44F2-887D-AED6C7DC16C2}"/>
+                <a16:creationId xmlns:a16="http://schemas.microsoft.com/office/drawing/2014/main" id="{868A43C7-957D-45FB-95B7-1827737FAC5C}"/>
               </a:ext>
             </a:extLst>
           </p:cNvPr>
@@ -12558,7 +12571,7 @@
           <p:cNvPr id="2" name="">
             <a:extLst xmlns:a="http://schemas.openxmlformats.org/drawingml/2006/main">
               <a:ext uri="{FF2B5EF4-FFF2-40B4-BE49-F238E27FC236}">
-                <a16:creationId xmlns:a16="http://schemas.microsoft.com/office/drawing/2014/main" id="{6725FDBC-741E-43C6-BE5B-3128796BBDDC}"/>
+                <a16:creationId xmlns:a16="http://schemas.microsoft.com/office/drawing/2014/main" id="{B03C8645-EAF6-4FA4-AF0F-0A95CF368CFF}"/>
               </a:ext>
             </a:extLst>
           </p:cNvPr>
@@ -12615,7 +12628,7 @@
           <p:cNvPr id="3" name="">
             <a:extLst xmlns:a="http://schemas.openxmlformats.org/drawingml/2006/main">
               <a:ext uri="{FF2B5EF4-FFF2-40B4-BE49-F238E27FC236}">
-                <a16:creationId xmlns:a16="http://schemas.microsoft.com/office/drawing/2014/main" id="{ACEC57C8-88F3-45D0-BEBF-3143468EE48C}"/>
+                <a16:creationId xmlns:a16="http://schemas.microsoft.com/office/drawing/2014/main" id="{D08B6D4F-59A8-4AF6-816A-5E2979440FFB}"/>
               </a:ext>
             </a:extLst>
           </p:cNvPr>
@@ -13029,7 +13042,7 @@
     </p:spTree>
     <p:extLst>
       <p:ext uri="{BB962C8B-B14F-4D97-AF65-F5344CB8AC3E}">
-        <p14:creationId xmlns:p14="http://schemas.microsoft.com/office/powerpoint/2010/main" val="927022904"/>
+        <p14:creationId xmlns:p14="http://schemas.microsoft.com/office/powerpoint/2010/main" val="169428397"/>
       </p:ext>
     </p:extLst>
   </p:cSld>
@@ -13060,7 +13073,7 @@
           <p:cNvPr id="9" name="">
             <a:extLst xmlns:a="http://schemas.openxmlformats.org/drawingml/2006/main">
               <a:ext uri="{FF2B5EF4-FFF2-40B4-BE49-F238E27FC236}">
-                <a16:creationId xmlns:a16="http://schemas.microsoft.com/office/drawing/2014/main" id="{DD6F1A53-D048-4571-A82A-77FA85F84425}"/>
+                <a16:creationId xmlns:a16="http://schemas.microsoft.com/office/drawing/2014/main" id="{EE6DA9B7-F60F-489B-B241-98FE5043D3A2}"/>
               </a:ext>
             </a:extLst>
           </p:cNvPr>
@@ -13117,7 +13130,7 @@
           <p:cNvPr id="2" name="">
             <a:extLst xmlns:a="http://schemas.openxmlformats.org/drawingml/2006/main">
               <a:ext uri="{FF2B5EF4-FFF2-40B4-BE49-F238E27FC236}">
-                <a16:creationId xmlns:a16="http://schemas.microsoft.com/office/drawing/2014/main" id="{50F5A7F3-CBD2-43F4-B9A2-34ABFF0B5BB4}"/>
+                <a16:creationId xmlns:a16="http://schemas.microsoft.com/office/drawing/2014/main" id="{92E6F405-8D85-4974-A273-480B849B94F5}"/>
               </a:ext>
             </a:extLst>
           </p:cNvPr>
@@ -13174,7 +13187,7 @@
           <p:cNvPr id="3" name="">
             <a:extLst xmlns:a="http://schemas.openxmlformats.org/drawingml/2006/main">
               <a:ext uri="{FF2B5EF4-FFF2-40B4-BE49-F238E27FC236}">
-                <a16:creationId xmlns:a16="http://schemas.microsoft.com/office/drawing/2014/main" id="{6BC82A0E-893D-4517-8617-69B38F41E430}"/>
+                <a16:creationId xmlns:a16="http://schemas.microsoft.com/office/drawing/2014/main" id="{E87FE2A1-8BE3-474B-B3A2-5ADEA6FE9122}"/>
               </a:ext>
             </a:extLst>
           </p:cNvPr>
@@ -13231,7 +13244,7 @@
           <p:cNvPr id="4" name="">
             <a:extLst xmlns:a="http://schemas.openxmlformats.org/drawingml/2006/main">
               <a:ext uri="{FF2B5EF4-FFF2-40B4-BE49-F238E27FC236}">
-                <a16:creationId xmlns:a16="http://schemas.microsoft.com/office/drawing/2014/main" id="{E6377937-E98E-43C0-AB32-2B5875CD3E7C}"/>
+                <a16:creationId xmlns:a16="http://schemas.microsoft.com/office/drawing/2014/main" id="{577AEE9C-0C6E-43C5-9419-069AFA530131}"/>
               </a:ext>
             </a:extLst>
           </p:cNvPr>
@@ -13292,7 +13305,7 @@
           <p:cNvPr id="5" name="">
             <a:extLst xmlns:a="http://schemas.openxmlformats.org/drawingml/2006/main">
               <a:ext uri="{FF2B5EF4-FFF2-40B4-BE49-F238E27FC236}">
-                <a16:creationId xmlns:a16="http://schemas.microsoft.com/office/drawing/2014/main" id="{8C971C1F-17EF-4710-8AB3-BA3398344F6D}"/>
+                <a16:creationId xmlns:a16="http://schemas.microsoft.com/office/drawing/2014/main" id="{885231EE-69CD-4445-8A6D-B74F76BEC09A}"/>
               </a:ext>
             </a:extLst>
           </p:cNvPr>
@@ -13349,7 +13362,7 @@
           <p:cNvPr id="6" name="">
             <a:extLst xmlns:a="http://schemas.openxmlformats.org/drawingml/2006/main">
               <a:ext uri="{FF2B5EF4-FFF2-40B4-BE49-F238E27FC236}">
-                <a16:creationId xmlns:a16="http://schemas.microsoft.com/office/drawing/2014/main" id="{D420B206-7506-4C74-B0FF-6547D1C3DC23}"/>
+                <a16:creationId xmlns:a16="http://schemas.microsoft.com/office/drawing/2014/main" id="{DC477BF9-4BD8-4AA7-85A3-9D9E44EE15ED}"/>
               </a:ext>
             </a:extLst>
           </p:cNvPr>
@@ -13410,7 +13423,7 @@
           <p:cNvPr id="7" name="">
             <a:extLst xmlns:a="http://schemas.openxmlformats.org/drawingml/2006/main">
               <a:ext uri="{FF2B5EF4-FFF2-40B4-BE49-F238E27FC236}">
-                <a16:creationId xmlns:a16="http://schemas.microsoft.com/office/drawing/2014/main" id="{D00FF0A2-78F3-4229-A6EA-65361DF68C71}"/>
+                <a16:creationId xmlns:a16="http://schemas.microsoft.com/office/drawing/2014/main" id="{1B88A194-1C87-47D8-B7FB-0CA0370637FC}"/>
               </a:ext>
             </a:extLst>
           </p:cNvPr>
@@ -13467,7 +13480,7 @@
           <p:cNvPr id="8" name="">
             <a:extLst xmlns:a="http://schemas.openxmlformats.org/drawingml/2006/main">
               <a:ext uri="{FF2B5EF4-FFF2-40B4-BE49-F238E27FC236}">
-                <a16:creationId xmlns:a16="http://schemas.microsoft.com/office/drawing/2014/main" id="{19E3BB0A-BFA3-4717-8BBD-1C31B0E58D9A}"/>
+                <a16:creationId xmlns:a16="http://schemas.microsoft.com/office/drawing/2014/main" id="{96AE9056-C0AD-445C-94B7-41527272514D}"/>
               </a:ext>
             </a:extLst>
           </p:cNvPr>
@@ -13522,7 +13535,7 @@
     </p:spTree>
     <p:extLst>
       <p:ext uri="{BB962C8B-B14F-4D97-AF65-F5344CB8AC3E}">
-        <p14:creationId xmlns:p14="http://schemas.microsoft.com/office/powerpoint/2010/main" val="1702687091"/>
+        <p14:creationId xmlns:p14="http://schemas.microsoft.com/office/powerpoint/2010/main" val="694160498"/>
       </p:ext>
     </p:extLst>
   </p:cSld>
@@ -13553,7 +13566,7 @@
           <p:cNvPr id="6" name="">
             <a:extLst xmlns:a="http://schemas.openxmlformats.org/drawingml/2006/main">
               <a:ext uri="{FF2B5EF4-FFF2-40B4-BE49-F238E27FC236}">
-                <a16:creationId xmlns:a16="http://schemas.microsoft.com/office/drawing/2014/main" id="{792F73D4-7FC3-4CF0-8799-946D4DDEDAB7}"/>
+                <a16:creationId xmlns:a16="http://schemas.microsoft.com/office/drawing/2014/main" id="{54756BC6-E61F-4BE5-9C9C-0B9D419F5788}"/>
               </a:ext>
             </a:extLst>
           </p:cNvPr>
@@ -13610,7 +13623,7 @@
           <p:cNvPr id="2" name="">
             <a:extLst xmlns:a="http://schemas.openxmlformats.org/drawingml/2006/main">
               <a:ext uri="{FF2B5EF4-FFF2-40B4-BE49-F238E27FC236}">
-                <a16:creationId xmlns:a16="http://schemas.microsoft.com/office/drawing/2014/main" id="{BA5272BD-AC75-41B0-859F-7DE3E75C903D}"/>
+                <a16:creationId xmlns:a16="http://schemas.microsoft.com/office/drawing/2014/main" id="{01CCF35F-CE2E-42F1-BCAF-D691BAFFF801}"/>
               </a:ext>
             </a:extLst>
           </p:cNvPr>
@@ -13667,7 +13680,7 @@
           <p:cNvPr id="3" name="">
             <a:extLst xmlns:a="http://schemas.openxmlformats.org/drawingml/2006/main">
               <a:ext uri="{FF2B5EF4-FFF2-40B4-BE49-F238E27FC236}">
-                <a16:creationId xmlns:a16="http://schemas.microsoft.com/office/drawing/2014/main" id="{7E6F8FD4-DB0D-4106-ADAB-B21335ED430D}"/>
+                <a16:creationId xmlns:a16="http://schemas.microsoft.com/office/drawing/2014/main" id="{47716137-55C9-4DFB-8A00-E94F8C7FFC51}"/>
               </a:ext>
             </a:extLst>
           </p:cNvPr>
@@ -13724,7 +13737,7 @@
           <p:cNvPr id="4" name="">
             <a:extLst xmlns:a="http://schemas.openxmlformats.org/drawingml/2006/main">
               <a:ext uri="{FF2B5EF4-FFF2-40B4-BE49-F238E27FC236}">
-                <a16:creationId xmlns:a16="http://schemas.microsoft.com/office/drawing/2014/main" id="{6259CAD9-3C27-4250-AAB4-93235A36833C}"/>
+                <a16:creationId xmlns:a16="http://schemas.microsoft.com/office/drawing/2014/main" id="{0E797420-AB25-4E8B-B4CE-4CA59E912071}"/>
               </a:ext>
             </a:extLst>
           </p:cNvPr>
@@ -13866,7 +13879,7 @@
           <p:cNvPr id="5" name="">
             <a:extLst xmlns:a="http://schemas.openxmlformats.org/drawingml/2006/main">
               <a:ext uri="{FF2B5EF4-FFF2-40B4-BE49-F238E27FC236}">
-                <a16:creationId xmlns:a16="http://schemas.microsoft.com/office/drawing/2014/main" id="{6062BA0A-ECED-4DEE-95B3-D6FFF1E22A0A}"/>
+                <a16:creationId xmlns:a16="http://schemas.microsoft.com/office/drawing/2014/main" id="{4ED16745-8C7A-48E8-8997-163E3B0D5D7E}"/>
               </a:ext>
             </a:extLst>
           </p:cNvPr>
@@ -13921,7 +13934,7 @@
     </p:spTree>
     <p:extLst>
       <p:ext uri="{BB962C8B-B14F-4D97-AF65-F5344CB8AC3E}">
-        <p14:creationId xmlns:p14="http://schemas.microsoft.com/office/powerpoint/2010/main" val="1785283183"/>
+        <p14:creationId xmlns:p14="http://schemas.microsoft.com/office/powerpoint/2010/main" val="601556736"/>
       </p:ext>
     </p:extLst>
   </p:cSld>
@@ -13952,7 +13965,7 @@
           <p:cNvPr id="12" name="">
             <a:extLst xmlns:a="http://schemas.openxmlformats.org/drawingml/2006/main">
               <a:ext uri="{FF2B5EF4-FFF2-40B4-BE49-F238E27FC236}">
-                <a16:creationId xmlns:a16="http://schemas.microsoft.com/office/drawing/2014/main" id="{D4D853AF-C761-4DA2-8765-B68C043E00AD}"/>
+                <a16:creationId xmlns:a16="http://schemas.microsoft.com/office/drawing/2014/main" id="{7D0094FF-D06F-482B-9242-7BDFB4A9C78D}"/>
               </a:ext>
             </a:extLst>
           </p:cNvPr>
@@ -14009,7 +14022,7 @@
           <p:cNvPr id="2" name="">
             <a:extLst xmlns:a="http://schemas.openxmlformats.org/drawingml/2006/main">
               <a:ext uri="{FF2B5EF4-FFF2-40B4-BE49-F238E27FC236}">
-                <a16:creationId xmlns:a16="http://schemas.microsoft.com/office/drawing/2014/main" id="{D90DCD1E-C6DE-45A0-A022-222066D91A07}"/>
+                <a16:creationId xmlns:a16="http://schemas.microsoft.com/office/drawing/2014/main" id="{C7B8DF2E-2A67-43E8-BC68-500678ABAB6F}"/>
               </a:ext>
             </a:extLst>
           </p:cNvPr>
@@ -14066,7 +14079,7 @@
           <p:cNvPr id="3" name="">
             <a:extLst xmlns:a="http://schemas.openxmlformats.org/drawingml/2006/main">
               <a:ext uri="{FF2B5EF4-FFF2-40B4-BE49-F238E27FC236}">
-                <a16:creationId xmlns:a16="http://schemas.microsoft.com/office/drawing/2014/main" id="{1DCC894F-656A-41C3-9B2E-F66B0B888985}"/>
+                <a16:creationId xmlns:a16="http://schemas.microsoft.com/office/drawing/2014/main" id="{9524CB2D-7365-45BB-AA6B-73B32B7F3A63}"/>
               </a:ext>
             </a:extLst>
           </p:cNvPr>
@@ -14123,7 +14136,7 @@
           <p:cNvPr id="4" name="">
             <a:extLst xmlns:a="http://schemas.openxmlformats.org/drawingml/2006/main">
               <a:ext uri="{FF2B5EF4-FFF2-40B4-BE49-F238E27FC236}">
-                <a16:creationId xmlns:a16="http://schemas.microsoft.com/office/drawing/2014/main" id="{F40695B3-CF66-46F7-8B21-BFFC0DF85315}"/>
+                <a16:creationId xmlns:a16="http://schemas.microsoft.com/office/drawing/2014/main" id="{B23DB8C7-25C3-468D-A25F-3F3D7025F824}"/>
               </a:ext>
             </a:extLst>
           </p:cNvPr>
@@ -14184,7 +14197,7 @@
           <p:cNvPr id="5" name="">
             <a:extLst xmlns:a="http://schemas.openxmlformats.org/drawingml/2006/main">
               <a:ext uri="{FF2B5EF4-FFF2-40B4-BE49-F238E27FC236}">
-                <a16:creationId xmlns:a16="http://schemas.microsoft.com/office/drawing/2014/main" id="{D3C16AB5-4208-418F-B1A0-54A23D6A8903}"/>
+                <a16:creationId xmlns:a16="http://schemas.microsoft.com/office/drawing/2014/main" id="{CE814467-ED1A-4400-BFB3-F808AE2195DA}"/>
               </a:ext>
             </a:extLst>
           </p:cNvPr>
@@ -14216,7 +14229,7 @@
           <p:cNvPr id="6" name="">
             <a:extLst xmlns:a="http://schemas.openxmlformats.org/drawingml/2006/main">
               <a:ext uri="{FF2B5EF4-FFF2-40B4-BE49-F238E27FC236}">
-                <a16:creationId xmlns:a16="http://schemas.microsoft.com/office/drawing/2014/main" id="{05B485C7-E960-4EAC-B4C5-0C35F420C4C6}"/>
+                <a16:creationId xmlns:a16="http://schemas.microsoft.com/office/drawing/2014/main" id="{6C7DD97A-7F99-4356-B33D-F8D138297D7E}"/>
               </a:ext>
             </a:extLst>
           </p:cNvPr>
@@ -14273,7 +14286,7 @@
           <p:cNvPr id="7" name="">
             <a:extLst xmlns:a="http://schemas.openxmlformats.org/drawingml/2006/main">
               <a:ext uri="{FF2B5EF4-FFF2-40B4-BE49-F238E27FC236}">
-                <a16:creationId xmlns:a16="http://schemas.microsoft.com/office/drawing/2014/main" id="{10CD0D37-BC50-4B47-A78B-32D6F4346256}"/>
+                <a16:creationId xmlns:a16="http://schemas.microsoft.com/office/drawing/2014/main" id="{19D159D8-DA08-4A07-B0FA-265373FAC45A}"/>
               </a:ext>
             </a:extLst>
           </p:cNvPr>
@@ -14330,7 +14343,7 @@
           <p:cNvPr id="8" name="">
             <a:extLst xmlns:a="http://schemas.openxmlformats.org/drawingml/2006/main">
               <a:ext uri="{FF2B5EF4-FFF2-40B4-BE49-F238E27FC236}">
-                <a16:creationId xmlns:a16="http://schemas.microsoft.com/office/drawing/2014/main" id="{444710FB-0765-402D-8454-E83CE206B99D}"/>
+                <a16:creationId xmlns:a16="http://schemas.microsoft.com/office/drawing/2014/main" id="{04E0DEF9-6650-415E-A398-6A114C24555A}"/>
               </a:ext>
             </a:extLst>
           </p:cNvPr>
@@ -14391,7 +14404,7 @@
           <p:cNvPr id="9" name="">
             <a:extLst xmlns:a="http://schemas.openxmlformats.org/drawingml/2006/main">
               <a:ext uri="{FF2B5EF4-FFF2-40B4-BE49-F238E27FC236}">
-                <a16:creationId xmlns:a16="http://schemas.microsoft.com/office/drawing/2014/main" id="{E94AB028-1A71-4941-BDD5-67B75AAF820D}"/>
+                <a16:creationId xmlns:a16="http://schemas.microsoft.com/office/drawing/2014/main" id="{47412A2E-02DE-4CDB-8073-565EB9E26ABC}"/>
               </a:ext>
             </a:extLst>
           </p:cNvPr>
@@ -14423,7 +14436,7 @@
           <p:cNvPr id="10" name="">
             <a:extLst xmlns:a="http://schemas.openxmlformats.org/drawingml/2006/main">
               <a:ext uri="{FF2B5EF4-FFF2-40B4-BE49-F238E27FC236}">
-                <a16:creationId xmlns:a16="http://schemas.microsoft.com/office/drawing/2014/main" id="{81792C3B-F69B-4268-91FA-5B4103559451}"/>
+                <a16:creationId xmlns:a16="http://schemas.microsoft.com/office/drawing/2014/main" id="{3DD79409-DA12-44E8-83E1-C08C83F66DF9}"/>
               </a:ext>
             </a:extLst>
           </p:cNvPr>
@@ -14480,7 +14493,7 @@
           <p:cNvPr id="11" name="">
             <a:extLst xmlns:a="http://schemas.openxmlformats.org/drawingml/2006/main">
               <a:ext uri="{FF2B5EF4-FFF2-40B4-BE49-F238E27FC236}">
-                <a16:creationId xmlns:a16="http://schemas.microsoft.com/office/drawing/2014/main" id="{740B7907-02BB-42C8-B8B8-20C34DECC240}"/>
+                <a16:creationId xmlns:a16="http://schemas.microsoft.com/office/drawing/2014/main" id="{9221B7A7-BB82-47E5-8297-BF3AA2D21AFB}"/>
               </a:ext>
             </a:extLst>
           </p:cNvPr>
@@ -14535,7 +14548,7 @@
     </p:spTree>
     <p:extLst>
       <p:ext uri="{BB962C8B-B14F-4D97-AF65-F5344CB8AC3E}">
-        <p14:creationId xmlns:p14="http://schemas.microsoft.com/office/powerpoint/2010/main" val="1781090242"/>
+        <p14:creationId xmlns:p14="http://schemas.microsoft.com/office/powerpoint/2010/main" val="2045445522"/>
       </p:ext>
     </p:extLst>
   </p:cSld>
@@ -14566,7 +14579,7 @@
           <p:cNvPr id="13" name="">
             <a:extLst xmlns:a="http://schemas.openxmlformats.org/drawingml/2006/main">
               <a:ext uri="{FF2B5EF4-FFF2-40B4-BE49-F238E27FC236}">
-                <a16:creationId xmlns:a16="http://schemas.microsoft.com/office/drawing/2014/main" id="{4A0A6802-60E1-4F71-841B-0B9DB7E3D07F}"/>
+                <a16:creationId xmlns:a16="http://schemas.microsoft.com/office/drawing/2014/main" id="{8F689941-81D0-410F-AB8B-57AEB8C1665F}"/>
               </a:ext>
             </a:extLst>
           </p:cNvPr>
@@ -14623,7 +14636,7 @@
           <p:cNvPr id="2" name="">
             <a:extLst xmlns:a="http://schemas.openxmlformats.org/drawingml/2006/main">
               <a:ext uri="{FF2B5EF4-FFF2-40B4-BE49-F238E27FC236}">
-                <a16:creationId xmlns:a16="http://schemas.microsoft.com/office/drawing/2014/main" id="{5FD35806-55B6-48E9-AE77-0ACD56DF9AE1}"/>
+                <a16:creationId xmlns:a16="http://schemas.microsoft.com/office/drawing/2014/main" id="{DE445F7D-7B7F-4154-A019-8A4A3F06776B}"/>
               </a:ext>
             </a:extLst>
           </p:cNvPr>
@@ -14680,7 +14693,7 @@
           <p:cNvPr id="3" name="">
             <a:extLst xmlns:a="http://schemas.openxmlformats.org/drawingml/2006/main">
               <a:ext uri="{FF2B5EF4-FFF2-40B4-BE49-F238E27FC236}">
-                <a16:creationId xmlns:a16="http://schemas.microsoft.com/office/drawing/2014/main" id="{9764B4CD-157D-43D5-AB9A-EBAFDC5F04E1}"/>
+                <a16:creationId xmlns:a16="http://schemas.microsoft.com/office/drawing/2014/main" id="{752ECA23-295A-4957-AC18-5B29EA19AF5C}"/>
               </a:ext>
             </a:extLst>
           </p:cNvPr>
@@ -14760,7 +14773,7 @@
           <p:cNvPr id="4" name="">
             <a:extLst xmlns:a="http://schemas.openxmlformats.org/drawingml/2006/main">
               <a:ext uri="{FF2B5EF4-FFF2-40B4-BE49-F238E27FC236}">
-                <a16:creationId xmlns:a16="http://schemas.microsoft.com/office/drawing/2014/main" id="{700A1483-CD9B-4E66-AF79-9DBED3DA28FF}"/>
+                <a16:creationId xmlns:a16="http://schemas.microsoft.com/office/drawing/2014/main" id="{369761E7-060B-4CB7-8B23-7F6B73943D29}"/>
               </a:ext>
             </a:extLst>
           </p:cNvPr>
@@ -14840,7 +14853,7 @@
           <p:cNvPr id="5" name="">
             <a:extLst xmlns:a="http://schemas.openxmlformats.org/drawingml/2006/main">
               <a:ext uri="{FF2B5EF4-FFF2-40B4-BE49-F238E27FC236}">
-                <a16:creationId xmlns:a16="http://schemas.microsoft.com/office/drawing/2014/main" id="{CA48B105-69D3-43C6-9F16-DD65D2CBC73F}"/>
+                <a16:creationId xmlns:a16="http://schemas.microsoft.com/office/drawing/2014/main" id="{11E4EAB0-2B96-415C-8E28-3E5472EF237B}"/>
               </a:ext>
             </a:extLst>
           </p:cNvPr>
@@ -14869,7 +14882,7 @@
           <p:cNvPr id="6" name="">
             <a:extLst xmlns:a="http://schemas.openxmlformats.org/drawingml/2006/main">
               <a:ext uri="{FF2B5EF4-FFF2-40B4-BE49-F238E27FC236}">
-                <a16:creationId xmlns:a16="http://schemas.microsoft.com/office/drawing/2014/main" id="{FD3044F7-8F33-4C18-835A-A0522F10B3E2}"/>
+                <a16:creationId xmlns:a16="http://schemas.microsoft.com/office/drawing/2014/main" id="{E85079C7-066D-4961-8B00-31F9984FB331}"/>
               </a:ext>
             </a:extLst>
           </p:cNvPr>
@@ -14949,7 +14962,7 @@
           <p:cNvPr id="7" name="">
             <a:extLst xmlns:a="http://schemas.openxmlformats.org/drawingml/2006/main">
               <a:ext uri="{FF2B5EF4-FFF2-40B4-BE49-F238E27FC236}">
-                <a16:creationId xmlns:a16="http://schemas.microsoft.com/office/drawing/2014/main" id="{099AAEA2-2CBB-4743-AF46-592AFF36E53C}"/>
+                <a16:creationId xmlns:a16="http://schemas.microsoft.com/office/drawing/2014/main" id="{17147D30-8F26-450B-94A3-A2CB3435E34B}"/>
               </a:ext>
             </a:extLst>
           </p:cNvPr>
@@ -15052,7 +15065,7 @@
           <p:cNvPr id="8" name="">
             <a:extLst xmlns:a="http://schemas.openxmlformats.org/drawingml/2006/main">
               <a:ext uri="{FF2B5EF4-FFF2-40B4-BE49-F238E27FC236}">
-                <a16:creationId xmlns:a16="http://schemas.microsoft.com/office/drawing/2014/main" id="{5B7DC1EA-A84A-4DA6-BEBA-0703FC176FCB}"/>
+                <a16:creationId xmlns:a16="http://schemas.microsoft.com/office/drawing/2014/main" id="{AF230726-4AE7-4CD9-8F36-9D17DF0A1E64}"/>
               </a:ext>
             </a:extLst>
           </p:cNvPr>
@@ -15081,7 +15094,7 @@
           <p:cNvPr id="9" name="">
             <a:extLst xmlns:a="http://schemas.openxmlformats.org/drawingml/2006/main">
               <a:ext uri="{FF2B5EF4-FFF2-40B4-BE49-F238E27FC236}">
-                <a16:creationId xmlns:a16="http://schemas.microsoft.com/office/drawing/2014/main" id="{B74A76E9-C457-4A65-B468-59A7F1A5AE9F}"/>
+                <a16:creationId xmlns:a16="http://schemas.microsoft.com/office/drawing/2014/main" id="{C20A3927-01C7-41B2-B761-26D0D432F00C}"/>
               </a:ext>
             </a:extLst>
           </p:cNvPr>
@@ -15161,7 +15174,7 @@
           <p:cNvPr id="10" name="">
             <a:extLst xmlns:a="http://schemas.openxmlformats.org/drawingml/2006/main">
               <a:ext uri="{FF2B5EF4-FFF2-40B4-BE49-F238E27FC236}">
-                <a16:creationId xmlns:a16="http://schemas.microsoft.com/office/drawing/2014/main" id="{C14773EF-9F56-4DA7-AC34-9CB4C9F59933}"/>
+                <a16:creationId xmlns:a16="http://schemas.microsoft.com/office/drawing/2014/main" id="{85254D21-E6AA-4F3E-9FEB-400BA3315AF8}"/>
               </a:ext>
             </a:extLst>
           </p:cNvPr>
@@ -15241,7 +15254,7 @@
           <p:cNvPr id="11" name="">
             <a:extLst xmlns:a="http://schemas.openxmlformats.org/drawingml/2006/main">
               <a:ext uri="{FF2B5EF4-FFF2-40B4-BE49-F238E27FC236}">
-                <a16:creationId xmlns:a16="http://schemas.microsoft.com/office/drawing/2014/main" id="{319A97AD-B028-4ADC-9E5F-3348E01FCE5F}"/>
+                <a16:creationId xmlns:a16="http://schemas.microsoft.com/office/drawing/2014/main" id="{DA6C99F6-69E2-4508-AAA7-26E93EE87238}"/>
               </a:ext>
             </a:extLst>
           </p:cNvPr>
@@ -15298,7 +15311,7 @@
           <p:cNvPr id="12" name="">
             <a:extLst xmlns:a="http://schemas.openxmlformats.org/drawingml/2006/main">
               <a:ext uri="{FF2B5EF4-FFF2-40B4-BE49-F238E27FC236}">
-                <a16:creationId xmlns:a16="http://schemas.microsoft.com/office/drawing/2014/main" id="{7B5DC6CA-C3C7-4715-878B-406D312C8EC3}"/>
+                <a16:creationId xmlns:a16="http://schemas.microsoft.com/office/drawing/2014/main" id="{4DCF1F5A-E7F9-4CF4-8BFD-8214ED0BBD01}"/>
               </a:ext>
             </a:extLst>
           </p:cNvPr>
@@ -15376,7 +15389,7 @@
     </p:spTree>
     <p:extLst>
       <p:ext uri="{BB962C8B-B14F-4D97-AF65-F5344CB8AC3E}">
-        <p14:creationId xmlns:p14="http://schemas.microsoft.com/office/powerpoint/2010/main" val="386584874"/>
+        <p14:creationId xmlns:p14="http://schemas.microsoft.com/office/powerpoint/2010/main" val="345486194"/>
       </p:ext>
     </p:extLst>
   </p:cSld>
@@ -15407,7 +15420,7 @@
           <p:cNvPr id="13" name="">
             <a:extLst xmlns:a="http://schemas.openxmlformats.org/drawingml/2006/main">
               <a:ext uri="{FF2B5EF4-FFF2-40B4-BE49-F238E27FC236}">
-                <a16:creationId xmlns:a16="http://schemas.microsoft.com/office/drawing/2014/main" id="{1AEE0D6C-C4B9-44FD-95A3-7FE38B892007}"/>
+                <a16:creationId xmlns:a16="http://schemas.microsoft.com/office/drawing/2014/main" id="{8BBF5194-FEEA-46CA-9010-6186471E4359}"/>
               </a:ext>
             </a:extLst>
           </p:cNvPr>
@@ -15464,7 +15477,7 @@
           <p:cNvPr id="2" name="">
             <a:extLst xmlns:a="http://schemas.openxmlformats.org/drawingml/2006/main">
               <a:ext uri="{FF2B5EF4-FFF2-40B4-BE49-F238E27FC236}">
-                <a16:creationId xmlns:a16="http://schemas.microsoft.com/office/drawing/2014/main" id="{8ACFE6E9-E7AD-43A1-B79F-DB52D31F433A}"/>
+                <a16:creationId xmlns:a16="http://schemas.microsoft.com/office/drawing/2014/main" id="{4A8A6468-B3F1-4DF1-B4F4-6A1FF615CF5B}"/>
               </a:ext>
             </a:extLst>
           </p:cNvPr>
@@ -15521,7 +15534,7 @@
           <p:cNvPr id="3" name="">
             <a:extLst xmlns:a="http://schemas.openxmlformats.org/drawingml/2006/main">
               <a:ext uri="{FF2B5EF4-FFF2-40B4-BE49-F238E27FC236}">
-                <a16:creationId xmlns:a16="http://schemas.microsoft.com/office/drawing/2014/main" id="{7AA12727-FDB6-4C8A-B214-8BFAC369F758}"/>
+                <a16:creationId xmlns:a16="http://schemas.microsoft.com/office/drawing/2014/main" id="{52363668-78B2-4682-BB2F-AFA4E8557FC9}"/>
               </a:ext>
             </a:extLst>
           </p:cNvPr>
@@ -15578,7 +15591,7 @@
           <p:cNvPr id="4" name="">
             <a:extLst xmlns:a="http://schemas.openxmlformats.org/drawingml/2006/main">
               <a:ext uri="{FF2B5EF4-FFF2-40B4-BE49-F238E27FC236}">
-                <a16:creationId xmlns:a16="http://schemas.microsoft.com/office/drawing/2014/main" id="{248C12FC-B961-47E0-BE82-C3E202D12CA0}"/>
+                <a16:creationId xmlns:a16="http://schemas.microsoft.com/office/drawing/2014/main" id="{D2EE6615-AD9A-40EC-9790-0BC1330F7EB8}"/>
               </a:ext>
             </a:extLst>
           </p:cNvPr>
@@ -15635,7 +15648,7 @@
           <p:cNvPr id="5" name="">
             <a:extLst xmlns:a="http://schemas.openxmlformats.org/drawingml/2006/main">
               <a:ext uri="{FF2B5EF4-FFF2-40B4-BE49-F238E27FC236}">
-                <a16:creationId xmlns:a16="http://schemas.microsoft.com/office/drawing/2014/main" id="{85913D47-B39E-46CF-89EC-DB045E975E62}"/>
+                <a16:creationId xmlns:a16="http://schemas.microsoft.com/office/drawing/2014/main" id="{458081A9-CE04-43AB-9B8B-0C639994366C}"/>
               </a:ext>
             </a:extLst>
           </p:cNvPr>
@@ -15692,7 +15705,7 @@
           <p:cNvPr id="6" name="">
             <a:extLst xmlns:a="http://schemas.openxmlformats.org/drawingml/2006/main">
               <a:ext uri="{FF2B5EF4-FFF2-40B4-BE49-F238E27FC236}">
-                <a16:creationId xmlns:a16="http://schemas.microsoft.com/office/drawing/2014/main" id="{30F3E37F-F324-439D-BA90-5BB03D5BDF74}"/>
+                <a16:creationId xmlns:a16="http://schemas.microsoft.com/office/drawing/2014/main" id="{7A892AA4-A78A-4874-875D-38D1F4ED341A}"/>
               </a:ext>
             </a:extLst>
           </p:cNvPr>
@@ -16333,7 +16346,7 @@
           <p:cNvPr id="9" name="">
             <a:extLst xmlns:a="http://schemas.openxmlformats.org/drawingml/2006/main">
               <a:ext uri="{FF2B5EF4-FFF2-40B4-BE49-F238E27FC236}">
-                <a16:creationId xmlns:a16="http://schemas.microsoft.com/office/drawing/2014/main" id="{F5F9059B-0022-469F-BD4A-D19A69E2FBD4}"/>
+                <a16:creationId xmlns:a16="http://schemas.microsoft.com/office/drawing/2014/main" id="{E5DE46CB-2CD0-4D27-863F-9A1A8B9822EA}"/>
               </a:ext>
             </a:extLst>
           </p:cNvPr>
@@ -16362,7 +16375,7 @@
           <p:cNvPr id="10" name="">
             <a:extLst xmlns:a="http://schemas.openxmlformats.org/drawingml/2006/main">
               <a:ext uri="{FF2B5EF4-FFF2-40B4-BE49-F238E27FC236}">
-                <a16:creationId xmlns:a16="http://schemas.microsoft.com/office/drawing/2014/main" id="{A2F07EE9-05BA-499C-BCFB-78E3A41B2A29}"/>
+                <a16:creationId xmlns:a16="http://schemas.microsoft.com/office/drawing/2014/main" id="{B8C19ECA-71B8-4971-A0FC-6CE595A51252}"/>
               </a:ext>
             </a:extLst>
           </p:cNvPr>
@@ -16419,7 +16432,7 @@
           <p:cNvPr id="11" name="">
             <a:extLst xmlns:a="http://schemas.openxmlformats.org/drawingml/2006/main">
               <a:ext uri="{FF2B5EF4-FFF2-40B4-BE49-F238E27FC236}">
-                <a16:creationId xmlns:a16="http://schemas.microsoft.com/office/drawing/2014/main" id="{ACB8663F-7049-4618-BD05-FBF0192726B2}"/>
+                <a16:creationId xmlns:a16="http://schemas.microsoft.com/office/drawing/2014/main" id="{5A75C413-DEE7-4861-B17D-6515401959BF}"/>
               </a:ext>
             </a:extLst>
           </p:cNvPr>
@@ -16476,7 +16489,7 @@
           <p:cNvPr id="12" name="">
             <a:extLst xmlns:a="http://schemas.openxmlformats.org/drawingml/2006/main">
               <a:ext uri="{FF2B5EF4-FFF2-40B4-BE49-F238E27FC236}">
-                <a16:creationId xmlns:a16="http://schemas.microsoft.com/office/drawing/2014/main" id="{5AACCB7D-5496-4790-95E7-488540F0C82E}"/>
+                <a16:creationId xmlns:a16="http://schemas.microsoft.com/office/drawing/2014/main" id="{1FAA44A5-B590-4499-8EB0-CC8D4249FDBB}"/>
               </a:ext>
             </a:extLst>
           </p:cNvPr>
@@ -16562,7 +16575,7 @@
     </p:spTree>
     <p:extLst>
       <p:ext uri="{BB962C8B-B14F-4D97-AF65-F5344CB8AC3E}">
-        <p14:creationId xmlns:p14="http://schemas.microsoft.com/office/powerpoint/2010/main" val="1565939520"/>
+        <p14:creationId xmlns:p14="http://schemas.microsoft.com/office/powerpoint/2010/main" val="1584666981"/>
       </p:ext>
     </p:extLst>
   </p:cSld>
@@ -16593,7 +16606,7 @@
           <p:cNvPr id="7" name="">
             <a:extLst xmlns:a="http://schemas.openxmlformats.org/drawingml/2006/main">
               <a:ext uri="{FF2B5EF4-FFF2-40B4-BE49-F238E27FC236}">
-                <a16:creationId xmlns:a16="http://schemas.microsoft.com/office/drawing/2014/main" id="{530203F8-063A-41FF-BE49-026824C9C152}"/>
+                <a16:creationId xmlns:a16="http://schemas.microsoft.com/office/drawing/2014/main" id="{44A8CF2A-A2DF-44D8-8CA8-42E4DC8874B9}"/>
               </a:ext>
             </a:extLst>
           </p:cNvPr>
@@ -16650,7 +16663,7 @@
           <p:cNvPr id="2" name="">
             <a:extLst xmlns:a="http://schemas.openxmlformats.org/drawingml/2006/main">
               <a:ext uri="{FF2B5EF4-FFF2-40B4-BE49-F238E27FC236}">
-                <a16:creationId xmlns:a16="http://schemas.microsoft.com/office/drawing/2014/main" id="{64EC3BB2-2CA0-4BDD-A69D-C55F9CE9EAB2}"/>
+                <a16:creationId xmlns:a16="http://schemas.microsoft.com/office/drawing/2014/main" id="{B46E3E09-CAFB-424A-85C7-EA6F0C854FCA}"/>
               </a:ext>
             </a:extLst>
           </p:cNvPr>
@@ -16707,7 +16720,7 @@
           <p:cNvPr id="3" name="">
             <a:extLst xmlns:a="http://schemas.openxmlformats.org/drawingml/2006/main">
               <a:ext uri="{FF2B5EF4-FFF2-40B4-BE49-F238E27FC236}">
-                <a16:creationId xmlns:a16="http://schemas.microsoft.com/office/drawing/2014/main" id="{F17EA671-C37B-4538-8E20-4E11F85D2D2F}"/>
+                <a16:creationId xmlns:a16="http://schemas.microsoft.com/office/drawing/2014/main" id="{47350866-03CB-4344-AB3C-3DBC517D60B4}"/>
               </a:ext>
             </a:extLst>
           </p:cNvPr>
@@ -16764,7 +16777,7 @@
           <p:cNvPr id="4" name="">
             <a:extLst xmlns:a="http://schemas.openxmlformats.org/drawingml/2006/main">
               <a:ext uri="{FF2B5EF4-FFF2-40B4-BE49-F238E27FC236}">
-                <a16:creationId xmlns:a16="http://schemas.microsoft.com/office/drawing/2014/main" id="{E19FD193-D912-427E-B74A-BC9F58455B3E}"/>
+                <a16:creationId xmlns:a16="http://schemas.microsoft.com/office/drawing/2014/main" id="{B871FCA2-D629-4D78-BC9F-555A136B6638}"/>
               </a:ext>
             </a:extLst>
           </p:cNvPr>
@@ -17244,7 +17257,7 @@
           <p:cNvPr id="6" name="">
             <a:extLst xmlns:a="http://schemas.openxmlformats.org/drawingml/2006/main">
               <a:ext uri="{FF2B5EF4-FFF2-40B4-BE49-F238E27FC236}">
-                <a16:creationId xmlns:a16="http://schemas.microsoft.com/office/drawing/2014/main" id="{1E3310EB-7759-43E9-A078-3D6C3FD810A9}"/>
+                <a16:creationId xmlns:a16="http://schemas.microsoft.com/office/drawing/2014/main" id="{22D7393C-BA82-49A6-B44A-BAB803BCC5CA}"/>
               </a:ext>
             </a:extLst>
           </p:cNvPr>
@@ -17299,7 +17312,7 @@
     </p:spTree>
     <p:extLst>
       <p:ext uri="{BB962C8B-B14F-4D97-AF65-F5344CB8AC3E}">
-        <p14:creationId xmlns:p14="http://schemas.microsoft.com/office/powerpoint/2010/main" val="921123833"/>
+        <p14:creationId xmlns:p14="http://schemas.microsoft.com/office/powerpoint/2010/main" val="222773135"/>
       </p:ext>
     </p:extLst>
   </p:cSld>
@@ -17330,7 +17343,7 @@
           <p:cNvPr id="11" name="">
             <a:extLst xmlns:a="http://schemas.openxmlformats.org/drawingml/2006/main">
               <a:ext uri="{FF2B5EF4-FFF2-40B4-BE49-F238E27FC236}">
-                <a16:creationId xmlns:a16="http://schemas.microsoft.com/office/drawing/2014/main" id="{1A9EC766-77A7-4389-B5FF-64FC1971935C}"/>
+                <a16:creationId xmlns:a16="http://schemas.microsoft.com/office/drawing/2014/main" id="{BF5E277B-C1D1-4483-B2FD-04AE347221EF}"/>
               </a:ext>
             </a:extLst>
           </p:cNvPr>
@@ -17387,7 +17400,7 @@
           <p:cNvPr id="2" name="">
             <a:extLst xmlns:a="http://schemas.openxmlformats.org/drawingml/2006/main">
               <a:ext uri="{FF2B5EF4-FFF2-40B4-BE49-F238E27FC236}">
-                <a16:creationId xmlns:a16="http://schemas.microsoft.com/office/drawing/2014/main" id="{85567666-AAC0-4B7C-96AB-85D15D3A87DE}"/>
+                <a16:creationId xmlns:a16="http://schemas.microsoft.com/office/drawing/2014/main" id="{A247485B-5955-4C35-9F57-27CCEEC912BF}"/>
               </a:ext>
             </a:extLst>
           </p:cNvPr>
@@ -17444,7 +17457,7 @@
           <p:cNvPr id="3" name="">
             <a:extLst xmlns:a="http://schemas.openxmlformats.org/drawingml/2006/main">
               <a:ext uri="{FF2B5EF4-FFF2-40B4-BE49-F238E27FC236}">
-                <a16:creationId xmlns:a16="http://schemas.microsoft.com/office/drawing/2014/main" id="{6323A5A9-B1E6-4060-8032-B6E244107C4A}"/>
+                <a16:creationId xmlns:a16="http://schemas.microsoft.com/office/drawing/2014/main" id="{DE3A25CC-357A-4C47-98DD-EB022F226405}"/>
               </a:ext>
             </a:extLst>
           </p:cNvPr>
@@ -17501,7 +17514,7 @@
           <p:cNvPr id="4" name="">
             <a:extLst xmlns:a="http://schemas.openxmlformats.org/drawingml/2006/main">
               <a:ext uri="{FF2B5EF4-FFF2-40B4-BE49-F238E27FC236}">
-                <a16:creationId xmlns:a16="http://schemas.microsoft.com/office/drawing/2014/main" id="{C345ECE2-89D5-4EF4-85A0-160E90189ADC}"/>
+                <a16:creationId xmlns:a16="http://schemas.microsoft.com/office/drawing/2014/main" id="{8956A68A-A1FA-4DA6-A32C-B5F890D75FFC}"/>
               </a:ext>
             </a:extLst>
           </p:cNvPr>
@@ -17558,7 +17571,7 @@
           <p:cNvPr id="5" name="">
             <a:extLst xmlns:a="http://schemas.openxmlformats.org/drawingml/2006/main">
               <a:ext uri="{FF2B5EF4-FFF2-40B4-BE49-F238E27FC236}">
-                <a16:creationId xmlns:a16="http://schemas.microsoft.com/office/drawing/2014/main" id="{2F6AB28F-A9CA-4536-AC0F-68BD5C74AD32}"/>
+                <a16:creationId xmlns:a16="http://schemas.microsoft.com/office/drawing/2014/main" id="{9D2896D0-D3E7-47F2-ADD4-A1F464B762C2}"/>
               </a:ext>
             </a:extLst>
           </p:cNvPr>
@@ -17615,7 +17628,7 @@
           <p:cNvPr id="6" name="">
             <a:extLst xmlns:a="http://schemas.openxmlformats.org/drawingml/2006/main">
               <a:ext uri="{FF2B5EF4-FFF2-40B4-BE49-F238E27FC236}">
-                <a16:creationId xmlns:a16="http://schemas.microsoft.com/office/drawing/2014/main" id="{26C9D8F6-2B95-4C71-B7BF-897685A95465}"/>
+                <a16:creationId xmlns:a16="http://schemas.microsoft.com/office/drawing/2014/main" id="{4137A967-7F02-4CD1-B6AC-06500951854C}"/>
               </a:ext>
             </a:extLst>
           </p:cNvPr>
@@ -17672,7 +17685,7 @@
           <p:cNvPr id="7" name="">
             <a:extLst xmlns:a="http://schemas.openxmlformats.org/drawingml/2006/main">
               <a:ext uri="{FF2B5EF4-FFF2-40B4-BE49-F238E27FC236}">
-                <a16:creationId xmlns:a16="http://schemas.microsoft.com/office/drawing/2014/main" id="{142126E8-305D-488B-A1EC-3AB53A4CD8AD}"/>
+                <a16:creationId xmlns:a16="http://schemas.microsoft.com/office/drawing/2014/main" id="{4E3B97A8-9E57-4588-963E-2D4EB585E46B}"/>
               </a:ext>
             </a:extLst>
           </p:cNvPr>
@@ -17760,7 +17773,7 @@
           <p:cNvPr id="8" name="">
             <a:extLst xmlns:a="http://schemas.openxmlformats.org/drawingml/2006/main">
               <a:ext uri="{FF2B5EF4-FFF2-40B4-BE49-F238E27FC236}">
-                <a16:creationId xmlns:a16="http://schemas.microsoft.com/office/drawing/2014/main" id="{A9070DA0-29A3-4EFF-B02F-E37870919204}"/>
+                <a16:creationId xmlns:a16="http://schemas.microsoft.com/office/drawing/2014/main" id="{82055B4A-41A5-4F73-B508-6488529D9057}"/>
               </a:ext>
             </a:extLst>
           </p:cNvPr>
@@ -17817,7 +17830,7 @@
           <p:cNvPr id="9" name="">
             <a:extLst xmlns:a="http://schemas.openxmlformats.org/drawingml/2006/main">
               <a:ext uri="{FF2B5EF4-FFF2-40B4-BE49-F238E27FC236}">
-                <a16:creationId xmlns:a16="http://schemas.microsoft.com/office/drawing/2014/main" id="{69AD5B74-29E0-4123-AE44-CF7D9DEF89FB}"/>
+                <a16:creationId xmlns:a16="http://schemas.microsoft.com/office/drawing/2014/main" id="{584981A0-8D2C-4969-854D-068B6AEFCB8B}"/>
               </a:ext>
             </a:extLst>
           </p:cNvPr>
@@ -17874,7 +17887,7 @@
           <p:cNvPr id="10" name="">
             <a:extLst xmlns:a="http://schemas.openxmlformats.org/drawingml/2006/main">
               <a:ext uri="{FF2B5EF4-FFF2-40B4-BE49-F238E27FC236}">
-                <a16:creationId xmlns:a16="http://schemas.microsoft.com/office/drawing/2014/main" id="{08970738-5308-405F-8E5B-B2D491585586}"/>
+                <a16:creationId xmlns:a16="http://schemas.microsoft.com/office/drawing/2014/main" id="{5FEB0AB1-71A1-45B0-BB16-B29FED619364}"/>
               </a:ext>
             </a:extLst>
           </p:cNvPr>
@@ -17960,7 +17973,7 @@
     </p:spTree>
     <p:extLst>
       <p:ext uri="{BB962C8B-B14F-4D97-AF65-F5344CB8AC3E}">
-        <p14:creationId xmlns:p14="http://schemas.microsoft.com/office/powerpoint/2010/main" val="954663590"/>
+        <p14:creationId xmlns:p14="http://schemas.microsoft.com/office/powerpoint/2010/main" val="50937248"/>
       </p:ext>
     </p:extLst>
   </p:cSld>
@@ -17991,7 +18004,7 @@
           <p:cNvPr id="5" name="">
             <a:extLst xmlns:a="http://schemas.openxmlformats.org/drawingml/2006/main">
               <a:ext uri="{FF2B5EF4-FFF2-40B4-BE49-F238E27FC236}">
-                <a16:creationId xmlns:a16="http://schemas.microsoft.com/office/drawing/2014/main" id="{F59022C3-8492-4A1A-9115-541B3434698A}"/>
+                <a16:creationId xmlns:a16="http://schemas.microsoft.com/office/drawing/2014/main" id="{7E8FD5C5-8EE8-44B4-8DC3-9E93C2F931F5}"/>
               </a:ext>
             </a:extLst>
           </p:cNvPr>
@@ -18048,7 +18061,7 @@
           <p:cNvPr id="2" name="">
             <a:extLst xmlns:a="http://schemas.openxmlformats.org/drawingml/2006/main">
               <a:ext uri="{FF2B5EF4-FFF2-40B4-BE49-F238E27FC236}">
-                <a16:creationId xmlns:a16="http://schemas.microsoft.com/office/drawing/2014/main" id="{42A1B70B-B1A7-44B0-AD75-8A440A85C1D3}"/>
+                <a16:creationId xmlns:a16="http://schemas.microsoft.com/office/drawing/2014/main" id="{13E62D48-0548-41BA-B291-C48F3D328C22}"/>
               </a:ext>
             </a:extLst>
           </p:cNvPr>
@@ -18105,7 +18118,7 @@
           <p:cNvPr id="3" name="">
             <a:extLst xmlns:a="http://schemas.openxmlformats.org/drawingml/2006/main">
               <a:ext uri="{FF2B5EF4-FFF2-40B4-BE49-F238E27FC236}">
-                <a16:creationId xmlns:a16="http://schemas.microsoft.com/office/drawing/2014/main" id="{8D781209-53D4-4F98-919E-464A38163246}"/>
+                <a16:creationId xmlns:a16="http://schemas.microsoft.com/office/drawing/2014/main" id="{E0DDD4C0-7D48-428B-801A-FDD94C7B13DB}"/>
               </a:ext>
             </a:extLst>
           </p:cNvPr>
@@ -18452,7 +18465,7 @@
     </p:spTree>
     <p:extLst>
       <p:ext uri="{BB962C8B-B14F-4D97-AF65-F5344CB8AC3E}">
-        <p14:creationId xmlns:p14="http://schemas.microsoft.com/office/powerpoint/2010/main" val="54921498"/>
+        <p14:creationId xmlns:p14="http://schemas.microsoft.com/office/powerpoint/2010/main" val="1488822957"/>
       </p:ext>
     </p:extLst>
   </p:cSld>
@@ -18483,7 +18496,7 @@
           <p:cNvPr id="11" name="">
             <a:extLst xmlns:a="http://schemas.openxmlformats.org/drawingml/2006/main">
               <a:ext uri="{FF2B5EF4-FFF2-40B4-BE49-F238E27FC236}">
-                <a16:creationId xmlns:a16="http://schemas.microsoft.com/office/drawing/2014/main" id="{E759C133-CC44-41D0-800A-FD32AA27D446}"/>
+                <a16:creationId xmlns:a16="http://schemas.microsoft.com/office/drawing/2014/main" id="{6114CA52-274F-433E-ABB8-2D911D3A85C6}"/>
               </a:ext>
             </a:extLst>
           </p:cNvPr>
@@ -18540,7 +18553,7 @@
           <p:cNvPr id="2" name="">
             <a:extLst xmlns:a="http://schemas.openxmlformats.org/drawingml/2006/main">
               <a:ext uri="{FF2B5EF4-FFF2-40B4-BE49-F238E27FC236}">
-                <a16:creationId xmlns:a16="http://schemas.microsoft.com/office/drawing/2014/main" id="{A0CC3C13-2C92-44B5-B27A-7F26B0BFB94C}"/>
+                <a16:creationId xmlns:a16="http://schemas.microsoft.com/office/drawing/2014/main" id="{E2B4C38D-2772-4F26-9BDD-91678CE996E2}"/>
               </a:ext>
             </a:extLst>
           </p:cNvPr>
@@ -18597,7 +18610,7 @@
           <p:cNvPr id="3" name="">
             <a:extLst xmlns:a="http://schemas.openxmlformats.org/drawingml/2006/main">
               <a:ext uri="{FF2B5EF4-FFF2-40B4-BE49-F238E27FC236}">
-                <a16:creationId xmlns:a16="http://schemas.microsoft.com/office/drawing/2014/main" id="{3B1DD1C5-7E8E-492D-8AE3-6F7C821738A5}"/>
+                <a16:creationId xmlns:a16="http://schemas.microsoft.com/office/drawing/2014/main" id="{512F66B1-62F2-4C2F-8214-8687C8989219}"/>
               </a:ext>
             </a:extLst>
           </p:cNvPr>
@@ -18654,7 +18667,7 @@
           <p:cNvPr id="4" name="">
             <a:extLst xmlns:a="http://schemas.openxmlformats.org/drawingml/2006/main">
               <a:ext uri="{FF2B5EF4-FFF2-40B4-BE49-F238E27FC236}">
-                <a16:creationId xmlns:a16="http://schemas.microsoft.com/office/drawing/2014/main" id="{80859537-BB7A-4813-9A5F-0C2846AC0F48}"/>
+                <a16:creationId xmlns:a16="http://schemas.microsoft.com/office/drawing/2014/main" id="{53B143AD-1642-4ECF-BE05-422AA4277AD8}"/>
               </a:ext>
             </a:extLst>
           </p:cNvPr>
@@ -18742,7 +18755,7 @@
           <p:cNvPr id="5" name="">
             <a:extLst xmlns:a="http://schemas.openxmlformats.org/drawingml/2006/main">
               <a:ext uri="{FF2B5EF4-FFF2-40B4-BE49-F238E27FC236}">
-                <a16:creationId xmlns:a16="http://schemas.microsoft.com/office/drawing/2014/main" id="{254BE008-643D-4571-85B4-8431E0C81359}"/>
+                <a16:creationId xmlns:a16="http://schemas.microsoft.com/office/drawing/2014/main" id="{F590A919-B82E-4E39-B417-4CC35FE8493D}"/>
               </a:ext>
             </a:extLst>
           </p:cNvPr>
@@ -18826,7 +18839,7 @@
           <p:cNvPr id="6" name="">
             <a:extLst xmlns:a="http://schemas.openxmlformats.org/drawingml/2006/main">
               <a:ext uri="{FF2B5EF4-FFF2-40B4-BE49-F238E27FC236}">
-                <a16:creationId xmlns:a16="http://schemas.microsoft.com/office/drawing/2014/main" id="{C70E6C67-B448-4F6A-B7F3-0E872F918F70}"/>
+                <a16:creationId xmlns:a16="http://schemas.microsoft.com/office/drawing/2014/main" id="{0066D6D9-1315-4F93-9F88-ADA149EBA050}"/>
               </a:ext>
             </a:extLst>
           </p:cNvPr>
@@ -18910,7 +18923,7 @@
           <p:cNvPr id="7" name="">
             <a:extLst xmlns:a="http://schemas.openxmlformats.org/drawingml/2006/main">
               <a:ext uri="{FF2B5EF4-FFF2-40B4-BE49-F238E27FC236}">
-                <a16:creationId xmlns:a16="http://schemas.microsoft.com/office/drawing/2014/main" id="{3FBFDBE0-7ABB-4EFE-96F8-F6982A7C9292}"/>
+                <a16:creationId xmlns:a16="http://schemas.microsoft.com/office/drawing/2014/main" id="{19CA6D13-C9EE-425B-88E6-6D74673A23A2}"/>
               </a:ext>
             </a:extLst>
           </p:cNvPr>
@@ -19050,7 +19063,7 @@
           <p:cNvPr id="10" name="">
             <a:extLst xmlns:a="http://schemas.openxmlformats.org/drawingml/2006/main">
               <a:ext uri="{FF2B5EF4-FFF2-40B4-BE49-F238E27FC236}">
-                <a16:creationId xmlns:a16="http://schemas.microsoft.com/office/drawing/2014/main" id="{8CF1867D-68D4-4E9E-B71F-7D292EF90FA7}"/>
+                <a16:creationId xmlns:a16="http://schemas.microsoft.com/office/drawing/2014/main" id="{95731F0C-BFF1-4203-8771-33B8E31CB2DE}"/>
               </a:ext>
             </a:extLst>
           </p:cNvPr>
@@ -19183,7 +19196,7 @@
     </p:spTree>
     <p:extLst>
       <p:ext uri="{BB962C8B-B14F-4D97-AF65-F5344CB8AC3E}">
-        <p14:creationId xmlns:p14="http://schemas.microsoft.com/office/powerpoint/2010/main" val="1406353616"/>
+        <p14:creationId xmlns:p14="http://schemas.microsoft.com/office/powerpoint/2010/main" val="374104987"/>
       </p:ext>
     </p:extLst>
   </p:cSld>

</xml_diff>

<commit_message>
Refine presentation explanations and fix chart label overlap
</commit_message>
<xml_diff>
--- a/presentation/unos_kidney_biopsy.pptx
+++ b/presentation/unos_kidney_biopsy.pptx
@@ -2,28 +2,28 @@
 <file path=ppt/presentation.xml><?xml version="1.0" encoding="utf-8"?>
 <p:presentation xmlns:p="http://schemas.openxmlformats.org/presentationml/2006/main" xmlns:r="http://schemas.openxmlformats.org/officeDocument/2006/relationships">
   <p:sldMasterIdLst>
-    <p:sldMasterId id="2147483648" r:id="R5ac9bf43fd1741ad"/>
+    <p:sldMasterId id="2147483648" r:id="R2f5593aa621b4e14"/>
   </p:sldMasterIdLst>
   <p:sldIdLst>
-    <p:sldId id="256" r:id="Rb761648119a748d7"/>
-    <p:sldId id="257" r:id="R20316546560d4435"/>
-    <p:sldId id="258" r:id="R6b87b9dc2cf344f5"/>
-    <p:sldId id="259" r:id="R4c73422dd9cb4624"/>
-    <p:sldId id="260" r:id="Rceaa3b837aa14030"/>
-    <p:sldId id="261" r:id="R01ed0b07ff504dab"/>
-    <p:sldId id="262" r:id="R0448e53deb174397"/>
-    <p:sldId id="263" r:id="R727f32439f9449bd"/>
-    <p:sldId id="264" r:id="R8cdb559f21fb41e5"/>
-    <p:sldId id="265" r:id="R804967aea8024232"/>
-    <p:sldId id="266" r:id="R394c5884fbe544ea"/>
-    <p:sldId id="267" r:id="Reb18bd7aab514550"/>
-    <p:sldId id="268" r:id="R7f734f0506d14450"/>
-    <p:sldId id="269" r:id="R32607bcb26f14daf"/>
-    <p:sldId id="270" r:id="R63f50a9736224c60"/>
-    <p:sldId id="271" r:id="R97c7b9b5e40e41aa"/>
-    <p:sldId id="272" r:id="R74f913f8555a4261"/>
-    <p:sldId id="273" r:id="R157d6b87740f43ad"/>
-    <p:sldId id="274" r:id="R285fdeb55cba4a3f"/>
+    <p:sldId id="256" r:id="R6af083f13c514270"/>
+    <p:sldId id="257" r:id="Rd2005c56bab44848"/>
+    <p:sldId id="258" r:id="R575f649317514e6d"/>
+    <p:sldId id="259" r:id="R5c78b9f69e99416c"/>
+    <p:sldId id="260" r:id="R3396020e0e3b4607"/>
+    <p:sldId id="261" r:id="Rde80d4debbc44634"/>
+    <p:sldId id="262" r:id="R28bc347e9b5f45d1"/>
+    <p:sldId id="263" r:id="Raf5f8eb1951f48d4"/>
+    <p:sldId id="264" r:id="R559de7d27ecd4ee4"/>
+    <p:sldId id="265" r:id="R462996b1044b4b66"/>
+    <p:sldId id="266" r:id="R6d1caee9d2924780"/>
+    <p:sldId id="267" r:id="R333a4931b4c04fd4"/>
+    <p:sldId id="268" r:id="R1deb519cb37446a0"/>
+    <p:sldId id="269" r:id="R8982a2c4a3254457"/>
+    <p:sldId id="270" r:id="R9e1c7f4126a94010"/>
+    <p:sldId id="271" r:id="Rcb9a468b62614145"/>
+    <p:sldId id="272" r:id="Re28cc3ae880c4886"/>
+    <p:sldId id="273" r:id="Rd0ffb4a6e6384feb"/>
+    <p:sldId id="274" r:id="R27da1c5114c646c2"/>
   </p:sldIdLst>
   <p:sldSz cx="12192000" cy="6858000"/>
   <p:notesSz cx="6858000" cy="9144000"/>
@@ -68,7 +68,7 @@
   </p:cSld>
   <p:clrMap bg1="lt1" tx1="dk1" bg2="lt2" tx2="dk2" accent1="accent1" accent2="accent2" accent3="accent3" accent4="accent4" accent5="accent5" accent6="accent6" hlink="hlink" folHlink="folHlink"/>
   <p:sldLayoutIdLst>
-    <p:sldLayoutId xmlns:r="http://schemas.openxmlformats.org/officeDocument/2006/relationships" id="2147483649" r:id="Rd4ddbdfe1f9a4c18"/>
+    <p:sldLayoutId xmlns:r="http://schemas.openxmlformats.org/officeDocument/2006/relationships" id="2147483649" r:id="R810f935cb2bb4b05"/>
   </p:sldLayoutIdLst>
   <p:txStyles>
     <p:titleStyle>
@@ -621,12 +621,10 @@
               <c:strCache>
                 <c:ptCount val="3"/>
                 <c:pt idx="0">
-                  <c:v>IFNG only
-(Logistic regression)</c:v>
+                  <c:v>IFNG only (Logistic regression)</c:v>
                 </c:pt>
                 <c:pt idx="1">
-                  <c:v>All RNA
-(Logistic Regression)</c:v>
+                  <c:v>All RNA (Logistic Regression)</c:v>
                 </c:pt>
                 <c:pt idx="2">
                   <c:v>CatBoost</c:v>
@@ -670,12 +668,10 @@
               <c:strCache>
                 <c:ptCount val="3"/>
                 <c:pt idx="0">
-                  <c:v>IFNG only
-(Logistic regression)</c:v>
+                  <c:v>IFNG only (Logistic regression)</c:v>
                 </c:pt>
                 <c:pt idx="1">
-                  <c:v>All RNA
-(Logistic Regression)</c:v>
+                  <c:v>All RNA (Logistic Regression)</c:v>
                 </c:pt>
                 <c:pt idx="2">
                   <c:v>CatBoost</c:v>
@@ -880,7 +876,7 @@
           <p:cNvPr id="2" name="">
             <a:extLst xmlns:a="http://schemas.openxmlformats.org/drawingml/2006/main">
               <a:ext uri="{FF2B5EF4-FFF2-40B4-BE49-F238E27FC236}">
-                <a16:creationId xmlns:a16="http://schemas.microsoft.com/office/drawing/2014/main" id="{55BC9681-E49C-460C-AC02-57CCC38F5CA3}"/>
+                <a16:creationId xmlns:a16="http://schemas.microsoft.com/office/drawing/2014/main" id="{BDFC2154-D641-48E7-BA1B-E292A3CFF361}"/>
               </a:ext>
             </a:extLst>
           </p:cNvPr>
@@ -981,7 +977,7 @@
     </p:spTree>
     <p:extLst>
       <p:ext uri="{BB962C8B-B14F-4D97-AF65-F5344CB8AC3E}">
-        <p14:creationId xmlns:p14="http://schemas.microsoft.com/office/powerpoint/2010/main" val="1110922102"/>
+        <p14:creationId xmlns:p14="http://schemas.microsoft.com/office/powerpoint/2010/main" val="1031283710"/>
       </p:ext>
     </p:extLst>
   </p:cSld>
@@ -1012,7 +1008,7 @@
           <p:cNvPr id="6" name="">
             <a:extLst xmlns:a="http://schemas.openxmlformats.org/drawingml/2006/main">
               <a:ext uri="{FF2B5EF4-FFF2-40B4-BE49-F238E27FC236}">
-                <a16:creationId xmlns:a16="http://schemas.microsoft.com/office/drawing/2014/main" id="{CC411EA0-D2F9-412E-9833-E99D3391CC47}"/>
+                <a16:creationId xmlns:a16="http://schemas.microsoft.com/office/drawing/2014/main" id="{0685FF4D-AFA1-41AC-8672-6378914C5B6A}"/>
               </a:ext>
             </a:extLst>
           </p:cNvPr>
@@ -1069,7 +1065,7 @@
           <p:cNvPr id="2" name="">
             <a:extLst xmlns:a="http://schemas.openxmlformats.org/drawingml/2006/main">
               <a:ext uri="{FF2B5EF4-FFF2-40B4-BE49-F238E27FC236}">
-                <a16:creationId xmlns:a16="http://schemas.microsoft.com/office/drawing/2014/main" id="{F657D59F-4801-480E-A688-053C354DBD22}"/>
+                <a16:creationId xmlns:a16="http://schemas.microsoft.com/office/drawing/2014/main" id="{51BE201A-DE25-4482-8E99-A5EE8FF5B835}"/>
               </a:ext>
             </a:extLst>
           </p:cNvPr>
@@ -1116,7 +1112,7 @@
                 <a:ea typeface="Arial"/>
                 <a:cs typeface="Arial"/>
               </a:rPr>
-              <a:t>Sources: primary configuration and analysis, 15 Sep 2026; Zhang et al., Supplementary Table S2</a:t>
+              <a:t>Sources: primary configuration and analysis; Zhang et al., Table S2; CatBoost documentation</a:t>
             </a:r>
           </a:p>
         </p:txBody>
@@ -1126,7 +1122,7 @@
           <p:cNvPr id="3" name="">
             <a:extLst xmlns:a="http://schemas.openxmlformats.org/drawingml/2006/main">
               <a:ext uri="{FF2B5EF4-FFF2-40B4-BE49-F238E27FC236}">
-                <a16:creationId xmlns:a16="http://schemas.microsoft.com/office/drawing/2014/main" id="{B0DE3C64-7DF6-43AD-8BDB-874565D1F0B3}"/>
+                <a16:creationId xmlns:a16="http://schemas.microsoft.com/office/drawing/2014/main" id="{CDBCBFE4-EFF9-4C14-999F-39D0DD82A92F}"/>
               </a:ext>
             </a:extLst>
           </p:cNvPr>
@@ -1183,7 +1179,7 @@
           <p:cNvPr id="4" name="">
             <a:extLst xmlns:a="http://schemas.openxmlformats.org/drawingml/2006/main">
               <a:ext uri="{FF2B5EF4-FFF2-40B4-BE49-F238E27FC236}">
-                <a16:creationId xmlns:a16="http://schemas.microsoft.com/office/drawing/2014/main" id="{AE9DA401-62DC-48B2-AFF8-4DE1874E1AFA}"/>
+                <a16:creationId xmlns:a16="http://schemas.microsoft.com/office/drawing/2014/main" id="{81C3F490-88C3-4E43-BDC9-80FAF95AD15C}"/>
               </a:ext>
             </a:extLst>
           </p:cNvPr>
@@ -1242,8 +1238,8 @@
           <p:nvPr/>
         </p:nvGraphicFramePr>
         <p:xfrm>
-          <a:off xmlns:a="http://schemas.openxmlformats.org/drawingml/2006/main" x="609600" y="2419350"/>
-          <a:ext xmlns:a="http://schemas.openxmlformats.org/drawingml/2006/main" cx="10972800" cy="3543300"/>
+          <a:off xmlns:a="http://schemas.openxmlformats.org/drawingml/2006/main" x="609600" y="2381250"/>
+          <a:ext xmlns:a="http://schemas.openxmlformats.org/drawingml/2006/main" cx="10972800" cy="3695700"/>
         </p:xfrm>
         <a:graphic xmlns:a="http://schemas.openxmlformats.org/drawingml/2006/main">
           <a:graphicData uri="http://schemas.openxmlformats.org/drawingml/2006/table">
@@ -1253,7 +1249,7 @@
                 <a:gridCol w="3371850"/>
                 <a:gridCol w="7600950"/>
               </a:tblGrid>
-              <a:tr h="504825">
+              <a:tr h="476250">
                 <a:tc>
                   <a:txBody>
                     <a:bodyPr>
@@ -1296,7 +1292,7 @@
                           <a:ea typeface="Arial"/>
                           <a:cs typeface="Arial"/>
                         </a:rPr>
-                        <a:t>What it learns</a:t>
+                        <a:t>Approach and rationale</a:t>
                       </a:r>
                     </a:p>
                   </a:txBody>
@@ -1307,7 +1303,7 @@
                   </a:tcPr>
                 </a:tc>
               </a:tr>
-              <a:tr h="581025">
+              <a:tr h="571500">
                 <a:tc>
                   <a:txBody>
                     <a:bodyPr>
@@ -1361,7 +1357,7 @@
                   </a:tcPr>
                 </a:tc>
               </a:tr>
-              <a:tr h="742950">
+              <a:tr h="819150">
                 <a:tc>
                   <a:txBody>
                     <a:bodyPr>
@@ -1441,7 +1437,7 @@
                   </a:tcPr>
                 </a:tc>
               </a:tr>
-              <a:tr h="1047750">
+              <a:tr h="914400">
                 <a:tc>
                   <a:txBody>
                     <a:bodyPr>
@@ -1521,7 +1517,7 @@
                   </a:tcPr>
                 </a:tc>
               </a:tr>
-              <a:tr h="666750">
+              <a:tr h="914400">
                 <a:tc>
                   <a:txBody>
                     <a:bodyPr>
@@ -1564,7 +1560,20 @@
                           <a:ea typeface="Arial"/>
                           <a:cs typeface="Arial"/>
                         </a:rPr>
-                        <a:t>A combination of decision trees</a:t>
+                        <a:t>Can capture nonlinear RNA patterns and interactions.</a:t>
+                      </a:r>
+                    </a:p>
+                    <a:p>
+                      <a:r>
+                        <a:rPr sz="2175" b="0">
+                          <a:solidFill>
+                            <a:srgbClr val="16343E"/>
+                          </a:solidFill>
+                          <a:latin typeface="Arial"/>
+                          <a:ea typeface="Arial"/>
+                          <a:cs typeface="Arial"/>
+                        </a:rPr>
+                        <a:t>Shallow trees help limit overfitting.</a:t>
                       </a:r>
                     </a:p>
                   </a:txBody>
@@ -1582,7 +1591,7 @@
     </p:spTree>
     <p:extLst>
       <p:ext uri="{BB962C8B-B14F-4D97-AF65-F5344CB8AC3E}">
-        <p14:creationId xmlns:p14="http://schemas.microsoft.com/office/powerpoint/2010/main" val="1352433315"/>
+        <p14:creationId xmlns:p14="http://schemas.microsoft.com/office/powerpoint/2010/main" val="182769313"/>
       </p:ext>
     </p:extLst>
   </p:cSld>
@@ -1610,10 +1619,10 @@
       </p:grpSpPr>
       <p:sp>
         <p:nvSpPr>
-          <p:cNvPr id="17" name="">
-            <a:extLst xmlns:a="http://schemas.openxmlformats.org/drawingml/2006/main">
-              <a:ext uri="{FF2B5EF4-FFF2-40B4-BE49-F238E27FC236}">
-                <a16:creationId xmlns:a16="http://schemas.microsoft.com/office/drawing/2014/main" id="{B5498CF6-9274-4372-AE63-643A82C9ED83}"/>
+          <p:cNvPr id="16" name="">
+            <a:extLst xmlns:a="http://schemas.openxmlformats.org/drawingml/2006/main">
+              <a:ext uri="{FF2B5EF4-FFF2-40B4-BE49-F238E27FC236}">
+                <a16:creationId xmlns:a16="http://schemas.microsoft.com/office/drawing/2014/main" id="{8FF86D79-7813-4009-BDA3-25DB380A239A}"/>
               </a:ext>
             </a:extLst>
           </p:cNvPr>
@@ -1670,7 +1679,7 @@
           <p:cNvPr id="2" name="">
             <a:extLst xmlns:a="http://schemas.openxmlformats.org/drawingml/2006/main">
               <a:ext uri="{FF2B5EF4-FFF2-40B4-BE49-F238E27FC236}">
-                <a16:creationId xmlns:a16="http://schemas.microsoft.com/office/drawing/2014/main" id="{8D636659-2E75-49D9-911E-068D2D2496B9}"/>
+                <a16:creationId xmlns:a16="http://schemas.microsoft.com/office/drawing/2014/main" id="{B55F21AB-DD30-4803-9712-EE0EE8404CAE}"/>
               </a:ext>
             </a:extLst>
           </p:cNvPr>
@@ -1717,7 +1726,7 @@
                 <a:ea typeface="Arial"/>
                 <a:cs typeface="Arial"/>
               </a:rPr>
-              <a:t>Source: discovery screening rule and selected model metadata</a:t>
+              <a:t>Reference: recorded biopsy diagnoses. Source: discovery screening rule and model metadata</a:t>
             </a:r>
           </a:p>
         </p:txBody>
@@ -1727,7 +1736,7 @@
           <p:cNvPr id="3" name="">
             <a:extLst xmlns:a="http://schemas.openxmlformats.org/drawingml/2006/main">
               <a:ext uri="{FF2B5EF4-FFF2-40B4-BE49-F238E27FC236}">
-                <a16:creationId xmlns:a16="http://schemas.microsoft.com/office/drawing/2014/main" id="{82B49FF9-FB97-416B-847D-F3DD8F2AE2AC}"/>
+                <a16:creationId xmlns:a16="http://schemas.microsoft.com/office/drawing/2014/main" id="{68D801E5-241B-4470-889C-7874FD170DBE}"/>
               </a:ext>
             </a:extLst>
           </p:cNvPr>
@@ -1784,7 +1793,7 @@
           <p:cNvPr id="4" name="">
             <a:extLst xmlns:a="http://schemas.openxmlformats.org/drawingml/2006/main">
               <a:ext uri="{FF2B5EF4-FFF2-40B4-BE49-F238E27FC236}">
-                <a16:creationId xmlns:a16="http://schemas.microsoft.com/office/drawing/2014/main" id="{9222552C-5868-49B4-B32A-BA1F70A6E490}"/>
+                <a16:creationId xmlns:a16="http://schemas.microsoft.com/office/drawing/2014/main" id="{832DD8D2-FF57-44AE-884E-85C2C88102CB}"/>
               </a:ext>
             </a:extLst>
           </p:cNvPr>
@@ -1841,7 +1850,7 @@
           <p:cNvPr id="5" name="">
             <a:extLst xmlns:a="http://schemas.openxmlformats.org/drawingml/2006/main">
               <a:ext uri="{FF2B5EF4-FFF2-40B4-BE49-F238E27FC236}">
-                <a16:creationId xmlns:a16="http://schemas.microsoft.com/office/drawing/2014/main" id="{7AA8B872-A5CE-430F-A094-062BF79D95E6}"/>
+                <a16:creationId xmlns:a16="http://schemas.microsoft.com/office/drawing/2014/main" id="{4F9D5E13-637C-48B6-85BD-A0EEB57955F7}"/>
               </a:ext>
             </a:extLst>
           </p:cNvPr>
@@ -1888,7 +1897,7 @@
                 <a:ea typeface="Arial"/>
                 <a:cs typeface="Arial"/>
               </a:rPr>
-              <a:t>Recorded rejection cases detected</a:t>
+              <a:t>Correctly flagged rejection cases</a:t>
             </a:r>
           </a:p>
         </p:txBody>
@@ -1898,7 +1907,7 @@
           <p:cNvPr id="6" name="">
             <a:extLst xmlns:a="http://schemas.openxmlformats.org/drawingml/2006/main">
               <a:ext uri="{FF2B5EF4-FFF2-40B4-BE49-F238E27FC236}">
-                <a16:creationId xmlns:a16="http://schemas.microsoft.com/office/drawing/2014/main" id="{A2067A76-5124-4307-9A23-48AF42B59DDE}"/>
+                <a16:creationId xmlns:a16="http://schemas.microsoft.com/office/drawing/2014/main" id="{82D4EE50-7DFA-4261-A6DA-B261A8A9F136}"/>
               </a:ext>
             </a:extLst>
           </p:cNvPr>
@@ -1927,7 +1936,7 @@
           <p:cNvPr id="7" name="">
             <a:extLst xmlns:a="http://schemas.openxmlformats.org/drawingml/2006/main">
               <a:ext uri="{FF2B5EF4-FFF2-40B4-BE49-F238E27FC236}">
-                <a16:creationId xmlns:a16="http://schemas.microsoft.com/office/drawing/2014/main" id="{E989BAFB-12BF-4CB7-8B82-B31C5BBE7C2B}"/>
+                <a16:creationId xmlns:a16="http://schemas.microsoft.com/office/drawing/2014/main" id="{DE0FFA52-364F-4537-A107-951CE7D2BDE3}"/>
               </a:ext>
             </a:extLst>
           </p:cNvPr>
@@ -1974,7 +1983,7 @@
                 <a:ea typeface="Arial"/>
                 <a:cs typeface="Arial"/>
               </a:rPr>
-              <a:t>All recorded rejection cases</a:t>
+              <a:t>All cases diagnosed as rejection</a:t>
             </a:r>
           </a:p>
         </p:txBody>
@@ -1984,7 +1993,7 @@
           <p:cNvPr id="8" name="">
             <a:extLst xmlns:a="http://schemas.openxmlformats.org/drawingml/2006/main">
               <a:ext uri="{FF2B5EF4-FFF2-40B4-BE49-F238E27FC236}">
-                <a16:creationId xmlns:a16="http://schemas.microsoft.com/office/drawing/2014/main" id="{763C7CD0-66F8-4DD5-A8D8-5051CB430E23}"/>
+                <a16:creationId xmlns:a16="http://schemas.microsoft.com/office/drawing/2014/main" id="{23161C76-98E1-4335-BF82-CF35C9E35B15}"/>
               </a:ext>
             </a:extLst>
           </p:cNvPr>
@@ -2041,7 +2050,7 @@
           <p:cNvPr id="9" name="">
             <a:extLst xmlns:a="http://schemas.openxmlformats.org/drawingml/2006/main">
               <a:ext uri="{FF2B5EF4-FFF2-40B4-BE49-F238E27FC236}">
-                <a16:creationId xmlns:a16="http://schemas.microsoft.com/office/drawing/2014/main" id="{62D31ADB-175D-4776-B85C-B8A7DEF340D6}"/>
+                <a16:creationId xmlns:a16="http://schemas.microsoft.com/office/drawing/2014/main" id="{5560FA24-84CD-4B0E-A326-A837FFB6E01E}"/>
               </a:ext>
             </a:extLst>
           </p:cNvPr>
@@ -2098,7 +2107,7 @@
           <p:cNvPr id="10" name="">
             <a:extLst xmlns:a="http://schemas.openxmlformats.org/drawingml/2006/main">
               <a:ext uri="{FF2B5EF4-FFF2-40B4-BE49-F238E27FC236}">
-                <a16:creationId xmlns:a16="http://schemas.microsoft.com/office/drawing/2014/main" id="{4BF0C857-B113-40EE-995A-C59457CFE7DD}"/>
+                <a16:creationId xmlns:a16="http://schemas.microsoft.com/office/drawing/2014/main" id="{B5FCE23D-6425-45BB-999F-4B8D1FD698B6}"/>
               </a:ext>
             </a:extLst>
           </p:cNvPr>
@@ -2145,7 +2154,7 @@
                 <a:ea typeface="Arial"/>
                 <a:cs typeface="Arial"/>
               </a:rPr>
-              <a:t>Flags with recorded rejection</a:t>
+              <a:t>Correctly flagged rejection cases</a:t>
             </a:r>
           </a:p>
         </p:txBody>
@@ -2155,7 +2164,7 @@
           <p:cNvPr id="11" name="">
             <a:extLst xmlns:a="http://schemas.openxmlformats.org/drawingml/2006/main">
               <a:ext uri="{FF2B5EF4-FFF2-40B4-BE49-F238E27FC236}">
-                <a16:creationId xmlns:a16="http://schemas.microsoft.com/office/drawing/2014/main" id="{4565C612-6B34-4BAE-A4AE-1C14A831C7B2}"/>
+                <a16:creationId xmlns:a16="http://schemas.microsoft.com/office/drawing/2014/main" id="{AAA5B813-FB01-4742-85BC-A7BAFED9D194}"/>
               </a:ext>
             </a:extLst>
           </p:cNvPr>
@@ -2184,7 +2193,7 @@
           <p:cNvPr id="12" name="">
             <a:extLst xmlns:a="http://schemas.openxmlformats.org/drawingml/2006/main">
               <a:ext uri="{FF2B5EF4-FFF2-40B4-BE49-F238E27FC236}">
-                <a16:creationId xmlns:a16="http://schemas.microsoft.com/office/drawing/2014/main" id="{39FFB15B-7FC6-4D76-9869-D8E71F4D09C1}"/>
+                <a16:creationId xmlns:a16="http://schemas.microsoft.com/office/drawing/2014/main" id="{12B68387-D58F-45F8-A27A-4E205405FF6B}"/>
               </a:ext>
             </a:extLst>
           </p:cNvPr>
@@ -2231,7 +2240,7 @@
                 <a:ea typeface="Arial"/>
                 <a:cs typeface="Arial"/>
               </a:rPr>
-              <a:t>All positive flags</a:t>
+              <a:t>All rejection flags</a:t>
             </a:r>
           </a:p>
         </p:txBody>
@@ -2241,7 +2250,7 @@
           <p:cNvPr id="13" name="">
             <a:extLst xmlns:a="http://schemas.openxmlformats.org/drawingml/2006/main">
               <a:ext uri="{FF2B5EF4-FFF2-40B4-BE49-F238E27FC236}">
-                <a16:creationId xmlns:a16="http://schemas.microsoft.com/office/drawing/2014/main" id="{CC60CD79-564F-4CD3-965D-9C60E9A78EED}"/>
+                <a16:creationId xmlns:a16="http://schemas.microsoft.com/office/drawing/2014/main" id="{8A4FC4EC-3D67-4901-84AC-FDCA80B99A7E}"/>
               </a:ext>
             </a:extLst>
           </p:cNvPr>
@@ -2298,7 +2307,7 @@
           <p:cNvPr id="14" name="">
             <a:extLst xmlns:a="http://schemas.openxmlformats.org/drawingml/2006/main">
               <a:ext uri="{FF2B5EF4-FFF2-40B4-BE49-F238E27FC236}">
-                <a16:creationId xmlns:a16="http://schemas.microsoft.com/office/drawing/2014/main" id="{F945782E-2D5F-47BD-93E6-82F8FE83487A}"/>
+                <a16:creationId xmlns:a16="http://schemas.microsoft.com/office/drawing/2014/main" id="{444E11BE-55FB-4615-BADB-618CE9E22FE0}"/>
               </a:ext>
             </a:extLst>
           </p:cNvPr>
@@ -2345,14 +2354,14 @@
                 <a:ea typeface="Arial"/>
                 <a:cs typeface="Arial"/>
               </a:rPr>
-              <a:t>Selection using screening specimens</a:t>
+              <a:t>My selection rule for screening specimens</a:t>
             </a:r>
           </a:p>
         </p:txBody>
       </p:sp>
       <p:graphicFrame>
         <p:nvGraphicFramePr>
-          <p:cNvPr id="31" name=""/>
+          <p:cNvPr id="30" name=""/>
           <p:cNvGraphicFramePr/>
           <p:nvPr/>
         </p:nvGraphicFramePr>
@@ -2465,7 +2474,7 @@
                           <a:ea typeface="Arial"/>
                           <a:cs typeface="Arial"/>
                         </a:rPr>
-                        <a:t>Detect at least 90% of recorded rejection cases.*</a:t>
+                        <a:t>Detect at least 90% of cases diagnosed as rejection.</a:t>
                       </a:r>
                     </a:p>
                   </a:txBody>
@@ -2588,67 +2597,10 @@
           </a:graphicData>
         </a:graphic>
       </p:graphicFrame>
-      <p:sp>
-        <p:nvSpPr>
-          <p:cNvPr id="16" name="">
-            <a:extLst xmlns:a="http://schemas.openxmlformats.org/drawingml/2006/main">
-              <a:ext uri="{FF2B5EF4-FFF2-40B4-BE49-F238E27FC236}">
-                <a16:creationId xmlns:a16="http://schemas.microsoft.com/office/drawing/2014/main" id="{2A7839D4-3B0F-4774-B32E-A582792A0A57}"/>
-              </a:ext>
-            </a:extLst>
-          </p:cNvPr>
-          <p:cNvSpPr>
-            <a:spLocks xmlns:a="http://schemas.openxmlformats.org/drawingml/2006/main" noGrp="1"/>
-          </p:cNvSpPr>
-          <p:nvPr/>
-        </p:nvSpPr>
-        <p:spPr>
-          <a:xfrm xmlns:a="http://schemas.openxmlformats.org/drawingml/2006/main">
-            <a:off x="609600" y="6019800"/>
-            <a:ext cx="10972800" cy="257175"/>
-          </a:xfrm>
-          <a:prstGeom xmlns:a="http://schemas.openxmlformats.org/drawingml/2006/main" prst="rect">
-            <a:avLst/>
-          </a:prstGeom>
-          <a:noFill xmlns:a="http://schemas.openxmlformats.org/drawingml/2006/main"/>
-          <a:ln xmlns:a="http://schemas.openxmlformats.org/drawingml/2006/main" w="0">
-            <a:noFill/>
-          </a:ln>
-        </p:spPr>
-        <p:txBody>
-          <a:bodyPr xmlns:a="http://schemas.openxmlformats.org/drawingml/2006/main" anchor="ctr">
-            <a:noAutofit/>
-          </a:bodyPr>
-          <a:lstStyle xmlns:a="http://schemas.openxmlformats.org/drawingml/2006/main"/>
-          <a:p xmlns:a="http://schemas.openxmlformats.org/drawingml/2006/main">
-            <a:pPr algn="l">
-              <a:defRPr sz="1725" b="0">
-                <a:solidFill>
-                  <a:srgbClr val="52656B"/>
-                </a:solidFill>
-                <a:latin typeface="Arial"/>
-                <a:ea typeface="Arial"/>
-                <a:cs typeface="Arial"/>
-              </a:defRPr>
-            </a:pPr>
-            <a:r>
-              <a:rPr sz="1725" b="0">
-                <a:solidFill>
-                  <a:srgbClr val="52656B"/>
-                </a:solidFill>
-                <a:latin typeface="Arial"/>
-                <a:ea typeface="Arial"/>
-                <a:cs typeface="Arial"/>
-              </a:rPr>
-              <a:t>*90% is an experimental target.</a:t>
-            </a:r>
-          </a:p>
-        </p:txBody>
-      </p:sp>
     </p:spTree>
     <p:extLst>
       <p:ext uri="{BB962C8B-B14F-4D97-AF65-F5344CB8AC3E}">
-        <p14:creationId xmlns:p14="http://schemas.microsoft.com/office/powerpoint/2010/main" val="950571463"/>
+        <p14:creationId xmlns:p14="http://schemas.microsoft.com/office/powerpoint/2010/main" val="1888654372"/>
       </p:ext>
     </p:extLst>
   </p:cSld>
@@ -2679,7 +2631,7 @@
           <p:cNvPr id="7" name="">
             <a:extLst xmlns:a="http://schemas.openxmlformats.org/drawingml/2006/main">
               <a:ext uri="{FF2B5EF4-FFF2-40B4-BE49-F238E27FC236}">
-                <a16:creationId xmlns:a16="http://schemas.microsoft.com/office/drawing/2014/main" id="{257C2020-65C3-404A-B319-98CC7E4254A4}"/>
+                <a16:creationId xmlns:a16="http://schemas.microsoft.com/office/drawing/2014/main" id="{978462B6-458A-4D0C-B5DA-72C8F146CA9C}"/>
               </a:ext>
             </a:extLst>
           </p:cNvPr>
@@ -2736,7 +2688,7 @@
           <p:cNvPr id="2" name="">
             <a:extLst xmlns:a="http://schemas.openxmlformats.org/drawingml/2006/main">
               <a:ext uri="{FF2B5EF4-FFF2-40B4-BE49-F238E27FC236}">
-                <a16:creationId xmlns:a16="http://schemas.microsoft.com/office/drawing/2014/main" id="{3EE09F3A-C2AC-4947-8AA1-75A5DD7A71D7}"/>
+                <a16:creationId xmlns:a16="http://schemas.microsoft.com/office/drawing/2014/main" id="{7C51F71F-2BDA-45BA-9BB4-DEE2ED37B815}"/>
               </a:ext>
             </a:extLst>
           </p:cNvPr>
@@ -2793,7 +2745,7 @@
           <p:cNvPr id="3" name="">
             <a:extLst xmlns:a="http://schemas.openxmlformats.org/drawingml/2006/main">
               <a:ext uri="{FF2B5EF4-FFF2-40B4-BE49-F238E27FC236}">
-                <a16:creationId xmlns:a16="http://schemas.microsoft.com/office/drawing/2014/main" id="{3567FABD-94A5-420E-B0D5-A41B333B268D}"/>
+                <a16:creationId xmlns:a16="http://schemas.microsoft.com/office/drawing/2014/main" id="{D3968B99-8C9A-443D-BE88-8B83AC469729}"/>
               </a:ext>
             </a:extLst>
           </p:cNvPr>
@@ -2850,7 +2802,7 @@
           <p:cNvPr id="4" name="">
             <a:extLst xmlns:a="http://schemas.openxmlformats.org/drawingml/2006/main">
               <a:ext uri="{FF2B5EF4-FFF2-40B4-BE49-F238E27FC236}">
-                <a16:creationId xmlns:a16="http://schemas.microsoft.com/office/drawing/2014/main" id="{E1324EF9-4754-4993-87F2-515997408F03}"/>
+                <a16:creationId xmlns:a16="http://schemas.microsoft.com/office/drawing/2014/main" id="{6C642893-29E5-4A62-A6B9-C450C10DAF31}"/>
               </a:ext>
             </a:extLst>
           </p:cNvPr>
@@ -2914,7 +2866,7 @@
         </p:xfrm>
         <a:graphic xmlns:a="http://schemas.openxmlformats.org/drawingml/2006/main">
           <a:graphicData uri="http://schemas.openxmlformats.org/drawingml/2006/chart">
-            <c:chart xmlns:r="http://schemas.openxmlformats.org/officeDocument/2006/relationships" xmlns:c="http://schemas.openxmlformats.org/drawingml/2006/chart" r:id="R678de3e59e194f4e"/>
+            <c:chart xmlns:r="http://schemas.openxmlformats.org/officeDocument/2006/relationships" xmlns:c="http://schemas.openxmlformats.org/drawingml/2006/chart" r:id="Rbc11e9ec15ec4666"/>
           </a:graphicData>
         </a:graphic>
       </p:graphicFrame>
@@ -2923,7 +2875,7 @@
           <p:cNvPr id="6" name="">
             <a:extLst xmlns:a="http://schemas.openxmlformats.org/drawingml/2006/main">
               <a:ext uri="{FF2B5EF4-FFF2-40B4-BE49-F238E27FC236}">
-                <a16:creationId xmlns:a16="http://schemas.microsoft.com/office/drawing/2014/main" id="{5893D65C-6FF0-4069-B2B3-B096C4EF40FD}"/>
+                <a16:creationId xmlns:a16="http://schemas.microsoft.com/office/drawing/2014/main" id="{E04CF800-19FE-4252-9FBE-658FE8A0943F}"/>
               </a:ext>
             </a:extLst>
           </p:cNvPr>
@@ -2935,7 +2887,7 @@
         <p:spPr>
           <a:xfrm xmlns:a="http://schemas.openxmlformats.org/drawingml/2006/main">
             <a:off x="609600" y="5200650"/>
-            <a:ext cx="10972800" cy="981075"/>
+            <a:ext cx="10972800" cy="571500"/>
           </a:xfrm>
           <a:prstGeom xmlns:a="http://schemas.openxmlformats.org/drawingml/2006/main" prst="rect">
             <a:avLst/>
@@ -2977,39 +2929,12 @@
               <a:t>Constant baseline: 0 false negatives, 176 false positives. It flags everyone.</a:t>
             </a:r>
           </a:p>
-          <a:p xmlns:a="http://schemas.openxmlformats.org/drawingml/2006/main">
-            <a:pPr marL="279400" indent="-152400" algn="l">
-              <a:spcAft>
-                <a:spcPts val="1100"/>
-              </a:spcAft>
-              <a:buChar char="•"/>
-              <a:defRPr sz="2175" b="0">
-                <a:solidFill>
-                  <a:srgbClr val="16343E"/>
-                </a:solidFill>
-                <a:latin typeface="Arial"/>
-                <a:ea typeface="Arial"/>
-                <a:cs typeface="Arial"/>
-              </a:defRPr>
-            </a:pPr>
-            <a:r>
-              <a:rPr sz="2175" b="0">
-                <a:solidFill>
-                  <a:srgbClr val="16343E"/>
-                </a:solidFill>
-                <a:latin typeface="Arial"/>
-                <a:ea typeface="Arial"/>
-                <a:cs typeface="Arial"/>
-              </a:rPr>
-              <a:t>CatBoost versus IFNG: 67 fewer false positives, 11 more false negatives.</a:t>
-            </a:r>
-          </a:p>
         </p:txBody>
       </p:sp>
     </p:spTree>
     <p:extLst>
       <p:ext uri="{BB962C8B-B14F-4D97-AF65-F5344CB8AC3E}">
-        <p14:creationId xmlns:p14="http://schemas.microsoft.com/office/powerpoint/2010/main" val="379318269"/>
+        <p14:creationId xmlns:p14="http://schemas.microsoft.com/office/powerpoint/2010/main" val="2067514369"/>
       </p:ext>
     </p:extLst>
   </p:cSld>
@@ -3040,7 +2965,7 @@
           <p:cNvPr id="7" name="">
             <a:extLst xmlns:a="http://schemas.openxmlformats.org/drawingml/2006/main">
               <a:ext uri="{FF2B5EF4-FFF2-40B4-BE49-F238E27FC236}">
-                <a16:creationId xmlns:a16="http://schemas.microsoft.com/office/drawing/2014/main" id="{3ABD9815-A2BD-4F2D-85A6-113175215A83}"/>
+                <a16:creationId xmlns:a16="http://schemas.microsoft.com/office/drawing/2014/main" id="{DD460867-16E5-480B-972B-36886CCC50A8}"/>
               </a:ext>
             </a:extLst>
           </p:cNvPr>
@@ -3097,7 +3022,7 @@
           <p:cNvPr id="2" name="">
             <a:extLst xmlns:a="http://schemas.openxmlformats.org/drawingml/2006/main">
               <a:ext uri="{FF2B5EF4-FFF2-40B4-BE49-F238E27FC236}">
-                <a16:creationId xmlns:a16="http://schemas.microsoft.com/office/drawing/2014/main" id="{108B9450-C5BD-4001-8267-C15CBFD1E8AB}"/>
+                <a16:creationId xmlns:a16="http://schemas.microsoft.com/office/drawing/2014/main" id="{C6C0C062-5B8C-416D-9600-33C511359AC9}"/>
               </a:ext>
             </a:extLst>
           </p:cNvPr>
@@ -3154,7 +3079,7 @@
           <p:cNvPr id="3" name="">
             <a:extLst xmlns:a="http://schemas.openxmlformats.org/drawingml/2006/main">
               <a:ext uri="{FF2B5EF4-FFF2-40B4-BE49-F238E27FC236}">
-                <a16:creationId xmlns:a16="http://schemas.microsoft.com/office/drawing/2014/main" id="{1D63CF49-F7CB-479A-AC11-1719E84D7542}"/>
+                <a16:creationId xmlns:a16="http://schemas.microsoft.com/office/drawing/2014/main" id="{A6E57419-E14E-4D26-9BF9-0CD871680E72}"/>
               </a:ext>
             </a:extLst>
           </p:cNvPr>
@@ -3211,7 +3136,7 @@
           <p:cNvPr id="4" name="">
             <a:extLst xmlns:a="http://schemas.openxmlformats.org/drawingml/2006/main">
               <a:ext uri="{FF2B5EF4-FFF2-40B4-BE49-F238E27FC236}">
-                <a16:creationId xmlns:a16="http://schemas.microsoft.com/office/drawing/2014/main" id="{525ABB64-82CF-44C1-BA44-0CDCCA9E9B53}"/>
+                <a16:creationId xmlns:a16="http://schemas.microsoft.com/office/drawing/2014/main" id="{2F5083F0-A870-4400-9A2B-ACE944747610}"/>
               </a:ext>
             </a:extLst>
           </p:cNvPr>
@@ -3268,7 +3193,7 @@
           <p:cNvPr id="5" name="">
             <a:extLst xmlns:a="http://schemas.openxmlformats.org/drawingml/2006/main">
               <a:ext uri="{FF2B5EF4-FFF2-40B4-BE49-F238E27FC236}">
-                <a16:creationId xmlns:a16="http://schemas.microsoft.com/office/drawing/2014/main" id="{C76FB4DB-A381-4FEE-9103-9405734993F0}"/>
+                <a16:creationId xmlns:a16="http://schemas.microsoft.com/office/drawing/2014/main" id="{B912FA76-504C-4592-9056-DB06B0048BC9}"/>
               </a:ext>
             </a:extLst>
           </p:cNvPr>
@@ -3383,7 +3308,7 @@
           <p:cNvPr id="6" name="">
             <a:extLst xmlns:a="http://schemas.openxmlformats.org/drawingml/2006/main">
               <a:ext uri="{FF2B5EF4-FFF2-40B4-BE49-F238E27FC236}">
-                <a16:creationId xmlns:a16="http://schemas.microsoft.com/office/drawing/2014/main" id="{3BA4E4AF-298F-4588-896B-9AC8563B1A7C}"/>
+                <a16:creationId xmlns:a16="http://schemas.microsoft.com/office/drawing/2014/main" id="{AD31ABC1-FE3F-41BA-B69B-1948FF867D79}"/>
               </a:ext>
             </a:extLst>
           </p:cNvPr>
@@ -3438,7 +3363,7 @@
     </p:spTree>
     <p:extLst>
       <p:ext uri="{BB962C8B-B14F-4D97-AF65-F5344CB8AC3E}">
-        <p14:creationId xmlns:p14="http://schemas.microsoft.com/office/powerpoint/2010/main" val="1434899958"/>
+        <p14:creationId xmlns:p14="http://schemas.microsoft.com/office/powerpoint/2010/main" val="1914430962"/>
       </p:ext>
     </p:extLst>
   </p:cSld>
@@ -3469,7 +3394,7 @@
           <p:cNvPr id="9" name="">
             <a:extLst xmlns:a="http://schemas.openxmlformats.org/drawingml/2006/main">
               <a:ext uri="{FF2B5EF4-FFF2-40B4-BE49-F238E27FC236}">
-                <a16:creationId xmlns:a16="http://schemas.microsoft.com/office/drawing/2014/main" id="{F37F33DC-BCC4-4358-A7EF-19B55CC97C1D}"/>
+                <a16:creationId xmlns:a16="http://schemas.microsoft.com/office/drawing/2014/main" id="{A2B4AE4A-EE10-4992-8728-DD2B651A5692}"/>
               </a:ext>
             </a:extLst>
           </p:cNvPr>
@@ -3526,7 +3451,7 @@
           <p:cNvPr id="2" name="">
             <a:extLst xmlns:a="http://schemas.openxmlformats.org/drawingml/2006/main">
               <a:ext uri="{FF2B5EF4-FFF2-40B4-BE49-F238E27FC236}">
-                <a16:creationId xmlns:a16="http://schemas.microsoft.com/office/drawing/2014/main" id="{FE163C54-13E3-4DC6-BCAC-4E0239671321}"/>
+                <a16:creationId xmlns:a16="http://schemas.microsoft.com/office/drawing/2014/main" id="{74BF6D9F-2F19-44E5-A5CA-FA38396AAD16}"/>
               </a:ext>
             </a:extLst>
           </p:cNvPr>
@@ -3583,7 +3508,7 @@
           <p:cNvPr id="3" name="">
             <a:extLst xmlns:a="http://schemas.openxmlformats.org/drawingml/2006/main">
               <a:ext uri="{FF2B5EF4-FFF2-40B4-BE49-F238E27FC236}">
-                <a16:creationId xmlns:a16="http://schemas.microsoft.com/office/drawing/2014/main" id="{166633F6-E0F7-4D9B-B326-08B75E181B65}"/>
+                <a16:creationId xmlns:a16="http://schemas.microsoft.com/office/drawing/2014/main" id="{4F5CD016-1329-4634-B6A3-9A0F8FEA3EB7}"/>
               </a:ext>
             </a:extLst>
           </p:cNvPr>
@@ -3640,7 +3565,7 @@
           <p:cNvPr id="4" name="">
             <a:extLst xmlns:a="http://schemas.openxmlformats.org/drawingml/2006/main">
               <a:ext uri="{FF2B5EF4-FFF2-40B4-BE49-F238E27FC236}">
-                <a16:creationId xmlns:a16="http://schemas.microsoft.com/office/drawing/2014/main" id="{73D82E7F-2E31-4A38-98DA-E7C4FE84E685}"/>
+                <a16:creationId xmlns:a16="http://schemas.microsoft.com/office/drawing/2014/main" id="{B4D36C0A-1095-444B-9010-F2FE53569A22}"/>
               </a:ext>
             </a:extLst>
           </p:cNvPr>
@@ -3884,7 +3809,7 @@
           <p:cNvPr id="6" name="">
             <a:extLst xmlns:a="http://schemas.openxmlformats.org/drawingml/2006/main">
               <a:ext uri="{FF2B5EF4-FFF2-40B4-BE49-F238E27FC236}">
-                <a16:creationId xmlns:a16="http://schemas.microsoft.com/office/drawing/2014/main" id="{54A06AE4-4C41-4242-A77F-6B0078713AAA}"/>
+                <a16:creationId xmlns:a16="http://schemas.microsoft.com/office/drawing/2014/main" id="{8FCA0C52-1056-44CB-B073-3BF9256E76F1}"/>
               </a:ext>
             </a:extLst>
           </p:cNvPr>
@@ -3941,7 +3866,7 @@
           <p:cNvPr id="7" name="">
             <a:extLst xmlns:a="http://schemas.openxmlformats.org/drawingml/2006/main">
               <a:ext uri="{FF2B5EF4-FFF2-40B4-BE49-F238E27FC236}">
-                <a16:creationId xmlns:a16="http://schemas.microsoft.com/office/drawing/2014/main" id="{4686B201-7C41-4C55-B0A2-67C4B8180493}"/>
+                <a16:creationId xmlns:a16="http://schemas.microsoft.com/office/drawing/2014/main" id="{4ACADE64-A7AF-408D-A893-692A7837628A}"/>
               </a:ext>
             </a:extLst>
           </p:cNvPr>
@@ -4029,7 +3954,7 @@
           <p:cNvPr id="8" name="">
             <a:extLst xmlns:a="http://schemas.openxmlformats.org/drawingml/2006/main">
               <a:ext uri="{FF2B5EF4-FFF2-40B4-BE49-F238E27FC236}">
-                <a16:creationId xmlns:a16="http://schemas.microsoft.com/office/drawing/2014/main" id="{36FA4853-1F73-438E-88A6-09CD41F825BA}"/>
+                <a16:creationId xmlns:a16="http://schemas.microsoft.com/office/drawing/2014/main" id="{151420BF-7358-4627-94D4-DC9893EF3661}"/>
               </a:ext>
             </a:extLst>
           </p:cNvPr>
@@ -4084,7 +4009,7 @@
     </p:spTree>
     <p:extLst>
       <p:ext uri="{BB962C8B-B14F-4D97-AF65-F5344CB8AC3E}">
-        <p14:creationId xmlns:p14="http://schemas.microsoft.com/office/powerpoint/2010/main" val="1110396161"/>
+        <p14:creationId xmlns:p14="http://schemas.microsoft.com/office/powerpoint/2010/main" val="437529894"/>
       </p:ext>
     </p:extLst>
   </p:cSld>
@@ -4115,7 +4040,7 @@
           <p:cNvPr id="13" name="">
             <a:extLst xmlns:a="http://schemas.openxmlformats.org/drawingml/2006/main">
               <a:ext uri="{FF2B5EF4-FFF2-40B4-BE49-F238E27FC236}">
-                <a16:creationId xmlns:a16="http://schemas.microsoft.com/office/drawing/2014/main" id="{E3AF68E0-E6E3-4F4A-A435-AE1C8A535035}"/>
+                <a16:creationId xmlns:a16="http://schemas.microsoft.com/office/drawing/2014/main" id="{EA0EB888-929C-4FFB-89C1-CCBA858102A9}"/>
               </a:ext>
             </a:extLst>
           </p:cNvPr>
@@ -4172,7 +4097,7 @@
           <p:cNvPr id="2" name="">
             <a:extLst xmlns:a="http://schemas.openxmlformats.org/drawingml/2006/main">
               <a:ext uri="{FF2B5EF4-FFF2-40B4-BE49-F238E27FC236}">
-                <a16:creationId xmlns:a16="http://schemas.microsoft.com/office/drawing/2014/main" id="{88D599D1-CC75-4F3F-9AFA-79E234996436}"/>
+                <a16:creationId xmlns:a16="http://schemas.microsoft.com/office/drawing/2014/main" id="{BF56D12A-1A32-48B8-944A-99179BAF164B}"/>
               </a:ext>
             </a:extLst>
           </p:cNvPr>
@@ -4229,7 +4154,7 @@
           <p:cNvPr id="3" name="">
             <a:extLst xmlns:a="http://schemas.openxmlformats.org/drawingml/2006/main">
               <a:ext uri="{FF2B5EF4-FFF2-40B4-BE49-F238E27FC236}">
-                <a16:creationId xmlns:a16="http://schemas.microsoft.com/office/drawing/2014/main" id="{1F5402B2-643C-4F11-88C5-E4083B3AC710}"/>
+                <a16:creationId xmlns:a16="http://schemas.microsoft.com/office/drawing/2014/main" id="{1BB5D65C-C070-4980-B19F-8620F1567308}"/>
               </a:ext>
             </a:extLst>
           </p:cNvPr>
@@ -4286,7 +4211,7 @@
           <p:cNvPr id="4" name="">
             <a:extLst xmlns:a="http://schemas.openxmlformats.org/drawingml/2006/main">
               <a:ext uri="{FF2B5EF4-FFF2-40B4-BE49-F238E27FC236}">
-                <a16:creationId xmlns:a16="http://schemas.microsoft.com/office/drawing/2014/main" id="{DB7E36D8-C66A-4693-994B-025C9B062463}"/>
+                <a16:creationId xmlns:a16="http://schemas.microsoft.com/office/drawing/2014/main" id="{52792544-C408-47F5-A436-304425A23F83}"/>
               </a:ext>
             </a:extLst>
           </p:cNvPr>
@@ -4343,7 +4268,7 @@
           <p:cNvPr id="5" name="">
             <a:extLst xmlns:a="http://schemas.openxmlformats.org/drawingml/2006/main">
               <a:ext uri="{FF2B5EF4-FFF2-40B4-BE49-F238E27FC236}">
-                <a16:creationId xmlns:a16="http://schemas.microsoft.com/office/drawing/2014/main" id="{F8530D30-C09F-48AF-B803-EFEAF4CC8E40}"/>
+                <a16:creationId xmlns:a16="http://schemas.microsoft.com/office/drawing/2014/main" id="{C328850B-9593-44D6-8113-E618162F535E}"/>
               </a:ext>
             </a:extLst>
           </p:cNvPr>
@@ -4404,7 +4329,7 @@
           <p:cNvPr id="6" name="">
             <a:extLst xmlns:a="http://schemas.openxmlformats.org/drawingml/2006/main">
               <a:ext uri="{FF2B5EF4-FFF2-40B4-BE49-F238E27FC236}">
-                <a16:creationId xmlns:a16="http://schemas.microsoft.com/office/drawing/2014/main" id="{676E9E75-27A8-4B2A-AF94-FA831AC34EEA}"/>
+                <a16:creationId xmlns:a16="http://schemas.microsoft.com/office/drawing/2014/main" id="{86400725-9640-43EC-8EC6-870EE511A84B}"/>
               </a:ext>
             </a:extLst>
           </p:cNvPr>
@@ -4465,7 +4390,7 @@
           <p:cNvPr id="7" name="">
             <a:extLst xmlns:a="http://schemas.openxmlformats.org/drawingml/2006/main">
               <a:ext uri="{FF2B5EF4-FFF2-40B4-BE49-F238E27FC236}">
-                <a16:creationId xmlns:a16="http://schemas.microsoft.com/office/drawing/2014/main" id="{1E4D188B-F46A-4E06-8152-B7B6542A2B69}"/>
+                <a16:creationId xmlns:a16="http://schemas.microsoft.com/office/drawing/2014/main" id="{BBCC17C4-62F1-4C13-A4FA-BCBFBD677097}"/>
               </a:ext>
             </a:extLst>
           </p:cNvPr>
@@ -4576,7 +4501,7 @@
           <p:cNvPr id="10" name="">
             <a:extLst xmlns:a="http://schemas.openxmlformats.org/drawingml/2006/main">
               <a:ext uri="{FF2B5EF4-FFF2-40B4-BE49-F238E27FC236}">
-                <a16:creationId xmlns:a16="http://schemas.microsoft.com/office/drawing/2014/main" id="{BBDD2950-BFD8-42DF-A3F9-6BCE675C343A}"/>
+                <a16:creationId xmlns:a16="http://schemas.microsoft.com/office/drawing/2014/main" id="{34965C22-73E6-4B66-BCB0-304E3B4047A3}"/>
               </a:ext>
             </a:extLst>
           </p:cNvPr>
@@ -4633,7 +4558,7 @@
           <p:cNvPr id="11" name="">
             <a:extLst xmlns:a="http://schemas.openxmlformats.org/drawingml/2006/main">
               <a:ext uri="{FF2B5EF4-FFF2-40B4-BE49-F238E27FC236}">
-                <a16:creationId xmlns:a16="http://schemas.microsoft.com/office/drawing/2014/main" id="{E84BD47A-54F3-4C51-9833-C7E60630D7F6}"/>
+                <a16:creationId xmlns:a16="http://schemas.microsoft.com/office/drawing/2014/main" id="{7776F767-C521-470B-8199-7A77793C1C7E}"/>
               </a:ext>
             </a:extLst>
           </p:cNvPr>
@@ -4759,7 +4684,7 @@
           <p:cNvPr id="12" name="">
             <a:extLst xmlns:a="http://schemas.openxmlformats.org/drawingml/2006/main">
               <a:ext uri="{FF2B5EF4-FFF2-40B4-BE49-F238E27FC236}">
-                <a16:creationId xmlns:a16="http://schemas.microsoft.com/office/drawing/2014/main" id="{2CBC9DD0-713F-4BC5-8820-5C72EFAED3E8}"/>
+                <a16:creationId xmlns:a16="http://schemas.microsoft.com/office/drawing/2014/main" id="{2A67ABF5-C377-4E3D-BDC2-FE0D16841CB8}"/>
               </a:ext>
             </a:extLst>
           </p:cNvPr>
@@ -4814,7 +4739,7 @@
     </p:spTree>
     <p:extLst>
       <p:ext uri="{BB962C8B-B14F-4D97-AF65-F5344CB8AC3E}">
-        <p14:creationId xmlns:p14="http://schemas.microsoft.com/office/powerpoint/2010/main" val="1347148943"/>
+        <p14:creationId xmlns:p14="http://schemas.microsoft.com/office/powerpoint/2010/main" val="2087244839"/>
       </p:ext>
     </p:extLst>
   </p:cSld>
@@ -4845,7 +4770,7 @@
           <p:cNvPr id="13" name="">
             <a:extLst xmlns:a="http://schemas.openxmlformats.org/drawingml/2006/main">
               <a:ext uri="{FF2B5EF4-FFF2-40B4-BE49-F238E27FC236}">
-                <a16:creationId xmlns:a16="http://schemas.microsoft.com/office/drawing/2014/main" id="{2C1C68C9-E244-4495-BCDF-B41526790AF6}"/>
+                <a16:creationId xmlns:a16="http://schemas.microsoft.com/office/drawing/2014/main" id="{D6B03CEB-2895-484A-B249-A17BF341E5D1}"/>
               </a:ext>
             </a:extLst>
           </p:cNvPr>
@@ -4902,7 +4827,7 @@
           <p:cNvPr id="2" name="">
             <a:extLst xmlns:a="http://schemas.openxmlformats.org/drawingml/2006/main">
               <a:ext uri="{FF2B5EF4-FFF2-40B4-BE49-F238E27FC236}">
-                <a16:creationId xmlns:a16="http://schemas.microsoft.com/office/drawing/2014/main" id="{85B22C30-C2FA-47F2-8114-E8B0EB8F1911}"/>
+                <a16:creationId xmlns:a16="http://schemas.microsoft.com/office/drawing/2014/main" id="{3C3657BD-BD0C-452C-9793-DC55D7138FA2}"/>
               </a:ext>
             </a:extLst>
           </p:cNvPr>
@@ -4959,7 +4884,7 @@
           <p:cNvPr id="3" name="">
             <a:extLst xmlns:a="http://schemas.openxmlformats.org/drawingml/2006/main">
               <a:ext uri="{FF2B5EF4-FFF2-40B4-BE49-F238E27FC236}">
-                <a16:creationId xmlns:a16="http://schemas.microsoft.com/office/drawing/2014/main" id="{E82A56FC-BB9A-428C-8A77-006E7504A52D}"/>
+                <a16:creationId xmlns:a16="http://schemas.microsoft.com/office/drawing/2014/main" id="{EBEEB2E8-B802-415F-AEF0-2E1A089AADC8}"/>
               </a:ext>
             </a:extLst>
           </p:cNvPr>
@@ -5016,7 +4941,7 @@
           <p:cNvPr id="4" name="">
             <a:extLst xmlns:a="http://schemas.openxmlformats.org/drawingml/2006/main">
               <a:ext uri="{FF2B5EF4-FFF2-40B4-BE49-F238E27FC236}">
-                <a16:creationId xmlns:a16="http://schemas.microsoft.com/office/drawing/2014/main" id="{EAA4147D-77D8-45B4-AB07-B9E5FCA73B94}"/>
+                <a16:creationId xmlns:a16="http://schemas.microsoft.com/office/drawing/2014/main" id="{F63F8304-6F68-4D37-A964-2878A120AEEF}"/>
               </a:ext>
             </a:extLst>
           </p:cNvPr>
@@ -5073,7 +4998,7 @@
           <p:cNvPr id="5" name="">
             <a:extLst xmlns:a="http://schemas.openxmlformats.org/drawingml/2006/main">
               <a:ext uri="{FF2B5EF4-FFF2-40B4-BE49-F238E27FC236}">
-                <a16:creationId xmlns:a16="http://schemas.microsoft.com/office/drawing/2014/main" id="{1B5B0AD1-EBC7-4B68-BBBF-A0B6FC20A6D6}"/>
+                <a16:creationId xmlns:a16="http://schemas.microsoft.com/office/drawing/2014/main" id="{7DC353DE-BE50-4E72-B03B-C5BD502D8760}"/>
               </a:ext>
             </a:extLst>
           </p:cNvPr>
@@ -5157,7 +5082,7 @@
           <p:cNvPr id="6" name="">
             <a:extLst xmlns:a="http://schemas.openxmlformats.org/drawingml/2006/main">
               <a:ext uri="{FF2B5EF4-FFF2-40B4-BE49-F238E27FC236}">
-                <a16:creationId xmlns:a16="http://schemas.microsoft.com/office/drawing/2014/main" id="{B612405E-EC2A-40AC-87BE-5A02AB8F41B1}"/>
+                <a16:creationId xmlns:a16="http://schemas.microsoft.com/office/drawing/2014/main" id="{9A422DB6-A5C1-4357-A9AA-75DBA242801D}"/>
               </a:ext>
             </a:extLst>
           </p:cNvPr>
@@ -5218,7 +5143,7 @@
           <p:cNvPr id="7" name="">
             <a:extLst xmlns:a="http://schemas.openxmlformats.org/drawingml/2006/main">
               <a:ext uri="{FF2B5EF4-FFF2-40B4-BE49-F238E27FC236}">
-                <a16:creationId xmlns:a16="http://schemas.microsoft.com/office/drawing/2014/main" id="{1BFA6E88-36D2-41FE-9C66-2EFCD4986477}"/>
+                <a16:creationId xmlns:a16="http://schemas.microsoft.com/office/drawing/2014/main" id="{7A8CA3F0-E39C-4676-BE70-CC6AF989F3C0}"/>
               </a:ext>
             </a:extLst>
           </p:cNvPr>
@@ -5352,7 +5277,7 @@
           <p:cNvPr id="10" name="">
             <a:extLst xmlns:a="http://schemas.openxmlformats.org/drawingml/2006/main">
               <a:ext uri="{FF2B5EF4-FFF2-40B4-BE49-F238E27FC236}">
-                <a16:creationId xmlns:a16="http://schemas.microsoft.com/office/drawing/2014/main" id="{A45D2A93-810E-4766-8B66-B6C1C621FC9E}"/>
+                <a16:creationId xmlns:a16="http://schemas.microsoft.com/office/drawing/2014/main" id="{1F5EBCC8-A1D5-4A5F-B8A3-77B4C691E8C7}"/>
               </a:ext>
             </a:extLst>
           </p:cNvPr>
@@ -5645,7 +5570,7 @@
           <p:cNvPr id="12" name="">
             <a:extLst xmlns:a="http://schemas.openxmlformats.org/drawingml/2006/main">
               <a:ext uri="{FF2B5EF4-FFF2-40B4-BE49-F238E27FC236}">
-                <a16:creationId xmlns:a16="http://schemas.microsoft.com/office/drawing/2014/main" id="{D1097816-3EE1-4FAA-915E-3669D677CCD2}"/>
+                <a16:creationId xmlns:a16="http://schemas.microsoft.com/office/drawing/2014/main" id="{6C4D64B8-C713-45C8-BBF5-2692E1944908}"/>
               </a:ext>
             </a:extLst>
           </p:cNvPr>
@@ -5700,7 +5625,7 @@
     </p:spTree>
     <p:extLst>
       <p:ext uri="{BB962C8B-B14F-4D97-AF65-F5344CB8AC3E}">
-        <p14:creationId xmlns:p14="http://schemas.microsoft.com/office/powerpoint/2010/main" val="1909616586"/>
+        <p14:creationId xmlns:p14="http://schemas.microsoft.com/office/powerpoint/2010/main" val="171491040"/>
       </p:ext>
     </p:extLst>
   </p:cSld>
@@ -5731,7 +5656,7 @@
           <p:cNvPr id="9" name="">
             <a:extLst xmlns:a="http://schemas.openxmlformats.org/drawingml/2006/main">
               <a:ext uri="{FF2B5EF4-FFF2-40B4-BE49-F238E27FC236}">
-                <a16:creationId xmlns:a16="http://schemas.microsoft.com/office/drawing/2014/main" id="{7BB8D7A7-1D0D-4203-B2FB-1591A46A3D49}"/>
+                <a16:creationId xmlns:a16="http://schemas.microsoft.com/office/drawing/2014/main" id="{1F7C30E4-DA30-46FD-A575-0D65F124FA2E}"/>
               </a:ext>
             </a:extLst>
           </p:cNvPr>
@@ -5788,7 +5713,7 @@
           <p:cNvPr id="2" name="">
             <a:extLst xmlns:a="http://schemas.openxmlformats.org/drawingml/2006/main">
               <a:ext uri="{FF2B5EF4-FFF2-40B4-BE49-F238E27FC236}">
-                <a16:creationId xmlns:a16="http://schemas.microsoft.com/office/drawing/2014/main" id="{F7800F54-F9AC-4AFF-A9D7-A4D6F4783B9F}"/>
+                <a16:creationId xmlns:a16="http://schemas.microsoft.com/office/drawing/2014/main" id="{394C30AD-70B0-46F2-A323-550D05375787}"/>
               </a:ext>
             </a:extLst>
           </p:cNvPr>
@@ -5845,7 +5770,7 @@
           <p:cNvPr id="3" name="">
             <a:extLst xmlns:a="http://schemas.openxmlformats.org/drawingml/2006/main">
               <a:ext uri="{FF2B5EF4-FFF2-40B4-BE49-F238E27FC236}">
-                <a16:creationId xmlns:a16="http://schemas.microsoft.com/office/drawing/2014/main" id="{087A001B-7EAA-4FF9-ABC4-3E0768AD3C59}"/>
+                <a16:creationId xmlns:a16="http://schemas.microsoft.com/office/drawing/2014/main" id="{57502E01-4129-464F-9DF1-B6A6906A0756}"/>
               </a:ext>
             </a:extLst>
           </p:cNvPr>
@@ -5902,7 +5827,7 @@
           <p:cNvPr id="4" name="">
             <a:extLst xmlns:a="http://schemas.openxmlformats.org/drawingml/2006/main">
               <a:ext uri="{FF2B5EF4-FFF2-40B4-BE49-F238E27FC236}">
-                <a16:creationId xmlns:a16="http://schemas.microsoft.com/office/drawing/2014/main" id="{C7830748-1543-4920-8080-B5B3AE62656C}"/>
+                <a16:creationId xmlns:a16="http://schemas.microsoft.com/office/drawing/2014/main" id="{9D4C14FB-155E-4B63-BA8B-630BBBADC4C0}"/>
               </a:ext>
             </a:extLst>
           </p:cNvPr>
@@ -5959,7 +5884,7 @@
           <p:cNvPr id="5" name="">
             <a:extLst xmlns:a="http://schemas.openxmlformats.org/drawingml/2006/main">
               <a:ext uri="{FF2B5EF4-FFF2-40B4-BE49-F238E27FC236}">
-                <a16:creationId xmlns:a16="http://schemas.microsoft.com/office/drawing/2014/main" id="{71169BE2-1BAE-4A4A-A113-4AAF7DD9BF42}"/>
+                <a16:creationId xmlns:a16="http://schemas.microsoft.com/office/drawing/2014/main" id="{E99A8972-D996-4DBE-B9DA-866C932F0E2B}"/>
               </a:ext>
             </a:extLst>
           </p:cNvPr>
@@ -6039,7 +5964,7 @@
           <p:cNvPr id="6" name="">
             <a:extLst xmlns:a="http://schemas.openxmlformats.org/drawingml/2006/main">
               <a:ext uri="{FF2B5EF4-FFF2-40B4-BE49-F238E27FC236}">
-                <a16:creationId xmlns:a16="http://schemas.microsoft.com/office/drawing/2014/main" id="{6F11DABD-28D5-40D0-9659-E96BACC961DE}"/>
+                <a16:creationId xmlns:a16="http://schemas.microsoft.com/office/drawing/2014/main" id="{A8604581-757F-472F-B82D-8E22A41C3C8B}"/>
               </a:ext>
             </a:extLst>
           </p:cNvPr>
@@ -6096,7 +6021,7 @@
           <p:cNvPr id="7" name="">
             <a:extLst xmlns:a="http://schemas.openxmlformats.org/drawingml/2006/main">
               <a:ext uri="{FF2B5EF4-FFF2-40B4-BE49-F238E27FC236}">
-                <a16:creationId xmlns:a16="http://schemas.microsoft.com/office/drawing/2014/main" id="{1ABA8F84-76E1-43F1-BA85-3D58BEF9B7B6}"/>
+                <a16:creationId xmlns:a16="http://schemas.microsoft.com/office/drawing/2014/main" id="{E454BEBA-E739-49F5-AB91-AE877AD13735}"/>
               </a:ext>
             </a:extLst>
           </p:cNvPr>
@@ -6381,7 +6306,7 @@
     </p:spTree>
     <p:extLst>
       <p:ext uri="{BB962C8B-B14F-4D97-AF65-F5344CB8AC3E}">
-        <p14:creationId xmlns:p14="http://schemas.microsoft.com/office/powerpoint/2010/main" val="1747341820"/>
+        <p14:creationId xmlns:p14="http://schemas.microsoft.com/office/powerpoint/2010/main" val="1246298868"/>
       </p:ext>
     </p:extLst>
   </p:cSld>
@@ -6412,7 +6337,7 @@
           <p:cNvPr id="7" name="">
             <a:extLst xmlns:a="http://schemas.openxmlformats.org/drawingml/2006/main">
               <a:ext uri="{FF2B5EF4-FFF2-40B4-BE49-F238E27FC236}">
-                <a16:creationId xmlns:a16="http://schemas.microsoft.com/office/drawing/2014/main" id="{695C5F18-B138-4F44-BD0E-98701514355C}"/>
+                <a16:creationId xmlns:a16="http://schemas.microsoft.com/office/drawing/2014/main" id="{AE1710C1-C96D-4883-A71E-5E91AB2E2E4B}"/>
               </a:ext>
             </a:extLst>
           </p:cNvPr>
@@ -6469,7 +6394,7 @@
           <p:cNvPr id="2" name="">
             <a:extLst xmlns:a="http://schemas.openxmlformats.org/drawingml/2006/main">
               <a:ext uri="{FF2B5EF4-FFF2-40B4-BE49-F238E27FC236}">
-                <a16:creationId xmlns:a16="http://schemas.microsoft.com/office/drawing/2014/main" id="{747E3E6D-EAB9-4D2B-9EF0-A5E0AFD5F62E}"/>
+                <a16:creationId xmlns:a16="http://schemas.microsoft.com/office/drawing/2014/main" id="{BA676DD2-77BE-4960-9CCF-DCCCC4D650A9}"/>
               </a:ext>
             </a:extLst>
           </p:cNvPr>
@@ -6526,7 +6451,7 @@
           <p:cNvPr id="3" name="">
             <a:extLst xmlns:a="http://schemas.openxmlformats.org/drawingml/2006/main">
               <a:ext uri="{FF2B5EF4-FFF2-40B4-BE49-F238E27FC236}">
-                <a16:creationId xmlns:a16="http://schemas.microsoft.com/office/drawing/2014/main" id="{458FB847-AC51-4432-9178-7BFAAD5A22C0}"/>
+                <a16:creationId xmlns:a16="http://schemas.microsoft.com/office/drawing/2014/main" id="{74995C4D-1DE2-4029-B1D9-DDF5045DC50C}"/>
               </a:ext>
             </a:extLst>
           </p:cNvPr>
@@ -6821,7 +6746,7 @@
           <p:cNvPr id="5" name="">
             <a:extLst xmlns:a="http://schemas.openxmlformats.org/drawingml/2006/main">
               <a:ext uri="{FF2B5EF4-FFF2-40B4-BE49-F238E27FC236}">
-                <a16:creationId xmlns:a16="http://schemas.microsoft.com/office/drawing/2014/main" id="{A3945520-1844-47EC-8506-A151AB08CDD6}"/>
+                <a16:creationId xmlns:a16="http://schemas.microsoft.com/office/drawing/2014/main" id="{6D2DBBA8-5C98-43BC-84C5-A014C6F3874D}"/>
               </a:ext>
             </a:extLst>
           </p:cNvPr>
@@ -6901,7 +6826,7 @@
           <p:cNvPr id="6" name="">
             <a:extLst xmlns:a="http://schemas.openxmlformats.org/drawingml/2006/main">
               <a:ext uri="{FF2B5EF4-FFF2-40B4-BE49-F238E27FC236}">
-                <a16:creationId xmlns:a16="http://schemas.microsoft.com/office/drawing/2014/main" id="{F8937F8F-969C-4CDE-B20C-08D780426CFE}"/>
+                <a16:creationId xmlns:a16="http://schemas.microsoft.com/office/drawing/2014/main" id="{3361CEBF-7DAB-47E0-BF8A-3A3638B907F6}"/>
               </a:ext>
             </a:extLst>
           </p:cNvPr>
@@ -6956,7 +6881,7 @@
     </p:spTree>
     <p:extLst>
       <p:ext uri="{BB962C8B-B14F-4D97-AF65-F5344CB8AC3E}">
-        <p14:creationId xmlns:p14="http://schemas.microsoft.com/office/powerpoint/2010/main" val="1126943669"/>
+        <p14:creationId xmlns:p14="http://schemas.microsoft.com/office/powerpoint/2010/main" val="1155768584"/>
       </p:ext>
     </p:extLst>
   </p:cSld>
@@ -6987,7 +6912,7 @@
           <p:cNvPr id="10" name="">
             <a:extLst xmlns:a="http://schemas.openxmlformats.org/drawingml/2006/main">
               <a:ext uri="{FF2B5EF4-FFF2-40B4-BE49-F238E27FC236}">
-                <a16:creationId xmlns:a16="http://schemas.microsoft.com/office/drawing/2014/main" id="{2BBACF9F-F502-4784-8D32-C34BD65C6D6B}"/>
+                <a16:creationId xmlns:a16="http://schemas.microsoft.com/office/drawing/2014/main" id="{E743F609-746B-47D3-A2AE-8C96D50FAC58}"/>
               </a:ext>
             </a:extLst>
           </p:cNvPr>
@@ -7044,7 +6969,7 @@
           <p:cNvPr id="2" name="">
             <a:extLst xmlns:a="http://schemas.openxmlformats.org/drawingml/2006/main">
               <a:ext uri="{FF2B5EF4-FFF2-40B4-BE49-F238E27FC236}">
-                <a16:creationId xmlns:a16="http://schemas.microsoft.com/office/drawing/2014/main" id="{BBCC311E-E987-4FC7-B90B-8A7878354342}"/>
+                <a16:creationId xmlns:a16="http://schemas.microsoft.com/office/drawing/2014/main" id="{818BB125-06AE-43E0-A28F-28FB1A9711F1}"/>
               </a:ext>
             </a:extLst>
           </p:cNvPr>
@@ -7101,7 +7026,7 @@
           <p:cNvPr id="3" name="">
             <a:extLst xmlns:a="http://schemas.openxmlformats.org/drawingml/2006/main">
               <a:ext uri="{FF2B5EF4-FFF2-40B4-BE49-F238E27FC236}">
-                <a16:creationId xmlns:a16="http://schemas.microsoft.com/office/drawing/2014/main" id="{4648ED80-4861-4822-871C-0EFC6D32E7BA}"/>
+                <a16:creationId xmlns:a16="http://schemas.microsoft.com/office/drawing/2014/main" id="{8ACC0460-5176-49A3-B622-F90D51D2C2DE}"/>
               </a:ext>
             </a:extLst>
           </p:cNvPr>
@@ -7158,7 +7083,7 @@
           <p:cNvPr id="4" name="">
             <a:extLst xmlns:a="http://schemas.openxmlformats.org/drawingml/2006/main">
               <a:ext uri="{FF2B5EF4-FFF2-40B4-BE49-F238E27FC236}">
-                <a16:creationId xmlns:a16="http://schemas.microsoft.com/office/drawing/2014/main" id="{1806DE64-69F7-4D1A-BDC6-F746E8A004AC}"/>
+                <a16:creationId xmlns:a16="http://schemas.microsoft.com/office/drawing/2014/main" id="{FB5E3A36-C794-486A-8732-FCA0C597CA3A}"/>
               </a:ext>
             </a:extLst>
           </p:cNvPr>
@@ -7215,7 +7140,7 @@
           <p:cNvPr id="5" name="">
             <a:extLst xmlns:a="http://schemas.openxmlformats.org/drawingml/2006/main">
               <a:ext uri="{FF2B5EF4-FFF2-40B4-BE49-F238E27FC236}">
-                <a16:creationId xmlns:a16="http://schemas.microsoft.com/office/drawing/2014/main" id="{94AC9A13-66E2-4C49-855F-8E1E1667B0F0}"/>
+                <a16:creationId xmlns:a16="http://schemas.microsoft.com/office/drawing/2014/main" id="{95A79F2D-6ABD-407D-A699-31B60B2C334F}"/>
               </a:ext>
             </a:extLst>
           </p:cNvPr>
@@ -7295,7 +7220,7 @@
           <p:cNvPr id="6" name="">
             <a:extLst xmlns:a="http://schemas.openxmlformats.org/drawingml/2006/main">
               <a:ext uri="{FF2B5EF4-FFF2-40B4-BE49-F238E27FC236}">
-                <a16:creationId xmlns:a16="http://schemas.microsoft.com/office/drawing/2014/main" id="{928F79EC-79C4-4ECE-9358-6341A59C38CC}"/>
+                <a16:creationId xmlns:a16="http://schemas.microsoft.com/office/drawing/2014/main" id="{5AFB34B5-29D2-49AE-8C64-5AC54BF0EAF1}"/>
               </a:ext>
             </a:extLst>
           </p:cNvPr>
@@ -7324,7 +7249,7 @@
           <p:cNvPr id="7" name="">
             <a:extLst xmlns:a="http://schemas.openxmlformats.org/drawingml/2006/main">
               <a:ext uri="{FF2B5EF4-FFF2-40B4-BE49-F238E27FC236}">
-                <a16:creationId xmlns:a16="http://schemas.microsoft.com/office/drawing/2014/main" id="{5D9FC106-78F0-4F7D-831A-6E150C7D46D6}"/>
+                <a16:creationId xmlns:a16="http://schemas.microsoft.com/office/drawing/2014/main" id="{2F6DC42F-F4FE-4219-809C-22B20D22EF61}"/>
               </a:ext>
             </a:extLst>
           </p:cNvPr>
@@ -7381,7 +7306,7 @@
           <p:cNvPr id="8" name="">
             <a:extLst xmlns:a="http://schemas.openxmlformats.org/drawingml/2006/main">
               <a:ext uri="{FF2B5EF4-FFF2-40B4-BE49-F238E27FC236}">
-                <a16:creationId xmlns:a16="http://schemas.microsoft.com/office/drawing/2014/main" id="{8E2D1F09-0FD2-4716-9934-C5D20FFACAF6}"/>
+                <a16:creationId xmlns:a16="http://schemas.microsoft.com/office/drawing/2014/main" id="{46BBFAF6-490B-4D8D-9F3A-EB94276F4E80}"/>
               </a:ext>
             </a:extLst>
           </p:cNvPr>
@@ -7438,7 +7363,7 @@
           <p:cNvPr id="9" name="">
             <a:extLst xmlns:a="http://schemas.openxmlformats.org/drawingml/2006/main">
               <a:ext uri="{FF2B5EF4-FFF2-40B4-BE49-F238E27FC236}">
-                <a16:creationId xmlns:a16="http://schemas.microsoft.com/office/drawing/2014/main" id="{2B568D7B-E69F-458F-91FD-1D8EF176B216}"/>
+                <a16:creationId xmlns:a16="http://schemas.microsoft.com/office/drawing/2014/main" id="{686D544B-B4CD-4897-B73D-D93F0B3E7F8E}"/>
               </a:ext>
             </a:extLst>
           </p:cNvPr>
@@ -7493,7 +7418,7 @@
     </p:spTree>
     <p:extLst>
       <p:ext uri="{BB962C8B-B14F-4D97-AF65-F5344CB8AC3E}">
-        <p14:creationId xmlns:p14="http://schemas.microsoft.com/office/powerpoint/2010/main" val="1149145310"/>
+        <p14:creationId xmlns:p14="http://schemas.microsoft.com/office/powerpoint/2010/main" val="1304344453"/>
       </p:ext>
     </p:extLst>
   </p:cSld>
@@ -7524,7 +7449,7 @@
           <p:cNvPr id="8" name="">
             <a:extLst xmlns:a="http://schemas.openxmlformats.org/drawingml/2006/main">
               <a:ext uri="{FF2B5EF4-FFF2-40B4-BE49-F238E27FC236}">
-                <a16:creationId xmlns:a16="http://schemas.microsoft.com/office/drawing/2014/main" id="{B99D6723-1931-44F3-9992-85F27DFCA3D3}"/>
+                <a16:creationId xmlns:a16="http://schemas.microsoft.com/office/drawing/2014/main" id="{2904ADFA-06F0-4E8B-8403-CD04B631350F}"/>
               </a:ext>
             </a:extLst>
           </p:cNvPr>
@@ -7581,7 +7506,7 @@
           <p:cNvPr id="2" name="">
             <a:extLst xmlns:a="http://schemas.openxmlformats.org/drawingml/2006/main">
               <a:ext uri="{FF2B5EF4-FFF2-40B4-BE49-F238E27FC236}">
-                <a16:creationId xmlns:a16="http://schemas.microsoft.com/office/drawing/2014/main" id="{A4EF684B-EF93-4831-A627-F6437D2B6783}"/>
+                <a16:creationId xmlns:a16="http://schemas.microsoft.com/office/drawing/2014/main" id="{1BF56291-845F-41C0-9717-365516CE930C}"/>
               </a:ext>
             </a:extLst>
           </p:cNvPr>
@@ -7638,7 +7563,7 @@
           <p:cNvPr id="3" name="">
             <a:extLst xmlns:a="http://schemas.openxmlformats.org/drawingml/2006/main">
               <a:ext uri="{FF2B5EF4-FFF2-40B4-BE49-F238E27FC236}">
-                <a16:creationId xmlns:a16="http://schemas.microsoft.com/office/drawing/2014/main" id="{A2B3D0CF-60B9-42EC-8159-656E9700BCC3}"/>
+                <a16:creationId xmlns:a16="http://schemas.microsoft.com/office/drawing/2014/main" id="{833A5581-2430-49C5-822F-F3ECC2FF2B75}"/>
               </a:ext>
             </a:extLst>
           </p:cNvPr>
@@ -7695,7 +7620,7 @@
           <p:cNvPr id="4" name="">
             <a:extLst xmlns:a="http://schemas.openxmlformats.org/drawingml/2006/main">
               <a:ext uri="{FF2B5EF4-FFF2-40B4-BE49-F238E27FC236}">
-                <a16:creationId xmlns:a16="http://schemas.microsoft.com/office/drawing/2014/main" id="{F6A7C095-227B-4166-961B-05D978BC1011}"/>
+                <a16:creationId xmlns:a16="http://schemas.microsoft.com/office/drawing/2014/main" id="{A7B488D8-8CAA-45B7-B3CB-EDB02CB44418}"/>
               </a:ext>
             </a:extLst>
           </p:cNvPr>
@@ -7752,7 +7677,7 @@
           <p:cNvPr id="5" name="">
             <a:extLst xmlns:a="http://schemas.openxmlformats.org/drawingml/2006/main">
               <a:ext uri="{FF2B5EF4-FFF2-40B4-BE49-F238E27FC236}">
-                <a16:creationId xmlns:a16="http://schemas.microsoft.com/office/drawing/2014/main" id="{94614A01-1DC1-4CC5-A599-5F86EE9E5A96}"/>
+                <a16:creationId xmlns:a16="http://schemas.microsoft.com/office/drawing/2014/main" id="{7EDBE9F1-32FA-47ED-B77F-396AA223BC9D}"/>
               </a:ext>
             </a:extLst>
           </p:cNvPr>
@@ -7809,7 +7734,7 @@
           <p:cNvPr id="6" name="">
             <a:extLst xmlns:a="http://schemas.openxmlformats.org/drawingml/2006/main">
               <a:ext uri="{FF2B5EF4-FFF2-40B4-BE49-F238E27FC236}">
-                <a16:creationId xmlns:a16="http://schemas.microsoft.com/office/drawing/2014/main" id="{55933123-8545-4C59-9D5D-4A5ABC1C1A97}"/>
+                <a16:creationId xmlns:a16="http://schemas.microsoft.com/office/drawing/2014/main" id="{CB697DF7-C04E-4293-B67B-8A5D5CFD271C}"/>
               </a:ext>
             </a:extLst>
           </p:cNvPr>
@@ -7856,7 +7781,7 @@
               <a:t>Histology: </a:t>
             </a:r>
             <a:r>
-              <a:t>Microscopic examination reveals injury and inflammation and supports the recorded diagnosis.</a:t>
+              <a:t>Microscopic examination reveals injury and inflammation that can support a rejection diagnosis.</a:t>
             </a:r>
           </a:p>
         </p:txBody>
@@ -7866,7 +7791,7 @@
           <p:cNvPr id="7" name="">
             <a:extLst xmlns:a="http://schemas.openxmlformats.org/drawingml/2006/main">
               <a:ext uri="{FF2B5EF4-FFF2-40B4-BE49-F238E27FC236}">
-                <a16:creationId xmlns:a16="http://schemas.microsoft.com/office/drawing/2014/main" id="{5045A4F9-F7A4-44DA-A4B1-6D4EEF763757}"/>
+                <a16:creationId xmlns:a16="http://schemas.microsoft.com/office/drawing/2014/main" id="{7E004F19-B81B-4144-A52C-A96B85BE0EBE}"/>
               </a:ext>
             </a:extLst>
           </p:cNvPr>
@@ -7878,7 +7803,7 @@
         <p:spPr>
           <a:xfrm xmlns:a="http://schemas.openxmlformats.org/drawingml/2006/main">
             <a:off x="1057275" y="4695825"/>
-            <a:ext cx="10525125" cy="876300"/>
+            <a:ext cx="10525125" cy="1104900"/>
           </a:xfrm>
           <a:prstGeom xmlns:a="http://schemas.openxmlformats.org/drawingml/2006/main" prst="rect">
             <a:avLst/>
@@ -7913,7 +7838,7 @@
               <a:t>Molecular measurements: </a:t>
             </a:r>
             <a:r>
-              <a:t>Counts of selected RNA types provide the model’s inputs.</a:t>
+              <a:t>Counts of selected RNA types reflect gene activity and the mix of cells in the tissue.</a:t>
             </a:r>
           </a:p>
         </p:txBody>
@@ -7921,7 +7846,7 @@
     </p:spTree>
     <p:extLst>
       <p:ext uri="{BB962C8B-B14F-4D97-AF65-F5344CB8AC3E}">
-        <p14:creationId xmlns:p14="http://schemas.microsoft.com/office/powerpoint/2010/main" val="2093742586"/>
+        <p14:creationId xmlns:p14="http://schemas.microsoft.com/office/powerpoint/2010/main" val="1079463213"/>
       </p:ext>
     </p:extLst>
   </p:cSld>
@@ -7949,10 +7874,10 @@
       </p:grpSpPr>
       <p:sp>
         <p:nvSpPr>
-          <p:cNvPr id="12" name="">
-            <a:extLst xmlns:a="http://schemas.openxmlformats.org/drawingml/2006/main">
-              <a:ext uri="{FF2B5EF4-FFF2-40B4-BE49-F238E27FC236}">
-                <a16:creationId xmlns:a16="http://schemas.microsoft.com/office/drawing/2014/main" id="{5BCAD1E5-69FC-469F-A3A7-49A3480A22B7}"/>
+          <p:cNvPr id="9" name="">
+            <a:extLst xmlns:a="http://schemas.openxmlformats.org/drawingml/2006/main">
+              <a:ext uri="{FF2B5EF4-FFF2-40B4-BE49-F238E27FC236}">
+                <a16:creationId xmlns:a16="http://schemas.microsoft.com/office/drawing/2014/main" id="{8A12B356-626B-4EBE-9F7C-DF1023FCE5BA}"/>
               </a:ext>
             </a:extLst>
           </p:cNvPr>
@@ -8009,7 +7934,7 @@
           <p:cNvPr id="2" name="">
             <a:extLst xmlns:a="http://schemas.openxmlformats.org/drawingml/2006/main">
               <a:ext uri="{FF2B5EF4-FFF2-40B4-BE49-F238E27FC236}">
-                <a16:creationId xmlns:a16="http://schemas.microsoft.com/office/drawing/2014/main" id="{DDE31E13-DAD6-45AE-8B61-36A7F0B8B08F}"/>
+                <a16:creationId xmlns:a16="http://schemas.microsoft.com/office/drawing/2014/main" id="{7C7235CB-D6B6-418B-A12A-CCDF7A1DA6FC}"/>
               </a:ext>
             </a:extLst>
           </p:cNvPr>
@@ -8056,7 +7981,7 @@
                 <a:ea typeface="Arial"/>
                 <a:cs typeface="Arial"/>
               </a:rPr>
-              <a:t>Source: Banff reference guide (updated Apr 2026).</a:t>
+              <a:t>Sources: Banff reference guide (Apr 2026); Nankivell et al. (2019)</a:t>
             </a:r>
           </a:p>
         </p:txBody>
@@ -8066,7 +7991,7 @@
           <p:cNvPr id="3" name="">
             <a:extLst xmlns:a="http://schemas.openxmlformats.org/drawingml/2006/main">
               <a:ext uri="{FF2B5EF4-FFF2-40B4-BE49-F238E27FC236}">
-                <a16:creationId xmlns:a16="http://schemas.microsoft.com/office/drawing/2014/main" id="{9E8CF440-9AEA-47AC-824D-CE2FDEEC94A3}"/>
+                <a16:creationId xmlns:a16="http://schemas.microsoft.com/office/drawing/2014/main" id="{E5FAC02F-E279-4894-BF27-B544964826FC}"/>
               </a:ext>
             </a:extLst>
           </p:cNvPr>
@@ -8123,7 +8048,7 @@
           <p:cNvPr id="4" name="">
             <a:extLst xmlns:a="http://schemas.openxmlformats.org/drawingml/2006/main">
               <a:ext uri="{FF2B5EF4-FFF2-40B4-BE49-F238E27FC236}">
-                <a16:creationId xmlns:a16="http://schemas.microsoft.com/office/drawing/2014/main" id="{2BCF21F6-5957-4DE6-91D3-EEA6C3B9038C}"/>
+                <a16:creationId xmlns:a16="http://schemas.microsoft.com/office/drawing/2014/main" id="{00527E65-8B05-4B23-84C6-3DE165EBE2FD}"/>
               </a:ext>
             </a:extLst>
           </p:cNvPr>
@@ -8174,7 +8099,7 @@
                 <a:ea typeface="Arial"/>
                 <a:cs typeface="Arial"/>
               </a:rPr>
-              <a:t>Sometimes the microscopic findings are borderline or conflict with other clinical evidence.</a:t>
+              <a:t>Sometimes the histology findings are ambiguous.</a:t>
             </a:r>
           </a:p>
         </p:txBody>
@@ -8184,7 +8109,7 @@
           <p:cNvPr id="5" name="">
             <a:extLst xmlns:a="http://schemas.openxmlformats.org/drawingml/2006/main">
               <a:ext uri="{FF2B5EF4-FFF2-40B4-BE49-F238E27FC236}">
-                <a16:creationId xmlns:a16="http://schemas.microsoft.com/office/drawing/2014/main" id="{05D71D5F-07D0-4174-82D2-64C7AC7EE66C}"/>
+                <a16:creationId xmlns:a16="http://schemas.microsoft.com/office/drawing/2014/main" id="{56B91C20-C85D-46EF-B4EC-D04314A793DD}"/>
               </a:ext>
             </a:extLst>
           </p:cNvPr>
@@ -8196,7 +8121,7 @@
         <p:spPr>
           <a:xfrm xmlns:a="http://schemas.openxmlformats.org/drawingml/2006/main">
             <a:off x="895350" y="2571750"/>
-            <a:ext cx="10687050" cy="1285875"/>
+            <a:ext cx="10687050" cy="1762125"/>
           </a:xfrm>
           <a:prstGeom xmlns:a="http://schemas.openxmlformats.org/drawingml/2006/main" prst="rect">
             <a:avLst/>
@@ -8216,7 +8141,7 @@
           <p:cNvPr id="6" name="">
             <a:extLst xmlns:a="http://schemas.openxmlformats.org/drawingml/2006/main">
               <a:ext uri="{FF2B5EF4-FFF2-40B4-BE49-F238E27FC236}">
-                <a16:creationId xmlns:a16="http://schemas.microsoft.com/office/drawing/2014/main" id="{8FF8B260-DBF6-49F6-924C-C485652B452A}"/>
+                <a16:creationId xmlns:a16="http://schemas.microsoft.com/office/drawing/2014/main" id="{EFAF72B7-FE80-4E57-BE62-DF50050F3E7B}"/>
               </a:ext>
             </a:extLst>
           </p:cNvPr>
@@ -8263,7 +8188,7 @@
                 <a:ea typeface="Arial"/>
                 <a:cs typeface="Arial"/>
               </a:rPr>
-              <a:t>Hypothetical Example:</a:t>
+              <a:t>Example:</a:t>
             </a:r>
           </a:p>
         </p:txBody>
@@ -8273,7 +8198,7 @@
           <p:cNvPr id="7" name="">
             <a:extLst xmlns:a="http://schemas.openxmlformats.org/drawingml/2006/main">
               <a:ext uri="{FF2B5EF4-FFF2-40B4-BE49-F238E27FC236}">
-                <a16:creationId xmlns:a16="http://schemas.microsoft.com/office/drawing/2014/main" id="{60508F05-A7B6-4131-86D6-4D90BC41FA02}"/>
+                <a16:creationId xmlns:a16="http://schemas.microsoft.com/office/drawing/2014/main" id="{9030F6FF-CBBB-4749-B0E8-D4E9041724A9}"/>
               </a:ext>
             </a:extLst>
           </p:cNvPr>
@@ -8285,7 +8210,7 @@
         <p:spPr>
           <a:xfrm xmlns:a="http://schemas.openxmlformats.org/drawingml/2006/main">
             <a:off x="1076325" y="3028950"/>
-            <a:ext cx="10325100" cy="762000"/>
+            <a:ext cx="10325100" cy="1238250"/>
           </a:xfrm>
           <a:prstGeom xmlns:a="http://schemas.openxmlformats.org/drawingml/2006/main" prst="rect">
             <a:avLst/>
@@ -8320,7 +8245,7 @@
                 <a:ea typeface="Arial"/>
                 <a:cs typeface="Arial"/>
               </a:rPr>
-              <a:t>A biopsy shows mild inflammation, but the microscopic findings do not clearly establish rejection.</a:t>
+              <a:t>A biopsy shows mild inflammation, but not enough to diagnose rejection. In a study of 146 borderline diagnoses, inflammation disappeared in some patients. Others later developed acute rejection.</a:t>
             </a:r>
           </a:p>
         </p:txBody>
@@ -8330,19 +8255,19 @@
           <p:cNvPr id="8" name="">
             <a:extLst xmlns:a="http://schemas.openxmlformats.org/drawingml/2006/main">
               <a:ext uri="{FF2B5EF4-FFF2-40B4-BE49-F238E27FC236}">
-                <a16:creationId xmlns:a16="http://schemas.microsoft.com/office/drawing/2014/main" id="{30409B41-D76A-43D8-97F8-88C17509C075}"/>
-              </a:ext>
-            </a:extLst>
-          </p:cNvPr>
-          <p:cNvSpPr>
-            <a:spLocks xmlns:a="http://schemas.openxmlformats.org/drawingml/2006/main" noGrp="1"/>
-          </p:cNvSpPr>
-          <p:nvPr/>
-        </p:nvSpPr>
-        <p:spPr>
-          <a:xfrm xmlns:a="http://schemas.openxmlformats.org/drawingml/2006/main">
-            <a:off x="609600" y="4048125"/>
-            <a:ext cx="10972800" cy="676275"/>
+                <a16:creationId xmlns:a16="http://schemas.microsoft.com/office/drawing/2014/main" id="{4B07F9B3-3274-4031-BCF6-3B8C633E3525}"/>
+              </a:ext>
+            </a:extLst>
+          </p:cNvPr>
+          <p:cNvSpPr>
+            <a:spLocks xmlns:a="http://schemas.openxmlformats.org/drawingml/2006/main" noGrp="1"/>
+          </p:cNvSpPr>
+          <p:nvPr/>
+        </p:nvSpPr>
+        <p:spPr>
+          <a:xfrm xmlns:a="http://schemas.openxmlformats.org/drawingml/2006/main">
+            <a:off x="609600" y="4591050"/>
+            <a:ext cx="10972800" cy="1504950"/>
           </a:xfrm>
           <a:prstGeom xmlns:a="http://schemas.openxmlformats.org/drawingml/2006/main" prst="rect">
             <a:avLst/>
@@ -8381,153 +8306,7 @@
                 <a:ea typeface="Arial"/>
                 <a:cs typeface="Arial"/>
               </a:rPr>
-              <a:t>I used RNA to classify recorded diagnoses in this personal project.</a:t>
-            </a:r>
-          </a:p>
-        </p:txBody>
-      </p:sp>
-      <p:sp>
-        <p:nvSpPr>
-          <p:cNvPr id="9" name="">
-            <a:extLst xmlns:a="http://schemas.openxmlformats.org/drawingml/2006/main">
-              <a:ext uri="{FF2B5EF4-FFF2-40B4-BE49-F238E27FC236}">
-                <a16:creationId xmlns:a16="http://schemas.microsoft.com/office/drawing/2014/main" id="{16E31919-7E1B-4F84-BC98-42EF93B2A4C9}"/>
-              </a:ext>
-            </a:extLst>
-          </p:cNvPr>
-          <p:cNvSpPr>
-            <a:spLocks xmlns:a="http://schemas.openxmlformats.org/drawingml/2006/main" noGrp="1"/>
-          </p:cNvSpPr>
-          <p:nvPr/>
-        </p:nvSpPr>
-        <p:spPr>
-          <a:xfrm xmlns:a="http://schemas.openxmlformats.org/drawingml/2006/main">
-            <a:off x="895350" y="4829175"/>
-            <a:ext cx="10687050" cy="1285875"/>
-          </a:xfrm>
-          <a:prstGeom xmlns:a="http://schemas.openxmlformats.org/drawingml/2006/main" prst="rect">
-            <a:avLst/>
-          </a:prstGeom>
-          <a:solidFill xmlns:a="http://schemas.openxmlformats.org/drawingml/2006/main">
-            <a:srgbClr val="E4EFEB"/>
-          </a:solidFill>
-          <a:ln xmlns:a="http://schemas.openxmlformats.org/drawingml/2006/main" w="9525">
-            <a:solidFill>
-              <a:srgbClr val="CEDBD7"/>
-            </a:solidFill>
-          </a:ln>
-        </p:spPr>
-      </p:sp>
-      <p:sp>
-        <p:nvSpPr>
-          <p:cNvPr id="10" name="">
-            <a:extLst xmlns:a="http://schemas.openxmlformats.org/drawingml/2006/main">
-              <a:ext uri="{FF2B5EF4-FFF2-40B4-BE49-F238E27FC236}">
-                <a16:creationId xmlns:a16="http://schemas.microsoft.com/office/drawing/2014/main" id="{C31F9090-525F-4855-9FC1-25E1D82ECA51}"/>
-              </a:ext>
-            </a:extLst>
-          </p:cNvPr>
-          <p:cNvSpPr>
-            <a:spLocks xmlns:a="http://schemas.openxmlformats.org/drawingml/2006/main" noGrp="1"/>
-          </p:cNvSpPr>
-          <p:nvPr/>
-        </p:nvSpPr>
-        <p:spPr>
-          <a:xfrm xmlns:a="http://schemas.openxmlformats.org/drawingml/2006/main">
-            <a:off x="1076325" y="4914900"/>
-            <a:ext cx="10325100" cy="352425"/>
-          </a:xfrm>
-          <a:prstGeom xmlns:a="http://schemas.openxmlformats.org/drawingml/2006/main" prst="rect">
-            <a:avLst/>
-          </a:prstGeom>
-          <a:noFill xmlns:a="http://schemas.openxmlformats.org/drawingml/2006/main"/>
-          <a:ln xmlns:a="http://schemas.openxmlformats.org/drawingml/2006/main" w="0">
-            <a:noFill/>
-          </a:ln>
-        </p:spPr>
-        <p:txBody>
-          <a:bodyPr xmlns:a="http://schemas.openxmlformats.org/drawingml/2006/main" anchor="ctr">
-            <a:noAutofit/>
-          </a:bodyPr>
-          <a:lstStyle xmlns:a="http://schemas.openxmlformats.org/drawingml/2006/main"/>
-          <a:p xmlns:a="http://schemas.openxmlformats.org/drawingml/2006/main">
-            <a:pPr algn="l">
-              <a:defRPr sz="2100" b="1">
-                <a:solidFill>
-                  <a:srgbClr val="007C78"/>
-                </a:solidFill>
-                <a:latin typeface="Arial"/>
-                <a:ea typeface="Arial"/>
-                <a:cs typeface="Arial"/>
-              </a:defRPr>
-            </a:pPr>
-            <a:r>
-              <a:rPr sz="2100" b="1">
-                <a:solidFill>
-                  <a:srgbClr val="007C78"/>
-                </a:solidFill>
-                <a:latin typeface="Arial"/>
-                <a:ea typeface="Arial"/>
-                <a:cs typeface="Arial"/>
-              </a:rPr>
-              <a:t>Hypothetical Example, continued:</a:t>
-            </a:r>
-          </a:p>
-        </p:txBody>
-      </p:sp>
-      <p:sp>
-        <p:nvSpPr>
-          <p:cNvPr id="11" name="">
-            <a:extLst xmlns:a="http://schemas.openxmlformats.org/drawingml/2006/main">
-              <a:ext uri="{FF2B5EF4-FFF2-40B4-BE49-F238E27FC236}">
-                <a16:creationId xmlns:a16="http://schemas.microsoft.com/office/drawing/2014/main" id="{F0EE0468-F29C-4F01-8FD4-3B97E531DBE8}"/>
-              </a:ext>
-            </a:extLst>
-          </p:cNvPr>
-          <p:cNvSpPr>
-            <a:spLocks xmlns:a="http://schemas.openxmlformats.org/drawingml/2006/main" noGrp="1"/>
-          </p:cNvSpPr>
-          <p:nvPr/>
-        </p:nvSpPr>
-        <p:spPr>
-          <a:xfrm xmlns:a="http://schemas.openxmlformats.org/drawingml/2006/main">
-            <a:off x="1076325" y="5286375"/>
-            <a:ext cx="10325100" cy="762000"/>
-          </a:xfrm>
-          <a:prstGeom xmlns:a="http://schemas.openxmlformats.org/drawingml/2006/main" prst="rect">
-            <a:avLst/>
-          </a:prstGeom>
-          <a:noFill xmlns:a="http://schemas.openxmlformats.org/drawingml/2006/main"/>
-          <a:ln xmlns:a="http://schemas.openxmlformats.org/drawingml/2006/main" w="0">
-            <a:noFill/>
-          </a:ln>
-        </p:spPr>
-        <p:txBody>
-          <a:bodyPr xmlns:a="http://schemas.openxmlformats.org/drawingml/2006/main" anchor="ctr">
-            <a:noAutofit/>
-          </a:bodyPr>
-          <a:lstStyle xmlns:a="http://schemas.openxmlformats.org/drawingml/2006/main"/>
-          <a:p xmlns:a="http://schemas.openxmlformats.org/drawingml/2006/main">
-            <a:pPr algn="l">
-              <a:defRPr sz="2250" b="0">
-                <a:solidFill>
-                  <a:srgbClr val="16343E"/>
-                </a:solidFill>
-                <a:latin typeface="Arial"/>
-                <a:ea typeface="Arial"/>
-                <a:cs typeface="Arial"/>
-              </a:defRPr>
-            </a:pPr>
-            <a:r>
-              <a:rPr sz="2250" b="0">
-                <a:solidFill>
-                  <a:srgbClr val="16343E"/>
-                </a:solidFill>
-                <a:latin typeface="Arial"/>
-                <a:ea typeface="Arial"/>
-                <a:cs typeface="Arial"/>
-              </a:rPr>
-              <a:t>A high rejection score could add evidence for specialist review of this biopsy.</a:t>
+              <a:t>As a step towards potentially helping resolve ambiguous biopsies, I used RNA counts to classify recorded diagnoses. A high rejection score could add evidence for specialist review.</a:t>
             </a:r>
           </a:p>
         </p:txBody>
@@ -8535,7 +8314,7 @@
     </p:spTree>
     <p:extLst>
       <p:ext uri="{BB962C8B-B14F-4D97-AF65-F5344CB8AC3E}">
-        <p14:creationId xmlns:p14="http://schemas.microsoft.com/office/powerpoint/2010/main" val="272483165"/>
+        <p14:creationId xmlns:p14="http://schemas.microsoft.com/office/powerpoint/2010/main" val="2000796435"/>
       </p:ext>
     </p:extLst>
   </p:cSld>
@@ -8566,7 +8345,7 @@
           <p:cNvPr id="13" name="">
             <a:extLst xmlns:a="http://schemas.openxmlformats.org/drawingml/2006/main">
               <a:ext uri="{FF2B5EF4-FFF2-40B4-BE49-F238E27FC236}">
-                <a16:creationId xmlns:a16="http://schemas.microsoft.com/office/drawing/2014/main" id="{97FF155C-8250-470B-B870-F85648A255A3}"/>
+                <a16:creationId xmlns:a16="http://schemas.microsoft.com/office/drawing/2014/main" id="{EF58B68E-C5D6-4586-9592-6D86E2C05028}"/>
               </a:ext>
             </a:extLst>
           </p:cNvPr>
@@ -8623,7 +8402,7 @@
           <p:cNvPr id="2" name="">
             <a:extLst xmlns:a="http://schemas.openxmlformats.org/drawingml/2006/main">
               <a:ext uri="{FF2B5EF4-FFF2-40B4-BE49-F238E27FC236}">
-                <a16:creationId xmlns:a16="http://schemas.microsoft.com/office/drawing/2014/main" id="{E32FE8A9-BD90-4E1F-90BF-D0D1176234D3}"/>
+                <a16:creationId xmlns:a16="http://schemas.microsoft.com/office/drawing/2014/main" id="{74C4918A-3C06-4D7F-A2CC-196F88328092}"/>
               </a:ext>
             </a:extLst>
           </p:cNvPr>
@@ -8680,7 +8459,7 @@
           <p:cNvPr id="3" name="">
             <a:extLst xmlns:a="http://schemas.openxmlformats.org/drawingml/2006/main">
               <a:ext uri="{FF2B5EF4-FFF2-40B4-BE49-F238E27FC236}">
-                <a16:creationId xmlns:a16="http://schemas.microsoft.com/office/drawing/2014/main" id="{E5373CF9-2422-4D87-A9A7-B59E1AC4A791}"/>
+                <a16:creationId xmlns:a16="http://schemas.microsoft.com/office/drawing/2014/main" id="{DBC3EF6B-9E35-493D-BD80-E77D068A4C21}"/>
               </a:ext>
             </a:extLst>
           </p:cNvPr>
@@ -8760,7 +8539,7 @@
           <p:cNvPr id="4" name="">
             <a:extLst xmlns:a="http://schemas.openxmlformats.org/drawingml/2006/main">
               <a:ext uri="{FF2B5EF4-FFF2-40B4-BE49-F238E27FC236}">
-                <a16:creationId xmlns:a16="http://schemas.microsoft.com/office/drawing/2014/main" id="{07A3A6C8-3903-482B-A9AD-5B5A29AFAF67}"/>
+                <a16:creationId xmlns:a16="http://schemas.microsoft.com/office/drawing/2014/main" id="{023F0052-4C25-4AE0-B94E-DC78DBDA9EA3}"/>
               </a:ext>
             </a:extLst>
           </p:cNvPr>
@@ -8840,7 +8619,7 @@
           <p:cNvPr id="5" name="">
             <a:extLst xmlns:a="http://schemas.openxmlformats.org/drawingml/2006/main">
               <a:ext uri="{FF2B5EF4-FFF2-40B4-BE49-F238E27FC236}">
-                <a16:creationId xmlns:a16="http://schemas.microsoft.com/office/drawing/2014/main" id="{4A0DC286-294A-4672-B4AD-B9FABB78EA25}"/>
+                <a16:creationId xmlns:a16="http://schemas.microsoft.com/office/drawing/2014/main" id="{B118EF41-B71E-4372-BCCE-8D1C5DCD2969}"/>
               </a:ext>
             </a:extLst>
           </p:cNvPr>
@@ -8869,7 +8648,7 @@
           <p:cNvPr id="6" name="">
             <a:extLst xmlns:a="http://schemas.openxmlformats.org/drawingml/2006/main">
               <a:ext uri="{FF2B5EF4-FFF2-40B4-BE49-F238E27FC236}">
-                <a16:creationId xmlns:a16="http://schemas.microsoft.com/office/drawing/2014/main" id="{41C3D0AC-14D3-4241-BDA2-BBCB6B94F0F7}"/>
+                <a16:creationId xmlns:a16="http://schemas.microsoft.com/office/drawing/2014/main" id="{4AB1D88E-C98E-4C9B-A3D5-D63E1D8F235F}"/>
               </a:ext>
             </a:extLst>
           </p:cNvPr>
@@ -8949,7 +8728,7 @@
           <p:cNvPr id="7" name="">
             <a:extLst xmlns:a="http://schemas.openxmlformats.org/drawingml/2006/main">
               <a:ext uri="{FF2B5EF4-FFF2-40B4-BE49-F238E27FC236}">
-                <a16:creationId xmlns:a16="http://schemas.microsoft.com/office/drawing/2014/main" id="{668BEF84-BD2B-4BC6-9457-00DA6D65ED29}"/>
+                <a16:creationId xmlns:a16="http://schemas.microsoft.com/office/drawing/2014/main" id="{874C97DE-0B13-4B9E-8166-7676B38F55B0}"/>
               </a:ext>
             </a:extLst>
           </p:cNvPr>
@@ -9052,7 +8831,7 @@
           <p:cNvPr id="8" name="">
             <a:extLst xmlns:a="http://schemas.openxmlformats.org/drawingml/2006/main">
               <a:ext uri="{FF2B5EF4-FFF2-40B4-BE49-F238E27FC236}">
-                <a16:creationId xmlns:a16="http://schemas.microsoft.com/office/drawing/2014/main" id="{2D744DF8-207F-470E-ADE1-3DA2E822DBE9}"/>
+                <a16:creationId xmlns:a16="http://schemas.microsoft.com/office/drawing/2014/main" id="{C91AF1B1-7A51-4C7D-98BA-61A51F2D8586}"/>
               </a:ext>
             </a:extLst>
           </p:cNvPr>
@@ -9081,18 +8860,18 @@
           <p:cNvPr id="9" name="">
             <a:extLst xmlns:a="http://schemas.openxmlformats.org/drawingml/2006/main">
               <a:ext uri="{FF2B5EF4-FFF2-40B4-BE49-F238E27FC236}">
-                <a16:creationId xmlns:a16="http://schemas.microsoft.com/office/drawing/2014/main" id="{56F62DAC-0CBC-4F70-9E62-47099600B34B}"/>
-              </a:ext>
-            </a:extLst>
-          </p:cNvPr>
-          <p:cNvSpPr>
-            <a:spLocks xmlns:a="http://schemas.openxmlformats.org/drawingml/2006/main" noGrp="1"/>
-          </p:cNvSpPr>
-          <p:nvPr/>
-        </p:nvSpPr>
-        <p:spPr>
-          <a:xfrm xmlns:a="http://schemas.openxmlformats.org/drawingml/2006/main">
-            <a:off x="609600" y="3829050"/>
+                <a16:creationId xmlns:a16="http://schemas.microsoft.com/office/drawing/2014/main" id="{B89040A1-8FA9-4D8C-8586-990F483A102F}"/>
+              </a:ext>
+            </a:extLst>
+          </p:cNvPr>
+          <p:cNvSpPr>
+            <a:spLocks xmlns:a="http://schemas.openxmlformats.org/drawingml/2006/main" noGrp="1"/>
+          </p:cNvSpPr>
+          <p:nvPr/>
+        </p:nvSpPr>
+        <p:spPr>
+          <a:xfrm xmlns:a="http://schemas.openxmlformats.org/drawingml/2006/main">
+            <a:off x="609600" y="3857625"/>
             <a:ext cx="2609850" cy="981075"/>
           </a:xfrm>
           <a:prstGeom xmlns:a="http://schemas.openxmlformats.org/drawingml/2006/main" prst="rect">
@@ -9128,7 +8907,7 @@
                 <a:ea typeface="Arial"/>
                 <a:cs typeface="Arial"/>
               </a:rPr>
-              <a:t>Why incorrect</a:t>
+              <a:t>Why both kinds</a:t>
             </a:r>
           </a:p>
           <a:p xmlns:a="http://schemas.openxmlformats.org/drawingml/2006/main">
@@ -9151,7 +8930,7 @@
                 <a:ea typeface="Arial"/>
                 <a:cs typeface="Arial"/>
               </a:rPr>
-              <a:t>rejection calls matter</a:t>
+              <a:t>of error matter</a:t>
             </a:r>
           </a:p>
         </p:txBody>
@@ -9161,19 +8940,19 @@
           <p:cNvPr id="10" name="">
             <a:extLst xmlns:a="http://schemas.openxmlformats.org/drawingml/2006/main">
               <a:ext uri="{FF2B5EF4-FFF2-40B4-BE49-F238E27FC236}">
-                <a16:creationId xmlns:a16="http://schemas.microsoft.com/office/drawing/2014/main" id="{0D4DFFAD-6D80-4EB1-99B7-CAE3A9581957}"/>
-              </a:ext>
-            </a:extLst>
-          </p:cNvPr>
-          <p:cNvSpPr>
-            <a:spLocks xmlns:a="http://schemas.openxmlformats.org/drawingml/2006/main" noGrp="1"/>
-          </p:cNvSpPr>
-          <p:nvPr/>
-        </p:nvSpPr>
-        <p:spPr>
-          <a:xfrm xmlns:a="http://schemas.openxmlformats.org/drawingml/2006/main">
-            <a:off x="3476625" y="3781425"/>
-            <a:ext cx="8105775" cy="1019175"/>
+                <a16:creationId xmlns:a16="http://schemas.microsoft.com/office/drawing/2014/main" id="{2D56AC8A-13B1-418A-8974-ADBC80B59BA1}"/>
+              </a:ext>
+            </a:extLst>
+          </p:cNvPr>
+          <p:cNvSpPr>
+            <a:spLocks xmlns:a="http://schemas.openxmlformats.org/drawingml/2006/main" noGrp="1"/>
+          </p:cNvSpPr>
+          <p:nvPr/>
+        </p:nvSpPr>
+        <p:spPr>
+          <a:xfrm xmlns:a="http://schemas.openxmlformats.org/drawingml/2006/main">
+            <a:off x="3476625" y="3762375"/>
+            <a:ext cx="8105775" cy="1171575"/>
           </a:xfrm>
           <a:prstGeom xmlns:a="http://schemas.openxmlformats.org/drawingml/2006/main" prst="rect">
             <a:avLst/>
@@ -9208,7 +8987,7 @@
                 <a:ea typeface="Arial"/>
                 <a:cs typeface="Arial"/>
               </a:rPr>
-              <a:t>Unnecessary rejection treatment can weaken the body’s</a:t>
+              <a:t>Missed rejection can leave kidney injury untreated.</a:t>
             </a:r>
           </a:p>
           <a:p xmlns:a="http://schemas.openxmlformats.org/drawingml/2006/main">
@@ -9231,7 +9010,30 @@
                 <a:ea typeface="Arial"/>
                 <a:cs typeface="Arial"/>
               </a:rPr>
-              <a:t>defenses and worsen an infection.</a:t>
+              <a:t>Unnecessary treatment can weaken the body’s defenses</a:t>
+            </a:r>
+          </a:p>
+          <a:p xmlns:a="http://schemas.openxmlformats.org/drawingml/2006/main">
+            <a:pPr algn="l">
+              <a:defRPr sz="2175" b="0">
+                <a:solidFill>
+                  <a:srgbClr val="16343E"/>
+                </a:solidFill>
+                <a:latin typeface="Arial"/>
+                <a:ea typeface="Arial"/>
+                <a:cs typeface="Arial"/>
+              </a:defRPr>
+            </a:pPr>
+            <a:r>
+              <a:rPr sz="2175" b="0">
+                <a:solidFill>
+                  <a:srgbClr val="16343E"/>
+                </a:solidFill>
+                <a:latin typeface="Arial"/>
+                <a:ea typeface="Arial"/>
+                <a:cs typeface="Arial"/>
+              </a:rPr>
+              <a:t>and worsen an infection.</a:t>
             </a:r>
           </a:p>
         </p:txBody>
@@ -9241,18 +9043,18 @@
           <p:cNvPr id="11" name="">
             <a:extLst xmlns:a="http://schemas.openxmlformats.org/drawingml/2006/main">
               <a:ext uri="{FF2B5EF4-FFF2-40B4-BE49-F238E27FC236}">
-                <a16:creationId xmlns:a16="http://schemas.microsoft.com/office/drawing/2014/main" id="{D080C7EF-C3A4-402B-BD38-986D14FD5742}"/>
-              </a:ext>
-            </a:extLst>
-          </p:cNvPr>
-          <p:cNvSpPr>
-            <a:spLocks xmlns:a="http://schemas.openxmlformats.org/drawingml/2006/main" noGrp="1"/>
-          </p:cNvSpPr>
-          <p:nvPr/>
-        </p:nvSpPr>
-        <p:spPr>
-          <a:xfrm xmlns:a="http://schemas.openxmlformats.org/drawingml/2006/main">
-            <a:off x="3476625" y="4829175"/>
+                <a16:creationId xmlns:a16="http://schemas.microsoft.com/office/drawing/2014/main" id="{44BFA0D1-CE29-4B8B-929F-BA81807447F7}"/>
+              </a:ext>
+            </a:extLst>
+          </p:cNvPr>
+          <p:cNvSpPr>
+            <a:spLocks xmlns:a="http://schemas.openxmlformats.org/drawingml/2006/main" noGrp="1"/>
+          </p:cNvSpPr>
+          <p:nvPr/>
+        </p:nvSpPr>
+        <p:spPr>
+          <a:xfrm xmlns:a="http://schemas.openxmlformats.org/drawingml/2006/main">
+            <a:off x="3476625" y="5010150"/>
             <a:ext cx="8105775" cy="257175"/>
           </a:xfrm>
           <a:prstGeom xmlns:a="http://schemas.openxmlformats.org/drawingml/2006/main" prst="rect">
@@ -9288,7 +9090,7 @@
                 <a:ea typeface="Arial"/>
                 <a:cs typeface="Arial"/>
               </a:rPr>
-              <a:t>KDIGO (2009); BK polyomavirus consensus (2024)</a:t>
+              <a:t>KDIGO (2009); Nankivell (2019); BK polyomavirus consensus (2024)</a:t>
             </a:r>
           </a:p>
         </p:txBody>
@@ -9298,19 +9100,19 @@
           <p:cNvPr id="12" name="">
             <a:extLst xmlns:a="http://schemas.openxmlformats.org/drawingml/2006/main">
               <a:ext uri="{FF2B5EF4-FFF2-40B4-BE49-F238E27FC236}">
-                <a16:creationId xmlns:a16="http://schemas.microsoft.com/office/drawing/2014/main" id="{1F7CD255-18FB-4FC1-A4BA-9C0887913E92}"/>
-              </a:ext>
-            </a:extLst>
-          </p:cNvPr>
-          <p:cNvSpPr>
-            <a:spLocks xmlns:a="http://schemas.openxmlformats.org/drawingml/2006/main" noGrp="1"/>
-          </p:cNvSpPr>
-          <p:nvPr/>
-        </p:nvSpPr>
-        <p:spPr>
-          <a:xfrm xmlns:a="http://schemas.openxmlformats.org/drawingml/2006/main">
-            <a:off x="609600" y="5286375"/>
-            <a:ext cx="10972800" cy="809625"/>
+                <a16:creationId xmlns:a16="http://schemas.microsoft.com/office/drawing/2014/main" id="{F38B6620-3B99-43A7-8E35-E89F674B1C23}"/>
+              </a:ext>
+            </a:extLst>
+          </p:cNvPr>
+          <p:cNvSpPr>
+            <a:spLocks xmlns:a="http://schemas.openxmlformats.org/drawingml/2006/main" noGrp="1"/>
+          </p:cNvSpPr>
+          <p:nvPr/>
+        </p:nvSpPr>
+        <p:spPr>
+          <a:xfrm xmlns:a="http://schemas.openxmlformats.org/drawingml/2006/main">
+            <a:off x="609600" y="5353050"/>
+            <a:ext cx="10972800" cy="819150"/>
           </a:xfrm>
           <a:prstGeom xmlns:a="http://schemas.openxmlformats.org/drawingml/2006/main" prst="rect">
             <a:avLst/>
@@ -9345,7 +9147,7 @@
                 <a:ea typeface="Arial"/>
                 <a:cs typeface="Arial"/>
               </a:rPr>
-              <a:t>This personal project measured agreement with recorded diagnoses.</a:t>
+              <a:t>This project has not established usefulness in ambiguous biopsies.</a:t>
             </a:r>
           </a:p>
           <a:p xmlns:a="http://schemas.openxmlformats.org/drawingml/2006/main">
@@ -9368,7 +9170,7 @@
                 <a:ea typeface="Arial"/>
                 <a:cs typeface="Arial"/>
               </a:rPr>
-              <a:t>Its value in ambiguous biopsies needs direct evaluation.</a:t>
+              <a:t>That requires comparing specialist assessment with and without RNA scores.</a:t>
             </a:r>
           </a:p>
         </p:txBody>
@@ -9376,7 +9178,7 @@
     </p:spTree>
     <p:extLst>
       <p:ext uri="{BB962C8B-B14F-4D97-AF65-F5344CB8AC3E}">
-        <p14:creationId xmlns:p14="http://schemas.microsoft.com/office/powerpoint/2010/main" val="1176125781"/>
+        <p14:creationId xmlns:p14="http://schemas.microsoft.com/office/powerpoint/2010/main" val="59722089"/>
       </p:ext>
     </p:extLst>
   </p:cSld>
@@ -9407,7 +9209,7 @@
           <p:cNvPr id="13" name="">
             <a:extLst xmlns:a="http://schemas.openxmlformats.org/drawingml/2006/main">
               <a:ext uri="{FF2B5EF4-FFF2-40B4-BE49-F238E27FC236}">
-                <a16:creationId xmlns:a16="http://schemas.microsoft.com/office/drawing/2014/main" id="{00020F42-CA4F-4C80-9CD9-5C17F15490B3}"/>
+                <a16:creationId xmlns:a16="http://schemas.microsoft.com/office/drawing/2014/main" id="{5F431C76-8A11-4C9E-AB61-4923052F290E}"/>
               </a:ext>
             </a:extLst>
           </p:cNvPr>
@@ -9464,7 +9266,7 @@
           <p:cNvPr id="2" name="">
             <a:extLst xmlns:a="http://schemas.openxmlformats.org/drawingml/2006/main">
               <a:ext uri="{FF2B5EF4-FFF2-40B4-BE49-F238E27FC236}">
-                <a16:creationId xmlns:a16="http://schemas.microsoft.com/office/drawing/2014/main" id="{A912527E-44E2-46BC-A3A1-DA74D4AE244F}"/>
+                <a16:creationId xmlns:a16="http://schemas.microsoft.com/office/drawing/2014/main" id="{C71AF8D3-3742-4D71-ADB4-7BE697D1FF41}"/>
               </a:ext>
             </a:extLst>
           </p:cNvPr>
@@ -9521,7 +9323,7 @@
           <p:cNvPr id="3" name="">
             <a:extLst xmlns:a="http://schemas.openxmlformats.org/drawingml/2006/main">
               <a:ext uri="{FF2B5EF4-FFF2-40B4-BE49-F238E27FC236}">
-                <a16:creationId xmlns:a16="http://schemas.microsoft.com/office/drawing/2014/main" id="{E11CB861-51AE-4DB7-8D00-D3F00D344237}"/>
+                <a16:creationId xmlns:a16="http://schemas.microsoft.com/office/drawing/2014/main" id="{71059A5E-51C6-4123-A0E9-B031B3410732}"/>
               </a:ext>
             </a:extLst>
           </p:cNvPr>
@@ -9578,7 +9380,7 @@
           <p:cNvPr id="4" name="">
             <a:extLst xmlns:a="http://schemas.openxmlformats.org/drawingml/2006/main">
               <a:ext uri="{FF2B5EF4-FFF2-40B4-BE49-F238E27FC236}">
-                <a16:creationId xmlns:a16="http://schemas.microsoft.com/office/drawing/2014/main" id="{7EC9A224-1053-40AD-88B0-B38F9A77FBF6}"/>
+                <a16:creationId xmlns:a16="http://schemas.microsoft.com/office/drawing/2014/main" id="{6970DC7B-E58F-45EB-BB17-897DF86B57B2}"/>
               </a:ext>
             </a:extLst>
           </p:cNvPr>
@@ -9635,7 +9437,7 @@
           <p:cNvPr id="5" name="">
             <a:extLst xmlns:a="http://schemas.openxmlformats.org/drawingml/2006/main">
               <a:ext uri="{FF2B5EF4-FFF2-40B4-BE49-F238E27FC236}">
-                <a16:creationId xmlns:a16="http://schemas.microsoft.com/office/drawing/2014/main" id="{EC1A3DEB-4856-47BF-9049-960109DAF3D8}"/>
+                <a16:creationId xmlns:a16="http://schemas.microsoft.com/office/drawing/2014/main" id="{BBF96DC9-0A9F-4F83-B308-ACE7C98219AC}"/>
               </a:ext>
             </a:extLst>
           </p:cNvPr>
@@ -9692,7 +9494,7 @@
           <p:cNvPr id="6" name="">
             <a:extLst xmlns:a="http://schemas.openxmlformats.org/drawingml/2006/main">
               <a:ext uri="{FF2B5EF4-FFF2-40B4-BE49-F238E27FC236}">
-                <a16:creationId xmlns:a16="http://schemas.microsoft.com/office/drawing/2014/main" id="{D2502894-20EC-4D60-ACBA-60CFA7585B21}"/>
+                <a16:creationId xmlns:a16="http://schemas.microsoft.com/office/drawing/2014/main" id="{BF6FAE34-481D-4D80-9908-EA81E5339E5E}"/>
               </a:ext>
             </a:extLst>
           </p:cNvPr>
@@ -10333,7 +10135,7 @@
           <p:cNvPr id="9" name="">
             <a:extLst xmlns:a="http://schemas.openxmlformats.org/drawingml/2006/main">
               <a:ext uri="{FF2B5EF4-FFF2-40B4-BE49-F238E27FC236}">
-                <a16:creationId xmlns:a16="http://schemas.microsoft.com/office/drawing/2014/main" id="{369E0FD5-63C0-4943-9912-77912EEBC511}"/>
+                <a16:creationId xmlns:a16="http://schemas.microsoft.com/office/drawing/2014/main" id="{9A247CCD-3FD6-4514-ABFC-3E7DD3613B15}"/>
               </a:ext>
             </a:extLst>
           </p:cNvPr>
@@ -10362,7 +10164,7 @@
           <p:cNvPr id="10" name="">
             <a:extLst xmlns:a="http://schemas.openxmlformats.org/drawingml/2006/main">
               <a:ext uri="{FF2B5EF4-FFF2-40B4-BE49-F238E27FC236}">
-                <a16:creationId xmlns:a16="http://schemas.microsoft.com/office/drawing/2014/main" id="{FD3ADC4E-77D7-4A5D-BB5D-082F7172BA28}"/>
+                <a16:creationId xmlns:a16="http://schemas.microsoft.com/office/drawing/2014/main" id="{598C77B8-DAE0-4583-9567-AF24558B564B}"/>
               </a:ext>
             </a:extLst>
           </p:cNvPr>
@@ -10419,7 +10221,7 @@
           <p:cNvPr id="11" name="">
             <a:extLst xmlns:a="http://schemas.openxmlformats.org/drawingml/2006/main">
               <a:ext uri="{FF2B5EF4-FFF2-40B4-BE49-F238E27FC236}">
-                <a16:creationId xmlns:a16="http://schemas.microsoft.com/office/drawing/2014/main" id="{A32BF0E6-A517-4F65-9708-7FC99A6301F0}"/>
+                <a16:creationId xmlns:a16="http://schemas.microsoft.com/office/drawing/2014/main" id="{C9D963E6-BC59-409C-9061-477D39C2358C}"/>
               </a:ext>
             </a:extLst>
           </p:cNvPr>
@@ -10476,7 +10278,7 @@
           <p:cNvPr id="12" name="">
             <a:extLst xmlns:a="http://schemas.openxmlformats.org/drawingml/2006/main">
               <a:ext uri="{FF2B5EF4-FFF2-40B4-BE49-F238E27FC236}">
-                <a16:creationId xmlns:a16="http://schemas.microsoft.com/office/drawing/2014/main" id="{6829C400-9CC7-456B-82E0-E00A97042F0F}"/>
+                <a16:creationId xmlns:a16="http://schemas.microsoft.com/office/drawing/2014/main" id="{A4FB3691-4916-414D-AAF9-D83054556C99}"/>
               </a:ext>
             </a:extLst>
           </p:cNvPr>
@@ -10562,7 +10364,7 @@
     </p:spTree>
     <p:extLst>
       <p:ext uri="{BB962C8B-B14F-4D97-AF65-F5344CB8AC3E}">
-        <p14:creationId xmlns:p14="http://schemas.microsoft.com/office/powerpoint/2010/main" val="420690078"/>
+        <p14:creationId xmlns:p14="http://schemas.microsoft.com/office/powerpoint/2010/main" val="1641302057"/>
       </p:ext>
     </p:extLst>
   </p:cSld>
@@ -10593,7 +10395,7 @@
           <p:cNvPr id="7" name="">
             <a:extLst xmlns:a="http://schemas.openxmlformats.org/drawingml/2006/main">
               <a:ext uri="{FF2B5EF4-FFF2-40B4-BE49-F238E27FC236}">
-                <a16:creationId xmlns:a16="http://schemas.microsoft.com/office/drawing/2014/main" id="{248B7970-AFAD-4D1C-8D06-7F49E914F3E6}"/>
+                <a16:creationId xmlns:a16="http://schemas.microsoft.com/office/drawing/2014/main" id="{ABC2A62F-124A-4982-9177-1729C336E399}"/>
               </a:ext>
             </a:extLst>
           </p:cNvPr>
@@ -10650,7 +10452,7 @@
           <p:cNvPr id="2" name="">
             <a:extLst xmlns:a="http://schemas.openxmlformats.org/drawingml/2006/main">
               <a:ext uri="{FF2B5EF4-FFF2-40B4-BE49-F238E27FC236}">
-                <a16:creationId xmlns:a16="http://schemas.microsoft.com/office/drawing/2014/main" id="{E7F07E5A-E1E3-4D05-80F7-8B368DBD35A8}"/>
+                <a16:creationId xmlns:a16="http://schemas.microsoft.com/office/drawing/2014/main" id="{ACA69403-A1D0-4BF0-ABA2-D1696C0A3EB8}"/>
               </a:ext>
             </a:extLst>
           </p:cNvPr>
@@ -10707,7 +10509,7 @@
           <p:cNvPr id="3" name="">
             <a:extLst xmlns:a="http://schemas.openxmlformats.org/drawingml/2006/main">
               <a:ext uri="{FF2B5EF4-FFF2-40B4-BE49-F238E27FC236}">
-                <a16:creationId xmlns:a16="http://schemas.microsoft.com/office/drawing/2014/main" id="{14B73AE0-FFDE-4B90-A3E1-A9618AA2ED0F}"/>
+                <a16:creationId xmlns:a16="http://schemas.microsoft.com/office/drawing/2014/main" id="{3E1D45C2-3D26-4395-AE54-89D96C46DCE2}"/>
               </a:ext>
             </a:extLst>
           </p:cNvPr>
@@ -10764,7 +10566,7 @@
           <p:cNvPr id="4" name="">
             <a:extLst xmlns:a="http://schemas.openxmlformats.org/drawingml/2006/main">
               <a:ext uri="{FF2B5EF4-FFF2-40B4-BE49-F238E27FC236}">
-                <a16:creationId xmlns:a16="http://schemas.microsoft.com/office/drawing/2014/main" id="{66AEE746-4D0F-4A52-93C2-E714549EEDFB}"/>
+                <a16:creationId xmlns:a16="http://schemas.microsoft.com/office/drawing/2014/main" id="{AE197FEF-73A5-4912-94C9-5B0E4E45B715}"/>
               </a:ext>
             </a:extLst>
           </p:cNvPr>
@@ -11244,7 +11046,7 @@
           <p:cNvPr id="6" name="">
             <a:extLst xmlns:a="http://schemas.openxmlformats.org/drawingml/2006/main">
               <a:ext uri="{FF2B5EF4-FFF2-40B4-BE49-F238E27FC236}">
-                <a16:creationId xmlns:a16="http://schemas.microsoft.com/office/drawing/2014/main" id="{6244E03C-C08C-4D4E-BD78-A6468A528420}"/>
+                <a16:creationId xmlns:a16="http://schemas.microsoft.com/office/drawing/2014/main" id="{B64EFF55-FEDB-4D1B-B62A-E618A5B2F290}"/>
               </a:ext>
             </a:extLst>
           </p:cNvPr>
@@ -11299,7 +11101,7 @@
     </p:spTree>
     <p:extLst>
       <p:ext uri="{BB962C8B-B14F-4D97-AF65-F5344CB8AC3E}">
-        <p14:creationId xmlns:p14="http://schemas.microsoft.com/office/powerpoint/2010/main" val="1434648340"/>
+        <p14:creationId xmlns:p14="http://schemas.microsoft.com/office/powerpoint/2010/main" val="2107203646"/>
       </p:ext>
     </p:extLst>
   </p:cSld>
@@ -11330,7 +11132,7 @@
           <p:cNvPr id="11" name="">
             <a:extLst xmlns:a="http://schemas.openxmlformats.org/drawingml/2006/main">
               <a:ext uri="{FF2B5EF4-FFF2-40B4-BE49-F238E27FC236}">
-                <a16:creationId xmlns:a16="http://schemas.microsoft.com/office/drawing/2014/main" id="{4D22231C-C958-4D64-80F8-7F63D9789E84}"/>
+                <a16:creationId xmlns:a16="http://schemas.microsoft.com/office/drawing/2014/main" id="{895F2407-C5EC-4FDE-9192-8528F4470218}"/>
               </a:ext>
             </a:extLst>
           </p:cNvPr>
@@ -11387,7 +11189,7 @@
           <p:cNvPr id="2" name="">
             <a:extLst xmlns:a="http://schemas.openxmlformats.org/drawingml/2006/main">
               <a:ext uri="{FF2B5EF4-FFF2-40B4-BE49-F238E27FC236}">
-                <a16:creationId xmlns:a16="http://schemas.microsoft.com/office/drawing/2014/main" id="{1BF2925D-1143-45DB-94F1-3F4AF56F6510}"/>
+                <a16:creationId xmlns:a16="http://schemas.microsoft.com/office/drawing/2014/main" id="{8A42B5D8-9BF7-4502-BD14-B7BD12F57DA5}"/>
               </a:ext>
             </a:extLst>
           </p:cNvPr>
@@ -11434,7 +11236,7 @@
                 <a:ea typeface="Arial"/>
                 <a:cs typeface="Arial"/>
               </a:rPr>
-              <a:t>Sources: GSE212160; B-HOT panel consensus (2020); project data contract</a:t>
+              <a:t>Sources: GSE212160; B-HOT panel consensus; NanoString analysis guidance; shared preprocessing</a:t>
             </a:r>
           </a:p>
         </p:txBody>
@@ -11444,7 +11246,7 @@
           <p:cNvPr id="3" name="">
             <a:extLst xmlns:a="http://schemas.openxmlformats.org/drawingml/2006/main">
               <a:ext uri="{FF2B5EF4-FFF2-40B4-BE49-F238E27FC236}">
-                <a16:creationId xmlns:a16="http://schemas.microsoft.com/office/drawing/2014/main" id="{82874B93-CCC5-4C56-81F4-454E8A709505}"/>
+                <a16:creationId xmlns:a16="http://schemas.microsoft.com/office/drawing/2014/main" id="{9B28A0B1-74B1-4E4E-B941-6A8A871CD72A}"/>
               </a:ext>
             </a:extLst>
           </p:cNvPr>
@@ -11501,7 +11303,7 @@
           <p:cNvPr id="4" name="">
             <a:extLst xmlns:a="http://schemas.openxmlformats.org/drawingml/2006/main">
               <a:ext uri="{FF2B5EF4-FFF2-40B4-BE49-F238E27FC236}">
-                <a16:creationId xmlns:a16="http://schemas.microsoft.com/office/drawing/2014/main" id="{1507FF61-6211-4750-A9ED-8346E49E5D38}"/>
+                <a16:creationId xmlns:a16="http://schemas.microsoft.com/office/drawing/2014/main" id="{2897DC9E-6EFA-4C3F-AE85-FE11B47A84C5}"/>
               </a:ext>
             </a:extLst>
           </p:cNvPr>
@@ -11558,19 +11360,19 @@
           <p:cNvPr id="5" name="">
             <a:extLst xmlns:a="http://schemas.openxmlformats.org/drawingml/2006/main">
               <a:ext uri="{FF2B5EF4-FFF2-40B4-BE49-F238E27FC236}">
-                <a16:creationId xmlns:a16="http://schemas.microsoft.com/office/drawing/2014/main" id="{2428D108-5306-49A5-B16E-F45D4A435668}"/>
-              </a:ext>
-            </a:extLst>
-          </p:cNvPr>
-          <p:cNvSpPr>
-            <a:spLocks xmlns:a="http://schemas.openxmlformats.org/drawingml/2006/main" noGrp="1"/>
-          </p:cNvSpPr>
-          <p:nvPr/>
-        </p:nvSpPr>
-        <p:spPr>
-          <a:xfrm xmlns:a="http://schemas.openxmlformats.org/drawingml/2006/main">
-            <a:off x="609600" y="2714625"/>
-            <a:ext cx="5095875" cy="762000"/>
+                <a16:creationId xmlns:a16="http://schemas.microsoft.com/office/drawing/2014/main" id="{078CCC6C-7B57-4EAE-AC99-98A2DBD13CD8}"/>
+              </a:ext>
+            </a:extLst>
+          </p:cNvPr>
+          <p:cNvSpPr>
+            <a:spLocks xmlns:a="http://schemas.openxmlformats.org/drawingml/2006/main" noGrp="1"/>
+          </p:cNvSpPr>
+          <p:nvPr/>
+        </p:nvSpPr>
+        <p:spPr>
+          <a:xfrm xmlns:a="http://schemas.openxmlformats.org/drawingml/2006/main">
+            <a:off x="609600" y="2562225"/>
+            <a:ext cx="5095875" cy="666750"/>
           </a:xfrm>
           <a:prstGeom xmlns:a="http://schemas.openxmlformats.org/drawingml/2006/main" prst="rect">
             <a:avLst/>
@@ -11615,18 +11417,18 @@
           <p:cNvPr id="6" name="">
             <a:extLst xmlns:a="http://schemas.openxmlformats.org/drawingml/2006/main">
               <a:ext uri="{FF2B5EF4-FFF2-40B4-BE49-F238E27FC236}">
-                <a16:creationId xmlns:a16="http://schemas.microsoft.com/office/drawing/2014/main" id="{0B75DA7B-6CA3-4B62-BEA3-BDC08EED5DD3}"/>
-              </a:ext>
-            </a:extLst>
-          </p:cNvPr>
-          <p:cNvSpPr>
-            <a:spLocks xmlns:a="http://schemas.openxmlformats.org/drawingml/2006/main" noGrp="1"/>
-          </p:cNvSpPr>
-          <p:nvPr/>
-        </p:nvSpPr>
-        <p:spPr>
-          <a:xfrm xmlns:a="http://schemas.openxmlformats.org/drawingml/2006/main">
-            <a:off x="609600" y="3514725"/>
+                <a16:creationId xmlns:a16="http://schemas.microsoft.com/office/drawing/2014/main" id="{94906B19-AFE7-46C8-AF9F-A577961D681B}"/>
+              </a:ext>
+            </a:extLst>
+          </p:cNvPr>
+          <p:cNvSpPr>
+            <a:spLocks xmlns:a="http://schemas.openxmlformats.org/drawingml/2006/main" noGrp="1"/>
+          </p:cNvSpPr>
+          <p:nvPr/>
+        </p:nvSpPr>
+        <p:spPr>
+          <a:xfrm xmlns:a="http://schemas.openxmlformats.org/drawingml/2006/main">
+            <a:off x="609600" y="3343275"/>
             <a:ext cx="5095875" cy="466725"/>
           </a:xfrm>
           <a:prstGeom xmlns:a="http://schemas.openxmlformats.org/drawingml/2006/main" prst="rect">
@@ -11672,19 +11474,19 @@
           <p:cNvPr id="7" name="">
             <a:extLst xmlns:a="http://schemas.openxmlformats.org/drawingml/2006/main">
               <a:ext uri="{FF2B5EF4-FFF2-40B4-BE49-F238E27FC236}">
-                <a16:creationId xmlns:a16="http://schemas.microsoft.com/office/drawing/2014/main" id="{925F36B8-D646-40DE-B168-B0630C798B52}"/>
-              </a:ext>
-            </a:extLst>
-          </p:cNvPr>
-          <p:cNvSpPr>
-            <a:spLocks xmlns:a="http://schemas.openxmlformats.org/drawingml/2006/main" noGrp="1"/>
-          </p:cNvSpPr>
-          <p:nvPr/>
-        </p:nvSpPr>
-        <p:spPr>
-          <a:xfrm xmlns:a="http://schemas.openxmlformats.org/drawingml/2006/main">
-            <a:off x="609600" y="4095750"/>
-            <a:ext cx="5143500" cy="1905000"/>
+                <a16:creationId xmlns:a16="http://schemas.microsoft.com/office/drawing/2014/main" id="{B38A6DA1-9F2D-4608-8FC1-A9A643A7D19E}"/>
+              </a:ext>
+            </a:extLst>
+          </p:cNvPr>
+          <p:cNvSpPr>
+            <a:spLocks xmlns:a="http://schemas.openxmlformats.org/drawingml/2006/main" noGrp="1"/>
+          </p:cNvSpPr>
+          <p:nvPr/>
+        </p:nvSpPr>
+        <p:spPr>
+          <a:xfrm xmlns:a="http://schemas.openxmlformats.org/drawingml/2006/main">
+            <a:off x="609600" y="3905250"/>
+            <a:ext cx="5143500" cy="2228850"/>
           </a:xfrm>
           <a:prstGeom xmlns:a="http://schemas.openxmlformats.org/drawingml/2006/main" prst="rect">
             <a:avLst/>
@@ -11702,7 +11504,7 @@
           <a:p xmlns:a="http://schemas.openxmlformats.org/drawingml/2006/main">
             <a:pPr marL="279400" indent="-152400" algn="l">
               <a:spcAft>
-                <a:spcPts val="1200"/>
+                <a:spcPts val="1000"/>
               </a:spcAft>
               <a:buChar char="•"/>
               <a:defRPr sz="2175" b="0">
@@ -11723,13 +11525,13 @@
                 <a:ea typeface="Arial"/>
                 <a:cs typeface="Arial"/>
               </a:rPr>
-              <a:t>Include human and viral RNA.</a:t>
+              <a:t>Selected human and viral RNA measurements.</a:t>
             </a:r>
           </a:p>
           <a:p xmlns:a="http://schemas.openxmlformats.org/drawingml/2006/main">
             <a:pPr marL="279400" indent="-152400" algn="l">
               <a:spcAft>
-                <a:spcPts val="1200"/>
+                <a:spcPts val="1000"/>
               </a:spcAft>
               <a:buChar char="•"/>
               <a:defRPr sz="2175" b="0">
@@ -11750,7 +11552,34 @@
                 <a:ea typeface="Arial"/>
                 <a:cs typeface="Arial"/>
               </a:rPr>
-              <a:t>Signals depend on gene activity and the cell mixture.</a:t>
+              <a:t>Signals reflect gene activity and the mixture of cells in the biopsy.</a:t>
+            </a:r>
+          </a:p>
+          <a:p xmlns:a="http://schemas.openxmlformats.org/drawingml/2006/main">
+            <a:pPr marL="279400" indent="-152400" algn="l">
+              <a:spcAft>
+                <a:spcPts val="1000"/>
+              </a:spcAft>
+              <a:buChar char="•"/>
+              <a:defRPr sz="2175" b="0">
+                <a:solidFill>
+                  <a:srgbClr val="16343E"/>
+                </a:solidFill>
+                <a:latin typeface="Arial"/>
+                <a:ea typeface="Arial"/>
+                <a:cs typeface="Arial"/>
+              </a:defRPr>
+            </a:pPr>
+            <a:r>
+              <a:rPr sz="2175" b="0">
+                <a:solidFill>
+                  <a:srgbClr val="16343E"/>
+                </a:solidFill>
+                <a:latin typeface="Arial"/>
+                <a:ea typeface="Arial"/>
+                <a:cs typeface="Arial"/>
+              </a:rPr>
+              <a:t>Normalized values become the model’s inputs.</a:t>
             </a:r>
           </a:p>
         </p:txBody>
@@ -11760,19 +11589,19 @@
           <p:cNvPr id="8" name="">
             <a:extLst xmlns:a="http://schemas.openxmlformats.org/drawingml/2006/main">
               <a:ext uri="{FF2B5EF4-FFF2-40B4-BE49-F238E27FC236}">
-                <a16:creationId xmlns:a16="http://schemas.microsoft.com/office/drawing/2014/main" id="{1964515F-62FD-4055-AECD-ECCB87DE5E9F}"/>
-              </a:ext>
-            </a:extLst>
-          </p:cNvPr>
-          <p:cNvSpPr>
-            <a:spLocks xmlns:a="http://schemas.openxmlformats.org/drawingml/2006/main" noGrp="1"/>
-          </p:cNvSpPr>
-          <p:nvPr/>
-        </p:nvSpPr>
-        <p:spPr>
-          <a:xfrm xmlns:a="http://schemas.openxmlformats.org/drawingml/2006/main">
-            <a:off x="6543675" y="2714625"/>
-            <a:ext cx="5038725" cy="762000"/>
+                <a16:creationId xmlns:a16="http://schemas.microsoft.com/office/drawing/2014/main" id="{332AC095-E167-4DE8-A1DB-489C1506B251}"/>
+              </a:ext>
+            </a:extLst>
+          </p:cNvPr>
+          <p:cNvSpPr>
+            <a:spLocks xmlns:a="http://schemas.openxmlformats.org/drawingml/2006/main" noGrp="1"/>
+          </p:cNvSpPr>
+          <p:nvPr/>
+        </p:nvSpPr>
+        <p:spPr>
+          <a:xfrm xmlns:a="http://schemas.openxmlformats.org/drawingml/2006/main">
+            <a:off x="6543675" y="2562225"/>
+            <a:ext cx="5038725" cy="666750"/>
           </a:xfrm>
           <a:prstGeom xmlns:a="http://schemas.openxmlformats.org/drawingml/2006/main" prst="rect">
             <a:avLst/>
@@ -11817,18 +11646,18 @@
           <p:cNvPr id="9" name="">
             <a:extLst xmlns:a="http://schemas.openxmlformats.org/drawingml/2006/main">
               <a:ext uri="{FF2B5EF4-FFF2-40B4-BE49-F238E27FC236}">
-                <a16:creationId xmlns:a16="http://schemas.microsoft.com/office/drawing/2014/main" id="{EBC3049B-DC8A-438B-B0C2-F6F43AF2FF32}"/>
-              </a:ext>
-            </a:extLst>
-          </p:cNvPr>
-          <p:cNvSpPr>
-            <a:spLocks xmlns:a="http://schemas.openxmlformats.org/drawingml/2006/main" noGrp="1"/>
-          </p:cNvSpPr>
-          <p:nvPr/>
-        </p:nvSpPr>
-        <p:spPr>
-          <a:xfrm xmlns:a="http://schemas.openxmlformats.org/drawingml/2006/main">
-            <a:off x="6543675" y="3514725"/>
+                <a16:creationId xmlns:a16="http://schemas.microsoft.com/office/drawing/2014/main" id="{2DB963A7-5719-49A6-BEBB-CCD1A19DCB05}"/>
+              </a:ext>
+            </a:extLst>
+          </p:cNvPr>
+          <p:cNvSpPr>
+            <a:spLocks xmlns:a="http://schemas.openxmlformats.org/drawingml/2006/main" noGrp="1"/>
+          </p:cNvSpPr>
+          <p:nvPr/>
+        </p:nvSpPr>
+        <p:spPr>
+          <a:xfrm xmlns:a="http://schemas.openxmlformats.org/drawingml/2006/main">
+            <a:off x="6543675" y="3343275"/>
             <a:ext cx="5038725" cy="466725"/>
           </a:xfrm>
           <a:prstGeom xmlns:a="http://schemas.openxmlformats.org/drawingml/2006/main" prst="rect">
@@ -11874,19 +11703,19 @@
           <p:cNvPr id="10" name="">
             <a:extLst xmlns:a="http://schemas.openxmlformats.org/drawingml/2006/main">
               <a:ext uri="{FF2B5EF4-FFF2-40B4-BE49-F238E27FC236}">
-                <a16:creationId xmlns:a16="http://schemas.microsoft.com/office/drawing/2014/main" id="{5FDA88FA-124F-416B-8F86-59B0303C0323}"/>
-              </a:ext>
-            </a:extLst>
-          </p:cNvPr>
-          <p:cNvSpPr>
-            <a:spLocks xmlns:a="http://schemas.openxmlformats.org/drawingml/2006/main" noGrp="1"/>
-          </p:cNvSpPr>
-          <p:nvPr/>
-        </p:nvSpPr>
-        <p:spPr>
-          <a:xfrm xmlns:a="http://schemas.openxmlformats.org/drawingml/2006/main">
-            <a:off x="6543675" y="4095750"/>
-            <a:ext cx="5038725" cy="1905000"/>
+                <a16:creationId xmlns:a16="http://schemas.microsoft.com/office/drawing/2014/main" id="{786DAC70-0981-4B06-8437-61A4F5BB780F}"/>
+              </a:ext>
+            </a:extLst>
+          </p:cNvPr>
+          <p:cNvSpPr>
+            <a:spLocks xmlns:a="http://schemas.openxmlformats.org/drawingml/2006/main" noGrp="1"/>
+          </p:cNvSpPr>
+          <p:nvPr/>
+        </p:nvSpPr>
+        <p:spPr>
+          <a:xfrm xmlns:a="http://schemas.openxmlformats.org/drawingml/2006/main">
+            <a:off x="6543675" y="3905250"/>
+            <a:ext cx="5038725" cy="2228850"/>
           </a:xfrm>
           <a:prstGeom xmlns:a="http://schemas.openxmlformats.org/drawingml/2006/main" prst="rect">
             <a:avLst/>
@@ -11904,7 +11733,7 @@
           <a:p xmlns:a="http://schemas.openxmlformats.org/drawingml/2006/main">
             <a:pPr marL="279400" indent="-152400" algn="l">
               <a:spcAft>
-                <a:spcPts val="1200"/>
+                <a:spcPts val="1000"/>
               </a:spcAft>
               <a:buChar char="•"/>
               <a:defRPr sz="2175" b="0">
@@ -11925,13 +11754,13 @@
                 <a:ea typeface="Arial"/>
                 <a:cs typeface="Arial"/>
               </a:rPr>
-              <a:t>12 different reference RNAs.</a:t>
+              <a:t>Relatively stable RNAs provide a reference for each specimen.</a:t>
             </a:r>
           </a:p>
           <a:p xmlns:a="http://schemas.openxmlformats.org/drawingml/2006/main">
             <a:pPr marL="279400" indent="-152400" algn="l">
               <a:spcAft>
-                <a:spcPts val="1200"/>
+                <a:spcPts val="1000"/>
               </a:spcAft>
               <a:buChar char="•"/>
               <a:defRPr sz="2175" b="0">
@@ -11952,7 +11781,34 @@
                 <a:ea typeface="Arial"/>
                 <a:cs typeface="Arial"/>
               </a:rPr>
-              <a:t>Used to adjust for differences in how much RNA each specimen supplies.</a:t>
+              <a:t>Help adjust for differences in overall measurable RNA input.</a:t>
+            </a:r>
+          </a:p>
+          <a:p xmlns:a="http://schemas.openxmlformats.org/drawingml/2006/main">
+            <a:pPr marL="279400" indent="-152400" algn="l">
+              <a:spcAft>
+                <a:spcPts val="1000"/>
+              </a:spcAft>
+              <a:buChar char="•"/>
+              <a:defRPr sz="2175" b="0">
+                <a:solidFill>
+                  <a:srgbClr val="16343E"/>
+                </a:solidFill>
+                <a:latin typeface="Arial"/>
+                <a:ea typeface="Arial"/>
+                <a:cs typeface="Arial"/>
+              </a:defRPr>
+            </a:pPr>
+            <a:r>
+              <a:rPr sz="2175" b="0">
+                <a:solidFill>
+                  <a:srgbClr val="16343E"/>
+                </a:solidFill>
+                <a:latin typeface="Arial"/>
+                <a:ea typeface="Arial"/>
+                <a:cs typeface="Arial"/>
+              </a:rPr>
+              <a:t>Used for normalization, then excluded from the model.</a:t>
             </a:r>
           </a:p>
         </p:txBody>
@@ -11960,7 +11816,7 @@
     </p:spTree>
     <p:extLst>
       <p:ext uri="{BB962C8B-B14F-4D97-AF65-F5344CB8AC3E}">
-        <p14:creationId xmlns:p14="http://schemas.microsoft.com/office/powerpoint/2010/main" val="1869026119"/>
+        <p14:creationId xmlns:p14="http://schemas.microsoft.com/office/powerpoint/2010/main" val="1033048387"/>
       </p:ext>
     </p:extLst>
   </p:cSld>
@@ -11991,7 +11847,7 @@
           <p:cNvPr id="5" name="">
             <a:extLst xmlns:a="http://schemas.openxmlformats.org/drawingml/2006/main">
               <a:ext uri="{FF2B5EF4-FFF2-40B4-BE49-F238E27FC236}">
-                <a16:creationId xmlns:a16="http://schemas.microsoft.com/office/drawing/2014/main" id="{3883DE41-3A9C-4BE1-AD00-B8A113D8686E}"/>
+                <a16:creationId xmlns:a16="http://schemas.microsoft.com/office/drawing/2014/main" id="{E88295D8-984F-4704-A828-A9D3DD060E24}"/>
               </a:ext>
             </a:extLst>
           </p:cNvPr>
@@ -12048,7 +11904,7 @@
           <p:cNvPr id="2" name="">
             <a:extLst xmlns:a="http://schemas.openxmlformats.org/drawingml/2006/main">
               <a:ext uri="{FF2B5EF4-FFF2-40B4-BE49-F238E27FC236}">
-                <a16:creationId xmlns:a16="http://schemas.microsoft.com/office/drawing/2014/main" id="{A8FA5CF4-8E98-4162-9E6B-9FEC54B8BDA8}"/>
+                <a16:creationId xmlns:a16="http://schemas.microsoft.com/office/drawing/2014/main" id="{3DB20259-434D-4901-981A-C74AB6ACC771}"/>
               </a:ext>
             </a:extLst>
           </p:cNvPr>
@@ -12105,7 +11961,7 @@
           <p:cNvPr id="3" name="">
             <a:extLst xmlns:a="http://schemas.openxmlformats.org/drawingml/2006/main">
               <a:ext uri="{FF2B5EF4-FFF2-40B4-BE49-F238E27FC236}">
-                <a16:creationId xmlns:a16="http://schemas.microsoft.com/office/drawing/2014/main" id="{FF239E75-3533-4080-AAA5-A3F6C72D8FA9}"/>
+                <a16:creationId xmlns:a16="http://schemas.microsoft.com/office/drawing/2014/main" id="{5A210E71-392A-4528-B030-FF235C1F46D9}"/>
               </a:ext>
             </a:extLst>
           </p:cNvPr>
@@ -12452,7 +12308,7 @@
     </p:spTree>
     <p:extLst>
       <p:ext uri="{BB962C8B-B14F-4D97-AF65-F5344CB8AC3E}">
-        <p14:creationId xmlns:p14="http://schemas.microsoft.com/office/powerpoint/2010/main" val="246310504"/>
+        <p14:creationId xmlns:p14="http://schemas.microsoft.com/office/powerpoint/2010/main" val="852904421"/>
       </p:ext>
     </p:extLst>
   </p:cSld>
@@ -12483,7 +12339,7 @@
           <p:cNvPr id="11" name="">
             <a:extLst xmlns:a="http://schemas.openxmlformats.org/drawingml/2006/main">
               <a:ext uri="{FF2B5EF4-FFF2-40B4-BE49-F238E27FC236}">
-                <a16:creationId xmlns:a16="http://schemas.microsoft.com/office/drawing/2014/main" id="{95AE2A46-412E-4DF4-95BD-FB1B7D0D0BA4}"/>
+                <a16:creationId xmlns:a16="http://schemas.microsoft.com/office/drawing/2014/main" id="{2962AE36-99C5-4042-88B7-E358FE895E9E}"/>
               </a:ext>
             </a:extLst>
           </p:cNvPr>
@@ -12540,7 +12396,7 @@
           <p:cNvPr id="2" name="">
             <a:extLst xmlns:a="http://schemas.openxmlformats.org/drawingml/2006/main">
               <a:ext uri="{FF2B5EF4-FFF2-40B4-BE49-F238E27FC236}">
-                <a16:creationId xmlns:a16="http://schemas.microsoft.com/office/drawing/2014/main" id="{C2E1DF07-998E-4A0A-9473-874BA019A2CB}"/>
+                <a16:creationId xmlns:a16="http://schemas.microsoft.com/office/drawing/2014/main" id="{ED5CCE2E-DF3C-4B0E-BA7C-1F1360B5AE11}"/>
               </a:ext>
             </a:extLst>
           </p:cNvPr>
@@ -12597,7 +12453,7 @@
           <p:cNvPr id="3" name="">
             <a:extLst xmlns:a="http://schemas.openxmlformats.org/drawingml/2006/main">
               <a:ext uri="{FF2B5EF4-FFF2-40B4-BE49-F238E27FC236}">
-                <a16:creationId xmlns:a16="http://schemas.microsoft.com/office/drawing/2014/main" id="{298ECCE5-885A-4434-98BF-FFF5139C52CA}"/>
+                <a16:creationId xmlns:a16="http://schemas.microsoft.com/office/drawing/2014/main" id="{61FB976A-EA03-4A73-A040-CDB5117AB436}"/>
               </a:ext>
             </a:extLst>
           </p:cNvPr>
@@ -12654,7 +12510,7 @@
           <p:cNvPr id="4" name="">
             <a:extLst xmlns:a="http://schemas.openxmlformats.org/drawingml/2006/main">
               <a:ext uri="{FF2B5EF4-FFF2-40B4-BE49-F238E27FC236}">
-                <a16:creationId xmlns:a16="http://schemas.microsoft.com/office/drawing/2014/main" id="{9D3F93CA-E462-40BC-8267-F2885B1D550C}"/>
+                <a16:creationId xmlns:a16="http://schemas.microsoft.com/office/drawing/2014/main" id="{7A6D0B42-0555-48BB-AFE8-454F72AC73DB}"/>
               </a:ext>
             </a:extLst>
           </p:cNvPr>
@@ -12742,7 +12598,7 @@
           <p:cNvPr id="5" name="">
             <a:extLst xmlns:a="http://schemas.openxmlformats.org/drawingml/2006/main">
               <a:ext uri="{FF2B5EF4-FFF2-40B4-BE49-F238E27FC236}">
-                <a16:creationId xmlns:a16="http://schemas.microsoft.com/office/drawing/2014/main" id="{56ED884B-C8E5-4A34-99E4-0B2E9FAFC447}"/>
+                <a16:creationId xmlns:a16="http://schemas.microsoft.com/office/drawing/2014/main" id="{102B869A-26A4-4246-AB7C-7F3462ED3F50}"/>
               </a:ext>
             </a:extLst>
           </p:cNvPr>
@@ -12826,7 +12682,7 @@
           <p:cNvPr id="6" name="">
             <a:extLst xmlns:a="http://schemas.openxmlformats.org/drawingml/2006/main">
               <a:ext uri="{FF2B5EF4-FFF2-40B4-BE49-F238E27FC236}">
-                <a16:creationId xmlns:a16="http://schemas.microsoft.com/office/drawing/2014/main" id="{4F585DF6-D350-4118-8D35-D660AF708CC6}"/>
+                <a16:creationId xmlns:a16="http://schemas.microsoft.com/office/drawing/2014/main" id="{C8DA0ABD-77D3-4B29-880B-73EA4818E2EE}"/>
               </a:ext>
             </a:extLst>
           </p:cNvPr>
@@ -12910,7 +12766,7 @@
           <p:cNvPr id="7" name="">
             <a:extLst xmlns:a="http://schemas.openxmlformats.org/drawingml/2006/main">
               <a:ext uri="{FF2B5EF4-FFF2-40B4-BE49-F238E27FC236}">
-                <a16:creationId xmlns:a16="http://schemas.microsoft.com/office/drawing/2014/main" id="{C240F3AD-77AB-49B5-A490-98E0C828D60C}"/>
+                <a16:creationId xmlns:a16="http://schemas.microsoft.com/office/drawing/2014/main" id="{62225C69-C1FD-4B90-AA82-BD514B8D2C9B}"/>
               </a:ext>
             </a:extLst>
           </p:cNvPr>
@@ -13050,7 +12906,7 @@
           <p:cNvPr id="10" name="">
             <a:extLst xmlns:a="http://schemas.openxmlformats.org/drawingml/2006/main">
               <a:ext uri="{FF2B5EF4-FFF2-40B4-BE49-F238E27FC236}">
-                <a16:creationId xmlns:a16="http://schemas.microsoft.com/office/drawing/2014/main" id="{355570F7-854D-4319-881C-3390639647B6}"/>
+                <a16:creationId xmlns:a16="http://schemas.microsoft.com/office/drawing/2014/main" id="{788EF9B9-ACE8-43D8-9CE2-C3F2892627AD}"/>
               </a:ext>
             </a:extLst>
           </p:cNvPr>
@@ -13183,7 +13039,7 @@
     </p:spTree>
     <p:extLst>
       <p:ext uri="{BB962C8B-B14F-4D97-AF65-F5344CB8AC3E}">
-        <p14:creationId xmlns:p14="http://schemas.microsoft.com/office/powerpoint/2010/main" val="203996891"/>
+        <p14:creationId xmlns:p14="http://schemas.microsoft.com/office/powerpoint/2010/main" val="1757600718"/>
       </p:ext>
     </p:extLst>
   </p:cSld>

</xml_diff>

<commit_message>
Reframe project purpose and clarify classifier selection evidence
</commit_message>
<xml_diff>
--- a/presentation/unos_kidney_biopsy.pptx
+++ b/presentation/unos_kidney_biopsy.pptx
@@ -2,28 +2,28 @@
 <file path=ppt/presentation.xml><?xml version="1.0" encoding="utf-8"?>
 <p:presentation xmlns:p="http://schemas.openxmlformats.org/presentationml/2006/main" xmlns:r="http://schemas.openxmlformats.org/officeDocument/2006/relationships">
   <p:sldMasterIdLst>
-    <p:sldMasterId id="2147483648" r:id="R2f5593aa621b4e14"/>
+    <p:sldMasterId id="2147483648" r:id="R50ca9ad9fd284fea"/>
   </p:sldMasterIdLst>
   <p:sldIdLst>
-    <p:sldId id="256" r:id="R6af083f13c514270"/>
-    <p:sldId id="257" r:id="Rd2005c56bab44848"/>
-    <p:sldId id="258" r:id="R575f649317514e6d"/>
-    <p:sldId id="259" r:id="R5c78b9f69e99416c"/>
-    <p:sldId id="260" r:id="R3396020e0e3b4607"/>
-    <p:sldId id="261" r:id="Rde80d4debbc44634"/>
-    <p:sldId id="262" r:id="R28bc347e9b5f45d1"/>
-    <p:sldId id="263" r:id="Raf5f8eb1951f48d4"/>
-    <p:sldId id="264" r:id="R559de7d27ecd4ee4"/>
-    <p:sldId id="265" r:id="R462996b1044b4b66"/>
-    <p:sldId id="266" r:id="R6d1caee9d2924780"/>
-    <p:sldId id="267" r:id="R333a4931b4c04fd4"/>
-    <p:sldId id="268" r:id="R1deb519cb37446a0"/>
-    <p:sldId id="269" r:id="R8982a2c4a3254457"/>
-    <p:sldId id="270" r:id="R9e1c7f4126a94010"/>
-    <p:sldId id="271" r:id="Rcb9a468b62614145"/>
-    <p:sldId id="272" r:id="Re28cc3ae880c4886"/>
-    <p:sldId id="273" r:id="Rd0ffb4a6e6384feb"/>
-    <p:sldId id="274" r:id="R27da1c5114c646c2"/>
+    <p:sldId id="256" r:id="Re7db7bb8a46d4b32"/>
+    <p:sldId id="257" r:id="R4f968604d946492e"/>
+    <p:sldId id="258" r:id="R34c49a3e23a94722"/>
+    <p:sldId id="259" r:id="R686d18927feb48d7"/>
+    <p:sldId id="260" r:id="R565c92036ba34a91"/>
+    <p:sldId id="261" r:id="R6b3df11763304d4a"/>
+    <p:sldId id="262" r:id="R849d321994f741aa"/>
+    <p:sldId id="263" r:id="Rbffebd4ea35540dc"/>
+    <p:sldId id="264" r:id="Rdc77cf83ba53449c"/>
+    <p:sldId id="265" r:id="Rd128ef0c147642eb"/>
+    <p:sldId id="266" r:id="R67e2eab437f2424e"/>
+    <p:sldId id="267" r:id="R900c6fba1bbe4bbf"/>
+    <p:sldId id="268" r:id="Rf0112f79d9cb419d"/>
+    <p:sldId id="269" r:id="R358fd6ca706044ea"/>
+    <p:sldId id="270" r:id="R4f95177ecd4b45b9"/>
+    <p:sldId id="271" r:id="R6136032f43d2435b"/>
+    <p:sldId id="272" r:id="Rbedbe09b8c514403"/>
+    <p:sldId id="273" r:id="Rd0dfdfa4a6284704"/>
+    <p:sldId id="274" r:id="Reb36b179ad554ac2"/>
   </p:sldIdLst>
   <p:sldSz cx="12192000" cy="6858000"/>
   <p:notesSz cx="6858000" cy="9144000"/>
@@ -68,7 +68,7 @@
   </p:cSld>
   <p:clrMap bg1="lt1" tx1="dk1" bg2="lt2" tx2="dk2" accent1="accent1" accent2="accent2" accent3="accent3" accent4="accent4" accent5="accent5" accent6="accent6" hlink="hlink" folHlink="folHlink"/>
   <p:sldLayoutIdLst>
-    <p:sldLayoutId xmlns:r="http://schemas.openxmlformats.org/officeDocument/2006/relationships" id="2147483649" r:id="R810f935cb2bb4b05"/>
+    <p:sldLayoutId xmlns:r="http://schemas.openxmlformats.org/officeDocument/2006/relationships" id="2147483649" r:id="Rebdb733dc8284093"/>
   </p:sldLayoutIdLst>
   <p:txStyles>
     <p:titleStyle>
@@ -876,7 +876,7 @@
           <p:cNvPr id="2" name="">
             <a:extLst xmlns:a="http://schemas.openxmlformats.org/drawingml/2006/main">
               <a:ext uri="{FF2B5EF4-FFF2-40B4-BE49-F238E27FC236}">
-                <a16:creationId xmlns:a16="http://schemas.microsoft.com/office/drawing/2014/main" id="{BDFC2154-D641-48E7-BA1B-E292A3CFF361}"/>
+                <a16:creationId xmlns:a16="http://schemas.microsoft.com/office/drawing/2014/main" id="{9FB5ED01-E630-46ED-8609-55A3E6A3FD72}"/>
               </a:ext>
             </a:extLst>
           </p:cNvPr>
@@ -977,7 +977,7 @@
     </p:spTree>
     <p:extLst>
       <p:ext uri="{BB962C8B-B14F-4D97-AF65-F5344CB8AC3E}">
-        <p14:creationId xmlns:p14="http://schemas.microsoft.com/office/powerpoint/2010/main" val="1031283710"/>
+        <p14:creationId xmlns:p14="http://schemas.microsoft.com/office/powerpoint/2010/main" val="654429306"/>
       </p:ext>
     </p:extLst>
   </p:cSld>
@@ -1008,7 +1008,7 @@
           <p:cNvPr id="6" name="">
             <a:extLst xmlns:a="http://schemas.openxmlformats.org/drawingml/2006/main">
               <a:ext uri="{FF2B5EF4-FFF2-40B4-BE49-F238E27FC236}">
-                <a16:creationId xmlns:a16="http://schemas.microsoft.com/office/drawing/2014/main" id="{0685FF4D-AFA1-41AC-8672-6378914C5B6A}"/>
+                <a16:creationId xmlns:a16="http://schemas.microsoft.com/office/drawing/2014/main" id="{5468FA2C-109C-47F4-9CD6-6E2820246E98}"/>
               </a:ext>
             </a:extLst>
           </p:cNvPr>
@@ -1065,7 +1065,7 @@
           <p:cNvPr id="2" name="">
             <a:extLst xmlns:a="http://schemas.openxmlformats.org/drawingml/2006/main">
               <a:ext uri="{FF2B5EF4-FFF2-40B4-BE49-F238E27FC236}">
-                <a16:creationId xmlns:a16="http://schemas.microsoft.com/office/drawing/2014/main" id="{51BE201A-DE25-4482-8E99-A5EE8FF5B835}"/>
+                <a16:creationId xmlns:a16="http://schemas.microsoft.com/office/drawing/2014/main" id="{C9BE6A94-DB81-4337-A21E-DA2A0845D098}"/>
               </a:ext>
             </a:extLst>
           </p:cNvPr>
@@ -1122,7 +1122,7 @@
           <p:cNvPr id="3" name="">
             <a:extLst xmlns:a="http://schemas.openxmlformats.org/drawingml/2006/main">
               <a:ext uri="{FF2B5EF4-FFF2-40B4-BE49-F238E27FC236}">
-                <a16:creationId xmlns:a16="http://schemas.microsoft.com/office/drawing/2014/main" id="{CDBCBFE4-EFF9-4C14-999F-39D0DD82A92F}"/>
+                <a16:creationId xmlns:a16="http://schemas.microsoft.com/office/drawing/2014/main" id="{796E94DA-7751-4EBF-8D09-FE46C0AF2937}"/>
               </a:ext>
             </a:extLst>
           </p:cNvPr>
@@ -1179,7 +1179,7 @@
           <p:cNvPr id="4" name="">
             <a:extLst xmlns:a="http://schemas.openxmlformats.org/drawingml/2006/main">
               <a:ext uri="{FF2B5EF4-FFF2-40B4-BE49-F238E27FC236}">
-                <a16:creationId xmlns:a16="http://schemas.microsoft.com/office/drawing/2014/main" id="{81C3F490-88C3-4E43-BDC9-80FAF95AD15C}"/>
+                <a16:creationId xmlns:a16="http://schemas.microsoft.com/office/drawing/2014/main" id="{05FA872B-10F4-4533-A9CB-69885B13390A}"/>
               </a:ext>
             </a:extLst>
           </p:cNvPr>
@@ -1591,7 +1591,7 @@
     </p:spTree>
     <p:extLst>
       <p:ext uri="{BB962C8B-B14F-4D97-AF65-F5344CB8AC3E}">
-        <p14:creationId xmlns:p14="http://schemas.microsoft.com/office/powerpoint/2010/main" val="182769313"/>
+        <p14:creationId xmlns:p14="http://schemas.microsoft.com/office/powerpoint/2010/main" val="1497333713"/>
       </p:ext>
     </p:extLst>
   </p:cSld>
@@ -1619,10 +1619,10 @@
       </p:grpSpPr>
       <p:sp>
         <p:nvSpPr>
-          <p:cNvPr id="16" name="">
-            <a:extLst xmlns:a="http://schemas.openxmlformats.org/drawingml/2006/main">
-              <a:ext uri="{FF2B5EF4-FFF2-40B4-BE49-F238E27FC236}">
-                <a16:creationId xmlns:a16="http://schemas.microsoft.com/office/drawing/2014/main" id="{8FF86D79-7813-4009-BDA3-25DB380A239A}"/>
+          <p:cNvPr id="17" name="">
+            <a:extLst xmlns:a="http://schemas.openxmlformats.org/drawingml/2006/main">
+              <a:ext uri="{FF2B5EF4-FFF2-40B4-BE49-F238E27FC236}">
+                <a16:creationId xmlns:a16="http://schemas.microsoft.com/office/drawing/2014/main" id="{2F9D1339-B69F-47AD-9B8B-E164306A21BA}"/>
               </a:ext>
             </a:extLst>
           </p:cNvPr>
@@ -1669,7 +1669,7 @@
                 <a:ea typeface="Arial"/>
                 <a:cs typeface="Arial"/>
               </a:rPr>
-              <a:t>Choosing a rejection threshold</a:t>
+              <a:t>Selecting the model and threshold</a:t>
             </a:r>
           </a:p>
         </p:txBody>
@@ -1679,7 +1679,7 @@
           <p:cNvPr id="2" name="">
             <a:extLst xmlns:a="http://schemas.openxmlformats.org/drawingml/2006/main">
               <a:ext uri="{FF2B5EF4-FFF2-40B4-BE49-F238E27FC236}">
-                <a16:creationId xmlns:a16="http://schemas.microsoft.com/office/drawing/2014/main" id="{B55F21AB-DD30-4803-9712-EE0EE8404CAE}"/>
+                <a16:creationId xmlns:a16="http://schemas.microsoft.com/office/drawing/2014/main" id="{85CA2ABC-BAC1-4D39-A14A-F878B54E6FF8}"/>
               </a:ext>
             </a:extLst>
           </p:cNvPr>
@@ -1726,7 +1726,7 @@
                 <a:ea typeface="Arial"/>
                 <a:cs typeface="Arial"/>
               </a:rPr>
-              <a:t>Reference: recorded biopsy diagnoses. Source: discovery screening rule and model metadata</a:t>
+              <a:t>Reference: recorded biopsy diagnoses. Source: saved discovery screening results, 15 Sep 2026</a:t>
             </a:r>
           </a:p>
         </p:txBody>
@@ -1736,7 +1736,7 @@
           <p:cNvPr id="3" name="">
             <a:extLst xmlns:a="http://schemas.openxmlformats.org/drawingml/2006/main">
               <a:ext uri="{FF2B5EF4-FFF2-40B4-BE49-F238E27FC236}">
-                <a16:creationId xmlns:a16="http://schemas.microsoft.com/office/drawing/2014/main" id="{68D801E5-241B-4470-889C-7874FD170DBE}"/>
+                <a16:creationId xmlns:a16="http://schemas.microsoft.com/office/drawing/2014/main" id="{91B9B459-1BB3-4BB9-90F3-A18C628439A5}"/>
               </a:ext>
             </a:extLst>
           </p:cNvPr>
@@ -1793,19 +1793,19 @@
           <p:cNvPr id="4" name="">
             <a:extLst xmlns:a="http://schemas.openxmlformats.org/drawingml/2006/main">
               <a:ext uri="{FF2B5EF4-FFF2-40B4-BE49-F238E27FC236}">
-                <a16:creationId xmlns:a16="http://schemas.microsoft.com/office/drawing/2014/main" id="{832DD8D2-FF57-44AE-884E-85C2C88102CB}"/>
-              </a:ext>
-            </a:extLst>
-          </p:cNvPr>
-          <p:cNvSpPr>
-            <a:spLocks xmlns:a="http://schemas.openxmlformats.org/drawingml/2006/main" noGrp="1"/>
-          </p:cNvSpPr>
-          <p:nvPr/>
-        </p:nvSpPr>
-        <p:spPr>
-          <a:xfrm xmlns:a="http://schemas.openxmlformats.org/drawingml/2006/main">
-            <a:off x="609600" y="1590675"/>
-            <a:ext cx="5181600" cy="428625"/>
+                <a16:creationId xmlns:a16="http://schemas.microsoft.com/office/drawing/2014/main" id="{0264A9A8-9D23-41C1-9CA0-A8A28146BE16}"/>
+              </a:ext>
+            </a:extLst>
+          </p:cNvPr>
+          <p:cNvSpPr>
+            <a:spLocks xmlns:a="http://schemas.openxmlformats.org/drawingml/2006/main" noGrp="1"/>
+          </p:cNvSpPr>
+          <p:nvPr/>
+        </p:nvSpPr>
+        <p:spPr>
+          <a:xfrm xmlns:a="http://schemas.openxmlformats.org/drawingml/2006/main">
+            <a:off x="609600" y="1476375"/>
+            <a:ext cx="5181600" cy="409575"/>
           </a:xfrm>
           <a:prstGeom xmlns:a="http://schemas.openxmlformats.org/drawingml/2006/main" prst="rect">
             <a:avLst/>
@@ -1850,19 +1850,19 @@
           <p:cNvPr id="5" name="">
             <a:extLst xmlns:a="http://schemas.openxmlformats.org/drawingml/2006/main">
               <a:ext uri="{FF2B5EF4-FFF2-40B4-BE49-F238E27FC236}">
-                <a16:creationId xmlns:a16="http://schemas.microsoft.com/office/drawing/2014/main" id="{4F9D5E13-637C-48B6-85BD-A0EEB57955F7}"/>
-              </a:ext>
-            </a:extLst>
-          </p:cNvPr>
-          <p:cNvSpPr>
-            <a:spLocks xmlns:a="http://schemas.openxmlformats.org/drawingml/2006/main" noGrp="1"/>
-          </p:cNvSpPr>
-          <p:nvPr/>
-        </p:nvSpPr>
-        <p:spPr>
-          <a:xfrm xmlns:a="http://schemas.openxmlformats.org/drawingml/2006/main">
-            <a:off x="609600" y="2124075"/>
-            <a:ext cx="5181600" cy="447675"/>
+                <a16:creationId xmlns:a16="http://schemas.microsoft.com/office/drawing/2014/main" id="{3DDA304F-5E34-4FCD-B021-6865DFE00B11}"/>
+              </a:ext>
+            </a:extLst>
+          </p:cNvPr>
+          <p:cNvSpPr>
+            <a:spLocks xmlns:a="http://schemas.openxmlformats.org/drawingml/2006/main" noGrp="1"/>
+          </p:cNvSpPr>
+          <p:nvPr/>
+        </p:nvSpPr>
+        <p:spPr>
+          <a:xfrm xmlns:a="http://schemas.openxmlformats.org/drawingml/2006/main">
+            <a:off x="609600" y="1943100"/>
+            <a:ext cx="5181600" cy="409575"/>
           </a:xfrm>
           <a:prstGeom xmlns:a="http://schemas.openxmlformats.org/drawingml/2006/main" prst="rect">
             <a:avLst/>
@@ -1907,18 +1907,18 @@
           <p:cNvPr id="6" name="">
             <a:extLst xmlns:a="http://schemas.openxmlformats.org/drawingml/2006/main">
               <a:ext uri="{FF2B5EF4-FFF2-40B4-BE49-F238E27FC236}">
-                <a16:creationId xmlns:a16="http://schemas.microsoft.com/office/drawing/2014/main" id="{82D4EE50-7DFA-4261-A6DA-B261A8A9F136}"/>
-              </a:ext>
-            </a:extLst>
-          </p:cNvPr>
-          <p:cNvSpPr>
-            <a:spLocks xmlns:a="http://schemas.openxmlformats.org/drawingml/2006/main" noGrp="1"/>
-          </p:cNvSpPr>
-          <p:nvPr/>
-        </p:nvSpPr>
-        <p:spPr>
-          <a:xfrm xmlns:a="http://schemas.openxmlformats.org/drawingml/2006/main">
-            <a:off x="723900" y="2647950"/>
+                <a16:creationId xmlns:a16="http://schemas.microsoft.com/office/drawing/2014/main" id="{A77590C4-F4EA-44F4-B546-DE2BFF0D1E45}"/>
+              </a:ext>
+            </a:extLst>
+          </p:cNvPr>
+          <p:cNvSpPr>
+            <a:spLocks xmlns:a="http://schemas.openxmlformats.org/drawingml/2006/main" noGrp="1"/>
+          </p:cNvSpPr>
+          <p:nvPr/>
+        </p:nvSpPr>
+        <p:spPr>
+          <a:xfrm xmlns:a="http://schemas.openxmlformats.org/drawingml/2006/main">
+            <a:off x="723900" y="2400300"/>
             <a:ext cx="4953000" cy="0"/>
           </a:xfrm>
           <a:prstGeom xmlns:a="http://schemas.openxmlformats.org/drawingml/2006/main" prst="line">
@@ -1936,19 +1936,19 @@
           <p:cNvPr id="7" name="">
             <a:extLst xmlns:a="http://schemas.openxmlformats.org/drawingml/2006/main">
               <a:ext uri="{FF2B5EF4-FFF2-40B4-BE49-F238E27FC236}">
-                <a16:creationId xmlns:a16="http://schemas.microsoft.com/office/drawing/2014/main" id="{DE0FFA52-364F-4537-A107-951CE7D2BDE3}"/>
-              </a:ext>
-            </a:extLst>
-          </p:cNvPr>
-          <p:cNvSpPr>
-            <a:spLocks xmlns:a="http://schemas.openxmlformats.org/drawingml/2006/main" noGrp="1"/>
-          </p:cNvSpPr>
-          <p:nvPr/>
-        </p:nvSpPr>
-        <p:spPr>
-          <a:xfrm xmlns:a="http://schemas.openxmlformats.org/drawingml/2006/main">
-            <a:off x="609600" y="2705100"/>
-            <a:ext cx="5181600" cy="447675"/>
+                <a16:creationId xmlns:a16="http://schemas.microsoft.com/office/drawing/2014/main" id="{0365FFDE-2F2F-4B25-A08C-8D3622C31FA5}"/>
+              </a:ext>
+            </a:extLst>
+          </p:cNvPr>
+          <p:cNvSpPr>
+            <a:spLocks xmlns:a="http://schemas.openxmlformats.org/drawingml/2006/main" noGrp="1"/>
+          </p:cNvSpPr>
+          <p:nvPr/>
+        </p:nvSpPr>
+        <p:spPr>
+          <a:xfrm xmlns:a="http://schemas.openxmlformats.org/drawingml/2006/main">
+            <a:off x="609600" y="2486025"/>
+            <a:ext cx="5181600" cy="409575"/>
           </a:xfrm>
           <a:prstGeom xmlns:a="http://schemas.openxmlformats.org/drawingml/2006/main" prst="rect">
             <a:avLst/>
@@ -1993,19 +1993,19 @@
           <p:cNvPr id="8" name="">
             <a:extLst xmlns:a="http://schemas.openxmlformats.org/drawingml/2006/main">
               <a:ext uri="{FF2B5EF4-FFF2-40B4-BE49-F238E27FC236}">
-                <a16:creationId xmlns:a16="http://schemas.microsoft.com/office/drawing/2014/main" id="{23161C76-98E1-4335-BF82-CF35C9E35B15}"/>
-              </a:ext>
-            </a:extLst>
-          </p:cNvPr>
-          <p:cNvSpPr>
-            <a:spLocks xmlns:a="http://schemas.openxmlformats.org/drawingml/2006/main" noGrp="1"/>
-          </p:cNvSpPr>
-          <p:nvPr/>
-        </p:nvSpPr>
-        <p:spPr>
-          <a:xfrm xmlns:a="http://schemas.openxmlformats.org/drawingml/2006/main">
-            <a:off x="609600" y="3257550"/>
-            <a:ext cx="5181600" cy="523875"/>
+                <a16:creationId xmlns:a16="http://schemas.microsoft.com/office/drawing/2014/main" id="{68FE5F7B-3BB8-4E93-B2C4-3DAD49A110B1}"/>
+              </a:ext>
+            </a:extLst>
+          </p:cNvPr>
+          <p:cNvSpPr>
+            <a:spLocks xmlns:a="http://schemas.openxmlformats.org/drawingml/2006/main" noGrp="1"/>
+          </p:cNvSpPr>
+          <p:nvPr/>
+        </p:nvSpPr>
+        <p:spPr>
+          <a:xfrm xmlns:a="http://schemas.openxmlformats.org/drawingml/2006/main">
+            <a:off x="609600" y="2981325"/>
+            <a:ext cx="5181600" cy="409575"/>
           </a:xfrm>
           <a:prstGeom xmlns:a="http://schemas.openxmlformats.org/drawingml/2006/main" prst="rect">
             <a:avLst/>
@@ -2022,7 +2022,7 @@
           <a:lstStyle xmlns:a="http://schemas.openxmlformats.org/drawingml/2006/main"/>
           <a:p xmlns:a="http://schemas.openxmlformats.org/drawingml/2006/main">
             <a:pPr algn="l">
-              <a:defRPr sz="2100" b="0">
+              <a:defRPr sz="2025" b="0">
                 <a:solidFill>
                   <a:srgbClr val="B55730"/>
                 </a:solidFill>
@@ -2032,7 +2032,7 @@
               </a:defRPr>
             </a:pPr>
             <a:r>
-              <a:rPr sz="2100" b="0">
+              <a:rPr sz="2025" b="0">
                 <a:solidFill>
                   <a:srgbClr val="B55730"/>
                 </a:solidFill>
@@ -2050,19 +2050,19 @@
           <p:cNvPr id="9" name="">
             <a:extLst xmlns:a="http://schemas.openxmlformats.org/drawingml/2006/main">
               <a:ext uri="{FF2B5EF4-FFF2-40B4-BE49-F238E27FC236}">
-                <a16:creationId xmlns:a16="http://schemas.microsoft.com/office/drawing/2014/main" id="{5560FA24-84CD-4B0E-A326-A837FFB6E01E}"/>
-              </a:ext>
-            </a:extLst>
-          </p:cNvPr>
-          <p:cNvSpPr>
-            <a:spLocks xmlns:a="http://schemas.openxmlformats.org/drawingml/2006/main" noGrp="1"/>
-          </p:cNvSpPr>
-          <p:nvPr/>
-        </p:nvSpPr>
-        <p:spPr>
-          <a:xfrm xmlns:a="http://schemas.openxmlformats.org/drawingml/2006/main">
-            <a:off x="6705600" y="1590675"/>
-            <a:ext cx="4876800" cy="428625"/>
+                <a16:creationId xmlns:a16="http://schemas.microsoft.com/office/drawing/2014/main" id="{06E50C29-8DF7-475B-98BC-7733C219A8C9}"/>
+              </a:ext>
+            </a:extLst>
+          </p:cNvPr>
+          <p:cNvSpPr>
+            <a:spLocks xmlns:a="http://schemas.openxmlformats.org/drawingml/2006/main" noGrp="1"/>
+          </p:cNvSpPr>
+          <p:nvPr/>
+        </p:nvSpPr>
+        <p:spPr>
+          <a:xfrm xmlns:a="http://schemas.openxmlformats.org/drawingml/2006/main">
+            <a:off x="6705600" y="1476375"/>
+            <a:ext cx="4876800" cy="409575"/>
           </a:xfrm>
           <a:prstGeom xmlns:a="http://schemas.openxmlformats.org/drawingml/2006/main" prst="rect">
             <a:avLst/>
@@ -2107,19 +2107,19 @@
           <p:cNvPr id="10" name="">
             <a:extLst xmlns:a="http://schemas.openxmlformats.org/drawingml/2006/main">
               <a:ext uri="{FF2B5EF4-FFF2-40B4-BE49-F238E27FC236}">
-                <a16:creationId xmlns:a16="http://schemas.microsoft.com/office/drawing/2014/main" id="{B5FCE23D-6425-45BB-999F-4B8D1FD698B6}"/>
-              </a:ext>
-            </a:extLst>
-          </p:cNvPr>
-          <p:cNvSpPr>
-            <a:spLocks xmlns:a="http://schemas.openxmlformats.org/drawingml/2006/main" noGrp="1"/>
-          </p:cNvSpPr>
-          <p:nvPr/>
-        </p:nvSpPr>
-        <p:spPr>
-          <a:xfrm xmlns:a="http://schemas.openxmlformats.org/drawingml/2006/main">
-            <a:off x="6705600" y="2124075"/>
-            <a:ext cx="4876800" cy="447675"/>
+                <a16:creationId xmlns:a16="http://schemas.microsoft.com/office/drawing/2014/main" id="{200837CC-1440-4C66-B50B-0184CC268DA1}"/>
+              </a:ext>
+            </a:extLst>
+          </p:cNvPr>
+          <p:cNvSpPr>
+            <a:spLocks xmlns:a="http://schemas.openxmlformats.org/drawingml/2006/main" noGrp="1"/>
+          </p:cNvSpPr>
+          <p:nvPr/>
+        </p:nvSpPr>
+        <p:spPr>
+          <a:xfrm xmlns:a="http://schemas.openxmlformats.org/drawingml/2006/main">
+            <a:off x="6705600" y="1943100"/>
+            <a:ext cx="4876800" cy="409575"/>
           </a:xfrm>
           <a:prstGeom xmlns:a="http://schemas.openxmlformats.org/drawingml/2006/main" prst="rect">
             <a:avLst/>
@@ -2164,18 +2164,18 @@
           <p:cNvPr id="11" name="">
             <a:extLst xmlns:a="http://schemas.openxmlformats.org/drawingml/2006/main">
               <a:ext uri="{FF2B5EF4-FFF2-40B4-BE49-F238E27FC236}">
-                <a16:creationId xmlns:a16="http://schemas.microsoft.com/office/drawing/2014/main" id="{AAA5B813-FB01-4742-85BC-A7BAFED9D194}"/>
-              </a:ext>
-            </a:extLst>
-          </p:cNvPr>
-          <p:cNvSpPr>
-            <a:spLocks xmlns:a="http://schemas.openxmlformats.org/drawingml/2006/main" noGrp="1"/>
-          </p:cNvSpPr>
-          <p:nvPr/>
-        </p:nvSpPr>
-        <p:spPr>
-          <a:xfrm xmlns:a="http://schemas.openxmlformats.org/drawingml/2006/main">
-            <a:off x="6819900" y="2647950"/>
+                <a16:creationId xmlns:a16="http://schemas.microsoft.com/office/drawing/2014/main" id="{1E34DBEE-F172-4903-94ED-6F2F356F1C4F}"/>
+              </a:ext>
+            </a:extLst>
+          </p:cNvPr>
+          <p:cNvSpPr>
+            <a:spLocks xmlns:a="http://schemas.openxmlformats.org/drawingml/2006/main" noGrp="1"/>
+          </p:cNvSpPr>
+          <p:nvPr/>
+        </p:nvSpPr>
+        <p:spPr>
+          <a:xfrm xmlns:a="http://schemas.openxmlformats.org/drawingml/2006/main">
+            <a:off x="6819900" y="2400300"/>
             <a:ext cx="4648200" cy="0"/>
           </a:xfrm>
           <a:prstGeom xmlns:a="http://schemas.openxmlformats.org/drawingml/2006/main" prst="line">
@@ -2193,19 +2193,19 @@
           <p:cNvPr id="12" name="">
             <a:extLst xmlns:a="http://schemas.openxmlformats.org/drawingml/2006/main">
               <a:ext uri="{FF2B5EF4-FFF2-40B4-BE49-F238E27FC236}">
-                <a16:creationId xmlns:a16="http://schemas.microsoft.com/office/drawing/2014/main" id="{12B68387-D58F-45F8-A27A-4E205405FF6B}"/>
-              </a:ext>
-            </a:extLst>
-          </p:cNvPr>
-          <p:cNvSpPr>
-            <a:spLocks xmlns:a="http://schemas.openxmlformats.org/drawingml/2006/main" noGrp="1"/>
-          </p:cNvSpPr>
-          <p:nvPr/>
-        </p:nvSpPr>
-        <p:spPr>
-          <a:xfrm xmlns:a="http://schemas.openxmlformats.org/drawingml/2006/main">
-            <a:off x="6705600" y="2705100"/>
-            <a:ext cx="4876800" cy="447675"/>
+                <a16:creationId xmlns:a16="http://schemas.microsoft.com/office/drawing/2014/main" id="{AF584EB6-4B4F-4EEE-AC12-F5C06ECBD4A7}"/>
+              </a:ext>
+            </a:extLst>
+          </p:cNvPr>
+          <p:cNvSpPr>
+            <a:spLocks xmlns:a="http://schemas.openxmlformats.org/drawingml/2006/main" noGrp="1"/>
+          </p:cNvSpPr>
+          <p:nvPr/>
+        </p:nvSpPr>
+        <p:spPr>
+          <a:xfrm xmlns:a="http://schemas.openxmlformats.org/drawingml/2006/main">
+            <a:off x="6705600" y="2486025"/>
+            <a:ext cx="4876800" cy="409575"/>
           </a:xfrm>
           <a:prstGeom xmlns:a="http://schemas.openxmlformats.org/drawingml/2006/main" prst="rect">
             <a:avLst/>
@@ -2250,19 +2250,19 @@
           <p:cNvPr id="13" name="">
             <a:extLst xmlns:a="http://schemas.openxmlformats.org/drawingml/2006/main">
               <a:ext uri="{FF2B5EF4-FFF2-40B4-BE49-F238E27FC236}">
-                <a16:creationId xmlns:a16="http://schemas.microsoft.com/office/drawing/2014/main" id="{8A4FC4EC-3D67-4901-84AC-FDCA80B99A7E}"/>
-              </a:ext>
-            </a:extLst>
-          </p:cNvPr>
-          <p:cNvSpPr>
-            <a:spLocks xmlns:a="http://schemas.openxmlformats.org/drawingml/2006/main" noGrp="1"/>
-          </p:cNvSpPr>
-          <p:nvPr/>
-        </p:nvSpPr>
-        <p:spPr>
-          <a:xfrm xmlns:a="http://schemas.openxmlformats.org/drawingml/2006/main">
-            <a:off x="6705600" y="3257550"/>
-            <a:ext cx="4876800" cy="523875"/>
+                <a16:creationId xmlns:a16="http://schemas.microsoft.com/office/drawing/2014/main" id="{56951C02-3FEF-43C0-B939-1056B496ADD6}"/>
+              </a:ext>
+            </a:extLst>
+          </p:cNvPr>
+          <p:cNvSpPr>
+            <a:spLocks xmlns:a="http://schemas.openxmlformats.org/drawingml/2006/main" noGrp="1"/>
+          </p:cNvSpPr>
+          <p:nvPr/>
+        </p:nvSpPr>
+        <p:spPr>
+          <a:xfrm xmlns:a="http://schemas.openxmlformats.org/drawingml/2006/main">
+            <a:off x="6705600" y="2981325"/>
+            <a:ext cx="4876800" cy="409575"/>
           </a:xfrm>
           <a:prstGeom xmlns:a="http://schemas.openxmlformats.org/drawingml/2006/main" prst="rect">
             <a:avLst/>
@@ -2279,7 +2279,7 @@
           <a:lstStyle xmlns:a="http://schemas.openxmlformats.org/drawingml/2006/main"/>
           <a:p xmlns:a="http://schemas.openxmlformats.org/drawingml/2006/main">
             <a:pPr algn="l">
-              <a:defRPr sz="2100" b="0">
+              <a:defRPr sz="2025" b="0">
                 <a:solidFill>
                   <a:srgbClr val="007C78"/>
                 </a:solidFill>
@@ -2289,7 +2289,7 @@
               </a:defRPr>
             </a:pPr>
             <a:r>
-              <a:rPr sz="2100" b="0">
+              <a:rPr sz="2025" b="0">
                 <a:solidFill>
                   <a:srgbClr val="007C78"/>
                 </a:solidFill>
@@ -2307,19 +2307,19 @@
           <p:cNvPr id="14" name="">
             <a:extLst xmlns:a="http://schemas.openxmlformats.org/drawingml/2006/main">
               <a:ext uri="{FF2B5EF4-FFF2-40B4-BE49-F238E27FC236}">
-                <a16:creationId xmlns:a16="http://schemas.microsoft.com/office/drawing/2014/main" id="{444E11BE-55FB-4615-BADB-618CE9E22FE0}"/>
-              </a:ext>
-            </a:extLst>
-          </p:cNvPr>
-          <p:cNvSpPr>
-            <a:spLocks xmlns:a="http://schemas.openxmlformats.org/drawingml/2006/main" noGrp="1"/>
-          </p:cNvSpPr>
-          <p:nvPr/>
-        </p:nvSpPr>
-        <p:spPr>
-          <a:xfrm xmlns:a="http://schemas.openxmlformats.org/drawingml/2006/main">
-            <a:off x="609600" y="4000500"/>
-            <a:ext cx="10972800" cy="381000"/>
+                <a16:creationId xmlns:a16="http://schemas.microsoft.com/office/drawing/2014/main" id="{EA390391-0978-4050-A971-78EB3D96AD6E}"/>
+              </a:ext>
+            </a:extLst>
+          </p:cNvPr>
+          <p:cNvSpPr>
+            <a:spLocks xmlns:a="http://schemas.openxmlformats.org/drawingml/2006/main" noGrp="1"/>
+          </p:cNvSpPr>
+          <p:nvPr/>
+        </p:nvSpPr>
+        <p:spPr>
+          <a:xfrm xmlns:a="http://schemas.openxmlformats.org/drawingml/2006/main">
+            <a:off x="609600" y="3552825"/>
+            <a:ext cx="10972800" cy="695325"/>
           </a:xfrm>
           <a:prstGeom xmlns:a="http://schemas.openxmlformats.org/drawingml/2006/main" prst="rect">
             <a:avLst/>
@@ -2336,48 +2336,72 @@
           <a:lstStyle xmlns:a="http://schemas.openxmlformats.org/drawingml/2006/main"/>
           <a:p xmlns:a="http://schemas.openxmlformats.org/drawingml/2006/main">
             <a:pPr algn="l">
-              <a:defRPr sz="2400" b="1">
-                <a:solidFill>
-                  <a:srgbClr val="16343E"/>
-                </a:solidFill>
-                <a:latin typeface="Arial"/>
-                <a:ea typeface="Arial"/>
-                <a:cs typeface="Arial"/>
-              </a:defRPr>
-            </a:pPr>
-            <a:r>
-              <a:rPr sz="2400" b="1">
-                <a:solidFill>
-                  <a:srgbClr val="16343E"/>
-                </a:solidFill>
-                <a:latin typeface="Arial"/>
-                <a:ea typeface="Arial"/>
-                <a:cs typeface="Arial"/>
-              </a:rPr>
-              <a:t>My selection rule for screening specimens</a:t>
+              <a:defRPr sz="2100" b="1">
+                <a:solidFill>
+                  <a:srgbClr val="16343E"/>
+                </a:solidFill>
+                <a:latin typeface="Arial"/>
+                <a:ea typeface="Arial"/>
+                <a:cs typeface="Arial"/>
+              </a:defRPr>
+            </a:pPr>
+            <a:r>
+              <a:rPr sz="2100" b="1">
+                <a:solidFill>
+                  <a:srgbClr val="16343E"/>
+                </a:solidFill>
+                <a:latin typeface="Arial"/>
+                <a:ea typeface="Arial"/>
+                <a:cs typeface="Arial"/>
+              </a:rPr>
+              <a:t>Screening rule: detect at least 90% of recorded rejection cases,</a:t>
+            </a:r>
+          </a:p>
+          <a:p xmlns:a="http://schemas.openxmlformats.org/drawingml/2006/main">
+            <a:pPr algn="l">
+              <a:defRPr sz="2100" b="1">
+                <a:solidFill>
+                  <a:srgbClr val="16343E"/>
+                </a:solidFill>
+                <a:latin typeface="Arial"/>
+                <a:ea typeface="Arial"/>
+                <a:cs typeface="Arial"/>
+              </a:defRPr>
+            </a:pPr>
+            <a:r>
+              <a:rPr sz="2100" b="1">
+                <a:solidFill>
+                  <a:srgbClr val="16343E"/>
+                </a:solidFill>
+                <a:latin typeface="Arial"/>
+                <a:ea typeface="Arial"/>
+                <a:cs typeface="Arial"/>
+              </a:rPr>
+              <a:t>then minimize false positives. ROC-AUC breaks ties.</a:t>
             </a:r>
           </a:p>
         </p:txBody>
       </p:sp>
       <p:graphicFrame>
         <p:nvGraphicFramePr>
-          <p:cNvPr id="30" name=""/>
+          <p:cNvPr id="31" name=""/>
           <p:cNvGraphicFramePr/>
           <p:nvPr/>
         </p:nvGraphicFramePr>
         <p:xfrm>
-          <a:off xmlns:a="http://schemas.openxmlformats.org/drawingml/2006/main" x="609600" y="4505325"/>
-          <a:ext xmlns:a="http://schemas.openxmlformats.org/drawingml/2006/main" cx="10972800" cy="1438275"/>
+          <a:off xmlns:a="http://schemas.openxmlformats.org/drawingml/2006/main" x="609600" y="4419600"/>
+          <a:ext xmlns:a="http://schemas.openxmlformats.org/drawingml/2006/main" cx="10972800" cy="1200150"/>
         </p:xfrm>
         <a:graphic xmlns:a="http://schemas.openxmlformats.org/drawingml/2006/main">
           <a:graphicData uri="http://schemas.openxmlformats.org/drawingml/2006/table">
             <a:tbl>
               <a:tblPr/>
               <a:tblGrid>
-                <a:gridCol w="1066800"/>
-                <a:gridCol w="9906000"/>
+                <a:gridCol w="4762500"/>
+                <a:gridCol w="3105150"/>
+                <a:gridCol w="3105150"/>
               </a:tblGrid>
-              <a:tr h="352425">
+              <a:tr h="400050">
                 <a:tc>
                   <a:txBody>
                     <a:bodyPr>
@@ -2386,7 +2410,7 @@
                     <a:lstStyle/>
                     <a:p>
                       <a:r>
-                        <a:rPr sz="1875" b="1">
+                        <a:rPr sz="2025" b="1">
                           <a:solidFill>
                             <a:srgbClr val="FFFFFF"/>
                           </a:solidFill>
@@ -2394,11 +2418,11 @@
                           <a:ea typeface="Arial"/>
                           <a:cs typeface="Arial"/>
                         </a:rPr>
-                        <a:t>Step</a:t>
+                        <a:t>Screening result</a:t>
                       </a:r>
                     </a:p>
                   </a:txBody>
-                  <a:tcPr marL="171450" marR="142875" marT="19050" marB="19050" anchor="ctr">
+                  <a:tcPr marL="171450" marR="142875" marT="28575" marB="28575" anchor="ctr">
                     <a:solidFill>
                       <a:srgbClr val="16343E"/>
                     </a:solidFill>
@@ -2412,7 +2436,7 @@
                     <a:lstStyle/>
                     <a:p>
                       <a:r>
-                        <a:rPr sz="1875" b="1">
+                        <a:rPr sz="2025" b="1">
                           <a:solidFill>
                             <a:srgbClr val="FFFFFF"/>
                           </a:solidFill>
@@ -2420,18 +2444,16 @@
                           <a:ea typeface="Arial"/>
                           <a:cs typeface="Arial"/>
                         </a:rPr>
-                        <a:t>Rule</a:t>
+                        <a:t>CatBoost</a:t>
                       </a:r>
                     </a:p>
                   </a:txBody>
-                  <a:tcPr marL="171450" marR="142875" marT="19050" marB="19050" anchor="ctr">
+                  <a:tcPr marL="171450" marR="142875" marT="28575" marB="28575" anchor="ctr">
                     <a:solidFill>
                       <a:srgbClr val="16343E"/>
                     </a:solidFill>
                   </a:tcPr>
                 </a:tc>
-              </a:tr>
-              <a:tr h="361950">
                 <a:tc>
                   <a:txBody>
                     <a:bodyPr>
@@ -2440,7 +2462,35 @@
                     <a:lstStyle/>
                     <a:p>
                       <a:r>
-                        <a:rPr sz="1875" b="0">
+                        <a:rPr sz="2025" b="1">
+                          <a:solidFill>
+                            <a:srgbClr val="FFFFFF"/>
+                          </a:solidFill>
+                          <a:latin typeface="Arial"/>
+                          <a:ea typeface="Arial"/>
+                          <a:cs typeface="Arial"/>
+                        </a:rPr>
+                        <a:t>All-RNA logistic</a:t>
+                      </a:r>
+                    </a:p>
+                  </a:txBody>
+                  <a:tcPr marL="171450" marR="142875" marT="28575" marB="28575" anchor="ctr">
+                    <a:solidFill>
+                      <a:srgbClr val="16343E"/>
+                    </a:solidFill>
+                  </a:tcPr>
+                </a:tc>
+              </a:tr>
+              <a:tr h="400050">
+                <a:tc>
+                  <a:txBody>
+                    <a:bodyPr>
+                      <a:noAutofit/>
+                    </a:bodyPr>
+                    <a:lstStyle/>
+                    <a:p>
+                      <a:r>
+                        <a:rPr sz="2025" b="0">
                           <a:solidFill>
                             <a:srgbClr val="16343E"/>
                           </a:solidFill>
@@ -2448,11 +2498,11 @@
                           <a:ea typeface="Arial"/>
                           <a:cs typeface="Arial"/>
                         </a:rPr>
-                        <a:t>1</a:t>
+                        <a:t>Rejection detected</a:t>
                       </a:r>
                     </a:p>
                   </a:txBody>
-                  <a:tcPr marL="171450" marR="142875" marT="19050" marB="19050" anchor="ctr">
+                  <a:tcPr marL="171450" marR="142875" marT="28575" marB="28575" anchor="ctr">
                     <a:solidFill>
                       <a:srgbClr val="FFFFFF"/>
                     </a:solidFill>
@@ -2466,7 +2516,7 @@
                     <a:lstStyle/>
                     <a:p>
                       <a:r>
-                        <a:rPr sz="1875" b="0">
+                        <a:rPr sz="2025" b="0">
                           <a:solidFill>
                             <a:srgbClr val="16343E"/>
                           </a:solidFill>
@@ -2474,18 +2524,16 @@
                           <a:ea typeface="Arial"/>
                           <a:cs typeface="Arial"/>
                         </a:rPr>
-                        <a:t>Detect at least 90% of cases diagnosed as rejection.</a:t>
+                        <a:t>157 / 174</a:t>
                       </a:r>
                     </a:p>
                   </a:txBody>
-                  <a:tcPr marL="171450" marR="142875" marT="19050" marB="19050" anchor="ctr">
+                  <a:tcPr marL="171450" marR="142875" marT="28575" marB="28575" anchor="ctr">
                     <a:solidFill>
                       <a:srgbClr val="FFFFFF"/>
                     </a:solidFill>
                   </a:tcPr>
                 </a:tc>
-              </a:tr>
-              <a:tr h="361950">
                 <a:tc>
                   <a:txBody>
                     <a:bodyPr>
@@ -2494,7 +2542,7 @@
                     <a:lstStyle/>
                     <a:p>
                       <a:r>
-                        <a:rPr sz="1875" b="0">
+                        <a:rPr sz="2025" b="0">
                           <a:solidFill>
                             <a:srgbClr val="16343E"/>
                           </a:solidFill>
@@ -2502,11 +2550,39 @@
                           <a:ea typeface="Arial"/>
                           <a:cs typeface="Arial"/>
                         </a:rPr>
-                        <a:t>2</a:t>
+                        <a:t>157 / 174</a:t>
                       </a:r>
                     </a:p>
                   </a:txBody>
-                  <a:tcPr marL="171450" marR="142875" marT="19050" marB="19050" anchor="ctr">
+                  <a:tcPr marL="171450" marR="142875" marT="28575" marB="28575" anchor="ctr">
+                    <a:solidFill>
+                      <a:srgbClr val="FFFFFF"/>
+                    </a:solidFill>
+                  </a:tcPr>
+                </a:tc>
+              </a:tr>
+              <a:tr h="400050">
+                <a:tc>
+                  <a:txBody>
+                    <a:bodyPr>
+                      <a:noAutofit/>
+                    </a:bodyPr>
+                    <a:lstStyle/>
+                    <a:p>
+                      <a:r>
+                        <a:rPr sz="2025" b="0">
+                          <a:solidFill>
+                            <a:srgbClr val="16343E"/>
+                          </a:solidFill>
+                          <a:latin typeface="Arial"/>
+                          <a:ea typeface="Arial"/>
+                          <a:cs typeface="Arial"/>
+                        </a:rPr>
+                        <a:t>False positives</a:t>
+                      </a:r>
+                    </a:p>
+                  </a:txBody>
+                  <a:tcPr marL="171450" marR="142875" marT="28575" marB="28575" anchor="ctr">
                     <a:solidFill>
                       <a:srgbClr val="EDF3F0"/>
                     </a:solidFill>
@@ -2520,7 +2596,7 @@
                     <a:lstStyle/>
                     <a:p>
                       <a:r>
-                        <a:rPr sz="1875" b="0">
+                        <a:rPr sz="2025" b="0">
                           <a:solidFill>
                             <a:srgbClr val="16343E"/>
                           </a:solidFill>
@@ -2528,41 +2604,13 @@
                           <a:ea typeface="Arial"/>
                           <a:cs typeface="Arial"/>
                         </a:rPr>
-                        <a:t>Among qualifying choices, minimize false positives.</a:t>
+                        <a:t>5 / 89</a:t>
                       </a:r>
                     </a:p>
                   </a:txBody>
-                  <a:tcPr marL="171450" marR="142875" marT="19050" marB="19050" anchor="ctr">
+                  <a:tcPr marL="171450" marR="142875" marT="28575" marB="28575" anchor="ctr">
                     <a:solidFill>
                       <a:srgbClr val="EDF3F0"/>
-                    </a:solidFill>
-                  </a:tcPr>
-                </a:tc>
-              </a:tr>
-              <a:tr h="361950">
-                <a:tc>
-                  <a:txBody>
-                    <a:bodyPr>
-                      <a:noAutofit/>
-                    </a:bodyPr>
-                    <a:lstStyle/>
-                    <a:p>
-                      <a:r>
-                        <a:rPr sz="1875" b="0">
-                          <a:solidFill>
-                            <a:srgbClr val="16343E"/>
-                          </a:solidFill>
-                          <a:latin typeface="Arial"/>
-                          <a:ea typeface="Arial"/>
-                          <a:cs typeface="Arial"/>
-                        </a:rPr>
-                        <a:t>3</a:t>
-                      </a:r>
-                    </a:p>
-                  </a:txBody>
-                  <a:tcPr marL="171450" marR="142875" marT="19050" marB="19050" anchor="ctr">
-                    <a:solidFill>
-                      <a:srgbClr val="FFFFFF"/>
                     </a:solidFill>
                   </a:tcPr>
                 </a:tc>
@@ -2574,7 +2622,7 @@
                     <a:lstStyle/>
                     <a:p>
                       <a:r>
-                        <a:rPr sz="1875" b="0">
+                        <a:rPr sz="2025" b="0">
                           <a:solidFill>
                             <a:srgbClr val="16343E"/>
                           </a:solidFill>
@@ -2582,13 +2630,13 @@
                           <a:ea typeface="Arial"/>
                           <a:cs typeface="Arial"/>
                         </a:rPr>
-                        <a:t>Keep the chosen model and threshold for evaluation.</a:t>
+                        <a:t>6 / 89</a:t>
                       </a:r>
                     </a:p>
                   </a:txBody>
-                  <a:tcPr marL="171450" marR="142875" marT="19050" marB="19050" anchor="ctr">
+                  <a:tcPr marL="171450" marR="142875" marT="28575" marB="28575" anchor="ctr">
                     <a:solidFill>
-                      <a:srgbClr val="FFFFFF"/>
+                      <a:srgbClr val="EDF3F0"/>
                     </a:solidFill>
                   </a:tcPr>
                 </a:tc>
@@ -2597,10 +2645,90 @@
           </a:graphicData>
         </a:graphic>
       </p:graphicFrame>
+      <p:sp>
+        <p:nvSpPr>
+          <p:cNvPr id="16" name="">
+            <a:extLst xmlns:a="http://schemas.openxmlformats.org/drawingml/2006/main">
+              <a:ext uri="{FF2B5EF4-FFF2-40B4-BE49-F238E27FC236}">
+                <a16:creationId xmlns:a16="http://schemas.microsoft.com/office/drawing/2014/main" id="{6F14F4E0-9141-499B-AC08-06E6F27AB081}"/>
+              </a:ext>
+            </a:extLst>
+          </p:cNvPr>
+          <p:cNvSpPr>
+            <a:spLocks xmlns:a="http://schemas.openxmlformats.org/drawingml/2006/main" noGrp="1"/>
+          </p:cNvSpPr>
+          <p:nvPr/>
+        </p:nvSpPr>
+        <p:spPr>
+          <a:xfrm xmlns:a="http://schemas.openxmlformats.org/drawingml/2006/main">
+            <a:off x="609600" y="5724525"/>
+            <a:ext cx="10972800" cy="457200"/>
+          </a:xfrm>
+          <a:prstGeom xmlns:a="http://schemas.openxmlformats.org/drawingml/2006/main" prst="rect">
+            <a:avLst/>
+          </a:prstGeom>
+          <a:noFill xmlns:a="http://schemas.openxmlformats.org/drawingml/2006/main"/>
+          <a:ln xmlns:a="http://schemas.openxmlformats.org/drawingml/2006/main" w="0">
+            <a:noFill/>
+          </a:ln>
+        </p:spPr>
+        <p:txBody>
+          <a:bodyPr xmlns:a="http://schemas.openxmlformats.org/drawingml/2006/main" anchor="ctr">
+            <a:noAutofit/>
+          </a:bodyPr>
+          <a:lstStyle xmlns:a="http://schemas.openxmlformats.org/drawingml/2006/main"/>
+          <a:p xmlns:a="http://schemas.openxmlformats.org/drawingml/2006/main">
+            <a:pPr algn="l">
+              <a:defRPr sz="1875" b="0">
+                <a:solidFill>
+                  <a:srgbClr val="16343E"/>
+                </a:solidFill>
+                <a:latin typeface="Arial"/>
+                <a:ea typeface="Arial"/>
+                <a:cs typeface="Arial"/>
+              </a:defRPr>
+            </a:pPr>
+            <a:r>
+              <a:rPr sz="1875" b="0">
+                <a:solidFill>
+                  <a:srgbClr val="16343E"/>
+                </a:solidFill>
+                <a:latin typeface="Arial"/>
+                <a:ea typeface="Arial"/>
+                <a:cs typeface="Arial"/>
+              </a:rPr>
+              <a:t>One fewer false positive selected CatBoost.</a:t>
+            </a:r>
+          </a:p>
+          <a:p xmlns:a="http://schemas.openxmlformats.org/drawingml/2006/main">
+            <a:pPr algn="l">
+              <a:defRPr sz="1875" b="0">
+                <a:solidFill>
+                  <a:srgbClr val="16343E"/>
+                </a:solidFill>
+                <a:latin typeface="Arial"/>
+                <a:ea typeface="Arial"/>
+                <a:cs typeface="Arial"/>
+              </a:defRPr>
+            </a:pPr>
+            <a:r>
+              <a:rPr sz="1875" b="0">
+                <a:solidFill>
+                  <a:srgbClr val="16343E"/>
+                </a:solidFill>
+                <a:latin typeface="Arial"/>
+                <a:ea typeface="Arial"/>
+                <a:cs typeface="Arial"/>
+              </a:rPr>
+              <a:t>The model and threshold then stayed fixed for evaluation.</a:t>
+            </a:r>
+          </a:p>
+        </p:txBody>
+      </p:sp>
     </p:spTree>
     <p:extLst>
       <p:ext uri="{BB962C8B-B14F-4D97-AF65-F5344CB8AC3E}">
-        <p14:creationId xmlns:p14="http://schemas.microsoft.com/office/powerpoint/2010/main" val="1888654372"/>
+        <p14:creationId xmlns:p14="http://schemas.microsoft.com/office/powerpoint/2010/main" val="454686708"/>
       </p:ext>
     </p:extLst>
   </p:cSld>
@@ -2628,10 +2756,10 @@
       </p:grpSpPr>
       <p:sp>
         <p:nvSpPr>
-          <p:cNvPr id="7" name="">
-            <a:extLst xmlns:a="http://schemas.openxmlformats.org/drawingml/2006/main">
-              <a:ext uri="{FF2B5EF4-FFF2-40B4-BE49-F238E27FC236}">
-                <a16:creationId xmlns:a16="http://schemas.microsoft.com/office/drawing/2014/main" id="{978462B6-458A-4D0C-B5DA-72C8F146CA9C}"/>
+          <p:cNvPr id="8" name="">
+            <a:extLst xmlns:a="http://schemas.openxmlformats.org/drawingml/2006/main">
+              <a:ext uri="{FF2B5EF4-FFF2-40B4-BE49-F238E27FC236}">
+                <a16:creationId xmlns:a16="http://schemas.microsoft.com/office/drawing/2014/main" id="{6B080C2B-8A04-4027-96B8-797FCFB59818}"/>
               </a:ext>
             </a:extLst>
           </p:cNvPr>
@@ -2688,7 +2816,7 @@
           <p:cNvPr id="2" name="">
             <a:extLst xmlns:a="http://schemas.openxmlformats.org/drawingml/2006/main">
               <a:ext uri="{FF2B5EF4-FFF2-40B4-BE49-F238E27FC236}">
-                <a16:creationId xmlns:a16="http://schemas.microsoft.com/office/drawing/2014/main" id="{7C51F71F-2BDA-45BA-9BB4-DEE2ED37B815}"/>
+                <a16:creationId xmlns:a16="http://schemas.microsoft.com/office/drawing/2014/main" id="{A6E75F5F-C2DA-4888-B22B-6B3BFAF2B9D5}"/>
               </a:ext>
             </a:extLst>
           </p:cNvPr>
@@ -2735,7 +2863,7 @@
                 <a:ea typeface="Arial"/>
                 <a:cs typeface="Arial"/>
               </a:rPr>
-              <a:t>Source: primary evaluation, 15 Sep 2026. Errors are against recorded diagnoses.</a:t>
+              <a:t>Sources: primary evaluation (15 Sep) and discovery-only stability follow-up (17 Sep 2026).</a:t>
             </a:r>
           </a:p>
         </p:txBody>
@@ -2745,7 +2873,7 @@
           <p:cNvPr id="3" name="">
             <a:extLst xmlns:a="http://schemas.openxmlformats.org/drawingml/2006/main">
               <a:ext uri="{FF2B5EF4-FFF2-40B4-BE49-F238E27FC236}">
-                <a16:creationId xmlns:a16="http://schemas.microsoft.com/office/drawing/2014/main" id="{D3968B99-8C9A-443D-BE88-8B83AC469729}"/>
+                <a16:creationId xmlns:a16="http://schemas.microsoft.com/office/drawing/2014/main" id="{E4EB2580-B756-4FA7-BE4D-29250C3D296B}"/>
               </a:ext>
             </a:extLst>
           </p:cNvPr>
@@ -2802,7 +2930,7 @@
           <p:cNvPr id="4" name="">
             <a:extLst xmlns:a="http://schemas.openxmlformats.org/drawingml/2006/main">
               <a:ext uri="{FF2B5EF4-FFF2-40B4-BE49-F238E27FC236}">
-                <a16:creationId xmlns:a16="http://schemas.microsoft.com/office/drawing/2014/main" id="{6C642893-29E5-4A62-A6B9-C450C10DAF31}"/>
+                <a16:creationId xmlns:a16="http://schemas.microsoft.com/office/drawing/2014/main" id="{DB756204-3158-4111-A824-A7B47F7A8F09}"/>
               </a:ext>
             </a:extLst>
           </p:cNvPr>
@@ -2856,7 +2984,7 @@
       </p:sp>
       <p:graphicFrame>
         <p:nvGraphicFramePr>
-          <p:cNvPr id="11" name="Chart"/>
+          <p:cNvPr id="12" name="Chart"/>
           <p:cNvGraphicFramePr/>
           <p:nvPr/>
         </p:nvGraphicFramePr>
@@ -2866,7 +2994,7 @@
         </p:xfrm>
         <a:graphic xmlns:a="http://schemas.openxmlformats.org/drawingml/2006/main">
           <a:graphicData uri="http://schemas.openxmlformats.org/drawingml/2006/chart">
-            <c:chart xmlns:r="http://schemas.openxmlformats.org/officeDocument/2006/relationships" xmlns:c="http://schemas.openxmlformats.org/drawingml/2006/chart" r:id="Rbc11e9ec15ec4666"/>
+            <c:chart xmlns:r="http://schemas.openxmlformats.org/officeDocument/2006/relationships" xmlns:c="http://schemas.openxmlformats.org/drawingml/2006/chart" r:id="Rc3668eff1a674212"/>
           </a:graphicData>
         </a:graphic>
       </p:graphicFrame>
@@ -2875,7 +3003,7 @@
           <p:cNvPr id="6" name="">
             <a:extLst xmlns:a="http://schemas.openxmlformats.org/drawingml/2006/main">
               <a:ext uri="{FF2B5EF4-FFF2-40B4-BE49-F238E27FC236}">
-                <a16:creationId xmlns:a16="http://schemas.microsoft.com/office/drawing/2014/main" id="{E04CF800-19FE-4252-9FBE-658FE8A0943F}"/>
+                <a16:creationId xmlns:a16="http://schemas.microsoft.com/office/drawing/2014/main" id="{1C2B0F19-1D1B-4186-B4AF-D7E948DA133D}"/>
               </a:ext>
             </a:extLst>
           </p:cNvPr>
@@ -2931,10 +3059,67 @@
           </a:p>
         </p:txBody>
       </p:sp>
+      <p:sp>
+        <p:nvSpPr>
+          <p:cNvPr id="7" name="">
+            <a:extLst xmlns:a="http://schemas.openxmlformats.org/drawingml/2006/main">
+              <a:ext uri="{FF2B5EF4-FFF2-40B4-BE49-F238E27FC236}">
+                <a16:creationId xmlns:a16="http://schemas.microsoft.com/office/drawing/2014/main" id="{5C8083B6-B332-47D2-8742-A87775734FDB}"/>
+              </a:ext>
+            </a:extLst>
+          </p:cNvPr>
+          <p:cNvSpPr>
+            <a:spLocks xmlns:a="http://schemas.openxmlformats.org/drawingml/2006/main" noGrp="1"/>
+          </p:cNvSpPr>
+          <p:nvPr/>
+        </p:nvSpPr>
+        <p:spPr>
+          <a:xfrm xmlns:a="http://schemas.openxmlformats.org/drawingml/2006/main">
+            <a:off x="609600" y="5848350"/>
+            <a:ext cx="10972800" cy="333375"/>
+          </a:xfrm>
+          <a:prstGeom xmlns:a="http://schemas.openxmlformats.org/drawingml/2006/main" prst="rect">
+            <a:avLst/>
+          </a:prstGeom>
+          <a:noFill xmlns:a="http://schemas.openxmlformats.org/drawingml/2006/main"/>
+          <a:ln xmlns:a="http://schemas.openxmlformats.org/drawingml/2006/main" w="0">
+            <a:noFill/>
+          </a:ln>
+        </p:spPr>
+        <p:txBody>
+          <a:bodyPr xmlns:a="http://schemas.openxmlformats.org/drawingml/2006/main" anchor="ctr">
+            <a:noAutofit/>
+          </a:bodyPr>
+          <a:lstStyle xmlns:a="http://schemas.openxmlformats.org/drawingml/2006/main"/>
+          <a:p xmlns:a="http://schemas.openxmlformats.org/drawingml/2006/main">
+            <a:pPr algn="l">
+              <a:defRPr sz="1875" b="0">
+                <a:solidFill>
+                  <a:srgbClr val="16343E"/>
+                </a:solidFill>
+                <a:latin typeface="Arial"/>
+                <a:ea typeface="Arial"/>
+                <a:cs typeface="Arial"/>
+              </a:defRPr>
+            </a:pPr>
+            <a:r>
+              <a:rPr sz="1875" b="0">
+                <a:solidFill>
+                  <a:srgbClr val="16343E"/>
+                </a:solidFill>
+                <a:latin typeface="Arial"/>
+                <a:ea typeface="Arial"/>
+                <a:cs typeface="Arial"/>
+              </a:rPr>
+              <a:t>Across 20 discovery splits: CatBoost selected 13 times, logistic 7.</a:t>
+            </a:r>
+          </a:p>
+        </p:txBody>
+      </p:sp>
     </p:spTree>
     <p:extLst>
       <p:ext uri="{BB962C8B-B14F-4D97-AF65-F5344CB8AC3E}">
-        <p14:creationId xmlns:p14="http://schemas.microsoft.com/office/powerpoint/2010/main" val="2067514369"/>
+        <p14:creationId xmlns:p14="http://schemas.microsoft.com/office/powerpoint/2010/main" val="83555725"/>
       </p:ext>
     </p:extLst>
   </p:cSld>
@@ -2965,7 +3150,7 @@
           <p:cNvPr id="7" name="">
             <a:extLst xmlns:a="http://schemas.openxmlformats.org/drawingml/2006/main">
               <a:ext uri="{FF2B5EF4-FFF2-40B4-BE49-F238E27FC236}">
-                <a16:creationId xmlns:a16="http://schemas.microsoft.com/office/drawing/2014/main" id="{DD460867-16E5-480B-972B-36886CCC50A8}"/>
+                <a16:creationId xmlns:a16="http://schemas.microsoft.com/office/drawing/2014/main" id="{E64DC71E-E96E-4D84-85BC-96EF0D800D33}"/>
               </a:ext>
             </a:extLst>
           </p:cNvPr>
@@ -3022,7 +3207,7 @@
           <p:cNvPr id="2" name="">
             <a:extLst xmlns:a="http://schemas.openxmlformats.org/drawingml/2006/main">
               <a:ext uri="{FF2B5EF4-FFF2-40B4-BE49-F238E27FC236}">
-                <a16:creationId xmlns:a16="http://schemas.microsoft.com/office/drawing/2014/main" id="{C6C0C062-5B8C-416D-9600-33C511359AC9}"/>
+                <a16:creationId xmlns:a16="http://schemas.microsoft.com/office/drawing/2014/main" id="{9D5FAD24-480A-4734-8D45-96BABA6CF233}"/>
               </a:ext>
             </a:extLst>
           </p:cNvPr>
@@ -3079,7 +3264,7 @@
           <p:cNvPr id="3" name="">
             <a:extLst xmlns:a="http://schemas.openxmlformats.org/drawingml/2006/main">
               <a:ext uri="{FF2B5EF4-FFF2-40B4-BE49-F238E27FC236}">
-                <a16:creationId xmlns:a16="http://schemas.microsoft.com/office/drawing/2014/main" id="{A6E57419-E14E-4D26-9BF9-0CD871680E72}"/>
+                <a16:creationId xmlns:a16="http://schemas.microsoft.com/office/drawing/2014/main" id="{3A986F6E-4B0E-4C24-AD0B-7F3BE37F1E2E}"/>
               </a:ext>
             </a:extLst>
           </p:cNvPr>
@@ -3136,7 +3321,7 @@
           <p:cNvPr id="4" name="">
             <a:extLst xmlns:a="http://schemas.openxmlformats.org/drawingml/2006/main">
               <a:ext uri="{FF2B5EF4-FFF2-40B4-BE49-F238E27FC236}">
-                <a16:creationId xmlns:a16="http://schemas.microsoft.com/office/drawing/2014/main" id="{2F5083F0-A870-4400-9A2B-ACE944747610}"/>
+                <a16:creationId xmlns:a16="http://schemas.microsoft.com/office/drawing/2014/main" id="{B796B2C8-9668-42A6-8C30-F0E3285631AC}"/>
               </a:ext>
             </a:extLst>
           </p:cNvPr>
@@ -3193,7 +3378,7 @@
           <p:cNvPr id="5" name="">
             <a:extLst xmlns:a="http://schemas.openxmlformats.org/drawingml/2006/main">
               <a:ext uri="{FF2B5EF4-FFF2-40B4-BE49-F238E27FC236}">
-                <a16:creationId xmlns:a16="http://schemas.microsoft.com/office/drawing/2014/main" id="{B912FA76-504C-4592-9056-DB06B0048BC9}"/>
+                <a16:creationId xmlns:a16="http://schemas.microsoft.com/office/drawing/2014/main" id="{CEFDF15D-A4FF-4D06-9869-73EFCA77A100}"/>
               </a:ext>
             </a:extLst>
           </p:cNvPr>
@@ -3308,7 +3493,7 @@
           <p:cNvPr id="6" name="">
             <a:extLst xmlns:a="http://schemas.openxmlformats.org/drawingml/2006/main">
               <a:ext uri="{FF2B5EF4-FFF2-40B4-BE49-F238E27FC236}">
-                <a16:creationId xmlns:a16="http://schemas.microsoft.com/office/drawing/2014/main" id="{AD31ABC1-FE3F-41BA-B69B-1948FF867D79}"/>
+                <a16:creationId xmlns:a16="http://schemas.microsoft.com/office/drawing/2014/main" id="{12924DAC-5091-4A90-B96E-8753F8BAD58B}"/>
               </a:ext>
             </a:extLst>
           </p:cNvPr>
@@ -3363,7 +3548,7 @@
     </p:spTree>
     <p:extLst>
       <p:ext uri="{BB962C8B-B14F-4D97-AF65-F5344CB8AC3E}">
-        <p14:creationId xmlns:p14="http://schemas.microsoft.com/office/powerpoint/2010/main" val="1914430962"/>
+        <p14:creationId xmlns:p14="http://schemas.microsoft.com/office/powerpoint/2010/main" val="1425319573"/>
       </p:ext>
     </p:extLst>
   </p:cSld>
@@ -3394,7 +3579,7 @@
           <p:cNvPr id="9" name="">
             <a:extLst xmlns:a="http://schemas.openxmlformats.org/drawingml/2006/main">
               <a:ext uri="{FF2B5EF4-FFF2-40B4-BE49-F238E27FC236}">
-                <a16:creationId xmlns:a16="http://schemas.microsoft.com/office/drawing/2014/main" id="{A2B4AE4A-EE10-4992-8728-DD2B651A5692}"/>
+                <a16:creationId xmlns:a16="http://schemas.microsoft.com/office/drawing/2014/main" id="{E26CC142-AD39-4AE7-A828-D6A059CA7DC0}"/>
               </a:ext>
             </a:extLst>
           </p:cNvPr>
@@ -3451,7 +3636,7 @@
           <p:cNvPr id="2" name="">
             <a:extLst xmlns:a="http://schemas.openxmlformats.org/drawingml/2006/main">
               <a:ext uri="{FF2B5EF4-FFF2-40B4-BE49-F238E27FC236}">
-                <a16:creationId xmlns:a16="http://schemas.microsoft.com/office/drawing/2014/main" id="{74BF6D9F-2F19-44E5-A5CA-FA38396AAD16}"/>
+                <a16:creationId xmlns:a16="http://schemas.microsoft.com/office/drawing/2014/main" id="{87E2C48B-B66D-4CBD-B628-BE7B874293C2}"/>
               </a:ext>
             </a:extLst>
           </p:cNvPr>
@@ -3508,7 +3693,7 @@
           <p:cNvPr id="3" name="">
             <a:extLst xmlns:a="http://schemas.openxmlformats.org/drawingml/2006/main">
               <a:ext uri="{FF2B5EF4-FFF2-40B4-BE49-F238E27FC236}">
-                <a16:creationId xmlns:a16="http://schemas.microsoft.com/office/drawing/2014/main" id="{4F5CD016-1329-4634-B6A3-9A0F8FEA3EB7}"/>
+                <a16:creationId xmlns:a16="http://schemas.microsoft.com/office/drawing/2014/main" id="{DEEAB9FD-5B38-45B5-93A9-1FDDC9565B94}"/>
               </a:ext>
             </a:extLst>
           </p:cNvPr>
@@ -3565,7 +3750,7 @@
           <p:cNvPr id="4" name="">
             <a:extLst xmlns:a="http://schemas.openxmlformats.org/drawingml/2006/main">
               <a:ext uri="{FF2B5EF4-FFF2-40B4-BE49-F238E27FC236}">
-                <a16:creationId xmlns:a16="http://schemas.microsoft.com/office/drawing/2014/main" id="{B4D36C0A-1095-444B-9010-F2FE53569A22}"/>
+                <a16:creationId xmlns:a16="http://schemas.microsoft.com/office/drawing/2014/main" id="{CBC14225-1320-4D91-81AB-4B1B428587CD}"/>
               </a:ext>
             </a:extLst>
           </p:cNvPr>
@@ -3809,7 +3994,7 @@
           <p:cNvPr id="6" name="">
             <a:extLst xmlns:a="http://schemas.openxmlformats.org/drawingml/2006/main">
               <a:ext uri="{FF2B5EF4-FFF2-40B4-BE49-F238E27FC236}">
-                <a16:creationId xmlns:a16="http://schemas.microsoft.com/office/drawing/2014/main" id="{8FCA0C52-1056-44CB-B073-3BF9256E76F1}"/>
+                <a16:creationId xmlns:a16="http://schemas.microsoft.com/office/drawing/2014/main" id="{2EE2CAFF-C2AF-46B1-BAC6-0F94F9DA3D87}"/>
               </a:ext>
             </a:extLst>
           </p:cNvPr>
@@ -3866,7 +4051,7 @@
           <p:cNvPr id="7" name="">
             <a:extLst xmlns:a="http://schemas.openxmlformats.org/drawingml/2006/main">
               <a:ext uri="{FF2B5EF4-FFF2-40B4-BE49-F238E27FC236}">
-                <a16:creationId xmlns:a16="http://schemas.microsoft.com/office/drawing/2014/main" id="{4ACADE64-A7AF-408D-A893-692A7837628A}"/>
+                <a16:creationId xmlns:a16="http://schemas.microsoft.com/office/drawing/2014/main" id="{CD433A9C-3127-46D9-AF2C-2454DD781909}"/>
               </a:ext>
             </a:extLst>
           </p:cNvPr>
@@ -3954,7 +4139,7 @@
           <p:cNvPr id="8" name="">
             <a:extLst xmlns:a="http://schemas.openxmlformats.org/drawingml/2006/main">
               <a:ext uri="{FF2B5EF4-FFF2-40B4-BE49-F238E27FC236}">
-                <a16:creationId xmlns:a16="http://schemas.microsoft.com/office/drawing/2014/main" id="{151420BF-7358-4627-94D4-DC9893EF3661}"/>
+                <a16:creationId xmlns:a16="http://schemas.microsoft.com/office/drawing/2014/main" id="{C051337F-57DB-488F-97AB-0FDB3EA81FA2}"/>
               </a:ext>
             </a:extLst>
           </p:cNvPr>
@@ -4009,7 +4194,7 @@
     </p:spTree>
     <p:extLst>
       <p:ext uri="{BB962C8B-B14F-4D97-AF65-F5344CB8AC3E}">
-        <p14:creationId xmlns:p14="http://schemas.microsoft.com/office/powerpoint/2010/main" val="437529894"/>
+        <p14:creationId xmlns:p14="http://schemas.microsoft.com/office/powerpoint/2010/main" val="1602566686"/>
       </p:ext>
     </p:extLst>
   </p:cSld>
@@ -4040,7 +4225,7 @@
           <p:cNvPr id="13" name="">
             <a:extLst xmlns:a="http://schemas.openxmlformats.org/drawingml/2006/main">
               <a:ext uri="{FF2B5EF4-FFF2-40B4-BE49-F238E27FC236}">
-                <a16:creationId xmlns:a16="http://schemas.microsoft.com/office/drawing/2014/main" id="{EA0EB888-929C-4FFB-89C1-CCBA858102A9}"/>
+                <a16:creationId xmlns:a16="http://schemas.microsoft.com/office/drawing/2014/main" id="{1C9C52EB-3140-4C54-B274-1B59CEFE03DA}"/>
               </a:ext>
             </a:extLst>
           </p:cNvPr>
@@ -4097,7 +4282,7 @@
           <p:cNvPr id="2" name="">
             <a:extLst xmlns:a="http://schemas.openxmlformats.org/drawingml/2006/main">
               <a:ext uri="{FF2B5EF4-FFF2-40B4-BE49-F238E27FC236}">
-                <a16:creationId xmlns:a16="http://schemas.microsoft.com/office/drawing/2014/main" id="{BF56D12A-1A32-48B8-944A-99179BAF164B}"/>
+                <a16:creationId xmlns:a16="http://schemas.microsoft.com/office/drawing/2014/main" id="{56D5E256-0ADF-4923-B1C6-8A080D05A145}"/>
               </a:ext>
             </a:extLst>
           </p:cNvPr>
@@ -4154,7 +4339,7 @@
           <p:cNvPr id="3" name="">
             <a:extLst xmlns:a="http://schemas.openxmlformats.org/drawingml/2006/main">
               <a:ext uri="{FF2B5EF4-FFF2-40B4-BE49-F238E27FC236}">
-                <a16:creationId xmlns:a16="http://schemas.microsoft.com/office/drawing/2014/main" id="{1BB5D65C-C070-4980-B19F-8620F1567308}"/>
+                <a16:creationId xmlns:a16="http://schemas.microsoft.com/office/drawing/2014/main" id="{2FA10CC2-790B-4B5C-A652-60021A23B463}"/>
               </a:ext>
             </a:extLst>
           </p:cNvPr>
@@ -4211,7 +4396,7 @@
           <p:cNvPr id="4" name="">
             <a:extLst xmlns:a="http://schemas.openxmlformats.org/drawingml/2006/main">
               <a:ext uri="{FF2B5EF4-FFF2-40B4-BE49-F238E27FC236}">
-                <a16:creationId xmlns:a16="http://schemas.microsoft.com/office/drawing/2014/main" id="{52792544-C408-47F5-A436-304425A23F83}"/>
+                <a16:creationId xmlns:a16="http://schemas.microsoft.com/office/drawing/2014/main" id="{297E0CB4-3726-4A7E-B9E6-1A2AADDE778F}"/>
               </a:ext>
             </a:extLst>
           </p:cNvPr>
@@ -4268,7 +4453,7 @@
           <p:cNvPr id="5" name="">
             <a:extLst xmlns:a="http://schemas.openxmlformats.org/drawingml/2006/main">
               <a:ext uri="{FF2B5EF4-FFF2-40B4-BE49-F238E27FC236}">
-                <a16:creationId xmlns:a16="http://schemas.microsoft.com/office/drawing/2014/main" id="{C328850B-9593-44D6-8113-E618162F535E}"/>
+                <a16:creationId xmlns:a16="http://schemas.microsoft.com/office/drawing/2014/main" id="{D19F5D60-F27D-400D-A552-3F0B20B49277}"/>
               </a:ext>
             </a:extLst>
           </p:cNvPr>
@@ -4329,7 +4514,7 @@
           <p:cNvPr id="6" name="">
             <a:extLst xmlns:a="http://schemas.openxmlformats.org/drawingml/2006/main">
               <a:ext uri="{FF2B5EF4-FFF2-40B4-BE49-F238E27FC236}">
-                <a16:creationId xmlns:a16="http://schemas.microsoft.com/office/drawing/2014/main" id="{86400725-9640-43EC-8EC6-870EE511A84B}"/>
+                <a16:creationId xmlns:a16="http://schemas.microsoft.com/office/drawing/2014/main" id="{4F9103CC-1621-4A5A-ADE3-9C391C5AB764}"/>
               </a:ext>
             </a:extLst>
           </p:cNvPr>
@@ -4390,7 +4575,7 @@
           <p:cNvPr id="7" name="">
             <a:extLst xmlns:a="http://schemas.openxmlformats.org/drawingml/2006/main">
               <a:ext uri="{FF2B5EF4-FFF2-40B4-BE49-F238E27FC236}">
-                <a16:creationId xmlns:a16="http://schemas.microsoft.com/office/drawing/2014/main" id="{BBCC17C4-62F1-4C13-A4FA-BCBFBD677097}"/>
+                <a16:creationId xmlns:a16="http://schemas.microsoft.com/office/drawing/2014/main" id="{3F117799-7568-4DF1-BFBB-81434B55D607}"/>
               </a:ext>
             </a:extLst>
           </p:cNvPr>
@@ -4501,7 +4686,7 @@
           <p:cNvPr id="10" name="">
             <a:extLst xmlns:a="http://schemas.openxmlformats.org/drawingml/2006/main">
               <a:ext uri="{FF2B5EF4-FFF2-40B4-BE49-F238E27FC236}">
-                <a16:creationId xmlns:a16="http://schemas.microsoft.com/office/drawing/2014/main" id="{34965C22-73E6-4B66-BCB0-304E3B4047A3}"/>
+                <a16:creationId xmlns:a16="http://schemas.microsoft.com/office/drawing/2014/main" id="{41E8B592-AC7A-460A-8AB8-074C6180A215}"/>
               </a:ext>
             </a:extLst>
           </p:cNvPr>
@@ -4558,7 +4743,7 @@
           <p:cNvPr id="11" name="">
             <a:extLst xmlns:a="http://schemas.openxmlformats.org/drawingml/2006/main">
               <a:ext uri="{FF2B5EF4-FFF2-40B4-BE49-F238E27FC236}">
-                <a16:creationId xmlns:a16="http://schemas.microsoft.com/office/drawing/2014/main" id="{7776F767-C521-470B-8199-7A77793C1C7E}"/>
+                <a16:creationId xmlns:a16="http://schemas.microsoft.com/office/drawing/2014/main" id="{2F237106-9B1A-4F63-B5BB-527D15108607}"/>
               </a:ext>
             </a:extLst>
           </p:cNvPr>
@@ -4684,7 +4869,7 @@
           <p:cNvPr id="12" name="">
             <a:extLst xmlns:a="http://schemas.openxmlformats.org/drawingml/2006/main">
               <a:ext uri="{FF2B5EF4-FFF2-40B4-BE49-F238E27FC236}">
-                <a16:creationId xmlns:a16="http://schemas.microsoft.com/office/drawing/2014/main" id="{2A67ABF5-C377-4E3D-BDC2-FE0D16841CB8}"/>
+                <a16:creationId xmlns:a16="http://schemas.microsoft.com/office/drawing/2014/main" id="{4B67BF1F-E4CF-496C-B404-41C3C6E3D3B6}"/>
               </a:ext>
             </a:extLst>
           </p:cNvPr>
@@ -4739,7 +4924,7 @@
     </p:spTree>
     <p:extLst>
       <p:ext uri="{BB962C8B-B14F-4D97-AF65-F5344CB8AC3E}">
-        <p14:creationId xmlns:p14="http://schemas.microsoft.com/office/powerpoint/2010/main" val="2087244839"/>
+        <p14:creationId xmlns:p14="http://schemas.microsoft.com/office/powerpoint/2010/main" val="2147352040"/>
       </p:ext>
     </p:extLst>
   </p:cSld>
@@ -4770,7 +4955,7 @@
           <p:cNvPr id="13" name="">
             <a:extLst xmlns:a="http://schemas.openxmlformats.org/drawingml/2006/main">
               <a:ext uri="{FF2B5EF4-FFF2-40B4-BE49-F238E27FC236}">
-                <a16:creationId xmlns:a16="http://schemas.microsoft.com/office/drawing/2014/main" id="{D6B03CEB-2895-484A-B249-A17BF341E5D1}"/>
+                <a16:creationId xmlns:a16="http://schemas.microsoft.com/office/drawing/2014/main" id="{F571348B-5634-4B92-86BE-ECC0051FC272}"/>
               </a:ext>
             </a:extLst>
           </p:cNvPr>
@@ -4827,7 +5012,7 @@
           <p:cNvPr id="2" name="">
             <a:extLst xmlns:a="http://schemas.openxmlformats.org/drawingml/2006/main">
               <a:ext uri="{FF2B5EF4-FFF2-40B4-BE49-F238E27FC236}">
-                <a16:creationId xmlns:a16="http://schemas.microsoft.com/office/drawing/2014/main" id="{3C3657BD-BD0C-452C-9793-DC55D7138FA2}"/>
+                <a16:creationId xmlns:a16="http://schemas.microsoft.com/office/drawing/2014/main" id="{AD8C73CF-4C8F-43DD-835A-EEC0AC7C18F6}"/>
               </a:ext>
             </a:extLst>
           </p:cNvPr>
@@ -4884,7 +5069,7 @@
           <p:cNvPr id="3" name="">
             <a:extLst xmlns:a="http://schemas.openxmlformats.org/drawingml/2006/main">
               <a:ext uri="{FF2B5EF4-FFF2-40B4-BE49-F238E27FC236}">
-                <a16:creationId xmlns:a16="http://schemas.microsoft.com/office/drawing/2014/main" id="{EBEEB2E8-B802-415F-AEF0-2E1A089AADC8}"/>
+                <a16:creationId xmlns:a16="http://schemas.microsoft.com/office/drawing/2014/main" id="{4BD25B97-C615-42DA-AFA2-8112A1F7B609}"/>
               </a:ext>
             </a:extLst>
           </p:cNvPr>
@@ -4941,7 +5126,7 @@
           <p:cNvPr id="4" name="">
             <a:extLst xmlns:a="http://schemas.openxmlformats.org/drawingml/2006/main">
               <a:ext uri="{FF2B5EF4-FFF2-40B4-BE49-F238E27FC236}">
-                <a16:creationId xmlns:a16="http://schemas.microsoft.com/office/drawing/2014/main" id="{F63F8304-6F68-4D37-A964-2878A120AEEF}"/>
+                <a16:creationId xmlns:a16="http://schemas.microsoft.com/office/drawing/2014/main" id="{12304A59-9880-4B55-AD64-51ED67817C5C}"/>
               </a:ext>
             </a:extLst>
           </p:cNvPr>
@@ -4998,7 +5183,7 @@
           <p:cNvPr id="5" name="">
             <a:extLst xmlns:a="http://schemas.openxmlformats.org/drawingml/2006/main">
               <a:ext uri="{FF2B5EF4-FFF2-40B4-BE49-F238E27FC236}">
-                <a16:creationId xmlns:a16="http://schemas.microsoft.com/office/drawing/2014/main" id="{7DC353DE-BE50-4E72-B03B-C5BD502D8760}"/>
+                <a16:creationId xmlns:a16="http://schemas.microsoft.com/office/drawing/2014/main" id="{E4867F57-793E-469F-BA13-28BC4539E9E5}"/>
               </a:ext>
             </a:extLst>
           </p:cNvPr>
@@ -5082,7 +5267,7 @@
           <p:cNvPr id="6" name="">
             <a:extLst xmlns:a="http://schemas.openxmlformats.org/drawingml/2006/main">
               <a:ext uri="{FF2B5EF4-FFF2-40B4-BE49-F238E27FC236}">
-                <a16:creationId xmlns:a16="http://schemas.microsoft.com/office/drawing/2014/main" id="{9A422DB6-A5C1-4357-A9AA-75DBA242801D}"/>
+                <a16:creationId xmlns:a16="http://schemas.microsoft.com/office/drawing/2014/main" id="{E5E76F25-CA7F-47B9-B0E1-FD30A42ADB91}"/>
               </a:ext>
             </a:extLst>
           </p:cNvPr>
@@ -5143,7 +5328,7 @@
           <p:cNvPr id="7" name="">
             <a:extLst xmlns:a="http://schemas.openxmlformats.org/drawingml/2006/main">
               <a:ext uri="{FF2B5EF4-FFF2-40B4-BE49-F238E27FC236}">
-                <a16:creationId xmlns:a16="http://schemas.microsoft.com/office/drawing/2014/main" id="{7A8CA3F0-E39C-4676-BE70-CC6AF989F3C0}"/>
+                <a16:creationId xmlns:a16="http://schemas.microsoft.com/office/drawing/2014/main" id="{F5407F16-F1AE-48B6-B79E-812121A83599}"/>
               </a:ext>
             </a:extLst>
           </p:cNvPr>
@@ -5277,7 +5462,7 @@
           <p:cNvPr id="10" name="">
             <a:extLst xmlns:a="http://schemas.openxmlformats.org/drawingml/2006/main">
               <a:ext uri="{FF2B5EF4-FFF2-40B4-BE49-F238E27FC236}">
-                <a16:creationId xmlns:a16="http://schemas.microsoft.com/office/drawing/2014/main" id="{1F5EBCC8-A1D5-4A5F-B8A3-77B4C691E8C7}"/>
+                <a16:creationId xmlns:a16="http://schemas.microsoft.com/office/drawing/2014/main" id="{A3ACADC1-727B-4BED-9813-2AB09DA64FD9}"/>
               </a:ext>
             </a:extLst>
           </p:cNvPr>
@@ -5570,7 +5755,7 @@
           <p:cNvPr id="12" name="">
             <a:extLst xmlns:a="http://schemas.openxmlformats.org/drawingml/2006/main">
               <a:ext uri="{FF2B5EF4-FFF2-40B4-BE49-F238E27FC236}">
-                <a16:creationId xmlns:a16="http://schemas.microsoft.com/office/drawing/2014/main" id="{6C4D64B8-C713-45C8-BBF5-2692E1944908}"/>
+                <a16:creationId xmlns:a16="http://schemas.microsoft.com/office/drawing/2014/main" id="{3ECDC01B-913E-4010-B155-CC7A1166D028}"/>
               </a:ext>
             </a:extLst>
           </p:cNvPr>
@@ -5625,7 +5810,7 @@
     </p:spTree>
     <p:extLst>
       <p:ext uri="{BB962C8B-B14F-4D97-AF65-F5344CB8AC3E}">
-        <p14:creationId xmlns:p14="http://schemas.microsoft.com/office/powerpoint/2010/main" val="171491040"/>
+        <p14:creationId xmlns:p14="http://schemas.microsoft.com/office/powerpoint/2010/main" val="1386148020"/>
       </p:ext>
     </p:extLst>
   </p:cSld>
@@ -5656,7 +5841,7 @@
           <p:cNvPr id="9" name="">
             <a:extLst xmlns:a="http://schemas.openxmlformats.org/drawingml/2006/main">
               <a:ext uri="{FF2B5EF4-FFF2-40B4-BE49-F238E27FC236}">
-                <a16:creationId xmlns:a16="http://schemas.microsoft.com/office/drawing/2014/main" id="{1F7C30E4-DA30-46FD-A575-0D65F124FA2E}"/>
+                <a16:creationId xmlns:a16="http://schemas.microsoft.com/office/drawing/2014/main" id="{0286CB63-137E-4EFA-9B50-3C3482B582CD}"/>
               </a:ext>
             </a:extLst>
           </p:cNvPr>
@@ -5713,7 +5898,7 @@
           <p:cNvPr id="2" name="">
             <a:extLst xmlns:a="http://schemas.openxmlformats.org/drawingml/2006/main">
               <a:ext uri="{FF2B5EF4-FFF2-40B4-BE49-F238E27FC236}">
-                <a16:creationId xmlns:a16="http://schemas.microsoft.com/office/drawing/2014/main" id="{394C30AD-70B0-46F2-A323-550D05375787}"/>
+                <a16:creationId xmlns:a16="http://schemas.microsoft.com/office/drawing/2014/main" id="{3DAE715A-824C-40E1-B2B1-37885B5BCC57}"/>
               </a:ext>
             </a:extLst>
           </p:cNvPr>
@@ -5770,7 +5955,7 @@
           <p:cNvPr id="3" name="">
             <a:extLst xmlns:a="http://schemas.openxmlformats.org/drawingml/2006/main">
               <a:ext uri="{FF2B5EF4-FFF2-40B4-BE49-F238E27FC236}">
-                <a16:creationId xmlns:a16="http://schemas.microsoft.com/office/drawing/2014/main" id="{57502E01-4129-464F-9DF1-B6A6906A0756}"/>
+                <a16:creationId xmlns:a16="http://schemas.microsoft.com/office/drawing/2014/main" id="{581FC795-E85D-476F-91F9-AB493D6C9827}"/>
               </a:ext>
             </a:extLst>
           </p:cNvPr>
@@ -5827,7 +6012,7 @@
           <p:cNvPr id="4" name="">
             <a:extLst xmlns:a="http://schemas.openxmlformats.org/drawingml/2006/main">
               <a:ext uri="{FF2B5EF4-FFF2-40B4-BE49-F238E27FC236}">
-                <a16:creationId xmlns:a16="http://schemas.microsoft.com/office/drawing/2014/main" id="{9D4C14FB-155E-4B63-BA8B-630BBBADC4C0}"/>
+                <a16:creationId xmlns:a16="http://schemas.microsoft.com/office/drawing/2014/main" id="{8B8B375B-FDFC-4991-A80C-8AD6D12A294C}"/>
               </a:ext>
             </a:extLst>
           </p:cNvPr>
@@ -5884,7 +6069,7 @@
           <p:cNvPr id="5" name="">
             <a:extLst xmlns:a="http://schemas.openxmlformats.org/drawingml/2006/main">
               <a:ext uri="{FF2B5EF4-FFF2-40B4-BE49-F238E27FC236}">
-                <a16:creationId xmlns:a16="http://schemas.microsoft.com/office/drawing/2014/main" id="{E99A8972-D996-4DBE-B9DA-866C932F0E2B}"/>
+                <a16:creationId xmlns:a16="http://schemas.microsoft.com/office/drawing/2014/main" id="{875EF708-88CD-493E-8B46-9F31BE48B0C4}"/>
               </a:ext>
             </a:extLst>
           </p:cNvPr>
@@ -5964,7 +6149,7 @@
           <p:cNvPr id="6" name="">
             <a:extLst xmlns:a="http://schemas.openxmlformats.org/drawingml/2006/main">
               <a:ext uri="{FF2B5EF4-FFF2-40B4-BE49-F238E27FC236}">
-                <a16:creationId xmlns:a16="http://schemas.microsoft.com/office/drawing/2014/main" id="{A8604581-757F-472F-B82D-8E22A41C3C8B}"/>
+                <a16:creationId xmlns:a16="http://schemas.microsoft.com/office/drawing/2014/main" id="{ECB7770F-5F80-4E99-9A49-9D6C3B2609B3}"/>
               </a:ext>
             </a:extLst>
           </p:cNvPr>
@@ -6021,7 +6206,7 @@
           <p:cNvPr id="7" name="">
             <a:extLst xmlns:a="http://schemas.openxmlformats.org/drawingml/2006/main">
               <a:ext uri="{FF2B5EF4-FFF2-40B4-BE49-F238E27FC236}">
-                <a16:creationId xmlns:a16="http://schemas.microsoft.com/office/drawing/2014/main" id="{E454BEBA-E739-49F5-AB91-AE877AD13735}"/>
+                <a16:creationId xmlns:a16="http://schemas.microsoft.com/office/drawing/2014/main" id="{C4E59603-A2E9-40E1-AAF9-6D23D4ED2DAF}"/>
               </a:ext>
             </a:extLst>
           </p:cNvPr>
@@ -6306,7 +6491,7 @@
     </p:spTree>
     <p:extLst>
       <p:ext uri="{BB962C8B-B14F-4D97-AF65-F5344CB8AC3E}">
-        <p14:creationId xmlns:p14="http://schemas.microsoft.com/office/powerpoint/2010/main" val="1246298868"/>
+        <p14:creationId xmlns:p14="http://schemas.microsoft.com/office/powerpoint/2010/main" val="1795389812"/>
       </p:ext>
     </p:extLst>
   </p:cSld>
@@ -6337,7 +6522,7 @@
           <p:cNvPr id="7" name="">
             <a:extLst xmlns:a="http://schemas.openxmlformats.org/drawingml/2006/main">
               <a:ext uri="{FF2B5EF4-FFF2-40B4-BE49-F238E27FC236}">
-                <a16:creationId xmlns:a16="http://schemas.microsoft.com/office/drawing/2014/main" id="{AE1710C1-C96D-4883-A71E-5E91AB2E2E4B}"/>
+                <a16:creationId xmlns:a16="http://schemas.microsoft.com/office/drawing/2014/main" id="{D941C514-487B-4A04-ABCE-1CADEB9DDC76}"/>
               </a:ext>
             </a:extLst>
           </p:cNvPr>
@@ -6394,7 +6579,7 @@
           <p:cNvPr id="2" name="">
             <a:extLst xmlns:a="http://schemas.openxmlformats.org/drawingml/2006/main">
               <a:ext uri="{FF2B5EF4-FFF2-40B4-BE49-F238E27FC236}">
-                <a16:creationId xmlns:a16="http://schemas.microsoft.com/office/drawing/2014/main" id="{BA676DD2-77BE-4960-9CCF-DCCCC4D650A9}"/>
+                <a16:creationId xmlns:a16="http://schemas.microsoft.com/office/drawing/2014/main" id="{AC1C99D8-9C27-4F97-AA8F-09620EB4C0C6}"/>
               </a:ext>
             </a:extLst>
           </p:cNvPr>
@@ -6451,7 +6636,7 @@
           <p:cNvPr id="3" name="">
             <a:extLst xmlns:a="http://schemas.openxmlformats.org/drawingml/2006/main">
               <a:ext uri="{FF2B5EF4-FFF2-40B4-BE49-F238E27FC236}">
-                <a16:creationId xmlns:a16="http://schemas.microsoft.com/office/drawing/2014/main" id="{74995C4D-1DE2-4029-B1D9-DDF5045DC50C}"/>
+                <a16:creationId xmlns:a16="http://schemas.microsoft.com/office/drawing/2014/main" id="{DE26D56C-CC83-4D2D-A986-7B0F0A3AA803}"/>
               </a:ext>
             </a:extLst>
           </p:cNvPr>
@@ -6746,7 +6931,7 @@
           <p:cNvPr id="5" name="">
             <a:extLst xmlns:a="http://schemas.openxmlformats.org/drawingml/2006/main">
               <a:ext uri="{FF2B5EF4-FFF2-40B4-BE49-F238E27FC236}">
-                <a16:creationId xmlns:a16="http://schemas.microsoft.com/office/drawing/2014/main" id="{6D2DBBA8-5C98-43BC-84C5-A014C6F3874D}"/>
+                <a16:creationId xmlns:a16="http://schemas.microsoft.com/office/drawing/2014/main" id="{0C32D742-77B0-42B4-B099-5458AE371525}"/>
               </a:ext>
             </a:extLst>
           </p:cNvPr>
@@ -6826,7 +7011,7 @@
           <p:cNvPr id="6" name="">
             <a:extLst xmlns:a="http://schemas.openxmlformats.org/drawingml/2006/main">
               <a:ext uri="{FF2B5EF4-FFF2-40B4-BE49-F238E27FC236}">
-                <a16:creationId xmlns:a16="http://schemas.microsoft.com/office/drawing/2014/main" id="{3361CEBF-7DAB-47E0-BF8A-3A3638B907F6}"/>
+                <a16:creationId xmlns:a16="http://schemas.microsoft.com/office/drawing/2014/main" id="{C75DB40E-667F-4CC6-9E7A-A886D34EA2B4}"/>
               </a:ext>
             </a:extLst>
           </p:cNvPr>
@@ -6881,7 +7066,7 @@
     </p:spTree>
     <p:extLst>
       <p:ext uri="{BB962C8B-B14F-4D97-AF65-F5344CB8AC3E}">
-        <p14:creationId xmlns:p14="http://schemas.microsoft.com/office/powerpoint/2010/main" val="1155768584"/>
+        <p14:creationId xmlns:p14="http://schemas.microsoft.com/office/powerpoint/2010/main" val="1530388932"/>
       </p:ext>
     </p:extLst>
   </p:cSld>
@@ -6912,7 +7097,7 @@
           <p:cNvPr id="10" name="">
             <a:extLst xmlns:a="http://schemas.openxmlformats.org/drawingml/2006/main">
               <a:ext uri="{FF2B5EF4-FFF2-40B4-BE49-F238E27FC236}">
-                <a16:creationId xmlns:a16="http://schemas.microsoft.com/office/drawing/2014/main" id="{E743F609-746B-47D3-A2AE-8C96D50FAC58}"/>
+                <a16:creationId xmlns:a16="http://schemas.microsoft.com/office/drawing/2014/main" id="{7C4FBCEF-E665-4ECA-9458-841AF728DBAF}"/>
               </a:ext>
             </a:extLst>
           </p:cNvPr>
@@ -6969,7 +7154,7 @@
           <p:cNvPr id="2" name="">
             <a:extLst xmlns:a="http://schemas.openxmlformats.org/drawingml/2006/main">
               <a:ext uri="{FF2B5EF4-FFF2-40B4-BE49-F238E27FC236}">
-                <a16:creationId xmlns:a16="http://schemas.microsoft.com/office/drawing/2014/main" id="{818BB125-06AE-43E0-A28F-28FB1A9711F1}"/>
+                <a16:creationId xmlns:a16="http://schemas.microsoft.com/office/drawing/2014/main" id="{9F2F6380-427E-4161-9DFD-B504FC098B38}"/>
               </a:ext>
             </a:extLst>
           </p:cNvPr>
@@ -7026,7 +7211,7 @@
           <p:cNvPr id="3" name="">
             <a:extLst xmlns:a="http://schemas.openxmlformats.org/drawingml/2006/main">
               <a:ext uri="{FF2B5EF4-FFF2-40B4-BE49-F238E27FC236}">
-                <a16:creationId xmlns:a16="http://schemas.microsoft.com/office/drawing/2014/main" id="{8ACC0460-5176-49A3-B622-F90D51D2C2DE}"/>
+                <a16:creationId xmlns:a16="http://schemas.microsoft.com/office/drawing/2014/main" id="{20D0262E-37D4-4FD2-A5B4-B556AFAFC7DD}"/>
               </a:ext>
             </a:extLst>
           </p:cNvPr>
@@ -7083,7 +7268,7 @@
           <p:cNvPr id="4" name="">
             <a:extLst xmlns:a="http://schemas.openxmlformats.org/drawingml/2006/main">
               <a:ext uri="{FF2B5EF4-FFF2-40B4-BE49-F238E27FC236}">
-                <a16:creationId xmlns:a16="http://schemas.microsoft.com/office/drawing/2014/main" id="{FB5E3A36-C794-486A-8732-FCA0C597CA3A}"/>
+                <a16:creationId xmlns:a16="http://schemas.microsoft.com/office/drawing/2014/main" id="{AB16095D-7070-45DD-9E60-1DD4D68C52E5}"/>
               </a:ext>
             </a:extLst>
           </p:cNvPr>
@@ -7130,7 +7315,7 @@
                 <a:ea typeface="Arial"/>
                 <a:cs typeface="Arial"/>
               </a:rPr>
-              <a:t>A reproducible model comparison</a:t>
+              <a:t>Evidence for the classifier choice</a:t>
             </a:r>
           </a:p>
         </p:txBody>
@@ -7140,7 +7325,7 @@
           <p:cNvPr id="5" name="">
             <a:extLst xmlns:a="http://schemas.openxmlformats.org/drawingml/2006/main">
               <a:ext uri="{FF2B5EF4-FFF2-40B4-BE49-F238E27FC236}">
-                <a16:creationId xmlns:a16="http://schemas.microsoft.com/office/drawing/2014/main" id="{95A79F2D-6ABD-407D-A699-31B60B2C334F}"/>
+                <a16:creationId xmlns:a16="http://schemas.microsoft.com/office/drawing/2014/main" id="{CB3F9C68-93E0-428A-A64F-B9A294A81CDD}"/>
               </a:ext>
             </a:extLst>
           </p:cNvPr>
@@ -7187,7 +7372,7 @@
                 <a:ea typeface="Arial"/>
                 <a:cs typeface="Arial"/>
               </a:rPr>
-              <a:t>Combined measurements reduced false flags, with a tradeoff in missed cases.</a:t>
+              <a:t>CatBoost missed 8 fewer rejection cases than logistic, with 8 false flags each.</a:t>
             </a:r>
           </a:p>
           <a:p xmlns:a="http://schemas.openxmlformats.org/drawingml/2006/main">
@@ -7210,7 +7395,7 @@
                 <a:ea typeface="Arial"/>
                 <a:cs typeface="Arial"/>
               </a:rPr>
-              <a:t>The practical advantage over logistic regression remains uncertain.</a:t>
+              <a:t>A dependable advantage remains uncertain.</a:t>
             </a:r>
           </a:p>
         </p:txBody>
@@ -7220,7 +7405,7 @@
           <p:cNvPr id="6" name="">
             <a:extLst xmlns:a="http://schemas.openxmlformats.org/drawingml/2006/main">
               <a:ext uri="{FF2B5EF4-FFF2-40B4-BE49-F238E27FC236}">
-                <a16:creationId xmlns:a16="http://schemas.microsoft.com/office/drawing/2014/main" id="{5AFB34B5-29D2-49AE-8C64-5AC54BF0EAF1}"/>
+                <a16:creationId xmlns:a16="http://schemas.microsoft.com/office/drawing/2014/main" id="{8D07A37B-B033-46B3-9909-D8D1E8DBF24B}"/>
               </a:ext>
             </a:extLst>
           </p:cNvPr>
@@ -7249,7 +7434,7 @@
           <p:cNvPr id="7" name="">
             <a:extLst xmlns:a="http://schemas.openxmlformats.org/drawingml/2006/main">
               <a:ext uri="{FF2B5EF4-FFF2-40B4-BE49-F238E27FC236}">
-                <a16:creationId xmlns:a16="http://schemas.microsoft.com/office/drawing/2014/main" id="{2F6DC42F-F4FE-4219-809C-22B20D22EF61}"/>
+                <a16:creationId xmlns:a16="http://schemas.microsoft.com/office/drawing/2014/main" id="{869691A3-64E7-4C9C-A867-DC424B464BA4}"/>
               </a:ext>
             </a:extLst>
           </p:cNvPr>
@@ -7306,7 +7491,7 @@
           <p:cNvPr id="8" name="">
             <a:extLst xmlns:a="http://schemas.openxmlformats.org/drawingml/2006/main">
               <a:ext uri="{FF2B5EF4-FFF2-40B4-BE49-F238E27FC236}">
-                <a16:creationId xmlns:a16="http://schemas.microsoft.com/office/drawing/2014/main" id="{46BBFAF6-490B-4D8D-9F3A-EB94276F4E80}"/>
+                <a16:creationId xmlns:a16="http://schemas.microsoft.com/office/drawing/2014/main" id="{B5BFC880-BE2F-4D97-AD7A-A79C557E6188}"/>
               </a:ext>
             </a:extLst>
           </p:cNvPr>
@@ -7363,19 +7548,19 @@
           <p:cNvPr id="9" name="">
             <a:extLst xmlns:a="http://schemas.openxmlformats.org/drawingml/2006/main">
               <a:ext uri="{FF2B5EF4-FFF2-40B4-BE49-F238E27FC236}">
-                <a16:creationId xmlns:a16="http://schemas.microsoft.com/office/drawing/2014/main" id="{686D544B-B4CD-4897-B73D-D93F0B3E7F8E}"/>
-              </a:ext>
-            </a:extLst>
-          </p:cNvPr>
-          <p:cNvSpPr>
-            <a:spLocks xmlns:a="http://schemas.openxmlformats.org/drawingml/2006/main" noGrp="1"/>
-          </p:cNvSpPr>
-          <p:nvPr/>
-        </p:nvSpPr>
-        <p:spPr>
-          <a:xfrm xmlns:a="http://schemas.openxmlformats.org/drawingml/2006/main">
-            <a:off x="609600" y="5629275"/>
-            <a:ext cx="10972800" cy="457200"/>
+                <a16:creationId xmlns:a16="http://schemas.microsoft.com/office/drawing/2014/main" id="{877465D6-6FED-4DED-B2BB-3C4D5CFA05D6}"/>
+              </a:ext>
+            </a:extLst>
+          </p:cNvPr>
+          <p:cNvSpPr>
+            <a:spLocks xmlns:a="http://schemas.openxmlformats.org/drawingml/2006/main" noGrp="1"/>
+          </p:cNvSpPr>
+          <p:nvPr/>
+        </p:nvSpPr>
+        <p:spPr>
+          <a:xfrm xmlns:a="http://schemas.openxmlformats.org/drawingml/2006/main">
+            <a:off x="609600" y="5514975"/>
+            <a:ext cx="10972800" cy="666750"/>
           </a:xfrm>
           <a:prstGeom xmlns:a="http://schemas.openxmlformats.org/drawingml/2006/main" prst="rect">
             <a:avLst/>
@@ -7392,7 +7577,7 @@
           <a:lstStyle xmlns:a="http://schemas.openxmlformats.org/drawingml/2006/main"/>
           <a:p xmlns:a="http://schemas.openxmlformats.org/drawingml/2006/main">
             <a:pPr algn="l">
-              <a:defRPr sz="2100" b="0">
+              <a:defRPr sz="1950" b="0">
                 <a:solidFill>
                   <a:srgbClr val="FFFFFF"/>
                 </a:solidFill>
@@ -7402,7 +7587,7 @@
               </a:defRPr>
             </a:pPr>
             <a:r>
-              <a:rPr sz="2100" b="0">
+              <a:rPr sz="1950" b="0">
                 <a:solidFill>
                   <a:srgbClr val="FFFFFF"/>
                 </a:solidFill>
@@ -7410,7 +7595,30 @@
                 <a:ea typeface="Arial"/>
                 <a:cs typeface="Arial"/>
               </a:rPr>
-              <a:t>Added value for uncertain biopsies still needs direct evaluation.</a:t>
+              <a:t>Next: cross-validation within discovery.</a:t>
+            </a:r>
+          </a:p>
+          <a:p xmlns:a="http://schemas.openxmlformats.org/drawingml/2006/main">
+            <a:pPr algn="l">
+              <a:defRPr sz="1950" b="0">
+                <a:solidFill>
+                  <a:srgbClr val="FFFFFF"/>
+                </a:solidFill>
+                <a:latin typeface="Arial"/>
+                <a:ea typeface="Arial"/>
+                <a:cs typeface="Arial"/>
+              </a:defRPr>
+            </a:pPr>
+            <a:r>
+              <a:rPr sz="1950" b="0">
+                <a:solidFill>
+                  <a:srgbClr val="FFFFFF"/>
+                </a:solidFill>
+                <a:latin typeface="Arial"/>
+                <a:ea typeface="Arial"/>
+                <a:cs typeface="Arial"/>
+              </a:rPr>
+              <a:t>Added diagnostic value of this particular score needs direct evaluation.</a:t>
             </a:r>
           </a:p>
         </p:txBody>
@@ -7418,7 +7626,7 @@
     </p:spTree>
     <p:extLst>
       <p:ext uri="{BB962C8B-B14F-4D97-AF65-F5344CB8AC3E}">
-        <p14:creationId xmlns:p14="http://schemas.microsoft.com/office/powerpoint/2010/main" val="1304344453"/>
+        <p14:creationId xmlns:p14="http://schemas.microsoft.com/office/powerpoint/2010/main" val="1086332129"/>
       </p:ext>
     </p:extLst>
   </p:cSld>
@@ -7449,7 +7657,7 @@
           <p:cNvPr id="8" name="">
             <a:extLst xmlns:a="http://schemas.openxmlformats.org/drawingml/2006/main">
               <a:ext uri="{FF2B5EF4-FFF2-40B4-BE49-F238E27FC236}">
-                <a16:creationId xmlns:a16="http://schemas.microsoft.com/office/drawing/2014/main" id="{2904ADFA-06F0-4E8B-8403-CD04B631350F}"/>
+                <a16:creationId xmlns:a16="http://schemas.microsoft.com/office/drawing/2014/main" id="{E5AACE76-F09B-4101-B69F-319645C3B164}"/>
               </a:ext>
             </a:extLst>
           </p:cNvPr>
@@ -7506,7 +7714,7 @@
           <p:cNvPr id="2" name="">
             <a:extLst xmlns:a="http://schemas.openxmlformats.org/drawingml/2006/main">
               <a:ext uri="{FF2B5EF4-FFF2-40B4-BE49-F238E27FC236}">
-                <a16:creationId xmlns:a16="http://schemas.microsoft.com/office/drawing/2014/main" id="{1BF56291-845F-41C0-9717-365516CE930C}"/>
+                <a16:creationId xmlns:a16="http://schemas.microsoft.com/office/drawing/2014/main" id="{2165E769-3B74-4AFC-B649-30DD52B6B0B9}"/>
               </a:ext>
             </a:extLst>
           </p:cNvPr>
@@ -7563,7 +7771,7 @@
           <p:cNvPr id="3" name="">
             <a:extLst xmlns:a="http://schemas.openxmlformats.org/drawingml/2006/main">
               <a:ext uri="{FF2B5EF4-FFF2-40B4-BE49-F238E27FC236}">
-                <a16:creationId xmlns:a16="http://schemas.microsoft.com/office/drawing/2014/main" id="{833A5581-2430-49C5-822F-F3ECC2FF2B75}"/>
+                <a16:creationId xmlns:a16="http://schemas.microsoft.com/office/drawing/2014/main" id="{526093F8-240E-4697-BE53-38CF30458E9D}"/>
               </a:ext>
             </a:extLst>
           </p:cNvPr>
@@ -7620,7 +7828,7 @@
           <p:cNvPr id="4" name="">
             <a:extLst xmlns:a="http://schemas.openxmlformats.org/drawingml/2006/main">
               <a:ext uri="{FF2B5EF4-FFF2-40B4-BE49-F238E27FC236}">
-                <a16:creationId xmlns:a16="http://schemas.microsoft.com/office/drawing/2014/main" id="{A7B488D8-8CAA-45B7-B3CB-EDB02CB44418}"/>
+                <a16:creationId xmlns:a16="http://schemas.microsoft.com/office/drawing/2014/main" id="{B3E775AA-DCF2-44F9-BA82-8E6D6CB7C49A}"/>
               </a:ext>
             </a:extLst>
           </p:cNvPr>
@@ -7677,7 +7885,7 @@
           <p:cNvPr id="5" name="">
             <a:extLst xmlns:a="http://schemas.openxmlformats.org/drawingml/2006/main">
               <a:ext uri="{FF2B5EF4-FFF2-40B4-BE49-F238E27FC236}">
-                <a16:creationId xmlns:a16="http://schemas.microsoft.com/office/drawing/2014/main" id="{7EDBE9F1-32FA-47ED-B77F-396AA223BC9D}"/>
+                <a16:creationId xmlns:a16="http://schemas.microsoft.com/office/drawing/2014/main" id="{5B477F46-999E-4402-B044-6C544FAE59FC}"/>
               </a:ext>
             </a:extLst>
           </p:cNvPr>
@@ -7734,7 +7942,7 @@
           <p:cNvPr id="6" name="">
             <a:extLst xmlns:a="http://schemas.openxmlformats.org/drawingml/2006/main">
               <a:ext uri="{FF2B5EF4-FFF2-40B4-BE49-F238E27FC236}">
-                <a16:creationId xmlns:a16="http://schemas.microsoft.com/office/drawing/2014/main" id="{CB697DF7-C04E-4293-B67B-8A5D5CFD271C}"/>
+                <a16:creationId xmlns:a16="http://schemas.microsoft.com/office/drawing/2014/main" id="{3C0411FF-8FF5-4EAA-8C68-6A9D258F4611}"/>
               </a:ext>
             </a:extLst>
           </p:cNvPr>
@@ -7791,7 +7999,7 @@
           <p:cNvPr id="7" name="">
             <a:extLst xmlns:a="http://schemas.openxmlformats.org/drawingml/2006/main">
               <a:ext uri="{FF2B5EF4-FFF2-40B4-BE49-F238E27FC236}">
-                <a16:creationId xmlns:a16="http://schemas.microsoft.com/office/drawing/2014/main" id="{7E004F19-B81B-4144-A52C-A96B85BE0EBE}"/>
+                <a16:creationId xmlns:a16="http://schemas.microsoft.com/office/drawing/2014/main" id="{9DA87B9A-090F-4236-9B5C-644E807A74CE}"/>
               </a:ext>
             </a:extLst>
           </p:cNvPr>
@@ -7846,7 +8054,7 @@
     </p:spTree>
     <p:extLst>
       <p:ext uri="{BB962C8B-B14F-4D97-AF65-F5344CB8AC3E}">
-        <p14:creationId xmlns:p14="http://schemas.microsoft.com/office/powerpoint/2010/main" val="1079463213"/>
+        <p14:creationId xmlns:p14="http://schemas.microsoft.com/office/powerpoint/2010/main" val="1604476119"/>
       </p:ext>
     </p:extLst>
   </p:cSld>
@@ -7874,10 +8082,10 @@
       </p:grpSpPr>
       <p:sp>
         <p:nvSpPr>
-          <p:cNvPr id="9" name="">
-            <a:extLst xmlns:a="http://schemas.openxmlformats.org/drawingml/2006/main">
-              <a:ext uri="{FF2B5EF4-FFF2-40B4-BE49-F238E27FC236}">
-                <a16:creationId xmlns:a16="http://schemas.microsoft.com/office/drawing/2014/main" id="{8A12B356-626B-4EBE-9F7C-DF1023FCE5BA}"/>
+          <p:cNvPr id="6" name="">
+            <a:extLst xmlns:a="http://schemas.openxmlformats.org/drawingml/2006/main">
+              <a:ext uri="{FF2B5EF4-FFF2-40B4-BE49-F238E27FC236}">
+                <a16:creationId xmlns:a16="http://schemas.microsoft.com/office/drawing/2014/main" id="{8C7CC288-B6D6-4EE7-91C3-FBAA20CB37B8}"/>
               </a:ext>
             </a:extLst>
           </p:cNvPr>
@@ -7924,7 +8132,7 @@
                 <a:ea typeface="Arial"/>
                 <a:cs typeface="Arial"/>
               </a:rPr>
-              <a:t>Possible Use: Molecular Second Opinion for Ambiguous Biopsies</a:t>
+              <a:t>Purpose of this project</a:t>
             </a:r>
           </a:p>
         </p:txBody>
@@ -7934,7 +8142,7 @@
           <p:cNvPr id="2" name="">
             <a:extLst xmlns:a="http://schemas.openxmlformats.org/drawingml/2006/main">
               <a:ext uri="{FF2B5EF4-FFF2-40B4-BE49-F238E27FC236}">
-                <a16:creationId xmlns:a16="http://schemas.microsoft.com/office/drawing/2014/main" id="{7C7235CB-D6B6-418B-A12A-CCDF7A1DA6FC}"/>
+                <a16:creationId xmlns:a16="http://schemas.microsoft.com/office/drawing/2014/main" id="{6DCC2A99-696D-4E71-B44E-608A723A5CC9}"/>
               </a:ext>
             </a:extLst>
           </p:cNvPr>
@@ -7981,7 +8189,7 @@
                 <a:ea typeface="Arial"/>
                 <a:cs typeface="Arial"/>
               </a:rPr>
-              <a:t>Sources: Banff reference guide (Apr 2026); Nankivell et al. (2019)</a:t>
+              <a:t>Clinical context: Banff Reference Guide (2026). Public data: Zhang et al. (2024).</a:t>
             </a:r>
           </a:p>
         </p:txBody>
@@ -7991,7 +8199,7 @@
           <p:cNvPr id="3" name="">
             <a:extLst xmlns:a="http://schemas.openxmlformats.org/drawingml/2006/main">
               <a:ext uri="{FF2B5EF4-FFF2-40B4-BE49-F238E27FC236}">
-                <a16:creationId xmlns:a16="http://schemas.microsoft.com/office/drawing/2014/main" id="{E5FAC02F-E279-4894-BF27-B544964826FC}"/>
+                <a16:creationId xmlns:a16="http://schemas.microsoft.com/office/drawing/2014/main" id="{50EFC309-97C9-474C-A6FC-618DEA7DDE9E}"/>
               </a:ext>
             </a:extLst>
           </p:cNvPr>
@@ -8048,19 +8256,19 @@
           <p:cNvPr id="4" name="">
             <a:extLst xmlns:a="http://schemas.openxmlformats.org/drawingml/2006/main">
               <a:ext uri="{FF2B5EF4-FFF2-40B4-BE49-F238E27FC236}">
-                <a16:creationId xmlns:a16="http://schemas.microsoft.com/office/drawing/2014/main" id="{00527E65-8B05-4B23-84C6-3DE165EBE2FD}"/>
-              </a:ext>
-            </a:extLst>
-          </p:cNvPr>
-          <p:cNvSpPr>
-            <a:spLocks xmlns:a="http://schemas.openxmlformats.org/drawingml/2006/main" noGrp="1"/>
-          </p:cNvSpPr>
-          <p:nvPr/>
-        </p:nvSpPr>
-        <p:spPr>
-          <a:xfrm xmlns:a="http://schemas.openxmlformats.org/drawingml/2006/main">
-            <a:off x="609600" y="1638300"/>
-            <a:ext cx="10972800" cy="819150"/>
+                <a16:creationId xmlns:a16="http://schemas.microsoft.com/office/drawing/2014/main" id="{C42C2754-8114-4BD0-ACC4-82F7CF1D74F5}"/>
+              </a:ext>
+            </a:extLst>
+          </p:cNvPr>
+          <p:cNvSpPr>
+            <a:spLocks xmlns:a="http://schemas.openxmlformats.org/drawingml/2006/main" noGrp="1"/>
+          </p:cNvSpPr>
+          <p:nvPr/>
+        </p:nvSpPr>
+        <p:spPr>
+          <a:xfrm xmlns:a="http://schemas.openxmlformats.org/drawingml/2006/main">
+            <a:off x="609600" y="1876425"/>
+            <a:ext cx="10972800" cy="3219450"/>
           </a:xfrm>
           <a:prstGeom xmlns:a="http://schemas.openxmlformats.org/drawingml/2006/main" prst="rect">
             <a:avLst/>
@@ -8078,28 +8286,82 @@
           <a:p xmlns:a="http://schemas.openxmlformats.org/drawingml/2006/main">
             <a:pPr marL="279400" indent="-152400" algn="l">
               <a:spcAft>
-                <a:spcPts val="1200"/>
+                <a:spcPts val="3000"/>
               </a:spcAft>
               <a:buChar char="•"/>
-              <a:defRPr sz="2325" b="0">
-                <a:solidFill>
-                  <a:srgbClr val="16343E"/>
-                </a:solidFill>
-                <a:latin typeface="Arial"/>
-                <a:ea typeface="Arial"/>
-                <a:cs typeface="Arial"/>
-              </a:defRPr>
-            </a:pPr>
-            <a:r>
-              <a:rPr sz="2325" b="0">
-                <a:solidFill>
-                  <a:srgbClr val="16343E"/>
-                </a:solidFill>
-                <a:latin typeface="Arial"/>
-                <a:ea typeface="Arial"/>
-                <a:cs typeface="Arial"/>
-              </a:rPr>
-              <a:t>Sometimes the histology findings are ambiguous.</a:t>
+              <a:defRPr sz="2550" b="0">
+                <a:solidFill>
+                  <a:srgbClr val="16343E"/>
+                </a:solidFill>
+                <a:latin typeface="Arial"/>
+                <a:ea typeface="Arial"/>
+                <a:cs typeface="Arial"/>
+              </a:defRPr>
+            </a:pPr>
+            <a:r>
+              <a:rPr sz="2550" b="0">
+                <a:solidFill>
+                  <a:srgbClr val="16343E"/>
+                </a:solidFill>
+                <a:latin typeface="Arial"/>
+                <a:ea typeface="Arial"/>
+                <a:cs typeface="Arial"/>
+              </a:rPr>
+              <a:t>Molecular measurements already have a recognized role in parts of transplant rejection assessment.</a:t>
+            </a:r>
+          </a:p>
+          <a:p xmlns:a="http://schemas.openxmlformats.org/drawingml/2006/main">
+            <a:pPr marL="279400" indent="-152400" algn="l">
+              <a:spcAft>
+                <a:spcPts val="3000"/>
+              </a:spcAft>
+              <a:buChar char="•"/>
+              <a:defRPr sz="2550" b="0">
+                <a:solidFill>
+                  <a:srgbClr val="16343E"/>
+                </a:solidFill>
+                <a:latin typeface="Arial"/>
+                <a:ea typeface="Arial"/>
+                <a:cs typeface="Arial"/>
+              </a:defRPr>
+            </a:pPr>
+            <a:r>
+              <a:rPr sz="2550" b="0">
+                <a:solidFill>
+                  <a:srgbClr val="16343E"/>
+                </a:solidFill>
+                <a:latin typeface="Arial"/>
+                <a:ea typeface="Arial"/>
+                <a:cs typeface="Arial"/>
+              </a:rPr>
+              <a:t>This project uses that established application to compare missed rejection and false flags across classifiers.</a:t>
+            </a:r>
+          </a:p>
+          <a:p xmlns:a="http://schemas.openxmlformats.org/drawingml/2006/main">
+            <a:pPr marL="279400" indent="-152400" algn="l">
+              <a:spcAft>
+                <a:spcPts val="3000"/>
+              </a:spcAft>
+              <a:buChar char="•"/>
+              <a:defRPr sz="2550" b="0">
+                <a:solidFill>
+                  <a:srgbClr val="16343E"/>
+                </a:solidFill>
+                <a:latin typeface="Arial"/>
+                <a:ea typeface="Arial"/>
+                <a:cs typeface="Arial"/>
+              </a:defRPr>
+            </a:pPr>
+            <a:r>
+              <a:rPr sz="2550" b="0">
+                <a:solidFill>
+                  <a:srgbClr val="16343E"/>
+                </a:solidFill>
+                <a:latin typeface="Arial"/>
+                <a:ea typeface="Arial"/>
+                <a:cs typeface="Arial"/>
+              </a:rPr>
+              <a:t>The aim is to assess what a more complex model contributes before further validation.</a:t>
             </a:r>
           </a:p>
         </p:txBody>
@@ -8109,51 +8371,19 @@
           <p:cNvPr id="5" name="">
             <a:extLst xmlns:a="http://schemas.openxmlformats.org/drawingml/2006/main">
               <a:ext uri="{FF2B5EF4-FFF2-40B4-BE49-F238E27FC236}">
-                <a16:creationId xmlns:a16="http://schemas.microsoft.com/office/drawing/2014/main" id="{56B91C20-C85D-46EF-B4EC-D04314A793DD}"/>
-              </a:ext>
-            </a:extLst>
-          </p:cNvPr>
-          <p:cNvSpPr>
-            <a:spLocks xmlns:a="http://schemas.openxmlformats.org/drawingml/2006/main" noGrp="1"/>
-          </p:cNvSpPr>
-          <p:nvPr/>
-        </p:nvSpPr>
-        <p:spPr>
-          <a:xfrm xmlns:a="http://schemas.openxmlformats.org/drawingml/2006/main">
-            <a:off x="895350" y="2571750"/>
-            <a:ext cx="10687050" cy="1762125"/>
-          </a:xfrm>
-          <a:prstGeom xmlns:a="http://schemas.openxmlformats.org/drawingml/2006/main" prst="rect">
-            <a:avLst/>
-          </a:prstGeom>
-          <a:solidFill xmlns:a="http://schemas.openxmlformats.org/drawingml/2006/main">
-            <a:srgbClr val="E4EFEB"/>
-          </a:solidFill>
-          <a:ln xmlns:a="http://schemas.openxmlformats.org/drawingml/2006/main" w="9525">
-            <a:solidFill>
-              <a:srgbClr val="CEDBD7"/>
-            </a:solidFill>
-          </a:ln>
-        </p:spPr>
-      </p:sp>
-      <p:sp>
-        <p:nvSpPr>
-          <p:cNvPr id="6" name="">
-            <a:extLst xmlns:a="http://schemas.openxmlformats.org/drawingml/2006/main">
-              <a:ext uri="{FF2B5EF4-FFF2-40B4-BE49-F238E27FC236}">
-                <a16:creationId xmlns:a16="http://schemas.microsoft.com/office/drawing/2014/main" id="{EFAF72B7-FE80-4E57-BE62-DF50050F3E7B}"/>
-              </a:ext>
-            </a:extLst>
-          </p:cNvPr>
-          <p:cNvSpPr>
-            <a:spLocks xmlns:a="http://schemas.openxmlformats.org/drawingml/2006/main" noGrp="1"/>
-          </p:cNvSpPr>
-          <p:nvPr/>
-        </p:nvSpPr>
-        <p:spPr>
-          <a:xfrm xmlns:a="http://schemas.openxmlformats.org/drawingml/2006/main">
-            <a:off x="1076325" y="2657475"/>
-            <a:ext cx="10325100" cy="352425"/>
+                <a16:creationId xmlns:a16="http://schemas.microsoft.com/office/drawing/2014/main" id="{81C1807E-D2B4-4CDA-9A53-0EF399727A26}"/>
+              </a:ext>
+            </a:extLst>
+          </p:cNvPr>
+          <p:cNvSpPr>
+            <a:spLocks xmlns:a="http://schemas.openxmlformats.org/drawingml/2006/main" noGrp="1"/>
+          </p:cNvSpPr>
+          <p:nvPr/>
+        </p:nvSpPr>
+        <p:spPr>
+          <a:xfrm xmlns:a="http://schemas.openxmlformats.org/drawingml/2006/main">
+            <a:off x="609600" y="5410200"/>
+            <a:ext cx="10972800" cy="714375"/>
           </a:xfrm>
           <a:prstGeom xmlns:a="http://schemas.openxmlformats.org/drawingml/2006/main" prst="rect">
             <a:avLst/>
@@ -8170,7 +8400,7 @@
           <a:lstStyle xmlns:a="http://schemas.openxmlformats.org/drawingml/2006/main"/>
           <a:p xmlns:a="http://schemas.openxmlformats.org/drawingml/2006/main">
             <a:pPr algn="l">
-              <a:defRPr sz="2100" b="1">
+              <a:defRPr sz="2175" b="1">
                 <a:solidFill>
                   <a:srgbClr val="007C78"/>
                 </a:solidFill>
@@ -8180,7 +8410,7 @@
               </a:defRPr>
             </a:pPr>
             <a:r>
-              <a:rPr sz="2100" b="1">
+              <a:rPr sz="2175" b="1">
                 <a:solidFill>
                   <a:srgbClr val="007C78"/>
                 </a:solidFill>
@@ -8188,125 +8418,7 @@
                 <a:ea typeface="Arial"/>
                 <a:cs typeface="Arial"/>
               </a:rPr>
-              <a:t>Example:</a:t>
-            </a:r>
-          </a:p>
-        </p:txBody>
-      </p:sp>
-      <p:sp>
-        <p:nvSpPr>
-          <p:cNvPr id="7" name="">
-            <a:extLst xmlns:a="http://schemas.openxmlformats.org/drawingml/2006/main">
-              <a:ext uri="{FF2B5EF4-FFF2-40B4-BE49-F238E27FC236}">
-                <a16:creationId xmlns:a16="http://schemas.microsoft.com/office/drawing/2014/main" id="{9030F6FF-CBBB-4749-B0E8-D4E9041724A9}"/>
-              </a:ext>
-            </a:extLst>
-          </p:cNvPr>
-          <p:cNvSpPr>
-            <a:spLocks xmlns:a="http://schemas.openxmlformats.org/drawingml/2006/main" noGrp="1"/>
-          </p:cNvSpPr>
-          <p:nvPr/>
-        </p:nvSpPr>
-        <p:spPr>
-          <a:xfrm xmlns:a="http://schemas.openxmlformats.org/drawingml/2006/main">
-            <a:off x="1076325" y="3028950"/>
-            <a:ext cx="10325100" cy="1238250"/>
-          </a:xfrm>
-          <a:prstGeom xmlns:a="http://schemas.openxmlformats.org/drawingml/2006/main" prst="rect">
-            <a:avLst/>
-          </a:prstGeom>
-          <a:noFill xmlns:a="http://schemas.openxmlformats.org/drawingml/2006/main"/>
-          <a:ln xmlns:a="http://schemas.openxmlformats.org/drawingml/2006/main" w="0">
-            <a:noFill/>
-          </a:ln>
-        </p:spPr>
-        <p:txBody>
-          <a:bodyPr xmlns:a="http://schemas.openxmlformats.org/drawingml/2006/main" anchor="ctr">
-            <a:noAutofit/>
-          </a:bodyPr>
-          <a:lstStyle xmlns:a="http://schemas.openxmlformats.org/drawingml/2006/main"/>
-          <a:p xmlns:a="http://schemas.openxmlformats.org/drawingml/2006/main">
-            <a:pPr algn="l">
-              <a:defRPr sz="2250" b="0">
-                <a:solidFill>
-                  <a:srgbClr val="16343E"/>
-                </a:solidFill>
-                <a:latin typeface="Arial"/>
-                <a:ea typeface="Arial"/>
-                <a:cs typeface="Arial"/>
-              </a:defRPr>
-            </a:pPr>
-            <a:r>
-              <a:rPr sz="2250" b="0">
-                <a:solidFill>
-                  <a:srgbClr val="16343E"/>
-                </a:solidFill>
-                <a:latin typeface="Arial"/>
-                <a:ea typeface="Arial"/>
-                <a:cs typeface="Arial"/>
-              </a:rPr>
-              <a:t>A biopsy shows mild inflammation, but not enough to diagnose rejection. In a study of 146 borderline diagnoses, inflammation disappeared in some patients. Others later developed acute rejection.</a:t>
-            </a:r>
-          </a:p>
-        </p:txBody>
-      </p:sp>
-      <p:sp>
-        <p:nvSpPr>
-          <p:cNvPr id="8" name="">
-            <a:extLst xmlns:a="http://schemas.openxmlformats.org/drawingml/2006/main">
-              <a:ext uri="{FF2B5EF4-FFF2-40B4-BE49-F238E27FC236}">
-                <a16:creationId xmlns:a16="http://schemas.microsoft.com/office/drawing/2014/main" id="{4B07F9B3-3274-4031-BCF6-3B8C633E3525}"/>
-              </a:ext>
-            </a:extLst>
-          </p:cNvPr>
-          <p:cNvSpPr>
-            <a:spLocks xmlns:a="http://schemas.openxmlformats.org/drawingml/2006/main" noGrp="1"/>
-          </p:cNvSpPr>
-          <p:nvPr/>
-        </p:nvSpPr>
-        <p:spPr>
-          <a:xfrm xmlns:a="http://schemas.openxmlformats.org/drawingml/2006/main">
-            <a:off x="609600" y="4591050"/>
-            <a:ext cx="10972800" cy="1504950"/>
-          </a:xfrm>
-          <a:prstGeom xmlns:a="http://schemas.openxmlformats.org/drawingml/2006/main" prst="rect">
-            <a:avLst/>
-          </a:prstGeom>
-          <a:noFill xmlns:a="http://schemas.openxmlformats.org/drawingml/2006/main"/>
-          <a:ln xmlns:a="http://schemas.openxmlformats.org/drawingml/2006/main" w="0">
-            <a:noFill/>
-          </a:ln>
-        </p:spPr>
-        <p:txBody>
-          <a:bodyPr xmlns:a="http://schemas.openxmlformats.org/drawingml/2006/main" anchor="t">
-            <a:noAutofit/>
-          </a:bodyPr>
-          <a:lstStyle xmlns:a="http://schemas.openxmlformats.org/drawingml/2006/main"/>
-          <a:p xmlns:a="http://schemas.openxmlformats.org/drawingml/2006/main">
-            <a:pPr marL="279400" indent="-152400" algn="l">
-              <a:spcAft>
-                <a:spcPts val="1200"/>
-              </a:spcAft>
-              <a:buChar char="•"/>
-              <a:defRPr sz="2325" b="0">
-                <a:solidFill>
-                  <a:srgbClr val="16343E"/>
-                </a:solidFill>
-                <a:latin typeface="Arial"/>
-                <a:ea typeface="Arial"/>
-                <a:cs typeface="Arial"/>
-              </a:defRPr>
-            </a:pPr>
-            <a:r>
-              <a:rPr sz="2325" b="0">
-                <a:solidFill>
-                  <a:srgbClr val="16343E"/>
-                </a:solidFill>
-                <a:latin typeface="Arial"/>
-                <a:ea typeface="Arial"/>
-                <a:cs typeface="Arial"/>
-              </a:rPr>
-              <a:t>As a step towards potentially helping resolve ambiguous biopsies, I used RNA counts to classify recorded diagnoses. A high rejection score could add evidence for specialist review.</a:t>
+              <a:t>The scoring software preserves the procedure evaluated here.</a:t>
             </a:r>
           </a:p>
         </p:txBody>
@@ -8314,7 +8426,7 @@
     </p:spTree>
     <p:extLst>
       <p:ext uri="{BB962C8B-B14F-4D97-AF65-F5344CB8AC3E}">
-        <p14:creationId xmlns:p14="http://schemas.microsoft.com/office/powerpoint/2010/main" val="2000796435"/>
+        <p14:creationId xmlns:p14="http://schemas.microsoft.com/office/powerpoint/2010/main" val="1753361183"/>
       </p:ext>
     </p:extLst>
   </p:cSld>
@@ -8345,7 +8457,7 @@
           <p:cNvPr id="13" name="">
             <a:extLst xmlns:a="http://schemas.openxmlformats.org/drawingml/2006/main">
               <a:ext uri="{FF2B5EF4-FFF2-40B4-BE49-F238E27FC236}">
-                <a16:creationId xmlns:a16="http://schemas.microsoft.com/office/drawing/2014/main" id="{EF58B68E-C5D6-4586-9592-6D86E2C05028}"/>
+                <a16:creationId xmlns:a16="http://schemas.microsoft.com/office/drawing/2014/main" id="{89882B71-677C-48B5-B535-30732198E9A4}"/>
               </a:ext>
             </a:extLst>
           </p:cNvPr>
@@ -8392,7 +8504,7 @@
                 <a:ea typeface="Arial"/>
                 <a:cs typeface="Arial"/>
               </a:rPr>
-              <a:t>Evidence for a molecular second opinion</a:t>
+              <a:t>Clinical and research context</a:t>
             </a:r>
           </a:p>
         </p:txBody>
@@ -8402,19 +8514,19 @@
           <p:cNvPr id="2" name="">
             <a:extLst xmlns:a="http://schemas.openxmlformats.org/drawingml/2006/main">
               <a:ext uri="{FF2B5EF4-FFF2-40B4-BE49-F238E27FC236}">
-                <a16:creationId xmlns:a16="http://schemas.microsoft.com/office/drawing/2014/main" id="{74C4918A-3C06-4D7F-A2CC-196F88328092}"/>
-              </a:ext>
-            </a:extLst>
-          </p:cNvPr>
-          <p:cNvSpPr>
-            <a:spLocks xmlns:a="http://schemas.openxmlformats.org/drawingml/2006/main" noGrp="1"/>
-          </p:cNvSpPr>
-          <p:nvPr/>
-        </p:nvSpPr>
-        <p:spPr>
-          <a:xfrm xmlns:a="http://schemas.openxmlformats.org/drawingml/2006/main">
-            <a:off x="11115675" y="6305550"/>
-            <a:ext cx="457200" cy="285750"/>
+                <a16:creationId xmlns:a16="http://schemas.microsoft.com/office/drawing/2014/main" id="{4B025956-A920-4E6F-83EE-463298E19F8D}"/>
+              </a:ext>
+            </a:extLst>
+          </p:cNvPr>
+          <p:cNvSpPr>
+            <a:spLocks xmlns:a="http://schemas.openxmlformats.org/drawingml/2006/main" noGrp="1"/>
+          </p:cNvSpPr>
+          <p:nvPr/>
+        </p:nvSpPr>
+        <p:spPr>
+          <a:xfrm xmlns:a="http://schemas.openxmlformats.org/drawingml/2006/main">
+            <a:off x="609600" y="6257925"/>
+            <a:ext cx="10382250" cy="361950"/>
           </a:xfrm>
           <a:prstGeom xmlns:a="http://schemas.openxmlformats.org/drawingml/2006/main" prst="rect">
             <a:avLst/>
@@ -8430,7 +8542,7 @@
           </a:bodyPr>
           <a:lstStyle xmlns:a="http://schemas.openxmlformats.org/drawingml/2006/main"/>
           <a:p xmlns:a="http://schemas.openxmlformats.org/drawingml/2006/main">
-            <a:pPr algn="r">
+            <a:pPr algn="l">
               <a:defRPr sz="1350" b="0">
                 <a:solidFill>
                   <a:srgbClr val="52656B"/>
@@ -8449,7 +8561,7 @@
                 <a:ea typeface="Arial"/>
                 <a:cs typeface="Arial"/>
               </a:rPr>
-              <a:t>04</a:t>
+              <a:t>Sources: Banff Reference Guide (2026); Zhang et al. (2024); KDIGO (2009); BK consensus (2024)</a:t>
             </a:r>
           </a:p>
         </p:txBody>
@@ -8459,19 +8571,19 @@
           <p:cNvPr id="3" name="">
             <a:extLst xmlns:a="http://schemas.openxmlformats.org/drawingml/2006/main">
               <a:ext uri="{FF2B5EF4-FFF2-40B4-BE49-F238E27FC236}">
-                <a16:creationId xmlns:a16="http://schemas.microsoft.com/office/drawing/2014/main" id="{DBC3EF6B-9E35-493D-BD80-E77D068A4C21}"/>
-              </a:ext>
-            </a:extLst>
-          </p:cNvPr>
-          <p:cNvSpPr>
-            <a:spLocks xmlns:a="http://schemas.openxmlformats.org/drawingml/2006/main" noGrp="1"/>
-          </p:cNvSpPr>
-          <p:nvPr/>
-        </p:nvSpPr>
-        <p:spPr>
-          <a:xfrm xmlns:a="http://schemas.openxmlformats.org/drawingml/2006/main">
-            <a:off x="609600" y="1533525"/>
-            <a:ext cx="2609850" cy="723900"/>
+                <a16:creationId xmlns:a16="http://schemas.microsoft.com/office/drawing/2014/main" id="{4DE6B718-AE8E-4743-824F-03079EDF4800}"/>
+              </a:ext>
+            </a:extLst>
+          </p:cNvPr>
+          <p:cNvSpPr>
+            <a:spLocks xmlns:a="http://schemas.openxmlformats.org/drawingml/2006/main" noGrp="1"/>
+          </p:cNvSpPr>
+          <p:nvPr/>
+        </p:nvSpPr>
+        <p:spPr>
+          <a:xfrm xmlns:a="http://schemas.openxmlformats.org/drawingml/2006/main">
+            <a:off x="11115675" y="6305550"/>
+            <a:ext cx="457200" cy="285750"/>
           </a:xfrm>
           <a:prstGeom xmlns:a="http://schemas.openxmlformats.org/drawingml/2006/main" prst="rect">
             <a:avLst/>
@@ -8487,49 +8599,26 @@
           </a:bodyPr>
           <a:lstStyle xmlns:a="http://schemas.openxmlformats.org/drawingml/2006/main"/>
           <a:p xmlns:a="http://schemas.openxmlformats.org/drawingml/2006/main">
-            <a:pPr algn="l">
-              <a:defRPr sz="2175" b="1">
-                <a:solidFill>
-                  <a:srgbClr val="16343E"/>
-                </a:solidFill>
-                <a:latin typeface="Arial"/>
-                <a:ea typeface="Arial"/>
-                <a:cs typeface="Arial"/>
-              </a:defRPr>
-            </a:pPr>
-            <a:r>
-              <a:rPr sz="2175" b="1">
-                <a:solidFill>
-                  <a:srgbClr val="16343E"/>
-                </a:solidFill>
-                <a:latin typeface="Arial"/>
-                <a:ea typeface="Arial"/>
-                <a:cs typeface="Arial"/>
-              </a:rPr>
-              <a:t>Banff guidance</a:t>
-            </a:r>
-          </a:p>
-          <a:p xmlns:a="http://schemas.openxmlformats.org/drawingml/2006/main">
-            <a:pPr algn="l">
-              <a:defRPr sz="2175" b="1">
-                <a:solidFill>
-                  <a:srgbClr val="16343E"/>
-                </a:solidFill>
-                <a:latin typeface="Arial"/>
-                <a:ea typeface="Arial"/>
-                <a:cs typeface="Arial"/>
-              </a:defRPr>
-            </a:pPr>
-            <a:r>
-              <a:rPr sz="2175" b="1">
-                <a:solidFill>
-                  <a:srgbClr val="16343E"/>
-                </a:solidFill>
-                <a:latin typeface="Arial"/>
-                <a:ea typeface="Arial"/>
-                <a:cs typeface="Arial"/>
-              </a:rPr>
-              <a:t>2026</a:t>
+            <a:pPr algn="r">
+              <a:defRPr sz="1350" b="0">
+                <a:solidFill>
+                  <a:srgbClr val="52656B"/>
+                </a:solidFill>
+                <a:latin typeface="Arial"/>
+                <a:ea typeface="Arial"/>
+                <a:cs typeface="Arial"/>
+              </a:defRPr>
+            </a:pPr>
+            <a:r>
+              <a:rPr sz="1350" b="0">
+                <a:solidFill>
+                  <a:srgbClr val="52656B"/>
+                </a:solidFill>
+                <a:latin typeface="Arial"/>
+                <a:ea typeface="Arial"/>
+                <a:cs typeface="Arial"/>
+              </a:rPr>
+              <a:t>04</a:t>
             </a:r>
           </a:p>
         </p:txBody>
@@ -8539,19 +8628,19 @@
           <p:cNvPr id="4" name="">
             <a:extLst xmlns:a="http://schemas.openxmlformats.org/drawingml/2006/main">
               <a:ext uri="{FF2B5EF4-FFF2-40B4-BE49-F238E27FC236}">
-                <a16:creationId xmlns:a16="http://schemas.microsoft.com/office/drawing/2014/main" id="{023F0052-4C25-4AE0-B94E-DC78DBDA9EA3}"/>
-              </a:ext>
-            </a:extLst>
-          </p:cNvPr>
-          <p:cNvSpPr>
-            <a:spLocks xmlns:a="http://schemas.openxmlformats.org/drawingml/2006/main" noGrp="1"/>
-          </p:cNvSpPr>
-          <p:nvPr/>
-        </p:nvSpPr>
-        <p:spPr>
-          <a:xfrm xmlns:a="http://schemas.openxmlformats.org/drawingml/2006/main">
-            <a:off x="3476625" y="1533525"/>
-            <a:ext cx="8105775" cy="723900"/>
+                <a16:creationId xmlns:a16="http://schemas.microsoft.com/office/drawing/2014/main" id="{DB731F01-9087-4049-9D69-5EAB0A4E7F4C}"/>
+              </a:ext>
+            </a:extLst>
+          </p:cNvPr>
+          <p:cNvSpPr>
+            <a:spLocks xmlns:a="http://schemas.openxmlformats.org/drawingml/2006/main" noGrp="1"/>
+          </p:cNvSpPr>
+          <p:nvPr/>
+        </p:nvSpPr>
+        <p:spPr>
+          <a:xfrm xmlns:a="http://schemas.openxmlformats.org/drawingml/2006/main">
+            <a:off x="609600" y="1619250"/>
+            <a:ext cx="2609850" cy="857250"/>
           </a:xfrm>
           <a:prstGeom xmlns:a="http://schemas.openxmlformats.org/drawingml/2006/main" prst="rect">
             <a:avLst/>
@@ -8568,27 +8657,84 @@
           <a:lstStyle xmlns:a="http://schemas.openxmlformats.org/drawingml/2006/main"/>
           <a:p xmlns:a="http://schemas.openxmlformats.org/drawingml/2006/main">
             <a:pPr algn="l">
-              <a:defRPr sz="2250" b="0">
-                <a:solidFill>
-                  <a:srgbClr val="16343E"/>
-                </a:solidFill>
-                <a:latin typeface="Arial"/>
-                <a:ea typeface="Arial"/>
-                <a:cs typeface="Arial"/>
-              </a:defRPr>
-            </a:pPr>
-            <a:r>
-              <a:rPr sz="2250" b="0">
-                <a:solidFill>
-                  <a:srgbClr val="16343E"/>
-                </a:solidFill>
-                <a:latin typeface="Arial"/>
-                <a:ea typeface="Arial"/>
-                <a:cs typeface="Arial"/>
-              </a:rPr>
-              <a:t>Considers validated molecular tests</a:t>
-            </a:r>
-          </a:p>
+              <a:defRPr sz="2175" b="1">
+                <a:solidFill>
+                  <a:srgbClr val="16343E"/>
+                </a:solidFill>
+                <a:latin typeface="Arial"/>
+                <a:ea typeface="Arial"/>
+                <a:cs typeface="Arial"/>
+              </a:defRPr>
+            </a:pPr>
+            <a:r>
+              <a:rPr sz="2175" b="1">
+                <a:solidFill>
+                  <a:srgbClr val="16343E"/>
+                </a:solidFill>
+                <a:latin typeface="Arial"/>
+                <a:ea typeface="Arial"/>
+                <a:cs typeface="Arial"/>
+              </a:rPr>
+              <a:t>Banff diagnostic</a:t>
+            </a:r>
+          </a:p>
+          <a:p xmlns:a="http://schemas.openxmlformats.org/drawingml/2006/main">
+            <a:pPr algn="l">
+              <a:defRPr sz="2175" b="1">
+                <a:solidFill>
+                  <a:srgbClr val="16343E"/>
+                </a:solidFill>
+                <a:latin typeface="Arial"/>
+                <a:ea typeface="Arial"/>
+                <a:cs typeface="Arial"/>
+              </a:defRPr>
+            </a:pPr>
+            <a:r>
+              <a:rPr sz="2175" b="1">
+                <a:solidFill>
+                  <a:srgbClr val="16343E"/>
+                </a:solidFill>
+                <a:latin typeface="Arial"/>
+                <a:ea typeface="Arial"/>
+                <a:cs typeface="Arial"/>
+              </a:rPr>
+              <a:t>framework</a:t>
+            </a:r>
+          </a:p>
+        </p:txBody>
+      </p:sp>
+      <p:sp>
+        <p:nvSpPr>
+          <p:cNvPr id="5" name="">
+            <a:extLst xmlns:a="http://schemas.openxmlformats.org/drawingml/2006/main">
+              <a:ext uri="{FF2B5EF4-FFF2-40B4-BE49-F238E27FC236}">
+                <a16:creationId xmlns:a16="http://schemas.microsoft.com/office/drawing/2014/main" id="{BC318E99-DD40-4013-925C-52B7CBD27482}"/>
+              </a:ext>
+            </a:extLst>
+          </p:cNvPr>
+          <p:cNvSpPr>
+            <a:spLocks xmlns:a="http://schemas.openxmlformats.org/drawingml/2006/main" noGrp="1"/>
+          </p:cNvSpPr>
+          <p:nvPr/>
+        </p:nvSpPr>
+        <p:spPr>
+          <a:xfrm xmlns:a="http://schemas.openxmlformats.org/drawingml/2006/main">
+            <a:off x="3476625" y="1619250"/>
+            <a:ext cx="8105775" cy="857250"/>
+          </a:xfrm>
+          <a:prstGeom xmlns:a="http://schemas.openxmlformats.org/drawingml/2006/main" prst="rect">
+            <a:avLst/>
+          </a:prstGeom>
+          <a:noFill xmlns:a="http://schemas.openxmlformats.org/drawingml/2006/main"/>
+          <a:ln xmlns:a="http://schemas.openxmlformats.org/drawingml/2006/main" w="0">
+            <a:noFill/>
+          </a:ln>
+        </p:spPr>
+        <p:txBody>
+          <a:bodyPr xmlns:a="http://schemas.openxmlformats.org/drawingml/2006/main" anchor="ctr">
+            <a:noAutofit/>
+          </a:bodyPr>
+          <a:lstStyle xmlns:a="http://schemas.openxmlformats.org/drawingml/2006/main"/>
           <a:p xmlns:a="http://schemas.openxmlformats.org/drawingml/2006/main">
             <a:pPr algn="l">
               <a:defRPr sz="2250" b="0">
@@ -8609,28 +8755,51 @@
                 <a:ea typeface="Arial"/>
                 <a:cs typeface="Arial"/>
               </a:rPr>
-              <a:t>for difficult biopsy interpretations</a:t>
+              <a:t>Validated biopsy transcript tests have a defined role</a:t>
+            </a:r>
+          </a:p>
+          <a:p xmlns:a="http://schemas.openxmlformats.org/drawingml/2006/main">
+            <a:pPr algn="l">
+              <a:defRPr sz="2250" b="0">
+                <a:solidFill>
+                  <a:srgbClr val="16343E"/>
+                </a:solidFill>
+                <a:latin typeface="Arial"/>
+                <a:ea typeface="Arial"/>
+                <a:cs typeface="Arial"/>
+              </a:defRPr>
+            </a:pPr>
+            <a:r>
+              <a:rPr sz="2250" b="0">
+                <a:solidFill>
+                  <a:srgbClr val="16343E"/>
+                </a:solidFill>
+                <a:latin typeface="Arial"/>
+                <a:ea typeface="Arial"/>
+                <a:cs typeface="Arial"/>
+              </a:rPr>
+              <a:t>in antibody-mediated rejection assessment.</a:t>
             </a:r>
           </a:p>
         </p:txBody>
       </p:sp>
       <p:sp>
         <p:nvSpPr>
-          <p:cNvPr id="5" name="">
-            <a:extLst xmlns:a="http://schemas.openxmlformats.org/drawingml/2006/main">
-              <a:ext uri="{FF2B5EF4-FFF2-40B4-BE49-F238E27FC236}">
-                <a16:creationId xmlns:a16="http://schemas.microsoft.com/office/drawing/2014/main" id="{B118EF41-B71E-4372-BCCE-8D1C5DCD2969}"/>
-              </a:ext>
-            </a:extLst>
-          </p:cNvPr>
-          <p:cNvSpPr>
-            <a:spLocks xmlns:a="http://schemas.openxmlformats.org/drawingml/2006/main" noGrp="1"/>
-          </p:cNvSpPr>
-          <p:nvPr/>
-        </p:nvSpPr>
-        <p:spPr>
-          <a:xfrm xmlns:a="http://schemas.openxmlformats.org/drawingml/2006/main">
-            <a:off x="609600" y="2371725"/>
+          <p:cNvPr id="6" name="">
+            <a:extLst xmlns:a="http://schemas.openxmlformats.org/drawingml/2006/main">
+              <a:ext uri="{FF2B5EF4-FFF2-40B4-BE49-F238E27FC236}">
+                <a16:creationId xmlns:a16="http://schemas.microsoft.com/office/drawing/2014/main" id="{A1B94C24-7100-44D2-AD6B-BF2F0FE32851}"/>
+              </a:ext>
+            </a:extLst>
+          </p:cNvPr>
+          <p:cNvSpPr>
+            <a:spLocks xmlns:a="http://schemas.openxmlformats.org/drawingml/2006/main" noGrp="1"/>
+          </p:cNvSpPr>
+          <p:nvPr/>
+        </p:nvSpPr>
+        <p:spPr>
+          <a:xfrm xmlns:a="http://schemas.openxmlformats.org/drawingml/2006/main">
+            <a:off x="609600" y="2686050"/>
             <a:ext cx="10972800" cy="0"/>
           </a:xfrm>
           <a:prstGeom xmlns:a="http://schemas.openxmlformats.org/drawingml/2006/main" prst="line">
@@ -8645,22 +8814,22 @@
       </p:sp>
       <p:sp>
         <p:nvSpPr>
-          <p:cNvPr id="6" name="">
-            <a:extLst xmlns:a="http://schemas.openxmlformats.org/drawingml/2006/main">
-              <a:ext uri="{FF2B5EF4-FFF2-40B4-BE49-F238E27FC236}">
-                <a16:creationId xmlns:a16="http://schemas.microsoft.com/office/drawing/2014/main" id="{4AB1D88E-C98E-4C9B-A3D5-D63E1D8F235F}"/>
-              </a:ext>
-            </a:extLst>
-          </p:cNvPr>
-          <p:cNvSpPr>
-            <a:spLocks xmlns:a="http://schemas.openxmlformats.org/drawingml/2006/main" noGrp="1"/>
-          </p:cNvSpPr>
-          <p:nvPr/>
-        </p:nvSpPr>
-        <p:spPr>
-          <a:xfrm xmlns:a="http://schemas.openxmlformats.org/drawingml/2006/main">
-            <a:off x="609600" y="2552700"/>
-            <a:ext cx="2609850" cy="771525"/>
+          <p:cNvPr id="7" name="">
+            <a:extLst xmlns:a="http://schemas.openxmlformats.org/drawingml/2006/main">
+              <a:ext uri="{FF2B5EF4-FFF2-40B4-BE49-F238E27FC236}">
+                <a16:creationId xmlns:a16="http://schemas.microsoft.com/office/drawing/2014/main" id="{EC3BCDDA-454D-48EB-8186-4A57FD6F191A}"/>
+              </a:ext>
+            </a:extLst>
+          </p:cNvPr>
+          <p:cNvSpPr>
+            <a:spLocks xmlns:a="http://schemas.openxmlformats.org/drawingml/2006/main" noGrp="1"/>
+          </p:cNvSpPr>
+          <p:nvPr/>
+        </p:nvSpPr>
+        <p:spPr>
+          <a:xfrm xmlns:a="http://schemas.openxmlformats.org/drawingml/2006/main">
+            <a:off x="609600" y="2952750"/>
+            <a:ext cx="2609850" cy="857250"/>
           </a:xfrm>
           <a:prstGeom xmlns:a="http://schemas.openxmlformats.org/drawingml/2006/main" prst="rect">
             <a:avLst/>
@@ -8695,7 +8864,7 @@
                 <a:ea typeface="Arial"/>
                 <a:cs typeface="Arial"/>
               </a:rPr>
-              <a:t>B-HOT study</a:t>
+              <a:t>Published B-HOT study</a:t>
             </a:r>
           </a:p>
           <a:p xmlns:a="http://schemas.openxmlformats.org/drawingml/2006/main">
@@ -8718,29 +8887,29 @@
                 <a:ea typeface="Arial"/>
                 <a:cs typeface="Arial"/>
               </a:rPr>
-              <a:t>Rosales, 2022</a:t>
+              <a:t>Zhang, 2024</a:t>
             </a:r>
           </a:p>
         </p:txBody>
       </p:sp>
       <p:sp>
         <p:nvSpPr>
-          <p:cNvPr id="7" name="">
-            <a:extLst xmlns:a="http://schemas.openxmlformats.org/drawingml/2006/main">
-              <a:ext uri="{FF2B5EF4-FFF2-40B4-BE49-F238E27FC236}">
-                <a16:creationId xmlns:a16="http://schemas.microsoft.com/office/drawing/2014/main" id="{874C97DE-0B13-4B9E-8166-7676B38F55B0}"/>
-              </a:ext>
-            </a:extLst>
-          </p:cNvPr>
-          <p:cNvSpPr>
-            <a:spLocks xmlns:a="http://schemas.openxmlformats.org/drawingml/2006/main" noGrp="1"/>
-          </p:cNvSpPr>
-          <p:nvPr/>
-        </p:nvSpPr>
-        <p:spPr>
-          <a:xfrm xmlns:a="http://schemas.openxmlformats.org/drawingml/2006/main">
-            <a:off x="3476625" y="2466975"/>
-            <a:ext cx="8105775" cy="1028700"/>
+          <p:cNvPr id="8" name="">
+            <a:extLst xmlns:a="http://schemas.openxmlformats.org/drawingml/2006/main">
+              <a:ext uri="{FF2B5EF4-FFF2-40B4-BE49-F238E27FC236}">
+                <a16:creationId xmlns:a16="http://schemas.microsoft.com/office/drawing/2014/main" id="{B3BD8F5A-BD67-47D6-BDF2-FB9C4905E3D2}"/>
+              </a:ext>
+            </a:extLst>
+          </p:cNvPr>
+          <p:cNvSpPr>
+            <a:spLocks xmlns:a="http://schemas.openxmlformats.org/drawingml/2006/main" noGrp="1"/>
+          </p:cNvSpPr>
+          <p:nvPr/>
+        </p:nvSpPr>
+        <p:spPr>
+          <a:xfrm xmlns:a="http://schemas.openxmlformats.org/drawingml/2006/main">
+            <a:off x="3476625" y="2857500"/>
+            <a:ext cx="8105775" cy="1076325"/>
           </a:xfrm>
           <a:prstGeom xmlns:a="http://schemas.openxmlformats.org/drawingml/2006/main" prst="rect">
             <a:avLst/>
@@ -8757,92 +8926,69 @@
           <a:lstStyle xmlns:a="http://schemas.openxmlformats.org/drawingml/2006/main"/>
           <a:p xmlns:a="http://schemas.openxmlformats.org/drawingml/2006/main">
             <a:pPr algn="l">
-              <a:defRPr sz="2100" b="0">
-                <a:solidFill>
-                  <a:srgbClr val="16343E"/>
-                </a:solidFill>
-                <a:latin typeface="Arial"/>
-                <a:ea typeface="Arial"/>
-                <a:cs typeface="Arial"/>
-              </a:defRPr>
-            </a:pPr>
-            <a:r>
-              <a:rPr sz="2100" b="0">
-                <a:solidFill>
-                  <a:srgbClr val="16343E"/>
-                </a:solidFill>
-                <a:latin typeface="Arial"/>
-                <a:ea typeface="Arial"/>
-                <a:cs typeface="Arial"/>
-              </a:rPr>
-              <a:t>Higher initial molecular scores in patients who later</a:t>
+              <a:defRPr sz="2250" b="0">
+                <a:solidFill>
+                  <a:srgbClr val="16343E"/>
+                </a:solidFill>
+                <a:latin typeface="Arial"/>
+                <a:ea typeface="Arial"/>
+                <a:cs typeface="Arial"/>
+              </a:defRPr>
+            </a:pPr>
+            <a:r>
+              <a:rPr sz="2250" b="0">
+                <a:solidFill>
+                  <a:srgbClr val="16343E"/>
+                </a:solidFill>
+                <a:latin typeface="Arial"/>
+                <a:ea typeface="Arial"/>
+                <a:cs typeface="Arial"/>
+              </a:rPr>
+              <a:t>Four-class study compared regression and boosting.</a:t>
             </a:r>
           </a:p>
           <a:p xmlns:a="http://schemas.openxmlformats.org/drawingml/2006/main">
             <a:pPr algn="l">
-              <a:defRPr sz="2100" b="0">
-                <a:solidFill>
-                  <a:srgbClr val="16343E"/>
-                </a:solidFill>
-                <a:latin typeface="Arial"/>
-                <a:ea typeface="Arial"/>
-                <a:cs typeface="Arial"/>
-              </a:defRPr>
-            </a:pPr>
-            <a:r>
-              <a:rPr sz="2100" b="0">
-                <a:solidFill>
-                  <a:srgbClr val="16343E"/>
-                </a:solidFill>
-                <a:latin typeface="Arial"/>
-                <a:ea typeface="Arial"/>
-                <a:cs typeface="Arial"/>
-              </a:rPr>
-              <a:t>developed chronic active antibody-mediated rejection,</a:t>
-            </a:r>
-          </a:p>
-          <a:p xmlns:a="http://schemas.openxmlformats.org/drawingml/2006/main">
-            <a:pPr algn="l">
-              <a:defRPr sz="2100" b="0">
-                <a:solidFill>
-                  <a:srgbClr val="16343E"/>
-                </a:solidFill>
-                <a:latin typeface="Arial"/>
-                <a:ea typeface="Arial"/>
-                <a:cs typeface="Arial"/>
-              </a:defRPr>
-            </a:pPr>
-            <a:r>
-              <a:rPr sz="2100" b="0">
-                <a:solidFill>
-                  <a:srgbClr val="16343E"/>
-                </a:solidFill>
-                <a:latin typeface="Arial"/>
-                <a:ea typeface="Arial"/>
-                <a:cs typeface="Arial"/>
-              </a:rPr>
-              <a:t>despite no initial diagnosis of it</a:t>
+              <a:defRPr sz="2250" b="0">
+                <a:solidFill>
+                  <a:srgbClr val="16343E"/>
+                </a:solidFill>
+                <a:latin typeface="Arial"/>
+                <a:ea typeface="Arial"/>
+                <a:cs typeface="Arial"/>
+              </a:defRPr>
+            </a:pPr>
+            <a:r>
+              <a:rPr sz="2250" b="0">
+                <a:solidFill>
+                  <a:srgbClr val="16343E"/>
+                </a:solidFill>
+                <a:latin typeface="Arial"/>
+                <a:ea typeface="Arial"/>
+                <a:cs typeface="Arial"/>
+              </a:rPr>
+              <a:t>Selected LASSO for similar accuracy with fewer features.</a:t>
             </a:r>
           </a:p>
         </p:txBody>
       </p:sp>
       <p:sp>
         <p:nvSpPr>
-          <p:cNvPr id="8" name="">
-            <a:extLst xmlns:a="http://schemas.openxmlformats.org/drawingml/2006/main">
-              <a:ext uri="{FF2B5EF4-FFF2-40B4-BE49-F238E27FC236}">
-                <a16:creationId xmlns:a16="http://schemas.microsoft.com/office/drawing/2014/main" id="{C91AF1B1-7A51-4C7D-98BA-61A51F2D8586}"/>
-              </a:ext>
-            </a:extLst>
-          </p:cNvPr>
-          <p:cNvSpPr>
-            <a:spLocks xmlns:a="http://schemas.openxmlformats.org/drawingml/2006/main" noGrp="1"/>
-          </p:cNvSpPr>
-          <p:nvPr/>
-        </p:nvSpPr>
-        <p:spPr>
-          <a:xfrm xmlns:a="http://schemas.openxmlformats.org/drawingml/2006/main">
-            <a:off x="609600" y="3648075"/>
+          <p:cNvPr id="9" name="">
+            <a:extLst xmlns:a="http://schemas.openxmlformats.org/drawingml/2006/main">
+              <a:ext uri="{FF2B5EF4-FFF2-40B4-BE49-F238E27FC236}">
+                <a16:creationId xmlns:a16="http://schemas.microsoft.com/office/drawing/2014/main" id="{E1DCC75A-4093-4917-B677-65ECD08F2308}"/>
+              </a:ext>
+            </a:extLst>
+          </p:cNvPr>
+          <p:cNvSpPr>
+            <a:spLocks xmlns:a="http://schemas.openxmlformats.org/drawingml/2006/main" noGrp="1"/>
+          </p:cNvSpPr>
+          <p:nvPr/>
+        </p:nvSpPr>
+        <p:spPr>
+          <a:xfrm xmlns:a="http://schemas.openxmlformats.org/drawingml/2006/main">
+            <a:off x="609600" y="4124325"/>
             <a:ext cx="10972800" cy="0"/>
           </a:xfrm>
           <a:prstGeom xmlns:a="http://schemas.openxmlformats.org/drawingml/2006/main" prst="line">
@@ -8857,21 +9003,21 @@
       </p:sp>
       <p:sp>
         <p:nvSpPr>
-          <p:cNvPr id="9" name="">
-            <a:extLst xmlns:a="http://schemas.openxmlformats.org/drawingml/2006/main">
-              <a:ext uri="{FF2B5EF4-FFF2-40B4-BE49-F238E27FC236}">
-                <a16:creationId xmlns:a16="http://schemas.microsoft.com/office/drawing/2014/main" id="{B89040A1-8FA9-4D8C-8586-990F483A102F}"/>
-              </a:ext>
-            </a:extLst>
-          </p:cNvPr>
-          <p:cNvSpPr>
-            <a:spLocks xmlns:a="http://schemas.openxmlformats.org/drawingml/2006/main" noGrp="1"/>
-          </p:cNvSpPr>
-          <p:nvPr/>
-        </p:nvSpPr>
-        <p:spPr>
-          <a:xfrm xmlns:a="http://schemas.openxmlformats.org/drawingml/2006/main">
-            <a:off x="609600" y="3857625"/>
+          <p:cNvPr id="10" name="">
+            <a:extLst xmlns:a="http://schemas.openxmlformats.org/drawingml/2006/main">
+              <a:ext uri="{FF2B5EF4-FFF2-40B4-BE49-F238E27FC236}">
+                <a16:creationId xmlns:a16="http://schemas.microsoft.com/office/drawing/2014/main" id="{581F0EF1-95FB-4083-BE57-3366BB616FAA}"/>
+              </a:ext>
+            </a:extLst>
+          </p:cNvPr>
+          <p:cNvSpPr>
+            <a:spLocks xmlns:a="http://schemas.openxmlformats.org/drawingml/2006/main" noGrp="1"/>
+          </p:cNvSpPr>
+          <p:nvPr/>
+        </p:nvSpPr>
+        <p:spPr>
+          <a:xfrm xmlns:a="http://schemas.openxmlformats.org/drawingml/2006/main">
+            <a:off x="609600" y="4333875"/>
             <a:ext cx="2609850" cy="981075"/>
           </a:xfrm>
           <a:prstGeom xmlns:a="http://schemas.openxmlformats.org/drawingml/2006/main" prst="rect">
@@ -8937,22 +9083,22 @@
       </p:sp>
       <p:sp>
         <p:nvSpPr>
-          <p:cNvPr id="10" name="">
-            <a:extLst xmlns:a="http://schemas.openxmlformats.org/drawingml/2006/main">
-              <a:ext uri="{FF2B5EF4-FFF2-40B4-BE49-F238E27FC236}">
-                <a16:creationId xmlns:a16="http://schemas.microsoft.com/office/drawing/2014/main" id="{2D56AC8A-13B1-418A-8974-ADBC80B59BA1}"/>
-              </a:ext>
-            </a:extLst>
-          </p:cNvPr>
-          <p:cNvSpPr>
-            <a:spLocks xmlns:a="http://schemas.openxmlformats.org/drawingml/2006/main" noGrp="1"/>
-          </p:cNvSpPr>
-          <p:nvPr/>
-        </p:nvSpPr>
-        <p:spPr>
-          <a:xfrm xmlns:a="http://schemas.openxmlformats.org/drawingml/2006/main">
-            <a:off x="3476625" y="3762375"/>
-            <a:ext cx="8105775" cy="1171575"/>
+          <p:cNvPr id="11" name="">
+            <a:extLst xmlns:a="http://schemas.openxmlformats.org/drawingml/2006/main">
+              <a:ext uri="{FF2B5EF4-FFF2-40B4-BE49-F238E27FC236}">
+                <a16:creationId xmlns:a16="http://schemas.microsoft.com/office/drawing/2014/main" id="{CA86BAC8-AD3B-4402-9DC4-8740AFC4929B}"/>
+              </a:ext>
+            </a:extLst>
+          </p:cNvPr>
+          <p:cNvSpPr>
+            <a:spLocks xmlns:a="http://schemas.openxmlformats.org/drawingml/2006/main" noGrp="1"/>
+          </p:cNvSpPr>
+          <p:nvPr/>
+        </p:nvSpPr>
+        <p:spPr>
+          <a:xfrm xmlns:a="http://schemas.openxmlformats.org/drawingml/2006/main">
+            <a:off x="3476625" y="4295775"/>
+            <a:ext cx="8105775" cy="1114425"/>
           </a:xfrm>
           <a:prstGeom xmlns:a="http://schemas.openxmlformats.org/drawingml/2006/main" prst="rect">
             <a:avLst/>
@@ -9040,22 +9186,22 @@
       </p:sp>
       <p:sp>
         <p:nvSpPr>
-          <p:cNvPr id="11" name="">
-            <a:extLst xmlns:a="http://schemas.openxmlformats.org/drawingml/2006/main">
-              <a:ext uri="{FF2B5EF4-FFF2-40B4-BE49-F238E27FC236}">
-                <a16:creationId xmlns:a16="http://schemas.microsoft.com/office/drawing/2014/main" id="{44BFA0D1-CE29-4B8B-929F-BA81807447F7}"/>
-              </a:ext>
-            </a:extLst>
-          </p:cNvPr>
-          <p:cNvSpPr>
-            <a:spLocks xmlns:a="http://schemas.openxmlformats.org/drawingml/2006/main" noGrp="1"/>
-          </p:cNvSpPr>
-          <p:nvPr/>
-        </p:nvSpPr>
-        <p:spPr>
-          <a:xfrm xmlns:a="http://schemas.openxmlformats.org/drawingml/2006/main">
-            <a:off x="3476625" y="5010150"/>
-            <a:ext cx="8105775" cy="257175"/>
+          <p:cNvPr id="12" name="">
+            <a:extLst xmlns:a="http://schemas.openxmlformats.org/drawingml/2006/main">
+              <a:ext uri="{FF2B5EF4-FFF2-40B4-BE49-F238E27FC236}">
+                <a16:creationId xmlns:a16="http://schemas.microsoft.com/office/drawing/2014/main" id="{54CA514D-A162-4946-9D14-57F704E6A83D}"/>
+              </a:ext>
+            </a:extLst>
+          </p:cNvPr>
+          <p:cNvSpPr>
+            <a:spLocks xmlns:a="http://schemas.openxmlformats.org/drawingml/2006/main" noGrp="1"/>
+          </p:cNvSpPr>
+          <p:nvPr/>
+        </p:nvSpPr>
+        <p:spPr>
+          <a:xfrm xmlns:a="http://schemas.openxmlformats.org/drawingml/2006/main">
+            <a:off x="609600" y="5705475"/>
+            <a:ext cx="10972800" cy="409575"/>
           </a:xfrm>
           <a:prstGeom xmlns:a="http://schemas.openxmlformats.org/drawingml/2006/main" prst="rect">
             <a:avLst/>
@@ -9072,64 +9218,7 @@
           <a:lstStyle xmlns:a="http://schemas.openxmlformats.org/drawingml/2006/main"/>
           <a:p xmlns:a="http://schemas.openxmlformats.org/drawingml/2006/main">
             <a:pPr algn="l">
-              <a:defRPr sz="1350" b="0">
-                <a:solidFill>
-                  <a:srgbClr val="52656B"/>
-                </a:solidFill>
-                <a:latin typeface="Arial"/>
-                <a:ea typeface="Arial"/>
-                <a:cs typeface="Arial"/>
-              </a:defRPr>
-            </a:pPr>
-            <a:r>
-              <a:rPr sz="1350" b="0">
-                <a:solidFill>
-                  <a:srgbClr val="52656B"/>
-                </a:solidFill>
-                <a:latin typeface="Arial"/>
-                <a:ea typeface="Arial"/>
-                <a:cs typeface="Arial"/>
-              </a:rPr>
-              <a:t>KDIGO (2009); Nankivell (2019); BK polyomavirus consensus (2024)</a:t>
-            </a:r>
-          </a:p>
-        </p:txBody>
-      </p:sp>
-      <p:sp>
-        <p:nvSpPr>
-          <p:cNvPr id="12" name="">
-            <a:extLst xmlns:a="http://schemas.openxmlformats.org/drawingml/2006/main">
-              <a:ext uri="{FF2B5EF4-FFF2-40B4-BE49-F238E27FC236}">
-                <a16:creationId xmlns:a16="http://schemas.microsoft.com/office/drawing/2014/main" id="{F38B6620-3B99-43A7-8E35-E89F674B1C23}"/>
-              </a:ext>
-            </a:extLst>
-          </p:cNvPr>
-          <p:cNvSpPr>
-            <a:spLocks xmlns:a="http://schemas.openxmlformats.org/drawingml/2006/main" noGrp="1"/>
-          </p:cNvSpPr>
-          <p:nvPr/>
-        </p:nvSpPr>
-        <p:spPr>
-          <a:xfrm xmlns:a="http://schemas.openxmlformats.org/drawingml/2006/main">
-            <a:off x="609600" y="5353050"/>
-            <a:ext cx="10972800" cy="819150"/>
-          </a:xfrm>
-          <a:prstGeom xmlns:a="http://schemas.openxmlformats.org/drawingml/2006/main" prst="rect">
-            <a:avLst/>
-          </a:prstGeom>
-          <a:noFill xmlns:a="http://schemas.openxmlformats.org/drawingml/2006/main"/>
-          <a:ln xmlns:a="http://schemas.openxmlformats.org/drawingml/2006/main" w="0">
-            <a:noFill/>
-          </a:ln>
-        </p:spPr>
-        <p:txBody>
-          <a:bodyPr xmlns:a="http://schemas.openxmlformats.org/drawingml/2006/main" anchor="ctr">
-            <a:noAutofit/>
-          </a:bodyPr>
-          <a:lstStyle xmlns:a="http://schemas.openxmlformats.org/drawingml/2006/main"/>
-          <a:p xmlns:a="http://schemas.openxmlformats.org/drawingml/2006/main">
-            <a:pPr algn="l">
-              <a:defRPr sz="2250" b="1">
+              <a:defRPr sz="2025" b="1">
                 <a:solidFill>
                   <a:srgbClr val="007C78"/>
                 </a:solidFill>
@@ -9139,7 +9228,7 @@
               </a:defRPr>
             </a:pPr>
             <a:r>
-              <a:rPr sz="2250" b="1">
+              <a:rPr sz="2025" b="1">
                 <a:solidFill>
                   <a:srgbClr val="007C78"/>
                 </a:solidFill>
@@ -9147,30 +9236,7 @@
                 <a:ea typeface="Arial"/>
                 <a:cs typeface="Arial"/>
               </a:rPr>
-              <a:t>This project has not established usefulness in ambiguous biopsies.</a:t>
-            </a:r>
-          </a:p>
-          <a:p xmlns:a="http://schemas.openxmlformats.org/drawingml/2006/main">
-            <a:pPr algn="l">
-              <a:defRPr sz="2250" b="1">
-                <a:solidFill>
-                  <a:srgbClr val="007C78"/>
-                </a:solidFill>
-                <a:latin typeface="Arial"/>
-                <a:ea typeface="Arial"/>
-                <a:cs typeface="Arial"/>
-              </a:defRPr>
-            </a:pPr>
-            <a:r>
-              <a:rPr sz="2250" b="1">
-                <a:solidFill>
-                  <a:srgbClr val="007C78"/>
-                </a:solidFill>
-                <a:latin typeface="Arial"/>
-                <a:ea typeface="Arial"/>
-                <a:cs typeface="Arial"/>
-              </a:rPr>
-              <a:t>That requires comparing specialist assessment with and without RNA scores.</a:t>
+              <a:t>This project compares binary classifier errors against recorded diagnoses.</a:t>
             </a:r>
           </a:p>
         </p:txBody>
@@ -9178,7 +9244,7 @@
     </p:spTree>
     <p:extLst>
       <p:ext uri="{BB962C8B-B14F-4D97-AF65-F5344CB8AC3E}">
-        <p14:creationId xmlns:p14="http://schemas.microsoft.com/office/powerpoint/2010/main" val="59722089"/>
+        <p14:creationId xmlns:p14="http://schemas.microsoft.com/office/powerpoint/2010/main" val="1970890627"/>
       </p:ext>
     </p:extLst>
   </p:cSld>
@@ -9209,7 +9275,7 @@
           <p:cNvPr id="13" name="">
             <a:extLst xmlns:a="http://schemas.openxmlformats.org/drawingml/2006/main">
               <a:ext uri="{FF2B5EF4-FFF2-40B4-BE49-F238E27FC236}">
-                <a16:creationId xmlns:a16="http://schemas.microsoft.com/office/drawing/2014/main" id="{5F431C76-8A11-4C9E-AB61-4923052F290E}"/>
+                <a16:creationId xmlns:a16="http://schemas.microsoft.com/office/drawing/2014/main" id="{6B592D23-9C3F-4415-A260-632034D43FB8}"/>
               </a:ext>
             </a:extLst>
           </p:cNvPr>
@@ -9266,7 +9332,7 @@
           <p:cNvPr id="2" name="">
             <a:extLst xmlns:a="http://schemas.openxmlformats.org/drawingml/2006/main">
               <a:ext uri="{FF2B5EF4-FFF2-40B4-BE49-F238E27FC236}">
-                <a16:creationId xmlns:a16="http://schemas.microsoft.com/office/drawing/2014/main" id="{C71AF8D3-3742-4D71-ADB4-7BE697D1FF41}"/>
+                <a16:creationId xmlns:a16="http://schemas.microsoft.com/office/drawing/2014/main" id="{E9346531-79DC-4042-B380-AA946EA16CE1}"/>
               </a:ext>
             </a:extLst>
           </p:cNvPr>
@@ -9323,7 +9389,7 @@
           <p:cNvPr id="3" name="">
             <a:extLst xmlns:a="http://schemas.openxmlformats.org/drawingml/2006/main">
               <a:ext uri="{FF2B5EF4-FFF2-40B4-BE49-F238E27FC236}">
-                <a16:creationId xmlns:a16="http://schemas.microsoft.com/office/drawing/2014/main" id="{71059A5E-51C6-4123-A0E9-B031B3410732}"/>
+                <a16:creationId xmlns:a16="http://schemas.microsoft.com/office/drawing/2014/main" id="{A5121A58-F425-4308-9E69-DB22AC74E026}"/>
               </a:ext>
             </a:extLst>
           </p:cNvPr>
@@ -9380,7 +9446,7 @@
           <p:cNvPr id="4" name="">
             <a:extLst xmlns:a="http://schemas.openxmlformats.org/drawingml/2006/main">
               <a:ext uri="{FF2B5EF4-FFF2-40B4-BE49-F238E27FC236}">
-                <a16:creationId xmlns:a16="http://schemas.microsoft.com/office/drawing/2014/main" id="{6970DC7B-E58F-45EB-BB17-897DF86B57B2}"/>
+                <a16:creationId xmlns:a16="http://schemas.microsoft.com/office/drawing/2014/main" id="{DA2F1B2F-4BEA-4510-A055-3AAF0AE08875}"/>
               </a:ext>
             </a:extLst>
           </p:cNvPr>
@@ -9437,7 +9503,7 @@
           <p:cNvPr id="5" name="">
             <a:extLst xmlns:a="http://schemas.openxmlformats.org/drawingml/2006/main">
               <a:ext uri="{FF2B5EF4-FFF2-40B4-BE49-F238E27FC236}">
-                <a16:creationId xmlns:a16="http://schemas.microsoft.com/office/drawing/2014/main" id="{BBF96DC9-0A9F-4F83-B308-ACE7C98219AC}"/>
+                <a16:creationId xmlns:a16="http://schemas.microsoft.com/office/drawing/2014/main" id="{2315F3E2-3C79-4FFA-94B5-967BD00BC777}"/>
               </a:ext>
             </a:extLst>
           </p:cNvPr>
@@ -9494,7 +9560,7 @@
           <p:cNvPr id="6" name="">
             <a:extLst xmlns:a="http://schemas.openxmlformats.org/drawingml/2006/main">
               <a:ext uri="{FF2B5EF4-FFF2-40B4-BE49-F238E27FC236}">
-                <a16:creationId xmlns:a16="http://schemas.microsoft.com/office/drawing/2014/main" id="{BF6FAE34-481D-4D80-9908-EA81E5339E5E}"/>
+                <a16:creationId xmlns:a16="http://schemas.microsoft.com/office/drawing/2014/main" id="{88ADB40B-F54E-43BE-B52F-F398410D2B13}"/>
               </a:ext>
             </a:extLst>
           </p:cNvPr>
@@ -10135,7 +10201,7 @@
           <p:cNvPr id="9" name="">
             <a:extLst xmlns:a="http://schemas.openxmlformats.org/drawingml/2006/main">
               <a:ext uri="{FF2B5EF4-FFF2-40B4-BE49-F238E27FC236}">
-                <a16:creationId xmlns:a16="http://schemas.microsoft.com/office/drawing/2014/main" id="{9A247CCD-3FD6-4514-ABFC-3E7DD3613B15}"/>
+                <a16:creationId xmlns:a16="http://schemas.microsoft.com/office/drawing/2014/main" id="{475A6440-CB86-4151-B8C4-9C61B0E7FE43}"/>
               </a:ext>
             </a:extLst>
           </p:cNvPr>
@@ -10164,7 +10230,7 @@
           <p:cNvPr id="10" name="">
             <a:extLst xmlns:a="http://schemas.openxmlformats.org/drawingml/2006/main">
               <a:ext uri="{FF2B5EF4-FFF2-40B4-BE49-F238E27FC236}">
-                <a16:creationId xmlns:a16="http://schemas.microsoft.com/office/drawing/2014/main" id="{598C77B8-DAE0-4583-9567-AF24558B564B}"/>
+                <a16:creationId xmlns:a16="http://schemas.microsoft.com/office/drawing/2014/main" id="{68027F8E-4165-41D5-9A6B-8D13F346716C}"/>
               </a:ext>
             </a:extLst>
           </p:cNvPr>
@@ -10221,7 +10287,7 @@
           <p:cNvPr id="11" name="">
             <a:extLst xmlns:a="http://schemas.openxmlformats.org/drawingml/2006/main">
               <a:ext uri="{FF2B5EF4-FFF2-40B4-BE49-F238E27FC236}">
-                <a16:creationId xmlns:a16="http://schemas.microsoft.com/office/drawing/2014/main" id="{C9D963E6-BC59-409C-9061-477D39C2358C}"/>
+                <a16:creationId xmlns:a16="http://schemas.microsoft.com/office/drawing/2014/main" id="{995F1FB3-A0CD-4E32-80AB-05B41C74ABD6}"/>
               </a:ext>
             </a:extLst>
           </p:cNvPr>
@@ -10278,7 +10344,7 @@
           <p:cNvPr id="12" name="">
             <a:extLst xmlns:a="http://schemas.openxmlformats.org/drawingml/2006/main">
               <a:ext uri="{FF2B5EF4-FFF2-40B4-BE49-F238E27FC236}">
-                <a16:creationId xmlns:a16="http://schemas.microsoft.com/office/drawing/2014/main" id="{A4FB3691-4916-414D-AAF9-D83054556C99}"/>
+                <a16:creationId xmlns:a16="http://schemas.microsoft.com/office/drawing/2014/main" id="{26AA2BAC-D6C5-4778-B86D-0D6FC86A34D5}"/>
               </a:ext>
             </a:extLst>
           </p:cNvPr>
@@ -10364,7 +10430,7 @@
     </p:spTree>
     <p:extLst>
       <p:ext uri="{BB962C8B-B14F-4D97-AF65-F5344CB8AC3E}">
-        <p14:creationId xmlns:p14="http://schemas.microsoft.com/office/powerpoint/2010/main" val="1641302057"/>
+        <p14:creationId xmlns:p14="http://schemas.microsoft.com/office/powerpoint/2010/main" val="1603777412"/>
       </p:ext>
     </p:extLst>
   </p:cSld>
@@ -10395,7 +10461,7 @@
           <p:cNvPr id="7" name="">
             <a:extLst xmlns:a="http://schemas.openxmlformats.org/drawingml/2006/main">
               <a:ext uri="{FF2B5EF4-FFF2-40B4-BE49-F238E27FC236}">
-                <a16:creationId xmlns:a16="http://schemas.microsoft.com/office/drawing/2014/main" id="{ABC2A62F-124A-4982-9177-1729C336E399}"/>
+                <a16:creationId xmlns:a16="http://schemas.microsoft.com/office/drawing/2014/main" id="{B89D7E1F-A9B1-4F1D-893B-C1A3188295B6}"/>
               </a:ext>
             </a:extLst>
           </p:cNvPr>
@@ -10452,7 +10518,7 @@
           <p:cNvPr id="2" name="">
             <a:extLst xmlns:a="http://schemas.openxmlformats.org/drawingml/2006/main">
               <a:ext uri="{FF2B5EF4-FFF2-40B4-BE49-F238E27FC236}">
-                <a16:creationId xmlns:a16="http://schemas.microsoft.com/office/drawing/2014/main" id="{ACA69403-A1D0-4BF0-ABA2-D1696C0A3EB8}"/>
+                <a16:creationId xmlns:a16="http://schemas.microsoft.com/office/drawing/2014/main" id="{CA900364-2973-45AF-BCCE-156A2C4EB980}"/>
               </a:ext>
             </a:extLst>
           </p:cNvPr>
@@ -10509,7 +10575,7 @@
           <p:cNvPr id="3" name="">
             <a:extLst xmlns:a="http://schemas.openxmlformats.org/drawingml/2006/main">
               <a:ext uri="{FF2B5EF4-FFF2-40B4-BE49-F238E27FC236}">
-                <a16:creationId xmlns:a16="http://schemas.microsoft.com/office/drawing/2014/main" id="{3E1D45C2-3D26-4395-AE54-89D96C46DCE2}"/>
+                <a16:creationId xmlns:a16="http://schemas.microsoft.com/office/drawing/2014/main" id="{E75A8CB9-2226-4BF2-91A2-3DF663178B7C}"/>
               </a:ext>
             </a:extLst>
           </p:cNvPr>
@@ -10566,7 +10632,7 @@
           <p:cNvPr id="4" name="">
             <a:extLst xmlns:a="http://schemas.openxmlformats.org/drawingml/2006/main">
               <a:ext uri="{FF2B5EF4-FFF2-40B4-BE49-F238E27FC236}">
-                <a16:creationId xmlns:a16="http://schemas.microsoft.com/office/drawing/2014/main" id="{AE197FEF-73A5-4912-94C9-5B0E4E45B715}"/>
+                <a16:creationId xmlns:a16="http://schemas.microsoft.com/office/drawing/2014/main" id="{4B2C25E3-0066-4C1A-9B4B-8BA458499657}"/>
               </a:ext>
             </a:extLst>
           </p:cNvPr>
@@ -11046,7 +11112,7 @@
           <p:cNvPr id="6" name="">
             <a:extLst xmlns:a="http://schemas.openxmlformats.org/drawingml/2006/main">
               <a:ext uri="{FF2B5EF4-FFF2-40B4-BE49-F238E27FC236}">
-                <a16:creationId xmlns:a16="http://schemas.microsoft.com/office/drawing/2014/main" id="{B64EFF55-FEDB-4D1B-B62A-E618A5B2F290}"/>
+                <a16:creationId xmlns:a16="http://schemas.microsoft.com/office/drawing/2014/main" id="{5570221F-E817-4CD2-BC4D-54C7DBE6095C}"/>
               </a:ext>
             </a:extLst>
           </p:cNvPr>
@@ -11101,7 +11167,7 @@
     </p:spTree>
     <p:extLst>
       <p:ext uri="{BB962C8B-B14F-4D97-AF65-F5344CB8AC3E}">
-        <p14:creationId xmlns:p14="http://schemas.microsoft.com/office/powerpoint/2010/main" val="2107203646"/>
+        <p14:creationId xmlns:p14="http://schemas.microsoft.com/office/powerpoint/2010/main" val="603845905"/>
       </p:ext>
     </p:extLst>
   </p:cSld>
@@ -11132,7 +11198,7 @@
           <p:cNvPr id="11" name="">
             <a:extLst xmlns:a="http://schemas.openxmlformats.org/drawingml/2006/main">
               <a:ext uri="{FF2B5EF4-FFF2-40B4-BE49-F238E27FC236}">
-                <a16:creationId xmlns:a16="http://schemas.microsoft.com/office/drawing/2014/main" id="{895F2407-C5EC-4FDE-9192-8528F4470218}"/>
+                <a16:creationId xmlns:a16="http://schemas.microsoft.com/office/drawing/2014/main" id="{2AEB6F53-48BE-4974-A36C-BC4960B955E8}"/>
               </a:ext>
             </a:extLst>
           </p:cNvPr>
@@ -11189,7 +11255,7 @@
           <p:cNvPr id="2" name="">
             <a:extLst xmlns:a="http://schemas.openxmlformats.org/drawingml/2006/main">
               <a:ext uri="{FF2B5EF4-FFF2-40B4-BE49-F238E27FC236}">
-                <a16:creationId xmlns:a16="http://schemas.microsoft.com/office/drawing/2014/main" id="{8A42B5D8-9BF7-4502-BD14-B7BD12F57DA5}"/>
+                <a16:creationId xmlns:a16="http://schemas.microsoft.com/office/drawing/2014/main" id="{F0D46A98-93FA-44BA-B37B-FD1C6A8C341D}"/>
               </a:ext>
             </a:extLst>
           </p:cNvPr>
@@ -11246,7 +11312,7 @@
           <p:cNvPr id="3" name="">
             <a:extLst xmlns:a="http://schemas.openxmlformats.org/drawingml/2006/main">
               <a:ext uri="{FF2B5EF4-FFF2-40B4-BE49-F238E27FC236}">
-                <a16:creationId xmlns:a16="http://schemas.microsoft.com/office/drawing/2014/main" id="{9B28A0B1-74B1-4E4E-B941-6A8A871CD72A}"/>
+                <a16:creationId xmlns:a16="http://schemas.microsoft.com/office/drawing/2014/main" id="{7D4C512E-848F-4799-891E-5D3048786173}"/>
               </a:ext>
             </a:extLst>
           </p:cNvPr>
@@ -11303,7 +11369,7 @@
           <p:cNvPr id="4" name="">
             <a:extLst xmlns:a="http://schemas.openxmlformats.org/drawingml/2006/main">
               <a:ext uri="{FF2B5EF4-FFF2-40B4-BE49-F238E27FC236}">
-                <a16:creationId xmlns:a16="http://schemas.microsoft.com/office/drawing/2014/main" id="{2897DC9E-6EFA-4C3F-AE85-FE11B47A84C5}"/>
+                <a16:creationId xmlns:a16="http://schemas.microsoft.com/office/drawing/2014/main" id="{0C10486F-DDF1-4D02-84BD-8E4C4463DCB0}"/>
               </a:ext>
             </a:extLst>
           </p:cNvPr>
@@ -11360,7 +11426,7 @@
           <p:cNvPr id="5" name="">
             <a:extLst xmlns:a="http://schemas.openxmlformats.org/drawingml/2006/main">
               <a:ext uri="{FF2B5EF4-FFF2-40B4-BE49-F238E27FC236}">
-                <a16:creationId xmlns:a16="http://schemas.microsoft.com/office/drawing/2014/main" id="{078CCC6C-7B57-4EAE-AC99-98A2DBD13CD8}"/>
+                <a16:creationId xmlns:a16="http://schemas.microsoft.com/office/drawing/2014/main" id="{D849AA30-0E40-494E-A35F-70888CE86844}"/>
               </a:ext>
             </a:extLst>
           </p:cNvPr>
@@ -11417,7 +11483,7 @@
           <p:cNvPr id="6" name="">
             <a:extLst xmlns:a="http://schemas.openxmlformats.org/drawingml/2006/main">
               <a:ext uri="{FF2B5EF4-FFF2-40B4-BE49-F238E27FC236}">
-                <a16:creationId xmlns:a16="http://schemas.microsoft.com/office/drawing/2014/main" id="{94906B19-AFE7-46C8-AF9F-A577961D681B}"/>
+                <a16:creationId xmlns:a16="http://schemas.microsoft.com/office/drawing/2014/main" id="{35AAC4F8-9CD9-4271-A482-123F8076F7A3}"/>
               </a:ext>
             </a:extLst>
           </p:cNvPr>
@@ -11474,7 +11540,7 @@
           <p:cNvPr id="7" name="">
             <a:extLst xmlns:a="http://schemas.openxmlformats.org/drawingml/2006/main">
               <a:ext uri="{FF2B5EF4-FFF2-40B4-BE49-F238E27FC236}">
-                <a16:creationId xmlns:a16="http://schemas.microsoft.com/office/drawing/2014/main" id="{B38A6DA1-9F2D-4608-8FC1-A9A643A7D19E}"/>
+                <a16:creationId xmlns:a16="http://schemas.microsoft.com/office/drawing/2014/main" id="{6B870C10-CD8A-4D7E-A5CA-D1FDACF73307}"/>
               </a:ext>
             </a:extLst>
           </p:cNvPr>
@@ -11589,7 +11655,7 @@
           <p:cNvPr id="8" name="">
             <a:extLst xmlns:a="http://schemas.openxmlformats.org/drawingml/2006/main">
               <a:ext uri="{FF2B5EF4-FFF2-40B4-BE49-F238E27FC236}">
-                <a16:creationId xmlns:a16="http://schemas.microsoft.com/office/drawing/2014/main" id="{332AC095-E167-4DE8-A1DB-489C1506B251}"/>
+                <a16:creationId xmlns:a16="http://schemas.microsoft.com/office/drawing/2014/main" id="{34E46DAF-6DBC-4FF6-80FD-9F0EC934F017}"/>
               </a:ext>
             </a:extLst>
           </p:cNvPr>
@@ -11646,7 +11712,7 @@
           <p:cNvPr id="9" name="">
             <a:extLst xmlns:a="http://schemas.openxmlformats.org/drawingml/2006/main">
               <a:ext uri="{FF2B5EF4-FFF2-40B4-BE49-F238E27FC236}">
-                <a16:creationId xmlns:a16="http://schemas.microsoft.com/office/drawing/2014/main" id="{2DB963A7-5719-49A6-BEBB-CCD1A19DCB05}"/>
+                <a16:creationId xmlns:a16="http://schemas.microsoft.com/office/drawing/2014/main" id="{8245895F-AD5B-4E5E-B04F-35ACB78B0F9F}"/>
               </a:ext>
             </a:extLst>
           </p:cNvPr>
@@ -11703,7 +11769,7 @@
           <p:cNvPr id="10" name="">
             <a:extLst xmlns:a="http://schemas.openxmlformats.org/drawingml/2006/main">
               <a:ext uri="{FF2B5EF4-FFF2-40B4-BE49-F238E27FC236}">
-                <a16:creationId xmlns:a16="http://schemas.microsoft.com/office/drawing/2014/main" id="{786DAC70-0981-4B06-8437-61A4F5BB780F}"/>
+                <a16:creationId xmlns:a16="http://schemas.microsoft.com/office/drawing/2014/main" id="{526288D3-816D-4289-89FE-276534E1137E}"/>
               </a:ext>
             </a:extLst>
           </p:cNvPr>
@@ -11816,7 +11882,7 @@
     </p:spTree>
     <p:extLst>
       <p:ext uri="{BB962C8B-B14F-4D97-AF65-F5344CB8AC3E}">
-        <p14:creationId xmlns:p14="http://schemas.microsoft.com/office/powerpoint/2010/main" val="1033048387"/>
+        <p14:creationId xmlns:p14="http://schemas.microsoft.com/office/powerpoint/2010/main" val="1179486579"/>
       </p:ext>
     </p:extLst>
   </p:cSld>
@@ -11847,7 +11913,7 @@
           <p:cNvPr id="5" name="">
             <a:extLst xmlns:a="http://schemas.openxmlformats.org/drawingml/2006/main">
               <a:ext uri="{FF2B5EF4-FFF2-40B4-BE49-F238E27FC236}">
-                <a16:creationId xmlns:a16="http://schemas.microsoft.com/office/drawing/2014/main" id="{E88295D8-984F-4704-A828-A9D3DD060E24}"/>
+                <a16:creationId xmlns:a16="http://schemas.microsoft.com/office/drawing/2014/main" id="{B8E70A33-9E5B-471C-A107-11F335211070}"/>
               </a:ext>
             </a:extLst>
           </p:cNvPr>
@@ -11904,7 +11970,7 @@
           <p:cNvPr id="2" name="">
             <a:extLst xmlns:a="http://schemas.openxmlformats.org/drawingml/2006/main">
               <a:ext uri="{FF2B5EF4-FFF2-40B4-BE49-F238E27FC236}">
-                <a16:creationId xmlns:a16="http://schemas.microsoft.com/office/drawing/2014/main" id="{3DB20259-434D-4901-981A-C74AB6ACC771}"/>
+                <a16:creationId xmlns:a16="http://schemas.microsoft.com/office/drawing/2014/main" id="{598601A4-507C-4B32-8325-78D0AB0957B9}"/>
               </a:ext>
             </a:extLst>
           </p:cNvPr>
@@ -11961,7 +12027,7 @@
           <p:cNvPr id="3" name="">
             <a:extLst xmlns:a="http://schemas.openxmlformats.org/drawingml/2006/main">
               <a:ext uri="{FF2B5EF4-FFF2-40B4-BE49-F238E27FC236}">
-                <a16:creationId xmlns:a16="http://schemas.microsoft.com/office/drawing/2014/main" id="{5A210E71-392A-4528-B030-FF235C1F46D9}"/>
+                <a16:creationId xmlns:a16="http://schemas.microsoft.com/office/drawing/2014/main" id="{0A2817DD-2D72-4DC2-9CF1-6AEDBD29224D}"/>
               </a:ext>
             </a:extLst>
           </p:cNvPr>
@@ -12308,7 +12374,7 @@
     </p:spTree>
     <p:extLst>
       <p:ext uri="{BB962C8B-B14F-4D97-AF65-F5344CB8AC3E}">
-        <p14:creationId xmlns:p14="http://schemas.microsoft.com/office/powerpoint/2010/main" val="852904421"/>
+        <p14:creationId xmlns:p14="http://schemas.microsoft.com/office/powerpoint/2010/main" val="141586907"/>
       </p:ext>
     </p:extLst>
   </p:cSld>
@@ -12339,7 +12405,7 @@
           <p:cNvPr id="11" name="">
             <a:extLst xmlns:a="http://schemas.openxmlformats.org/drawingml/2006/main">
               <a:ext uri="{FF2B5EF4-FFF2-40B4-BE49-F238E27FC236}">
-                <a16:creationId xmlns:a16="http://schemas.microsoft.com/office/drawing/2014/main" id="{2962AE36-99C5-4042-88B7-E358FE895E9E}"/>
+                <a16:creationId xmlns:a16="http://schemas.microsoft.com/office/drawing/2014/main" id="{A3B64EFB-D7CB-4C1C-8105-A69DF1692552}"/>
               </a:ext>
             </a:extLst>
           </p:cNvPr>
@@ -12396,7 +12462,7 @@
           <p:cNvPr id="2" name="">
             <a:extLst xmlns:a="http://schemas.openxmlformats.org/drawingml/2006/main">
               <a:ext uri="{FF2B5EF4-FFF2-40B4-BE49-F238E27FC236}">
-                <a16:creationId xmlns:a16="http://schemas.microsoft.com/office/drawing/2014/main" id="{ED5CCE2E-DF3C-4B0E-BA7C-1F1360B5AE11}"/>
+                <a16:creationId xmlns:a16="http://schemas.microsoft.com/office/drawing/2014/main" id="{BC921378-8F81-45C5-AF83-6BCECD7007E0}"/>
               </a:ext>
             </a:extLst>
           </p:cNvPr>
@@ -12453,7 +12519,7 @@
           <p:cNvPr id="3" name="">
             <a:extLst xmlns:a="http://schemas.openxmlformats.org/drawingml/2006/main">
               <a:ext uri="{FF2B5EF4-FFF2-40B4-BE49-F238E27FC236}">
-                <a16:creationId xmlns:a16="http://schemas.microsoft.com/office/drawing/2014/main" id="{61FB976A-EA03-4A73-A040-CDB5117AB436}"/>
+                <a16:creationId xmlns:a16="http://schemas.microsoft.com/office/drawing/2014/main" id="{86668167-0F9C-48FC-B43C-A350B21BDD7C}"/>
               </a:ext>
             </a:extLst>
           </p:cNvPr>
@@ -12510,7 +12576,7 @@
           <p:cNvPr id="4" name="">
             <a:extLst xmlns:a="http://schemas.openxmlformats.org/drawingml/2006/main">
               <a:ext uri="{FF2B5EF4-FFF2-40B4-BE49-F238E27FC236}">
-                <a16:creationId xmlns:a16="http://schemas.microsoft.com/office/drawing/2014/main" id="{7A6D0B42-0555-48BB-AFE8-454F72AC73DB}"/>
+                <a16:creationId xmlns:a16="http://schemas.microsoft.com/office/drawing/2014/main" id="{44B39263-190D-43A6-9D4A-534152A7991A}"/>
               </a:ext>
             </a:extLst>
           </p:cNvPr>
@@ -12598,7 +12664,7 @@
           <p:cNvPr id="5" name="">
             <a:extLst xmlns:a="http://schemas.openxmlformats.org/drawingml/2006/main">
               <a:ext uri="{FF2B5EF4-FFF2-40B4-BE49-F238E27FC236}">
-                <a16:creationId xmlns:a16="http://schemas.microsoft.com/office/drawing/2014/main" id="{102B869A-26A4-4246-AB7C-7F3462ED3F50}"/>
+                <a16:creationId xmlns:a16="http://schemas.microsoft.com/office/drawing/2014/main" id="{855E4670-9989-4D38-BA32-ECC0E1126B8B}"/>
               </a:ext>
             </a:extLst>
           </p:cNvPr>
@@ -12682,7 +12748,7 @@
           <p:cNvPr id="6" name="">
             <a:extLst xmlns:a="http://schemas.openxmlformats.org/drawingml/2006/main">
               <a:ext uri="{FF2B5EF4-FFF2-40B4-BE49-F238E27FC236}">
-                <a16:creationId xmlns:a16="http://schemas.microsoft.com/office/drawing/2014/main" id="{C8DA0ABD-77D3-4B29-880B-73EA4818E2EE}"/>
+                <a16:creationId xmlns:a16="http://schemas.microsoft.com/office/drawing/2014/main" id="{235F124B-CF62-41AD-B116-AE87FFAF1849}"/>
               </a:ext>
             </a:extLst>
           </p:cNvPr>
@@ -12766,7 +12832,7 @@
           <p:cNvPr id="7" name="">
             <a:extLst xmlns:a="http://schemas.openxmlformats.org/drawingml/2006/main">
               <a:ext uri="{FF2B5EF4-FFF2-40B4-BE49-F238E27FC236}">
-                <a16:creationId xmlns:a16="http://schemas.microsoft.com/office/drawing/2014/main" id="{62225C69-C1FD-4B90-AA82-BD514B8D2C9B}"/>
+                <a16:creationId xmlns:a16="http://schemas.microsoft.com/office/drawing/2014/main" id="{BD499024-1C99-439A-B4B6-815A5172C2F7}"/>
               </a:ext>
             </a:extLst>
           </p:cNvPr>
@@ -12906,7 +12972,7 @@
           <p:cNvPr id="10" name="">
             <a:extLst xmlns:a="http://schemas.openxmlformats.org/drawingml/2006/main">
               <a:ext uri="{FF2B5EF4-FFF2-40B4-BE49-F238E27FC236}">
-                <a16:creationId xmlns:a16="http://schemas.microsoft.com/office/drawing/2014/main" id="{788EF9B9-ACE8-43D8-9CE2-C3F2892627AD}"/>
+                <a16:creationId xmlns:a16="http://schemas.microsoft.com/office/drawing/2014/main" id="{B669DB85-AE16-4E4E-AA00-CB7E40D505F8}"/>
               </a:ext>
             </a:extLst>
           </p:cNvPr>
@@ -13039,7 +13105,7 @@
     </p:spTree>
     <p:extLst>
       <p:ext uri="{BB962C8B-B14F-4D97-AF65-F5344CB8AC3E}">
-        <p14:creationId xmlns:p14="http://schemas.microsoft.com/office/powerpoint/2010/main" val="1757600718"/>
+        <p14:creationId xmlns:p14="http://schemas.microsoft.com/office/powerpoint/2010/main" val="940028908"/>
       </p:ext>
     </p:extLst>
   </p:cSld>

</xml_diff>

<commit_message>
Finalize slides and synchronize presentation materials
Replace slide 4’s error row with KDIGO biopsy guidance and move the
error discussion to slide 3’s script. Reorder slide 12’s legend,
rename slide 13 and remove its bullets, and remove slide 14’s next steps.

Refresh the deck, PDF, script, previews, documentation, and manifests.
</commit_message>
<xml_diff>
--- a/presentation/unos_kidney_biopsy.pptx
+++ b/presentation/unos_kidney_biopsy.pptx
@@ -2,23 +2,23 @@
 <file path=ppt/presentation.xml><?xml version="1.0" encoding="utf-8"?>
 <p:presentation xmlns:p="http://schemas.openxmlformats.org/presentationml/2006/main" xmlns:r="http://schemas.openxmlformats.org/officeDocument/2006/relationships">
   <p:sldMasterIdLst>
-    <p:sldMasterId id="2147483648" r:id="R0ed844c1105f43f4"/>
+    <p:sldMasterId id="2147483648" r:id="Radcac8545d59437c"/>
   </p:sldMasterIdLst>
   <p:sldIdLst>
-    <p:sldId id="256" r:id="R1da50bf531ec4aac"/>
-    <p:sldId id="257" r:id="Rf84452d2265644c6"/>
-    <p:sldId id="258" r:id="Rd2bbc35d9db44420"/>
-    <p:sldId id="259" r:id="Re748c4c2b0c548ea"/>
-    <p:sldId id="260" r:id="Rd7d2817c67384cbf"/>
-    <p:sldId id="261" r:id="R326e2b707e904e08"/>
-    <p:sldId id="262" r:id="R9f4d3c9562e940fd"/>
-    <p:sldId id="263" r:id="Rcf1563392a334b63"/>
-    <p:sldId id="264" r:id="R80cebfcf34f4494f"/>
-    <p:sldId id="265" r:id="Rfc305686560343d3"/>
-    <p:sldId id="266" r:id="Raa05d04e427a4301"/>
-    <p:sldId id="267" r:id="R4d42540895c64039"/>
-    <p:sldId id="268" r:id="R7acc59df41194444"/>
-    <p:sldId id="269" r:id="R12b69fb94bfe4fd3"/>
+    <p:sldId id="256" r:id="R781d5cc738c34436"/>
+    <p:sldId id="257" r:id="Rec3db5835e1f439a"/>
+    <p:sldId id="258" r:id="R51719fcafa0f403e"/>
+    <p:sldId id="259" r:id="R00b76af712754641"/>
+    <p:sldId id="260" r:id="Re8cd26c337104d9f"/>
+    <p:sldId id="261" r:id="Rcfef350d5687436e"/>
+    <p:sldId id="262" r:id="R15d2744f03f84fc0"/>
+    <p:sldId id="263" r:id="R66384e3f01c94cf4"/>
+    <p:sldId id="264" r:id="Rec0215ee7d3a4316"/>
+    <p:sldId id="265" r:id="R0332bfbb659f45a8"/>
+    <p:sldId id="266" r:id="R440cffbe54994fea"/>
+    <p:sldId id="267" r:id="Re07831943fa54d19"/>
+    <p:sldId id="268" r:id="Rc2c60499f0df4be4"/>
+    <p:sldId id="269" r:id="Rfc31a2a832e0429b"/>
   </p:sldIdLst>
   <p:sldSz cx="12192000" cy="6858000"/>
   <p:notesSz cx="6858000" cy="9144000"/>
@@ -63,7 +63,7 @@
   </p:cSld>
   <p:clrMap bg1="lt1" tx1="dk1" bg2="lt2" tx2="dk2" accent1="accent1" accent2="accent2" accent3="accent3" accent4="accent4" accent5="accent5" accent6="accent6" hlink="hlink" folHlink="folHlink"/>
   <p:sldLayoutIdLst>
-    <p:sldLayoutId xmlns:r="http://schemas.openxmlformats.org/officeDocument/2006/relationships" id="2147483649" r:id="R7ebc50db3a104ecd"/>
+    <p:sldLayoutId xmlns:r="http://schemas.openxmlformats.org/officeDocument/2006/relationships" id="2147483649" r:id="Re16480a5278443de"/>
   </p:sldLayoutIdLst>
   <p:txStyles>
     <p:titleStyle>
@@ -814,26 +814,6 @@
         </a:solidFill>
       </c:spPr>
     </c:plotArea>
-    <c:legend>
-      <c:legendPos val="b"/>
-      <c:overlay val="0"/>
-      <c:txPr>
-        <a:bodyPr xmlns:a="http://schemas.openxmlformats.org/drawingml/2006/main" anchorCtr="1"/>
-        <a:lstStyle xmlns:a="http://schemas.openxmlformats.org/drawingml/2006/main"/>
-        <a:p xmlns:a="http://schemas.openxmlformats.org/drawingml/2006/main">
-          <a:pPr>
-            <a:defRPr sz="1875">
-              <a:solidFill>
-                <a:srgbClr val="16343E"/>
-              </a:solidFill>
-              <a:latin typeface="Arial"/>
-              <a:ea typeface="Arial"/>
-              <a:cs typeface="Arial"/>
-            </a:defRPr>
-          </a:pPr>
-        </a:p>
-      </c:txPr>
-    </c:legend>
     <c:plotVisOnly val="1"/>
   </c:chart>
   <c:spPr>
@@ -871,7 +851,7 @@
           <p:cNvPr id="2" name="">
             <a:extLst xmlns:a="http://schemas.openxmlformats.org/drawingml/2006/main">
               <a:ext uri="{FF2B5EF4-FFF2-40B4-BE49-F238E27FC236}">
-                <a16:creationId xmlns:a16="http://schemas.microsoft.com/office/drawing/2014/main" id="{0F8CF6AB-CAFC-4852-A4A6-32339F559DBF}"/>
+                <a16:creationId xmlns:a16="http://schemas.microsoft.com/office/drawing/2014/main" id="{B0A82B52-8CE3-4D48-99D9-33FFE7A9A04E}"/>
               </a:ext>
             </a:extLst>
           </p:cNvPr>
@@ -972,7 +952,7 @@
     </p:spTree>
     <p:extLst>
       <p:ext uri="{BB962C8B-B14F-4D97-AF65-F5344CB8AC3E}">
-        <p14:creationId xmlns:p14="http://schemas.microsoft.com/office/powerpoint/2010/main" val="1042494574"/>
+        <p14:creationId xmlns:p14="http://schemas.microsoft.com/office/powerpoint/2010/main" val="127899676"/>
       </p:ext>
     </p:extLst>
   </p:cSld>
@@ -1003,7 +983,7 @@
           <p:cNvPr id="6" name="">
             <a:extLst xmlns:a="http://schemas.openxmlformats.org/drawingml/2006/main">
               <a:ext uri="{FF2B5EF4-FFF2-40B4-BE49-F238E27FC236}">
-                <a16:creationId xmlns:a16="http://schemas.microsoft.com/office/drawing/2014/main" id="{955859BB-C459-4BC4-8216-0140BA1794ED}"/>
+                <a16:creationId xmlns:a16="http://schemas.microsoft.com/office/drawing/2014/main" id="{E73B0216-C3F7-4604-905B-288AB82100BB}"/>
               </a:ext>
             </a:extLst>
           </p:cNvPr>
@@ -1060,7 +1040,7 @@
           <p:cNvPr id="2" name="">
             <a:extLst xmlns:a="http://schemas.openxmlformats.org/drawingml/2006/main">
               <a:ext uri="{FF2B5EF4-FFF2-40B4-BE49-F238E27FC236}">
-                <a16:creationId xmlns:a16="http://schemas.microsoft.com/office/drawing/2014/main" id="{EC4AEA37-B91E-4A37-8A64-79FFCE738AEE}"/>
+                <a16:creationId xmlns:a16="http://schemas.microsoft.com/office/drawing/2014/main" id="{9002DCF9-2C2B-4281-A28A-3E3437622966}"/>
               </a:ext>
             </a:extLst>
           </p:cNvPr>
@@ -1117,7 +1097,7 @@
           <p:cNvPr id="3" name="">
             <a:extLst xmlns:a="http://schemas.openxmlformats.org/drawingml/2006/main">
               <a:ext uri="{FF2B5EF4-FFF2-40B4-BE49-F238E27FC236}">
-                <a16:creationId xmlns:a16="http://schemas.microsoft.com/office/drawing/2014/main" id="{5181A541-BBC7-4329-8328-AB79E16ABD48}"/>
+                <a16:creationId xmlns:a16="http://schemas.microsoft.com/office/drawing/2014/main" id="{34ABB45B-2395-4206-9F1D-FA213348ED9F}"/>
               </a:ext>
             </a:extLst>
           </p:cNvPr>
@@ -1174,7 +1154,7 @@
           <p:cNvPr id="4" name="">
             <a:extLst xmlns:a="http://schemas.openxmlformats.org/drawingml/2006/main">
               <a:ext uri="{FF2B5EF4-FFF2-40B4-BE49-F238E27FC236}">
-                <a16:creationId xmlns:a16="http://schemas.microsoft.com/office/drawing/2014/main" id="{E2FA1A24-85D4-4840-9C8A-06AB6CCEE35F}"/>
+                <a16:creationId xmlns:a16="http://schemas.microsoft.com/office/drawing/2014/main" id="{5A1F7487-B277-4FED-805A-26C08DA5DD40}"/>
               </a:ext>
             </a:extLst>
           </p:cNvPr>
@@ -1586,7 +1566,7 @@
     </p:spTree>
     <p:extLst>
       <p:ext uri="{BB962C8B-B14F-4D97-AF65-F5344CB8AC3E}">
-        <p14:creationId xmlns:p14="http://schemas.microsoft.com/office/powerpoint/2010/main" val="242133843"/>
+        <p14:creationId xmlns:p14="http://schemas.microsoft.com/office/powerpoint/2010/main" val="284554763"/>
       </p:ext>
     </p:extLst>
   </p:cSld>
@@ -1617,7 +1597,7 @@
           <p:cNvPr id="17" name="">
             <a:extLst xmlns:a="http://schemas.openxmlformats.org/drawingml/2006/main">
               <a:ext uri="{FF2B5EF4-FFF2-40B4-BE49-F238E27FC236}">
-                <a16:creationId xmlns:a16="http://schemas.microsoft.com/office/drawing/2014/main" id="{C5C11C9D-1CA5-4BF2-A777-52B504D1C532}"/>
+                <a16:creationId xmlns:a16="http://schemas.microsoft.com/office/drawing/2014/main" id="{4739A7F1-8656-4254-9701-296F90B78597}"/>
               </a:ext>
             </a:extLst>
           </p:cNvPr>
@@ -1674,7 +1654,7 @@
           <p:cNvPr id="2" name="">
             <a:extLst xmlns:a="http://schemas.openxmlformats.org/drawingml/2006/main">
               <a:ext uri="{FF2B5EF4-FFF2-40B4-BE49-F238E27FC236}">
-                <a16:creationId xmlns:a16="http://schemas.microsoft.com/office/drawing/2014/main" id="{81582DD5-62AA-4394-9C7C-606E2CB4FD5C}"/>
+                <a16:creationId xmlns:a16="http://schemas.microsoft.com/office/drawing/2014/main" id="{066855E6-2273-4C73-88F4-055AD4EF9706}"/>
               </a:ext>
             </a:extLst>
           </p:cNvPr>
@@ -1731,7 +1711,7 @@
           <p:cNvPr id="3" name="">
             <a:extLst xmlns:a="http://schemas.openxmlformats.org/drawingml/2006/main">
               <a:ext uri="{FF2B5EF4-FFF2-40B4-BE49-F238E27FC236}">
-                <a16:creationId xmlns:a16="http://schemas.microsoft.com/office/drawing/2014/main" id="{E7AF7B64-0097-4729-8FC1-B999E83E5F5B}"/>
+                <a16:creationId xmlns:a16="http://schemas.microsoft.com/office/drawing/2014/main" id="{F769555E-9913-4882-A2B7-07EF127E5499}"/>
               </a:ext>
             </a:extLst>
           </p:cNvPr>
@@ -1788,7 +1768,7 @@
           <p:cNvPr id="4" name="">
             <a:extLst xmlns:a="http://schemas.openxmlformats.org/drawingml/2006/main">
               <a:ext uri="{FF2B5EF4-FFF2-40B4-BE49-F238E27FC236}">
-                <a16:creationId xmlns:a16="http://schemas.microsoft.com/office/drawing/2014/main" id="{CAF7B699-8488-445C-A2BD-0E77DB4F5E91}"/>
+                <a16:creationId xmlns:a16="http://schemas.microsoft.com/office/drawing/2014/main" id="{345CD311-FDF0-446C-9E3B-95D41E892E90}"/>
               </a:ext>
             </a:extLst>
           </p:cNvPr>
@@ -1845,7 +1825,7 @@
           <p:cNvPr id="5" name="">
             <a:extLst xmlns:a="http://schemas.openxmlformats.org/drawingml/2006/main">
               <a:ext uri="{FF2B5EF4-FFF2-40B4-BE49-F238E27FC236}">
-                <a16:creationId xmlns:a16="http://schemas.microsoft.com/office/drawing/2014/main" id="{C49B3DF7-76E1-43E1-884B-1DA8F5C87839}"/>
+                <a16:creationId xmlns:a16="http://schemas.microsoft.com/office/drawing/2014/main" id="{CF7005A7-3B01-40F4-A783-AD8640306483}"/>
               </a:ext>
             </a:extLst>
           </p:cNvPr>
@@ -1902,7 +1882,7 @@
           <p:cNvPr id="6" name="">
             <a:extLst xmlns:a="http://schemas.openxmlformats.org/drawingml/2006/main">
               <a:ext uri="{FF2B5EF4-FFF2-40B4-BE49-F238E27FC236}">
-                <a16:creationId xmlns:a16="http://schemas.microsoft.com/office/drawing/2014/main" id="{E3DD8664-F410-4247-B7F8-61650F5AACB7}"/>
+                <a16:creationId xmlns:a16="http://schemas.microsoft.com/office/drawing/2014/main" id="{026FE924-BD19-415D-A330-252FDA587CC3}"/>
               </a:ext>
             </a:extLst>
           </p:cNvPr>
@@ -1931,7 +1911,7 @@
           <p:cNvPr id="7" name="">
             <a:extLst xmlns:a="http://schemas.openxmlformats.org/drawingml/2006/main">
               <a:ext uri="{FF2B5EF4-FFF2-40B4-BE49-F238E27FC236}">
-                <a16:creationId xmlns:a16="http://schemas.microsoft.com/office/drawing/2014/main" id="{0A903C10-2C82-4656-9FB9-EEB6DDD98F5F}"/>
+                <a16:creationId xmlns:a16="http://schemas.microsoft.com/office/drawing/2014/main" id="{DCFF365D-98EE-4A4A-A9E7-6A7B7F6E7623}"/>
               </a:ext>
             </a:extLst>
           </p:cNvPr>
@@ -1988,7 +1968,7 @@
           <p:cNvPr id="8" name="">
             <a:extLst xmlns:a="http://schemas.openxmlformats.org/drawingml/2006/main">
               <a:ext uri="{FF2B5EF4-FFF2-40B4-BE49-F238E27FC236}">
-                <a16:creationId xmlns:a16="http://schemas.microsoft.com/office/drawing/2014/main" id="{C5F98733-F947-4FE3-AFBE-D403CEACB835}"/>
+                <a16:creationId xmlns:a16="http://schemas.microsoft.com/office/drawing/2014/main" id="{74E8CCC5-1AA3-41E8-81BD-FF7036BEBDC3}"/>
               </a:ext>
             </a:extLst>
           </p:cNvPr>
@@ -2045,7 +2025,7 @@
           <p:cNvPr id="9" name="">
             <a:extLst xmlns:a="http://schemas.openxmlformats.org/drawingml/2006/main">
               <a:ext uri="{FF2B5EF4-FFF2-40B4-BE49-F238E27FC236}">
-                <a16:creationId xmlns:a16="http://schemas.microsoft.com/office/drawing/2014/main" id="{5CDF9B54-EB57-4011-9EB6-44449F58A285}"/>
+                <a16:creationId xmlns:a16="http://schemas.microsoft.com/office/drawing/2014/main" id="{02073927-9BB1-4E6C-A3AD-BFA7C7A2E5F1}"/>
               </a:ext>
             </a:extLst>
           </p:cNvPr>
@@ -2102,7 +2082,7 @@
           <p:cNvPr id="10" name="">
             <a:extLst xmlns:a="http://schemas.openxmlformats.org/drawingml/2006/main">
               <a:ext uri="{FF2B5EF4-FFF2-40B4-BE49-F238E27FC236}">
-                <a16:creationId xmlns:a16="http://schemas.microsoft.com/office/drawing/2014/main" id="{6F08D2CB-3415-410E-A455-577623E8F27F}"/>
+                <a16:creationId xmlns:a16="http://schemas.microsoft.com/office/drawing/2014/main" id="{C9182292-7BC1-40CA-99DC-78DAABB4453B}"/>
               </a:ext>
             </a:extLst>
           </p:cNvPr>
@@ -2159,7 +2139,7 @@
           <p:cNvPr id="11" name="">
             <a:extLst xmlns:a="http://schemas.openxmlformats.org/drawingml/2006/main">
               <a:ext uri="{FF2B5EF4-FFF2-40B4-BE49-F238E27FC236}">
-                <a16:creationId xmlns:a16="http://schemas.microsoft.com/office/drawing/2014/main" id="{46B469E6-0F2C-483F-A1FF-991F72F251FA}"/>
+                <a16:creationId xmlns:a16="http://schemas.microsoft.com/office/drawing/2014/main" id="{ABAC7DC1-9675-45A9-BA6A-2B3A34D13E58}"/>
               </a:ext>
             </a:extLst>
           </p:cNvPr>
@@ -2188,7 +2168,7 @@
           <p:cNvPr id="12" name="">
             <a:extLst xmlns:a="http://schemas.openxmlformats.org/drawingml/2006/main">
               <a:ext uri="{FF2B5EF4-FFF2-40B4-BE49-F238E27FC236}">
-                <a16:creationId xmlns:a16="http://schemas.microsoft.com/office/drawing/2014/main" id="{F97EE539-693A-4775-A212-11E1D6AAD336}"/>
+                <a16:creationId xmlns:a16="http://schemas.microsoft.com/office/drawing/2014/main" id="{8AE41C2D-D195-4D6F-8786-F1461927C9EA}"/>
               </a:ext>
             </a:extLst>
           </p:cNvPr>
@@ -2245,7 +2225,7 @@
           <p:cNvPr id="13" name="">
             <a:extLst xmlns:a="http://schemas.openxmlformats.org/drawingml/2006/main">
               <a:ext uri="{FF2B5EF4-FFF2-40B4-BE49-F238E27FC236}">
-                <a16:creationId xmlns:a16="http://schemas.microsoft.com/office/drawing/2014/main" id="{60F1CB5C-8673-4A4A-8CE7-A49F1D16091F}"/>
+                <a16:creationId xmlns:a16="http://schemas.microsoft.com/office/drawing/2014/main" id="{E9B645D9-71EF-44F3-AC34-8EF5AFF41FB5}"/>
               </a:ext>
             </a:extLst>
           </p:cNvPr>
@@ -2302,7 +2282,7 @@
           <p:cNvPr id="14" name="">
             <a:extLst xmlns:a="http://schemas.openxmlformats.org/drawingml/2006/main">
               <a:ext uri="{FF2B5EF4-FFF2-40B4-BE49-F238E27FC236}">
-                <a16:creationId xmlns:a16="http://schemas.microsoft.com/office/drawing/2014/main" id="{BE67BF4A-751C-43E8-BD8B-5C4818DE798E}"/>
+                <a16:creationId xmlns:a16="http://schemas.microsoft.com/office/drawing/2014/main" id="{EAC29816-8B17-4F06-8F31-A2D03385B137}"/>
               </a:ext>
             </a:extLst>
           </p:cNvPr>
@@ -2645,7 +2625,7 @@
           <p:cNvPr id="16" name="">
             <a:extLst xmlns:a="http://schemas.openxmlformats.org/drawingml/2006/main">
               <a:ext uri="{FF2B5EF4-FFF2-40B4-BE49-F238E27FC236}">
-                <a16:creationId xmlns:a16="http://schemas.microsoft.com/office/drawing/2014/main" id="{D4878F94-935E-470F-8330-D6EAEC799531}"/>
+                <a16:creationId xmlns:a16="http://schemas.microsoft.com/office/drawing/2014/main" id="{AE62C9A8-D667-4B8F-84A4-B7FD2A2BCB0B}"/>
               </a:ext>
             </a:extLst>
           </p:cNvPr>
@@ -2723,7 +2703,7 @@
     </p:spTree>
     <p:extLst>
       <p:ext uri="{BB962C8B-B14F-4D97-AF65-F5344CB8AC3E}">
-        <p14:creationId xmlns:p14="http://schemas.microsoft.com/office/powerpoint/2010/main" val="964084325"/>
+        <p14:creationId xmlns:p14="http://schemas.microsoft.com/office/powerpoint/2010/main" val="912230454"/>
       </p:ext>
     </p:extLst>
   </p:cSld>
@@ -2751,10 +2731,10 @@
       </p:grpSpPr>
       <p:sp>
         <p:nvSpPr>
-          <p:cNvPr id="8" name="">
-            <a:extLst xmlns:a="http://schemas.openxmlformats.org/drawingml/2006/main">
-              <a:ext uri="{FF2B5EF4-FFF2-40B4-BE49-F238E27FC236}">
-                <a16:creationId xmlns:a16="http://schemas.microsoft.com/office/drawing/2014/main" id="{98674A69-06CA-4897-8180-E2ABCDD8FD95}"/>
+          <p:cNvPr id="12" name="">
+            <a:extLst xmlns:a="http://schemas.openxmlformats.org/drawingml/2006/main">
+              <a:ext uri="{FF2B5EF4-FFF2-40B4-BE49-F238E27FC236}">
+                <a16:creationId xmlns:a16="http://schemas.microsoft.com/office/drawing/2014/main" id="{5C8E6EC2-31F3-4035-9346-B501394FB6BB}"/>
               </a:ext>
             </a:extLst>
           </p:cNvPr>
@@ -2811,7 +2791,7 @@
           <p:cNvPr id="2" name="">
             <a:extLst xmlns:a="http://schemas.openxmlformats.org/drawingml/2006/main">
               <a:ext uri="{FF2B5EF4-FFF2-40B4-BE49-F238E27FC236}">
-                <a16:creationId xmlns:a16="http://schemas.microsoft.com/office/drawing/2014/main" id="{19E6E7B2-210F-42D1-B602-F861841702CA}"/>
+                <a16:creationId xmlns:a16="http://schemas.microsoft.com/office/drawing/2014/main" id="{9A4AD195-AD4B-40A6-B989-1D15AEFE0986}"/>
               </a:ext>
             </a:extLst>
           </p:cNvPr>
@@ -2868,7 +2848,7 @@
           <p:cNvPr id="3" name="">
             <a:extLst xmlns:a="http://schemas.openxmlformats.org/drawingml/2006/main">
               <a:ext uri="{FF2B5EF4-FFF2-40B4-BE49-F238E27FC236}">
-                <a16:creationId xmlns:a16="http://schemas.microsoft.com/office/drawing/2014/main" id="{B0718E58-AC94-4535-9839-A90F4A253994}"/>
+                <a16:creationId xmlns:a16="http://schemas.microsoft.com/office/drawing/2014/main" id="{FA2FA11F-14ED-47AE-83FE-90D12918E02E}"/>
               </a:ext>
             </a:extLst>
           </p:cNvPr>
@@ -2925,7 +2905,7 @@
           <p:cNvPr id="4" name="">
             <a:extLst xmlns:a="http://schemas.openxmlformats.org/drawingml/2006/main">
               <a:ext uri="{FF2B5EF4-FFF2-40B4-BE49-F238E27FC236}">
-                <a16:creationId xmlns:a16="http://schemas.microsoft.com/office/drawing/2014/main" id="{457F1B5A-93AE-4956-98C3-5EDBDEC50275}"/>
+                <a16:creationId xmlns:a16="http://schemas.microsoft.com/office/drawing/2014/main" id="{9142C96A-3CE7-49FC-AFDB-F746BBC5725C}"/>
               </a:ext>
             </a:extLst>
           </p:cNvPr>
@@ -2979,17 +2959,17 @@
       </p:sp>
       <p:graphicFrame>
         <p:nvGraphicFramePr>
-          <p:cNvPr id="12" name="Chart"/>
+          <p:cNvPr id="16" name="Chart"/>
           <p:cNvGraphicFramePr/>
           <p:nvPr/>
         </p:nvGraphicFramePr>
         <p:xfrm>
           <a:off xmlns:a="http://schemas.openxmlformats.org/drawingml/2006/main" x="533400" y="1924050"/>
-          <a:ext xmlns:a="http://schemas.openxmlformats.org/drawingml/2006/main" cx="11144250" cy="3114675"/>
+          <a:ext xmlns:a="http://schemas.openxmlformats.org/drawingml/2006/main" cx="11144250" cy="2762250"/>
         </p:xfrm>
         <a:graphic xmlns:a="http://schemas.openxmlformats.org/drawingml/2006/main">
           <a:graphicData uri="http://schemas.openxmlformats.org/drawingml/2006/chart">
-            <c:chart xmlns:r="http://schemas.openxmlformats.org/officeDocument/2006/relationships" xmlns:c="http://schemas.openxmlformats.org/drawingml/2006/chart" r:id="Re36337c169344784"/>
+            <c:chart xmlns:r="http://schemas.openxmlformats.org/officeDocument/2006/relationships" xmlns:c="http://schemas.openxmlformats.org/drawingml/2006/chart" r:id="Rd7f09683c6344652"/>
           </a:graphicData>
         </a:graphic>
       </p:graphicFrame>
@@ -2998,7 +2978,181 @@
           <p:cNvPr id="6" name="">
             <a:extLst xmlns:a="http://schemas.openxmlformats.org/drawingml/2006/main">
               <a:ext uri="{FF2B5EF4-FFF2-40B4-BE49-F238E27FC236}">
-                <a16:creationId xmlns:a16="http://schemas.microsoft.com/office/drawing/2014/main" id="{A2080127-3FAF-45B7-A042-2A14D2F35BF5}"/>
+                <a16:creationId xmlns:a16="http://schemas.microsoft.com/office/drawing/2014/main" id="{9C7BE111-CC24-4F7E-BE86-D30BA340E39B}"/>
+              </a:ext>
+            </a:extLst>
+          </p:cNvPr>
+          <p:cNvSpPr>
+            <a:spLocks xmlns:a="http://schemas.openxmlformats.org/drawingml/2006/main" noGrp="1"/>
+          </p:cNvSpPr>
+          <p:nvPr/>
+        </p:nvSpPr>
+        <p:spPr>
+          <a:xfrm xmlns:a="http://schemas.openxmlformats.org/drawingml/2006/main">
+            <a:off x="3829050" y="4810125"/>
+            <a:ext cx="95250" cy="95250"/>
+          </a:xfrm>
+          <a:prstGeom xmlns:a="http://schemas.openxmlformats.org/drawingml/2006/main" prst="rect">
+            <a:avLst/>
+          </a:prstGeom>
+          <a:solidFill xmlns:a="http://schemas.openxmlformats.org/drawingml/2006/main">
+            <a:srgbClr val="007C78"/>
+          </a:solidFill>
+          <a:ln xmlns:a="http://schemas.openxmlformats.org/drawingml/2006/main" w="0">
+            <a:noFill/>
+          </a:ln>
+        </p:spPr>
+      </p:sp>
+      <p:sp>
+        <p:nvSpPr>
+          <p:cNvPr id="7" name="">
+            <a:extLst xmlns:a="http://schemas.openxmlformats.org/drawingml/2006/main">
+              <a:ext uri="{FF2B5EF4-FFF2-40B4-BE49-F238E27FC236}">
+                <a16:creationId xmlns:a16="http://schemas.microsoft.com/office/drawing/2014/main" id="{E7EA94A8-E4C8-4D2D-B420-2B072FD3C222}"/>
+              </a:ext>
+            </a:extLst>
+          </p:cNvPr>
+          <p:cNvSpPr>
+            <a:spLocks xmlns:a="http://schemas.openxmlformats.org/drawingml/2006/main" noGrp="1"/>
+          </p:cNvSpPr>
+          <p:nvPr/>
+        </p:nvSpPr>
+        <p:spPr>
+          <a:xfrm xmlns:a="http://schemas.openxmlformats.org/drawingml/2006/main">
+            <a:off x="3981450" y="4667250"/>
+            <a:ext cx="2324100" cy="381000"/>
+          </a:xfrm>
+          <a:prstGeom xmlns:a="http://schemas.openxmlformats.org/drawingml/2006/main" prst="rect">
+            <a:avLst/>
+          </a:prstGeom>
+          <a:noFill xmlns:a="http://schemas.openxmlformats.org/drawingml/2006/main"/>
+          <a:ln xmlns:a="http://schemas.openxmlformats.org/drawingml/2006/main" w="0">
+            <a:noFill/>
+          </a:ln>
+        </p:spPr>
+        <p:txBody>
+          <a:bodyPr xmlns:a="http://schemas.openxmlformats.org/drawingml/2006/main" anchor="ctr">
+            <a:noAutofit/>
+          </a:bodyPr>
+          <a:lstStyle xmlns:a="http://schemas.openxmlformats.org/drawingml/2006/main"/>
+          <a:p xmlns:a="http://schemas.openxmlformats.org/drawingml/2006/main">
+            <a:pPr algn="l">
+              <a:defRPr sz="1875" b="0">
+                <a:solidFill>
+                  <a:srgbClr val="16343E"/>
+                </a:solidFill>
+                <a:latin typeface="Arial"/>
+                <a:ea typeface="Arial"/>
+                <a:cs typeface="Arial"/>
+              </a:defRPr>
+            </a:pPr>
+            <a:r>
+              <a:rPr sz="1875" b="0">
+                <a:solidFill>
+                  <a:srgbClr val="16343E"/>
+                </a:solidFill>
+                <a:latin typeface="Arial"/>
+                <a:ea typeface="Arial"/>
+                <a:cs typeface="Arial"/>
+              </a:rPr>
+              <a:t>Incorrect flags / 176</a:t>
+            </a:r>
+          </a:p>
+        </p:txBody>
+      </p:sp>
+      <p:sp>
+        <p:nvSpPr>
+          <p:cNvPr id="8" name="">
+            <a:extLst xmlns:a="http://schemas.openxmlformats.org/drawingml/2006/main">
+              <a:ext uri="{FF2B5EF4-FFF2-40B4-BE49-F238E27FC236}">
+                <a16:creationId xmlns:a16="http://schemas.microsoft.com/office/drawing/2014/main" id="{A2E9DE57-5E6E-4250-9F40-244987335A79}"/>
+              </a:ext>
+            </a:extLst>
+          </p:cNvPr>
+          <p:cNvSpPr>
+            <a:spLocks xmlns:a="http://schemas.openxmlformats.org/drawingml/2006/main" noGrp="1"/>
+          </p:cNvSpPr>
+          <p:nvPr/>
+        </p:nvSpPr>
+        <p:spPr>
+          <a:xfrm xmlns:a="http://schemas.openxmlformats.org/drawingml/2006/main">
+            <a:off x="6248400" y="4810125"/>
+            <a:ext cx="95250" cy="95250"/>
+          </a:xfrm>
+          <a:prstGeom xmlns:a="http://schemas.openxmlformats.org/drawingml/2006/main" prst="rect">
+            <a:avLst/>
+          </a:prstGeom>
+          <a:solidFill xmlns:a="http://schemas.openxmlformats.org/drawingml/2006/main">
+            <a:srgbClr val="B55730"/>
+          </a:solidFill>
+          <a:ln xmlns:a="http://schemas.openxmlformats.org/drawingml/2006/main" w="0">
+            <a:noFill/>
+          </a:ln>
+        </p:spPr>
+      </p:sp>
+      <p:sp>
+        <p:nvSpPr>
+          <p:cNvPr id="9" name="">
+            <a:extLst xmlns:a="http://schemas.openxmlformats.org/drawingml/2006/main">
+              <a:ext uri="{FF2B5EF4-FFF2-40B4-BE49-F238E27FC236}">
+                <a16:creationId xmlns:a16="http://schemas.microsoft.com/office/drawing/2014/main" id="{614EDB17-6B04-42FD-A061-4C267BFC875B}"/>
+              </a:ext>
+            </a:extLst>
+          </p:cNvPr>
+          <p:cNvSpPr>
+            <a:spLocks xmlns:a="http://schemas.openxmlformats.org/drawingml/2006/main" noGrp="1"/>
+          </p:cNvSpPr>
+          <p:nvPr/>
+        </p:nvSpPr>
+        <p:spPr>
+          <a:xfrm xmlns:a="http://schemas.openxmlformats.org/drawingml/2006/main">
+            <a:off x="6400800" y="4667250"/>
+            <a:ext cx="2381250" cy="381000"/>
+          </a:xfrm>
+          <a:prstGeom xmlns:a="http://schemas.openxmlformats.org/drawingml/2006/main" prst="rect">
+            <a:avLst/>
+          </a:prstGeom>
+          <a:noFill xmlns:a="http://schemas.openxmlformats.org/drawingml/2006/main"/>
+          <a:ln xmlns:a="http://schemas.openxmlformats.org/drawingml/2006/main" w="0">
+            <a:noFill/>
+          </a:ln>
+        </p:spPr>
+        <p:txBody>
+          <a:bodyPr xmlns:a="http://schemas.openxmlformats.org/drawingml/2006/main" anchor="ctr">
+            <a:noAutofit/>
+          </a:bodyPr>
+          <a:lstStyle xmlns:a="http://schemas.openxmlformats.org/drawingml/2006/main"/>
+          <a:p xmlns:a="http://schemas.openxmlformats.org/drawingml/2006/main">
+            <a:pPr algn="l">
+              <a:defRPr sz="1875" b="0">
+                <a:solidFill>
+                  <a:srgbClr val="16343E"/>
+                </a:solidFill>
+                <a:latin typeface="Arial"/>
+                <a:ea typeface="Arial"/>
+                <a:cs typeface="Arial"/>
+              </a:defRPr>
+            </a:pPr>
+            <a:r>
+              <a:rPr sz="1875" b="0">
+                <a:solidFill>
+                  <a:srgbClr val="16343E"/>
+                </a:solidFill>
+                <a:latin typeface="Arial"/>
+                <a:ea typeface="Arial"/>
+                <a:cs typeface="Arial"/>
+              </a:rPr>
+              <a:t>Missed cases / 169</a:t>
+            </a:r>
+          </a:p>
+        </p:txBody>
+      </p:sp>
+      <p:sp>
+        <p:nvSpPr>
+          <p:cNvPr id="10" name="">
+            <a:extLst xmlns:a="http://schemas.openxmlformats.org/drawingml/2006/main">
+              <a:ext uri="{FF2B5EF4-FFF2-40B4-BE49-F238E27FC236}">
+                <a16:creationId xmlns:a16="http://schemas.microsoft.com/office/drawing/2014/main" id="{56E8268C-4E47-426E-9D81-568A89D3B4ED}"/>
               </a:ext>
             </a:extLst>
           </p:cNvPr>
@@ -3056,10 +3210,10 @@
       </p:sp>
       <p:sp>
         <p:nvSpPr>
-          <p:cNvPr id="7" name="">
-            <a:extLst xmlns:a="http://schemas.openxmlformats.org/drawingml/2006/main">
-              <a:ext uri="{FF2B5EF4-FFF2-40B4-BE49-F238E27FC236}">
-                <a16:creationId xmlns:a16="http://schemas.microsoft.com/office/drawing/2014/main" id="{6011E46D-F4EA-4E44-890D-7271A44A5B24}"/>
+          <p:cNvPr id="11" name="">
+            <a:extLst xmlns:a="http://schemas.openxmlformats.org/drawingml/2006/main">
+              <a:ext uri="{FF2B5EF4-FFF2-40B4-BE49-F238E27FC236}">
+                <a16:creationId xmlns:a16="http://schemas.microsoft.com/office/drawing/2014/main" id="{496F0C23-7281-4EFF-9040-535900A97197}"/>
               </a:ext>
             </a:extLst>
           </p:cNvPr>
@@ -3114,7 +3268,7 @@
     </p:spTree>
     <p:extLst>
       <p:ext uri="{BB962C8B-B14F-4D97-AF65-F5344CB8AC3E}">
-        <p14:creationId xmlns:p14="http://schemas.microsoft.com/office/powerpoint/2010/main" val="948490270"/>
+        <p14:creationId xmlns:p14="http://schemas.microsoft.com/office/powerpoint/2010/main" val="1750877085"/>
       </p:ext>
     </p:extLst>
   </p:cSld>
@@ -3142,10 +3296,10 @@
       </p:grpSpPr>
       <p:sp>
         <p:nvSpPr>
-          <p:cNvPr id="5" name="">
-            <a:extLst xmlns:a="http://schemas.openxmlformats.org/drawingml/2006/main">
-              <a:ext uri="{FF2B5EF4-FFF2-40B4-BE49-F238E27FC236}">
-                <a16:creationId xmlns:a16="http://schemas.microsoft.com/office/drawing/2014/main" id="{20E9CA22-C8B7-4D1C-9310-165429E549A1}"/>
+          <p:cNvPr id="4" name="">
+            <a:extLst xmlns:a="http://schemas.openxmlformats.org/drawingml/2006/main">
+              <a:ext uri="{FF2B5EF4-FFF2-40B4-BE49-F238E27FC236}">
+                <a16:creationId xmlns:a16="http://schemas.microsoft.com/office/drawing/2014/main" id="{C69A5426-B04F-4300-B53F-51226A6AEABE}"/>
               </a:ext>
             </a:extLst>
           </p:cNvPr>
@@ -3192,7 +3346,7 @@
                 <a:ea typeface="Arial"/>
                 <a:cs typeface="Arial"/>
               </a:rPr>
-              <a:t>Software engineering</a:t>
+              <a:t>Software Engineering Demo</a:t>
             </a:r>
           </a:p>
         </p:txBody>
@@ -3202,7 +3356,7 @@
           <p:cNvPr id="2" name="">
             <a:extLst xmlns:a="http://schemas.openxmlformats.org/drawingml/2006/main">
               <a:ext uri="{FF2B5EF4-FFF2-40B4-BE49-F238E27FC236}">
-                <a16:creationId xmlns:a16="http://schemas.microsoft.com/office/drawing/2014/main" id="{8BF2BD10-1A38-4374-8B1E-7E2B5B339F62}"/>
+                <a16:creationId xmlns:a16="http://schemas.microsoft.com/office/drawing/2014/main" id="{DEA39A17-67EB-486C-9C9C-F4920F3DBF18}"/>
               </a:ext>
             </a:extLst>
           </p:cNvPr>
@@ -3259,7 +3413,7 @@
           <p:cNvPr id="3" name="">
             <a:extLst xmlns:a="http://schemas.openxmlformats.org/drawingml/2006/main">
               <a:ext uri="{FF2B5EF4-FFF2-40B4-BE49-F238E27FC236}">
-                <a16:creationId xmlns:a16="http://schemas.microsoft.com/office/drawing/2014/main" id="{2481557B-C43C-4C62-AD65-B18490676247}"/>
+                <a16:creationId xmlns:a16="http://schemas.microsoft.com/office/drawing/2014/main" id="{153F1898-AD1B-4D73-AB61-245DF1B24B4F}"/>
               </a:ext>
             </a:extLst>
           </p:cNvPr>
@@ -3311,125 +3465,10 @@
           </a:p>
         </p:txBody>
       </p:sp>
-      <p:sp>
-        <p:nvSpPr>
-          <p:cNvPr id="4" name="">
-            <a:extLst xmlns:a="http://schemas.openxmlformats.org/drawingml/2006/main">
-              <a:ext uri="{FF2B5EF4-FFF2-40B4-BE49-F238E27FC236}">
-                <a16:creationId xmlns:a16="http://schemas.microsoft.com/office/drawing/2014/main" id="{6268E36E-F3BA-40C9-B663-377CF51AF555}"/>
-              </a:ext>
-            </a:extLst>
-          </p:cNvPr>
-          <p:cNvSpPr>
-            <a:spLocks xmlns:a="http://schemas.openxmlformats.org/drawingml/2006/main" noGrp="1"/>
-          </p:cNvSpPr>
-          <p:nvPr/>
-        </p:nvSpPr>
-        <p:spPr>
-          <a:xfrm xmlns:a="http://schemas.openxmlformats.org/drawingml/2006/main">
-            <a:off x="609600" y="2943225"/>
-            <a:ext cx="10972800" cy="2200275"/>
-          </a:xfrm>
-          <a:prstGeom xmlns:a="http://schemas.openxmlformats.org/drawingml/2006/main" prst="rect">
-            <a:avLst/>
-          </a:prstGeom>
-          <a:noFill xmlns:a="http://schemas.openxmlformats.org/drawingml/2006/main"/>
-          <a:ln xmlns:a="http://schemas.openxmlformats.org/drawingml/2006/main" w="0">
-            <a:noFill/>
-          </a:ln>
-        </p:spPr>
-        <p:txBody>
-          <a:bodyPr xmlns:a="http://schemas.openxmlformats.org/drawingml/2006/main" anchor="t">
-            <a:noAutofit/>
-          </a:bodyPr>
-          <a:lstStyle xmlns:a="http://schemas.openxmlformats.org/drawingml/2006/main"/>
-          <a:p xmlns:a="http://schemas.openxmlformats.org/drawingml/2006/main">
-            <a:pPr marL="279400" indent="-152400" algn="l">
-              <a:spcAft>
-                <a:spcPts val="2800"/>
-              </a:spcAft>
-              <a:buChar char="•"/>
-              <a:defRPr sz="2850" b="0">
-                <a:solidFill>
-                  <a:srgbClr val="16343E"/>
-                </a:solidFill>
-                <a:latin typeface="Arial"/>
-                <a:ea typeface="Arial"/>
-                <a:cs typeface="Arial"/>
-              </a:defRPr>
-            </a:pPr>
-            <a:r>
-              <a:rPr sz="2850" b="0">
-                <a:solidFill>
-                  <a:srgbClr val="16343E"/>
-                </a:solidFill>
-                <a:latin typeface="Arial"/>
-                <a:ea typeface="Arial"/>
-                <a:cs typeface="Arial"/>
-              </a:rPr>
-              <a:t>Inspect the evidence</a:t>
-            </a:r>
-          </a:p>
-          <a:p xmlns:a="http://schemas.openxmlformats.org/drawingml/2006/main">
-            <a:pPr marL="279400" indent="-152400" algn="l">
-              <a:spcAft>
-                <a:spcPts val="2800"/>
-              </a:spcAft>
-              <a:buChar char="•"/>
-              <a:defRPr sz="2850" b="0">
-                <a:solidFill>
-                  <a:srgbClr val="16343E"/>
-                </a:solidFill>
-                <a:latin typeface="Arial"/>
-                <a:ea typeface="Arial"/>
-                <a:cs typeface="Arial"/>
-              </a:defRPr>
-            </a:pPr>
-            <a:r>
-              <a:rPr sz="2850" b="0">
-                <a:solidFill>
-                  <a:srgbClr val="16343E"/>
-                </a:solidFill>
-                <a:latin typeface="Arial"/>
-                <a:ea typeface="Arial"/>
-                <a:cs typeface="Arial"/>
-              </a:rPr>
-              <a:t>Score a public specimen</a:t>
-            </a:r>
-          </a:p>
-          <a:p xmlns:a="http://schemas.openxmlformats.org/drawingml/2006/main">
-            <a:pPr marL="279400" indent="-152400" algn="l">
-              <a:spcAft>
-                <a:spcPts val="2800"/>
-              </a:spcAft>
-              <a:buChar char="•"/>
-              <a:defRPr sz="2850" b="0">
-                <a:solidFill>
-                  <a:srgbClr val="16343E"/>
-                </a:solidFill>
-                <a:latin typeface="Arial"/>
-                <a:ea typeface="Arial"/>
-                <a:cs typeface="Arial"/>
-              </a:defRPr>
-            </a:pPr>
-            <a:r>
-              <a:rPr sz="2850" b="0">
-                <a:solidFill>
-                  <a:srgbClr val="16343E"/>
-                </a:solidFill>
-                <a:latin typeface="Arial"/>
-                <a:ea typeface="Arial"/>
-                <a:cs typeface="Arial"/>
-              </a:rPr>
-              <a:t>Trace and check the calculation</a:t>
-            </a:r>
-          </a:p>
-        </p:txBody>
-      </p:sp>
     </p:spTree>
     <p:extLst>
       <p:ext uri="{BB962C8B-B14F-4D97-AF65-F5344CB8AC3E}">
-        <p14:creationId xmlns:p14="http://schemas.microsoft.com/office/powerpoint/2010/main" val="2100830968"/>
+        <p14:creationId xmlns:p14="http://schemas.microsoft.com/office/powerpoint/2010/main" val="1091844925"/>
       </p:ext>
     </p:extLst>
   </p:cSld>
@@ -3457,10 +3496,10 @@
       </p:grpSpPr>
       <p:sp>
         <p:nvSpPr>
-          <p:cNvPr id="10" name="">
-            <a:extLst xmlns:a="http://schemas.openxmlformats.org/drawingml/2006/main">
-              <a:ext uri="{FF2B5EF4-FFF2-40B4-BE49-F238E27FC236}">
-                <a16:creationId xmlns:a16="http://schemas.microsoft.com/office/drawing/2014/main" id="{74F2D1C2-2FFB-4A56-9F28-510255EFE9A6}"/>
+          <p:cNvPr id="9" name="">
+            <a:extLst xmlns:a="http://schemas.openxmlformats.org/drawingml/2006/main">
+              <a:ext uri="{FF2B5EF4-FFF2-40B4-BE49-F238E27FC236}">
+                <a16:creationId xmlns:a16="http://schemas.microsoft.com/office/drawing/2014/main" id="{A980FE43-807B-4742-BCCE-854C510A4549}"/>
               </a:ext>
             </a:extLst>
           </p:cNvPr>
@@ -3517,7 +3556,7 @@
           <p:cNvPr id="2" name="">
             <a:extLst xmlns:a="http://schemas.openxmlformats.org/drawingml/2006/main">
               <a:ext uri="{FF2B5EF4-FFF2-40B4-BE49-F238E27FC236}">
-                <a16:creationId xmlns:a16="http://schemas.microsoft.com/office/drawing/2014/main" id="{C7747D3A-B9C6-4D28-8827-042B0BCAB0CF}"/>
+                <a16:creationId xmlns:a16="http://schemas.microsoft.com/office/drawing/2014/main" id="{9E92B173-B533-4038-B622-B2FB2BC5F3AB}"/>
               </a:ext>
             </a:extLst>
           </p:cNvPr>
@@ -3574,7 +3613,7 @@
           <p:cNvPr id="3" name="">
             <a:extLst xmlns:a="http://schemas.openxmlformats.org/drawingml/2006/main">
               <a:ext uri="{FF2B5EF4-FFF2-40B4-BE49-F238E27FC236}">
-                <a16:creationId xmlns:a16="http://schemas.microsoft.com/office/drawing/2014/main" id="{FD809459-563E-46FD-82B6-AF6549F7485A}"/>
+                <a16:creationId xmlns:a16="http://schemas.microsoft.com/office/drawing/2014/main" id="{67BAAEF5-C09C-4C45-BAEE-29E60923F65F}"/>
               </a:ext>
             </a:extLst>
           </p:cNvPr>
@@ -3631,7 +3670,7 @@
           <p:cNvPr id="4" name="">
             <a:extLst xmlns:a="http://schemas.openxmlformats.org/drawingml/2006/main">
               <a:ext uri="{FF2B5EF4-FFF2-40B4-BE49-F238E27FC236}">
-                <a16:creationId xmlns:a16="http://schemas.microsoft.com/office/drawing/2014/main" id="{5675126E-5CAC-4F8E-BC96-F8E4A86107AB}"/>
+                <a16:creationId xmlns:a16="http://schemas.microsoft.com/office/drawing/2014/main" id="{E1710BEF-9EEC-45EA-9B8E-D44AAA0A9B95}"/>
               </a:ext>
             </a:extLst>
           </p:cNvPr>
@@ -3688,7 +3727,7 @@
           <p:cNvPr id="5" name="">
             <a:extLst xmlns:a="http://schemas.openxmlformats.org/drawingml/2006/main">
               <a:ext uri="{FF2B5EF4-FFF2-40B4-BE49-F238E27FC236}">
-                <a16:creationId xmlns:a16="http://schemas.microsoft.com/office/drawing/2014/main" id="{5C0F2C50-330D-45A1-8B71-7F987C1B7341}"/>
+                <a16:creationId xmlns:a16="http://schemas.microsoft.com/office/drawing/2014/main" id="{7F059A08-0788-4AB3-B4F1-851B990DC589}"/>
               </a:ext>
             </a:extLst>
           </p:cNvPr>
@@ -3768,7 +3807,7 @@
           <p:cNvPr id="6" name="">
             <a:extLst xmlns:a="http://schemas.openxmlformats.org/drawingml/2006/main">
               <a:ext uri="{FF2B5EF4-FFF2-40B4-BE49-F238E27FC236}">
-                <a16:creationId xmlns:a16="http://schemas.microsoft.com/office/drawing/2014/main" id="{8F8FE265-7F9F-4FF1-AA98-42BDAAF586B2}"/>
+                <a16:creationId xmlns:a16="http://schemas.microsoft.com/office/drawing/2014/main" id="{79BE1B5A-2FA5-4AC3-A9D2-C8197DC60080}"/>
               </a:ext>
             </a:extLst>
           </p:cNvPr>
@@ -3797,7 +3836,7 @@
           <p:cNvPr id="7" name="">
             <a:extLst xmlns:a="http://schemas.openxmlformats.org/drawingml/2006/main">
               <a:ext uri="{FF2B5EF4-FFF2-40B4-BE49-F238E27FC236}">
-                <a16:creationId xmlns:a16="http://schemas.microsoft.com/office/drawing/2014/main" id="{51D44CC5-7581-4ECD-97EE-2D89FB47EC8E}"/>
+                <a16:creationId xmlns:a16="http://schemas.microsoft.com/office/drawing/2014/main" id="{94D1DC89-53B2-4B91-B60F-B29F4EC478D9}"/>
               </a:ext>
             </a:extLst>
           </p:cNvPr>
@@ -3854,7 +3893,7 @@
           <p:cNvPr id="8" name="">
             <a:extLst xmlns:a="http://schemas.openxmlformats.org/drawingml/2006/main">
               <a:ext uri="{FF2B5EF4-FFF2-40B4-BE49-F238E27FC236}">
-                <a16:creationId xmlns:a16="http://schemas.microsoft.com/office/drawing/2014/main" id="{893C5769-C5C7-4137-B0F7-48A20CF575F1}"/>
+                <a16:creationId xmlns:a16="http://schemas.microsoft.com/office/drawing/2014/main" id="{2FDF0F0D-D727-49D4-81CA-1EE12BA07B54}"/>
               </a:ext>
             </a:extLst>
           </p:cNvPr>
@@ -3929,90 +3968,10 @@
           </a:p>
         </p:txBody>
       </p:sp>
-      <p:sp>
-        <p:nvSpPr>
-          <p:cNvPr id="9" name="">
-            <a:extLst xmlns:a="http://schemas.openxmlformats.org/drawingml/2006/main">
-              <a:ext uri="{FF2B5EF4-FFF2-40B4-BE49-F238E27FC236}">
-                <a16:creationId xmlns:a16="http://schemas.microsoft.com/office/drawing/2014/main" id="{406F0F6F-77E5-4E9F-81BD-8B56BAD1D329}"/>
-              </a:ext>
-            </a:extLst>
-          </p:cNvPr>
-          <p:cNvSpPr>
-            <a:spLocks xmlns:a="http://schemas.openxmlformats.org/drawingml/2006/main" noGrp="1"/>
-          </p:cNvSpPr>
-          <p:nvPr/>
-        </p:nvSpPr>
-        <p:spPr>
-          <a:xfrm xmlns:a="http://schemas.openxmlformats.org/drawingml/2006/main">
-            <a:off x="609600" y="5572125"/>
-            <a:ext cx="10972800" cy="619125"/>
-          </a:xfrm>
-          <a:prstGeom xmlns:a="http://schemas.openxmlformats.org/drawingml/2006/main" prst="rect">
-            <a:avLst/>
-          </a:prstGeom>
-          <a:noFill xmlns:a="http://schemas.openxmlformats.org/drawingml/2006/main"/>
-          <a:ln xmlns:a="http://schemas.openxmlformats.org/drawingml/2006/main" w="0">
-            <a:noFill/>
-          </a:ln>
-        </p:spPr>
-        <p:txBody>
-          <a:bodyPr xmlns:a="http://schemas.openxmlformats.org/drawingml/2006/main" anchor="ctr">
-            <a:noAutofit/>
-          </a:bodyPr>
-          <a:lstStyle xmlns:a="http://schemas.openxmlformats.org/drawingml/2006/main"/>
-          <a:p xmlns:a="http://schemas.openxmlformats.org/drawingml/2006/main">
-            <a:pPr algn="l">
-              <a:defRPr sz="1950" b="0">
-                <a:solidFill>
-                  <a:srgbClr val="FFFFFF"/>
-                </a:solidFill>
-                <a:latin typeface="Arial"/>
-                <a:ea typeface="Arial"/>
-                <a:cs typeface="Arial"/>
-              </a:defRPr>
-            </a:pPr>
-            <a:r>
-              <a:rPr sz="1950" b="0">
-                <a:solidFill>
-                  <a:srgbClr val="FFFFFF"/>
-                </a:solidFill>
-                <a:latin typeface="Arial"/>
-                <a:ea typeface="Arial"/>
-                <a:cs typeface="Arial"/>
-              </a:rPr>
-              <a:t>Next: cross-validation within discovery.</a:t>
-            </a:r>
-          </a:p>
-          <a:p xmlns:a="http://schemas.openxmlformats.org/drawingml/2006/main">
-            <a:pPr algn="l">
-              <a:defRPr sz="1950" b="0">
-                <a:solidFill>
-                  <a:srgbClr val="FFFFFF"/>
-                </a:solidFill>
-                <a:latin typeface="Arial"/>
-                <a:ea typeface="Arial"/>
-                <a:cs typeface="Arial"/>
-              </a:defRPr>
-            </a:pPr>
-            <a:r>
-              <a:rPr sz="1950" b="0">
-                <a:solidFill>
-                  <a:srgbClr val="FFFFFF"/>
-                </a:solidFill>
-                <a:latin typeface="Arial"/>
-                <a:ea typeface="Arial"/>
-                <a:cs typeface="Arial"/>
-              </a:rPr>
-              <a:t>Then investigate whether the score adds useful diagnostic information.</a:t>
-            </a:r>
-          </a:p>
-        </p:txBody>
-      </p:sp>
     </p:spTree>
     <p:extLst>
       <p:ext uri="{BB962C8B-B14F-4D97-AF65-F5344CB8AC3E}">
-        <p14:creationId xmlns:p14="http://schemas.microsoft.com/office/powerpoint/2010/main" val="654479045"/>
+        <p14:creationId xmlns:p14="http://schemas.microsoft.com/office/powerpoint/2010/main" val="1607663596"/>
       </p:ext>
     </p:extLst>
   </p:cSld>
@@ -4043,7 +4002,7 @@
           <p:cNvPr id="8" name="">
             <a:extLst xmlns:a="http://schemas.openxmlformats.org/drawingml/2006/main">
               <a:ext uri="{FF2B5EF4-FFF2-40B4-BE49-F238E27FC236}">
-                <a16:creationId xmlns:a16="http://schemas.microsoft.com/office/drawing/2014/main" id="{27930E4E-2091-44E3-9EF4-8DC9CC020A9D}"/>
+                <a16:creationId xmlns:a16="http://schemas.microsoft.com/office/drawing/2014/main" id="{CA76857C-FCFC-4198-8D20-06F13949F4EB}"/>
               </a:ext>
             </a:extLst>
           </p:cNvPr>
@@ -4100,7 +4059,7 @@
           <p:cNvPr id="2" name="">
             <a:extLst xmlns:a="http://schemas.openxmlformats.org/drawingml/2006/main">
               <a:ext uri="{FF2B5EF4-FFF2-40B4-BE49-F238E27FC236}">
-                <a16:creationId xmlns:a16="http://schemas.microsoft.com/office/drawing/2014/main" id="{DF694DCC-E773-4582-91F2-81495E3C6ACC}"/>
+                <a16:creationId xmlns:a16="http://schemas.microsoft.com/office/drawing/2014/main" id="{84D2937C-5BAB-4401-B4C2-9A5FCDA822A4}"/>
               </a:ext>
             </a:extLst>
           </p:cNvPr>
@@ -4157,7 +4116,7 @@
           <p:cNvPr id="3" name="">
             <a:extLst xmlns:a="http://schemas.openxmlformats.org/drawingml/2006/main">
               <a:ext uri="{FF2B5EF4-FFF2-40B4-BE49-F238E27FC236}">
-                <a16:creationId xmlns:a16="http://schemas.microsoft.com/office/drawing/2014/main" id="{156986E7-4656-4C62-867E-CA74CA558D31}"/>
+                <a16:creationId xmlns:a16="http://schemas.microsoft.com/office/drawing/2014/main" id="{6F17A776-DE48-4B28-B9C3-B74FB9078909}"/>
               </a:ext>
             </a:extLst>
           </p:cNvPr>
@@ -4214,7 +4173,7 @@
           <p:cNvPr id="4" name="">
             <a:extLst xmlns:a="http://schemas.openxmlformats.org/drawingml/2006/main">
               <a:ext uri="{FF2B5EF4-FFF2-40B4-BE49-F238E27FC236}">
-                <a16:creationId xmlns:a16="http://schemas.microsoft.com/office/drawing/2014/main" id="{6E338257-570F-4126-9AD8-7F7D0711BF83}"/>
+                <a16:creationId xmlns:a16="http://schemas.microsoft.com/office/drawing/2014/main" id="{8D2B2CCD-BA95-4351-8FF4-7176765E72BE}"/>
               </a:ext>
             </a:extLst>
           </p:cNvPr>
@@ -4271,7 +4230,7 @@
           <p:cNvPr id="5" name="">
             <a:extLst xmlns:a="http://schemas.openxmlformats.org/drawingml/2006/main">
               <a:ext uri="{FF2B5EF4-FFF2-40B4-BE49-F238E27FC236}">
-                <a16:creationId xmlns:a16="http://schemas.microsoft.com/office/drawing/2014/main" id="{F4D1325E-2BCE-4A98-83C3-76BDE9A19ED4}"/>
+                <a16:creationId xmlns:a16="http://schemas.microsoft.com/office/drawing/2014/main" id="{EF4D9A95-A095-40E5-8059-9DB63F7F7E0C}"/>
               </a:ext>
             </a:extLst>
           </p:cNvPr>
@@ -4328,7 +4287,7 @@
           <p:cNvPr id="6" name="">
             <a:extLst xmlns:a="http://schemas.openxmlformats.org/drawingml/2006/main">
               <a:ext uri="{FF2B5EF4-FFF2-40B4-BE49-F238E27FC236}">
-                <a16:creationId xmlns:a16="http://schemas.microsoft.com/office/drawing/2014/main" id="{8A23FF54-7C51-4397-A52D-AA52987614BB}"/>
+                <a16:creationId xmlns:a16="http://schemas.microsoft.com/office/drawing/2014/main" id="{4EC37699-C424-45B8-9F89-6E33858EBB42}"/>
               </a:ext>
             </a:extLst>
           </p:cNvPr>
@@ -4385,7 +4344,7 @@
           <p:cNvPr id="7" name="">
             <a:extLst xmlns:a="http://schemas.openxmlformats.org/drawingml/2006/main">
               <a:ext uri="{FF2B5EF4-FFF2-40B4-BE49-F238E27FC236}">
-                <a16:creationId xmlns:a16="http://schemas.microsoft.com/office/drawing/2014/main" id="{E117BB0A-9A66-40A4-8026-18EE06DC4EA0}"/>
+                <a16:creationId xmlns:a16="http://schemas.microsoft.com/office/drawing/2014/main" id="{B046639D-A9B4-4BEF-AB28-65B490A5E5F9}"/>
               </a:ext>
             </a:extLst>
           </p:cNvPr>
@@ -4440,7 +4399,7 @@
     </p:spTree>
     <p:extLst>
       <p:ext uri="{BB962C8B-B14F-4D97-AF65-F5344CB8AC3E}">
-        <p14:creationId xmlns:p14="http://schemas.microsoft.com/office/powerpoint/2010/main" val="794775973"/>
+        <p14:creationId xmlns:p14="http://schemas.microsoft.com/office/powerpoint/2010/main" val="1513283384"/>
       </p:ext>
     </p:extLst>
   </p:cSld>
@@ -4471,7 +4430,7 @@
           <p:cNvPr id="9" name="">
             <a:extLst xmlns:a="http://schemas.openxmlformats.org/drawingml/2006/main">
               <a:ext uri="{FF2B5EF4-FFF2-40B4-BE49-F238E27FC236}">
-                <a16:creationId xmlns:a16="http://schemas.microsoft.com/office/drawing/2014/main" id="{A30E12C4-0B63-4971-A369-B32354E20995}"/>
+                <a16:creationId xmlns:a16="http://schemas.microsoft.com/office/drawing/2014/main" id="{E9E3CE2B-AA48-4CE5-A97D-932CC25947C1}"/>
               </a:ext>
             </a:extLst>
           </p:cNvPr>
@@ -4528,7 +4487,7 @@
           <p:cNvPr id="2" name="">
             <a:extLst xmlns:a="http://schemas.openxmlformats.org/drawingml/2006/main">
               <a:ext uri="{FF2B5EF4-FFF2-40B4-BE49-F238E27FC236}">
-                <a16:creationId xmlns:a16="http://schemas.microsoft.com/office/drawing/2014/main" id="{45F89D6D-F1C0-4CB1-8BBB-A4B55CD8C03B}"/>
+                <a16:creationId xmlns:a16="http://schemas.microsoft.com/office/drawing/2014/main" id="{3947172C-13AA-474E-88FD-389859DF21F7}"/>
               </a:ext>
             </a:extLst>
           </p:cNvPr>
@@ -4585,7 +4544,7 @@
           <p:cNvPr id="3" name="">
             <a:extLst xmlns:a="http://schemas.openxmlformats.org/drawingml/2006/main">
               <a:ext uri="{FF2B5EF4-FFF2-40B4-BE49-F238E27FC236}">
-                <a16:creationId xmlns:a16="http://schemas.microsoft.com/office/drawing/2014/main" id="{56200CA0-C12D-4421-8696-DE2F68E059A8}"/>
+                <a16:creationId xmlns:a16="http://schemas.microsoft.com/office/drawing/2014/main" id="{F1B3ABC6-AF79-4801-AB10-0BAD1B3F33FB}"/>
               </a:ext>
             </a:extLst>
           </p:cNvPr>
@@ -4642,7 +4601,7 @@
           <p:cNvPr id="4" name="">
             <a:extLst xmlns:a="http://schemas.openxmlformats.org/drawingml/2006/main">
               <a:ext uri="{FF2B5EF4-FFF2-40B4-BE49-F238E27FC236}">
-                <a16:creationId xmlns:a16="http://schemas.microsoft.com/office/drawing/2014/main" id="{AFAB733E-4575-4F90-9A74-0D82A1BD2C43}"/>
+                <a16:creationId xmlns:a16="http://schemas.microsoft.com/office/drawing/2014/main" id="{3D522432-CF2F-400C-ABA1-8558D96CD48A}"/>
               </a:ext>
             </a:extLst>
           </p:cNvPr>
@@ -4699,7 +4658,7 @@
           <p:cNvPr id="5" name="">
             <a:extLst xmlns:a="http://schemas.openxmlformats.org/drawingml/2006/main">
               <a:ext uri="{FF2B5EF4-FFF2-40B4-BE49-F238E27FC236}">
-                <a16:creationId xmlns:a16="http://schemas.microsoft.com/office/drawing/2014/main" id="{EDE55258-FBBB-4669-AAC5-5E0FC5488BF0}"/>
+                <a16:creationId xmlns:a16="http://schemas.microsoft.com/office/drawing/2014/main" id="{EDAB55F9-F91E-4EF5-93C3-2111FC801E13}"/>
               </a:ext>
             </a:extLst>
           </p:cNvPr>
@@ -4756,7 +4715,7 @@
           <p:cNvPr id="6" name="">
             <a:extLst xmlns:a="http://schemas.openxmlformats.org/drawingml/2006/main">
               <a:ext uri="{FF2B5EF4-FFF2-40B4-BE49-F238E27FC236}">
-                <a16:creationId xmlns:a16="http://schemas.microsoft.com/office/drawing/2014/main" id="{0FD4F0F7-8DBE-4665-974D-BE48EE485C12}"/>
+                <a16:creationId xmlns:a16="http://schemas.microsoft.com/office/drawing/2014/main" id="{9B2B7D56-19AA-4FF2-B342-D5BBB62D0E81}"/>
               </a:ext>
             </a:extLst>
           </p:cNvPr>
@@ -4813,7 +4772,7 @@
           <p:cNvPr id="7" name="">
             <a:extLst xmlns:a="http://schemas.openxmlformats.org/drawingml/2006/main">
               <a:ext uri="{FF2B5EF4-FFF2-40B4-BE49-F238E27FC236}">
-                <a16:creationId xmlns:a16="http://schemas.microsoft.com/office/drawing/2014/main" id="{1F406C38-78F6-461D-8193-2E2DBB230A2B}"/>
+                <a16:creationId xmlns:a16="http://schemas.microsoft.com/office/drawing/2014/main" id="{24F88333-DAA8-40E4-A282-F970B5994CAD}"/>
               </a:ext>
             </a:extLst>
           </p:cNvPr>
@@ -4870,7 +4829,7 @@
           <p:cNvPr id="8" name="">
             <a:extLst xmlns:a="http://schemas.openxmlformats.org/drawingml/2006/main">
               <a:ext uri="{FF2B5EF4-FFF2-40B4-BE49-F238E27FC236}">
-                <a16:creationId xmlns:a16="http://schemas.microsoft.com/office/drawing/2014/main" id="{A7FCD3FA-819B-4BE7-A050-F7C44F2A8B16}"/>
+                <a16:creationId xmlns:a16="http://schemas.microsoft.com/office/drawing/2014/main" id="{ECFE1E6E-53EF-468B-B466-3F252072A6CA}"/>
               </a:ext>
             </a:extLst>
           </p:cNvPr>
@@ -4925,7 +4884,7 @@
     </p:spTree>
     <p:extLst>
       <p:ext uri="{BB962C8B-B14F-4D97-AF65-F5344CB8AC3E}">
-        <p14:creationId xmlns:p14="http://schemas.microsoft.com/office/powerpoint/2010/main" val="1416086153"/>
+        <p14:creationId xmlns:p14="http://schemas.microsoft.com/office/powerpoint/2010/main" val="1441763343"/>
       </p:ext>
     </p:extLst>
   </p:cSld>
@@ -4956,7 +4915,7 @@
           <p:cNvPr id="12" name="">
             <a:extLst xmlns:a="http://schemas.openxmlformats.org/drawingml/2006/main">
               <a:ext uri="{FF2B5EF4-FFF2-40B4-BE49-F238E27FC236}">
-                <a16:creationId xmlns:a16="http://schemas.microsoft.com/office/drawing/2014/main" id="{23EDC805-410E-4128-95F4-39638F4CBD7C}"/>
+                <a16:creationId xmlns:a16="http://schemas.microsoft.com/office/drawing/2014/main" id="{4CB293F1-2271-4BDB-B17C-D5B82D5F0194}"/>
               </a:ext>
             </a:extLst>
           </p:cNvPr>
@@ -5013,7 +4972,7 @@
           <p:cNvPr id="2" name="">
             <a:extLst xmlns:a="http://schemas.openxmlformats.org/drawingml/2006/main">
               <a:ext uri="{FF2B5EF4-FFF2-40B4-BE49-F238E27FC236}">
-                <a16:creationId xmlns:a16="http://schemas.microsoft.com/office/drawing/2014/main" id="{43E5B513-0EE0-49DA-89A8-B2A9780CC8F1}"/>
+                <a16:creationId xmlns:a16="http://schemas.microsoft.com/office/drawing/2014/main" id="{A7DA66FC-8CD8-4FEF-B025-051E14A20247}"/>
               </a:ext>
             </a:extLst>
           </p:cNvPr>
@@ -5060,7 +5019,7 @@
                 <a:ea typeface="Arial"/>
                 <a:cs typeface="Arial"/>
               </a:rPr>
-              <a:t>Sources: Banff Reference Guide (2026); Zhang et al. (2024); KDIGO (2009); BK consensus (2024)</a:t>
+              <a:t>Sources: Banff Reference Guide (2026); Zhang et al. (2024); KDIGO (2009), recommendation 6.1</a:t>
             </a:r>
           </a:p>
         </p:txBody>
@@ -5070,7 +5029,7 @@
           <p:cNvPr id="3" name="">
             <a:extLst xmlns:a="http://schemas.openxmlformats.org/drawingml/2006/main">
               <a:ext uri="{FF2B5EF4-FFF2-40B4-BE49-F238E27FC236}">
-                <a16:creationId xmlns:a16="http://schemas.microsoft.com/office/drawing/2014/main" id="{7B6AC371-0525-485D-8140-7D508E686CE6}"/>
+                <a16:creationId xmlns:a16="http://schemas.microsoft.com/office/drawing/2014/main" id="{9E9C4292-573F-4785-986F-09F2D5E84463}"/>
               </a:ext>
             </a:extLst>
           </p:cNvPr>
@@ -5127,7 +5086,7 @@
           <p:cNvPr id="4" name="">
             <a:extLst xmlns:a="http://schemas.openxmlformats.org/drawingml/2006/main">
               <a:ext uri="{FF2B5EF4-FFF2-40B4-BE49-F238E27FC236}">
-                <a16:creationId xmlns:a16="http://schemas.microsoft.com/office/drawing/2014/main" id="{1D4C0E9A-ACEF-4B7A-A3B7-63E2B1D66BFB}"/>
+                <a16:creationId xmlns:a16="http://schemas.microsoft.com/office/drawing/2014/main" id="{697C47FD-2169-44C9-A15E-16A426E76F8C}"/>
               </a:ext>
             </a:extLst>
           </p:cNvPr>
@@ -5207,7 +5166,7 @@
           <p:cNvPr id="5" name="">
             <a:extLst xmlns:a="http://schemas.openxmlformats.org/drawingml/2006/main">
               <a:ext uri="{FF2B5EF4-FFF2-40B4-BE49-F238E27FC236}">
-                <a16:creationId xmlns:a16="http://schemas.microsoft.com/office/drawing/2014/main" id="{C6B172A2-B223-45A8-A653-A336B0E8D32C}"/>
+                <a16:creationId xmlns:a16="http://schemas.microsoft.com/office/drawing/2014/main" id="{E349854A-4A33-4A90-AEAA-B900834D5637}"/>
               </a:ext>
             </a:extLst>
           </p:cNvPr>
@@ -5287,7 +5246,7 @@
           <p:cNvPr id="6" name="">
             <a:extLst xmlns:a="http://schemas.openxmlformats.org/drawingml/2006/main">
               <a:ext uri="{FF2B5EF4-FFF2-40B4-BE49-F238E27FC236}">
-                <a16:creationId xmlns:a16="http://schemas.microsoft.com/office/drawing/2014/main" id="{BAA786D6-4586-42C9-A760-50D0BB99C8D3}"/>
+                <a16:creationId xmlns:a16="http://schemas.microsoft.com/office/drawing/2014/main" id="{D926CC53-1725-4049-AC2F-896332E3F44B}"/>
               </a:ext>
             </a:extLst>
           </p:cNvPr>
@@ -5316,7 +5275,7 @@
           <p:cNvPr id="7" name="">
             <a:extLst xmlns:a="http://schemas.openxmlformats.org/drawingml/2006/main">
               <a:ext uri="{FF2B5EF4-FFF2-40B4-BE49-F238E27FC236}">
-                <a16:creationId xmlns:a16="http://schemas.microsoft.com/office/drawing/2014/main" id="{62260371-60F6-4F3D-98C1-3355DB734693}"/>
+                <a16:creationId xmlns:a16="http://schemas.microsoft.com/office/drawing/2014/main" id="{F8451A83-6FF2-4FF3-A21F-87738FF6704E}"/>
               </a:ext>
             </a:extLst>
           </p:cNvPr>
@@ -5396,7 +5355,7 @@
           <p:cNvPr id="8" name="">
             <a:extLst xmlns:a="http://schemas.openxmlformats.org/drawingml/2006/main">
               <a:ext uri="{FF2B5EF4-FFF2-40B4-BE49-F238E27FC236}">
-                <a16:creationId xmlns:a16="http://schemas.microsoft.com/office/drawing/2014/main" id="{CD414656-1AB4-4C79-8CFB-0D9F095ABEA0}"/>
+                <a16:creationId xmlns:a16="http://schemas.microsoft.com/office/drawing/2014/main" id="{27AE159F-C68B-440B-962A-8A4D2A6A01CA}"/>
               </a:ext>
             </a:extLst>
           </p:cNvPr>
@@ -5476,7 +5435,7 @@
           <p:cNvPr id="9" name="">
             <a:extLst xmlns:a="http://schemas.openxmlformats.org/drawingml/2006/main">
               <a:ext uri="{FF2B5EF4-FFF2-40B4-BE49-F238E27FC236}">
-                <a16:creationId xmlns:a16="http://schemas.microsoft.com/office/drawing/2014/main" id="{E0CAB12F-C1DE-4987-B5B9-C736B783AA5C}"/>
+                <a16:creationId xmlns:a16="http://schemas.microsoft.com/office/drawing/2014/main" id="{73A01B1C-517C-42B7-BCA9-7E0F7C4A35FE}"/>
               </a:ext>
             </a:extLst>
           </p:cNvPr>
@@ -5505,7 +5464,7 @@
           <p:cNvPr id="10" name="">
             <a:extLst xmlns:a="http://schemas.openxmlformats.org/drawingml/2006/main">
               <a:ext uri="{FF2B5EF4-FFF2-40B4-BE49-F238E27FC236}">
-                <a16:creationId xmlns:a16="http://schemas.microsoft.com/office/drawing/2014/main" id="{65FBA750-94C7-42B9-A14C-37351B715DC2}"/>
+                <a16:creationId xmlns:a16="http://schemas.microsoft.com/office/drawing/2014/main" id="{E21AC423-B99D-43E5-B11D-89F9D9BD3CA9}"/>
               </a:ext>
             </a:extLst>
           </p:cNvPr>
@@ -5534,48 +5493,48 @@
           <a:lstStyle xmlns:a="http://schemas.openxmlformats.org/drawingml/2006/main"/>
           <a:p xmlns:a="http://schemas.openxmlformats.org/drawingml/2006/main">
             <a:pPr algn="l">
-              <a:defRPr sz="2100" b="1">
-                <a:solidFill>
-                  <a:srgbClr val="16343E"/>
-                </a:solidFill>
-                <a:latin typeface="Arial"/>
-                <a:ea typeface="Arial"/>
-                <a:cs typeface="Arial"/>
-              </a:defRPr>
-            </a:pPr>
-            <a:r>
-              <a:rPr sz="2100" b="1">
-                <a:solidFill>
-                  <a:srgbClr val="16343E"/>
-                </a:solidFill>
-                <a:latin typeface="Arial"/>
-                <a:ea typeface="Arial"/>
-                <a:cs typeface="Arial"/>
-              </a:rPr>
-              <a:t>Why both kinds</a:t>
+              <a:defRPr sz="2175" b="1">
+                <a:solidFill>
+                  <a:srgbClr val="16343E"/>
+                </a:solidFill>
+                <a:latin typeface="Arial"/>
+                <a:ea typeface="Arial"/>
+                <a:cs typeface="Arial"/>
+              </a:defRPr>
+            </a:pPr>
+            <a:r>
+              <a:rPr sz="2175" b="1">
+                <a:solidFill>
+                  <a:srgbClr val="16343E"/>
+                </a:solidFill>
+                <a:latin typeface="Arial"/>
+                <a:ea typeface="Arial"/>
+                <a:cs typeface="Arial"/>
+              </a:rPr>
+              <a:t>Biopsy and</a:t>
             </a:r>
           </a:p>
           <a:p xmlns:a="http://schemas.openxmlformats.org/drawingml/2006/main">
             <a:pPr algn="l">
-              <a:defRPr sz="2100" b="1">
-                <a:solidFill>
-                  <a:srgbClr val="16343E"/>
-                </a:solidFill>
-                <a:latin typeface="Arial"/>
-                <a:ea typeface="Arial"/>
-                <a:cs typeface="Arial"/>
-              </a:defRPr>
-            </a:pPr>
-            <a:r>
-              <a:rPr sz="2100" b="1">
-                <a:solidFill>
-                  <a:srgbClr val="16343E"/>
-                </a:solidFill>
-                <a:latin typeface="Arial"/>
-                <a:ea typeface="Arial"/>
-                <a:cs typeface="Arial"/>
-              </a:rPr>
-              <a:t>of error matter</a:t>
+              <a:defRPr sz="2175" b="1">
+                <a:solidFill>
+                  <a:srgbClr val="16343E"/>
+                </a:solidFill>
+                <a:latin typeface="Arial"/>
+                <a:ea typeface="Arial"/>
+                <a:cs typeface="Arial"/>
+              </a:defRPr>
+            </a:pPr>
+            <a:r>
+              <a:rPr sz="2175" b="1">
+                <a:solidFill>
+                  <a:srgbClr val="16343E"/>
+                </a:solidFill>
+                <a:latin typeface="Arial"/>
+                <a:ea typeface="Arial"/>
+                <a:cs typeface="Arial"/>
+              </a:rPr>
+              <a:t>treatment</a:t>
             </a:r>
           </a:p>
         </p:txBody>
@@ -5585,7 +5544,7 @@
           <p:cNvPr id="11" name="">
             <a:extLst xmlns:a="http://schemas.openxmlformats.org/drawingml/2006/main">
               <a:ext uri="{FF2B5EF4-FFF2-40B4-BE49-F238E27FC236}">
-                <a16:creationId xmlns:a16="http://schemas.microsoft.com/office/drawing/2014/main" id="{6A5B9486-652D-4AD0-8CC7-A6A77A952ED1}"/>
+                <a16:creationId xmlns:a16="http://schemas.microsoft.com/office/drawing/2014/main" id="{FE3FBC30-1B00-490A-B6EB-5A0B6F16221E}"/>
               </a:ext>
             </a:extLst>
           </p:cNvPr>
@@ -5614,71 +5573,48 @@
           <a:lstStyle xmlns:a="http://schemas.openxmlformats.org/drawingml/2006/main"/>
           <a:p xmlns:a="http://schemas.openxmlformats.org/drawingml/2006/main">
             <a:pPr algn="l">
-              <a:defRPr sz="2175" b="0">
-                <a:solidFill>
-                  <a:srgbClr val="16343E"/>
-                </a:solidFill>
-                <a:latin typeface="Arial"/>
-                <a:ea typeface="Arial"/>
-                <a:cs typeface="Arial"/>
-              </a:defRPr>
-            </a:pPr>
-            <a:r>
-              <a:rPr sz="2175" b="0">
-                <a:solidFill>
-                  <a:srgbClr val="16343E"/>
-                </a:solidFill>
-                <a:latin typeface="Arial"/>
-                <a:ea typeface="Arial"/>
-                <a:cs typeface="Arial"/>
-              </a:rPr>
-              <a:t>Biopsy findings help guide treatment for rejection.</a:t>
+              <a:defRPr sz="2250" b="0">
+                <a:solidFill>
+                  <a:srgbClr val="16343E"/>
+                </a:solidFill>
+                <a:latin typeface="Arial"/>
+                <a:ea typeface="Arial"/>
+                <a:cs typeface="Arial"/>
+              </a:defRPr>
+            </a:pPr>
+            <a:r>
+              <a:rPr sz="2250" b="0">
+                <a:solidFill>
+                  <a:srgbClr val="16343E"/>
+                </a:solidFill>
+                <a:latin typeface="Arial"/>
+                <a:ea typeface="Arial"/>
+                <a:cs typeface="Arial"/>
+              </a:rPr>
+              <a:t>KDIGO recommends biopsy before treating acute rejection,</a:t>
             </a:r>
           </a:p>
           <a:p xmlns:a="http://schemas.openxmlformats.org/drawingml/2006/main">
             <a:pPr algn="l">
-              <a:defRPr sz="2175" b="0">
-                <a:solidFill>
-                  <a:srgbClr val="16343E"/>
-                </a:solidFill>
-                <a:latin typeface="Arial"/>
-                <a:ea typeface="Arial"/>
-                <a:cs typeface="Arial"/>
-              </a:defRPr>
-            </a:pPr>
-            <a:r>
-              <a:rPr sz="2175" b="0">
-                <a:solidFill>
-                  <a:srgbClr val="16343E"/>
-                </a:solidFill>
-                <a:latin typeface="Arial"/>
-                <a:ea typeface="Arial"/>
-                <a:cs typeface="Arial"/>
-              </a:rPr>
-              <a:t>Missed rejection can leave kidney injury untreated.</a:t>
-            </a:r>
-          </a:p>
-          <a:p xmlns:a="http://schemas.openxmlformats.org/drawingml/2006/main">
-            <a:pPr algn="l">
-              <a:defRPr sz="2175" b="0">
-                <a:solidFill>
-                  <a:srgbClr val="16343E"/>
-                </a:solidFill>
-                <a:latin typeface="Arial"/>
-                <a:ea typeface="Arial"/>
-                <a:cs typeface="Arial"/>
-              </a:defRPr>
-            </a:pPr>
-            <a:r>
-              <a:rPr sz="2175" b="0">
-                <a:solidFill>
-                  <a:srgbClr val="16343E"/>
-                </a:solidFill>
-                <a:latin typeface="Arial"/>
-                <a:ea typeface="Arial"/>
-                <a:cs typeface="Arial"/>
-              </a:rPr>
-              <a:t>Unnecessary treatment can worsen an infection.</a:t>
+              <a:defRPr sz="2250" b="0">
+                <a:solidFill>
+                  <a:srgbClr val="16343E"/>
+                </a:solidFill>
+                <a:latin typeface="Arial"/>
+                <a:ea typeface="Arial"/>
+                <a:cs typeface="Arial"/>
+              </a:defRPr>
+            </a:pPr>
+            <a:r>
+              <a:rPr sz="2250" b="0">
+                <a:solidFill>
+                  <a:srgbClr val="16343E"/>
+                </a:solidFill>
+                <a:latin typeface="Arial"/>
+                <a:ea typeface="Arial"/>
+                <a:cs typeface="Arial"/>
+              </a:rPr>
+              <a:t>unless waiting would substantially delay treatment.</a:t>
             </a:r>
           </a:p>
         </p:txBody>
@@ -5686,7 +5622,7 @@
     </p:spTree>
     <p:extLst>
       <p:ext uri="{BB962C8B-B14F-4D97-AF65-F5344CB8AC3E}">
-        <p14:creationId xmlns:p14="http://schemas.microsoft.com/office/powerpoint/2010/main" val="1899912211"/>
+        <p14:creationId xmlns:p14="http://schemas.microsoft.com/office/powerpoint/2010/main" val="1699217620"/>
       </p:ext>
     </p:extLst>
   </p:cSld>
@@ -5717,7 +5653,7 @@
           <p:cNvPr id="13" name="">
             <a:extLst xmlns:a="http://schemas.openxmlformats.org/drawingml/2006/main">
               <a:ext uri="{FF2B5EF4-FFF2-40B4-BE49-F238E27FC236}">
-                <a16:creationId xmlns:a16="http://schemas.microsoft.com/office/drawing/2014/main" id="{8E5A9869-9C66-4100-9666-5EF7957BFAC0}"/>
+                <a16:creationId xmlns:a16="http://schemas.microsoft.com/office/drawing/2014/main" id="{96EBAD5A-7AC4-42AC-958A-2B591CCB573F}"/>
               </a:ext>
             </a:extLst>
           </p:cNvPr>
@@ -5774,7 +5710,7 @@
           <p:cNvPr id="2" name="">
             <a:extLst xmlns:a="http://schemas.openxmlformats.org/drawingml/2006/main">
               <a:ext uri="{FF2B5EF4-FFF2-40B4-BE49-F238E27FC236}">
-                <a16:creationId xmlns:a16="http://schemas.microsoft.com/office/drawing/2014/main" id="{4D21B652-97B5-423E-B643-8533DD97F683}"/>
+                <a16:creationId xmlns:a16="http://schemas.microsoft.com/office/drawing/2014/main" id="{5E6E1D15-BE57-4CDB-A574-51E23AA2D977}"/>
               </a:ext>
             </a:extLst>
           </p:cNvPr>
@@ -5831,7 +5767,7 @@
           <p:cNvPr id="3" name="">
             <a:extLst xmlns:a="http://schemas.openxmlformats.org/drawingml/2006/main">
               <a:ext uri="{FF2B5EF4-FFF2-40B4-BE49-F238E27FC236}">
-                <a16:creationId xmlns:a16="http://schemas.microsoft.com/office/drawing/2014/main" id="{C31855AF-8522-4E66-AA21-CF1F33859040}"/>
+                <a16:creationId xmlns:a16="http://schemas.microsoft.com/office/drawing/2014/main" id="{EE867CA5-B1B4-481C-8FC7-92678305ACC4}"/>
               </a:ext>
             </a:extLst>
           </p:cNvPr>
@@ -5888,7 +5824,7 @@
           <p:cNvPr id="4" name="">
             <a:extLst xmlns:a="http://schemas.openxmlformats.org/drawingml/2006/main">
               <a:ext uri="{FF2B5EF4-FFF2-40B4-BE49-F238E27FC236}">
-                <a16:creationId xmlns:a16="http://schemas.microsoft.com/office/drawing/2014/main" id="{C7F07D4A-1DFF-43A2-B189-43307C47E32A}"/>
+                <a16:creationId xmlns:a16="http://schemas.microsoft.com/office/drawing/2014/main" id="{143EDC5C-D4A5-44E1-9A14-4D487B9AF519}"/>
               </a:ext>
             </a:extLst>
           </p:cNvPr>
@@ -5945,7 +5881,7 @@
           <p:cNvPr id="5" name="">
             <a:extLst xmlns:a="http://schemas.openxmlformats.org/drawingml/2006/main">
               <a:ext uri="{FF2B5EF4-FFF2-40B4-BE49-F238E27FC236}">
-                <a16:creationId xmlns:a16="http://schemas.microsoft.com/office/drawing/2014/main" id="{E1A8B6BE-737E-43DD-9DD9-661476979D12}"/>
+                <a16:creationId xmlns:a16="http://schemas.microsoft.com/office/drawing/2014/main" id="{2AE16F40-45D8-4EAE-AC7D-49155562D809}"/>
               </a:ext>
             </a:extLst>
           </p:cNvPr>
@@ -6002,7 +5938,7 @@
           <p:cNvPr id="6" name="">
             <a:extLst xmlns:a="http://schemas.openxmlformats.org/drawingml/2006/main">
               <a:ext uri="{FF2B5EF4-FFF2-40B4-BE49-F238E27FC236}">
-                <a16:creationId xmlns:a16="http://schemas.microsoft.com/office/drawing/2014/main" id="{D647E10B-4E3B-49D5-AE01-044D0529054B}"/>
+                <a16:creationId xmlns:a16="http://schemas.microsoft.com/office/drawing/2014/main" id="{1A87ED3A-7D97-4FE6-88F3-5BD5055C485E}"/>
               </a:ext>
             </a:extLst>
           </p:cNvPr>
@@ -6643,7 +6579,7 @@
           <p:cNvPr id="9" name="">
             <a:extLst xmlns:a="http://schemas.openxmlformats.org/drawingml/2006/main">
               <a:ext uri="{FF2B5EF4-FFF2-40B4-BE49-F238E27FC236}">
-                <a16:creationId xmlns:a16="http://schemas.microsoft.com/office/drawing/2014/main" id="{DE05F357-D214-4F82-BB1F-3EA07D3755CD}"/>
+                <a16:creationId xmlns:a16="http://schemas.microsoft.com/office/drawing/2014/main" id="{450BE7C0-BC1F-4E36-8246-28C193B308EE}"/>
               </a:ext>
             </a:extLst>
           </p:cNvPr>
@@ -6672,7 +6608,7 @@
           <p:cNvPr id="10" name="">
             <a:extLst xmlns:a="http://schemas.openxmlformats.org/drawingml/2006/main">
               <a:ext uri="{FF2B5EF4-FFF2-40B4-BE49-F238E27FC236}">
-                <a16:creationId xmlns:a16="http://schemas.microsoft.com/office/drawing/2014/main" id="{9F6C7AB4-206C-46DE-8204-110ABA381C38}"/>
+                <a16:creationId xmlns:a16="http://schemas.microsoft.com/office/drawing/2014/main" id="{45E4AB8B-C8D5-44BE-B8AF-2FF66400E12B}"/>
               </a:ext>
             </a:extLst>
           </p:cNvPr>
@@ -6729,7 +6665,7 @@
           <p:cNvPr id="11" name="">
             <a:extLst xmlns:a="http://schemas.openxmlformats.org/drawingml/2006/main">
               <a:ext uri="{FF2B5EF4-FFF2-40B4-BE49-F238E27FC236}">
-                <a16:creationId xmlns:a16="http://schemas.microsoft.com/office/drawing/2014/main" id="{C2B016DF-049F-41CA-A166-EF16C9F13341}"/>
+                <a16:creationId xmlns:a16="http://schemas.microsoft.com/office/drawing/2014/main" id="{C27A4426-E489-47D0-BDC7-11A774C4B281}"/>
               </a:ext>
             </a:extLst>
           </p:cNvPr>
@@ -6786,7 +6722,7 @@
           <p:cNvPr id="12" name="">
             <a:extLst xmlns:a="http://schemas.openxmlformats.org/drawingml/2006/main">
               <a:ext uri="{FF2B5EF4-FFF2-40B4-BE49-F238E27FC236}">
-                <a16:creationId xmlns:a16="http://schemas.microsoft.com/office/drawing/2014/main" id="{7D96BC94-05CC-48CF-9CFC-C5A43F3E2F89}"/>
+                <a16:creationId xmlns:a16="http://schemas.microsoft.com/office/drawing/2014/main" id="{6AA7A7C0-05F1-4916-9BF2-F4C3A0CAA872}"/>
               </a:ext>
             </a:extLst>
           </p:cNvPr>
@@ -6872,7 +6808,7 @@
     </p:spTree>
     <p:extLst>
       <p:ext uri="{BB962C8B-B14F-4D97-AF65-F5344CB8AC3E}">
-        <p14:creationId xmlns:p14="http://schemas.microsoft.com/office/powerpoint/2010/main" val="113553735"/>
+        <p14:creationId xmlns:p14="http://schemas.microsoft.com/office/powerpoint/2010/main" val="1680210600"/>
       </p:ext>
     </p:extLst>
   </p:cSld>
@@ -6903,7 +6839,7 @@
           <p:cNvPr id="7" name="">
             <a:extLst xmlns:a="http://schemas.openxmlformats.org/drawingml/2006/main">
               <a:ext uri="{FF2B5EF4-FFF2-40B4-BE49-F238E27FC236}">
-                <a16:creationId xmlns:a16="http://schemas.microsoft.com/office/drawing/2014/main" id="{4C908E84-9FB4-4BE1-ABB5-7F6B6E4D198B}"/>
+                <a16:creationId xmlns:a16="http://schemas.microsoft.com/office/drawing/2014/main" id="{0B503235-E3A0-4F4F-B7EB-EF1D63287BF3}"/>
               </a:ext>
             </a:extLst>
           </p:cNvPr>
@@ -6960,7 +6896,7 @@
           <p:cNvPr id="2" name="">
             <a:extLst xmlns:a="http://schemas.openxmlformats.org/drawingml/2006/main">
               <a:ext uri="{FF2B5EF4-FFF2-40B4-BE49-F238E27FC236}">
-                <a16:creationId xmlns:a16="http://schemas.microsoft.com/office/drawing/2014/main" id="{713318D5-1415-400F-808A-D6E495131E0E}"/>
+                <a16:creationId xmlns:a16="http://schemas.microsoft.com/office/drawing/2014/main" id="{AD82C2FC-2873-42D7-969E-F9D9D682366F}"/>
               </a:ext>
             </a:extLst>
           </p:cNvPr>
@@ -7017,7 +6953,7 @@
           <p:cNvPr id="3" name="">
             <a:extLst xmlns:a="http://schemas.openxmlformats.org/drawingml/2006/main">
               <a:ext uri="{FF2B5EF4-FFF2-40B4-BE49-F238E27FC236}">
-                <a16:creationId xmlns:a16="http://schemas.microsoft.com/office/drawing/2014/main" id="{D1489D7E-6A70-4B4A-93D6-2C629D296A2A}"/>
+                <a16:creationId xmlns:a16="http://schemas.microsoft.com/office/drawing/2014/main" id="{ABEB3D62-F89A-4577-BB45-F20603D0F3F0}"/>
               </a:ext>
             </a:extLst>
           </p:cNvPr>
@@ -7074,7 +7010,7 @@
           <p:cNvPr id="4" name="">
             <a:extLst xmlns:a="http://schemas.openxmlformats.org/drawingml/2006/main">
               <a:ext uri="{FF2B5EF4-FFF2-40B4-BE49-F238E27FC236}">
-                <a16:creationId xmlns:a16="http://schemas.microsoft.com/office/drawing/2014/main" id="{CB41243F-7142-48B5-93AB-B83E755279F7}"/>
+                <a16:creationId xmlns:a16="http://schemas.microsoft.com/office/drawing/2014/main" id="{F289C4D6-6BD2-4A4C-AB7C-3384BFB5454C}"/>
               </a:ext>
             </a:extLst>
           </p:cNvPr>
@@ -7554,7 +7490,7 @@
           <p:cNvPr id="6" name="">
             <a:extLst xmlns:a="http://schemas.openxmlformats.org/drawingml/2006/main">
               <a:ext uri="{FF2B5EF4-FFF2-40B4-BE49-F238E27FC236}">
-                <a16:creationId xmlns:a16="http://schemas.microsoft.com/office/drawing/2014/main" id="{CBECAEA7-A9D1-4427-A1CB-F8B0B501654E}"/>
+                <a16:creationId xmlns:a16="http://schemas.microsoft.com/office/drawing/2014/main" id="{19864617-E989-4DD4-8A87-03D47171BA93}"/>
               </a:ext>
             </a:extLst>
           </p:cNvPr>
@@ -7609,7 +7545,7 @@
     </p:spTree>
     <p:extLst>
       <p:ext uri="{BB962C8B-B14F-4D97-AF65-F5344CB8AC3E}">
-        <p14:creationId xmlns:p14="http://schemas.microsoft.com/office/powerpoint/2010/main" val="609354919"/>
+        <p14:creationId xmlns:p14="http://schemas.microsoft.com/office/powerpoint/2010/main" val="701418320"/>
       </p:ext>
     </p:extLst>
   </p:cSld>
@@ -7640,7 +7576,7 @@
           <p:cNvPr id="11" name="">
             <a:extLst xmlns:a="http://schemas.openxmlformats.org/drawingml/2006/main">
               <a:ext uri="{FF2B5EF4-FFF2-40B4-BE49-F238E27FC236}">
-                <a16:creationId xmlns:a16="http://schemas.microsoft.com/office/drawing/2014/main" id="{63F61011-B34B-4687-AC39-EBBDCEA06E55}"/>
+                <a16:creationId xmlns:a16="http://schemas.microsoft.com/office/drawing/2014/main" id="{94596A69-3FF9-4DF3-8926-D69B69A670B5}"/>
               </a:ext>
             </a:extLst>
           </p:cNvPr>
@@ -7697,7 +7633,7 @@
           <p:cNvPr id="2" name="">
             <a:extLst xmlns:a="http://schemas.openxmlformats.org/drawingml/2006/main">
               <a:ext uri="{FF2B5EF4-FFF2-40B4-BE49-F238E27FC236}">
-                <a16:creationId xmlns:a16="http://schemas.microsoft.com/office/drawing/2014/main" id="{5D6AD6C3-6DA3-4035-89C8-E864941E8B99}"/>
+                <a16:creationId xmlns:a16="http://schemas.microsoft.com/office/drawing/2014/main" id="{A6FC6155-AA4C-42DC-A2ED-0C42BDBE360C}"/>
               </a:ext>
             </a:extLst>
           </p:cNvPr>
@@ -7754,7 +7690,7 @@
           <p:cNvPr id="3" name="">
             <a:extLst xmlns:a="http://schemas.openxmlformats.org/drawingml/2006/main">
               <a:ext uri="{FF2B5EF4-FFF2-40B4-BE49-F238E27FC236}">
-                <a16:creationId xmlns:a16="http://schemas.microsoft.com/office/drawing/2014/main" id="{7E4FAE6D-78C5-4BBC-BB2D-0B2480B06408}"/>
+                <a16:creationId xmlns:a16="http://schemas.microsoft.com/office/drawing/2014/main" id="{2C830EA4-CAE0-41B7-A70A-C0FA37B771CD}"/>
               </a:ext>
             </a:extLst>
           </p:cNvPr>
@@ -7811,7 +7747,7 @@
           <p:cNvPr id="4" name="">
             <a:extLst xmlns:a="http://schemas.openxmlformats.org/drawingml/2006/main">
               <a:ext uri="{FF2B5EF4-FFF2-40B4-BE49-F238E27FC236}">
-                <a16:creationId xmlns:a16="http://schemas.microsoft.com/office/drawing/2014/main" id="{744AE511-1DBC-4CE4-8838-F07576B5C202}"/>
+                <a16:creationId xmlns:a16="http://schemas.microsoft.com/office/drawing/2014/main" id="{C8E6217F-7CB8-4753-BE71-448433FD2C1E}"/>
               </a:ext>
             </a:extLst>
           </p:cNvPr>
@@ -7868,7 +7804,7 @@
           <p:cNvPr id="5" name="">
             <a:extLst xmlns:a="http://schemas.openxmlformats.org/drawingml/2006/main">
               <a:ext uri="{FF2B5EF4-FFF2-40B4-BE49-F238E27FC236}">
-                <a16:creationId xmlns:a16="http://schemas.microsoft.com/office/drawing/2014/main" id="{DE4D5BF5-4173-423C-8BE2-04D512F3BBAD}"/>
+                <a16:creationId xmlns:a16="http://schemas.microsoft.com/office/drawing/2014/main" id="{86B4DB6D-2E56-44E8-AF9F-5B0934BB2F3B}"/>
               </a:ext>
             </a:extLst>
           </p:cNvPr>
@@ -7925,7 +7861,7 @@
           <p:cNvPr id="6" name="">
             <a:extLst xmlns:a="http://schemas.openxmlformats.org/drawingml/2006/main">
               <a:ext uri="{FF2B5EF4-FFF2-40B4-BE49-F238E27FC236}">
-                <a16:creationId xmlns:a16="http://schemas.microsoft.com/office/drawing/2014/main" id="{C661F9CC-36F5-4550-98F3-7D59768D881A}"/>
+                <a16:creationId xmlns:a16="http://schemas.microsoft.com/office/drawing/2014/main" id="{71B56ADA-D9B9-417C-B1F0-4E05B66445DC}"/>
               </a:ext>
             </a:extLst>
           </p:cNvPr>
@@ -7982,7 +7918,7 @@
           <p:cNvPr id="7" name="">
             <a:extLst xmlns:a="http://schemas.openxmlformats.org/drawingml/2006/main">
               <a:ext uri="{FF2B5EF4-FFF2-40B4-BE49-F238E27FC236}">
-                <a16:creationId xmlns:a16="http://schemas.microsoft.com/office/drawing/2014/main" id="{8ECEDEA3-2482-4ED6-8CDD-E941E3CABA7F}"/>
+                <a16:creationId xmlns:a16="http://schemas.microsoft.com/office/drawing/2014/main" id="{658152AF-8711-40A0-A848-74F6545182D2}"/>
               </a:ext>
             </a:extLst>
           </p:cNvPr>
@@ -8097,7 +8033,7 @@
           <p:cNvPr id="8" name="">
             <a:extLst xmlns:a="http://schemas.openxmlformats.org/drawingml/2006/main">
               <a:ext uri="{FF2B5EF4-FFF2-40B4-BE49-F238E27FC236}">
-                <a16:creationId xmlns:a16="http://schemas.microsoft.com/office/drawing/2014/main" id="{ADFE5690-D9C7-4ADE-8917-1E4FD7B71DCE}"/>
+                <a16:creationId xmlns:a16="http://schemas.microsoft.com/office/drawing/2014/main" id="{7A0DD812-9C65-4A35-B898-F8C8D4596C28}"/>
               </a:ext>
             </a:extLst>
           </p:cNvPr>
@@ -8154,7 +8090,7 @@
           <p:cNvPr id="9" name="">
             <a:extLst xmlns:a="http://schemas.openxmlformats.org/drawingml/2006/main">
               <a:ext uri="{FF2B5EF4-FFF2-40B4-BE49-F238E27FC236}">
-                <a16:creationId xmlns:a16="http://schemas.microsoft.com/office/drawing/2014/main" id="{B4A98344-A490-41AA-B318-EA8469C68F58}"/>
+                <a16:creationId xmlns:a16="http://schemas.microsoft.com/office/drawing/2014/main" id="{46ACDAAE-B004-4174-A7D0-508A49CA648D}"/>
               </a:ext>
             </a:extLst>
           </p:cNvPr>
@@ -8211,7 +8147,7 @@
           <p:cNvPr id="10" name="">
             <a:extLst xmlns:a="http://schemas.openxmlformats.org/drawingml/2006/main">
               <a:ext uri="{FF2B5EF4-FFF2-40B4-BE49-F238E27FC236}">
-                <a16:creationId xmlns:a16="http://schemas.microsoft.com/office/drawing/2014/main" id="{FD7B2646-8BD7-4149-988C-A19DC0923889}"/>
+                <a16:creationId xmlns:a16="http://schemas.microsoft.com/office/drawing/2014/main" id="{63E3917B-75CE-45B5-8E28-4E37EF43B452}"/>
               </a:ext>
             </a:extLst>
           </p:cNvPr>
@@ -8324,7 +8260,7 @@
     </p:spTree>
     <p:extLst>
       <p:ext uri="{BB962C8B-B14F-4D97-AF65-F5344CB8AC3E}">
-        <p14:creationId xmlns:p14="http://schemas.microsoft.com/office/powerpoint/2010/main" val="1288594396"/>
+        <p14:creationId xmlns:p14="http://schemas.microsoft.com/office/powerpoint/2010/main" val="1579420710"/>
       </p:ext>
     </p:extLst>
   </p:cSld>
@@ -8355,7 +8291,7 @@
           <p:cNvPr id="5" name="">
             <a:extLst xmlns:a="http://schemas.openxmlformats.org/drawingml/2006/main">
               <a:ext uri="{FF2B5EF4-FFF2-40B4-BE49-F238E27FC236}">
-                <a16:creationId xmlns:a16="http://schemas.microsoft.com/office/drawing/2014/main" id="{6EF01540-E329-4D06-89E1-D8CE30B0FE55}"/>
+                <a16:creationId xmlns:a16="http://schemas.microsoft.com/office/drawing/2014/main" id="{BACD7049-9214-45FF-AC0A-0C033403621C}"/>
               </a:ext>
             </a:extLst>
           </p:cNvPr>
@@ -8412,7 +8348,7 @@
           <p:cNvPr id="2" name="">
             <a:extLst xmlns:a="http://schemas.openxmlformats.org/drawingml/2006/main">
               <a:ext uri="{FF2B5EF4-FFF2-40B4-BE49-F238E27FC236}">
-                <a16:creationId xmlns:a16="http://schemas.microsoft.com/office/drawing/2014/main" id="{F3E1F216-C47E-4633-9047-9CE28FABB450}"/>
+                <a16:creationId xmlns:a16="http://schemas.microsoft.com/office/drawing/2014/main" id="{CF40F072-C767-4E58-8A1C-96A48C3B7917}"/>
               </a:ext>
             </a:extLst>
           </p:cNvPr>
@@ -8469,7 +8405,7 @@
           <p:cNvPr id="3" name="">
             <a:extLst xmlns:a="http://schemas.openxmlformats.org/drawingml/2006/main">
               <a:ext uri="{FF2B5EF4-FFF2-40B4-BE49-F238E27FC236}">
-                <a16:creationId xmlns:a16="http://schemas.microsoft.com/office/drawing/2014/main" id="{67047B84-5D7E-41AC-AF20-9EF0E5248837}"/>
+                <a16:creationId xmlns:a16="http://schemas.microsoft.com/office/drawing/2014/main" id="{847D6A82-ED39-44DE-8A2E-697A95D9B9EE}"/>
               </a:ext>
             </a:extLst>
           </p:cNvPr>
@@ -8816,7 +8752,7 @@
     </p:spTree>
     <p:extLst>
       <p:ext uri="{BB962C8B-B14F-4D97-AF65-F5344CB8AC3E}">
-        <p14:creationId xmlns:p14="http://schemas.microsoft.com/office/powerpoint/2010/main" val="578683797"/>
+        <p14:creationId xmlns:p14="http://schemas.microsoft.com/office/powerpoint/2010/main" val="725308089"/>
       </p:ext>
     </p:extLst>
   </p:cSld>
@@ -8847,7 +8783,7 @@
           <p:cNvPr id="11" name="">
             <a:extLst xmlns:a="http://schemas.openxmlformats.org/drawingml/2006/main">
               <a:ext uri="{FF2B5EF4-FFF2-40B4-BE49-F238E27FC236}">
-                <a16:creationId xmlns:a16="http://schemas.microsoft.com/office/drawing/2014/main" id="{49DFAA9C-709E-4321-9A5B-84F1351FA5C3}"/>
+                <a16:creationId xmlns:a16="http://schemas.microsoft.com/office/drawing/2014/main" id="{83EBDC0A-4E2B-4B15-BB67-D661660D3137}"/>
               </a:ext>
             </a:extLst>
           </p:cNvPr>
@@ -8904,7 +8840,7 @@
           <p:cNvPr id="2" name="">
             <a:extLst xmlns:a="http://schemas.openxmlformats.org/drawingml/2006/main">
               <a:ext uri="{FF2B5EF4-FFF2-40B4-BE49-F238E27FC236}">
-                <a16:creationId xmlns:a16="http://schemas.microsoft.com/office/drawing/2014/main" id="{05AF8900-D210-4B09-AD3F-511CFA430300}"/>
+                <a16:creationId xmlns:a16="http://schemas.microsoft.com/office/drawing/2014/main" id="{009655F9-C97F-4EB7-9639-44EF32AA7F52}"/>
               </a:ext>
             </a:extLst>
           </p:cNvPr>
@@ -8961,7 +8897,7 @@
           <p:cNvPr id="3" name="">
             <a:extLst xmlns:a="http://schemas.openxmlformats.org/drawingml/2006/main">
               <a:ext uri="{FF2B5EF4-FFF2-40B4-BE49-F238E27FC236}">
-                <a16:creationId xmlns:a16="http://schemas.microsoft.com/office/drawing/2014/main" id="{7DA05A24-EC25-436F-85A1-D5A688963D48}"/>
+                <a16:creationId xmlns:a16="http://schemas.microsoft.com/office/drawing/2014/main" id="{F0B3F083-4BFB-4DB4-BF97-81B0B829F88C}"/>
               </a:ext>
             </a:extLst>
           </p:cNvPr>
@@ -9018,7 +8954,7 @@
           <p:cNvPr id="4" name="">
             <a:extLst xmlns:a="http://schemas.openxmlformats.org/drawingml/2006/main">
               <a:ext uri="{FF2B5EF4-FFF2-40B4-BE49-F238E27FC236}">
-                <a16:creationId xmlns:a16="http://schemas.microsoft.com/office/drawing/2014/main" id="{3DA863DB-D8ED-4BB7-AF31-6F064D8DE71C}"/>
+                <a16:creationId xmlns:a16="http://schemas.microsoft.com/office/drawing/2014/main" id="{29C76656-63ED-493E-9EDB-817AF0C68F57}"/>
               </a:ext>
             </a:extLst>
           </p:cNvPr>
@@ -9106,7 +9042,7 @@
           <p:cNvPr id="5" name="">
             <a:extLst xmlns:a="http://schemas.openxmlformats.org/drawingml/2006/main">
               <a:ext uri="{FF2B5EF4-FFF2-40B4-BE49-F238E27FC236}">
-                <a16:creationId xmlns:a16="http://schemas.microsoft.com/office/drawing/2014/main" id="{43E7CB50-5CAD-4493-8E18-051526345DE8}"/>
+                <a16:creationId xmlns:a16="http://schemas.microsoft.com/office/drawing/2014/main" id="{C531D12D-8DAA-4FA7-A856-63CE44766DBF}"/>
               </a:ext>
             </a:extLst>
           </p:cNvPr>
@@ -9190,7 +9126,7 @@
           <p:cNvPr id="6" name="">
             <a:extLst xmlns:a="http://schemas.openxmlformats.org/drawingml/2006/main">
               <a:ext uri="{FF2B5EF4-FFF2-40B4-BE49-F238E27FC236}">
-                <a16:creationId xmlns:a16="http://schemas.microsoft.com/office/drawing/2014/main" id="{DE9FC681-8373-4283-8515-F4609020649A}"/>
+                <a16:creationId xmlns:a16="http://schemas.microsoft.com/office/drawing/2014/main" id="{291D677B-532B-44D7-9373-49595D2302C1}"/>
               </a:ext>
             </a:extLst>
           </p:cNvPr>
@@ -9274,7 +9210,7 @@
           <p:cNvPr id="7" name="">
             <a:extLst xmlns:a="http://schemas.openxmlformats.org/drawingml/2006/main">
               <a:ext uri="{FF2B5EF4-FFF2-40B4-BE49-F238E27FC236}">
-                <a16:creationId xmlns:a16="http://schemas.microsoft.com/office/drawing/2014/main" id="{0204CFB1-070E-4655-AF21-29B49D4F7826}"/>
+                <a16:creationId xmlns:a16="http://schemas.microsoft.com/office/drawing/2014/main" id="{02AB2353-F00E-407F-8EDA-053B4F905BFE}"/>
               </a:ext>
             </a:extLst>
           </p:cNvPr>
@@ -9414,7 +9350,7 @@
           <p:cNvPr id="10" name="">
             <a:extLst xmlns:a="http://schemas.openxmlformats.org/drawingml/2006/main">
               <a:ext uri="{FF2B5EF4-FFF2-40B4-BE49-F238E27FC236}">
-                <a16:creationId xmlns:a16="http://schemas.microsoft.com/office/drawing/2014/main" id="{DA674A1E-0399-4A94-AF0F-6C97E6843C88}"/>
+                <a16:creationId xmlns:a16="http://schemas.microsoft.com/office/drawing/2014/main" id="{29DFE84E-76F6-4DD7-A13D-C0AE3C87BED7}"/>
               </a:ext>
             </a:extLst>
           </p:cNvPr>
@@ -9547,7 +9483,7 @@
     </p:spTree>
     <p:extLst>
       <p:ext uri="{BB962C8B-B14F-4D97-AF65-F5344CB8AC3E}">
-        <p14:creationId xmlns:p14="http://schemas.microsoft.com/office/powerpoint/2010/main" val="100263638"/>
+        <p14:creationId xmlns:p14="http://schemas.microsoft.com/office/powerpoint/2010/main" val="1036492177"/>
       </p:ext>
     </p:extLst>
   </p:cSld>

</xml_diff>

<commit_message>
Clarify repeated-split model selection in the presentation
Label the 13/7 result as screening selections, shorten the demo
explanation, and make assessment errors expandable. Update the
matching narration and rebuild the PowerPoint, PDF, and HTML.
</commit_message>
<xml_diff>
--- a/presentation/unos_kidney_biopsy.pptx
+++ b/presentation/unos_kidney_biopsy.pptx
@@ -2,23 +2,23 @@
 <file path=ppt/presentation.xml><?xml version="1.0" encoding="utf-8"?>
 <p:presentation xmlns:p="http://schemas.openxmlformats.org/presentationml/2006/main" xmlns:r="http://schemas.openxmlformats.org/officeDocument/2006/relationships">
   <p:sldMasterIdLst>
-    <p:sldMasterId id="2147483648" r:id="Radcac8545d59437c"/>
+    <p:sldMasterId id="2147483648" r:id="Rf66096a0ca224ace"/>
   </p:sldMasterIdLst>
   <p:sldIdLst>
-    <p:sldId id="256" r:id="R781d5cc738c34436"/>
-    <p:sldId id="257" r:id="Rec3db5835e1f439a"/>
-    <p:sldId id="258" r:id="R51719fcafa0f403e"/>
-    <p:sldId id="259" r:id="R00b76af712754641"/>
-    <p:sldId id="260" r:id="Re8cd26c337104d9f"/>
-    <p:sldId id="261" r:id="Rcfef350d5687436e"/>
-    <p:sldId id="262" r:id="R15d2744f03f84fc0"/>
-    <p:sldId id="263" r:id="R66384e3f01c94cf4"/>
-    <p:sldId id="264" r:id="Rec0215ee7d3a4316"/>
-    <p:sldId id="265" r:id="R0332bfbb659f45a8"/>
-    <p:sldId id="266" r:id="R440cffbe54994fea"/>
-    <p:sldId id="267" r:id="Re07831943fa54d19"/>
-    <p:sldId id="268" r:id="Rc2c60499f0df4be4"/>
-    <p:sldId id="269" r:id="Rfc31a2a832e0429b"/>
+    <p:sldId id="256" r:id="R929541006fc24323"/>
+    <p:sldId id="257" r:id="R2308b4464e3c4e1a"/>
+    <p:sldId id="258" r:id="R201bcbad29c846be"/>
+    <p:sldId id="259" r:id="R1bb58af00cbd417d"/>
+    <p:sldId id="260" r:id="Rd9d67569632d49d9"/>
+    <p:sldId id="261" r:id="Rcc4d16d8b1c2481c"/>
+    <p:sldId id="262" r:id="Ra8f975ce5fa1491e"/>
+    <p:sldId id="263" r:id="R6d4dc4deb0b64c6a"/>
+    <p:sldId id="264" r:id="Rb6d568d672f34e11"/>
+    <p:sldId id="265" r:id="R1cf8861be31d4378"/>
+    <p:sldId id="266" r:id="R97a7dbaedb524ab1"/>
+    <p:sldId id="267" r:id="R362554e70bdc4c83"/>
+    <p:sldId id="268" r:id="R960bdb4507324ca4"/>
+    <p:sldId id="269" r:id="R5e88523445fb41fb"/>
   </p:sldIdLst>
   <p:sldSz cx="12192000" cy="6858000"/>
   <p:notesSz cx="6858000" cy="9144000"/>
@@ -63,7 +63,7 @@
   </p:cSld>
   <p:clrMap bg1="lt1" tx1="dk1" bg2="lt2" tx2="dk2" accent1="accent1" accent2="accent2" accent3="accent3" accent4="accent4" accent5="accent5" accent6="accent6" hlink="hlink" folHlink="folHlink"/>
   <p:sldLayoutIdLst>
-    <p:sldLayoutId xmlns:r="http://schemas.openxmlformats.org/officeDocument/2006/relationships" id="2147483649" r:id="Re16480a5278443de"/>
+    <p:sldLayoutId xmlns:r="http://schemas.openxmlformats.org/officeDocument/2006/relationships" id="2147483649" r:id="Rcd76588cdc9b4739"/>
   </p:sldLayoutIdLst>
   <p:txStyles>
     <p:titleStyle>
@@ -851,7 +851,7 @@
           <p:cNvPr id="2" name="">
             <a:extLst xmlns:a="http://schemas.openxmlformats.org/drawingml/2006/main">
               <a:ext uri="{FF2B5EF4-FFF2-40B4-BE49-F238E27FC236}">
-                <a16:creationId xmlns:a16="http://schemas.microsoft.com/office/drawing/2014/main" id="{B0A82B52-8CE3-4D48-99D9-33FFE7A9A04E}"/>
+                <a16:creationId xmlns:a16="http://schemas.microsoft.com/office/drawing/2014/main" id="{1BEBBD3D-FF57-4B8D-B446-1D3FCF6697A3}"/>
               </a:ext>
             </a:extLst>
           </p:cNvPr>
@@ -952,7 +952,7 @@
     </p:spTree>
     <p:extLst>
       <p:ext uri="{BB962C8B-B14F-4D97-AF65-F5344CB8AC3E}">
-        <p14:creationId xmlns:p14="http://schemas.microsoft.com/office/powerpoint/2010/main" val="127899676"/>
+        <p14:creationId xmlns:p14="http://schemas.microsoft.com/office/powerpoint/2010/main" val="242733946"/>
       </p:ext>
     </p:extLst>
   </p:cSld>
@@ -983,7 +983,7 @@
           <p:cNvPr id="6" name="">
             <a:extLst xmlns:a="http://schemas.openxmlformats.org/drawingml/2006/main">
               <a:ext uri="{FF2B5EF4-FFF2-40B4-BE49-F238E27FC236}">
-                <a16:creationId xmlns:a16="http://schemas.microsoft.com/office/drawing/2014/main" id="{E73B0216-C3F7-4604-905B-288AB82100BB}"/>
+                <a16:creationId xmlns:a16="http://schemas.microsoft.com/office/drawing/2014/main" id="{36FC60F0-700F-496D-B5D0-7547E524AEA3}"/>
               </a:ext>
             </a:extLst>
           </p:cNvPr>
@@ -1040,7 +1040,7 @@
           <p:cNvPr id="2" name="">
             <a:extLst xmlns:a="http://schemas.openxmlformats.org/drawingml/2006/main">
               <a:ext uri="{FF2B5EF4-FFF2-40B4-BE49-F238E27FC236}">
-                <a16:creationId xmlns:a16="http://schemas.microsoft.com/office/drawing/2014/main" id="{9002DCF9-2C2B-4281-A28A-3E3437622966}"/>
+                <a16:creationId xmlns:a16="http://schemas.microsoft.com/office/drawing/2014/main" id="{60EC6AC6-3711-4140-8904-6525632228CD}"/>
               </a:ext>
             </a:extLst>
           </p:cNvPr>
@@ -1097,7 +1097,7 @@
           <p:cNvPr id="3" name="">
             <a:extLst xmlns:a="http://schemas.openxmlformats.org/drawingml/2006/main">
               <a:ext uri="{FF2B5EF4-FFF2-40B4-BE49-F238E27FC236}">
-                <a16:creationId xmlns:a16="http://schemas.microsoft.com/office/drawing/2014/main" id="{34ABB45B-2395-4206-9F1D-FA213348ED9F}"/>
+                <a16:creationId xmlns:a16="http://schemas.microsoft.com/office/drawing/2014/main" id="{0FA2B47F-7C60-4817-A669-58B76A36B421}"/>
               </a:ext>
             </a:extLst>
           </p:cNvPr>
@@ -1154,7 +1154,7 @@
           <p:cNvPr id="4" name="">
             <a:extLst xmlns:a="http://schemas.openxmlformats.org/drawingml/2006/main">
               <a:ext uri="{FF2B5EF4-FFF2-40B4-BE49-F238E27FC236}">
-                <a16:creationId xmlns:a16="http://schemas.microsoft.com/office/drawing/2014/main" id="{5A1F7487-B277-4FED-805A-26C08DA5DD40}"/>
+                <a16:creationId xmlns:a16="http://schemas.microsoft.com/office/drawing/2014/main" id="{72829B63-058D-4FFC-A9D5-1FA344EB77CB}"/>
               </a:ext>
             </a:extLst>
           </p:cNvPr>
@@ -1566,7 +1566,7 @@
     </p:spTree>
     <p:extLst>
       <p:ext uri="{BB962C8B-B14F-4D97-AF65-F5344CB8AC3E}">
-        <p14:creationId xmlns:p14="http://schemas.microsoft.com/office/powerpoint/2010/main" val="284554763"/>
+        <p14:creationId xmlns:p14="http://schemas.microsoft.com/office/powerpoint/2010/main" val="573810268"/>
       </p:ext>
     </p:extLst>
   </p:cSld>
@@ -1597,7 +1597,7 @@
           <p:cNvPr id="17" name="">
             <a:extLst xmlns:a="http://schemas.openxmlformats.org/drawingml/2006/main">
               <a:ext uri="{FF2B5EF4-FFF2-40B4-BE49-F238E27FC236}">
-                <a16:creationId xmlns:a16="http://schemas.microsoft.com/office/drawing/2014/main" id="{4739A7F1-8656-4254-9701-296F90B78597}"/>
+                <a16:creationId xmlns:a16="http://schemas.microsoft.com/office/drawing/2014/main" id="{DDFD68C6-2833-4DB1-B462-897A2BE8B65F}"/>
               </a:ext>
             </a:extLst>
           </p:cNvPr>
@@ -1654,7 +1654,7 @@
           <p:cNvPr id="2" name="">
             <a:extLst xmlns:a="http://schemas.openxmlformats.org/drawingml/2006/main">
               <a:ext uri="{FF2B5EF4-FFF2-40B4-BE49-F238E27FC236}">
-                <a16:creationId xmlns:a16="http://schemas.microsoft.com/office/drawing/2014/main" id="{066855E6-2273-4C73-88F4-055AD4EF9706}"/>
+                <a16:creationId xmlns:a16="http://schemas.microsoft.com/office/drawing/2014/main" id="{FA3F4A08-A164-43E6-8B99-D21CD762ACD7}"/>
               </a:ext>
             </a:extLst>
           </p:cNvPr>
@@ -1711,7 +1711,7 @@
           <p:cNvPr id="3" name="">
             <a:extLst xmlns:a="http://schemas.openxmlformats.org/drawingml/2006/main">
               <a:ext uri="{FF2B5EF4-FFF2-40B4-BE49-F238E27FC236}">
-                <a16:creationId xmlns:a16="http://schemas.microsoft.com/office/drawing/2014/main" id="{F769555E-9913-4882-A2B7-07EF127E5499}"/>
+                <a16:creationId xmlns:a16="http://schemas.microsoft.com/office/drawing/2014/main" id="{6FD0C6A7-CD7E-42BC-BF01-62B4378E3530}"/>
               </a:ext>
             </a:extLst>
           </p:cNvPr>
@@ -1768,7 +1768,7 @@
           <p:cNvPr id="4" name="">
             <a:extLst xmlns:a="http://schemas.openxmlformats.org/drawingml/2006/main">
               <a:ext uri="{FF2B5EF4-FFF2-40B4-BE49-F238E27FC236}">
-                <a16:creationId xmlns:a16="http://schemas.microsoft.com/office/drawing/2014/main" id="{345CD311-FDF0-446C-9E3B-95D41E892E90}"/>
+                <a16:creationId xmlns:a16="http://schemas.microsoft.com/office/drawing/2014/main" id="{61B48FED-F5B9-4605-98F2-79EE34D331E4}"/>
               </a:ext>
             </a:extLst>
           </p:cNvPr>
@@ -1825,7 +1825,7 @@
           <p:cNvPr id="5" name="">
             <a:extLst xmlns:a="http://schemas.openxmlformats.org/drawingml/2006/main">
               <a:ext uri="{FF2B5EF4-FFF2-40B4-BE49-F238E27FC236}">
-                <a16:creationId xmlns:a16="http://schemas.microsoft.com/office/drawing/2014/main" id="{CF7005A7-3B01-40F4-A783-AD8640306483}"/>
+                <a16:creationId xmlns:a16="http://schemas.microsoft.com/office/drawing/2014/main" id="{F5D2DCED-540A-419B-BBD8-AC692D724B54}"/>
               </a:ext>
             </a:extLst>
           </p:cNvPr>
@@ -1882,7 +1882,7 @@
           <p:cNvPr id="6" name="">
             <a:extLst xmlns:a="http://schemas.openxmlformats.org/drawingml/2006/main">
               <a:ext uri="{FF2B5EF4-FFF2-40B4-BE49-F238E27FC236}">
-                <a16:creationId xmlns:a16="http://schemas.microsoft.com/office/drawing/2014/main" id="{026FE924-BD19-415D-A330-252FDA587CC3}"/>
+                <a16:creationId xmlns:a16="http://schemas.microsoft.com/office/drawing/2014/main" id="{85AB7043-CB28-41FB-9141-3CD9A78CD500}"/>
               </a:ext>
             </a:extLst>
           </p:cNvPr>
@@ -1911,7 +1911,7 @@
           <p:cNvPr id="7" name="">
             <a:extLst xmlns:a="http://schemas.openxmlformats.org/drawingml/2006/main">
               <a:ext uri="{FF2B5EF4-FFF2-40B4-BE49-F238E27FC236}">
-                <a16:creationId xmlns:a16="http://schemas.microsoft.com/office/drawing/2014/main" id="{DCFF365D-98EE-4A4A-A9E7-6A7B7F6E7623}"/>
+                <a16:creationId xmlns:a16="http://schemas.microsoft.com/office/drawing/2014/main" id="{9B919CC4-85F2-4171-9C01-2E0E413D74B4}"/>
               </a:ext>
             </a:extLst>
           </p:cNvPr>
@@ -1968,7 +1968,7 @@
           <p:cNvPr id="8" name="">
             <a:extLst xmlns:a="http://schemas.openxmlformats.org/drawingml/2006/main">
               <a:ext uri="{FF2B5EF4-FFF2-40B4-BE49-F238E27FC236}">
-                <a16:creationId xmlns:a16="http://schemas.microsoft.com/office/drawing/2014/main" id="{74E8CCC5-1AA3-41E8-81BD-FF7036BEBDC3}"/>
+                <a16:creationId xmlns:a16="http://schemas.microsoft.com/office/drawing/2014/main" id="{A6FCD865-F750-42BE-8BD5-2A4531A23785}"/>
               </a:ext>
             </a:extLst>
           </p:cNvPr>
@@ -2025,7 +2025,7 @@
           <p:cNvPr id="9" name="">
             <a:extLst xmlns:a="http://schemas.openxmlformats.org/drawingml/2006/main">
               <a:ext uri="{FF2B5EF4-FFF2-40B4-BE49-F238E27FC236}">
-                <a16:creationId xmlns:a16="http://schemas.microsoft.com/office/drawing/2014/main" id="{02073927-9BB1-4E6C-A3AD-BFA7C7A2E5F1}"/>
+                <a16:creationId xmlns:a16="http://schemas.microsoft.com/office/drawing/2014/main" id="{EFE0D82E-6D7F-4410-8838-2074C10753FD}"/>
               </a:ext>
             </a:extLst>
           </p:cNvPr>
@@ -2082,7 +2082,7 @@
           <p:cNvPr id="10" name="">
             <a:extLst xmlns:a="http://schemas.openxmlformats.org/drawingml/2006/main">
               <a:ext uri="{FF2B5EF4-FFF2-40B4-BE49-F238E27FC236}">
-                <a16:creationId xmlns:a16="http://schemas.microsoft.com/office/drawing/2014/main" id="{C9182292-7BC1-40CA-99DC-78DAABB4453B}"/>
+                <a16:creationId xmlns:a16="http://schemas.microsoft.com/office/drawing/2014/main" id="{29EDA83C-CF3F-4B4F-8291-CC735229CB25}"/>
               </a:ext>
             </a:extLst>
           </p:cNvPr>
@@ -2139,7 +2139,7 @@
           <p:cNvPr id="11" name="">
             <a:extLst xmlns:a="http://schemas.openxmlformats.org/drawingml/2006/main">
               <a:ext uri="{FF2B5EF4-FFF2-40B4-BE49-F238E27FC236}">
-                <a16:creationId xmlns:a16="http://schemas.microsoft.com/office/drawing/2014/main" id="{ABAC7DC1-9675-45A9-BA6A-2B3A34D13E58}"/>
+                <a16:creationId xmlns:a16="http://schemas.microsoft.com/office/drawing/2014/main" id="{00E13638-A0B0-4884-89FD-590D48A0A7DD}"/>
               </a:ext>
             </a:extLst>
           </p:cNvPr>
@@ -2168,7 +2168,7 @@
           <p:cNvPr id="12" name="">
             <a:extLst xmlns:a="http://schemas.openxmlformats.org/drawingml/2006/main">
               <a:ext uri="{FF2B5EF4-FFF2-40B4-BE49-F238E27FC236}">
-                <a16:creationId xmlns:a16="http://schemas.microsoft.com/office/drawing/2014/main" id="{8AE41C2D-D195-4D6F-8786-F1461927C9EA}"/>
+                <a16:creationId xmlns:a16="http://schemas.microsoft.com/office/drawing/2014/main" id="{CB893A15-B7FB-40CC-96F3-76B73F5D8EB6}"/>
               </a:ext>
             </a:extLst>
           </p:cNvPr>
@@ -2225,7 +2225,7 @@
           <p:cNvPr id="13" name="">
             <a:extLst xmlns:a="http://schemas.openxmlformats.org/drawingml/2006/main">
               <a:ext uri="{FF2B5EF4-FFF2-40B4-BE49-F238E27FC236}">
-                <a16:creationId xmlns:a16="http://schemas.microsoft.com/office/drawing/2014/main" id="{E9B645D9-71EF-44F3-AC34-8EF5AFF41FB5}"/>
+                <a16:creationId xmlns:a16="http://schemas.microsoft.com/office/drawing/2014/main" id="{BD2FBDFE-CB11-4C35-BB07-DAF602A81EF7}"/>
               </a:ext>
             </a:extLst>
           </p:cNvPr>
@@ -2282,7 +2282,7 @@
           <p:cNvPr id="14" name="">
             <a:extLst xmlns:a="http://schemas.openxmlformats.org/drawingml/2006/main">
               <a:ext uri="{FF2B5EF4-FFF2-40B4-BE49-F238E27FC236}">
-                <a16:creationId xmlns:a16="http://schemas.microsoft.com/office/drawing/2014/main" id="{EAC29816-8B17-4F06-8F31-A2D03385B137}"/>
+                <a16:creationId xmlns:a16="http://schemas.microsoft.com/office/drawing/2014/main" id="{73F5AB52-7F41-4F3B-B0B2-7649C9AB59CC}"/>
               </a:ext>
             </a:extLst>
           </p:cNvPr>
@@ -2625,7 +2625,7 @@
           <p:cNvPr id="16" name="">
             <a:extLst xmlns:a="http://schemas.openxmlformats.org/drawingml/2006/main">
               <a:ext uri="{FF2B5EF4-FFF2-40B4-BE49-F238E27FC236}">
-                <a16:creationId xmlns:a16="http://schemas.microsoft.com/office/drawing/2014/main" id="{AE62C9A8-D667-4B8F-84A4-B7FD2A2BCB0B}"/>
+                <a16:creationId xmlns:a16="http://schemas.microsoft.com/office/drawing/2014/main" id="{EFF4FB92-EBB4-4360-B2AE-62A3E4D87C09}"/>
               </a:ext>
             </a:extLst>
           </p:cNvPr>
@@ -2703,7 +2703,7 @@
     </p:spTree>
     <p:extLst>
       <p:ext uri="{BB962C8B-B14F-4D97-AF65-F5344CB8AC3E}">
-        <p14:creationId xmlns:p14="http://schemas.microsoft.com/office/powerpoint/2010/main" val="912230454"/>
+        <p14:creationId xmlns:p14="http://schemas.microsoft.com/office/powerpoint/2010/main" val="1312984157"/>
       </p:ext>
     </p:extLst>
   </p:cSld>
@@ -2734,7 +2734,7 @@
           <p:cNvPr id="12" name="">
             <a:extLst xmlns:a="http://schemas.openxmlformats.org/drawingml/2006/main">
               <a:ext uri="{FF2B5EF4-FFF2-40B4-BE49-F238E27FC236}">
-                <a16:creationId xmlns:a16="http://schemas.microsoft.com/office/drawing/2014/main" id="{5C8E6EC2-31F3-4035-9346-B501394FB6BB}"/>
+                <a16:creationId xmlns:a16="http://schemas.microsoft.com/office/drawing/2014/main" id="{13270DC5-5AC3-42F8-94DA-0F69DD8F95BA}"/>
               </a:ext>
             </a:extLst>
           </p:cNvPr>
@@ -2791,7 +2791,7 @@
           <p:cNvPr id="2" name="">
             <a:extLst xmlns:a="http://schemas.openxmlformats.org/drawingml/2006/main">
               <a:ext uri="{FF2B5EF4-FFF2-40B4-BE49-F238E27FC236}">
-                <a16:creationId xmlns:a16="http://schemas.microsoft.com/office/drawing/2014/main" id="{9A4AD195-AD4B-40A6-B989-1D15AEFE0986}"/>
+                <a16:creationId xmlns:a16="http://schemas.microsoft.com/office/drawing/2014/main" id="{DA96CC09-3819-4C5B-AA7F-9A6B23B53D90}"/>
               </a:ext>
             </a:extLst>
           </p:cNvPr>
@@ -2848,7 +2848,7 @@
           <p:cNvPr id="3" name="">
             <a:extLst xmlns:a="http://schemas.openxmlformats.org/drawingml/2006/main">
               <a:ext uri="{FF2B5EF4-FFF2-40B4-BE49-F238E27FC236}">
-                <a16:creationId xmlns:a16="http://schemas.microsoft.com/office/drawing/2014/main" id="{FA2FA11F-14ED-47AE-83FE-90D12918E02E}"/>
+                <a16:creationId xmlns:a16="http://schemas.microsoft.com/office/drawing/2014/main" id="{B4C0DF9D-BFD2-471B-82C8-6025FBE5D778}"/>
               </a:ext>
             </a:extLst>
           </p:cNvPr>
@@ -2905,7 +2905,7 @@
           <p:cNvPr id="4" name="">
             <a:extLst xmlns:a="http://schemas.openxmlformats.org/drawingml/2006/main">
               <a:ext uri="{FF2B5EF4-FFF2-40B4-BE49-F238E27FC236}">
-                <a16:creationId xmlns:a16="http://schemas.microsoft.com/office/drawing/2014/main" id="{9142C96A-3CE7-49FC-AFDB-F746BBC5725C}"/>
+                <a16:creationId xmlns:a16="http://schemas.microsoft.com/office/drawing/2014/main" id="{96E901F3-205B-4B68-9314-0B627065A2F1}"/>
               </a:ext>
             </a:extLst>
           </p:cNvPr>
@@ -2969,7 +2969,7 @@
         </p:xfrm>
         <a:graphic xmlns:a="http://schemas.openxmlformats.org/drawingml/2006/main">
           <a:graphicData uri="http://schemas.openxmlformats.org/drawingml/2006/chart">
-            <c:chart xmlns:r="http://schemas.openxmlformats.org/officeDocument/2006/relationships" xmlns:c="http://schemas.openxmlformats.org/drawingml/2006/chart" r:id="Rd7f09683c6344652"/>
+            <c:chart xmlns:r="http://schemas.openxmlformats.org/officeDocument/2006/relationships" xmlns:c="http://schemas.openxmlformats.org/drawingml/2006/chart" r:id="R3da263465cde4fcb"/>
           </a:graphicData>
         </a:graphic>
       </p:graphicFrame>
@@ -2978,7 +2978,7 @@
           <p:cNvPr id="6" name="">
             <a:extLst xmlns:a="http://schemas.openxmlformats.org/drawingml/2006/main">
               <a:ext uri="{FF2B5EF4-FFF2-40B4-BE49-F238E27FC236}">
-                <a16:creationId xmlns:a16="http://schemas.microsoft.com/office/drawing/2014/main" id="{9C7BE111-CC24-4F7E-BE86-D30BA340E39B}"/>
+                <a16:creationId xmlns:a16="http://schemas.microsoft.com/office/drawing/2014/main" id="{27818D9F-C4D2-4F6A-BA72-08CAE5BA6018}"/>
               </a:ext>
             </a:extLst>
           </p:cNvPr>
@@ -3008,7 +3008,7 @@
           <p:cNvPr id="7" name="">
             <a:extLst xmlns:a="http://schemas.openxmlformats.org/drawingml/2006/main">
               <a:ext uri="{FF2B5EF4-FFF2-40B4-BE49-F238E27FC236}">
-                <a16:creationId xmlns:a16="http://schemas.microsoft.com/office/drawing/2014/main" id="{E7EA94A8-E4C8-4D2D-B420-2B072FD3C222}"/>
+                <a16:creationId xmlns:a16="http://schemas.microsoft.com/office/drawing/2014/main" id="{4704AF32-FB84-45A9-81B6-A3F6EB86827D}"/>
               </a:ext>
             </a:extLst>
           </p:cNvPr>
@@ -3065,7 +3065,7 @@
           <p:cNvPr id="8" name="">
             <a:extLst xmlns:a="http://schemas.openxmlformats.org/drawingml/2006/main">
               <a:ext uri="{FF2B5EF4-FFF2-40B4-BE49-F238E27FC236}">
-                <a16:creationId xmlns:a16="http://schemas.microsoft.com/office/drawing/2014/main" id="{A2E9DE57-5E6E-4250-9F40-244987335A79}"/>
+                <a16:creationId xmlns:a16="http://schemas.microsoft.com/office/drawing/2014/main" id="{90F23125-7B6D-4A3C-B6B8-02D2D22214D2}"/>
               </a:ext>
             </a:extLst>
           </p:cNvPr>
@@ -3095,7 +3095,7 @@
           <p:cNvPr id="9" name="">
             <a:extLst xmlns:a="http://schemas.openxmlformats.org/drawingml/2006/main">
               <a:ext uri="{FF2B5EF4-FFF2-40B4-BE49-F238E27FC236}">
-                <a16:creationId xmlns:a16="http://schemas.microsoft.com/office/drawing/2014/main" id="{614EDB17-6B04-42FD-A061-4C267BFC875B}"/>
+                <a16:creationId xmlns:a16="http://schemas.microsoft.com/office/drawing/2014/main" id="{C38B7DB9-949F-4C2C-9FC5-8DAB905F81C8}"/>
               </a:ext>
             </a:extLst>
           </p:cNvPr>
@@ -3152,7 +3152,7 @@
           <p:cNvPr id="10" name="">
             <a:extLst xmlns:a="http://schemas.openxmlformats.org/drawingml/2006/main">
               <a:ext uri="{FF2B5EF4-FFF2-40B4-BE49-F238E27FC236}">
-                <a16:creationId xmlns:a16="http://schemas.microsoft.com/office/drawing/2014/main" id="{56E8268C-4E47-426E-9D81-568A89D3B4ED}"/>
+                <a16:creationId xmlns:a16="http://schemas.microsoft.com/office/drawing/2014/main" id="{0DCF4F92-D749-49EA-A271-7901241AB2A2}"/>
               </a:ext>
             </a:extLst>
           </p:cNvPr>
@@ -3213,7 +3213,7 @@
           <p:cNvPr id="11" name="">
             <a:extLst xmlns:a="http://schemas.openxmlformats.org/drawingml/2006/main">
               <a:ext uri="{FF2B5EF4-FFF2-40B4-BE49-F238E27FC236}">
-                <a16:creationId xmlns:a16="http://schemas.microsoft.com/office/drawing/2014/main" id="{496F0C23-7281-4EFF-9040-535900A97197}"/>
+                <a16:creationId xmlns:a16="http://schemas.microsoft.com/office/drawing/2014/main" id="{9C7E8306-34BF-41A0-B942-707D9A927537}"/>
               </a:ext>
             </a:extLst>
           </p:cNvPr>
@@ -3260,7 +3260,7 @@
                 <a:ea typeface="Arial"/>
                 <a:cs typeface="Arial"/>
               </a:rPr>
-              <a:t>Across 20 discovery splits: CatBoost selected 13 times, logistic 7.</a:t>
+              <a:t>Follow-up screening selections across 20 discovery splits: CatBoost 13, logistic 7.</a:t>
             </a:r>
           </a:p>
         </p:txBody>
@@ -3268,7 +3268,7 @@
     </p:spTree>
     <p:extLst>
       <p:ext uri="{BB962C8B-B14F-4D97-AF65-F5344CB8AC3E}">
-        <p14:creationId xmlns:p14="http://schemas.microsoft.com/office/powerpoint/2010/main" val="1750877085"/>
+        <p14:creationId xmlns:p14="http://schemas.microsoft.com/office/powerpoint/2010/main" val="305746940"/>
       </p:ext>
     </p:extLst>
   </p:cSld>
@@ -3299,7 +3299,7 @@
           <p:cNvPr id="4" name="">
             <a:extLst xmlns:a="http://schemas.openxmlformats.org/drawingml/2006/main">
               <a:ext uri="{FF2B5EF4-FFF2-40B4-BE49-F238E27FC236}">
-                <a16:creationId xmlns:a16="http://schemas.microsoft.com/office/drawing/2014/main" id="{C69A5426-B04F-4300-B53F-51226A6AEABE}"/>
+                <a16:creationId xmlns:a16="http://schemas.microsoft.com/office/drawing/2014/main" id="{59ED9233-E711-4DE2-8D6F-88A260B19AC5}"/>
               </a:ext>
             </a:extLst>
           </p:cNvPr>
@@ -3356,7 +3356,7 @@
           <p:cNvPr id="2" name="">
             <a:extLst xmlns:a="http://schemas.openxmlformats.org/drawingml/2006/main">
               <a:ext uri="{FF2B5EF4-FFF2-40B4-BE49-F238E27FC236}">
-                <a16:creationId xmlns:a16="http://schemas.microsoft.com/office/drawing/2014/main" id="{DEA39A17-67EB-486C-9C9C-F4920F3DBF18}"/>
+                <a16:creationId xmlns:a16="http://schemas.microsoft.com/office/drawing/2014/main" id="{F02AD4FA-32F8-4BE7-BD4E-25A7D74E1055}"/>
               </a:ext>
             </a:extLst>
           </p:cNvPr>
@@ -3413,7 +3413,7 @@
           <p:cNvPr id="3" name="">
             <a:extLst xmlns:a="http://schemas.openxmlformats.org/drawingml/2006/main">
               <a:ext uri="{FF2B5EF4-FFF2-40B4-BE49-F238E27FC236}">
-                <a16:creationId xmlns:a16="http://schemas.microsoft.com/office/drawing/2014/main" id="{153F1898-AD1B-4D73-AB61-245DF1B24B4F}"/>
+                <a16:creationId xmlns:a16="http://schemas.microsoft.com/office/drawing/2014/main" id="{9E24FAC0-F59E-44AC-B20D-42FABB957BA6}"/>
               </a:ext>
             </a:extLst>
           </p:cNvPr>
@@ -3468,7 +3468,7 @@
     </p:spTree>
     <p:extLst>
       <p:ext uri="{BB962C8B-B14F-4D97-AF65-F5344CB8AC3E}">
-        <p14:creationId xmlns:p14="http://schemas.microsoft.com/office/powerpoint/2010/main" val="1091844925"/>
+        <p14:creationId xmlns:p14="http://schemas.microsoft.com/office/powerpoint/2010/main" val="340105872"/>
       </p:ext>
     </p:extLst>
   </p:cSld>
@@ -3499,7 +3499,7 @@
           <p:cNvPr id="9" name="">
             <a:extLst xmlns:a="http://schemas.openxmlformats.org/drawingml/2006/main">
               <a:ext uri="{FF2B5EF4-FFF2-40B4-BE49-F238E27FC236}">
-                <a16:creationId xmlns:a16="http://schemas.microsoft.com/office/drawing/2014/main" id="{A980FE43-807B-4742-BCCE-854C510A4549}"/>
+                <a16:creationId xmlns:a16="http://schemas.microsoft.com/office/drawing/2014/main" id="{32AFC8B9-3661-4B76-8396-F344D0CE0D78}"/>
               </a:ext>
             </a:extLst>
           </p:cNvPr>
@@ -3556,7 +3556,7 @@
           <p:cNvPr id="2" name="">
             <a:extLst xmlns:a="http://schemas.openxmlformats.org/drawingml/2006/main">
               <a:ext uri="{FF2B5EF4-FFF2-40B4-BE49-F238E27FC236}">
-                <a16:creationId xmlns:a16="http://schemas.microsoft.com/office/drawing/2014/main" id="{9E92B173-B533-4038-B622-B2FB2BC5F3AB}"/>
+                <a16:creationId xmlns:a16="http://schemas.microsoft.com/office/drawing/2014/main" id="{19D194F2-79B6-4474-A94F-50FCA779AC36}"/>
               </a:ext>
             </a:extLst>
           </p:cNvPr>
@@ -3613,7 +3613,7 @@
           <p:cNvPr id="3" name="">
             <a:extLst xmlns:a="http://schemas.openxmlformats.org/drawingml/2006/main">
               <a:ext uri="{FF2B5EF4-FFF2-40B4-BE49-F238E27FC236}">
-                <a16:creationId xmlns:a16="http://schemas.microsoft.com/office/drawing/2014/main" id="{67BAAEF5-C09C-4C45-BAEE-29E60923F65F}"/>
+                <a16:creationId xmlns:a16="http://schemas.microsoft.com/office/drawing/2014/main" id="{CCB6C3CB-CFAC-4452-90A8-AC00B62A1940}"/>
               </a:ext>
             </a:extLst>
           </p:cNvPr>
@@ -3670,7 +3670,7 @@
           <p:cNvPr id="4" name="">
             <a:extLst xmlns:a="http://schemas.openxmlformats.org/drawingml/2006/main">
               <a:ext uri="{FF2B5EF4-FFF2-40B4-BE49-F238E27FC236}">
-                <a16:creationId xmlns:a16="http://schemas.microsoft.com/office/drawing/2014/main" id="{E1710BEF-9EEC-45EA-9B8E-D44AAA0A9B95}"/>
+                <a16:creationId xmlns:a16="http://schemas.microsoft.com/office/drawing/2014/main" id="{F036F871-2BB1-44DD-A309-A77C3F85C588}"/>
               </a:ext>
             </a:extLst>
           </p:cNvPr>
@@ -3727,7 +3727,7 @@
           <p:cNvPr id="5" name="">
             <a:extLst xmlns:a="http://schemas.openxmlformats.org/drawingml/2006/main">
               <a:ext uri="{FF2B5EF4-FFF2-40B4-BE49-F238E27FC236}">
-                <a16:creationId xmlns:a16="http://schemas.microsoft.com/office/drawing/2014/main" id="{7F059A08-0788-4AB3-B4F1-851B990DC589}"/>
+                <a16:creationId xmlns:a16="http://schemas.microsoft.com/office/drawing/2014/main" id="{9A27C6C6-B17A-42AC-8EEF-7718CE60CC7F}"/>
               </a:ext>
             </a:extLst>
           </p:cNvPr>
@@ -3807,7 +3807,7 @@
           <p:cNvPr id="6" name="">
             <a:extLst xmlns:a="http://schemas.openxmlformats.org/drawingml/2006/main">
               <a:ext uri="{FF2B5EF4-FFF2-40B4-BE49-F238E27FC236}">
-                <a16:creationId xmlns:a16="http://schemas.microsoft.com/office/drawing/2014/main" id="{79BE1B5A-2FA5-4AC3-A9D2-C8197DC60080}"/>
+                <a16:creationId xmlns:a16="http://schemas.microsoft.com/office/drawing/2014/main" id="{21E7E826-C1D8-467D-9624-8D9E99E30336}"/>
               </a:ext>
             </a:extLst>
           </p:cNvPr>
@@ -3836,7 +3836,7 @@
           <p:cNvPr id="7" name="">
             <a:extLst xmlns:a="http://schemas.openxmlformats.org/drawingml/2006/main">
               <a:ext uri="{FF2B5EF4-FFF2-40B4-BE49-F238E27FC236}">
-                <a16:creationId xmlns:a16="http://schemas.microsoft.com/office/drawing/2014/main" id="{94D1DC89-53B2-4B91-B60F-B29F4EC478D9}"/>
+                <a16:creationId xmlns:a16="http://schemas.microsoft.com/office/drawing/2014/main" id="{A62B7C18-567D-4EA2-AD49-3276E40441EE}"/>
               </a:ext>
             </a:extLst>
           </p:cNvPr>
@@ -3893,7 +3893,7 @@
           <p:cNvPr id="8" name="">
             <a:extLst xmlns:a="http://schemas.openxmlformats.org/drawingml/2006/main">
               <a:ext uri="{FF2B5EF4-FFF2-40B4-BE49-F238E27FC236}">
-                <a16:creationId xmlns:a16="http://schemas.microsoft.com/office/drawing/2014/main" id="{2FDF0F0D-D727-49D4-81CA-1EE12BA07B54}"/>
+                <a16:creationId xmlns:a16="http://schemas.microsoft.com/office/drawing/2014/main" id="{752D35D5-3534-448A-97FE-BA5BCED6AE67}"/>
               </a:ext>
             </a:extLst>
           </p:cNvPr>
@@ -3971,7 +3971,7 @@
     </p:spTree>
     <p:extLst>
       <p:ext uri="{BB962C8B-B14F-4D97-AF65-F5344CB8AC3E}">
-        <p14:creationId xmlns:p14="http://schemas.microsoft.com/office/powerpoint/2010/main" val="1607663596"/>
+        <p14:creationId xmlns:p14="http://schemas.microsoft.com/office/powerpoint/2010/main" val="405358652"/>
       </p:ext>
     </p:extLst>
   </p:cSld>
@@ -4002,7 +4002,7 @@
           <p:cNvPr id="8" name="">
             <a:extLst xmlns:a="http://schemas.openxmlformats.org/drawingml/2006/main">
               <a:ext uri="{FF2B5EF4-FFF2-40B4-BE49-F238E27FC236}">
-                <a16:creationId xmlns:a16="http://schemas.microsoft.com/office/drawing/2014/main" id="{CA76857C-FCFC-4198-8D20-06F13949F4EB}"/>
+                <a16:creationId xmlns:a16="http://schemas.microsoft.com/office/drawing/2014/main" id="{307D6D15-6760-4258-B568-E5D44FFC7190}"/>
               </a:ext>
             </a:extLst>
           </p:cNvPr>
@@ -4059,7 +4059,7 @@
           <p:cNvPr id="2" name="">
             <a:extLst xmlns:a="http://schemas.openxmlformats.org/drawingml/2006/main">
               <a:ext uri="{FF2B5EF4-FFF2-40B4-BE49-F238E27FC236}">
-                <a16:creationId xmlns:a16="http://schemas.microsoft.com/office/drawing/2014/main" id="{84D2937C-5BAB-4401-B4C2-9A5FCDA822A4}"/>
+                <a16:creationId xmlns:a16="http://schemas.microsoft.com/office/drawing/2014/main" id="{89D74DD0-31A8-4B4A-90CC-9C4CEEB45C8A}"/>
               </a:ext>
             </a:extLst>
           </p:cNvPr>
@@ -4116,7 +4116,7 @@
           <p:cNvPr id="3" name="">
             <a:extLst xmlns:a="http://schemas.openxmlformats.org/drawingml/2006/main">
               <a:ext uri="{FF2B5EF4-FFF2-40B4-BE49-F238E27FC236}">
-                <a16:creationId xmlns:a16="http://schemas.microsoft.com/office/drawing/2014/main" id="{6F17A776-DE48-4B28-B9C3-B74FB9078909}"/>
+                <a16:creationId xmlns:a16="http://schemas.microsoft.com/office/drawing/2014/main" id="{4ECCAD31-B16F-4E7B-A383-1369A18B611A}"/>
               </a:ext>
             </a:extLst>
           </p:cNvPr>
@@ -4173,7 +4173,7 @@
           <p:cNvPr id="4" name="">
             <a:extLst xmlns:a="http://schemas.openxmlformats.org/drawingml/2006/main">
               <a:ext uri="{FF2B5EF4-FFF2-40B4-BE49-F238E27FC236}">
-                <a16:creationId xmlns:a16="http://schemas.microsoft.com/office/drawing/2014/main" id="{8D2B2CCD-BA95-4351-8FF4-7176765E72BE}"/>
+                <a16:creationId xmlns:a16="http://schemas.microsoft.com/office/drawing/2014/main" id="{B931218D-E9EB-4B22-BE44-3B682E99AD3B}"/>
               </a:ext>
             </a:extLst>
           </p:cNvPr>
@@ -4230,7 +4230,7 @@
           <p:cNvPr id="5" name="">
             <a:extLst xmlns:a="http://schemas.openxmlformats.org/drawingml/2006/main">
               <a:ext uri="{FF2B5EF4-FFF2-40B4-BE49-F238E27FC236}">
-                <a16:creationId xmlns:a16="http://schemas.microsoft.com/office/drawing/2014/main" id="{EF4D9A95-A095-40E5-8059-9DB63F7F7E0C}"/>
+                <a16:creationId xmlns:a16="http://schemas.microsoft.com/office/drawing/2014/main" id="{D6D9F45F-48A1-4696-B7A4-97DC2961C833}"/>
               </a:ext>
             </a:extLst>
           </p:cNvPr>
@@ -4287,7 +4287,7 @@
           <p:cNvPr id="6" name="">
             <a:extLst xmlns:a="http://schemas.openxmlformats.org/drawingml/2006/main">
               <a:ext uri="{FF2B5EF4-FFF2-40B4-BE49-F238E27FC236}">
-                <a16:creationId xmlns:a16="http://schemas.microsoft.com/office/drawing/2014/main" id="{4EC37699-C424-45B8-9F89-6E33858EBB42}"/>
+                <a16:creationId xmlns:a16="http://schemas.microsoft.com/office/drawing/2014/main" id="{9C701502-21B5-4E84-B84F-DFB545703F79}"/>
               </a:ext>
             </a:extLst>
           </p:cNvPr>
@@ -4344,7 +4344,7 @@
           <p:cNvPr id="7" name="">
             <a:extLst xmlns:a="http://schemas.openxmlformats.org/drawingml/2006/main">
               <a:ext uri="{FF2B5EF4-FFF2-40B4-BE49-F238E27FC236}">
-                <a16:creationId xmlns:a16="http://schemas.microsoft.com/office/drawing/2014/main" id="{B046639D-A9B4-4BEF-AB28-65B490A5E5F9}"/>
+                <a16:creationId xmlns:a16="http://schemas.microsoft.com/office/drawing/2014/main" id="{7C41AA78-848E-4EDD-875A-99A399A8865A}"/>
               </a:ext>
             </a:extLst>
           </p:cNvPr>
@@ -4399,7 +4399,7 @@
     </p:spTree>
     <p:extLst>
       <p:ext uri="{BB962C8B-B14F-4D97-AF65-F5344CB8AC3E}">
-        <p14:creationId xmlns:p14="http://schemas.microsoft.com/office/powerpoint/2010/main" val="1513283384"/>
+        <p14:creationId xmlns:p14="http://schemas.microsoft.com/office/powerpoint/2010/main" val="576648320"/>
       </p:ext>
     </p:extLst>
   </p:cSld>
@@ -4430,7 +4430,7 @@
           <p:cNvPr id="9" name="">
             <a:extLst xmlns:a="http://schemas.openxmlformats.org/drawingml/2006/main">
               <a:ext uri="{FF2B5EF4-FFF2-40B4-BE49-F238E27FC236}">
-                <a16:creationId xmlns:a16="http://schemas.microsoft.com/office/drawing/2014/main" id="{E9E3CE2B-AA48-4CE5-A97D-932CC25947C1}"/>
+                <a16:creationId xmlns:a16="http://schemas.microsoft.com/office/drawing/2014/main" id="{05934B30-F0D9-4634-99E9-5D41D0BCD911}"/>
               </a:ext>
             </a:extLst>
           </p:cNvPr>
@@ -4487,7 +4487,7 @@
           <p:cNvPr id="2" name="">
             <a:extLst xmlns:a="http://schemas.openxmlformats.org/drawingml/2006/main">
               <a:ext uri="{FF2B5EF4-FFF2-40B4-BE49-F238E27FC236}">
-                <a16:creationId xmlns:a16="http://schemas.microsoft.com/office/drawing/2014/main" id="{3947172C-13AA-474E-88FD-389859DF21F7}"/>
+                <a16:creationId xmlns:a16="http://schemas.microsoft.com/office/drawing/2014/main" id="{BE92FD7A-7429-46F5-8A5C-F8389A4055BB}"/>
               </a:ext>
             </a:extLst>
           </p:cNvPr>
@@ -4544,7 +4544,7 @@
           <p:cNvPr id="3" name="">
             <a:extLst xmlns:a="http://schemas.openxmlformats.org/drawingml/2006/main">
               <a:ext uri="{FF2B5EF4-FFF2-40B4-BE49-F238E27FC236}">
-                <a16:creationId xmlns:a16="http://schemas.microsoft.com/office/drawing/2014/main" id="{F1B3ABC6-AF79-4801-AB10-0BAD1B3F33FB}"/>
+                <a16:creationId xmlns:a16="http://schemas.microsoft.com/office/drawing/2014/main" id="{B5846C47-60FF-4427-8686-BE4737896067}"/>
               </a:ext>
             </a:extLst>
           </p:cNvPr>
@@ -4601,7 +4601,7 @@
           <p:cNvPr id="4" name="">
             <a:extLst xmlns:a="http://schemas.openxmlformats.org/drawingml/2006/main">
               <a:ext uri="{FF2B5EF4-FFF2-40B4-BE49-F238E27FC236}">
-                <a16:creationId xmlns:a16="http://schemas.microsoft.com/office/drawing/2014/main" id="{3D522432-CF2F-400C-ABA1-8558D96CD48A}"/>
+                <a16:creationId xmlns:a16="http://schemas.microsoft.com/office/drawing/2014/main" id="{DBEC1414-65CA-47D9-A074-6BB7E4BD35D5}"/>
               </a:ext>
             </a:extLst>
           </p:cNvPr>
@@ -4658,7 +4658,7 @@
           <p:cNvPr id="5" name="">
             <a:extLst xmlns:a="http://schemas.openxmlformats.org/drawingml/2006/main">
               <a:ext uri="{FF2B5EF4-FFF2-40B4-BE49-F238E27FC236}">
-                <a16:creationId xmlns:a16="http://schemas.microsoft.com/office/drawing/2014/main" id="{EDAB55F9-F91E-4EF5-93C3-2111FC801E13}"/>
+                <a16:creationId xmlns:a16="http://schemas.microsoft.com/office/drawing/2014/main" id="{BDECC472-940E-4CE8-B89C-7C3954F78198}"/>
               </a:ext>
             </a:extLst>
           </p:cNvPr>
@@ -4715,7 +4715,7 @@
           <p:cNvPr id="6" name="">
             <a:extLst xmlns:a="http://schemas.openxmlformats.org/drawingml/2006/main">
               <a:ext uri="{FF2B5EF4-FFF2-40B4-BE49-F238E27FC236}">
-                <a16:creationId xmlns:a16="http://schemas.microsoft.com/office/drawing/2014/main" id="{9B2B7D56-19AA-4FF2-B342-D5BBB62D0E81}"/>
+                <a16:creationId xmlns:a16="http://schemas.microsoft.com/office/drawing/2014/main" id="{F0EE228C-BE5E-4BDD-BD93-6BBACDF88744}"/>
               </a:ext>
             </a:extLst>
           </p:cNvPr>
@@ -4772,7 +4772,7 @@
           <p:cNvPr id="7" name="">
             <a:extLst xmlns:a="http://schemas.openxmlformats.org/drawingml/2006/main">
               <a:ext uri="{FF2B5EF4-FFF2-40B4-BE49-F238E27FC236}">
-                <a16:creationId xmlns:a16="http://schemas.microsoft.com/office/drawing/2014/main" id="{24F88333-DAA8-40E4-A282-F970B5994CAD}"/>
+                <a16:creationId xmlns:a16="http://schemas.microsoft.com/office/drawing/2014/main" id="{1AE21BE2-29CC-4A5A-9CDA-B64A52211C05}"/>
               </a:ext>
             </a:extLst>
           </p:cNvPr>
@@ -4829,7 +4829,7 @@
           <p:cNvPr id="8" name="">
             <a:extLst xmlns:a="http://schemas.openxmlformats.org/drawingml/2006/main">
               <a:ext uri="{FF2B5EF4-FFF2-40B4-BE49-F238E27FC236}">
-                <a16:creationId xmlns:a16="http://schemas.microsoft.com/office/drawing/2014/main" id="{ECFE1E6E-53EF-468B-B466-3F252072A6CA}"/>
+                <a16:creationId xmlns:a16="http://schemas.microsoft.com/office/drawing/2014/main" id="{81AEE26C-CD1C-4939-BF39-5001777D8AEB}"/>
               </a:ext>
             </a:extLst>
           </p:cNvPr>
@@ -4884,7 +4884,7 @@
     </p:spTree>
     <p:extLst>
       <p:ext uri="{BB962C8B-B14F-4D97-AF65-F5344CB8AC3E}">
-        <p14:creationId xmlns:p14="http://schemas.microsoft.com/office/powerpoint/2010/main" val="1441763343"/>
+        <p14:creationId xmlns:p14="http://schemas.microsoft.com/office/powerpoint/2010/main" val="1969791153"/>
       </p:ext>
     </p:extLst>
   </p:cSld>
@@ -4915,7 +4915,7 @@
           <p:cNvPr id="12" name="">
             <a:extLst xmlns:a="http://schemas.openxmlformats.org/drawingml/2006/main">
               <a:ext uri="{FF2B5EF4-FFF2-40B4-BE49-F238E27FC236}">
-                <a16:creationId xmlns:a16="http://schemas.microsoft.com/office/drawing/2014/main" id="{4CB293F1-2271-4BDB-B17C-D5B82D5F0194}"/>
+                <a16:creationId xmlns:a16="http://schemas.microsoft.com/office/drawing/2014/main" id="{D2EA8BD4-567E-42E6-8B21-0CCAEA123245}"/>
               </a:ext>
             </a:extLst>
           </p:cNvPr>
@@ -4972,7 +4972,7 @@
           <p:cNvPr id="2" name="">
             <a:extLst xmlns:a="http://schemas.openxmlformats.org/drawingml/2006/main">
               <a:ext uri="{FF2B5EF4-FFF2-40B4-BE49-F238E27FC236}">
-                <a16:creationId xmlns:a16="http://schemas.microsoft.com/office/drawing/2014/main" id="{A7DA66FC-8CD8-4FEF-B025-051E14A20247}"/>
+                <a16:creationId xmlns:a16="http://schemas.microsoft.com/office/drawing/2014/main" id="{1EE745EA-253C-422C-97CB-B7815CA79FD5}"/>
               </a:ext>
             </a:extLst>
           </p:cNvPr>
@@ -5029,7 +5029,7 @@
           <p:cNvPr id="3" name="">
             <a:extLst xmlns:a="http://schemas.openxmlformats.org/drawingml/2006/main">
               <a:ext uri="{FF2B5EF4-FFF2-40B4-BE49-F238E27FC236}">
-                <a16:creationId xmlns:a16="http://schemas.microsoft.com/office/drawing/2014/main" id="{9E9C4292-573F-4785-986F-09F2D5E84463}"/>
+                <a16:creationId xmlns:a16="http://schemas.microsoft.com/office/drawing/2014/main" id="{2D5F84BD-7FF1-4705-8C4D-02D9BF771D35}"/>
               </a:ext>
             </a:extLst>
           </p:cNvPr>
@@ -5086,7 +5086,7 @@
           <p:cNvPr id="4" name="">
             <a:extLst xmlns:a="http://schemas.openxmlformats.org/drawingml/2006/main">
               <a:ext uri="{FF2B5EF4-FFF2-40B4-BE49-F238E27FC236}">
-                <a16:creationId xmlns:a16="http://schemas.microsoft.com/office/drawing/2014/main" id="{697C47FD-2169-44C9-A15E-16A426E76F8C}"/>
+                <a16:creationId xmlns:a16="http://schemas.microsoft.com/office/drawing/2014/main" id="{4E1FA940-A8DE-4AC7-BB31-725533C90577}"/>
               </a:ext>
             </a:extLst>
           </p:cNvPr>
@@ -5166,7 +5166,7 @@
           <p:cNvPr id="5" name="">
             <a:extLst xmlns:a="http://schemas.openxmlformats.org/drawingml/2006/main">
               <a:ext uri="{FF2B5EF4-FFF2-40B4-BE49-F238E27FC236}">
-                <a16:creationId xmlns:a16="http://schemas.microsoft.com/office/drawing/2014/main" id="{E349854A-4A33-4A90-AEAA-B900834D5637}"/>
+                <a16:creationId xmlns:a16="http://schemas.microsoft.com/office/drawing/2014/main" id="{7930EE56-988B-4564-884E-DBC4AB7032FD}"/>
               </a:ext>
             </a:extLst>
           </p:cNvPr>
@@ -5246,7 +5246,7 @@
           <p:cNvPr id="6" name="">
             <a:extLst xmlns:a="http://schemas.openxmlformats.org/drawingml/2006/main">
               <a:ext uri="{FF2B5EF4-FFF2-40B4-BE49-F238E27FC236}">
-                <a16:creationId xmlns:a16="http://schemas.microsoft.com/office/drawing/2014/main" id="{D926CC53-1725-4049-AC2F-896332E3F44B}"/>
+                <a16:creationId xmlns:a16="http://schemas.microsoft.com/office/drawing/2014/main" id="{5E1314FF-6E04-417B-B2B9-9DBE59EA7130}"/>
               </a:ext>
             </a:extLst>
           </p:cNvPr>
@@ -5275,7 +5275,7 @@
           <p:cNvPr id="7" name="">
             <a:extLst xmlns:a="http://schemas.openxmlformats.org/drawingml/2006/main">
               <a:ext uri="{FF2B5EF4-FFF2-40B4-BE49-F238E27FC236}">
-                <a16:creationId xmlns:a16="http://schemas.microsoft.com/office/drawing/2014/main" id="{F8451A83-6FF2-4FF3-A21F-87738FF6704E}"/>
+                <a16:creationId xmlns:a16="http://schemas.microsoft.com/office/drawing/2014/main" id="{CC4F0B82-946A-4EE2-AE29-C0DCE4AD2FDD}"/>
               </a:ext>
             </a:extLst>
           </p:cNvPr>
@@ -5355,7 +5355,7 @@
           <p:cNvPr id="8" name="">
             <a:extLst xmlns:a="http://schemas.openxmlformats.org/drawingml/2006/main">
               <a:ext uri="{FF2B5EF4-FFF2-40B4-BE49-F238E27FC236}">
-                <a16:creationId xmlns:a16="http://schemas.microsoft.com/office/drawing/2014/main" id="{27AE159F-C68B-440B-962A-8A4D2A6A01CA}"/>
+                <a16:creationId xmlns:a16="http://schemas.microsoft.com/office/drawing/2014/main" id="{240F2441-A8B9-4EC8-A6D9-5FD1406CB6A8}"/>
               </a:ext>
             </a:extLst>
           </p:cNvPr>
@@ -5435,7 +5435,7 @@
           <p:cNvPr id="9" name="">
             <a:extLst xmlns:a="http://schemas.openxmlformats.org/drawingml/2006/main">
               <a:ext uri="{FF2B5EF4-FFF2-40B4-BE49-F238E27FC236}">
-                <a16:creationId xmlns:a16="http://schemas.microsoft.com/office/drawing/2014/main" id="{73A01B1C-517C-42B7-BCA9-7E0F7C4A35FE}"/>
+                <a16:creationId xmlns:a16="http://schemas.microsoft.com/office/drawing/2014/main" id="{2D016587-C6EC-49F3-9637-80C59F73BAEC}"/>
               </a:ext>
             </a:extLst>
           </p:cNvPr>
@@ -5464,7 +5464,7 @@
           <p:cNvPr id="10" name="">
             <a:extLst xmlns:a="http://schemas.openxmlformats.org/drawingml/2006/main">
               <a:ext uri="{FF2B5EF4-FFF2-40B4-BE49-F238E27FC236}">
-                <a16:creationId xmlns:a16="http://schemas.microsoft.com/office/drawing/2014/main" id="{E21AC423-B99D-43E5-B11D-89F9D9BD3CA9}"/>
+                <a16:creationId xmlns:a16="http://schemas.microsoft.com/office/drawing/2014/main" id="{51C1D718-297A-4983-857E-1F06CBED013B}"/>
               </a:ext>
             </a:extLst>
           </p:cNvPr>
@@ -5544,7 +5544,7 @@
           <p:cNvPr id="11" name="">
             <a:extLst xmlns:a="http://schemas.openxmlformats.org/drawingml/2006/main">
               <a:ext uri="{FF2B5EF4-FFF2-40B4-BE49-F238E27FC236}">
-                <a16:creationId xmlns:a16="http://schemas.microsoft.com/office/drawing/2014/main" id="{FE3FBC30-1B00-490A-B6EB-5A0B6F16221E}"/>
+                <a16:creationId xmlns:a16="http://schemas.microsoft.com/office/drawing/2014/main" id="{56D42D15-2713-4648-B87C-EB6D27CC9FD3}"/>
               </a:ext>
             </a:extLst>
           </p:cNvPr>
@@ -5622,7 +5622,7 @@
     </p:spTree>
     <p:extLst>
       <p:ext uri="{BB962C8B-B14F-4D97-AF65-F5344CB8AC3E}">
-        <p14:creationId xmlns:p14="http://schemas.microsoft.com/office/powerpoint/2010/main" val="1699217620"/>
+        <p14:creationId xmlns:p14="http://schemas.microsoft.com/office/powerpoint/2010/main" val="1605068816"/>
       </p:ext>
     </p:extLst>
   </p:cSld>
@@ -5653,7 +5653,7 @@
           <p:cNvPr id="13" name="">
             <a:extLst xmlns:a="http://schemas.openxmlformats.org/drawingml/2006/main">
               <a:ext uri="{FF2B5EF4-FFF2-40B4-BE49-F238E27FC236}">
-                <a16:creationId xmlns:a16="http://schemas.microsoft.com/office/drawing/2014/main" id="{96EBAD5A-7AC4-42AC-958A-2B591CCB573F}"/>
+                <a16:creationId xmlns:a16="http://schemas.microsoft.com/office/drawing/2014/main" id="{FFFEEA99-7895-493F-82FF-602E7F1DEF83}"/>
               </a:ext>
             </a:extLst>
           </p:cNvPr>
@@ -5710,7 +5710,7 @@
           <p:cNvPr id="2" name="">
             <a:extLst xmlns:a="http://schemas.openxmlformats.org/drawingml/2006/main">
               <a:ext uri="{FF2B5EF4-FFF2-40B4-BE49-F238E27FC236}">
-                <a16:creationId xmlns:a16="http://schemas.microsoft.com/office/drawing/2014/main" id="{5E6E1D15-BE57-4CDB-A574-51E23AA2D977}"/>
+                <a16:creationId xmlns:a16="http://schemas.microsoft.com/office/drawing/2014/main" id="{9DC8F077-CB97-4C17-AC00-7D575BB4C680}"/>
               </a:ext>
             </a:extLst>
           </p:cNvPr>
@@ -5767,7 +5767,7 @@
           <p:cNvPr id="3" name="">
             <a:extLst xmlns:a="http://schemas.openxmlformats.org/drawingml/2006/main">
               <a:ext uri="{FF2B5EF4-FFF2-40B4-BE49-F238E27FC236}">
-                <a16:creationId xmlns:a16="http://schemas.microsoft.com/office/drawing/2014/main" id="{EE867CA5-B1B4-481C-8FC7-92678305ACC4}"/>
+                <a16:creationId xmlns:a16="http://schemas.microsoft.com/office/drawing/2014/main" id="{E8F199D6-06F7-455C-8D60-19022D34296B}"/>
               </a:ext>
             </a:extLst>
           </p:cNvPr>
@@ -5824,7 +5824,7 @@
           <p:cNvPr id="4" name="">
             <a:extLst xmlns:a="http://schemas.openxmlformats.org/drawingml/2006/main">
               <a:ext uri="{FF2B5EF4-FFF2-40B4-BE49-F238E27FC236}">
-                <a16:creationId xmlns:a16="http://schemas.microsoft.com/office/drawing/2014/main" id="{143EDC5C-D4A5-44E1-9A14-4D487B9AF519}"/>
+                <a16:creationId xmlns:a16="http://schemas.microsoft.com/office/drawing/2014/main" id="{53E6BE25-2195-4D2D-BC20-96E59029AD6F}"/>
               </a:ext>
             </a:extLst>
           </p:cNvPr>
@@ -5881,7 +5881,7 @@
           <p:cNvPr id="5" name="">
             <a:extLst xmlns:a="http://schemas.openxmlformats.org/drawingml/2006/main">
               <a:ext uri="{FF2B5EF4-FFF2-40B4-BE49-F238E27FC236}">
-                <a16:creationId xmlns:a16="http://schemas.microsoft.com/office/drawing/2014/main" id="{2AE16F40-45D8-4EAE-AC7D-49155562D809}"/>
+                <a16:creationId xmlns:a16="http://schemas.microsoft.com/office/drawing/2014/main" id="{BAF2C263-4C1E-4FAF-8065-852797ED03C2}"/>
               </a:ext>
             </a:extLst>
           </p:cNvPr>
@@ -5938,7 +5938,7 @@
           <p:cNvPr id="6" name="">
             <a:extLst xmlns:a="http://schemas.openxmlformats.org/drawingml/2006/main">
               <a:ext uri="{FF2B5EF4-FFF2-40B4-BE49-F238E27FC236}">
-                <a16:creationId xmlns:a16="http://schemas.microsoft.com/office/drawing/2014/main" id="{1A87ED3A-7D97-4FE6-88F3-5BD5055C485E}"/>
+                <a16:creationId xmlns:a16="http://schemas.microsoft.com/office/drawing/2014/main" id="{D511355A-654B-41DA-8F42-A46D1EFB3318}"/>
               </a:ext>
             </a:extLst>
           </p:cNvPr>
@@ -6579,7 +6579,7 @@
           <p:cNvPr id="9" name="">
             <a:extLst xmlns:a="http://schemas.openxmlformats.org/drawingml/2006/main">
               <a:ext uri="{FF2B5EF4-FFF2-40B4-BE49-F238E27FC236}">
-                <a16:creationId xmlns:a16="http://schemas.microsoft.com/office/drawing/2014/main" id="{450BE7C0-BC1F-4E36-8246-28C193B308EE}"/>
+                <a16:creationId xmlns:a16="http://schemas.microsoft.com/office/drawing/2014/main" id="{588C2C4E-09BE-4CF7-BD35-F4423CCC1F8F}"/>
               </a:ext>
             </a:extLst>
           </p:cNvPr>
@@ -6608,7 +6608,7 @@
           <p:cNvPr id="10" name="">
             <a:extLst xmlns:a="http://schemas.openxmlformats.org/drawingml/2006/main">
               <a:ext uri="{FF2B5EF4-FFF2-40B4-BE49-F238E27FC236}">
-                <a16:creationId xmlns:a16="http://schemas.microsoft.com/office/drawing/2014/main" id="{45E4AB8B-C8D5-44BE-B8AF-2FF66400E12B}"/>
+                <a16:creationId xmlns:a16="http://schemas.microsoft.com/office/drawing/2014/main" id="{53569A82-3E21-4090-B39A-C00992A0C432}"/>
               </a:ext>
             </a:extLst>
           </p:cNvPr>
@@ -6665,7 +6665,7 @@
           <p:cNvPr id="11" name="">
             <a:extLst xmlns:a="http://schemas.openxmlformats.org/drawingml/2006/main">
               <a:ext uri="{FF2B5EF4-FFF2-40B4-BE49-F238E27FC236}">
-                <a16:creationId xmlns:a16="http://schemas.microsoft.com/office/drawing/2014/main" id="{C27A4426-E489-47D0-BDC7-11A774C4B281}"/>
+                <a16:creationId xmlns:a16="http://schemas.microsoft.com/office/drawing/2014/main" id="{44CF6F7B-55CA-4EA2-AB82-C8C924E7B6BE}"/>
               </a:ext>
             </a:extLst>
           </p:cNvPr>
@@ -6722,7 +6722,7 @@
           <p:cNvPr id="12" name="">
             <a:extLst xmlns:a="http://schemas.openxmlformats.org/drawingml/2006/main">
               <a:ext uri="{FF2B5EF4-FFF2-40B4-BE49-F238E27FC236}">
-                <a16:creationId xmlns:a16="http://schemas.microsoft.com/office/drawing/2014/main" id="{6AA7A7C0-05F1-4916-9BF2-F4C3A0CAA872}"/>
+                <a16:creationId xmlns:a16="http://schemas.microsoft.com/office/drawing/2014/main" id="{D3FB9634-0DAC-4D08-AA89-A2FD0E6B0BB3}"/>
               </a:ext>
             </a:extLst>
           </p:cNvPr>
@@ -6808,7 +6808,7 @@
     </p:spTree>
     <p:extLst>
       <p:ext uri="{BB962C8B-B14F-4D97-AF65-F5344CB8AC3E}">
-        <p14:creationId xmlns:p14="http://schemas.microsoft.com/office/powerpoint/2010/main" val="1680210600"/>
+        <p14:creationId xmlns:p14="http://schemas.microsoft.com/office/powerpoint/2010/main" val="236602185"/>
       </p:ext>
     </p:extLst>
   </p:cSld>
@@ -6839,7 +6839,7 @@
           <p:cNvPr id="7" name="">
             <a:extLst xmlns:a="http://schemas.openxmlformats.org/drawingml/2006/main">
               <a:ext uri="{FF2B5EF4-FFF2-40B4-BE49-F238E27FC236}">
-                <a16:creationId xmlns:a16="http://schemas.microsoft.com/office/drawing/2014/main" id="{0B503235-E3A0-4F4F-B7EB-EF1D63287BF3}"/>
+                <a16:creationId xmlns:a16="http://schemas.microsoft.com/office/drawing/2014/main" id="{40CC7029-DBD2-4BD1-8F4E-DAFB09B04863}"/>
               </a:ext>
             </a:extLst>
           </p:cNvPr>
@@ -6896,7 +6896,7 @@
           <p:cNvPr id="2" name="">
             <a:extLst xmlns:a="http://schemas.openxmlformats.org/drawingml/2006/main">
               <a:ext uri="{FF2B5EF4-FFF2-40B4-BE49-F238E27FC236}">
-                <a16:creationId xmlns:a16="http://schemas.microsoft.com/office/drawing/2014/main" id="{AD82C2FC-2873-42D7-969E-F9D9D682366F}"/>
+                <a16:creationId xmlns:a16="http://schemas.microsoft.com/office/drawing/2014/main" id="{A66AF794-AF5D-4C8D-A9FF-9BDFDC5A7E68}"/>
               </a:ext>
             </a:extLst>
           </p:cNvPr>
@@ -6953,7 +6953,7 @@
           <p:cNvPr id="3" name="">
             <a:extLst xmlns:a="http://schemas.openxmlformats.org/drawingml/2006/main">
               <a:ext uri="{FF2B5EF4-FFF2-40B4-BE49-F238E27FC236}">
-                <a16:creationId xmlns:a16="http://schemas.microsoft.com/office/drawing/2014/main" id="{ABEB3D62-F89A-4577-BB45-F20603D0F3F0}"/>
+                <a16:creationId xmlns:a16="http://schemas.microsoft.com/office/drawing/2014/main" id="{1271DA19-0206-4445-BAAF-AF64750E6DB9}"/>
               </a:ext>
             </a:extLst>
           </p:cNvPr>
@@ -7010,7 +7010,7 @@
           <p:cNvPr id="4" name="">
             <a:extLst xmlns:a="http://schemas.openxmlformats.org/drawingml/2006/main">
               <a:ext uri="{FF2B5EF4-FFF2-40B4-BE49-F238E27FC236}">
-                <a16:creationId xmlns:a16="http://schemas.microsoft.com/office/drawing/2014/main" id="{F289C4D6-6BD2-4A4C-AB7C-3384BFB5454C}"/>
+                <a16:creationId xmlns:a16="http://schemas.microsoft.com/office/drawing/2014/main" id="{B3943C6D-ACF7-43F6-AC3A-7E789F520419}"/>
               </a:ext>
             </a:extLst>
           </p:cNvPr>
@@ -7490,7 +7490,7 @@
           <p:cNvPr id="6" name="">
             <a:extLst xmlns:a="http://schemas.openxmlformats.org/drawingml/2006/main">
               <a:ext uri="{FF2B5EF4-FFF2-40B4-BE49-F238E27FC236}">
-                <a16:creationId xmlns:a16="http://schemas.microsoft.com/office/drawing/2014/main" id="{19864617-E989-4DD4-8A87-03D47171BA93}"/>
+                <a16:creationId xmlns:a16="http://schemas.microsoft.com/office/drawing/2014/main" id="{65C8D265-FF69-4251-8FAC-327D61325784}"/>
               </a:ext>
             </a:extLst>
           </p:cNvPr>
@@ -7545,7 +7545,7 @@
     </p:spTree>
     <p:extLst>
       <p:ext uri="{BB962C8B-B14F-4D97-AF65-F5344CB8AC3E}">
-        <p14:creationId xmlns:p14="http://schemas.microsoft.com/office/powerpoint/2010/main" val="701418320"/>
+        <p14:creationId xmlns:p14="http://schemas.microsoft.com/office/powerpoint/2010/main" val="1234190895"/>
       </p:ext>
     </p:extLst>
   </p:cSld>
@@ -7576,7 +7576,7 @@
           <p:cNvPr id="11" name="">
             <a:extLst xmlns:a="http://schemas.openxmlformats.org/drawingml/2006/main">
               <a:ext uri="{FF2B5EF4-FFF2-40B4-BE49-F238E27FC236}">
-                <a16:creationId xmlns:a16="http://schemas.microsoft.com/office/drawing/2014/main" id="{94596A69-3FF9-4DF3-8926-D69B69A670B5}"/>
+                <a16:creationId xmlns:a16="http://schemas.microsoft.com/office/drawing/2014/main" id="{78EBFF8C-0834-42BA-B300-F390843BDF2B}"/>
               </a:ext>
             </a:extLst>
           </p:cNvPr>
@@ -7633,7 +7633,7 @@
           <p:cNvPr id="2" name="">
             <a:extLst xmlns:a="http://schemas.openxmlformats.org/drawingml/2006/main">
               <a:ext uri="{FF2B5EF4-FFF2-40B4-BE49-F238E27FC236}">
-                <a16:creationId xmlns:a16="http://schemas.microsoft.com/office/drawing/2014/main" id="{A6FC6155-AA4C-42DC-A2ED-0C42BDBE360C}"/>
+                <a16:creationId xmlns:a16="http://schemas.microsoft.com/office/drawing/2014/main" id="{53BBC085-BA2A-4D9D-BA07-47E350E56883}"/>
               </a:ext>
             </a:extLst>
           </p:cNvPr>
@@ -7690,7 +7690,7 @@
           <p:cNvPr id="3" name="">
             <a:extLst xmlns:a="http://schemas.openxmlformats.org/drawingml/2006/main">
               <a:ext uri="{FF2B5EF4-FFF2-40B4-BE49-F238E27FC236}">
-                <a16:creationId xmlns:a16="http://schemas.microsoft.com/office/drawing/2014/main" id="{2C830EA4-CAE0-41B7-A70A-C0FA37B771CD}"/>
+                <a16:creationId xmlns:a16="http://schemas.microsoft.com/office/drawing/2014/main" id="{760C0861-B6EF-4E1C-A108-AD67D84D83E0}"/>
               </a:ext>
             </a:extLst>
           </p:cNvPr>
@@ -7747,7 +7747,7 @@
           <p:cNvPr id="4" name="">
             <a:extLst xmlns:a="http://schemas.openxmlformats.org/drawingml/2006/main">
               <a:ext uri="{FF2B5EF4-FFF2-40B4-BE49-F238E27FC236}">
-                <a16:creationId xmlns:a16="http://schemas.microsoft.com/office/drawing/2014/main" id="{C8E6217F-7CB8-4753-BE71-448433FD2C1E}"/>
+                <a16:creationId xmlns:a16="http://schemas.microsoft.com/office/drawing/2014/main" id="{B5EDFDBA-3564-4A63-8C00-1DE1BFCB1869}"/>
               </a:ext>
             </a:extLst>
           </p:cNvPr>
@@ -7804,7 +7804,7 @@
           <p:cNvPr id="5" name="">
             <a:extLst xmlns:a="http://schemas.openxmlformats.org/drawingml/2006/main">
               <a:ext uri="{FF2B5EF4-FFF2-40B4-BE49-F238E27FC236}">
-                <a16:creationId xmlns:a16="http://schemas.microsoft.com/office/drawing/2014/main" id="{86B4DB6D-2E56-44E8-AF9F-5B0934BB2F3B}"/>
+                <a16:creationId xmlns:a16="http://schemas.microsoft.com/office/drawing/2014/main" id="{041C30C9-716D-477C-A244-18084488CBD1}"/>
               </a:ext>
             </a:extLst>
           </p:cNvPr>
@@ -7861,7 +7861,7 @@
           <p:cNvPr id="6" name="">
             <a:extLst xmlns:a="http://schemas.openxmlformats.org/drawingml/2006/main">
               <a:ext uri="{FF2B5EF4-FFF2-40B4-BE49-F238E27FC236}">
-                <a16:creationId xmlns:a16="http://schemas.microsoft.com/office/drawing/2014/main" id="{71B56ADA-D9B9-417C-B1F0-4E05B66445DC}"/>
+                <a16:creationId xmlns:a16="http://schemas.microsoft.com/office/drawing/2014/main" id="{20E69EE8-F983-4063-AAF0-7A66514103AA}"/>
               </a:ext>
             </a:extLst>
           </p:cNvPr>
@@ -7918,7 +7918,7 @@
           <p:cNvPr id="7" name="">
             <a:extLst xmlns:a="http://schemas.openxmlformats.org/drawingml/2006/main">
               <a:ext uri="{FF2B5EF4-FFF2-40B4-BE49-F238E27FC236}">
-                <a16:creationId xmlns:a16="http://schemas.microsoft.com/office/drawing/2014/main" id="{658152AF-8711-40A0-A848-74F6545182D2}"/>
+                <a16:creationId xmlns:a16="http://schemas.microsoft.com/office/drawing/2014/main" id="{D3F714A9-1B3D-401C-944A-BCD59409CD28}"/>
               </a:ext>
             </a:extLst>
           </p:cNvPr>
@@ -8033,7 +8033,7 @@
           <p:cNvPr id="8" name="">
             <a:extLst xmlns:a="http://schemas.openxmlformats.org/drawingml/2006/main">
               <a:ext uri="{FF2B5EF4-FFF2-40B4-BE49-F238E27FC236}">
-                <a16:creationId xmlns:a16="http://schemas.microsoft.com/office/drawing/2014/main" id="{7A0DD812-9C65-4A35-B898-F8C8D4596C28}"/>
+                <a16:creationId xmlns:a16="http://schemas.microsoft.com/office/drawing/2014/main" id="{07571F6C-10AA-4653-9B64-16799E8458FB}"/>
               </a:ext>
             </a:extLst>
           </p:cNvPr>
@@ -8090,7 +8090,7 @@
           <p:cNvPr id="9" name="">
             <a:extLst xmlns:a="http://schemas.openxmlformats.org/drawingml/2006/main">
               <a:ext uri="{FF2B5EF4-FFF2-40B4-BE49-F238E27FC236}">
-                <a16:creationId xmlns:a16="http://schemas.microsoft.com/office/drawing/2014/main" id="{46ACDAAE-B004-4174-A7D0-508A49CA648D}"/>
+                <a16:creationId xmlns:a16="http://schemas.microsoft.com/office/drawing/2014/main" id="{A3E4AF80-47EB-493E-9C43-CD8A537326F7}"/>
               </a:ext>
             </a:extLst>
           </p:cNvPr>
@@ -8147,7 +8147,7 @@
           <p:cNvPr id="10" name="">
             <a:extLst xmlns:a="http://schemas.openxmlformats.org/drawingml/2006/main">
               <a:ext uri="{FF2B5EF4-FFF2-40B4-BE49-F238E27FC236}">
-                <a16:creationId xmlns:a16="http://schemas.microsoft.com/office/drawing/2014/main" id="{63E3917B-75CE-45B5-8E28-4E37EF43B452}"/>
+                <a16:creationId xmlns:a16="http://schemas.microsoft.com/office/drawing/2014/main" id="{84BF9274-2889-4216-8431-552A365E4EE5}"/>
               </a:ext>
             </a:extLst>
           </p:cNvPr>
@@ -8260,7 +8260,7 @@
     </p:spTree>
     <p:extLst>
       <p:ext uri="{BB962C8B-B14F-4D97-AF65-F5344CB8AC3E}">
-        <p14:creationId xmlns:p14="http://schemas.microsoft.com/office/powerpoint/2010/main" val="1579420710"/>
+        <p14:creationId xmlns:p14="http://schemas.microsoft.com/office/powerpoint/2010/main" val="1957838437"/>
       </p:ext>
     </p:extLst>
   </p:cSld>
@@ -8291,7 +8291,7 @@
           <p:cNvPr id="5" name="">
             <a:extLst xmlns:a="http://schemas.openxmlformats.org/drawingml/2006/main">
               <a:ext uri="{FF2B5EF4-FFF2-40B4-BE49-F238E27FC236}">
-                <a16:creationId xmlns:a16="http://schemas.microsoft.com/office/drawing/2014/main" id="{BACD7049-9214-45FF-AC0A-0C033403621C}"/>
+                <a16:creationId xmlns:a16="http://schemas.microsoft.com/office/drawing/2014/main" id="{E66EDA1E-EDDF-4B16-AFEA-5EF77DCE7906}"/>
               </a:ext>
             </a:extLst>
           </p:cNvPr>
@@ -8348,7 +8348,7 @@
           <p:cNvPr id="2" name="">
             <a:extLst xmlns:a="http://schemas.openxmlformats.org/drawingml/2006/main">
               <a:ext uri="{FF2B5EF4-FFF2-40B4-BE49-F238E27FC236}">
-                <a16:creationId xmlns:a16="http://schemas.microsoft.com/office/drawing/2014/main" id="{CF40F072-C767-4E58-8A1C-96A48C3B7917}"/>
+                <a16:creationId xmlns:a16="http://schemas.microsoft.com/office/drawing/2014/main" id="{87E28662-F24A-4C4E-AADC-51C1F7C3E527}"/>
               </a:ext>
             </a:extLst>
           </p:cNvPr>
@@ -8405,7 +8405,7 @@
           <p:cNvPr id="3" name="">
             <a:extLst xmlns:a="http://schemas.openxmlformats.org/drawingml/2006/main">
               <a:ext uri="{FF2B5EF4-FFF2-40B4-BE49-F238E27FC236}">
-                <a16:creationId xmlns:a16="http://schemas.microsoft.com/office/drawing/2014/main" id="{847D6A82-ED39-44DE-8A2E-697A95D9B9EE}"/>
+                <a16:creationId xmlns:a16="http://schemas.microsoft.com/office/drawing/2014/main" id="{E3498D4E-79A7-4E97-AE3F-8460403EDB79}"/>
               </a:ext>
             </a:extLst>
           </p:cNvPr>
@@ -8752,7 +8752,7 @@
     </p:spTree>
     <p:extLst>
       <p:ext uri="{BB962C8B-B14F-4D97-AF65-F5344CB8AC3E}">
-        <p14:creationId xmlns:p14="http://schemas.microsoft.com/office/powerpoint/2010/main" val="725308089"/>
+        <p14:creationId xmlns:p14="http://schemas.microsoft.com/office/powerpoint/2010/main" val="1311100645"/>
       </p:ext>
     </p:extLst>
   </p:cSld>
@@ -8783,7 +8783,7 @@
           <p:cNvPr id="11" name="">
             <a:extLst xmlns:a="http://schemas.openxmlformats.org/drawingml/2006/main">
               <a:ext uri="{FF2B5EF4-FFF2-40B4-BE49-F238E27FC236}">
-                <a16:creationId xmlns:a16="http://schemas.microsoft.com/office/drawing/2014/main" id="{83EBDC0A-4E2B-4B15-BB67-D661660D3137}"/>
+                <a16:creationId xmlns:a16="http://schemas.microsoft.com/office/drawing/2014/main" id="{B56EC34A-E9FC-40BA-8771-D6C8C48BC30B}"/>
               </a:ext>
             </a:extLst>
           </p:cNvPr>
@@ -8840,7 +8840,7 @@
           <p:cNvPr id="2" name="">
             <a:extLst xmlns:a="http://schemas.openxmlformats.org/drawingml/2006/main">
               <a:ext uri="{FF2B5EF4-FFF2-40B4-BE49-F238E27FC236}">
-                <a16:creationId xmlns:a16="http://schemas.microsoft.com/office/drawing/2014/main" id="{009655F9-C97F-4EB7-9639-44EF32AA7F52}"/>
+                <a16:creationId xmlns:a16="http://schemas.microsoft.com/office/drawing/2014/main" id="{C30DA7C5-1BC6-4E16-8142-28AF8DAB5600}"/>
               </a:ext>
             </a:extLst>
           </p:cNvPr>
@@ -8897,7 +8897,7 @@
           <p:cNvPr id="3" name="">
             <a:extLst xmlns:a="http://schemas.openxmlformats.org/drawingml/2006/main">
               <a:ext uri="{FF2B5EF4-FFF2-40B4-BE49-F238E27FC236}">
-                <a16:creationId xmlns:a16="http://schemas.microsoft.com/office/drawing/2014/main" id="{F0B3F083-4BFB-4DB4-BF97-81B0B829F88C}"/>
+                <a16:creationId xmlns:a16="http://schemas.microsoft.com/office/drawing/2014/main" id="{9FF541F2-F367-4B39-BB7F-A8FEBA119818}"/>
               </a:ext>
             </a:extLst>
           </p:cNvPr>
@@ -8954,7 +8954,7 @@
           <p:cNvPr id="4" name="">
             <a:extLst xmlns:a="http://schemas.openxmlformats.org/drawingml/2006/main">
               <a:ext uri="{FF2B5EF4-FFF2-40B4-BE49-F238E27FC236}">
-                <a16:creationId xmlns:a16="http://schemas.microsoft.com/office/drawing/2014/main" id="{29C76656-63ED-493E-9EDB-817AF0C68F57}"/>
+                <a16:creationId xmlns:a16="http://schemas.microsoft.com/office/drawing/2014/main" id="{24E7D227-A067-4EF1-80C9-203094F68EDD}"/>
               </a:ext>
             </a:extLst>
           </p:cNvPr>
@@ -9042,7 +9042,7 @@
           <p:cNvPr id="5" name="">
             <a:extLst xmlns:a="http://schemas.openxmlformats.org/drawingml/2006/main">
               <a:ext uri="{FF2B5EF4-FFF2-40B4-BE49-F238E27FC236}">
-                <a16:creationId xmlns:a16="http://schemas.microsoft.com/office/drawing/2014/main" id="{C531D12D-8DAA-4FA7-A856-63CE44766DBF}"/>
+                <a16:creationId xmlns:a16="http://schemas.microsoft.com/office/drawing/2014/main" id="{978D17B2-0AE0-422F-A42E-1F25CD1EF473}"/>
               </a:ext>
             </a:extLst>
           </p:cNvPr>
@@ -9126,7 +9126,7 @@
           <p:cNvPr id="6" name="">
             <a:extLst xmlns:a="http://schemas.openxmlformats.org/drawingml/2006/main">
               <a:ext uri="{FF2B5EF4-FFF2-40B4-BE49-F238E27FC236}">
-                <a16:creationId xmlns:a16="http://schemas.microsoft.com/office/drawing/2014/main" id="{291D677B-532B-44D7-9373-49595D2302C1}"/>
+                <a16:creationId xmlns:a16="http://schemas.microsoft.com/office/drawing/2014/main" id="{0B69B962-E85B-458A-AE49-512F74500A26}"/>
               </a:ext>
             </a:extLst>
           </p:cNvPr>
@@ -9210,7 +9210,7 @@
           <p:cNvPr id="7" name="">
             <a:extLst xmlns:a="http://schemas.openxmlformats.org/drawingml/2006/main">
               <a:ext uri="{FF2B5EF4-FFF2-40B4-BE49-F238E27FC236}">
-                <a16:creationId xmlns:a16="http://schemas.microsoft.com/office/drawing/2014/main" id="{02AB2353-F00E-407F-8EDA-053B4F905BFE}"/>
+                <a16:creationId xmlns:a16="http://schemas.microsoft.com/office/drawing/2014/main" id="{F85FE899-28F4-4E79-A455-98A1CFFDB8DA}"/>
               </a:ext>
             </a:extLst>
           </p:cNvPr>
@@ -9350,7 +9350,7 @@
           <p:cNvPr id="10" name="">
             <a:extLst xmlns:a="http://schemas.openxmlformats.org/drawingml/2006/main">
               <a:ext uri="{FF2B5EF4-FFF2-40B4-BE49-F238E27FC236}">
-                <a16:creationId xmlns:a16="http://schemas.microsoft.com/office/drawing/2014/main" id="{29DFE84E-76F6-4DD7-A13D-C0AE3C87BED7}"/>
+                <a16:creationId xmlns:a16="http://schemas.microsoft.com/office/drawing/2014/main" id="{A1EA4F0F-2865-4F53-A0D6-2212A1E31176}"/>
               </a:ext>
             </a:extLst>
           </p:cNvPr>
@@ -9483,7 +9483,7 @@
     </p:spTree>
     <p:extLst>
       <p:ext uri="{BB962C8B-B14F-4D97-AF65-F5344CB8AC3E}">
-        <p14:creationId xmlns:p14="http://schemas.microsoft.com/office/powerpoint/2010/main" val="1036492177"/>
+        <p14:creationId xmlns:p14="http://schemas.microsoft.com/office/powerpoint/2010/main" val="1115869935"/>
       </p:ext>
     </p:extLst>
   </p:cSld>

</xml_diff>

<commit_message>
Reorder slide 4 sections and sync PDF and speaking script
</commit_message>
<xml_diff>
--- a/presentation/unos_kidney_biopsy.pptx
+++ b/presentation/unos_kidney_biopsy.pptx
@@ -2,23 +2,23 @@
 <file path=ppt/presentation.xml><?xml version="1.0" encoding="utf-8"?>
 <p:presentation xmlns:p="http://schemas.openxmlformats.org/presentationml/2006/main" xmlns:r="http://schemas.openxmlformats.org/officeDocument/2006/relationships">
   <p:sldMasterIdLst>
-    <p:sldMasterId id="2147483648" r:id="Rf66096a0ca224ace"/>
+    <p:sldMasterId id="2147483648" r:id="R223b3d1551fb458e"/>
   </p:sldMasterIdLst>
   <p:sldIdLst>
-    <p:sldId id="256" r:id="R929541006fc24323"/>
-    <p:sldId id="257" r:id="R2308b4464e3c4e1a"/>
-    <p:sldId id="258" r:id="R201bcbad29c846be"/>
-    <p:sldId id="259" r:id="R1bb58af00cbd417d"/>
-    <p:sldId id="260" r:id="Rd9d67569632d49d9"/>
-    <p:sldId id="261" r:id="Rcc4d16d8b1c2481c"/>
-    <p:sldId id="262" r:id="Ra8f975ce5fa1491e"/>
-    <p:sldId id="263" r:id="R6d4dc4deb0b64c6a"/>
-    <p:sldId id="264" r:id="Rb6d568d672f34e11"/>
-    <p:sldId id="265" r:id="R1cf8861be31d4378"/>
-    <p:sldId id="266" r:id="R97a7dbaedb524ab1"/>
-    <p:sldId id="267" r:id="R362554e70bdc4c83"/>
-    <p:sldId id="268" r:id="R960bdb4507324ca4"/>
-    <p:sldId id="269" r:id="R5e88523445fb41fb"/>
+    <p:sldId id="256" r:id="R26b9c642ec2b44b0"/>
+    <p:sldId id="257" r:id="R2df6f29c10d243d2"/>
+    <p:sldId id="258" r:id="Rb88705bb3eed4fc4"/>
+    <p:sldId id="259" r:id="R49555f813d4d43b7"/>
+    <p:sldId id="260" r:id="Rdeb095eec77044ed"/>
+    <p:sldId id="261" r:id="R8ed3e188531a49af"/>
+    <p:sldId id="262" r:id="R604ebb13927242dc"/>
+    <p:sldId id="263" r:id="Rb48c3bd1588c47dc"/>
+    <p:sldId id="264" r:id="R531b9980dfb14724"/>
+    <p:sldId id="265" r:id="R9e95bab0a2ba467f"/>
+    <p:sldId id="266" r:id="Rf12f23cfa0a143af"/>
+    <p:sldId id="267" r:id="Rfbfce958f36643df"/>
+    <p:sldId id="268" r:id="R1e29edb8ef5e40f9"/>
+    <p:sldId id="269" r:id="R7d1d62e4045b46ea"/>
   </p:sldIdLst>
   <p:sldSz cx="12192000" cy="6858000"/>
   <p:notesSz cx="6858000" cy="9144000"/>
@@ -63,7 +63,7 @@
   </p:cSld>
   <p:clrMap bg1="lt1" tx1="dk1" bg2="lt2" tx2="dk2" accent1="accent1" accent2="accent2" accent3="accent3" accent4="accent4" accent5="accent5" accent6="accent6" hlink="hlink" folHlink="folHlink"/>
   <p:sldLayoutIdLst>
-    <p:sldLayoutId xmlns:r="http://schemas.openxmlformats.org/officeDocument/2006/relationships" id="2147483649" r:id="Rcd76588cdc9b4739"/>
+    <p:sldLayoutId xmlns:r="http://schemas.openxmlformats.org/officeDocument/2006/relationships" id="2147483649" r:id="R3bc950443ebf492a"/>
   </p:sldLayoutIdLst>
   <p:txStyles>
     <p:titleStyle>
@@ -851,7 +851,7 @@
           <p:cNvPr id="2" name="">
             <a:extLst xmlns:a="http://schemas.openxmlformats.org/drawingml/2006/main">
               <a:ext uri="{FF2B5EF4-FFF2-40B4-BE49-F238E27FC236}">
-                <a16:creationId xmlns:a16="http://schemas.microsoft.com/office/drawing/2014/main" id="{1BEBBD3D-FF57-4B8D-B446-1D3FCF6697A3}"/>
+                <a16:creationId xmlns:a16="http://schemas.microsoft.com/office/drawing/2014/main" id="{B8AF5ADB-7C66-4B93-9A41-E99F5EBBD240}"/>
               </a:ext>
             </a:extLst>
           </p:cNvPr>
@@ -952,7 +952,7 @@
     </p:spTree>
     <p:extLst>
       <p:ext uri="{BB962C8B-B14F-4D97-AF65-F5344CB8AC3E}">
-        <p14:creationId xmlns:p14="http://schemas.microsoft.com/office/powerpoint/2010/main" val="242733946"/>
+        <p14:creationId xmlns:p14="http://schemas.microsoft.com/office/powerpoint/2010/main" val="539046513"/>
       </p:ext>
     </p:extLst>
   </p:cSld>
@@ -983,7 +983,7 @@
           <p:cNvPr id="6" name="">
             <a:extLst xmlns:a="http://schemas.openxmlformats.org/drawingml/2006/main">
               <a:ext uri="{FF2B5EF4-FFF2-40B4-BE49-F238E27FC236}">
-                <a16:creationId xmlns:a16="http://schemas.microsoft.com/office/drawing/2014/main" id="{36FC60F0-700F-496D-B5D0-7547E524AEA3}"/>
+                <a16:creationId xmlns:a16="http://schemas.microsoft.com/office/drawing/2014/main" id="{7BB99064-C32E-4D38-8756-BE824DF27552}"/>
               </a:ext>
             </a:extLst>
           </p:cNvPr>
@@ -1040,7 +1040,7 @@
           <p:cNvPr id="2" name="">
             <a:extLst xmlns:a="http://schemas.openxmlformats.org/drawingml/2006/main">
               <a:ext uri="{FF2B5EF4-FFF2-40B4-BE49-F238E27FC236}">
-                <a16:creationId xmlns:a16="http://schemas.microsoft.com/office/drawing/2014/main" id="{60EC6AC6-3711-4140-8904-6525632228CD}"/>
+                <a16:creationId xmlns:a16="http://schemas.microsoft.com/office/drawing/2014/main" id="{31F54562-DDF9-43A2-B98D-99AC6A855C22}"/>
               </a:ext>
             </a:extLst>
           </p:cNvPr>
@@ -1097,7 +1097,7 @@
           <p:cNvPr id="3" name="">
             <a:extLst xmlns:a="http://schemas.openxmlformats.org/drawingml/2006/main">
               <a:ext uri="{FF2B5EF4-FFF2-40B4-BE49-F238E27FC236}">
-                <a16:creationId xmlns:a16="http://schemas.microsoft.com/office/drawing/2014/main" id="{0FA2B47F-7C60-4817-A669-58B76A36B421}"/>
+                <a16:creationId xmlns:a16="http://schemas.microsoft.com/office/drawing/2014/main" id="{21EDCD74-94FC-4446-9A56-E5BF81C9203C}"/>
               </a:ext>
             </a:extLst>
           </p:cNvPr>
@@ -1154,7 +1154,7 @@
           <p:cNvPr id="4" name="">
             <a:extLst xmlns:a="http://schemas.openxmlformats.org/drawingml/2006/main">
               <a:ext uri="{FF2B5EF4-FFF2-40B4-BE49-F238E27FC236}">
-                <a16:creationId xmlns:a16="http://schemas.microsoft.com/office/drawing/2014/main" id="{72829B63-058D-4FFC-A9D5-1FA344EB77CB}"/>
+                <a16:creationId xmlns:a16="http://schemas.microsoft.com/office/drawing/2014/main" id="{6F8CBD8F-6D4B-409B-B81C-C83BDD0C8430}"/>
               </a:ext>
             </a:extLst>
           </p:cNvPr>
@@ -1566,7 +1566,7 @@
     </p:spTree>
     <p:extLst>
       <p:ext uri="{BB962C8B-B14F-4D97-AF65-F5344CB8AC3E}">
-        <p14:creationId xmlns:p14="http://schemas.microsoft.com/office/powerpoint/2010/main" val="573810268"/>
+        <p14:creationId xmlns:p14="http://schemas.microsoft.com/office/powerpoint/2010/main" val="1463190424"/>
       </p:ext>
     </p:extLst>
   </p:cSld>
@@ -1597,7 +1597,7 @@
           <p:cNvPr id="17" name="">
             <a:extLst xmlns:a="http://schemas.openxmlformats.org/drawingml/2006/main">
               <a:ext uri="{FF2B5EF4-FFF2-40B4-BE49-F238E27FC236}">
-                <a16:creationId xmlns:a16="http://schemas.microsoft.com/office/drawing/2014/main" id="{DDFD68C6-2833-4DB1-B462-897A2BE8B65F}"/>
+                <a16:creationId xmlns:a16="http://schemas.microsoft.com/office/drawing/2014/main" id="{E085C082-8744-4A43-9F46-00846ED79656}"/>
               </a:ext>
             </a:extLst>
           </p:cNvPr>
@@ -1654,7 +1654,7 @@
           <p:cNvPr id="2" name="">
             <a:extLst xmlns:a="http://schemas.openxmlformats.org/drawingml/2006/main">
               <a:ext uri="{FF2B5EF4-FFF2-40B4-BE49-F238E27FC236}">
-                <a16:creationId xmlns:a16="http://schemas.microsoft.com/office/drawing/2014/main" id="{FA3F4A08-A164-43E6-8B99-D21CD762ACD7}"/>
+                <a16:creationId xmlns:a16="http://schemas.microsoft.com/office/drawing/2014/main" id="{0CBFA457-C493-4AF8-B0A0-27C0B7C02D06}"/>
               </a:ext>
             </a:extLst>
           </p:cNvPr>
@@ -1711,7 +1711,7 @@
           <p:cNvPr id="3" name="">
             <a:extLst xmlns:a="http://schemas.openxmlformats.org/drawingml/2006/main">
               <a:ext uri="{FF2B5EF4-FFF2-40B4-BE49-F238E27FC236}">
-                <a16:creationId xmlns:a16="http://schemas.microsoft.com/office/drawing/2014/main" id="{6FD0C6A7-CD7E-42BC-BF01-62B4378E3530}"/>
+                <a16:creationId xmlns:a16="http://schemas.microsoft.com/office/drawing/2014/main" id="{9F2C4317-F75D-440A-A937-603D301B87CB}"/>
               </a:ext>
             </a:extLst>
           </p:cNvPr>
@@ -1768,7 +1768,7 @@
           <p:cNvPr id="4" name="">
             <a:extLst xmlns:a="http://schemas.openxmlformats.org/drawingml/2006/main">
               <a:ext uri="{FF2B5EF4-FFF2-40B4-BE49-F238E27FC236}">
-                <a16:creationId xmlns:a16="http://schemas.microsoft.com/office/drawing/2014/main" id="{61B48FED-F5B9-4605-98F2-79EE34D331E4}"/>
+                <a16:creationId xmlns:a16="http://schemas.microsoft.com/office/drawing/2014/main" id="{C227CF2A-66C4-4DD1-8734-51AFF3CFABA5}"/>
               </a:ext>
             </a:extLst>
           </p:cNvPr>
@@ -1825,7 +1825,7 @@
           <p:cNvPr id="5" name="">
             <a:extLst xmlns:a="http://schemas.openxmlformats.org/drawingml/2006/main">
               <a:ext uri="{FF2B5EF4-FFF2-40B4-BE49-F238E27FC236}">
-                <a16:creationId xmlns:a16="http://schemas.microsoft.com/office/drawing/2014/main" id="{F5D2DCED-540A-419B-BBD8-AC692D724B54}"/>
+                <a16:creationId xmlns:a16="http://schemas.microsoft.com/office/drawing/2014/main" id="{F0F6D3F3-A6CF-4E49-8176-68C03C331412}"/>
               </a:ext>
             </a:extLst>
           </p:cNvPr>
@@ -1882,7 +1882,7 @@
           <p:cNvPr id="6" name="">
             <a:extLst xmlns:a="http://schemas.openxmlformats.org/drawingml/2006/main">
               <a:ext uri="{FF2B5EF4-FFF2-40B4-BE49-F238E27FC236}">
-                <a16:creationId xmlns:a16="http://schemas.microsoft.com/office/drawing/2014/main" id="{85AB7043-CB28-41FB-9141-3CD9A78CD500}"/>
+                <a16:creationId xmlns:a16="http://schemas.microsoft.com/office/drawing/2014/main" id="{64167E4F-FAA8-4469-9FC5-7FF85CFAC3BC}"/>
               </a:ext>
             </a:extLst>
           </p:cNvPr>
@@ -1911,7 +1911,7 @@
           <p:cNvPr id="7" name="">
             <a:extLst xmlns:a="http://schemas.openxmlformats.org/drawingml/2006/main">
               <a:ext uri="{FF2B5EF4-FFF2-40B4-BE49-F238E27FC236}">
-                <a16:creationId xmlns:a16="http://schemas.microsoft.com/office/drawing/2014/main" id="{9B919CC4-85F2-4171-9C01-2E0E413D74B4}"/>
+                <a16:creationId xmlns:a16="http://schemas.microsoft.com/office/drawing/2014/main" id="{99C5E791-83F9-495D-A6DB-57DE3EC97AC5}"/>
               </a:ext>
             </a:extLst>
           </p:cNvPr>
@@ -1968,7 +1968,7 @@
           <p:cNvPr id="8" name="">
             <a:extLst xmlns:a="http://schemas.openxmlformats.org/drawingml/2006/main">
               <a:ext uri="{FF2B5EF4-FFF2-40B4-BE49-F238E27FC236}">
-                <a16:creationId xmlns:a16="http://schemas.microsoft.com/office/drawing/2014/main" id="{A6FCD865-F750-42BE-8BD5-2A4531A23785}"/>
+                <a16:creationId xmlns:a16="http://schemas.microsoft.com/office/drawing/2014/main" id="{2F7D7868-D2E4-4919-853D-517E05D9B1AD}"/>
               </a:ext>
             </a:extLst>
           </p:cNvPr>
@@ -2025,7 +2025,7 @@
           <p:cNvPr id="9" name="">
             <a:extLst xmlns:a="http://schemas.openxmlformats.org/drawingml/2006/main">
               <a:ext uri="{FF2B5EF4-FFF2-40B4-BE49-F238E27FC236}">
-                <a16:creationId xmlns:a16="http://schemas.microsoft.com/office/drawing/2014/main" id="{EFE0D82E-6D7F-4410-8838-2074C10753FD}"/>
+                <a16:creationId xmlns:a16="http://schemas.microsoft.com/office/drawing/2014/main" id="{13C2E51C-B075-4CE5-93AD-2BF05008FFE3}"/>
               </a:ext>
             </a:extLst>
           </p:cNvPr>
@@ -2082,7 +2082,7 @@
           <p:cNvPr id="10" name="">
             <a:extLst xmlns:a="http://schemas.openxmlformats.org/drawingml/2006/main">
               <a:ext uri="{FF2B5EF4-FFF2-40B4-BE49-F238E27FC236}">
-                <a16:creationId xmlns:a16="http://schemas.microsoft.com/office/drawing/2014/main" id="{29EDA83C-CF3F-4B4F-8291-CC735229CB25}"/>
+                <a16:creationId xmlns:a16="http://schemas.microsoft.com/office/drawing/2014/main" id="{E982E456-B2A7-4664-8D75-B88FE0B31542}"/>
               </a:ext>
             </a:extLst>
           </p:cNvPr>
@@ -2139,7 +2139,7 @@
           <p:cNvPr id="11" name="">
             <a:extLst xmlns:a="http://schemas.openxmlformats.org/drawingml/2006/main">
               <a:ext uri="{FF2B5EF4-FFF2-40B4-BE49-F238E27FC236}">
-                <a16:creationId xmlns:a16="http://schemas.microsoft.com/office/drawing/2014/main" id="{00E13638-A0B0-4884-89FD-590D48A0A7DD}"/>
+                <a16:creationId xmlns:a16="http://schemas.microsoft.com/office/drawing/2014/main" id="{2833BAD6-7248-4DD6-81F2-B70CA4C6C4CE}"/>
               </a:ext>
             </a:extLst>
           </p:cNvPr>
@@ -2168,7 +2168,7 @@
           <p:cNvPr id="12" name="">
             <a:extLst xmlns:a="http://schemas.openxmlformats.org/drawingml/2006/main">
               <a:ext uri="{FF2B5EF4-FFF2-40B4-BE49-F238E27FC236}">
-                <a16:creationId xmlns:a16="http://schemas.microsoft.com/office/drawing/2014/main" id="{CB893A15-B7FB-40CC-96F3-76B73F5D8EB6}"/>
+                <a16:creationId xmlns:a16="http://schemas.microsoft.com/office/drawing/2014/main" id="{B237188E-70FD-463F-B028-DDC3D8C789EA}"/>
               </a:ext>
             </a:extLst>
           </p:cNvPr>
@@ -2225,7 +2225,7 @@
           <p:cNvPr id="13" name="">
             <a:extLst xmlns:a="http://schemas.openxmlformats.org/drawingml/2006/main">
               <a:ext uri="{FF2B5EF4-FFF2-40B4-BE49-F238E27FC236}">
-                <a16:creationId xmlns:a16="http://schemas.microsoft.com/office/drawing/2014/main" id="{BD2FBDFE-CB11-4C35-BB07-DAF602A81EF7}"/>
+                <a16:creationId xmlns:a16="http://schemas.microsoft.com/office/drawing/2014/main" id="{7274EEE0-A162-4AA8-9780-B3F8FDCC68B9}"/>
               </a:ext>
             </a:extLst>
           </p:cNvPr>
@@ -2282,7 +2282,7 @@
           <p:cNvPr id="14" name="">
             <a:extLst xmlns:a="http://schemas.openxmlformats.org/drawingml/2006/main">
               <a:ext uri="{FF2B5EF4-FFF2-40B4-BE49-F238E27FC236}">
-                <a16:creationId xmlns:a16="http://schemas.microsoft.com/office/drawing/2014/main" id="{73F5AB52-7F41-4F3B-B0B2-7649C9AB59CC}"/>
+                <a16:creationId xmlns:a16="http://schemas.microsoft.com/office/drawing/2014/main" id="{26FEF1EE-3FB1-4270-8E3E-38E16AE6E60B}"/>
               </a:ext>
             </a:extLst>
           </p:cNvPr>
@@ -2625,7 +2625,7 @@
           <p:cNvPr id="16" name="">
             <a:extLst xmlns:a="http://schemas.openxmlformats.org/drawingml/2006/main">
               <a:ext uri="{FF2B5EF4-FFF2-40B4-BE49-F238E27FC236}">
-                <a16:creationId xmlns:a16="http://schemas.microsoft.com/office/drawing/2014/main" id="{EFF4FB92-EBB4-4360-B2AE-62A3E4D87C09}"/>
+                <a16:creationId xmlns:a16="http://schemas.microsoft.com/office/drawing/2014/main" id="{D1C15353-160F-4A5B-BC33-C19A336EE293}"/>
               </a:ext>
             </a:extLst>
           </p:cNvPr>
@@ -2703,7 +2703,7 @@
     </p:spTree>
     <p:extLst>
       <p:ext uri="{BB962C8B-B14F-4D97-AF65-F5344CB8AC3E}">
-        <p14:creationId xmlns:p14="http://schemas.microsoft.com/office/powerpoint/2010/main" val="1312984157"/>
+        <p14:creationId xmlns:p14="http://schemas.microsoft.com/office/powerpoint/2010/main" val="320137286"/>
       </p:ext>
     </p:extLst>
   </p:cSld>
@@ -2734,7 +2734,7 @@
           <p:cNvPr id="12" name="">
             <a:extLst xmlns:a="http://schemas.openxmlformats.org/drawingml/2006/main">
               <a:ext uri="{FF2B5EF4-FFF2-40B4-BE49-F238E27FC236}">
-                <a16:creationId xmlns:a16="http://schemas.microsoft.com/office/drawing/2014/main" id="{13270DC5-5AC3-42F8-94DA-0F69DD8F95BA}"/>
+                <a16:creationId xmlns:a16="http://schemas.microsoft.com/office/drawing/2014/main" id="{2630A666-C0D1-4CCC-833D-2FE765101306}"/>
               </a:ext>
             </a:extLst>
           </p:cNvPr>
@@ -2791,7 +2791,7 @@
           <p:cNvPr id="2" name="">
             <a:extLst xmlns:a="http://schemas.openxmlformats.org/drawingml/2006/main">
               <a:ext uri="{FF2B5EF4-FFF2-40B4-BE49-F238E27FC236}">
-                <a16:creationId xmlns:a16="http://schemas.microsoft.com/office/drawing/2014/main" id="{DA96CC09-3819-4C5B-AA7F-9A6B23B53D90}"/>
+                <a16:creationId xmlns:a16="http://schemas.microsoft.com/office/drawing/2014/main" id="{9A46C718-A8F2-4983-9613-1DAFCBEE7287}"/>
               </a:ext>
             </a:extLst>
           </p:cNvPr>
@@ -2848,7 +2848,7 @@
           <p:cNvPr id="3" name="">
             <a:extLst xmlns:a="http://schemas.openxmlformats.org/drawingml/2006/main">
               <a:ext uri="{FF2B5EF4-FFF2-40B4-BE49-F238E27FC236}">
-                <a16:creationId xmlns:a16="http://schemas.microsoft.com/office/drawing/2014/main" id="{B4C0DF9D-BFD2-471B-82C8-6025FBE5D778}"/>
+                <a16:creationId xmlns:a16="http://schemas.microsoft.com/office/drawing/2014/main" id="{0C24A47A-67EB-4D18-9A62-C3E87650B548}"/>
               </a:ext>
             </a:extLst>
           </p:cNvPr>
@@ -2905,7 +2905,7 @@
           <p:cNvPr id="4" name="">
             <a:extLst xmlns:a="http://schemas.openxmlformats.org/drawingml/2006/main">
               <a:ext uri="{FF2B5EF4-FFF2-40B4-BE49-F238E27FC236}">
-                <a16:creationId xmlns:a16="http://schemas.microsoft.com/office/drawing/2014/main" id="{96E901F3-205B-4B68-9314-0B627065A2F1}"/>
+                <a16:creationId xmlns:a16="http://schemas.microsoft.com/office/drawing/2014/main" id="{EB78B5F8-B4B7-4C5E-9EA4-3E96BF3E9E75}"/>
               </a:ext>
             </a:extLst>
           </p:cNvPr>
@@ -2969,7 +2969,7 @@
         </p:xfrm>
         <a:graphic xmlns:a="http://schemas.openxmlformats.org/drawingml/2006/main">
           <a:graphicData uri="http://schemas.openxmlformats.org/drawingml/2006/chart">
-            <c:chart xmlns:r="http://schemas.openxmlformats.org/officeDocument/2006/relationships" xmlns:c="http://schemas.openxmlformats.org/drawingml/2006/chart" r:id="R3da263465cde4fcb"/>
+            <c:chart xmlns:r="http://schemas.openxmlformats.org/officeDocument/2006/relationships" xmlns:c="http://schemas.openxmlformats.org/drawingml/2006/chart" r:id="R0b156990f18546c2"/>
           </a:graphicData>
         </a:graphic>
       </p:graphicFrame>
@@ -2978,7 +2978,7 @@
           <p:cNvPr id="6" name="">
             <a:extLst xmlns:a="http://schemas.openxmlformats.org/drawingml/2006/main">
               <a:ext uri="{FF2B5EF4-FFF2-40B4-BE49-F238E27FC236}">
-                <a16:creationId xmlns:a16="http://schemas.microsoft.com/office/drawing/2014/main" id="{27818D9F-C4D2-4F6A-BA72-08CAE5BA6018}"/>
+                <a16:creationId xmlns:a16="http://schemas.microsoft.com/office/drawing/2014/main" id="{5DA10638-D3A9-4AB3-8A16-3475BAAFB08E}"/>
               </a:ext>
             </a:extLst>
           </p:cNvPr>
@@ -3008,7 +3008,7 @@
           <p:cNvPr id="7" name="">
             <a:extLst xmlns:a="http://schemas.openxmlformats.org/drawingml/2006/main">
               <a:ext uri="{FF2B5EF4-FFF2-40B4-BE49-F238E27FC236}">
-                <a16:creationId xmlns:a16="http://schemas.microsoft.com/office/drawing/2014/main" id="{4704AF32-FB84-45A9-81B6-A3F6EB86827D}"/>
+                <a16:creationId xmlns:a16="http://schemas.microsoft.com/office/drawing/2014/main" id="{98EDDD5B-8D8A-4502-9171-0FDD775F667F}"/>
               </a:ext>
             </a:extLst>
           </p:cNvPr>
@@ -3065,7 +3065,7 @@
           <p:cNvPr id="8" name="">
             <a:extLst xmlns:a="http://schemas.openxmlformats.org/drawingml/2006/main">
               <a:ext uri="{FF2B5EF4-FFF2-40B4-BE49-F238E27FC236}">
-                <a16:creationId xmlns:a16="http://schemas.microsoft.com/office/drawing/2014/main" id="{90F23125-7B6D-4A3C-B6B8-02D2D22214D2}"/>
+                <a16:creationId xmlns:a16="http://schemas.microsoft.com/office/drawing/2014/main" id="{1A8E3120-338E-4602-884A-81A7A0EA89A8}"/>
               </a:ext>
             </a:extLst>
           </p:cNvPr>
@@ -3095,7 +3095,7 @@
           <p:cNvPr id="9" name="">
             <a:extLst xmlns:a="http://schemas.openxmlformats.org/drawingml/2006/main">
               <a:ext uri="{FF2B5EF4-FFF2-40B4-BE49-F238E27FC236}">
-                <a16:creationId xmlns:a16="http://schemas.microsoft.com/office/drawing/2014/main" id="{C38B7DB9-949F-4C2C-9FC5-8DAB905F81C8}"/>
+                <a16:creationId xmlns:a16="http://schemas.microsoft.com/office/drawing/2014/main" id="{CCB137AA-9A30-4600-A9BD-4B3F24AAC27E}"/>
               </a:ext>
             </a:extLst>
           </p:cNvPr>
@@ -3152,7 +3152,7 @@
           <p:cNvPr id="10" name="">
             <a:extLst xmlns:a="http://schemas.openxmlformats.org/drawingml/2006/main">
               <a:ext uri="{FF2B5EF4-FFF2-40B4-BE49-F238E27FC236}">
-                <a16:creationId xmlns:a16="http://schemas.microsoft.com/office/drawing/2014/main" id="{0DCF4F92-D749-49EA-A271-7901241AB2A2}"/>
+                <a16:creationId xmlns:a16="http://schemas.microsoft.com/office/drawing/2014/main" id="{7658BB83-5610-4790-A10F-F918C67B9B42}"/>
               </a:ext>
             </a:extLst>
           </p:cNvPr>
@@ -3213,7 +3213,7 @@
           <p:cNvPr id="11" name="">
             <a:extLst xmlns:a="http://schemas.openxmlformats.org/drawingml/2006/main">
               <a:ext uri="{FF2B5EF4-FFF2-40B4-BE49-F238E27FC236}">
-                <a16:creationId xmlns:a16="http://schemas.microsoft.com/office/drawing/2014/main" id="{9C7E8306-34BF-41A0-B942-707D9A927537}"/>
+                <a16:creationId xmlns:a16="http://schemas.microsoft.com/office/drawing/2014/main" id="{60B57B95-C587-4C71-B678-7DF6216FA42D}"/>
               </a:ext>
             </a:extLst>
           </p:cNvPr>
@@ -3268,7 +3268,7 @@
     </p:spTree>
     <p:extLst>
       <p:ext uri="{BB962C8B-B14F-4D97-AF65-F5344CB8AC3E}">
-        <p14:creationId xmlns:p14="http://schemas.microsoft.com/office/powerpoint/2010/main" val="305746940"/>
+        <p14:creationId xmlns:p14="http://schemas.microsoft.com/office/powerpoint/2010/main" val="2079004286"/>
       </p:ext>
     </p:extLst>
   </p:cSld>
@@ -3299,7 +3299,7 @@
           <p:cNvPr id="4" name="">
             <a:extLst xmlns:a="http://schemas.openxmlformats.org/drawingml/2006/main">
               <a:ext uri="{FF2B5EF4-FFF2-40B4-BE49-F238E27FC236}">
-                <a16:creationId xmlns:a16="http://schemas.microsoft.com/office/drawing/2014/main" id="{59ED9233-E711-4DE2-8D6F-88A260B19AC5}"/>
+                <a16:creationId xmlns:a16="http://schemas.microsoft.com/office/drawing/2014/main" id="{664DDC8C-D0BB-42A2-B6C4-40D4754B93D6}"/>
               </a:ext>
             </a:extLst>
           </p:cNvPr>
@@ -3356,7 +3356,7 @@
           <p:cNvPr id="2" name="">
             <a:extLst xmlns:a="http://schemas.openxmlformats.org/drawingml/2006/main">
               <a:ext uri="{FF2B5EF4-FFF2-40B4-BE49-F238E27FC236}">
-                <a16:creationId xmlns:a16="http://schemas.microsoft.com/office/drawing/2014/main" id="{F02AD4FA-32F8-4BE7-BD4E-25A7D74E1055}"/>
+                <a16:creationId xmlns:a16="http://schemas.microsoft.com/office/drawing/2014/main" id="{98B6566D-E309-4E3C-8A79-ED3DC653D436}"/>
               </a:ext>
             </a:extLst>
           </p:cNvPr>
@@ -3413,7 +3413,7 @@
           <p:cNvPr id="3" name="">
             <a:extLst xmlns:a="http://schemas.openxmlformats.org/drawingml/2006/main">
               <a:ext uri="{FF2B5EF4-FFF2-40B4-BE49-F238E27FC236}">
-                <a16:creationId xmlns:a16="http://schemas.microsoft.com/office/drawing/2014/main" id="{9E24FAC0-F59E-44AC-B20D-42FABB957BA6}"/>
+                <a16:creationId xmlns:a16="http://schemas.microsoft.com/office/drawing/2014/main" id="{C03D12AC-1B4A-4747-932E-3A4989329FDE}"/>
               </a:ext>
             </a:extLst>
           </p:cNvPr>
@@ -3468,7 +3468,7 @@
     </p:spTree>
     <p:extLst>
       <p:ext uri="{BB962C8B-B14F-4D97-AF65-F5344CB8AC3E}">
-        <p14:creationId xmlns:p14="http://schemas.microsoft.com/office/powerpoint/2010/main" val="340105872"/>
+        <p14:creationId xmlns:p14="http://schemas.microsoft.com/office/powerpoint/2010/main" val="1215287104"/>
       </p:ext>
     </p:extLst>
   </p:cSld>
@@ -3499,7 +3499,7 @@
           <p:cNvPr id="9" name="">
             <a:extLst xmlns:a="http://schemas.openxmlformats.org/drawingml/2006/main">
               <a:ext uri="{FF2B5EF4-FFF2-40B4-BE49-F238E27FC236}">
-                <a16:creationId xmlns:a16="http://schemas.microsoft.com/office/drawing/2014/main" id="{32AFC8B9-3661-4B76-8396-F344D0CE0D78}"/>
+                <a16:creationId xmlns:a16="http://schemas.microsoft.com/office/drawing/2014/main" id="{EB8E6CBD-E26D-4785-BED2-B0DD45D4B49D}"/>
               </a:ext>
             </a:extLst>
           </p:cNvPr>
@@ -3556,7 +3556,7 @@
           <p:cNvPr id="2" name="">
             <a:extLst xmlns:a="http://schemas.openxmlformats.org/drawingml/2006/main">
               <a:ext uri="{FF2B5EF4-FFF2-40B4-BE49-F238E27FC236}">
-                <a16:creationId xmlns:a16="http://schemas.microsoft.com/office/drawing/2014/main" id="{19D194F2-79B6-4474-A94F-50FCA779AC36}"/>
+                <a16:creationId xmlns:a16="http://schemas.microsoft.com/office/drawing/2014/main" id="{C2C84770-F38C-4A9E-A71E-348FCD1E01CB}"/>
               </a:ext>
             </a:extLst>
           </p:cNvPr>
@@ -3613,7 +3613,7 @@
           <p:cNvPr id="3" name="">
             <a:extLst xmlns:a="http://schemas.openxmlformats.org/drawingml/2006/main">
               <a:ext uri="{FF2B5EF4-FFF2-40B4-BE49-F238E27FC236}">
-                <a16:creationId xmlns:a16="http://schemas.microsoft.com/office/drawing/2014/main" id="{CCB6C3CB-CFAC-4452-90A8-AC00B62A1940}"/>
+                <a16:creationId xmlns:a16="http://schemas.microsoft.com/office/drawing/2014/main" id="{071C1239-ECEA-49F1-BD72-B0BEBFCB61FE}"/>
               </a:ext>
             </a:extLst>
           </p:cNvPr>
@@ -3670,7 +3670,7 @@
           <p:cNvPr id="4" name="">
             <a:extLst xmlns:a="http://schemas.openxmlformats.org/drawingml/2006/main">
               <a:ext uri="{FF2B5EF4-FFF2-40B4-BE49-F238E27FC236}">
-                <a16:creationId xmlns:a16="http://schemas.microsoft.com/office/drawing/2014/main" id="{F036F871-2BB1-44DD-A309-A77C3F85C588}"/>
+                <a16:creationId xmlns:a16="http://schemas.microsoft.com/office/drawing/2014/main" id="{46BC4060-4482-42CB-A806-828B52251794}"/>
               </a:ext>
             </a:extLst>
           </p:cNvPr>
@@ -3727,7 +3727,7 @@
           <p:cNvPr id="5" name="">
             <a:extLst xmlns:a="http://schemas.openxmlformats.org/drawingml/2006/main">
               <a:ext uri="{FF2B5EF4-FFF2-40B4-BE49-F238E27FC236}">
-                <a16:creationId xmlns:a16="http://schemas.microsoft.com/office/drawing/2014/main" id="{9A27C6C6-B17A-42AC-8EEF-7718CE60CC7F}"/>
+                <a16:creationId xmlns:a16="http://schemas.microsoft.com/office/drawing/2014/main" id="{7B7BC3F2-5516-4AA3-A4D2-2175218F6065}"/>
               </a:ext>
             </a:extLst>
           </p:cNvPr>
@@ -3807,7 +3807,7 @@
           <p:cNvPr id="6" name="">
             <a:extLst xmlns:a="http://schemas.openxmlformats.org/drawingml/2006/main">
               <a:ext uri="{FF2B5EF4-FFF2-40B4-BE49-F238E27FC236}">
-                <a16:creationId xmlns:a16="http://schemas.microsoft.com/office/drawing/2014/main" id="{21E7E826-C1D8-467D-9624-8D9E99E30336}"/>
+                <a16:creationId xmlns:a16="http://schemas.microsoft.com/office/drawing/2014/main" id="{0D641DEA-E52E-4FFA-9C95-705AA93EAE01}"/>
               </a:ext>
             </a:extLst>
           </p:cNvPr>
@@ -3836,7 +3836,7 @@
           <p:cNvPr id="7" name="">
             <a:extLst xmlns:a="http://schemas.openxmlformats.org/drawingml/2006/main">
               <a:ext uri="{FF2B5EF4-FFF2-40B4-BE49-F238E27FC236}">
-                <a16:creationId xmlns:a16="http://schemas.microsoft.com/office/drawing/2014/main" id="{A62B7C18-567D-4EA2-AD49-3276E40441EE}"/>
+                <a16:creationId xmlns:a16="http://schemas.microsoft.com/office/drawing/2014/main" id="{346EE597-DA69-404A-AFE4-E8731AD3D82B}"/>
               </a:ext>
             </a:extLst>
           </p:cNvPr>
@@ -3893,7 +3893,7 @@
           <p:cNvPr id="8" name="">
             <a:extLst xmlns:a="http://schemas.openxmlformats.org/drawingml/2006/main">
               <a:ext uri="{FF2B5EF4-FFF2-40B4-BE49-F238E27FC236}">
-                <a16:creationId xmlns:a16="http://schemas.microsoft.com/office/drawing/2014/main" id="{752D35D5-3534-448A-97FE-BA5BCED6AE67}"/>
+                <a16:creationId xmlns:a16="http://schemas.microsoft.com/office/drawing/2014/main" id="{3A1ED07E-9304-4335-9107-019BB0E977A7}"/>
               </a:ext>
             </a:extLst>
           </p:cNvPr>
@@ -3971,7 +3971,7 @@
     </p:spTree>
     <p:extLst>
       <p:ext uri="{BB962C8B-B14F-4D97-AF65-F5344CB8AC3E}">
-        <p14:creationId xmlns:p14="http://schemas.microsoft.com/office/powerpoint/2010/main" val="405358652"/>
+        <p14:creationId xmlns:p14="http://schemas.microsoft.com/office/powerpoint/2010/main" val="1062656025"/>
       </p:ext>
     </p:extLst>
   </p:cSld>
@@ -4002,7 +4002,7 @@
           <p:cNvPr id="8" name="">
             <a:extLst xmlns:a="http://schemas.openxmlformats.org/drawingml/2006/main">
               <a:ext uri="{FF2B5EF4-FFF2-40B4-BE49-F238E27FC236}">
-                <a16:creationId xmlns:a16="http://schemas.microsoft.com/office/drawing/2014/main" id="{307D6D15-6760-4258-B568-E5D44FFC7190}"/>
+                <a16:creationId xmlns:a16="http://schemas.microsoft.com/office/drawing/2014/main" id="{38E61777-A03D-44C4-A99D-92D893DA220F}"/>
               </a:ext>
             </a:extLst>
           </p:cNvPr>
@@ -4059,7 +4059,7 @@
           <p:cNvPr id="2" name="">
             <a:extLst xmlns:a="http://schemas.openxmlformats.org/drawingml/2006/main">
               <a:ext uri="{FF2B5EF4-FFF2-40B4-BE49-F238E27FC236}">
-                <a16:creationId xmlns:a16="http://schemas.microsoft.com/office/drawing/2014/main" id="{89D74DD0-31A8-4B4A-90CC-9C4CEEB45C8A}"/>
+                <a16:creationId xmlns:a16="http://schemas.microsoft.com/office/drawing/2014/main" id="{7C57FE96-C3E4-4D4E-A277-4F44F6420B03}"/>
               </a:ext>
             </a:extLst>
           </p:cNvPr>
@@ -4116,7 +4116,7 @@
           <p:cNvPr id="3" name="">
             <a:extLst xmlns:a="http://schemas.openxmlformats.org/drawingml/2006/main">
               <a:ext uri="{FF2B5EF4-FFF2-40B4-BE49-F238E27FC236}">
-                <a16:creationId xmlns:a16="http://schemas.microsoft.com/office/drawing/2014/main" id="{4ECCAD31-B16F-4E7B-A383-1369A18B611A}"/>
+                <a16:creationId xmlns:a16="http://schemas.microsoft.com/office/drawing/2014/main" id="{AE33C83E-C307-45FC-AE22-7AD9D7A3459F}"/>
               </a:ext>
             </a:extLst>
           </p:cNvPr>
@@ -4173,7 +4173,7 @@
           <p:cNvPr id="4" name="">
             <a:extLst xmlns:a="http://schemas.openxmlformats.org/drawingml/2006/main">
               <a:ext uri="{FF2B5EF4-FFF2-40B4-BE49-F238E27FC236}">
-                <a16:creationId xmlns:a16="http://schemas.microsoft.com/office/drawing/2014/main" id="{B931218D-E9EB-4B22-BE44-3B682E99AD3B}"/>
+                <a16:creationId xmlns:a16="http://schemas.microsoft.com/office/drawing/2014/main" id="{63682E03-5327-40D1-8768-99516F9210CC}"/>
               </a:ext>
             </a:extLst>
           </p:cNvPr>
@@ -4230,7 +4230,7 @@
           <p:cNvPr id="5" name="">
             <a:extLst xmlns:a="http://schemas.openxmlformats.org/drawingml/2006/main">
               <a:ext uri="{FF2B5EF4-FFF2-40B4-BE49-F238E27FC236}">
-                <a16:creationId xmlns:a16="http://schemas.microsoft.com/office/drawing/2014/main" id="{D6D9F45F-48A1-4696-B7A4-97DC2961C833}"/>
+                <a16:creationId xmlns:a16="http://schemas.microsoft.com/office/drawing/2014/main" id="{4A9AD0C9-90DE-49EC-85DC-CBF1BD0ED863}"/>
               </a:ext>
             </a:extLst>
           </p:cNvPr>
@@ -4287,7 +4287,7 @@
           <p:cNvPr id="6" name="">
             <a:extLst xmlns:a="http://schemas.openxmlformats.org/drawingml/2006/main">
               <a:ext uri="{FF2B5EF4-FFF2-40B4-BE49-F238E27FC236}">
-                <a16:creationId xmlns:a16="http://schemas.microsoft.com/office/drawing/2014/main" id="{9C701502-21B5-4E84-B84F-DFB545703F79}"/>
+                <a16:creationId xmlns:a16="http://schemas.microsoft.com/office/drawing/2014/main" id="{9C0FEEEF-3B61-40EA-B527-4932FA16BC8A}"/>
               </a:ext>
             </a:extLst>
           </p:cNvPr>
@@ -4344,7 +4344,7 @@
           <p:cNvPr id="7" name="">
             <a:extLst xmlns:a="http://schemas.openxmlformats.org/drawingml/2006/main">
               <a:ext uri="{FF2B5EF4-FFF2-40B4-BE49-F238E27FC236}">
-                <a16:creationId xmlns:a16="http://schemas.microsoft.com/office/drawing/2014/main" id="{7C41AA78-848E-4EDD-875A-99A399A8865A}"/>
+                <a16:creationId xmlns:a16="http://schemas.microsoft.com/office/drawing/2014/main" id="{42BAAD8F-EE73-4444-9EE8-52A107DB6ABA}"/>
               </a:ext>
             </a:extLst>
           </p:cNvPr>
@@ -4399,7 +4399,7 @@
     </p:spTree>
     <p:extLst>
       <p:ext uri="{BB962C8B-B14F-4D97-AF65-F5344CB8AC3E}">
-        <p14:creationId xmlns:p14="http://schemas.microsoft.com/office/powerpoint/2010/main" val="576648320"/>
+        <p14:creationId xmlns:p14="http://schemas.microsoft.com/office/powerpoint/2010/main" val="843963215"/>
       </p:ext>
     </p:extLst>
   </p:cSld>
@@ -4430,7 +4430,7 @@
           <p:cNvPr id="9" name="">
             <a:extLst xmlns:a="http://schemas.openxmlformats.org/drawingml/2006/main">
               <a:ext uri="{FF2B5EF4-FFF2-40B4-BE49-F238E27FC236}">
-                <a16:creationId xmlns:a16="http://schemas.microsoft.com/office/drawing/2014/main" id="{05934B30-F0D9-4634-99E9-5D41D0BCD911}"/>
+                <a16:creationId xmlns:a16="http://schemas.microsoft.com/office/drawing/2014/main" id="{80593794-E2DD-48EC-8560-1FB854BF8533}"/>
               </a:ext>
             </a:extLst>
           </p:cNvPr>
@@ -4487,7 +4487,7 @@
           <p:cNvPr id="2" name="">
             <a:extLst xmlns:a="http://schemas.openxmlformats.org/drawingml/2006/main">
               <a:ext uri="{FF2B5EF4-FFF2-40B4-BE49-F238E27FC236}">
-                <a16:creationId xmlns:a16="http://schemas.microsoft.com/office/drawing/2014/main" id="{BE92FD7A-7429-46F5-8A5C-F8389A4055BB}"/>
+                <a16:creationId xmlns:a16="http://schemas.microsoft.com/office/drawing/2014/main" id="{4A8D8C43-032F-48C3-AD05-E746AE21E09B}"/>
               </a:ext>
             </a:extLst>
           </p:cNvPr>
@@ -4544,7 +4544,7 @@
           <p:cNvPr id="3" name="">
             <a:extLst xmlns:a="http://schemas.openxmlformats.org/drawingml/2006/main">
               <a:ext uri="{FF2B5EF4-FFF2-40B4-BE49-F238E27FC236}">
-                <a16:creationId xmlns:a16="http://schemas.microsoft.com/office/drawing/2014/main" id="{B5846C47-60FF-4427-8686-BE4737896067}"/>
+                <a16:creationId xmlns:a16="http://schemas.microsoft.com/office/drawing/2014/main" id="{DCEE9675-8FF7-4B94-A5CA-977CD4EC15B3}"/>
               </a:ext>
             </a:extLst>
           </p:cNvPr>
@@ -4601,7 +4601,7 @@
           <p:cNvPr id="4" name="">
             <a:extLst xmlns:a="http://schemas.openxmlformats.org/drawingml/2006/main">
               <a:ext uri="{FF2B5EF4-FFF2-40B4-BE49-F238E27FC236}">
-                <a16:creationId xmlns:a16="http://schemas.microsoft.com/office/drawing/2014/main" id="{DBEC1414-65CA-47D9-A074-6BB7E4BD35D5}"/>
+                <a16:creationId xmlns:a16="http://schemas.microsoft.com/office/drawing/2014/main" id="{B6EE2600-5C74-4545-BBA0-3D5F411737B4}"/>
               </a:ext>
             </a:extLst>
           </p:cNvPr>
@@ -4658,7 +4658,7 @@
           <p:cNvPr id="5" name="">
             <a:extLst xmlns:a="http://schemas.openxmlformats.org/drawingml/2006/main">
               <a:ext uri="{FF2B5EF4-FFF2-40B4-BE49-F238E27FC236}">
-                <a16:creationId xmlns:a16="http://schemas.microsoft.com/office/drawing/2014/main" id="{BDECC472-940E-4CE8-B89C-7C3954F78198}"/>
+                <a16:creationId xmlns:a16="http://schemas.microsoft.com/office/drawing/2014/main" id="{98037F6E-0839-487D-A1A8-D98DCB5D74AB}"/>
               </a:ext>
             </a:extLst>
           </p:cNvPr>
@@ -4715,7 +4715,7 @@
           <p:cNvPr id="6" name="">
             <a:extLst xmlns:a="http://schemas.openxmlformats.org/drawingml/2006/main">
               <a:ext uri="{FF2B5EF4-FFF2-40B4-BE49-F238E27FC236}">
-                <a16:creationId xmlns:a16="http://schemas.microsoft.com/office/drawing/2014/main" id="{F0EE228C-BE5E-4BDD-BD93-6BBACDF88744}"/>
+                <a16:creationId xmlns:a16="http://schemas.microsoft.com/office/drawing/2014/main" id="{BBBE4D8B-CCB5-4641-A4EA-5E4224F5034D}"/>
               </a:ext>
             </a:extLst>
           </p:cNvPr>
@@ -4772,7 +4772,7 @@
           <p:cNvPr id="7" name="">
             <a:extLst xmlns:a="http://schemas.openxmlformats.org/drawingml/2006/main">
               <a:ext uri="{FF2B5EF4-FFF2-40B4-BE49-F238E27FC236}">
-                <a16:creationId xmlns:a16="http://schemas.microsoft.com/office/drawing/2014/main" id="{1AE21BE2-29CC-4A5A-9CDA-B64A52211C05}"/>
+                <a16:creationId xmlns:a16="http://schemas.microsoft.com/office/drawing/2014/main" id="{68FE9C3E-418D-477D-B521-211112C3E7AA}"/>
               </a:ext>
             </a:extLst>
           </p:cNvPr>
@@ -4829,7 +4829,7 @@
           <p:cNvPr id="8" name="">
             <a:extLst xmlns:a="http://schemas.openxmlformats.org/drawingml/2006/main">
               <a:ext uri="{FF2B5EF4-FFF2-40B4-BE49-F238E27FC236}">
-                <a16:creationId xmlns:a16="http://schemas.microsoft.com/office/drawing/2014/main" id="{81AEE26C-CD1C-4939-BF39-5001777D8AEB}"/>
+                <a16:creationId xmlns:a16="http://schemas.microsoft.com/office/drawing/2014/main" id="{DAA24551-5C72-404B-9E47-41B1D82DF921}"/>
               </a:ext>
             </a:extLst>
           </p:cNvPr>
@@ -4884,7 +4884,7 @@
     </p:spTree>
     <p:extLst>
       <p:ext uri="{BB962C8B-B14F-4D97-AF65-F5344CB8AC3E}">
-        <p14:creationId xmlns:p14="http://schemas.microsoft.com/office/powerpoint/2010/main" val="1969791153"/>
+        <p14:creationId xmlns:p14="http://schemas.microsoft.com/office/powerpoint/2010/main" val="1195776425"/>
       </p:ext>
     </p:extLst>
   </p:cSld>
@@ -4915,7 +4915,7 @@
           <p:cNvPr id="12" name="">
             <a:extLst xmlns:a="http://schemas.openxmlformats.org/drawingml/2006/main">
               <a:ext uri="{FF2B5EF4-FFF2-40B4-BE49-F238E27FC236}">
-                <a16:creationId xmlns:a16="http://schemas.microsoft.com/office/drawing/2014/main" id="{D2EA8BD4-567E-42E6-8B21-0CCAEA123245}"/>
+                <a16:creationId xmlns:a16="http://schemas.microsoft.com/office/drawing/2014/main" id="{65F473C2-9ACB-4D5C-81EE-EE5A9DB62BA8}"/>
               </a:ext>
             </a:extLst>
           </p:cNvPr>
@@ -4972,7 +4972,7 @@
           <p:cNvPr id="2" name="">
             <a:extLst xmlns:a="http://schemas.openxmlformats.org/drawingml/2006/main">
               <a:ext uri="{FF2B5EF4-FFF2-40B4-BE49-F238E27FC236}">
-                <a16:creationId xmlns:a16="http://schemas.microsoft.com/office/drawing/2014/main" id="{1EE745EA-253C-422C-97CB-B7815CA79FD5}"/>
+                <a16:creationId xmlns:a16="http://schemas.microsoft.com/office/drawing/2014/main" id="{30627592-BA4C-4633-A23A-6076FDFADFED}"/>
               </a:ext>
             </a:extLst>
           </p:cNvPr>
@@ -5029,7 +5029,7 @@
           <p:cNvPr id="3" name="">
             <a:extLst xmlns:a="http://schemas.openxmlformats.org/drawingml/2006/main">
               <a:ext uri="{FF2B5EF4-FFF2-40B4-BE49-F238E27FC236}">
-                <a16:creationId xmlns:a16="http://schemas.microsoft.com/office/drawing/2014/main" id="{2D5F84BD-7FF1-4705-8C4D-02D9BF771D35}"/>
+                <a16:creationId xmlns:a16="http://schemas.microsoft.com/office/drawing/2014/main" id="{484052BD-ED26-42D0-A6D5-3118D89858A2}"/>
               </a:ext>
             </a:extLst>
           </p:cNvPr>
@@ -5086,7 +5086,7 @@
           <p:cNvPr id="4" name="">
             <a:extLst xmlns:a="http://schemas.openxmlformats.org/drawingml/2006/main">
               <a:ext uri="{FF2B5EF4-FFF2-40B4-BE49-F238E27FC236}">
-                <a16:creationId xmlns:a16="http://schemas.microsoft.com/office/drawing/2014/main" id="{4E1FA940-A8DE-4AC7-BB31-725533C90577}"/>
+                <a16:creationId xmlns:a16="http://schemas.microsoft.com/office/drawing/2014/main" id="{811F7440-4F55-4611-912F-1FD4D3E11CE0}"/>
               </a:ext>
             </a:extLst>
           </p:cNvPr>
@@ -5166,7 +5166,7 @@
           <p:cNvPr id="5" name="">
             <a:extLst xmlns:a="http://schemas.openxmlformats.org/drawingml/2006/main">
               <a:ext uri="{FF2B5EF4-FFF2-40B4-BE49-F238E27FC236}">
-                <a16:creationId xmlns:a16="http://schemas.microsoft.com/office/drawing/2014/main" id="{7930EE56-988B-4564-884E-DBC4AB7032FD}"/>
+                <a16:creationId xmlns:a16="http://schemas.microsoft.com/office/drawing/2014/main" id="{E5535579-1A90-4BED-9B66-138307CD1970}"/>
               </a:ext>
             </a:extLst>
           </p:cNvPr>
@@ -5246,7 +5246,7 @@
           <p:cNvPr id="6" name="">
             <a:extLst xmlns:a="http://schemas.openxmlformats.org/drawingml/2006/main">
               <a:ext uri="{FF2B5EF4-FFF2-40B4-BE49-F238E27FC236}">
-                <a16:creationId xmlns:a16="http://schemas.microsoft.com/office/drawing/2014/main" id="{5E1314FF-6E04-417B-B2B9-9DBE59EA7130}"/>
+                <a16:creationId xmlns:a16="http://schemas.microsoft.com/office/drawing/2014/main" id="{1B83D37D-2A65-4B9C-A4C0-F5D3FD94A1D0}"/>
               </a:ext>
             </a:extLst>
           </p:cNvPr>
@@ -5275,7 +5275,7 @@
           <p:cNvPr id="7" name="">
             <a:extLst xmlns:a="http://schemas.openxmlformats.org/drawingml/2006/main">
               <a:ext uri="{FF2B5EF4-FFF2-40B4-BE49-F238E27FC236}">
-                <a16:creationId xmlns:a16="http://schemas.microsoft.com/office/drawing/2014/main" id="{CC4F0B82-946A-4EE2-AE29-C0DCE4AD2FDD}"/>
+                <a16:creationId xmlns:a16="http://schemas.microsoft.com/office/drawing/2014/main" id="{DF6596ED-A4E1-4F1D-BE0A-86E839DF5DA8}"/>
               </a:ext>
             </a:extLst>
           </p:cNvPr>
@@ -5322,7 +5322,7 @@
                 <a:ea typeface="Arial"/>
                 <a:cs typeface="Arial"/>
               </a:rPr>
-              <a:t>Published B-HOT study</a:t>
+              <a:t>Biopsy and</a:t>
             </a:r>
           </a:p>
           <a:p xmlns:a="http://schemas.openxmlformats.org/drawingml/2006/main">
@@ -5345,7 +5345,7 @@
                 <a:ea typeface="Arial"/>
                 <a:cs typeface="Arial"/>
               </a:rPr>
-              <a:t>Zhang, 2024</a:t>
+              <a:t>treatment</a:t>
             </a:r>
           </a:p>
         </p:txBody>
@@ -5355,7 +5355,7 @@
           <p:cNvPr id="8" name="">
             <a:extLst xmlns:a="http://schemas.openxmlformats.org/drawingml/2006/main">
               <a:ext uri="{FF2B5EF4-FFF2-40B4-BE49-F238E27FC236}">
-                <a16:creationId xmlns:a16="http://schemas.microsoft.com/office/drawing/2014/main" id="{240F2441-A8B9-4EC8-A6D9-5FD1406CB6A8}"/>
+                <a16:creationId xmlns:a16="http://schemas.microsoft.com/office/drawing/2014/main" id="{694C1C0C-D2EB-4F8C-83DB-3682A965AEAE}"/>
               </a:ext>
             </a:extLst>
           </p:cNvPr>
@@ -5402,7 +5402,7 @@
                 <a:ea typeface="Arial"/>
                 <a:cs typeface="Arial"/>
               </a:rPr>
-              <a:t>Four-class study compared regression and boosting.</a:t>
+              <a:t>KDIGO recommends biopsy before treating acute rejection,</a:t>
             </a:r>
           </a:p>
           <a:p xmlns:a="http://schemas.openxmlformats.org/drawingml/2006/main">
@@ -5425,7 +5425,7 @@
                 <a:ea typeface="Arial"/>
                 <a:cs typeface="Arial"/>
               </a:rPr>
-              <a:t>Selected LASSO for similar accuracy with fewer features.</a:t>
+              <a:t>unless waiting would substantially delay treatment.</a:t>
             </a:r>
           </a:p>
         </p:txBody>
@@ -5435,7 +5435,7 @@
           <p:cNvPr id="9" name="">
             <a:extLst xmlns:a="http://schemas.openxmlformats.org/drawingml/2006/main">
               <a:ext uri="{FF2B5EF4-FFF2-40B4-BE49-F238E27FC236}">
-                <a16:creationId xmlns:a16="http://schemas.microsoft.com/office/drawing/2014/main" id="{2D016587-C6EC-49F3-9637-80C59F73BAEC}"/>
+                <a16:creationId xmlns:a16="http://schemas.microsoft.com/office/drawing/2014/main" id="{DA0E6AA3-29CA-4E37-942A-FD69163E9D7E}"/>
               </a:ext>
             </a:extLst>
           </p:cNvPr>
@@ -5464,7 +5464,7 @@
           <p:cNvPr id="10" name="">
             <a:extLst xmlns:a="http://schemas.openxmlformats.org/drawingml/2006/main">
               <a:ext uri="{FF2B5EF4-FFF2-40B4-BE49-F238E27FC236}">
-                <a16:creationId xmlns:a16="http://schemas.microsoft.com/office/drawing/2014/main" id="{51C1D718-297A-4983-857E-1F06CBED013B}"/>
+                <a16:creationId xmlns:a16="http://schemas.microsoft.com/office/drawing/2014/main" id="{5E783D3C-C3CC-4CF1-B394-17084842F51A}"/>
               </a:ext>
             </a:extLst>
           </p:cNvPr>
@@ -5511,7 +5511,7 @@
                 <a:ea typeface="Arial"/>
                 <a:cs typeface="Arial"/>
               </a:rPr>
-              <a:t>Biopsy and</a:t>
+              <a:t>Published B-HOT study</a:t>
             </a:r>
           </a:p>
           <a:p xmlns:a="http://schemas.openxmlformats.org/drawingml/2006/main">
@@ -5534,7 +5534,7 @@
                 <a:ea typeface="Arial"/>
                 <a:cs typeface="Arial"/>
               </a:rPr>
-              <a:t>treatment</a:t>
+              <a:t>Zhang, 2024</a:t>
             </a:r>
           </a:p>
         </p:txBody>
@@ -5544,7 +5544,7 @@
           <p:cNvPr id="11" name="">
             <a:extLst xmlns:a="http://schemas.openxmlformats.org/drawingml/2006/main">
               <a:ext uri="{FF2B5EF4-FFF2-40B4-BE49-F238E27FC236}">
-                <a16:creationId xmlns:a16="http://schemas.microsoft.com/office/drawing/2014/main" id="{56D42D15-2713-4648-B87C-EB6D27CC9FD3}"/>
+                <a16:creationId xmlns:a16="http://schemas.microsoft.com/office/drawing/2014/main" id="{E4BE20FC-DC25-4F38-AA27-D9F42041CF50}"/>
               </a:ext>
             </a:extLst>
           </p:cNvPr>
@@ -5591,7 +5591,7 @@
                 <a:ea typeface="Arial"/>
                 <a:cs typeface="Arial"/>
               </a:rPr>
-              <a:t>KDIGO recommends biopsy before treating acute rejection,</a:t>
+              <a:t>Four-class study compared regression and boosting.</a:t>
             </a:r>
           </a:p>
           <a:p xmlns:a="http://schemas.openxmlformats.org/drawingml/2006/main">
@@ -5614,7 +5614,7 @@
                 <a:ea typeface="Arial"/>
                 <a:cs typeface="Arial"/>
               </a:rPr>
-              <a:t>unless waiting would substantially delay treatment.</a:t>
+              <a:t>Selected LASSO for similar accuracy with fewer features.</a:t>
             </a:r>
           </a:p>
         </p:txBody>
@@ -5622,7 +5622,7 @@
     </p:spTree>
     <p:extLst>
       <p:ext uri="{BB962C8B-B14F-4D97-AF65-F5344CB8AC3E}">
-        <p14:creationId xmlns:p14="http://schemas.microsoft.com/office/powerpoint/2010/main" val="1605068816"/>
+        <p14:creationId xmlns:p14="http://schemas.microsoft.com/office/powerpoint/2010/main" val="600997037"/>
       </p:ext>
     </p:extLst>
   </p:cSld>
@@ -5653,7 +5653,7 @@
           <p:cNvPr id="13" name="">
             <a:extLst xmlns:a="http://schemas.openxmlformats.org/drawingml/2006/main">
               <a:ext uri="{FF2B5EF4-FFF2-40B4-BE49-F238E27FC236}">
-                <a16:creationId xmlns:a16="http://schemas.microsoft.com/office/drawing/2014/main" id="{FFFEEA99-7895-493F-82FF-602E7F1DEF83}"/>
+                <a16:creationId xmlns:a16="http://schemas.microsoft.com/office/drawing/2014/main" id="{7EE1977F-D804-4932-9D5A-E8C4FF422C28}"/>
               </a:ext>
             </a:extLst>
           </p:cNvPr>
@@ -5710,7 +5710,7 @@
           <p:cNvPr id="2" name="">
             <a:extLst xmlns:a="http://schemas.openxmlformats.org/drawingml/2006/main">
               <a:ext uri="{FF2B5EF4-FFF2-40B4-BE49-F238E27FC236}">
-                <a16:creationId xmlns:a16="http://schemas.microsoft.com/office/drawing/2014/main" id="{9DC8F077-CB97-4C17-AC00-7D575BB4C680}"/>
+                <a16:creationId xmlns:a16="http://schemas.microsoft.com/office/drawing/2014/main" id="{B056A256-47AC-4A37-8960-1C7B521B68FF}"/>
               </a:ext>
             </a:extLst>
           </p:cNvPr>
@@ -5767,7 +5767,7 @@
           <p:cNvPr id="3" name="">
             <a:extLst xmlns:a="http://schemas.openxmlformats.org/drawingml/2006/main">
               <a:ext uri="{FF2B5EF4-FFF2-40B4-BE49-F238E27FC236}">
-                <a16:creationId xmlns:a16="http://schemas.microsoft.com/office/drawing/2014/main" id="{E8F199D6-06F7-455C-8D60-19022D34296B}"/>
+                <a16:creationId xmlns:a16="http://schemas.microsoft.com/office/drawing/2014/main" id="{5D4D967F-56C3-4621-B29E-0FAEA51B9A15}"/>
               </a:ext>
             </a:extLst>
           </p:cNvPr>
@@ -5824,7 +5824,7 @@
           <p:cNvPr id="4" name="">
             <a:extLst xmlns:a="http://schemas.openxmlformats.org/drawingml/2006/main">
               <a:ext uri="{FF2B5EF4-FFF2-40B4-BE49-F238E27FC236}">
-                <a16:creationId xmlns:a16="http://schemas.microsoft.com/office/drawing/2014/main" id="{53E6BE25-2195-4D2D-BC20-96E59029AD6F}"/>
+                <a16:creationId xmlns:a16="http://schemas.microsoft.com/office/drawing/2014/main" id="{B609F5AA-57B8-439E-A9C5-AD6A283E4A26}"/>
               </a:ext>
             </a:extLst>
           </p:cNvPr>
@@ -5881,7 +5881,7 @@
           <p:cNvPr id="5" name="">
             <a:extLst xmlns:a="http://schemas.openxmlformats.org/drawingml/2006/main">
               <a:ext uri="{FF2B5EF4-FFF2-40B4-BE49-F238E27FC236}">
-                <a16:creationId xmlns:a16="http://schemas.microsoft.com/office/drawing/2014/main" id="{BAF2C263-4C1E-4FAF-8065-852797ED03C2}"/>
+                <a16:creationId xmlns:a16="http://schemas.microsoft.com/office/drawing/2014/main" id="{7BF8A34C-93EA-4548-88A0-36DD5C4A2306}"/>
               </a:ext>
             </a:extLst>
           </p:cNvPr>
@@ -5938,7 +5938,7 @@
           <p:cNvPr id="6" name="">
             <a:extLst xmlns:a="http://schemas.openxmlformats.org/drawingml/2006/main">
               <a:ext uri="{FF2B5EF4-FFF2-40B4-BE49-F238E27FC236}">
-                <a16:creationId xmlns:a16="http://schemas.microsoft.com/office/drawing/2014/main" id="{D511355A-654B-41DA-8F42-A46D1EFB3318}"/>
+                <a16:creationId xmlns:a16="http://schemas.microsoft.com/office/drawing/2014/main" id="{146CEBAC-6F6E-4402-AB14-3D0E87A6F623}"/>
               </a:ext>
             </a:extLst>
           </p:cNvPr>
@@ -6579,7 +6579,7 @@
           <p:cNvPr id="9" name="">
             <a:extLst xmlns:a="http://schemas.openxmlformats.org/drawingml/2006/main">
               <a:ext uri="{FF2B5EF4-FFF2-40B4-BE49-F238E27FC236}">
-                <a16:creationId xmlns:a16="http://schemas.microsoft.com/office/drawing/2014/main" id="{588C2C4E-09BE-4CF7-BD35-F4423CCC1F8F}"/>
+                <a16:creationId xmlns:a16="http://schemas.microsoft.com/office/drawing/2014/main" id="{31A40323-2628-444E-A14D-FBFCD543CCF3}"/>
               </a:ext>
             </a:extLst>
           </p:cNvPr>
@@ -6608,7 +6608,7 @@
           <p:cNvPr id="10" name="">
             <a:extLst xmlns:a="http://schemas.openxmlformats.org/drawingml/2006/main">
               <a:ext uri="{FF2B5EF4-FFF2-40B4-BE49-F238E27FC236}">
-                <a16:creationId xmlns:a16="http://schemas.microsoft.com/office/drawing/2014/main" id="{53569A82-3E21-4090-B39A-C00992A0C432}"/>
+                <a16:creationId xmlns:a16="http://schemas.microsoft.com/office/drawing/2014/main" id="{304E74FE-F50E-40BC-A5EA-F5ED464B5579}"/>
               </a:ext>
             </a:extLst>
           </p:cNvPr>
@@ -6665,7 +6665,7 @@
           <p:cNvPr id="11" name="">
             <a:extLst xmlns:a="http://schemas.openxmlformats.org/drawingml/2006/main">
               <a:ext uri="{FF2B5EF4-FFF2-40B4-BE49-F238E27FC236}">
-                <a16:creationId xmlns:a16="http://schemas.microsoft.com/office/drawing/2014/main" id="{44CF6F7B-55CA-4EA2-AB82-C8C924E7B6BE}"/>
+                <a16:creationId xmlns:a16="http://schemas.microsoft.com/office/drawing/2014/main" id="{117959F8-12D3-43E1-A84B-064135448D76}"/>
               </a:ext>
             </a:extLst>
           </p:cNvPr>
@@ -6722,7 +6722,7 @@
           <p:cNvPr id="12" name="">
             <a:extLst xmlns:a="http://schemas.openxmlformats.org/drawingml/2006/main">
               <a:ext uri="{FF2B5EF4-FFF2-40B4-BE49-F238E27FC236}">
-                <a16:creationId xmlns:a16="http://schemas.microsoft.com/office/drawing/2014/main" id="{D3FB9634-0DAC-4D08-AA89-A2FD0E6B0BB3}"/>
+                <a16:creationId xmlns:a16="http://schemas.microsoft.com/office/drawing/2014/main" id="{48BC482D-774A-4CA4-8495-9C649AD2AB59}"/>
               </a:ext>
             </a:extLst>
           </p:cNvPr>
@@ -6808,7 +6808,7 @@
     </p:spTree>
     <p:extLst>
       <p:ext uri="{BB962C8B-B14F-4D97-AF65-F5344CB8AC3E}">
-        <p14:creationId xmlns:p14="http://schemas.microsoft.com/office/powerpoint/2010/main" val="236602185"/>
+        <p14:creationId xmlns:p14="http://schemas.microsoft.com/office/powerpoint/2010/main" val="326481135"/>
       </p:ext>
     </p:extLst>
   </p:cSld>
@@ -6839,7 +6839,7 @@
           <p:cNvPr id="7" name="">
             <a:extLst xmlns:a="http://schemas.openxmlformats.org/drawingml/2006/main">
               <a:ext uri="{FF2B5EF4-FFF2-40B4-BE49-F238E27FC236}">
-                <a16:creationId xmlns:a16="http://schemas.microsoft.com/office/drawing/2014/main" id="{40CC7029-DBD2-4BD1-8F4E-DAFB09B04863}"/>
+                <a16:creationId xmlns:a16="http://schemas.microsoft.com/office/drawing/2014/main" id="{53432AEE-C184-46F0-B112-A878530AFFCC}"/>
               </a:ext>
             </a:extLst>
           </p:cNvPr>
@@ -6896,7 +6896,7 @@
           <p:cNvPr id="2" name="">
             <a:extLst xmlns:a="http://schemas.openxmlformats.org/drawingml/2006/main">
               <a:ext uri="{FF2B5EF4-FFF2-40B4-BE49-F238E27FC236}">
-                <a16:creationId xmlns:a16="http://schemas.microsoft.com/office/drawing/2014/main" id="{A66AF794-AF5D-4C8D-A9FF-9BDFDC5A7E68}"/>
+                <a16:creationId xmlns:a16="http://schemas.microsoft.com/office/drawing/2014/main" id="{729D865A-4AB0-42EA-9363-806E2249DF3E}"/>
               </a:ext>
             </a:extLst>
           </p:cNvPr>
@@ -6953,7 +6953,7 @@
           <p:cNvPr id="3" name="">
             <a:extLst xmlns:a="http://schemas.openxmlformats.org/drawingml/2006/main">
               <a:ext uri="{FF2B5EF4-FFF2-40B4-BE49-F238E27FC236}">
-                <a16:creationId xmlns:a16="http://schemas.microsoft.com/office/drawing/2014/main" id="{1271DA19-0206-4445-BAAF-AF64750E6DB9}"/>
+                <a16:creationId xmlns:a16="http://schemas.microsoft.com/office/drawing/2014/main" id="{D582E29E-8B5F-401A-B3A4-1E8DDA9FE924}"/>
               </a:ext>
             </a:extLst>
           </p:cNvPr>
@@ -7010,7 +7010,7 @@
           <p:cNvPr id="4" name="">
             <a:extLst xmlns:a="http://schemas.openxmlformats.org/drawingml/2006/main">
               <a:ext uri="{FF2B5EF4-FFF2-40B4-BE49-F238E27FC236}">
-                <a16:creationId xmlns:a16="http://schemas.microsoft.com/office/drawing/2014/main" id="{B3943C6D-ACF7-43F6-AC3A-7E789F520419}"/>
+                <a16:creationId xmlns:a16="http://schemas.microsoft.com/office/drawing/2014/main" id="{7D568820-3644-4D85-892C-FB621DA3B689}"/>
               </a:ext>
             </a:extLst>
           </p:cNvPr>
@@ -7490,7 +7490,7 @@
           <p:cNvPr id="6" name="">
             <a:extLst xmlns:a="http://schemas.openxmlformats.org/drawingml/2006/main">
               <a:ext uri="{FF2B5EF4-FFF2-40B4-BE49-F238E27FC236}">
-                <a16:creationId xmlns:a16="http://schemas.microsoft.com/office/drawing/2014/main" id="{65C8D265-FF69-4251-8FAC-327D61325784}"/>
+                <a16:creationId xmlns:a16="http://schemas.microsoft.com/office/drawing/2014/main" id="{BF458036-F445-4BBB-BFE4-9FDC8462A826}"/>
               </a:ext>
             </a:extLst>
           </p:cNvPr>
@@ -7545,7 +7545,7 @@
     </p:spTree>
     <p:extLst>
       <p:ext uri="{BB962C8B-B14F-4D97-AF65-F5344CB8AC3E}">
-        <p14:creationId xmlns:p14="http://schemas.microsoft.com/office/powerpoint/2010/main" val="1234190895"/>
+        <p14:creationId xmlns:p14="http://schemas.microsoft.com/office/powerpoint/2010/main" val="1758839984"/>
       </p:ext>
     </p:extLst>
   </p:cSld>
@@ -7576,7 +7576,7 @@
           <p:cNvPr id="11" name="">
             <a:extLst xmlns:a="http://schemas.openxmlformats.org/drawingml/2006/main">
               <a:ext uri="{FF2B5EF4-FFF2-40B4-BE49-F238E27FC236}">
-                <a16:creationId xmlns:a16="http://schemas.microsoft.com/office/drawing/2014/main" id="{78EBFF8C-0834-42BA-B300-F390843BDF2B}"/>
+                <a16:creationId xmlns:a16="http://schemas.microsoft.com/office/drawing/2014/main" id="{DDAB2819-0BE5-4935-9E25-02E0C8BF6F38}"/>
               </a:ext>
             </a:extLst>
           </p:cNvPr>
@@ -7633,7 +7633,7 @@
           <p:cNvPr id="2" name="">
             <a:extLst xmlns:a="http://schemas.openxmlformats.org/drawingml/2006/main">
               <a:ext uri="{FF2B5EF4-FFF2-40B4-BE49-F238E27FC236}">
-                <a16:creationId xmlns:a16="http://schemas.microsoft.com/office/drawing/2014/main" id="{53BBC085-BA2A-4D9D-BA07-47E350E56883}"/>
+                <a16:creationId xmlns:a16="http://schemas.microsoft.com/office/drawing/2014/main" id="{65FB3B4F-7E57-4801-8136-B1705E6041FC}"/>
               </a:ext>
             </a:extLst>
           </p:cNvPr>
@@ -7690,7 +7690,7 @@
           <p:cNvPr id="3" name="">
             <a:extLst xmlns:a="http://schemas.openxmlformats.org/drawingml/2006/main">
               <a:ext uri="{FF2B5EF4-FFF2-40B4-BE49-F238E27FC236}">
-                <a16:creationId xmlns:a16="http://schemas.microsoft.com/office/drawing/2014/main" id="{760C0861-B6EF-4E1C-A108-AD67D84D83E0}"/>
+                <a16:creationId xmlns:a16="http://schemas.microsoft.com/office/drawing/2014/main" id="{C42AA788-BD2A-4BAB-96B8-8BCCBFA85BAE}"/>
               </a:ext>
             </a:extLst>
           </p:cNvPr>
@@ -7747,7 +7747,7 @@
           <p:cNvPr id="4" name="">
             <a:extLst xmlns:a="http://schemas.openxmlformats.org/drawingml/2006/main">
               <a:ext uri="{FF2B5EF4-FFF2-40B4-BE49-F238E27FC236}">
-                <a16:creationId xmlns:a16="http://schemas.microsoft.com/office/drawing/2014/main" id="{B5EDFDBA-3564-4A63-8C00-1DE1BFCB1869}"/>
+                <a16:creationId xmlns:a16="http://schemas.microsoft.com/office/drawing/2014/main" id="{E6083D05-684D-490F-822A-27C7EAC7C639}"/>
               </a:ext>
             </a:extLst>
           </p:cNvPr>
@@ -7804,7 +7804,7 @@
           <p:cNvPr id="5" name="">
             <a:extLst xmlns:a="http://schemas.openxmlformats.org/drawingml/2006/main">
               <a:ext uri="{FF2B5EF4-FFF2-40B4-BE49-F238E27FC236}">
-                <a16:creationId xmlns:a16="http://schemas.microsoft.com/office/drawing/2014/main" id="{041C30C9-716D-477C-A244-18084488CBD1}"/>
+                <a16:creationId xmlns:a16="http://schemas.microsoft.com/office/drawing/2014/main" id="{7C59A351-F84C-4770-9AA7-F1ECE03E450E}"/>
               </a:ext>
             </a:extLst>
           </p:cNvPr>
@@ -7861,7 +7861,7 @@
           <p:cNvPr id="6" name="">
             <a:extLst xmlns:a="http://schemas.openxmlformats.org/drawingml/2006/main">
               <a:ext uri="{FF2B5EF4-FFF2-40B4-BE49-F238E27FC236}">
-                <a16:creationId xmlns:a16="http://schemas.microsoft.com/office/drawing/2014/main" id="{20E69EE8-F983-4063-AAF0-7A66514103AA}"/>
+                <a16:creationId xmlns:a16="http://schemas.microsoft.com/office/drawing/2014/main" id="{854C5531-8363-4DF2-AE32-44D4ACC37D31}"/>
               </a:ext>
             </a:extLst>
           </p:cNvPr>
@@ -7918,7 +7918,7 @@
           <p:cNvPr id="7" name="">
             <a:extLst xmlns:a="http://schemas.openxmlformats.org/drawingml/2006/main">
               <a:ext uri="{FF2B5EF4-FFF2-40B4-BE49-F238E27FC236}">
-                <a16:creationId xmlns:a16="http://schemas.microsoft.com/office/drawing/2014/main" id="{D3F714A9-1B3D-401C-944A-BCD59409CD28}"/>
+                <a16:creationId xmlns:a16="http://schemas.microsoft.com/office/drawing/2014/main" id="{C059595D-20D6-4F43-8201-1C6A6BBC2C47}"/>
               </a:ext>
             </a:extLst>
           </p:cNvPr>
@@ -8033,7 +8033,7 @@
           <p:cNvPr id="8" name="">
             <a:extLst xmlns:a="http://schemas.openxmlformats.org/drawingml/2006/main">
               <a:ext uri="{FF2B5EF4-FFF2-40B4-BE49-F238E27FC236}">
-                <a16:creationId xmlns:a16="http://schemas.microsoft.com/office/drawing/2014/main" id="{07571F6C-10AA-4653-9B64-16799E8458FB}"/>
+                <a16:creationId xmlns:a16="http://schemas.microsoft.com/office/drawing/2014/main" id="{1272E807-4039-475D-9CB9-0483F1A3451A}"/>
               </a:ext>
             </a:extLst>
           </p:cNvPr>
@@ -8090,7 +8090,7 @@
           <p:cNvPr id="9" name="">
             <a:extLst xmlns:a="http://schemas.openxmlformats.org/drawingml/2006/main">
               <a:ext uri="{FF2B5EF4-FFF2-40B4-BE49-F238E27FC236}">
-                <a16:creationId xmlns:a16="http://schemas.microsoft.com/office/drawing/2014/main" id="{A3E4AF80-47EB-493E-9C43-CD8A537326F7}"/>
+                <a16:creationId xmlns:a16="http://schemas.microsoft.com/office/drawing/2014/main" id="{1682A441-3114-4443-97C3-A2A711F1DD76}"/>
               </a:ext>
             </a:extLst>
           </p:cNvPr>
@@ -8147,7 +8147,7 @@
           <p:cNvPr id="10" name="">
             <a:extLst xmlns:a="http://schemas.openxmlformats.org/drawingml/2006/main">
               <a:ext uri="{FF2B5EF4-FFF2-40B4-BE49-F238E27FC236}">
-                <a16:creationId xmlns:a16="http://schemas.microsoft.com/office/drawing/2014/main" id="{84BF9274-2889-4216-8431-552A365E4EE5}"/>
+                <a16:creationId xmlns:a16="http://schemas.microsoft.com/office/drawing/2014/main" id="{B5ADB508-80FB-42D3-968F-AC30AE7BB608}"/>
               </a:ext>
             </a:extLst>
           </p:cNvPr>
@@ -8260,7 +8260,7 @@
     </p:spTree>
     <p:extLst>
       <p:ext uri="{BB962C8B-B14F-4D97-AF65-F5344CB8AC3E}">
-        <p14:creationId xmlns:p14="http://schemas.microsoft.com/office/powerpoint/2010/main" val="1957838437"/>
+        <p14:creationId xmlns:p14="http://schemas.microsoft.com/office/powerpoint/2010/main" val="1527990080"/>
       </p:ext>
     </p:extLst>
   </p:cSld>
@@ -8291,7 +8291,7 @@
           <p:cNvPr id="5" name="">
             <a:extLst xmlns:a="http://schemas.openxmlformats.org/drawingml/2006/main">
               <a:ext uri="{FF2B5EF4-FFF2-40B4-BE49-F238E27FC236}">
-                <a16:creationId xmlns:a16="http://schemas.microsoft.com/office/drawing/2014/main" id="{E66EDA1E-EDDF-4B16-AFEA-5EF77DCE7906}"/>
+                <a16:creationId xmlns:a16="http://schemas.microsoft.com/office/drawing/2014/main" id="{641E403C-D991-4AED-B030-A435ED8A6840}"/>
               </a:ext>
             </a:extLst>
           </p:cNvPr>
@@ -8348,7 +8348,7 @@
           <p:cNvPr id="2" name="">
             <a:extLst xmlns:a="http://schemas.openxmlformats.org/drawingml/2006/main">
               <a:ext uri="{FF2B5EF4-FFF2-40B4-BE49-F238E27FC236}">
-                <a16:creationId xmlns:a16="http://schemas.microsoft.com/office/drawing/2014/main" id="{87E28662-F24A-4C4E-AADC-51C1F7C3E527}"/>
+                <a16:creationId xmlns:a16="http://schemas.microsoft.com/office/drawing/2014/main" id="{65CD13AB-C623-4B81-A95E-A6FCA2CBCD18}"/>
               </a:ext>
             </a:extLst>
           </p:cNvPr>
@@ -8405,7 +8405,7 @@
           <p:cNvPr id="3" name="">
             <a:extLst xmlns:a="http://schemas.openxmlformats.org/drawingml/2006/main">
               <a:ext uri="{FF2B5EF4-FFF2-40B4-BE49-F238E27FC236}">
-                <a16:creationId xmlns:a16="http://schemas.microsoft.com/office/drawing/2014/main" id="{E3498D4E-79A7-4E97-AE3F-8460403EDB79}"/>
+                <a16:creationId xmlns:a16="http://schemas.microsoft.com/office/drawing/2014/main" id="{DBB44267-176A-42A3-AEFF-0774D6EBC2E0}"/>
               </a:ext>
             </a:extLst>
           </p:cNvPr>
@@ -8752,7 +8752,7 @@
     </p:spTree>
     <p:extLst>
       <p:ext uri="{BB962C8B-B14F-4D97-AF65-F5344CB8AC3E}">
-        <p14:creationId xmlns:p14="http://schemas.microsoft.com/office/powerpoint/2010/main" val="1311100645"/>
+        <p14:creationId xmlns:p14="http://schemas.microsoft.com/office/powerpoint/2010/main" val="2085686686"/>
       </p:ext>
     </p:extLst>
   </p:cSld>
@@ -8783,7 +8783,7 @@
           <p:cNvPr id="11" name="">
             <a:extLst xmlns:a="http://schemas.openxmlformats.org/drawingml/2006/main">
               <a:ext uri="{FF2B5EF4-FFF2-40B4-BE49-F238E27FC236}">
-                <a16:creationId xmlns:a16="http://schemas.microsoft.com/office/drawing/2014/main" id="{B56EC34A-E9FC-40BA-8771-D6C8C48BC30B}"/>
+                <a16:creationId xmlns:a16="http://schemas.microsoft.com/office/drawing/2014/main" id="{ECAC70C1-078C-445C-B8B7-866FDF086A61}"/>
               </a:ext>
             </a:extLst>
           </p:cNvPr>
@@ -8840,7 +8840,7 @@
           <p:cNvPr id="2" name="">
             <a:extLst xmlns:a="http://schemas.openxmlformats.org/drawingml/2006/main">
               <a:ext uri="{FF2B5EF4-FFF2-40B4-BE49-F238E27FC236}">
-                <a16:creationId xmlns:a16="http://schemas.microsoft.com/office/drawing/2014/main" id="{C30DA7C5-1BC6-4E16-8142-28AF8DAB5600}"/>
+                <a16:creationId xmlns:a16="http://schemas.microsoft.com/office/drawing/2014/main" id="{2B1D951F-889C-4242-8C6A-5920ECF371A8}"/>
               </a:ext>
             </a:extLst>
           </p:cNvPr>
@@ -8897,7 +8897,7 @@
           <p:cNvPr id="3" name="">
             <a:extLst xmlns:a="http://schemas.openxmlformats.org/drawingml/2006/main">
               <a:ext uri="{FF2B5EF4-FFF2-40B4-BE49-F238E27FC236}">
-                <a16:creationId xmlns:a16="http://schemas.microsoft.com/office/drawing/2014/main" id="{9FF541F2-F367-4B39-BB7F-A8FEBA119818}"/>
+                <a16:creationId xmlns:a16="http://schemas.microsoft.com/office/drawing/2014/main" id="{05F3B26F-9B59-4EF0-9D8F-7D17E97ECD35}"/>
               </a:ext>
             </a:extLst>
           </p:cNvPr>
@@ -8954,7 +8954,7 @@
           <p:cNvPr id="4" name="">
             <a:extLst xmlns:a="http://schemas.openxmlformats.org/drawingml/2006/main">
               <a:ext uri="{FF2B5EF4-FFF2-40B4-BE49-F238E27FC236}">
-                <a16:creationId xmlns:a16="http://schemas.microsoft.com/office/drawing/2014/main" id="{24E7D227-A067-4EF1-80C9-203094F68EDD}"/>
+                <a16:creationId xmlns:a16="http://schemas.microsoft.com/office/drawing/2014/main" id="{AB3E1C50-1CC1-410E-B6C5-31F9F76FBFAA}"/>
               </a:ext>
             </a:extLst>
           </p:cNvPr>
@@ -9042,7 +9042,7 @@
           <p:cNvPr id="5" name="">
             <a:extLst xmlns:a="http://schemas.openxmlformats.org/drawingml/2006/main">
               <a:ext uri="{FF2B5EF4-FFF2-40B4-BE49-F238E27FC236}">
-                <a16:creationId xmlns:a16="http://schemas.microsoft.com/office/drawing/2014/main" id="{978D17B2-0AE0-422F-A42E-1F25CD1EF473}"/>
+                <a16:creationId xmlns:a16="http://schemas.microsoft.com/office/drawing/2014/main" id="{DF30AF7D-B15A-4749-99BB-5AD3C23239A8}"/>
               </a:ext>
             </a:extLst>
           </p:cNvPr>
@@ -9126,7 +9126,7 @@
           <p:cNvPr id="6" name="">
             <a:extLst xmlns:a="http://schemas.openxmlformats.org/drawingml/2006/main">
               <a:ext uri="{FF2B5EF4-FFF2-40B4-BE49-F238E27FC236}">
-                <a16:creationId xmlns:a16="http://schemas.microsoft.com/office/drawing/2014/main" id="{0B69B962-E85B-458A-AE49-512F74500A26}"/>
+                <a16:creationId xmlns:a16="http://schemas.microsoft.com/office/drawing/2014/main" id="{6817AC26-A6DA-44A8-8D32-EEBE2895BE06}"/>
               </a:ext>
             </a:extLst>
           </p:cNvPr>
@@ -9210,7 +9210,7 @@
           <p:cNvPr id="7" name="">
             <a:extLst xmlns:a="http://schemas.openxmlformats.org/drawingml/2006/main">
               <a:ext uri="{FF2B5EF4-FFF2-40B4-BE49-F238E27FC236}">
-                <a16:creationId xmlns:a16="http://schemas.microsoft.com/office/drawing/2014/main" id="{F85FE899-28F4-4E79-A455-98A1CFFDB8DA}"/>
+                <a16:creationId xmlns:a16="http://schemas.microsoft.com/office/drawing/2014/main" id="{99FE52A2-0C09-412B-9217-CFA87B84F849}"/>
               </a:ext>
             </a:extLst>
           </p:cNvPr>
@@ -9350,7 +9350,7 @@
           <p:cNvPr id="10" name="">
             <a:extLst xmlns:a="http://schemas.openxmlformats.org/drawingml/2006/main">
               <a:ext uri="{FF2B5EF4-FFF2-40B4-BE49-F238E27FC236}">
-                <a16:creationId xmlns:a16="http://schemas.microsoft.com/office/drawing/2014/main" id="{A1EA4F0F-2865-4F53-A0D6-2212A1E31176}"/>
+                <a16:creationId xmlns:a16="http://schemas.microsoft.com/office/drawing/2014/main" id="{15C57391-5DBE-49C5-BCFB-A40D3AE4FFA2}"/>
               </a:ext>
             </a:extLst>
           </p:cNvPr>
@@ -9483,7 +9483,7 @@
     </p:spTree>
     <p:extLst>
       <p:ext uri="{BB962C8B-B14F-4D97-AF65-F5344CB8AC3E}">
-        <p14:creationId xmlns:p14="http://schemas.microsoft.com/office/powerpoint/2010/main" val="1115869935"/>
+        <p14:creationId xmlns:p14="http://schemas.microsoft.com/office/powerpoint/2010/main" val="1728724351"/>
       </p:ext>
     </p:extLst>
   </p:cSld>

</xml_diff>